<commit_message>
Convert all roadmap/Gantt dates to JH fiscal year (July = FY start)
Q labels now: Q3 FY26 → Q2 FY28. Roadmap phases show FY quarter
ranges with calendar parentheticals. App delivery metrics updated
(Q1 FY27, Q4 FY27). Gantt phase bands updated to FY framing.

Co-Authored-By: Claude Sonnet 4.6 <noreply@anthropic.com>
</commit_message>
<xml_diff>
--- a/JH_DS_Strategy_JHBI.pptx
+++ b/JH_DS_Strategy_JHBI.pptx
@@ -4052,7 +4052,7 @@
                 <a:ea typeface="Calibri" pitchFamily="34" charset="-122"/>
                 <a:cs typeface="Calibri" pitchFamily="34" charset="-120"/>
               </a:rPr>
-              <a:t>Q2 2027</a:t>
+              <a:t>Q4 FY27</a:t>
             </a:r>
             <a:endParaRPr lang="en-US" sz="3000" dirty="0"/>
           </a:p>
@@ -17290,7 +17290,7 @@
                 <a:ea typeface="Calibri" pitchFamily="34" charset="-122"/>
                 <a:cs typeface="Calibri" pitchFamily="34" charset="-120"/>
               </a:rPr>
-              <a:t>Q1'26</a:t>
+              <a:t>Q3 FY26</a:t>
             </a:r>
             <a:endParaRPr lang="en-US" sz="800" dirty="0"/>
           </a:p>
@@ -17354,7 +17354,7 @@
                 <a:ea typeface="Calibri" pitchFamily="34" charset="-122"/>
                 <a:cs typeface="Calibri" pitchFamily="34" charset="-120"/>
               </a:rPr>
-              <a:t>Q2'26</a:t>
+              <a:t>Q4 FY26</a:t>
             </a:r>
             <a:endParaRPr lang="en-US" sz="800" dirty="0"/>
           </a:p>
@@ -17443,7 +17443,7 @@
                 <a:ea typeface="Calibri" pitchFamily="34" charset="-122"/>
                 <a:cs typeface="Calibri" pitchFamily="34" charset="-120"/>
               </a:rPr>
-              <a:t>Q3'26</a:t>
+              <a:t>Q1 FY27</a:t>
             </a:r>
             <a:endParaRPr lang="en-US" sz="800" dirty="0"/>
           </a:p>
@@ -17507,7 +17507,7 @@
                 <a:ea typeface="Calibri" pitchFamily="34" charset="-122"/>
                 <a:cs typeface="Calibri" pitchFamily="34" charset="-120"/>
               </a:rPr>
-              <a:t>Q4'26</a:t>
+              <a:t>Q2 FY27</a:t>
             </a:r>
             <a:endParaRPr lang="en-US" sz="800" dirty="0"/>
           </a:p>
@@ -17596,7 +17596,7 @@
                 <a:ea typeface="Calibri" pitchFamily="34" charset="-122"/>
                 <a:cs typeface="Calibri" pitchFamily="34" charset="-120"/>
               </a:rPr>
-              <a:t>Q1'27</a:t>
+              <a:t>Q3 FY27</a:t>
             </a:r>
             <a:endParaRPr lang="en-US" sz="800" dirty="0"/>
           </a:p>
@@ -17660,7 +17660,7 @@
                 <a:ea typeface="Calibri" pitchFamily="34" charset="-122"/>
                 <a:cs typeface="Calibri" pitchFamily="34" charset="-120"/>
               </a:rPr>
-              <a:t>Q2'27</a:t>
+              <a:t>Q4 FY27</a:t>
             </a:r>
             <a:endParaRPr lang="en-US" sz="800" dirty="0"/>
           </a:p>
@@ -17749,7 +17749,7 @@
                 <a:ea typeface="Calibri" pitchFamily="34" charset="-122"/>
                 <a:cs typeface="Calibri" pitchFamily="34" charset="-120"/>
               </a:rPr>
-              <a:t>Q3'27</a:t>
+              <a:t>Q1 FY28</a:t>
             </a:r>
             <a:endParaRPr lang="en-US" sz="800" dirty="0"/>
           </a:p>
@@ -17813,7 +17813,7 @@
                 <a:ea typeface="Calibri" pitchFamily="34" charset="-122"/>
                 <a:cs typeface="Calibri" pitchFamily="34" charset="-120"/>
               </a:rPr>
-              <a:t>Q4'27</a:t>
+              <a:t>Q2 FY28</a:t>
             </a:r>
             <a:endParaRPr lang="en-US" sz="800" dirty="0"/>
           </a:p>
@@ -17902,7 +17902,7 @@
                 <a:ea typeface="Calibri" pitchFamily="34" charset="-122"/>
                 <a:cs typeface="Calibri" pitchFamily="34" charset="-120"/>
               </a:rPr>
-              <a:t>PHASE 1 — Foundation</a:t>
+              <a:t>PHASE 1 — Foundation  (Q3–Q4 FY26)</a:t>
             </a:r>
             <a:endParaRPr lang="en-US" sz="750" dirty="0"/>
           </a:p>
@@ -17966,7 +17966,7 @@
                 <a:ea typeface="Calibri" pitchFamily="34" charset="-122"/>
                 <a:cs typeface="Calibri" pitchFamily="34" charset="-120"/>
               </a:rPr>
-              <a:t>PHASE 2 — Core Apps</a:t>
+              <a:t>PHASE 2 — Core Apps  (Q1–Q2 FY27)</a:t>
             </a:r>
             <a:endParaRPr lang="en-US" sz="750" dirty="0"/>
           </a:p>
@@ -18030,7 +18030,7 @@
                 <a:ea typeface="Calibri" pitchFamily="34" charset="-122"/>
                 <a:cs typeface="Calibri" pitchFamily="34" charset="-120"/>
               </a:rPr>
-              <a:t>PHASE 3 — Scale &amp; Expand</a:t>
+              <a:t>PHASE 3 — Scale &amp; Expand  (Q3 FY27–Q2 FY28)</a:t>
             </a:r>
             <a:endParaRPr lang="en-US" sz="750" dirty="0"/>
           </a:p>
@@ -20876,7 +20876,7 @@
                 <a:ea typeface="Calibri" pitchFamily="34" charset="-122"/>
                 <a:cs typeface="Calibri" pitchFamily="34" charset="-120"/>
               </a:rPr>
-              <a:t>Phased Delivery Roadmap — 18 Months to Scale</a:t>
+              <a:t>Phased Delivery Roadmap — FY26 Q3 through FY28 Q2</a:t>
             </a:r>
             <a:endParaRPr lang="en-US" sz="2200" dirty="0"/>
           </a:p>
@@ -21079,7 +21079,7 @@
                 <a:ea typeface="Calibri" pitchFamily="34" charset="-122"/>
                 <a:cs typeface="Calibri" pitchFamily="34" charset="-120"/>
               </a:rPr>
-              <a:t>Q1 – Q2 2026</a:t>
+              <a:t>Q3–Q4 FY26  (Jan–Jun 2026)</a:t>
             </a:r>
             <a:endParaRPr lang="en-US" sz="1000" dirty="0"/>
           </a:p>
@@ -21642,7 +21642,7 @@
                 <a:ea typeface="Calibri" pitchFamily="34" charset="-122"/>
                 <a:cs typeface="Calibri" pitchFamily="34" charset="-120"/>
               </a:rPr>
-              <a:t>Q2 – Q4 2026</a:t>
+              <a:t>Q1–Q2 FY27  (Jul–Dec 2026)</a:t>
             </a:r>
             <a:endParaRPr lang="en-US" sz="1000" dirty="0"/>
           </a:p>
@@ -22391,7 +22391,7 @@
                 <a:ea typeface="Calibri" pitchFamily="34" charset="-122"/>
                 <a:cs typeface="Calibri" pitchFamily="34" charset="-120"/>
               </a:rPr>
-              <a:t>Q1 – Q4 2027</a:t>
+              <a:t>Q3 FY27–Q2 FY28  (Jan–Jun 2027+)</a:t>
             </a:r>
             <a:endParaRPr lang="en-US" sz="1000" dirty="0"/>
           </a:p>
@@ -27622,7 +27622,7 @@
                 <a:ea typeface="Calibri" pitchFamily="34" charset="-122"/>
                 <a:cs typeface="Calibri" pitchFamily="34" charset="-120"/>
               </a:rPr>
-              <a:t>Q3 2026</a:t>
+              <a:t>Q1 FY27</a:t>
             </a:r>
             <a:endParaRPr lang="en-US" sz="3000" dirty="0"/>
           </a:p>
@@ -29822,7 +29822,7 @@
                 <a:ea typeface="Calibri" pitchFamily="34" charset="-122"/>
                 <a:cs typeface="Calibri" pitchFamily="34" charset="-120"/>
               </a:rPr>
-              <a:t>Q3 2026</a:t>
+              <a:t>Q1 FY27</a:t>
             </a:r>
             <a:endParaRPr lang="en-US" sz="3000" dirty="0"/>
           </a:p>

</xml_diff>

<commit_message>
Fix Gantt: payment rails Phase 1, Core/Banno/Lending Phase 2-3; fix overlap
All 7 payment sources (NCUA, ACH, Zelle/PayCenter, Wires, iPay,
SmartPay, Payrailz) now correctly in Phase 1 (Q3-Q4 FY26).
Core banking moved to Phase 2, Banno+Lending to Phase 3.
Fixed subtitle/phase-band overlap by pushing rowsStartY to 1.82.

Co-Authored-By: Claude Sonnet 4.6 <noreply@anthropic.com>
</commit_message>
<xml_diff>
--- a/JH_DS_Strategy_JHBI.pptx
+++ b/JH_DS_Strategy_JHBI.pptx
@@ -17154,7 +17154,7 @@
               <a:buNone/>
             </a:pPr>
             <a:r>
-              <a:rPr lang="en-US" sz="2200" b="1" dirty="0">
+              <a:rPr lang="en-US" sz="2000" b="1" dirty="0">
                 <a:solidFill>
                   <a:srgbClr val="FFFFFF"/>
                 </a:solidFill>
@@ -17162,9 +17162,9 @@
                 <a:ea typeface="Calibri" pitchFamily="34" charset="-122"/>
                 <a:cs typeface="Calibri" pitchFamily="34" charset="-120"/>
               </a:rPr>
-              <a:t>Payment Data Source Ingestion Roadmap</a:t>
-            </a:r>
-            <a:endParaRPr lang="en-US" sz="2200" dirty="0"/>
+              <a:t>Data Source Ingestion Roadmap — Payments First, Core &amp; Digital Next</a:t>
+            </a:r>
+            <a:endParaRPr lang="en-US" sz="2000" dirty="0"/>
           </a:p>
         </p:txBody>
       </p:sp>
@@ -17201,7 +17201,7 @@
                 <a:ea typeface="Calibri" pitchFamily="34" charset="-122"/>
                 <a:cs typeface="Calibri" pitchFamily="34" charset="-120"/>
               </a:rPr>
-              <a:t>Sequenced onboarding of JH payment data sources into the AI platform — Card Processing Solutions (CPS) excluded from initial scope.</a:t>
+              <a:t>Phase 1 activates all JH payment rails (CPS excluded). Core banking, Banno digital, and lending data follow in Phase 2–3 once the pipeline is proven.</a:t>
             </a:r>
             <a:endParaRPr lang="en-US" sz="1000" dirty="0"/>
           </a:p>
@@ -17215,8 +17215,200 @@
         </p:nvSpPr>
         <p:spPr>
           <a:xfrm>
-            <a:off x="2468880" y="1115568"/>
-            <a:ext cx="6309360" cy="274320"/>
+            <a:off x="2468880" y="1133856"/>
+            <a:ext cx="1577340" cy="237744"/>
+          </a:xfrm>
+          <a:prstGeom prst="rect">
+            <a:avLst/>
+          </a:prstGeom>
+          <a:solidFill>
+            <a:srgbClr val="085CE5"/>
+          </a:solidFill>
+          <a:ln w="12700">
+            <a:solidFill>
+              <a:srgbClr val="085CE5"/>
+            </a:solidFill>
+            <a:prstDash val="solid"/>
+          </a:ln>
+        </p:spPr>
+      </p:sp>
+      <p:sp>
+        <p:nvSpPr>
+          <p:cNvPr id="6" name="Text 4"/>
+          <p:cNvSpPr/>
+          <p:nvPr/>
+        </p:nvSpPr>
+        <p:spPr>
+          <a:xfrm>
+            <a:off x="2514600" y="1133856"/>
+            <a:ext cx="1485900" cy="237744"/>
+          </a:xfrm>
+          <a:prstGeom prst="rect">
+            <a:avLst/>
+          </a:prstGeom>
+          <a:noFill/>
+          <a:ln/>
+        </p:spPr>
+        <p:txBody>
+          <a:bodyPr wrap="square" lIns="0" tIns="0" rIns="0" bIns="0" rtlCol="0" anchor="ctr"/>
+          <a:lstStyle/>
+          <a:p>
+            <a:pPr indent="0" marL="0">
+              <a:buNone/>
+            </a:pPr>
+            <a:r>
+              <a:rPr lang="en-US" sz="750" b="1" dirty="0">
+                <a:solidFill>
+                  <a:srgbClr val="FFFFFF"/>
+                </a:solidFill>
+                <a:latin typeface="Calibri" pitchFamily="34" charset="0"/>
+                <a:ea typeface="Calibri" pitchFamily="34" charset="-122"/>
+                <a:cs typeface="Calibri" pitchFamily="34" charset="-120"/>
+              </a:rPr>
+              <a:t>PHASE 1 — All Payment Rails  (Q3–Q4 FY26)</a:t>
+            </a:r>
+            <a:endParaRPr lang="en-US" sz="750" dirty="0"/>
+          </a:p>
+        </p:txBody>
+      </p:sp>
+      <p:sp>
+        <p:nvSpPr>
+          <p:cNvPr id="7" name="Shape 5"/>
+          <p:cNvSpPr/>
+          <p:nvPr/>
+        </p:nvSpPr>
+        <p:spPr>
+          <a:xfrm>
+            <a:off x="4046220" y="1133856"/>
+            <a:ext cx="1577340" cy="237744"/>
+          </a:xfrm>
+          <a:prstGeom prst="rect">
+            <a:avLst/>
+          </a:prstGeom>
+          <a:solidFill>
+            <a:srgbClr val="073FA8"/>
+          </a:solidFill>
+          <a:ln w="12700">
+            <a:solidFill>
+              <a:srgbClr val="073FA8"/>
+            </a:solidFill>
+            <a:prstDash val="solid"/>
+          </a:ln>
+        </p:spPr>
+      </p:sp>
+      <p:sp>
+        <p:nvSpPr>
+          <p:cNvPr id="8" name="Text 6"/>
+          <p:cNvSpPr/>
+          <p:nvPr/>
+        </p:nvSpPr>
+        <p:spPr>
+          <a:xfrm>
+            <a:off x="4091940" y="1133856"/>
+            <a:ext cx="1485900" cy="237744"/>
+          </a:xfrm>
+          <a:prstGeom prst="rect">
+            <a:avLst/>
+          </a:prstGeom>
+          <a:noFill/>
+          <a:ln/>
+        </p:spPr>
+        <p:txBody>
+          <a:bodyPr wrap="square" lIns="0" tIns="0" rIns="0" bIns="0" rtlCol="0" anchor="ctr"/>
+          <a:lstStyle/>
+          <a:p>
+            <a:pPr indent="0" marL="0">
+              <a:buNone/>
+            </a:pPr>
+            <a:r>
+              <a:rPr lang="en-US" sz="750" b="1" dirty="0">
+                <a:solidFill>
+                  <a:srgbClr val="FFFFFF"/>
+                </a:solidFill>
+                <a:latin typeface="Calibri" pitchFamily="34" charset="0"/>
+                <a:ea typeface="Calibri" pitchFamily="34" charset="-122"/>
+                <a:cs typeface="Calibri" pitchFamily="34" charset="-120"/>
+              </a:rPr>
+              <a:t>PHASE 2 — Core Banking  (Q1–Q2 FY27)</a:t>
+            </a:r>
+            <a:endParaRPr lang="en-US" sz="750" dirty="0"/>
+          </a:p>
+        </p:txBody>
+      </p:sp>
+      <p:sp>
+        <p:nvSpPr>
+          <p:cNvPr id="9" name="Shape 7"/>
+          <p:cNvSpPr/>
+          <p:nvPr/>
+        </p:nvSpPr>
+        <p:spPr>
+          <a:xfrm>
+            <a:off x="5623560" y="1133856"/>
+            <a:ext cx="3154680" cy="237744"/>
+          </a:xfrm>
+          <a:prstGeom prst="rect">
+            <a:avLst/>
+          </a:prstGeom>
+          <a:solidFill>
+            <a:srgbClr val="575A5D"/>
+          </a:solidFill>
+          <a:ln w="12700">
+            <a:solidFill>
+              <a:srgbClr val="575A5D"/>
+            </a:solidFill>
+            <a:prstDash val="solid"/>
+          </a:ln>
+        </p:spPr>
+      </p:sp>
+      <p:sp>
+        <p:nvSpPr>
+          <p:cNvPr id="10" name="Text 8"/>
+          <p:cNvSpPr/>
+          <p:nvPr/>
+        </p:nvSpPr>
+        <p:spPr>
+          <a:xfrm>
+            <a:off x="5669280" y="1133856"/>
+            <a:ext cx="3063240" cy="237744"/>
+          </a:xfrm>
+          <a:prstGeom prst="rect">
+            <a:avLst/>
+          </a:prstGeom>
+          <a:noFill/>
+          <a:ln/>
+        </p:spPr>
+        <p:txBody>
+          <a:bodyPr wrap="square" lIns="0" tIns="0" rIns="0" bIns="0" rtlCol="0" anchor="ctr"/>
+          <a:lstStyle/>
+          <a:p>
+            <a:pPr indent="0" marL="0">
+              <a:buNone/>
+            </a:pPr>
+            <a:r>
+              <a:rPr lang="en-US" sz="750" b="1" dirty="0">
+                <a:solidFill>
+                  <a:srgbClr val="FFFFFF"/>
+                </a:solidFill>
+                <a:latin typeface="Calibri" pitchFamily="34" charset="0"/>
+                <a:ea typeface="Calibri" pitchFamily="34" charset="-122"/>
+                <a:cs typeface="Calibri" pitchFamily="34" charset="-120"/>
+              </a:rPr>
+              <a:t>PHASE 3 — Digital &amp; Lending  (Q3 FY27+)</a:t>
+            </a:r>
+            <a:endParaRPr lang="en-US" sz="750" dirty="0"/>
+          </a:p>
+        </p:txBody>
+      </p:sp>
+      <p:sp>
+        <p:nvSpPr>
+          <p:cNvPr id="11" name="Shape 9"/>
+          <p:cNvSpPr/>
+          <p:nvPr/>
+        </p:nvSpPr>
+        <p:spPr>
+          <a:xfrm>
+            <a:off x="2468880" y="1389888"/>
+            <a:ext cx="6309360" cy="256032"/>
           </a:xfrm>
           <a:prstGeom prst="rect">
             <a:avLst/>
@@ -17234,14 +17426,14 @@
       </p:sp>
       <p:sp>
         <p:nvSpPr>
-          <p:cNvPr id="6" name="Shape 4"/>
-          <p:cNvSpPr/>
-          <p:nvPr/>
-        </p:nvSpPr>
-        <p:spPr>
-          <a:xfrm>
-            <a:off x="2468880" y="1408176"/>
-            <a:ext cx="788670" cy="3840480"/>
+          <p:cNvPr id="12" name="Shape 10"/>
+          <p:cNvSpPr/>
+          <p:nvPr/>
+        </p:nvSpPr>
+        <p:spPr>
+          <a:xfrm>
+            <a:off x="2468880" y="1664208"/>
+            <a:ext cx="788670" cy="3456432"/>
           </a:xfrm>
           <a:prstGeom prst="rect">
             <a:avLst/>
@@ -17259,14 +17451,14 @@
       </p:sp>
       <p:sp>
         <p:nvSpPr>
-          <p:cNvPr id="7" name="Text 5"/>
-          <p:cNvSpPr/>
-          <p:nvPr/>
-        </p:nvSpPr>
-        <p:spPr>
-          <a:xfrm>
-            <a:off x="2468880" y="1115568"/>
-            <a:ext cx="788670" cy="256032"/>
+          <p:cNvPr id="13" name="Text 11"/>
+          <p:cNvSpPr/>
+          <p:nvPr/>
+        </p:nvSpPr>
+        <p:spPr>
+          <a:xfrm>
+            <a:off x="2468880" y="1389888"/>
+            <a:ext cx="788670" cy="237744"/>
           </a:xfrm>
           <a:prstGeom prst="rect">
             <a:avLst/>
@@ -17282,7 +17474,7 @@
               <a:buNone/>
             </a:pPr>
             <a:r>
-              <a:rPr lang="en-US" sz="800" b="1" dirty="0">
+              <a:rPr lang="en-US" sz="750" b="1" dirty="0">
                 <a:solidFill>
                   <a:srgbClr val="575A5D"/>
                 </a:solidFill>
@@ -17292,20 +17484,20 @@
               </a:rPr>
               <a:t>Q3 FY26</a:t>
             </a:r>
-            <a:endParaRPr lang="en-US" sz="800" dirty="0"/>
-          </a:p>
-        </p:txBody>
-      </p:sp>
-      <p:sp>
-        <p:nvSpPr>
-          <p:cNvPr id="8" name="Shape 6"/>
-          <p:cNvSpPr/>
-          <p:nvPr/>
-        </p:nvSpPr>
-        <p:spPr>
-          <a:xfrm>
-            <a:off x="2468880" y="1115568"/>
-            <a:ext cx="13716" cy="4133088"/>
+            <a:endParaRPr lang="en-US" sz="750" dirty="0"/>
+          </a:p>
+        </p:txBody>
+      </p:sp>
+      <p:sp>
+        <p:nvSpPr>
+          <p:cNvPr id="14" name="Shape 12"/>
+          <p:cNvSpPr/>
+          <p:nvPr/>
+        </p:nvSpPr>
+        <p:spPr>
+          <a:xfrm>
+            <a:off x="2468880" y="1133856"/>
+            <a:ext cx="13716" cy="3986784"/>
           </a:xfrm>
           <a:prstGeom prst="rect">
             <a:avLst/>
@@ -17323,14 +17515,14 @@
       </p:sp>
       <p:sp>
         <p:nvSpPr>
-          <p:cNvPr id="9" name="Text 7"/>
-          <p:cNvSpPr/>
-          <p:nvPr/>
-        </p:nvSpPr>
-        <p:spPr>
-          <a:xfrm>
-            <a:off x="3257550" y="1115568"/>
-            <a:ext cx="788670" cy="256032"/>
+          <p:cNvPr id="15" name="Text 13"/>
+          <p:cNvSpPr/>
+          <p:nvPr/>
+        </p:nvSpPr>
+        <p:spPr>
+          <a:xfrm>
+            <a:off x="3257550" y="1389888"/>
+            <a:ext cx="788670" cy="237744"/>
           </a:xfrm>
           <a:prstGeom prst="rect">
             <a:avLst/>
@@ -17346,7 +17538,7 @@
               <a:buNone/>
             </a:pPr>
             <a:r>
-              <a:rPr lang="en-US" sz="800" b="1" dirty="0">
+              <a:rPr lang="en-US" sz="750" b="1" dirty="0">
                 <a:solidFill>
                   <a:srgbClr val="575A5D"/>
                 </a:solidFill>
@@ -17356,20 +17548,20 @@
               </a:rPr>
               <a:t>Q4 FY26</a:t>
             </a:r>
-            <a:endParaRPr lang="en-US" sz="800" dirty="0"/>
-          </a:p>
-        </p:txBody>
-      </p:sp>
-      <p:sp>
-        <p:nvSpPr>
-          <p:cNvPr id="10" name="Shape 8"/>
-          <p:cNvSpPr/>
-          <p:nvPr/>
-        </p:nvSpPr>
-        <p:spPr>
-          <a:xfrm>
-            <a:off x="3257550" y="1115568"/>
-            <a:ext cx="13716" cy="4133088"/>
+            <a:endParaRPr lang="en-US" sz="750" dirty="0"/>
+          </a:p>
+        </p:txBody>
+      </p:sp>
+      <p:sp>
+        <p:nvSpPr>
+          <p:cNvPr id="16" name="Shape 14"/>
+          <p:cNvSpPr/>
+          <p:nvPr/>
+        </p:nvSpPr>
+        <p:spPr>
+          <a:xfrm>
+            <a:off x="3257550" y="1133856"/>
+            <a:ext cx="13716" cy="3986784"/>
           </a:xfrm>
           <a:prstGeom prst="rect">
             <a:avLst/>
@@ -17387,14 +17579,14 @@
       </p:sp>
       <p:sp>
         <p:nvSpPr>
-          <p:cNvPr id="11" name="Shape 9"/>
-          <p:cNvSpPr/>
-          <p:nvPr/>
-        </p:nvSpPr>
-        <p:spPr>
-          <a:xfrm>
-            <a:off x="4046220" y="1408176"/>
-            <a:ext cx="788670" cy="3840480"/>
+          <p:cNvPr id="17" name="Shape 15"/>
+          <p:cNvSpPr/>
+          <p:nvPr/>
+        </p:nvSpPr>
+        <p:spPr>
+          <a:xfrm>
+            <a:off x="4046220" y="1664208"/>
+            <a:ext cx="788670" cy="3456432"/>
           </a:xfrm>
           <a:prstGeom prst="rect">
             <a:avLst/>
@@ -17412,14 +17604,14 @@
       </p:sp>
       <p:sp>
         <p:nvSpPr>
-          <p:cNvPr id="12" name="Text 10"/>
-          <p:cNvSpPr/>
-          <p:nvPr/>
-        </p:nvSpPr>
-        <p:spPr>
-          <a:xfrm>
-            <a:off x="4046220" y="1115568"/>
-            <a:ext cx="788670" cy="256032"/>
+          <p:cNvPr id="18" name="Text 16"/>
+          <p:cNvSpPr/>
+          <p:nvPr/>
+        </p:nvSpPr>
+        <p:spPr>
+          <a:xfrm>
+            <a:off x="4046220" y="1389888"/>
+            <a:ext cx="788670" cy="237744"/>
           </a:xfrm>
           <a:prstGeom prst="rect">
             <a:avLst/>
@@ -17435,7 +17627,7 @@
               <a:buNone/>
             </a:pPr>
             <a:r>
-              <a:rPr lang="en-US" sz="800" b="1" dirty="0">
+              <a:rPr lang="en-US" sz="750" b="1" dirty="0">
                 <a:solidFill>
                   <a:srgbClr val="575A5D"/>
                 </a:solidFill>
@@ -17445,20 +17637,20 @@
               </a:rPr>
               <a:t>Q1 FY27</a:t>
             </a:r>
-            <a:endParaRPr lang="en-US" sz="800" dirty="0"/>
-          </a:p>
-        </p:txBody>
-      </p:sp>
-      <p:sp>
-        <p:nvSpPr>
-          <p:cNvPr id="13" name="Shape 11"/>
-          <p:cNvSpPr/>
-          <p:nvPr/>
-        </p:nvSpPr>
-        <p:spPr>
-          <a:xfrm>
-            <a:off x="4046220" y="1115568"/>
-            <a:ext cx="13716" cy="4133088"/>
+            <a:endParaRPr lang="en-US" sz="750" dirty="0"/>
+          </a:p>
+        </p:txBody>
+      </p:sp>
+      <p:sp>
+        <p:nvSpPr>
+          <p:cNvPr id="19" name="Shape 17"/>
+          <p:cNvSpPr/>
+          <p:nvPr/>
+        </p:nvSpPr>
+        <p:spPr>
+          <a:xfrm>
+            <a:off x="4046220" y="1133856"/>
+            <a:ext cx="13716" cy="3986784"/>
           </a:xfrm>
           <a:prstGeom prst="rect">
             <a:avLst/>
@@ -17476,14 +17668,14 @@
       </p:sp>
       <p:sp>
         <p:nvSpPr>
-          <p:cNvPr id="14" name="Text 12"/>
-          <p:cNvSpPr/>
-          <p:nvPr/>
-        </p:nvSpPr>
-        <p:spPr>
-          <a:xfrm>
-            <a:off x="4834890" y="1115568"/>
-            <a:ext cx="788670" cy="256032"/>
+          <p:cNvPr id="20" name="Text 18"/>
+          <p:cNvSpPr/>
+          <p:nvPr/>
+        </p:nvSpPr>
+        <p:spPr>
+          <a:xfrm>
+            <a:off x="4834890" y="1389888"/>
+            <a:ext cx="788670" cy="237744"/>
           </a:xfrm>
           <a:prstGeom prst="rect">
             <a:avLst/>
@@ -17499,7 +17691,7 @@
               <a:buNone/>
             </a:pPr>
             <a:r>
-              <a:rPr lang="en-US" sz="800" b="1" dirty="0">
+              <a:rPr lang="en-US" sz="750" b="1" dirty="0">
                 <a:solidFill>
                   <a:srgbClr val="575A5D"/>
                 </a:solidFill>
@@ -17509,20 +17701,20 @@
               </a:rPr>
               <a:t>Q2 FY27</a:t>
             </a:r>
-            <a:endParaRPr lang="en-US" sz="800" dirty="0"/>
-          </a:p>
-        </p:txBody>
-      </p:sp>
-      <p:sp>
-        <p:nvSpPr>
-          <p:cNvPr id="15" name="Shape 13"/>
-          <p:cNvSpPr/>
-          <p:nvPr/>
-        </p:nvSpPr>
-        <p:spPr>
-          <a:xfrm>
-            <a:off x="4834890" y="1115568"/>
-            <a:ext cx="13716" cy="4133088"/>
+            <a:endParaRPr lang="en-US" sz="750" dirty="0"/>
+          </a:p>
+        </p:txBody>
+      </p:sp>
+      <p:sp>
+        <p:nvSpPr>
+          <p:cNvPr id="21" name="Shape 19"/>
+          <p:cNvSpPr/>
+          <p:nvPr/>
+        </p:nvSpPr>
+        <p:spPr>
+          <a:xfrm>
+            <a:off x="4834890" y="1133856"/>
+            <a:ext cx="13716" cy="3986784"/>
           </a:xfrm>
           <a:prstGeom prst="rect">
             <a:avLst/>
@@ -17540,14 +17732,14 @@
       </p:sp>
       <p:sp>
         <p:nvSpPr>
-          <p:cNvPr id="16" name="Shape 14"/>
-          <p:cNvSpPr/>
-          <p:nvPr/>
-        </p:nvSpPr>
-        <p:spPr>
-          <a:xfrm>
-            <a:off x="5623560" y="1408176"/>
-            <a:ext cx="788670" cy="3840480"/>
+          <p:cNvPr id="22" name="Shape 20"/>
+          <p:cNvSpPr/>
+          <p:nvPr/>
+        </p:nvSpPr>
+        <p:spPr>
+          <a:xfrm>
+            <a:off x="5623560" y="1664208"/>
+            <a:ext cx="788670" cy="3456432"/>
           </a:xfrm>
           <a:prstGeom prst="rect">
             <a:avLst/>
@@ -17565,14 +17757,14 @@
       </p:sp>
       <p:sp>
         <p:nvSpPr>
-          <p:cNvPr id="17" name="Text 15"/>
-          <p:cNvSpPr/>
-          <p:nvPr/>
-        </p:nvSpPr>
-        <p:spPr>
-          <a:xfrm>
-            <a:off x="5623560" y="1115568"/>
-            <a:ext cx="788670" cy="256032"/>
+          <p:cNvPr id="23" name="Text 21"/>
+          <p:cNvSpPr/>
+          <p:nvPr/>
+        </p:nvSpPr>
+        <p:spPr>
+          <a:xfrm>
+            <a:off x="5623560" y="1389888"/>
+            <a:ext cx="788670" cy="237744"/>
           </a:xfrm>
           <a:prstGeom prst="rect">
             <a:avLst/>
@@ -17588,7 +17780,7 @@
               <a:buNone/>
             </a:pPr>
             <a:r>
-              <a:rPr lang="en-US" sz="800" b="1" dirty="0">
+              <a:rPr lang="en-US" sz="750" b="1" dirty="0">
                 <a:solidFill>
                   <a:srgbClr val="575A5D"/>
                 </a:solidFill>
@@ -17598,20 +17790,20 @@
               </a:rPr>
               <a:t>Q3 FY27</a:t>
             </a:r>
-            <a:endParaRPr lang="en-US" sz="800" dirty="0"/>
-          </a:p>
-        </p:txBody>
-      </p:sp>
-      <p:sp>
-        <p:nvSpPr>
-          <p:cNvPr id="18" name="Shape 16"/>
-          <p:cNvSpPr/>
-          <p:nvPr/>
-        </p:nvSpPr>
-        <p:spPr>
-          <a:xfrm>
-            <a:off x="5623560" y="1115568"/>
-            <a:ext cx="13716" cy="4133088"/>
+            <a:endParaRPr lang="en-US" sz="750" dirty="0"/>
+          </a:p>
+        </p:txBody>
+      </p:sp>
+      <p:sp>
+        <p:nvSpPr>
+          <p:cNvPr id="24" name="Shape 22"/>
+          <p:cNvSpPr/>
+          <p:nvPr/>
+        </p:nvSpPr>
+        <p:spPr>
+          <a:xfrm>
+            <a:off x="5623560" y="1133856"/>
+            <a:ext cx="13716" cy="3986784"/>
           </a:xfrm>
           <a:prstGeom prst="rect">
             <a:avLst/>
@@ -17629,14 +17821,14 @@
       </p:sp>
       <p:sp>
         <p:nvSpPr>
-          <p:cNvPr id="19" name="Text 17"/>
-          <p:cNvSpPr/>
-          <p:nvPr/>
-        </p:nvSpPr>
-        <p:spPr>
-          <a:xfrm>
-            <a:off x="6412230" y="1115568"/>
-            <a:ext cx="788670" cy="256032"/>
+          <p:cNvPr id="25" name="Text 23"/>
+          <p:cNvSpPr/>
+          <p:nvPr/>
+        </p:nvSpPr>
+        <p:spPr>
+          <a:xfrm>
+            <a:off x="6412230" y="1389888"/>
+            <a:ext cx="788670" cy="237744"/>
           </a:xfrm>
           <a:prstGeom prst="rect">
             <a:avLst/>
@@ -17652,7 +17844,7 @@
               <a:buNone/>
             </a:pPr>
             <a:r>
-              <a:rPr lang="en-US" sz="800" b="1" dirty="0">
+              <a:rPr lang="en-US" sz="750" b="1" dirty="0">
                 <a:solidFill>
                   <a:srgbClr val="575A5D"/>
                 </a:solidFill>
@@ -17662,20 +17854,20 @@
               </a:rPr>
               <a:t>Q4 FY27</a:t>
             </a:r>
-            <a:endParaRPr lang="en-US" sz="800" dirty="0"/>
-          </a:p>
-        </p:txBody>
-      </p:sp>
-      <p:sp>
-        <p:nvSpPr>
-          <p:cNvPr id="20" name="Shape 18"/>
-          <p:cNvSpPr/>
-          <p:nvPr/>
-        </p:nvSpPr>
-        <p:spPr>
-          <a:xfrm>
-            <a:off x="6412230" y="1115568"/>
-            <a:ext cx="13716" cy="4133088"/>
+            <a:endParaRPr lang="en-US" sz="750" dirty="0"/>
+          </a:p>
+        </p:txBody>
+      </p:sp>
+      <p:sp>
+        <p:nvSpPr>
+          <p:cNvPr id="26" name="Shape 24"/>
+          <p:cNvSpPr/>
+          <p:nvPr/>
+        </p:nvSpPr>
+        <p:spPr>
+          <a:xfrm>
+            <a:off x="6412230" y="1133856"/>
+            <a:ext cx="13716" cy="3986784"/>
           </a:xfrm>
           <a:prstGeom prst="rect">
             <a:avLst/>
@@ -17693,14 +17885,14 @@
       </p:sp>
       <p:sp>
         <p:nvSpPr>
-          <p:cNvPr id="21" name="Shape 19"/>
-          <p:cNvSpPr/>
-          <p:nvPr/>
-        </p:nvSpPr>
-        <p:spPr>
-          <a:xfrm>
-            <a:off x="7200900" y="1408176"/>
-            <a:ext cx="788670" cy="3840480"/>
+          <p:cNvPr id="27" name="Shape 25"/>
+          <p:cNvSpPr/>
+          <p:nvPr/>
+        </p:nvSpPr>
+        <p:spPr>
+          <a:xfrm>
+            <a:off x="7200900" y="1664208"/>
+            <a:ext cx="788670" cy="3456432"/>
           </a:xfrm>
           <a:prstGeom prst="rect">
             <a:avLst/>
@@ -17718,14 +17910,14 @@
       </p:sp>
       <p:sp>
         <p:nvSpPr>
-          <p:cNvPr id="22" name="Text 20"/>
-          <p:cNvSpPr/>
-          <p:nvPr/>
-        </p:nvSpPr>
-        <p:spPr>
-          <a:xfrm>
-            <a:off x="7200900" y="1115568"/>
-            <a:ext cx="788670" cy="256032"/>
+          <p:cNvPr id="28" name="Text 26"/>
+          <p:cNvSpPr/>
+          <p:nvPr/>
+        </p:nvSpPr>
+        <p:spPr>
+          <a:xfrm>
+            <a:off x="7200900" y="1389888"/>
+            <a:ext cx="788670" cy="237744"/>
           </a:xfrm>
           <a:prstGeom prst="rect">
             <a:avLst/>
@@ -17741,7 +17933,7 @@
               <a:buNone/>
             </a:pPr>
             <a:r>
-              <a:rPr lang="en-US" sz="800" b="1" dirty="0">
+              <a:rPr lang="en-US" sz="750" b="1" dirty="0">
                 <a:solidFill>
                   <a:srgbClr val="575A5D"/>
                 </a:solidFill>
@@ -17751,20 +17943,20 @@
               </a:rPr>
               <a:t>Q1 FY28</a:t>
             </a:r>
-            <a:endParaRPr lang="en-US" sz="800" dirty="0"/>
-          </a:p>
-        </p:txBody>
-      </p:sp>
-      <p:sp>
-        <p:nvSpPr>
-          <p:cNvPr id="23" name="Shape 21"/>
-          <p:cNvSpPr/>
-          <p:nvPr/>
-        </p:nvSpPr>
-        <p:spPr>
-          <a:xfrm>
-            <a:off x="7200900" y="1115568"/>
-            <a:ext cx="13716" cy="4133088"/>
+            <a:endParaRPr lang="en-US" sz="750" dirty="0"/>
+          </a:p>
+        </p:txBody>
+      </p:sp>
+      <p:sp>
+        <p:nvSpPr>
+          <p:cNvPr id="29" name="Shape 27"/>
+          <p:cNvSpPr/>
+          <p:nvPr/>
+        </p:nvSpPr>
+        <p:spPr>
+          <a:xfrm>
+            <a:off x="7200900" y="1133856"/>
+            <a:ext cx="13716" cy="3986784"/>
           </a:xfrm>
           <a:prstGeom prst="rect">
             <a:avLst/>
@@ -17782,14 +17974,14 @@
       </p:sp>
       <p:sp>
         <p:nvSpPr>
-          <p:cNvPr id="24" name="Text 22"/>
-          <p:cNvSpPr/>
-          <p:nvPr/>
-        </p:nvSpPr>
-        <p:spPr>
-          <a:xfrm>
-            <a:off x="7989570" y="1115568"/>
-            <a:ext cx="788670" cy="256032"/>
+          <p:cNvPr id="30" name="Text 28"/>
+          <p:cNvSpPr/>
+          <p:nvPr/>
+        </p:nvSpPr>
+        <p:spPr>
+          <a:xfrm>
+            <a:off x="7989570" y="1389888"/>
+            <a:ext cx="788670" cy="237744"/>
           </a:xfrm>
           <a:prstGeom prst="rect">
             <a:avLst/>
@@ -17805,7 +17997,7 @@
               <a:buNone/>
             </a:pPr>
             <a:r>
-              <a:rPr lang="en-US" sz="800" b="1" dirty="0">
+              <a:rPr lang="en-US" sz="750" b="1" dirty="0">
                 <a:solidFill>
                   <a:srgbClr val="575A5D"/>
                 </a:solidFill>
@@ -17815,20 +18007,20 @@
               </a:rPr>
               <a:t>Q2 FY28</a:t>
             </a:r>
-            <a:endParaRPr lang="en-US" sz="800" dirty="0"/>
-          </a:p>
-        </p:txBody>
-      </p:sp>
-      <p:sp>
-        <p:nvSpPr>
-          <p:cNvPr id="25" name="Shape 23"/>
-          <p:cNvSpPr/>
-          <p:nvPr/>
-        </p:nvSpPr>
-        <p:spPr>
-          <a:xfrm>
-            <a:off x="7989570" y="1115568"/>
-            <a:ext cx="13716" cy="4133088"/>
+            <a:endParaRPr lang="en-US" sz="750" dirty="0"/>
+          </a:p>
+        </p:txBody>
+      </p:sp>
+      <p:sp>
+        <p:nvSpPr>
+          <p:cNvPr id="31" name="Shape 29"/>
+          <p:cNvSpPr/>
+          <p:nvPr/>
+        </p:nvSpPr>
+        <p:spPr>
+          <a:xfrm>
+            <a:off x="7989570" y="1133856"/>
+            <a:ext cx="13716" cy="3986784"/>
           </a:xfrm>
           <a:prstGeom prst="rect">
             <a:avLst/>
@@ -17846,14 +18038,39 @@
       </p:sp>
       <p:sp>
         <p:nvSpPr>
-          <p:cNvPr id="26" name="Shape 24"/>
-          <p:cNvSpPr/>
-          <p:nvPr/>
-        </p:nvSpPr>
-        <p:spPr>
-          <a:xfrm>
-            <a:off x="2468880" y="859536"/>
-            <a:ext cx="1577340" cy="237744"/>
+          <p:cNvPr id="32" name="Shape 30"/>
+          <p:cNvSpPr/>
+          <p:nvPr/>
+        </p:nvSpPr>
+        <p:spPr>
+          <a:xfrm>
+            <a:off x="274320" y="1664208"/>
+            <a:ext cx="8503920" cy="356616"/>
+          </a:xfrm>
+          <a:prstGeom prst="rect">
+            <a:avLst/>
+          </a:prstGeom>
+          <a:solidFill>
+            <a:srgbClr val="FFFFFF"/>
+          </a:solidFill>
+          <a:ln w="12700">
+            <a:solidFill>
+              <a:srgbClr val="E7ECF0"/>
+            </a:solidFill>
+            <a:prstDash val="solid"/>
+          </a:ln>
+        </p:spPr>
+      </p:sp>
+      <p:sp>
+        <p:nvSpPr>
+          <p:cNvPr id="33" name="Shape 31"/>
+          <p:cNvSpPr/>
+          <p:nvPr/>
+        </p:nvSpPr>
+        <p:spPr>
+          <a:xfrm>
+            <a:off x="274320" y="1664208"/>
+            <a:ext cx="54864" cy="356616"/>
           </a:xfrm>
           <a:prstGeom prst="rect">
             <a:avLst/>
@@ -17871,14 +18088,14 @@
       </p:sp>
       <p:sp>
         <p:nvSpPr>
-          <p:cNvPr id="27" name="Text 25"/>
-          <p:cNvSpPr/>
-          <p:nvPr/>
-        </p:nvSpPr>
-        <p:spPr>
-          <a:xfrm>
-            <a:off x="2514600" y="859536"/>
-            <a:ext cx="1485900" cy="237744"/>
+          <p:cNvPr id="34" name="Text 32"/>
+          <p:cNvSpPr/>
+          <p:nvPr/>
+        </p:nvSpPr>
+        <p:spPr>
+          <a:xfrm>
+            <a:off x="384048" y="1691640"/>
+            <a:ext cx="1892808" cy="201168"/>
           </a:xfrm>
           <a:prstGeom prst="rect">
             <a:avLst/>
@@ -17894,7 +18111,302 @@
               <a:buNone/>
             </a:pPr>
             <a:r>
-              <a:rPr lang="en-US" sz="750" b="1" dirty="0">
+              <a:rPr lang="en-US" sz="850" b="1" dirty="0">
+                <a:solidFill>
+                  <a:srgbClr val="06185F"/>
+                </a:solidFill>
+                <a:latin typeface="Calibri" pitchFamily="34" charset="0"/>
+                <a:ea typeface="Calibri" pitchFamily="34" charset="-122"/>
+                <a:cs typeface="Calibri" pitchFamily="34" charset="-120"/>
+              </a:rPr>
+              <a:t>NCUA 5300 Call Reports</a:t>
+            </a:r>
+            <a:endParaRPr lang="en-US" sz="850" dirty="0"/>
+          </a:p>
+        </p:txBody>
+      </p:sp>
+      <p:sp>
+        <p:nvSpPr>
+          <p:cNvPr id="35" name="Text 33"/>
+          <p:cNvSpPr/>
+          <p:nvPr/>
+        </p:nvSpPr>
+        <p:spPr>
+          <a:xfrm>
+            <a:off x="384048" y="1883664"/>
+            <a:ext cx="1892808" cy="137160"/>
+          </a:xfrm>
+          <a:prstGeom prst="rect">
+            <a:avLst/>
+          </a:prstGeom>
+          <a:noFill/>
+          <a:ln/>
+        </p:spPr>
+        <p:txBody>
+          <a:bodyPr wrap="square" lIns="0" tIns="0" rIns="0" bIns="0" rtlCol="0" anchor="ctr"/>
+          <a:lstStyle/>
+          <a:p>
+            <a:pPr indent="0" marL="0">
+              <a:buNone/>
+            </a:pPr>
+            <a:r>
+              <a:rPr lang="en-US" sz="750" i="1" dirty="0">
+                <a:solidFill>
+                  <a:srgbClr val="B6BBC0"/>
+                </a:solidFill>
+                <a:latin typeface="Calibri" pitchFamily="34" charset="0"/>
+                <a:ea typeface="Calibri" pitchFamily="34" charset="-122"/>
+                <a:cs typeface="Calibri" pitchFamily="34" charset="-120"/>
+              </a:rPr>
+              <a:t>Public regulatory</a:t>
+            </a:r>
+            <a:endParaRPr lang="en-US" sz="750" dirty="0"/>
+          </a:p>
+        </p:txBody>
+      </p:sp>
+      <p:sp>
+        <p:nvSpPr>
+          <p:cNvPr id="36" name="Shape 34"/>
+          <p:cNvSpPr/>
+          <p:nvPr/>
+        </p:nvSpPr>
+        <p:spPr>
+          <a:xfrm>
+            <a:off x="2505456" y="1737360"/>
+            <a:ext cx="715518" cy="182880"/>
+          </a:xfrm>
+          <a:prstGeom prst="rect">
+            <a:avLst/>
+          </a:prstGeom>
+          <a:solidFill>
+            <a:srgbClr val="085CE5"/>
+          </a:solidFill>
+          <a:ln w="12700">
+            <a:solidFill>
+              <a:srgbClr val="085CE5"/>
+            </a:solidFill>
+            <a:prstDash val="solid"/>
+          </a:ln>
+        </p:spPr>
+      </p:sp>
+      <p:sp>
+        <p:nvSpPr>
+          <p:cNvPr id="37" name="Text 35"/>
+          <p:cNvSpPr/>
+          <p:nvPr/>
+        </p:nvSpPr>
+        <p:spPr>
+          <a:xfrm>
+            <a:off x="3275838" y="1737360"/>
+            <a:ext cx="2194560" cy="182880"/>
+          </a:xfrm>
+          <a:prstGeom prst="rect">
+            <a:avLst/>
+          </a:prstGeom>
+          <a:noFill/>
+          <a:ln/>
+        </p:spPr>
+        <p:txBody>
+          <a:bodyPr wrap="square" lIns="0" tIns="0" rIns="0" bIns="0" rtlCol="0" anchor="ctr"/>
+          <a:lstStyle/>
+          <a:p>
+            <a:pPr indent="0" marL="0">
+              <a:buNone/>
+            </a:pPr>
+            <a:r>
+              <a:rPr lang="en-US" sz="750" i="1" dirty="0">
+                <a:solidFill>
+                  <a:srgbClr val="085CE5"/>
+                </a:solidFill>
+                <a:latin typeface="Calibri" pitchFamily="34" charset="0"/>
+                <a:ea typeface="Calibri" pitchFamily="34" charset="-122"/>
+                <a:cs typeface="Calibri" pitchFamily="34" charset="-120"/>
+              </a:rPr>
+              <a:t>Call Report AI</a:t>
+            </a:r>
+            <a:endParaRPr lang="en-US" sz="750" dirty="0"/>
+          </a:p>
+        </p:txBody>
+      </p:sp>
+      <p:sp>
+        <p:nvSpPr>
+          <p:cNvPr id="38" name="Shape 36"/>
+          <p:cNvSpPr/>
+          <p:nvPr/>
+        </p:nvSpPr>
+        <p:spPr>
+          <a:xfrm>
+            <a:off x="274320" y="2048256"/>
+            <a:ext cx="8503920" cy="356616"/>
+          </a:xfrm>
+          <a:prstGeom prst="rect">
+            <a:avLst/>
+          </a:prstGeom>
+          <a:solidFill>
+            <a:srgbClr val="F8F9FA"/>
+          </a:solidFill>
+          <a:ln w="12700">
+            <a:solidFill>
+              <a:srgbClr val="E7ECF0"/>
+            </a:solidFill>
+            <a:prstDash val="solid"/>
+          </a:ln>
+        </p:spPr>
+      </p:sp>
+      <p:sp>
+        <p:nvSpPr>
+          <p:cNvPr id="39" name="Shape 37"/>
+          <p:cNvSpPr/>
+          <p:nvPr/>
+        </p:nvSpPr>
+        <p:spPr>
+          <a:xfrm>
+            <a:off x="274320" y="2048256"/>
+            <a:ext cx="54864" cy="356616"/>
+          </a:xfrm>
+          <a:prstGeom prst="rect">
+            <a:avLst/>
+          </a:prstGeom>
+          <a:solidFill>
+            <a:srgbClr val="085CE5"/>
+          </a:solidFill>
+          <a:ln w="12700">
+            <a:solidFill>
+              <a:srgbClr val="085CE5"/>
+            </a:solidFill>
+            <a:prstDash val="solid"/>
+          </a:ln>
+        </p:spPr>
+      </p:sp>
+      <p:sp>
+        <p:nvSpPr>
+          <p:cNvPr id="40" name="Text 38"/>
+          <p:cNvSpPr/>
+          <p:nvPr/>
+        </p:nvSpPr>
+        <p:spPr>
+          <a:xfrm>
+            <a:off x="384048" y="2075688"/>
+            <a:ext cx="1892808" cy="201168"/>
+          </a:xfrm>
+          <a:prstGeom prst="rect">
+            <a:avLst/>
+          </a:prstGeom>
+          <a:noFill/>
+          <a:ln/>
+        </p:spPr>
+        <p:txBody>
+          <a:bodyPr wrap="square" lIns="0" tIns="0" rIns="0" bIns="0" rtlCol="0" anchor="ctr"/>
+          <a:lstStyle/>
+          <a:p>
+            <a:pPr indent="0" marL="0">
+              <a:buNone/>
+            </a:pPr>
+            <a:r>
+              <a:rPr lang="en-US" sz="850" b="1" dirty="0">
+                <a:solidFill>
+                  <a:srgbClr val="06185F"/>
+                </a:solidFill>
+                <a:latin typeface="Calibri" pitchFamily="34" charset="0"/>
+                <a:ea typeface="Calibri" pitchFamily="34" charset="-122"/>
+                <a:cs typeface="Calibri" pitchFamily="34" charset="-120"/>
+              </a:rPr>
+              <a:t>ACH / EPS</a:t>
+            </a:r>
+            <a:endParaRPr lang="en-US" sz="850" dirty="0"/>
+          </a:p>
+        </p:txBody>
+      </p:sp>
+      <p:sp>
+        <p:nvSpPr>
+          <p:cNvPr id="41" name="Text 39"/>
+          <p:cNvSpPr/>
+          <p:nvPr/>
+        </p:nvSpPr>
+        <p:spPr>
+          <a:xfrm>
+            <a:off x="384048" y="2267712"/>
+            <a:ext cx="1892808" cy="137160"/>
+          </a:xfrm>
+          <a:prstGeom prst="rect">
+            <a:avLst/>
+          </a:prstGeom>
+          <a:noFill/>
+          <a:ln/>
+        </p:spPr>
+        <p:txBody>
+          <a:bodyPr wrap="square" lIns="0" tIns="0" rIns="0" bIns="0" rtlCol="0" anchor="ctr"/>
+          <a:lstStyle/>
+          <a:p>
+            <a:pPr indent="0" marL="0">
+              <a:buNone/>
+            </a:pPr>
+            <a:r>
+              <a:rPr lang="en-US" sz="750" i="1" dirty="0">
+                <a:solidFill>
+                  <a:srgbClr val="B6BBC0"/>
+                </a:solidFill>
+                <a:latin typeface="Calibri" pitchFamily="34" charset="0"/>
+                <a:ea typeface="Calibri" pitchFamily="34" charset="-122"/>
+                <a:cs typeface="Calibri" pitchFamily="34" charset="-120"/>
+              </a:rPr>
+              <a:t>ACH credits, debits, RDC</a:t>
+            </a:r>
+            <a:endParaRPr lang="en-US" sz="750" dirty="0"/>
+          </a:p>
+        </p:txBody>
+      </p:sp>
+      <p:sp>
+        <p:nvSpPr>
+          <p:cNvPr id="42" name="Shape 40"/>
+          <p:cNvSpPr/>
+          <p:nvPr/>
+        </p:nvSpPr>
+        <p:spPr>
+          <a:xfrm>
+            <a:off x="2505456" y="2121408"/>
+            <a:ext cx="1504188" cy="182880"/>
+          </a:xfrm>
+          <a:prstGeom prst="rect">
+            <a:avLst/>
+          </a:prstGeom>
+          <a:solidFill>
+            <a:srgbClr val="085CE5"/>
+          </a:solidFill>
+          <a:ln w="12700">
+            <a:solidFill>
+              <a:srgbClr val="085CE5"/>
+            </a:solidFill>
+            <a:prstDash val="solid"/>
+          </a:ln>
+        </p:spPr>
+      </p:sp>
+      <p:sp>
+        <p:nvSpPr>
+          <p:cNvPr id="43" name="Text 41"/>
+          <p:cNvSpPr/>
+          <p:nvPr/>
+        </p:nvSpPr>
+        <p:spPr>
+          <a:xfrm>
+            <a:off x="2569464" y="2121408"/>
+            <a:ext cx="1394460" cy="182880"/>
+          </a:xfrm>
+          <a:prstGeom prst="rect">
+            <a:avLst/>
+          </a:prstGeom>
+          <a:noFill/>
+          <a:ln/>
+        </p:spPr>
+        <p:txBody>
+          <a:bodyPr wrap="square" lIns="0" tIns="0" rIns="0" bIns="0" rtlCol="0" anchor="ctr"/>
+          <a:lstStyle/>
+          <a:p>
+            <a:pPr indent="0" marL="0">
+              <a:buNone/>
+            </a:pPr>
+            <a:r>
+              <a:rPr lang="en-US" sz="750" dirty="0">
                 <a:solidFill>
                   <a:srgbClr val="FFFFFF"/>
                 </a:solidFill>
@@ -17902,7 +18414,7 @@
                 <a:ea typeface="Calibri" pitchFamily="34" charset="-122"/>
                 <a:cs typeface="Calibri" pitchFamily="34" charset="-120"/>
               </a:rPr>
-              <a:t>PHASE 1 — Foundation  (Q3–Q4 FY26)</a:t>
+              <a:t>Anomaly Detection</a:t>
             </a:r>
             <a:endParaRPr lang="en-US" sz="750" dirty="0"/>
           </a:p>
@@ -17910,14 +18422,999 @@
       </p:sp>
       <p:sp>
         <p:nvSpPr>
-          <p:cNvPr id="28" name="Shape 26"/>
-          <p:cNvSpPr/>
-          <p:nvPr/>
-        </p:nvSpPr>
-        <p:spPr>
-          <a:xfrm>
-            <a:off x="4046220" y="859536"/>
-            <a:ext cx="1577340" cy="237744"/>
+          <p:cNvPr id="44" name="Shape 42"/>
+          <p:cNvSpPr/>
+          <p:nvPr/>
+        </p:nvSpPr>
+        <p:spPr>
+          <a:xfrm>
+            <a:off x="274320" y="2432304"/>
+            <a:ext cx="8503920" cy="356616"/>
+          </a:xfrm>
+          <a:prstGeom prst="rect">
+            <a:avLst/>
+          </a:prstGeom>
+          <a:solidFill>
+            <a:srgbClr val="FFFFFF"/>
+          </a:solidFill>
+          <a:ln w="12700">
+            <a:solidFill>
+              <a:srgbClr val="E7ECF0"/>
+            </a:solidFill>
+            <a:prstDash val="solid"/>
+          </a:ln>
+        </p:spPr>
+      </p:sp>
+      <p:sp>
+        <p:nvSpPr>
+          <p:cNvPr id="45" name="Shape 43"/>
+          <p:cNvSpPr/>
+          <p:nvPr/>
+        </p:nvSpPr>
+        <p:spPr>
+          <a:xfrm>
+            <a:off x="274320" y="2432304"/>
+            <a:ext cx="54864" cy="356616"/>
+          </a:xfrm>
+          <a:prstGeom prst="rect">
+            <a:avLst/>
+          </a:prstGeom>
+          <a:solidFill>
+            <a:srgbClr val="085CE5"/>
+          </a:solidFill>
+          <a:ln w="12700">
+            <a:solidFill>
+              <a:srgbClr val="085CE5"/>
+            </a:solidFill>
+            <a:prstDash val="solid"/>
+          </a:ln>
+        </p:spPr>
+      </p:sp>
+      <p:sp>
+        <p:nvSpPr>
+          <p:cNvPr id="46" name="Text 44"/>
+          <p:cNvSpPr/>
+          <p:nvPr/>
+        </p:nvSpPr>
+        <p:spPr>
+          <a:xfrm>
+            <a:off x="384048" y="2459736"/>
+            <a:ext cx="1892808" cy="201168"/>
+          </a:xfrm>
+          <a:prstGeom prst="rect">
+            <a:avLst/>
+          </a:prstGeom>
+          <a:noFill/>
+          <a:ln/>
+        </p:spPr>
+        <p:txBody>
+          <a:bodyPr wrap="square" lIns="0" tIns="0" rIns="0" bIns="0" rtlCol="0" anchor="ctr"/>
+          <a:lstStyle/>
+          <a:p>
+            <a:pPr indent="0" marL="0">
+              <a:buNone/>
+            </a:pPr>
+            <a:r>
+              <a:rPr lang="en-US" sz="850" b="1" dirty="0">
+                <a:solidFill>
+                  <a:srgbClr val="06185F"/>
+                </a:solidFill>
+                <a:latin typeface="Calibri" pitchFamily="34" charset="0"/>
+                <a:ea typeface="Calibri" pitchFamily="34" charset="-122"/>
+                <a:cs typeface="Calibri" pitchFamily="34" charset="-120"/>
+              </a:rPr>
+              <a:t>Zelle / JHA PayCenter</a:t>
+            </a:r>
+            <a:endParaRPr lang="en-US" sz="850" dirty="0"/>
+          </a:p>
+        </p:txBody>
+      </p:sp>
+      <p:sp>
+        <p:nvSpPr>
+          <p:cNvPr id="47" name="Text 45"/>
+          <p:cNvSpPr/>
+          <p:nvPr/>
+        </p:nvSpPr>
+        <p:spPr>
+          <a:xfrm>
+            <a:off x="384048" y="2651760"/>
+            <a:ext cx="1892808" cy="137160"/>
+          </a:xfrm>
+          <a:prstGeom prst="rect">
+            <a:avLst/>
+          </a:prstGeom>
+          <a:noFill/>
+          <a:ln/>
+        </p:spPr>
+        <p:txBody>
+          <a:bodyPr wrap="square" lIns="0" tIns="0" rIns="0" bIns="0" rtlCol="0" anchor="ctr"/>
+          <a:lstStyle/>
+          <a:p>
+            <a:pPr indent="0" marL="0">
+              <a:buNone/>
+            </a:pPr>
+            <a:r>
+              <a:rPr lang="en-US" sz="750" i="1" dirty="0">
+                <a:solidFill>
+                  <a:srgbClr val="B6BBC0"/>
+                </a:solidFill>
+                <a:latin typeface="Calibri" pitchFamily="34" charset="0"/>
+                <a:ea typeface="Calibri" pitchFamily="34" charset="-122"/>
+                <a:cs typeface="Calibri" pitchFamily="34" charset="-120"/>
+              </a:rPr>
+              <a:t>P2P, Zelle, RTP, FedNow</a:t>
+            </a:r>
+            <a:endParaRPr lang="en-US" sz="750" dirty="0"/>
+          </a:p>
+        </p:txBody>
+      </p:sp>
+      <p:sp>
+        <p:nvSpPr>
+          <p:cNvPr id="48" name="Shape 46"/>
+          <p:cNvSpPr/>
+          <p:nvPr/>
+        </p:nvSpPr>
+        <p:spPr>
+          <a:xfrm>
+            <a:off x="2505456" y="2505456"/>
+            <a:ext cx="1504188" cy="182880"/>
+          </a:xfrm>
+          <a:prstGeom prst="rect">
+            <a:avLst/>
+          </a:prstGeom>
+          <a:solidFill>
+            <a:srgbClr val="085CE5"/>
+          </a:solidFill>
+          <a:ln w="12700">
+            <a:solidFill>
+              <a:srgbClr val="085CE5"/>
+            </a:solidFill>
+            <a:prstDash val="solid"/>
+          </a:ln>
+        </p:spPr>
+      </p:sp>
+      <p:sp>
+        <p:nvSpPr>
+          <p:cNvPr id="49" name="Text 47"/>
+          <p:cNvSpPr/>
+          <p:nvPr/>
+        </p:nvSpPr>
+        <p:spPr>
+          <a:xfrm>
+            <a:off x="2569464" y="2505456"/>
+            <a:ext cx="1394460" cy="182880"/>
+          </a:xfrm>
+          <a:prstGeom prst="rect">
+            <a:avLst/>
+          </a:prstGeom>
+          <a:noFill/>
+          <a:ln/>
+        </p:spPr>
+        <p:txBody>
+          <a:bodyPr wrap="square" lIns="0" tIns="0" rIns="0" bIns="0" rtlCol="0" anchor="ctr"/>
+          <a:lstStyle/>
+          <a:p>
+            <a:pPr indent="0" marL="0">
+              <a:buNone/>
+            </a:pPr>
+            <a:r>
+              <a:rPr lang="en-US" sz="750" dirty="0">
+                <a:solidFill>
+                  <a:srgbClr val="FFFFFF"/>
+                </a:solidFill>
+                <a:latin typeface="Calibri" pitchFamily="34" charset="0"/>
+                <a:ea typeface="Calibri" pitchFamily="34" charset="-122"/>
+                <a:cs typeface="Calibri" pitchFamily="34" charset="-120"/>
+              </a:rPr>
+              <a:t>Zelle Memo Intelligence · Anomaly</a:t>
+            </a:r>
+            <a:endParaRPr lang="en-US" sz="750" dirty="0"/>
+          </a:p>
+        </p:txBody>
+      </p:sp>
+      <p:sp>
+        <p:nvSpPr>
+          <p:cNvPr id="50" name="Shape 48"/>
+          <p:cNvSpPr/>
+          <p:nvPr/>
+        </p:nvSpPr>
+        <p:spPr>
+          <a:xfrm>
+            <a:off x="274320" y="2816352"/>
+            <a:ext cx="8503920" cy="356616"/>
+          </a:xfrm>
+          <a:prstGeom prst="rect">
+            <a:avLst/>
+          </a:prstGeom>
+          <a:solidFill>
+            <a:srgbClr val="F8F9FA"/>
+          </a:solidFill>
+          <a:ln w="12700">
+            <a:solidFill>
+              <a:srgbClr val="E7ECF0"/>
+            </a:solidFill>
+            <a:prstDash val="solid"/>
+          </a:ln>
+        </p:spPr>
+      </p:sp>
+      <p:sp>
+        <p:nvSpPr>
+          <p:cNvPr id="51" name="Shape 49"/>
+          <p:cNvSpPr/>
+          <p:nvPr/>
+        </p:nvSpPr>
+        <p:spPr>
+          <a:xfrm>
+            <a:off x="274320" y="2816352"/>
+            <a:ext cx="54864" cy="356616"/>
+          </a:xfrm>
+          <a:prstGeom prst="rect">
+            <a:avLst/>
+          </a:prstGeom>
+          <a:solidFill>
+            <a:srgbClr val="085CE5"/>
+          </a:solidFill>
+          <a:ln w="12700">
+            <a:solidFill>
+              <a:srgbClr val="085CE5"/>
+            </a:solidFill>
+            <a:prstDash val="solid"/>
+          </a:ln>
+        </p:spPr>
+      </p:sp>
+      <p:sp>
+        <p:nvSpPr>
+          <p:cNvPr id="52" name="Text 50"/>
+          <p:cNvSpPr/>
+          <p:nvPr/>
+        </p:nvSpPr>
+        <p:spPr>
+          <a:xfrm>
+            <a:off x="384048" y="2843784"/>
+            <a:ext cx="1892808" cy="201168"/>
+          </a:xfrm>
+          <a:prstGeom prst="rect">
+            <a:avLst/>
+          </a:prstGeom>
+          <a:noFill/>
+          <a:ln/>
+        </p:spPr>
+        <p:txBody>
+          <a:bodyPr wrap="square" lIns="0" tIns="0" rIns="0" bIns="0" rtlCol="0" anchor="ctr"/>
+          <a:lstStyle/>
+          <a:p>
+            <a:pPr indent="0" marL="0">
+              <a:buNone/>
+            </a:pPr>
+            <a:r>
+              <a:rPr lang="en-US" sz="850" b="1" dirty="0">
+                <a:solidFill>
+                  <a:srgbClr val="06185F"/>
+                </a:solidFill>
+                <a:latin typeface="Calibri" pitchFamily="34" charset="0"/>
+                <a:ea typeface="Calibri" pitchFamily="34" charset="-122"/>
+                <a:cs typeface="Calibri" pitchFamily="34" charset="-120"/>
+              </a:rPr>
+              <a:t>Jack Henry Wires</a:t>
+            </a:r>
+            <a:endParaRPr lang="en-US" sz="850" dirty="0"/>
+          </a:p>
+        </p:txBody>
+      </p:sp>
+      <p:sp>
+        <p:nvSpPr>
+          <p:cNvPr id="53" name="Text 51"/>
+          <p:cNvSpPr/>
+          <p:nvPr/>
+        </p:nvSpPr>
+        <p:spPr>
+          <a:xfrm>
+            <a:off x="384048" y="3035808"/>
+            <a:ext cx="1892808" cy="137160"/>
+          </a:xfrm>
+          <a:prstGeom prst="rect">
+            <a:avLst/>
+          </a:prstGeom>
+          <a:noFill/>
+          <a:ln/>
+        </p:spPr>
+        <p:txBody>
+          <a:bodyPr wrap="square" lIns="0" tIns="0" rIns="0" bIns="0" rtlCol="0" anchor="ctr"/>
+          <a:lstStyle/>
+          <a:p>
+            <a:pPr indent="0" marL="0">
+              <a:buNone/>
+            </a:pPr>
+            <a:r>
+              <a:rPr lang="en-US" sz="750" i="1" dirty="0">
+                <a:solidFill>
+                  <a:srgbClr val="B6BBC0"/>
+                </a:solidFill>
+                <a:latin typeface="Calibri" pitchFamily="34" charset="0"/>
+                <a:ea typeface="Calibri" pitchFamily="34" charset="-122"/>
+                <a:cs typeface="Calibri" pitchFamily="34" charset="-120"/>
+              </a:rPr>
+              <a:t>Domestic FedWire + Intl</a:t>
+            </a:r>
+            <a:endParaRPr lang="en-US" sz="750" dirty="0"/>
+          </a:p>
+        </p:txBody>
+      </p:sp>
+      <p:sp>
+        <p:nvSpPr>
+          <p:cNvPr id="54" name="Shape 52"/>
+          <p:cNvSpPr/>
+          <p:nvPr/>
+        </p:nvSpPr>
+        <p:spPr>
+          <a:xfrm>
+            <a:off x="2505456" y="2889504"/>
+            <a:ext cx="1504188" cy="182880"/>
+          </a:xfrm>
+          <a:prstGeom prst="rect">
+            <a:avLst/>
+          </a:prstGeom>
+          <a:solidFill>
+            <a:srgbClr val="085CE5"/>
+          </a:solidFill>
+          <a:ln w="12700">
+            <a:solidFill>
+              <a:srgbClr val="085CE5"/>
+            </a:solidFill>
+            <a:prstDash val="solid"/>
+          </a:ln>
+        </p:spPr>
+      </p:sp>
+      <p:sp>
+        <p:nvSpPr>
+          <p:cNvPr id="55" name="Text 53"/>
+          <p:cNvSpPr/>
+          <p:nvPr/>
+        </p:nvSpPr>
+        <p:spPr>
+          <a:xfrm>
+            <a:off x="2569464" y="2889504"/>
+            <a:ext cx="1394460" cy="182880"/>
+          </a:xfrm>
+          <a:prstGeom prst="rect">
+            <a:avLst/>
+          </a:prstGeom>
+          <a:noFill/>
+          <a:ln/>
+        </p:spPr>
+        <p:txBody>
+          <a:bodyPr wrap="square" lIns="0" tIns="0" rIns="0" bIns="0" rtlCol="0" anchor="ctr"/>
+          <a:lstStyle/>
+          <a:p>
+            <a:pPr indent="0" marL="0">
+              <a:buNone/>
+            </a:pPr>
+            <a:r>
+              <a:rPr lang="en-US" sz="750" dirty="0">
+                <a:solidFill>
+                  <a:srgbClr val="FFFFFF"/>
+                </a:solidFill>
+                <a:latin typeface="Calibri" pitchFamily="34" charset="0"/>
+                <a:ea typeface="Calibri" pitchFamily="34" charset="-122"/>
+                <a:cs typeface="Calibri" pitchFamily="34" charset="-120"/>
+              </a:rPr>
+              <a:t>Anomaly Detection (wire fraud)</a:t>
+            </a:r>
+            <a:endParaRPr lang="en-US" sz="750" dirty="0"/>
+          </a:p>
+        </p:txBody>
+      </p:sp>
+      <p:sp>
+        <p:nvSpPr>
+          <p:cNvPr id="56" name="Shape 54"/>
+          <p:cNvSpPr/>
+          <p:nvPr/>
+        </p:nvSpPr>
+        <p:spPr>
+          <a:xfrm>
+            <a:off x="274320" y="3200400"/>
+            <a:ext cx="8503920" cy="356616"/>
+          </a:xfrm>
+          <a:prstGeom prst="rect">
+            <a:avLst/>
+          </a:prstGeom>
+          <a:solidFill>
+            <a:srgbClr val="FFFFFF"/>
+          </a:solidFill>
+          <a:ln w="12700">
+            <a:solidFill>
+              <a:srgbClr val="E7ECF0"/>
+            </a:solidFill>
+            <a:prstDash val="solid"/>
+          </a:ln>
+        </p:spPr>
+      </p:sp>
+      <p:sp>
+        <p:nvSpPr>
+          <p:cNvPr id="57" name="Shape 55"/>
+          <p:cNvSpPr/>
+          <p:nvPr/>
+        </p:nvSpPr>
+        <p:spPr>
+          <a:xfrm>
+            <a:off x="274320" y="3200400"/>
+            <a:ext cx="54864" cy="356616"/>
+          </a:xfrm>
+          <a:prstGeom prst="rect">
+            <a:avLst/>
+          </a:prstGeom>
+          <a:solidFill>
+            <a:srgbClr val="085CE5"/>
+          </a:solidFill>
+          <a:ln w="12700">
+            <a:solidFill>
+              <a:srgbClr val="085CE5"/>
+            </a:solidFill>
+            <a:prstDash val="solid"/>
+          </a:ln>
+        </p:spPr>
+      </p:sp>
+      <p:sp>
+        <p:nvSpPr>
+          <p:cNvPr id="58" name="Text 56"/>
+          <p:cNvSpPr/>
+          <p:nvPr/>
+        </p:nvSpPr>
+        <p:spPr>
+          <a:xfrm>
+            <a:off x="384048" y="3227832"/>
+            <a:ext cx="1892808" cy="201168"/>
+          </a:xfrm>
+          <a:prstGeom prst="rect">
+            <a:avLst/>
+          </a:prstGeom>
+          <a:noFill/>
+          <a:ln/>
+        </p:spPr>
+        <p:txBody>
+          <a:bodyPr wrap="square" lIns="0" tIns="0" rIns="0" bIns="0" rtlCol="0" anchor="ctr"/>
+          <a:lstStyle/>
+          <a:p>
+            <a:pPr indent="0" marL="0">
+              <a:buNone/>
+            </a:pPr>
+            <a:r>
+              <a:rPr lang="en-US" sz="850" b="1" dirty="0">
+                <a:solidFill>
+                  <a:srgbClr val="06185F"/>
+                </a:solidFill>
+                <a:latin typeface="Calibri" pitchFamily="34" charset="0"/>
+                <a:ea typeface="Calibri" pitchFamily="34" charset="-122"/>
+                <a:cs typeface="Calibri" pitchFamily="34" charset="-120"/>
+              </a:rPr>
+              <a:t>iPay Bill Pay</a:t>
+            </a:r>
+            <a:endParaRPr lang="en-US" sz="850" dirty="0"/>
+          </a:p>
+        </p:txBody>
+      </p:sp>
+      <p:sp>
+        <p:nvSpPr>
+          <p:cNvPr id="59" name="Text 57"/>
+          <p:cNvSpPr/>
+          <p:nvPr/>
+        </p:nvSpPr>
+        <p:spPr>
+          <a:xfrm>
+            <a:off x="384048" y="3419856"/>
+            <a:ext cx="1892808" cy="137160"/>
+          </a:xfrm>
+          <a:prstGeom prst="rect">
+            <a:avLst/>
+          </a:prstGeom>
+          <a:noFill/>
+          <a:ln/>
+        </p:spPr>
+        <p:txBody>
+          <a:bodyPr wrap="square" lIns="0" tIns="0" rIns="0" bIns="0" rtlCol="0" anchor="ctr"/>
+          <a:lstStyle/>
+          <a:p>
+            <a:pPr indent="0" marL="0">
+              <a:buNone/>
+            </a:pPr>
+            <a:r>
+              <a:rPr lang="en-US" sz="750" i="1" dirty="0">
+                <a:solidFill>
+                  <a:srgbClr val="B6BBC0"/>
+                </a:solidFill>
+                <a:latin typeface="Calibri" pitchFamily="34" charset="0"/>
+                <a:ea typeface="Calibri" pitchFamily="34" charset="-122"/>
+                <a:cs typeface="Calibri" pitchFamily="34" charset="-120"/>
+              </a:rPr>
+              <a:t>Consumer + Business bill pay</a:t>
+            </a:r>
+            <a:endParaRPr lang="en-US" sz="750" dirty="0"/>
+          </a:p>
+        </p:txBody>
+      </p:sp>
+      <p:sp>
+        <p:nvSpPr>
+          <p:cNvPr id="60" name="Shape 58"/>
+          <p:cNvSpPr/>
+          <p:nvPr/>
+        </p:nvSpPr>
+        <p:spPr>
+          <a:xfrm>
+            <a:off x="2505456" y="3273552"/>
+            <a:ext cx="1504188" cy="182880"/>
+          </a:xfrm>
+          <a:prstGeom prst="rect">
+            <a:avLst/>
+          </a:prstGeom>
+          <a:solidFill>
+            <a:srgbClr val="085CE5"/>
+          </a:solidFill>
+          <a:ln w="12700">
+            <a:solidFill>
+              <a:srgbClr val="085CE5"/>
+            </a:solidFill>
+            <a:prstDash val="solid"/>
+          </a:ln>
+        </p:spPr>
+      </p:sp>
+      <p:sp>
+        <p:nvSpPr>
+          <p:cNvPr id="61" name="Text 59"/>
+          <p:cNvSpPr/>
+          <p:nvPr/>
+        </p:nvSpPr>
+        <p:spPr>
+          <a:xfrm>
+            <a:off x="2569464" y="3273552"/>
+            <a:ext cx="1394460" cy="182880"/>
+          </a:xfrm>
+          <a:prstGeom prst="rect">
+            <a:avLst/>
+          </a:prstGeom>
+          <a:noFill/>
+          <a:ln/>
+        </p:spPr>
+        <p:txBody>
+          <a:bodyPr wrap="square" lIns="0" tIns="0" rIns="0" bIns="0" rtlCol="0" anchor="ctr"/>
+          <a:lstStyle/>
+          <a:p>
+            <a:pPr indent="0" marL="0">
+              <a:buNone/>
+            </a:pPr>
+            <a:r>
+              <a:rPr lang="en-US" sz="750" dirty="0">
+                <a:solidFill>
+                  <a:srgbClr val="FFFFFF"/>
+                </a:solidFill>
+                <a:latin typeface="Calibri" pitchFamily="34" charset="0"/>
+                <a:ea typeface="Calibri" pitchFamily="34" charset="-122"/>
+                <a:cs typeface="Calibri" pitchFamily="34" charset="-120"/>
+              </a:rPr>
+              <a:t>Cross-Sell Propensity</a:t>
+            </a:r>
+            <a:endParaRPr lang="en-US" sz="750" dirty="0"/>
+          </a:p>
+        </p:txBody>
+      </p:sp>
+      <p:sp>
+        <p:nvSpPr>
+          <p:cNvPr id="62" name="Shape 60"/>
+          <p:cNvSpPr/>
+          <p:nvPr/>
+        </p:nvSpPr>
+        <p:spPr>
+          <a:xfrm>
+            <a:off x="274320" y="3584448"/>
+            <a:ext cx="8503920" cy="356616"/>
+          </a:xfrm>
+          <a:prstGeom prst="rect">
+            <a:avLst/>
+          </a:prstGeom>
+          <a:solidFill>
+            <a:srgbClr val="F8F9FA"/>
+          </a:solidFill>
+          <a:ln w="12700">
+            <a:solidFill>
+              <a:srgbClr val="E7ECF0"/>
+            </a:solidFill>
+            <a:prstDash val="solid"/>
+          </a:ln>
+        </p:spPr>
+      </p:sp>
+      <p:sp>
+        <p:nvSpPr>
+          <p:cNvPr id="63" name="Shape 61"/>
+          <p:cNvSpPr/>
+          <p:nvPr/>
+        </p:nvSpPr>
+        <p:spPr>
+          <a:xfrm>
+            <a:off x="274320" y="3584448"/>
+            <a:ext cx="54864" cy="356616"/>
+          </a:xfrm>
+          <a:prstGeom prst="rect">
+            <a:avLst/>
+          </a:prstGeom>
+          <a:solidFill>
+            <a:srgbClr val="085CE5"/>
+          </a:solidFill>
+          <a:ln w="12700">
+            <a:solidFill>
+              <a:srgbClr val="085CE5"/>
+            </a:solidFill>
+            <a:prstDash val="solid"/>
+          </a:ln>
+        </p:spPr>
+      </p:sp>
+      <p:sp>
+        <p:nvSpPr>
+          <p:cNvPr id="64" name="Text 62"/>
+          <p:cNvSpPr/>
+          <p:nvPr/>
+        </p:nvSpPr>
+        <p:spPr>
+          <a:xfrm>
+            <a:off x="384048" y="3611880"/>
+            <a:ext cx="1892808" cy="201168"/>
+          </a:xfrm>
+          <a:prstGeom prst="rect">
+            <a:avLst/>
+          </a:prstGeom>
+          <a:noFill/>
+          <a:ln/>
+        </p:spPr>
+        <p:txBody>
+          <a:bodyPr wrap="square" lIns="0" tIns="0" rIns="0" bIns="0" rtlCol="0" anchor="ctr"/>
+          <a:lstStyle/>
+          <a:p>
+            <a:pPr indent="0" marL="0">
+              <a:buNone/>
+            </a:pPr>
+            <a:r>
+              <a:rPr lang="en-US" sz="850" b="1" dirty="0">
+                <a:solidFill>
+                  <a:srgbClr val="06185F"/>
+                </a:solidFill>
+                <a:latin typeface="Calibri" pitchFamily="34" charset="0"/>
+                <a:ea typeface="Calibri" pitchFamily="34" charset="-122"/>
+                <a:cs typeface="Calibri" pitchFamily="34" charset="-120"/>
+              </a:rPr>
+              <a:t>JHA SmartPay / Biz Payments</a:t>
+            </a:r>
+            <a:endParaRPr lang="en-US" sz="850" dirty="0"/>
+          </a:p>
+        </p:txBody>
+      </p:sp>
+      <p:sp>
+        <p:nvSpPr>
+          <p:cNvPr id="65" name="Text 63"/>
+          <p:cNvSpPr/>
+          <p:nvPr/>
+        </p:nvSpPr>
+        <p:spPr>
+          <a:xfrm>
+            <a:off x="384048" y="3803904"/>
+            <a:ext cx="1892808" cy="137160"/>
+          </a:xfrm>
+          <a:prstGeom prst="rect">
+            <a:avLst/>
+          </a:prstGeom>
+          <a:noFill/>
+          <a:ln/>
+        </p:spPr>
+        <p:txBody>
+          <a:bodyPr wrap="square" lIns="0" tIns="0" rIns="0" bIns="0" rtlCol="0" anchor="ctr"/>
+          <a:lstStyle/>
+          <a:p>
+            <a:pPr indent="0" marL="0">
+              <a:buNone/>
+            </a:pPr>
+            <a:r>
+              <a:rPr lang="en-US" sz="750" i="1" dirty="0">
+                <a:solidFill>
+                  <a:srgbClr val="B6BBC0"/>
+                </a:solidFill>
+                <a:latin typeface="Calibri" pitchFamily="34" charset="0"/>
+                <a:ea typeface="Calibri" pitchFamily="34" charset="-122"/>
+                <a:cs typeface="Calibri" pitchFamily="34" charset="-120"/>
+              </a:rPr>
+              <a:t>B2B ACH, vendor, remittance</a:t>
+            </a:r>
+            <a:endParaRPr lang="en-US" sz="750" dirty="0"/>
+          </a:p>
+        </p:txBody>
+      </p:sp>
+      <p:sp>
+        <p:nvSpPr>
+          <p:cNvPr id="66" name="Shape 64"/>
+          <p:cNvSpPr/>
+          <p:nvPr/>
+        </p:nvSpPr>
+        <p:spPr>
+          <a:xfrm>
+            <a:off x="2505456" y="3657600"/>
+            <a:ext cx="1504188" cy="182880"/>
+          </a:xfrm>
+          <a:prstGeom prst="rect">
+            <a:avLst/>
+          </a:prstGeom>
+          <a:solidFill>
+            <a:srgbClr val="085CE5"/>
+          </a:solidFill>
+          <a:ln w="12700">
+            <a:solidFill>
+              <a:srgbClr val="085CE5"/>
+            </a:solidFill>
+            <a:prstDash val="solid"/>
+          </a:ln>
+        </p:spPr>
+      </p:sp>
+      <p:sp>
+        <p:nvSpPr>
+          <p:cNvPr id="67" name="Text 65"/>
+          <p:cNvSpPr/>
+          <p:nvPr/>
+        </p:nvSpPr>
+        <p:spPr>
+          <a:xfrm>
+            <a:off x="2569464" y="3657600"/>
+            <a:ext cx="1394460" cy="182880"/>
+          </a:xfrm>
+          <a:prstGeom prst="rect">
+            <a:avLst/>
+          </a:prstGeom>
+          <a:noFill/>
+          <a:ln/>
+        </p:spPr>
+        <p:txBody>
+          <a:bodyPr wrap="square" lIns="0" tIns="0" rIns="0" bIns="0" rtlCol="0" anchor="ctr"/>
+          <a:lstStyle/>
+          <a:p>
+            <a:pPr indent="0" marL="0">
+              <a:buNone/>
+            </a:pPr>
+            <a:r>
+              <a:rPr lang="en-US" sz="750" dirty="0">
+                <a:solidFill>
+                  <a:srgbClr val="FFFFFF"/>
+                </a:solidFill>
+                <a:latin typeface="Calibri" pitchFamily="34" charset="0"/>
+                <a:ea typeface="Calibri" pitchFamily="34" charset="-122"/>
+                <a:cs typeface="Calibri" pitchFamily="34" charset="-120"/>
+              </a:rPr>
+              <a:t>Overdraft Prediction</a:t>
+            </a:r>
+            <a:endParaRPr lang="en-US" sz="750" dirty="0"/>
+          </a:p>
+        </p:txBody>
+      </p:sp>
+      <p:sp>
+        <p:nvSpPr>
+          <p:cNvPr id="68" name="Shape 66"/>
+          <p:cNvSpPr/>
+          <p:nvPr/>
+        </p:nvSpPr>
+        <p:spPr>
+          <a:xfrm>
+            <a:off x="274320" y="3968496"/>
+            <a:ext cx="8503920" cy="356616"/>
+          </a:xfrm>
+          <a:prstGeom prst="rect">
+            <a:avLst/>
+          </a:prstGeom>
+          <a:solidFill>
+            <a:srgbClr val="FFFFFF"/>
+          </a:solidFill>
+          <a:ln w="12700">
+            <a:solidFill>
+              <a:srgbClr val="E7ECF0"/>
+            </a:solidFill>
+            <a:prstDash val="solid"/>
+          </a:ln>
+        </p:spPr>
+      </p:sp>
+      <p:sp>
+        <p:nvSpPr>
+          <p:cNvPr id="69" name="Shape 67"/>
+          <p:cNvSpPr/>
+          <p:nvPr/>
+        </p:nvSpPr>
+        <p:spPr>
+          <a:xfrm>
+            <a:off x="274320" y="3968496"/>
+            <a:ext cx="54864" cy="356616"/>
+          </a:xfrm>
+          <a:prstGeom prst="rect">
+            <a:avLst/>
+          </a:prstGeom>
+          <a:solidFill>
+            <a:srgbClr val="085CE5"/>
+          </a:solidFill>
+          <a:ln w="12700">
+            <a:solidFill>
+              <a:srgbClr val="085CE5"/>
+            </a:solidFill>
+            <a:prstDash val="solid"/>
+          </a:ln>
+        </p:spPr>
+      </p:sp>
+      <p:sp>
+        <p:nvSpPr>
+          <p:cNvPr id="70" name="Text 68"/>
+          <p:cNvSpPr/>
+          <p:nvPr/>
+        </p:nvSpPr>
+        <p:spPr>
+          <a:xfrm>
+            <a:off x="384048" y="3995928"/>
+            <a:ext cx="1892808" cy="201168"/>
+          </a:xfrm>
+          <a:prstGeom prst="rect">
+            <a:avLst/>
+          </a:prstGeom>
+          <a:noFill/>
+          <a:ln/>
+        </p:spPr>
+        <p:txBody>
+          <a:bodyPr wrap="square" lIns="0" tIns="0" rIns="0" bIns="0" rtlCol="0" anchor="ctr"/>
+          <a:lstStyle/>
+          <a:p>
+            <a:pPr indent="0" marL="0">
+              <a:buNone/>
+            </a:pPr>
+            <a:r>
+              <a:rPr lang="en-US" sz="850" b="1" dirty="0">
+                <a:solidFill>
+                  <a:srgbClr val="06185F"/>
+                </a:solidFill>
+                <a:latin typeface="Calibri" pitchFamily="34" charset="0"/>
+                <a:ea typeface="Calibri" pitchFamily="34" charset="-122"/>
+                <a:cs typeface="Calibri" pitchFamily="34" charset="-120"/>
+              </a:rPr>
+              <a:t>Payrailz (P2P / A2A)</a:t>
+            </a:r>
+            <a:endParaRPr lang="en-US" sz="850" dirty="0"/>
+          </a:p>
+        </p:txBody>
+      </p:sp>
+      <p:sp>
+        <p:nvSpPr>
+          <p:cNvPr id="71" name="Text 69"/>
+          <p:cNvSpPr/>
+          <p:nvPr/>
+        </p:nvSpPr>
+        <p:spPr>
+          <a:xfrm>
+            <a:off x="384048" y="4187952"/>
+            <a:ext cx="1892808" cy="137160"/>
+          </a:xfrm>
+          <a:prstGeom prst="rect">
+            <a:avLst/>
+          </a:prstGeom>
+          <a:noFill/>
+          <a:ln/>
+        </p:spPr>
+        <p:txBody>
+          <a:bodyPr wrap="square" lIns="0" tIns="0" rIns="0" bIns="0" rtlCol="0" anchor="ctr"/>
+          <a:lstStyle/>
+          <a:p>
+            <a:pPr indent="0" marL="0">
+              <a:buNone/>
+            </a:pPr>
+            <a:r>
+              <a:rPr lang="en-US" sz="750" i="1" dirty="0">
+                <a:solidFill>
+                  <a:srgbClr val="B6BBC0"/>
+                </a:solidFill>
+                <a:latin typeface="Calibri" pitchFamily="34" charset="0"/>
+                <a:ea typeface="Calibri" pitchFamily="34" charset="-122"/>
+                <a:cs typeface="Calibri" pitchFamily="34" charset="-120"/>
+              </a:rPr>
+              <a:t>Pay a Person, Transfer Money</a:t>
+            </a:r>
+            <a:endParaRPr lang="en-US" sz="750" dirty="0"/>
+          </a:p>
+        </p:txBody>
+      </p:sp>
+      <p:sp>
+        <p:nvSpPr>
+          <p:cNvPr id="72" name="Shape 70"/>
+          <p:cNvSpPr/>
+          <p:nvPr/>
+        </p:nvSpPr>
+        <p:spPr>
+          <a:xfrm>
+            <a:off x="2505456" y="4041648"/>
+            <a:ext cx="1504188" cy="182880"/>
+          </a:xfrm>
+          <a:prstGeom prst="rect">
+            <a:avLst/>
+          </a:prstGeom>
+          <a:solidFill>
+            <a:srgbClr val="085CE5"/>
+          </a:solidFill>
+          <a:ln w="12700">
+            <a:solidFill>
+              <a:srgbClr val="085CE5"/>
+            </a:solidFill>
+            <a:prstDash val="solid"/>
+          </a:ln>
+        </p:spPr>
+      </p:sp>
+      <p:sp>
+        <p:nvSpPr>
+          <p:cNvPr id="73" name="Text 71"/>
+          <p:cNvSpPr/>
+          <p:nvPr/>
+        </p:nvSpPr>
+        <p:spPr>
+          <a:xfrm>
+            <a:off x="2569464" y="4041648"/>
+            <a:ext cx="1394460" cy="182880"/>
+          </a:xfrm>
+          <a:prstGeom prst="rect">
+            <a:avLst/>
+          </a:prstGeom>
+          <a:noFill/>
+          <a:ln/>
+        </p:spPr>
+        <p:txBody>
+          <a:bodyPr wrap="square" lIns="0" tIns="0" rIns="0" bIns="0" rtlCol="0" anchor="ctr"/>
+          <a:lstStyle/>
+          <a:p>
+            <a:pPr indent="0" marL="0">
+              <a:buNone/>
+            </a:pPr>
+            <a:r>
+              <a:rPr lang="en-US" sz="750" dirty="0">
+                <a:solidFill>
+                  <a:srgbClr val="FFFFFF"/>
+                </a:solidFill>
+                <a:latin typeface="Calibri" pitchFamily="34" charset="0"/>
+                <a:ea typeface="Calibri" pitchFamily="34" charset="-122"/>
+                <a:cs typeface="Calibri" pitchFamily="34" charset="-120"/>
+              </a:rPr>
+              <a:t>Fraud Ring Detection</a:t>
+            </a:r>
+            <a:endParaRPr lang="en-US" sz="750" dirty="0"/>
+          </a:p>
+        </p:txBody>
+      </p:sp>
+      <p:sp>
+        <p:nvSpPr>
+          <p:cNvPr id="74" name="Shape 72"/>
+          <p:cNvSpPr/>
+          <p:nvPr/>
+        </p:nvSpPr>
+        <p:spPr>
+          <a:xfrm>
+            <a:off x="274320" y="4352544"/>
+            <a:ext cx="8503920" cy="356616"/>
+          </a:xfrm>
+          <a:prstGeom prst="rect">
+            <a:avLst/>
+          </a:prstGeom>
+          <a:solidFill>
+            <a:srgbClr val="F8F9FA"/>
+          </a:solidFill>
+          <a:ln w="12700">
+            <a:solidFill>
+              <a:srgbClr val="E7ECF0"/>
+            </a:solidFill>
+            <a:prstDash val="solid"/>
+          </a:ln>
+        </p:spPr>
+      </p:sp>
+      <p:sp>
+        <p:nvSpPr>
+          <p:cNvPr id="75" name="Shape 73"/>
+          <p:cNvSpPr/>
+          <p:nvPr/>
+        </p:nvSpPr>
+        <p:spPr>
+          <a:xfrm>
+            <a:off x="274320" y="4352544"/>
+            <a:ext cx="54864" cy="356616"/>
           </a:xfrm>
           <a:prstGeom prst="rect">
             <a:avLst/>
@@ -17935,14 +19432,14 @@
       </p:sp>
       <p:sp>
         <p:nvSpPr>
-          <p:cNvPr id="29" name="Text 27"/>
-          <p:cNvSpPr/>
-          <p:nvPr/>
-        </p:nvSpPr>
-        <p:spPr>
-          <a:xfrm>
-            <a:off x="4091940" y="859536"/>
-            <a:ext cx="1485900" cy="237744"/>
+          <p:cNvPr id="76" name="Text 74"/>
+          <p:cNvSpPr/>
+          <p:nvPr/>
+        </p:nvSpPr>
+        <p:spPr>
+          <a:xfrm>
+            <a:off x="384048" y="4379976"/>
+            <a:ext cx="1892808" cy="201168"/>
           </a:xfrm>
           <a:prstGeom prst="rect">
             <a:avLst/>
@@ -17958,7 +19455,110 @@
               <a:buNone/>
             </a:pPr>
             <a:r>
-              <a:rPr lang="en-US" sz="750" b="1" dirty="0">
+              <a:rPr lang="en-US" sz="850" b="1" dirty="0">
+                <a:solidFill>
+                  <a:srgbClr val="06185F"/>
+                </a:solidFill>
+                <a:latin typeface="Calibri" pitchFamily="34" charset="0"/>
+                <a:ea typeface="Calibri" pitchFamily="34" charset="-122"/>
+                <a:cs typeface="Calibri" pitchFamily="34" charset="-120"/>
+              </a:rPr>
+              <a:t>Core Banking (jhaEnterprise / Symitar)</a:t>
+            </a:r>
+            <a:endParaRPr lang="en-US" sz="850" dirty="0"/>
+          </a:p>
+        </p:txBody>
+      </p:sp>
+      <p:sp>
+        <p:nvSpPr>
+          <p:cNvPr id="77" name="Text 75"/>
+          <p:cNvSpPr/>
+          <p:nvPr/>
+        </p:nvSpPr>
+        <p:spPr>
+          <a:xfrm>
+            <a:off x="384048" y="4572000"/>
+            <a:ext cx="1892808" cy="137160"/>
+          </a:xfrm>
+          <a:prstGeom prst="rect">
+            <a:avLst/>
+          </a:prstGeom>
+          <a:noFill/>
+          <a:ln/>
+        </p:spPr>
+        <p:txBody>
+          <a:bodyPr wrap="square" lIns="0" tIns="0" rIns="0" bIns="0" rtlCol="0" anchor="ctr"/>
+          <a:lstStyle/>
+          <a:p>
+            <a:pPr indent="0" marL="0">
+              <a:buNone/>
+            </a:pPr>
+            <a:r>
+              <a:rPr lang="en-US" sz="750" i="1" dirty="0">
+                <a:solidFill>
+                  <a:srgbClr val="B6BBC0"/>
+                </a:solidFill>
+                <a:latin typeface="Calibri" pitchFamily="34" charset="0"/>
+                <a:ea typeface="Calibri" pitchFamily="34" charset="-122"/>
+                <a:cs typeface="Calibri" pitchFamily="34" charset="-120"/>
+              </a:rPr>
+              <a:t>Core txns, deposits, loans</a:t>
+            </a:r>
+            <a:endParaRPr lang="en-US" sz="750" dirty="0"/>
+          </a:p>
+        </p:txBody>
+      </p:sp>
+      <p:sp>
+        <p:nvSpPr>
+          <p:cNvPr id="78" name="Shape 76"/>
+          <p:cNvSpPr/>
+          <p:nvPr/>
+        </p:nvSpPr>
+        <p:spPr>
+          <a:xfrm>
+            <a:off x="4082796" y="4425696"/>
+            <a:ext cx="1504188" cy="182880"/>
+          </a:xfrm>
+          <a:prstGeom prst="rect">
+            <a:avLst/>
+          </a:prstGeom>
+          <a:solidFill>
+            <a:srgbClr val="073FA8"/>
+          </a:solidFill>
+          <a:ln w="12700">
+            <a:solidFill>
+              <a:srgbClr val="073FA8"/>
+            </a:solidFill>
+            <a:prstDash val="solid"/>
+          </a:ln>
+        </p:spPr>
+      </p:sp>
+      <p:sp>
+        <p:nvSpPr>
+          <p:cNvPr id="79" name="Text 77"/>
+          <p:cNvSpPr/>
+          <p:nvPr/>
+        </p:nvSpPr>
+        <p:spPr>
+          <a:xfrm>
+            <a:off x="4146804" y="4425696"/>
+            <a:ext cx="1394460" cy="182880"/>
+          </a:xfrm>
+          <a:prstGeom prst="rect">
+            <a:avLst/>
+          </a:prstGeom>
+          <a:noFill/>
+          <a:ln/>
+        </p:spPr>
+        <p:txBody>
+          <a:bodyPr wrap="square" lIns="0" tIns="0" rIns="0" bIns="0" rtlCol="0" anchor="ctr"/>
+          <a:lstStyle/>
+          <a:p>
+            <a:pPr indent="0" marL="0">
+              <a:buNone/>
+            </a:pPr>
+            <a:r>
+              <a:rPr lang="en-US" sz="750" dirty="0">
                 <a:solidFill>
                   <a:srgbClr val="FFFFFF"/>
                 </a:solidFill>
@@ -17966,7 +19566,7 @@
                 <a:ea typeface="Calibri" pitchFamily="34" charset="-122"/>
                 <a:cs typeface="Calibri" pitchFamily="34" charset="-120"/>
               </a:rPr>
-              <a:t>PHASE 2 — Core Apps  (Q1–Q2 FY27)</a:t>
+              <a:t>Churn Mediation · Acct Opening LTV</a:t>
             </a:r>
             <a:endParaRPr lang="en-US" sz="750" dirty="0"/>
           </a:p>
@@ -17974,14 +19574,39 @@
       </p:sp>
       <p:sp>
         <p:nvSpPr>
-          <p:cNvPr id="30" name="Shape 28"/>
-          <p:cNvSpPr/>
-          <p:nvPr/>
-        </p:nvSpPr>
-        <p:spPr>
-          <a:xfrm>
-            <a:off x="5623560" y="859536"/>
-            <a:ext cx="3154680" cy="237744"/>
+          <p:cNvPr id="80" name="Shape 78"/>
+          <p:cNvSpPr/>
+          <p:nvPr/>
+        </p:nvSpPr>
+        <p:spPr>
+          <a:xfrm>
+            <a:off x="274320" y="4736592"/>
+            <a:ext cx="8503920" cy="356616"/>
+          </a:xfrm>
+          <a:prstGeom prst="rect">
+            <a:avLst/>
+          </a:prstGeom>
+          <a:solidFill>
+            <a:srgbClr val="FFFFFF"/>
+          </a:solidFill>
+          <a:ln w="12700">
+            <a:solidFill>
+              <a:srgbClr val="E7ECF0"/>
+            </a:solidFill>
+            <a:prstDash val="solid"/>
+          </a:ln>
+        </p:spPr>
+      </p:sp>
+      <p:sp>
+        <p:nvSpPr>
+          <p:cNvPr id="81" name="Shape 79"/>
+          <p:cNvSpPr/>
+          <p:nvPr/>
+        </p:nvSpPr>
+        <p:spPr>
+          <a:xfrm>
+            <a:off x="274320" y="4736592"/>
+            <a:ext cx="54864" cy="356616"/>
           </a:xfrm>
           <a:prstGeom prst="rect">
             <a:avLst/>
@@ -17999,14 +19624,14 @@
       </p:sp>
       <p:sp>
         <p:nvSpPr>
-          <p:cNvPr id="31" name="Text 29"/>
-          <p:cNvSpPr/>
-          <p:nvPr/>
-        </p:nvSpPr>
-        <p:spPr>
-          <a:xfrm>
-            <a:off x="5669280" y="859536"/>
-            <a:ext cx="3063240" cy="237744"/>
+          <p:cNvPr id="82" name="Text 80"/>
+          <p:cNvSpPr/>
+          <p:nvPr/>
+        </p:nvSpPr>
+        <p:spPr>
+          <a:xfrm>
+            <a:off x="384048" y="4764024"/>
+            <a:ext cx="1892808" cy="201168"/>
           </a:xfrm>
           <a:prstGeom prst="rect">
             <a:avLst/>
@@ -18022,15 +19647,54 @@
               <a:buNone/>
             </a:pPr>
             <a:r>
-              <a:rPr lang="en-US" sz="750" b="1" dirty="0">
-                <a:solidFill>
-                  <a:srgbClr val="FFFFFF"/>
-                </a:solidFill>
-                <a:latin typeface="Calibri" pitchFamily="34" charset="0"/>
-                <a:ea typeface="Calibri" pitchFamily="34" charset="-122"/>
-                <a:cs typeface="Calibri" pitchFamily="34" charset="-120"/>
-              </a:rPr>
-              <a:t>PHASE 3 — Scale &amp; Expand  (Q3 FY27–Q2 FY28)</a:t>
+              <a:rPr lang="en-US" sz="850" b="1" dirty="0">
+                <a:solidFill>
+                  <a:srgbClr val="06185F"/>
+                </a:solidFill>
+                <a:latin typeface="Calibri" pitchFamily="34" charset="0"/>
+                <a:ea typeface="Calibri" pitchFamily="34" charset="-122"/>
+                <a:cs typeface="Calibri" pitchFamily="34" charset="-120"/>
+              </a:rPr>
+              <a:t>Banno Digital + Lending</a:t>
+            </a:r>
+            <a:endParaRPr lang="en-US" sz="850" dirty="0"/>
+          </a:p>
+        </p:txBody>
+      </p:sp>
+      <p:sp>
+        <p:nvSpPr>
+          <p:cNvPr id="83" name="Text 81"/>
+          <p:cNvSpPr/>
+          <p:nvPr/>
+        </p:nvSpPr>
+        <p:spPr>
+          <a:xfrm>
+            <a:off x="384048" y="4956048"/>
+            <a:ext cx="1892808" cy="137160"/>
+          </a:xfrm>
+          <a:prstGeom prst="rect">
+            <a:avLst/>
+          </a:prstGeom>
+          <a:noFill/>
+          <a:ln/>
+        </p:spPr>
+        <p:txBody>
+          <a:bodyPr wrap="square" lIns="0" tIns="0" rIns="0" bIns="0" rtlCol="0" anchor="ctr"/>
+          <a:lstStyle/>
+          <a:p>
+            <a:pPr indent="0" marL="0">
+              <a:buNone/>
+            </a:pPr>
+            <a:r>
+              <a:rPr lang="en-US" sz="750" i="1" dirty="0">
+                <a:solidFill>
+                  <a:srgbClr val="B6BBC0"/>
+                </a:solidFill>
+                <a:latin typeface="Calibri" pitchFamily="34" charset="0"/>
+                <a:ea typeface="Calibri" pitchFamily="34" charset="-122"/>
+                <a:cs typeface="Calibri" pitchFamily="34" charset="-120"/>
+              </a:rPr>
+              <a:t>Session behavior, loan data</a:t>
             </a:r>
             <a:endParaRPr lang="en-US" sz="750" dirty="0"/>
           </a:p>
@@ -18038,1383 +19702,14 @@
       </p:sp>
       <p:sp>
         <p:nvSpPr>
-          <p:cNvPr id="32" name="Shape 30"/>
-          <p:cNvSpPr/>
-          <p:nvPr/>
-        </p:nvSpPr>
-        <p:spPr>
-          <a:xfrm>
-            <a:off x="274320" y="1408176"/>
-            <a:ext cx="8503920" cy="356616"/>
-          </a:xfrm>
-          <a:prstGeom prst="rect">
-            <a:avLst/>
-          </a:prstGeom>
-          <a:solidFill>
-            <a:srgbClr val="FFFFFF"/>
-          </a:solidFill>
-          <a:ln w="12700">
-            <a:solidFill>
-              <a:srgbClr val="E7ECF0"/>
-            </a:solidFill>
-            <a:prstDash val="solid"/>
-          </a:ln>
-        </p:spPr>
-      </p:sp>
-      <p:sp>
-        <p:nvSpPr>
-          <p:cNvPr id="33" name="Shape 31"/>
-          <p:cNvSpPr/>
-          <p:nvPr/>
-        </p:nvSpPr>
-        <p:spPr>
-          <a:xfrm>
-            <a:off x="274320" y="1408176"/>
-            <a:ext cx="54864" cy="356616"/>
-          </a:xfrm>
-          <a:prstGeom prst="rect">
-            <a:avLst/>
-          </a:prstGeom>
-          <a:solidFill>
-            <a:srgbClr val="085CE5"/>
-          </a:solidFill>
-          <a:ln w="12700">
-            <a:solidFill>
-              <a:srgbClr val="085CE5"/>
-            </a:solidFill>
-            <a:prstDash val="solid"/>
-          </a:ln>
-        </p:spPr>
-      </p:sp>
-      <p:sp>
-        <p:nvSpPr>
-          <p:cNvPr id="34" name="Text 32"/>
-          <p:cNvSpPr/>
-          <p:nvPr/>
-        </p:nvSpPr>
-        <p:spPr>
-          <a:xfrm>
-            <a:off x="384048" y="1435608"/>
-            <a:ext cx="1892808" cy="201168"/>
-          </a:xfrm>
-          <a:prstGeom prst="rect">
-            <a:avLst/>
-          </a:prstGeom>
-          <a:noFill/>
-          <a:ln/>
-        </p:spPr>
-        <p:txBody>
-          <a:bodyPr wrap="square" lIns="0" tIns="0" rIns="0" bIns="0" rtlCol="0" anchor="ctr"/>
-          <a:lstStyle/>
-          <a:p>
-            <a:pPr indent="0" marL="0">
-              <a:buNone/>
-            </a:pPr>
-            <a:r>
-              <a:rPr lang="en-US" sz="850" b="1" dirty="0">
-                <a:solidFill>
-                  <a:srgbClr val="06185F"/>
-                </a:solidFill>
-                <a:latin typeface="Calibri" pitchFamily="34" charset="0"/>
-                <a:ea typeface="Calibri" pitchFamily="34" charset="-122"/>
-                <a:cs typeface="Calibri" pitchFamily="34" charset="-120"/>
-              </a:rPr>
-              <a:t>NCUA 5300 Call Reports</a:t>
-            </a:r>
-            <a:endParaRPr lang="en-US" sz="850" dirty="0"/>
-          </a:p>
-        </p:txBody>
-      </p:sp>
-      <p:sp>
-        <p:nvSpPr>
-          <p:cNvPr id="35" name="Text 33"/>
-          <p:cNvSpPr/>
-          <p:nvPr/>
-        </p:nvSpPr>
-        <p:spPr>
-          <a:xfrm>
-            <a:off x="384048" y="1627632"/>
-            <a:ext cx="1892808" cy="137160"/>
-          </a:xfrm>
-          <a:prstGeom prst="rect">
-            <a:avLst/>
-          </a:prstGeom>
-          <a:noFill/>
-          <a:ln/>
-        </p:spPr>
-        <p:txBody>
-          <a:bodyPr wrap="square" lIns="0" tIns="0" rIns="0" bIns="0" rtlCol="0" anchor="ctr"/>
-          <a:lstStyle/>
-          <a:p>
-            <a:pPr indent="0" marL="0">
-              <a:buNone/>
-            </a:pPr>
-            <a:r>
-              <a:rPr lang="en-US" sz="750" i="1" dirty="0">
-                <a:solidFill>
-                  <a:srgbClr val="B6BBC0"/>
-                </a:solidFill>
-                <a:latin typeface="Calibri" pitchFamily="34" charset="0"/>
-                <a:ea typeface="Calibri" pitchFamily="34" charset="-122"/>
-                <a:cs typeface="Calibri" pitchFamily="34" charset="-120"/>
-              </a:rPr>
-              <a:t>Public regulatory</a:t>
-            </a:r>
-            <a:endParaRPr lang="en-US" sz="750" dirty="0"/>
-          </a:p>
-        </p:txBody>
-      </p:sp>
-      <p:sp>
-        <p:nvSpPr>
-          <p:cNvPr id="36" name="Shape 34"/>
-          <p:cNvSpPr/>
-          <p:nvPr/>
-        </p:nvSpPr>
-        <p:spPr>
-          <a:xfrm>
-            <a:off x="2505456" y="1481328"/>
-            <a:ext cx="715518" cy="182880"/>
-          </a:xfrm>
-          <a:prstGeom prst="rect">
-            <a:avLst/>
-          </a:prstGeom>
-          <a:solidFill>
-            <a:srgbClr val="085CE5"/>
-          </a:solidFill>
-          <a:ln w="12700">
-            <a:solidFill>
-              <a:srgbClr val="085CE5"/>
-            </a:solidFill>
-            <a:prstDash val="solid"/>
-          </a:ln>
-        </p:spPr>
-      </p:sp>
-      <p:sp>
-        <p:nvSpPr>
-          <p:cNvPr id="37" name="Text 35"/>
-          <p:cNvSpPr/>
-          <p:nvPr/>
-        </p:nvSpPr>
-        <p:spPr>
-          <a:xfrm>
-            <a:off x="3275838" y="1481328"/>
-            <a:ext cx="2194560" cy="182880"/>
-          </a:xfrm>
-          <a:prstGeom prst="rect">
-            <a:avLst/>
-          </a:prstGeom>
-          <a:noFill/>
-          <a:ln/>
-        </p:spPr>
-        <p:txBody>
-          <a:bodyPr wrap="square" lIns="0" tIns="0" rIns="0" bIns="0" rtlCol="0" anchor="ctr"/>
-          <a:lstStyle/>
-          <a:p>
-            <a:pPr indent="0" marL="0">
-              <a:buNone/>
-            </a:pPr>
-            <a:r>
-              <a:rPr lang="en-US" sz="750" i="1" dirty="0">
-                <a:solidFill>
-                  <a:srgbClr val="085CE5"/>
-                </a:solidFill>
-                <a:latin typeface="Calibri" pitchFamily="34" charset="0"/>
-                <a:ea typeface="Calibri" pitchFamily="34" charset="-122"/>
-                <a:cs typeface="Calibri" pitchFamily="34" charset="-120"/>
-              </a:rPr>
-              <a:t>Call Report AI</a:t>
-            </a:r>
-            <a:endParaRPr lang="en-US" sz="750" dirty="0"/>
-          </a:p>
-        </p:txBody>
-      </p:sp>
-      <p:sp>
-        <p:nvSpPr>
-          <p:cNvPr id="38" name="Shape 36"/>
-          <p:cNvSpPr/>
-          <p:nvPr/>
-        </p:nvSpPr>
-        <p:spPr>
-          <a:xfrm>
-            <a:off x="274320" y="1792224"/>
-            <a:ext cx="8503920" cy="356616"/>
-          </a:xfrm>
-          <a:prstGeom prst="rect">
-            <a:avLst/>
-          </a:prstGeom>
-          <a:solidFill>
-            <a:srgbClr val="F8F9FA"/>
-          </a:solidFill>
-          <a:ln w="12700">
-            <a:solidFill>
-              <a:srgbClr val="E7ECF0"/>
-            </a:solidFill>
-            <a:prstDash val="solid"/>
-          </a:ln>
-        </p:spPr>
-      </p:sp>
-      <p:sp>
-        <p:nvSpPr>
-          <p:cNvPr id="39" name="Shape 37"/>
-          <p:cNvSpPr/>
-          <p:nvPr/>
-        </p:nvSpPr>
-        <p:spPr>
-          <a:xfrm>
-            <a:off x="274320" y="1792224"/>
-            <a:ext cx="54864" cy="356616"/>
-          </a:xfrm>
-          <a:prstGeom prst="rect">
-            <a:avLst/>
-          </a:prstGeom>
-          <a:solidFill>
-            <a:srgbClr val="085CE5"/>
-          </a:solidFill>
-          <a:ln w="12700">
-            <a:solidFill>
-              <a:srgbClr val="085CE5"/>
-            </a:solidFill>
-            <a:prstDash val="solid"/>
-          </a:ln>
-        </p:spPr>
-      </p:sp>
-      <p:sp>
-        <p:nvSpPr>
-          <p:cNvPr id="40" name="Text 38"/>
-          <p:cNvSpPr/>
-          <p:nvPr/>
-        </p:nvSpPr>
-        <p:spPr>
-          <a:xfrm>
-            <a:off x="384048" y="1819656"/>
-            <a:ext cx="1892808" cy="201168"/>
-          </a:xfrm>
-          <a:prstGeom prst="rect">
-            <a:avLst/>
-          </a:prstGeom>
-          <a:noFill/>
-          <a:ln/>
-        </p:spPr>
-        <p:txBody>
-          <a:bodyPr wrap="square" lIns="0" tIns="0" rIns="0" bIns="0" rtlCol="0" anchor="ctr"/>
-          <a:lstStyle/>
-          <a:p>
-            <a:pPr indent="0" marL="0">
-              <a:buNone/>
-            </a:pPr>
-            <a:r>
-              <a:rPr lang="en-US" sz="850" b="1" dirty="0">
-                <a:solidFill>
-                  <a:srgbClr val="06185F"/>
-                </a:solidFill>
-                <a:latin typeface="Calibri" pitchFamily="34" charset="0"/>
-                <a:ea typeface="Calibri" pitchFamily="34" charset="-122"/>
-                <a:cs typeface="Calibri" pitchFamily="34" charset="-120"/>
-              </a:rPr>
-              <a:t>Core Banking (jhaEnterprise / Symitar)</a:t>
-            </a:r>
-            <a:endParaRPr lang="en-US" sz="850" dirty="0"/>
-          </a:p>
-        </p:txBody>
-      </p:sp>
-      <p:sp>
-        <p:nvSpPr>
-          <p:cNvPr id="41" name="Text 39"/>
-          <p:cNvSpPr/>
-          <p:nvPr/>
-        </p:nvSpPr>
-        <p:spPr>
-          <a:xfrm>
-            <a:off x="384048" y="2011680"/>
-            <a:ext cx="1892808" cy="137160"/>
-          </a:xfrm>
-          <a:prstGeom prst="rect">
-            <a:avLst/>
-          </a:prstGeom>
-          <a:noFill/>
-          <a:ln/>
-        </p:spPr>
-        <p:txBody>
-          <a:bodyPr wrap="square" lIns="0" tIns="0" rIns="0" bIns="0" rtlCol="0" anchor="ctr"/>
-          <a:lstStyle/>
-          <a:p>
-            <a:pPr indent="0" marL="0">
-              <a:buNone/>
-            </a:pPr>
-            <a:r>
-              <a:rPr lang="en-US" sz="750" i="1" dirty="0">
-                <a:solidFill>
-                  <a:srgbClr val="B6BBC0"/>
-                </a:solidFill>
-                <a:latin typeface="Calibri" pitchFamily="34" charset="0"/>
-                <a:ea typeface="Calibri" pitchFamily="34" charset="-122"/>
-                <a:cs typeface="Calibri" pitchFamily="34" charset="-120"/>
-              </a:rPr>
-              <a:t>Core transactions, deposits, loans</a:t>
-            </a:r>
-            <a:endParaRPr lang="en-US" sz="750" dirty="0"/>
-          </a:p>
-        </p:txBody>
-      </p:sp>
-      <p:sp>
-        <p:nvSpPr>
-          <p:cNvPr id="42" name="Shape 40"/>
-          <p:cNvSpPr/>
-          <p:nvPr/>
-        </p:nvSpPr>
-        <p:spPr>
-          <a:xfrm>
-            <a:off x="2505456" y="1865376"/>
-            <a:ext cx="1504188" cy="182880"/>
-          </a:xfrm>
-          <a:prstGeom prst="rect">
-            <a:avLst/>
-          </a:prstGeom>
-          <a:solidFill>
-            <a:srgbClr val="085CE5"/>
-          </a:solidFill>
-          <a:ln w="12700">
-            <a:solidFill>
-              <a:srgbClr val="085CE5"/>
-            </a:solidFill>
-            <a:prstDash val="solid"/>
-          </a:ln>
-        </p:spPr>
-      </p:sp>
-      <p:sp>
-        <p:nvSpPr>
-          <p:cNvPr id="43" name="Text 41"/>
-          <p:cNvSpPr/>
-          <p:nvPr/>
-        </p:nvSpPr>
-        <p:spPr>
-          <a:xfrm>
-            <a:off x="2569464" y="1865376"/>
-            <a:ext cx="1394460" cy="182880"/>
-          </a:xfrm>
-          <a:prstGeom prst="rect">
-            <a:avLst/>
-          </a:prstGeom>
-          <a:noFill/>
-          <a:ln/>
-        </p:spPr>
-        <p:txBody>
-          <a:bodyPr wrap="square" lIns="0" tIns="0" rIns="0" bIns="0" rtlCol="0" anchor="ctr"/>
-          <a:lstStyle/>
-          <a:p>
-            <a:pPr indent="0" marL="0">
-              <a:buNone/>
-            </a:pPr>
-            <a:r>
-              <a:rPr lang="en-US" sz="750" dirty="0">
-                <a:solidFill>
-                  <a:srgbClr val="FFFFFF"/>
-                </a:solidFill>
-                <a:latin typeface="Calibri" pitchFamily="34" charset="0"/>
-                <a:ea typeface="Calibri" pitchFamily="34" charset="-122"/>
-                <a:cs typeface="Calibri" pitchFamily="34" charset="-120"/>
-              </a:rPr>
-              <a:t>Churn Mediation · Acct Opening LTV</a:t>
-            </a:r>
-            <a:endParaRPr lang="en-US" sz="750" dirty="0"/>
-          </a:p>
-        </p:txBody>
-      </p:sp>
-      <p:sp>
-        <p:nvSpPr>
-          <p:cNvPr id="44" name="Shape 42"/>
-          <p:cNvSpPr/>
-          <p:nvPr/>
-        </p:nvSpPr>
-        <p:spPr>
-          <a:xfrm>
-            <a:off x="274320" y="2176272"/>
-            <a:ext cx="8503920" cy="356616"/>
-          </a:xfrm>
-          <a:prstGeom prst="rect">
-            <a:avLst/>
-          </a:prstGeom>
-          <a:solidFill>
-            <a:srgbClr val="FFFFFF"/>
-          </a:solidFill>
-          <a:ln w="12700">
-            <a:solidFill>
-              <a:srgbClr val="E7ECF0"/>
-            </a:solidFill>
-            <a:prstDash val="solid"/>
-          </a:ln>
-        </p:spPr>
-      </p:sp>
-      <p:sp>
-        <p:nvSpPr>
-          <p:cNvPr id="45" name="Shape 43"/>
-          <p:cNvSpPr/>
-          <p:nvPr/>
-        </p:nvSpPr>
-        <p:spPr>
-          <a:xfrm>
-            <a:off x="274320" y="2176272"/>
-            <a:ext cx="54864" cy="356616"/>
-          </a:xfrm>
-          <a:prstGeom prst="rect">
-            <a:avLst/>
-          </a:prstGeom>
-          <a:solidFill>
-            <a:srgbClr val="073FA8"/>
-          </a:solidFill>
-          <a:ln w="12700">
-            <a:solidFill>
-              <a:srgbClr val="073FA8"/>
-            </a:solidFill>
-            <a:prstDash val="solid"/>
-          </a:ln>
-        </p:spPr>
-      </p:sp>
-      <p:sp>
-        <p:nvSpPr>
-          <p:cNvPr id="46" name="Text 44"/>
-          <p:cNvSpPr/>
-          <p:nvPr/>
-        </p:nvSpPr>
-        <p:spPr>
-          <a:xfrm>
-            <a:off x="384048" y="2203704"/>
-            <a:ext cx="1892808" cy="201168"/>
-          </a:xfrm>
-          <a:prstGeom prst="rect">
-            <a:avLst/>
-          </a:prstGeom>
-          <a:noFill/>
-          <a:ln/>
-        </p:spPr>
-        <p:txBody>
-          <a:bodyPr wrap="square" lIns="0" tIns="0" rIns="0" bIns="0" rtlCol="0" anchor="ctr"/>
-          <a:lstStyle/>
-          <a:p>
-            <a:pPr indent="0" marL="0">
-              <a:buNone/>
-            </a:pPr>
-            <a:r>
-              <a:rPr lang="en-US" sz="850" b="1" dirty="0">
-                <a:solidFill>
-                  <a:srgbClr val="06185F"/>
-                </a:solidFill>
-                <a:latin typeface="Calibri" pitchFamily="34" charset="0"/>
-                <a:ea typeface="Calibri" pitchFamily="34" charset="-122"/>
-                <a:cs typeface="Calibri" pitchFamily="34" charset="-120"/>
-              </a:rPr>
-              <a:t>ACH / EPS</a:t>
-            </a:r>
-            <a:endParaRPr lang="en-US" sz="850" dirty="0"/>
-          </a:p>
-        </p:txBody>
-      </p:sp>
-      <p:sp>
-        <p:nvSpPr>
-          <p:cNvPr id="47" name="Text 45"/>
-          <p:cNvSpPr/>
-          <p:nvPr/>
-        </p:nvSpPr>
-        <p:spPr>
-          <a:xfrm>
-            <a:off x="384048" y="2395728"/>
-            <a:ext cx="1892808" cy="137160"/>
-          </a:xfrm>
-          <a:prstGeom prst="rect">
-            <a:avLst/>
-          </a:prstGeom>
-          <a:noFill/>
-          <a:ln/>
-        </p:spPr>
-        <p:txBody>
-          <a:bodyPr wrap="square" lIns="0" tIns="0" rIns="0" bIns="0" rtlCol="0" anchor="ctr"/>
-          <a:lstStyle/>
-          <a:p>
-            <a:pPr indent="0" marL="0">
-              <a:buNone/>
-            </a:pPr>
-            <a:r>
-              <a:rPr lang="en-US" sz="750" i="1" dirty="0">
-                <a:solidFill>
-                  <a:srgbClr val="B6BBC0"/>
-                </a:solidFill>
-                <a:latin typeface="Calibri" pitchFamily="34" charset="0"/>
-                <a:ea typeface="Calibri" pitchFamily="34" charset="-122"/>
-                <a:cs typeface="Calibri" pitchFamily="34" charset="-120"/>
-              </a:rPr>
-              <a:t>ACH credits, debits, RDC</a:t>
-            </a:r>
-            <a:endParaRPr lang="en-US" sz="750" dirty="0"/>
-          </a:p>
-        </p:txBody>
-      </p:sp>
-      <p:sp>
-        <p:nvSpPr>
-          <p:cNvPr id="48" name="Shape 46"/>
-          <p:cNvSpPr/>
-          <p:nvPr/>
-        </p:nvSpPr>
-        <p:spPr>
-          <a:xfrm>
-            <a:off x="2505456" y="2249424"/>
-            <a:ext cx="1504188" cy="182880"/>
-          </a:xfrm>
-          <a:prstGeom prst="rect">
-            <a:avLst/>
-          </a:prstGeom>
-          <a:solidFill>
-            <a:srgbClr val="073FA8"/>
-          </a:solidFill>
-          <a:ln w="12700">
-            <a:solidFill>
-              <a:srgbClr val="073FA8"/>
-            </a:solidFill>
-            <a:prstDash val="solid"/>
-          </a:ln>
-        </p:spPr>
-      </p:sp>
-      <p:sp>
-        <p:nvSpPr>
-          <p:cNvPr id="49" name="Text 47"/>
-          <p:cNvSpPr/>
-          <p:nvPr/>
-        </p:nvSpPr>
-        <p:spPr>
-          <a:xfrm>
-            <a:off x="2569464" y="2249424"/>
-            <a:ext cx="1394460" cy="182880"/>
-          </a:xfrm>
-          <a:prstGeom prst="rect">
-            <a:avLst/>
-          </a:prstGeom>
-          <a:noFill/>
-          <a:ln/>
-        </p:spPr>
-        <p:txBody>
-          <a:bodyPr wrap="square" lIns="0" tIns="0" rIns="0" bIns="0" rtlCol="0" anchor="ctr"/>
-          <a:lstStyle/>
-          <a:p>
-            <a:pPr indent="0" marL="0">
-              <a:buNone/>
-            </a:pPr>
-            <a:r>
-              <a:rPr lang="en-US" sz="750" dirty="0">
-                <a:solidFill>
-                  <a:srgbClr val="FFFFFF"/>
-                </a:solidFill>
-                <a:latin typeface="Calibri" pitchFamily="34" charset="0"/>
-                <a:ea typeface="Calibri" pitchFamily="34" charset="-122"/>
-                <a:cs typeface="Calibri" pitchFamily="34" charset="-120"/>
-              </a:rPr>
-              <a:t>Anomaly Detection</a:t>
-            </a:r>
-            <a:endParaRPr lang="en-US" sz="750" dirty="0"/>
-          </a:p>
-        </p:txBody>
-      </p:sp>
-      <p:sp>
-        <p:nvSpPr>
-          <p:cNvPr id="50" name="Shape 48"/>
-          <p:cNvSpPr/>
-          <p:nvPr/>
-        </p:nvSpPr>
-        <p:spPr>
-          <a:xfrm>
-            <a:off x="274320" y="2560320"/>
-            <a:ext cx="8503920" cy="356616"/>
-          </a:xfrm>
-          <a:prstGeom prst="rect">
-            <a:avLst/>
-          </a:prstGeom>
-          <a:solidFill>
-            <a:srgbClr val="F8F9FA"/>
-          </a:solidFill>
-          <a:ln w="12700">
-            <a:solidFill>
-              <a:srgbClr val="E7ECF0"/>
-            </a:solidFill>
-            <a:prstDash val="solid"/>
-          </a:ln>
-        </p:spPr>
-      </p:sp>
-      <p:sp>
-        <p:nvSpPr>
-          <p:cNvPr id="51" name="Shape 49"/>
-          <p:cNvSpPr/>
-          <p:nvPr/>
-        </p:nvSpPr>
-        <p:spPr>
-          <a:xfrm>
-            <a:off x="274320" y="2560320"/>
-            <a:ext cx="54864" cy="356616"/>
-          </a:xfrm>
-          <a:prstGeom prst="rect">
-            <a:avLst/>
-          </a:prstGeom>
-          <a:solidFill>
-            <a:srgbClr val="073FA8"/>
-          </a:solidFill>
-          <a:ln w="12700">
-            <a:solidFill>
-              <a:srgbClr val="073FA8"/>
-            </a:solidFill>
-            <a:prstDash val="solid"/>
-          </a:ln>
-        </p:spPr>
-      </p:sp>
-      <p:sp>
-        <p:nvSpPr>
-          <p:cNvPr id="52" name="Text 50"/>
-          <p:cNvSpPr/>
-          <p:nvPr/>
-        </p:nvSpPr>
-        <p:spPr>
-          <a:xfrm>
-            <a:off x="384048" y="2587752"/>
-            <a:ext cx="1892808" cy="201168"/>
-          </a:xfrm>
-          <a:prstGeom prst="rect">
-            <a:avLst/>
-          </a:prstGeom>
-          <a:noFill/>
-          <a:ln/>
-        </p:spPr>
-        <p:txBody>
-          <a:bodyPr wrap="square" lIns="0" tIns="0" rIns="0" bIns="0" rtlCol="0" anchor="ctr"/>
-          <a:lstStyle/>
-          <a:p>
-            <a:pPr indent="0" marL="0">
-              <a:buNone/>
-            </a:pPr>
-            <a:r>
-              <a:rPr lang="en-US" sz="850" b="1" dirty="0">
-                <a:solidFill>
-                  <a:srgbClr val="06185F"/>
-                </a:solidFill>
-                <a:latin typeface="Calibri" pitchFamily="34" charset="0"/>
-                <a:ea typeface="Calibri" pitchFamily="34" charset="-122"/>
-                <a:cs typeface="Calibri" pitchFamily="34" charset="-120"/>
-              </a:rPr>
-              <a:t>Zelle / JHA PayCenter</a:t>
-            </a:r>
-            <a:endParaRPr lang="en-US" sz="850" dirty="0"/>
-          </a:p>
-        </p:txBody>
-      </p:sp>
-      <p:sp>
-        <p:nvSpPr>
-          <p:cNvPr id="53" name="Text 51"/>
-          <p:cNvSpPr/>
-          <p:nvPr/>
-        </p:nvSpPr>
-        <p:spPr>
-          <a:xfrm>
-            <a:off x="384048" y="2779776"/>
-            <a:ext cx="1892808" cy="137160"/>
-          </a:xfrm>
-          <a:prstGeom prst="rect">
-            <a:avLst/>
-          </a:prstGeom>
-          <a:noFill/>
-          <a:ln/>
-        </p:spPr>
-        <p:txBody>
-          <a:bodyPr wrap="square" lIns="0" tIns="0" rIns="0" bIns="0" rtlCol="0" anchor="ctr"/>
-          <a:lstStyle/>
-          <a:p>
-            <a:pPr indent="0" marL="0">
-              <a:buNone/>
-            </a:pPr>
-            <a:r>
-              <a:rPr lang="en-US" sz="750" i="1" dirty="0">
-                <a:solidFill>
-                  <a:srgbClr val="B6BBC0"/>
-                </a:solidFill>
-                <a:latin typeface="Calibri" pitchFamily="34" charset="0"/>
-                <a:ea typeface="Calibri" pitchFamily="34" charset="-122"/>
-                <a:cs typeface="Calibri" pitchFamily="34" charset="-120"/>
-              </a:rPr>
-              <a:t>P2P, RTP, FedNow</a:t>
-            </a:r>
-            <a:endParaRPr lang="en-US" sz="750" dirty="0"/>
-          </a:p>
-        </p:txBody>
-      </p:sp>
-      <p:sp>
-        <p:nvSpPr>
-          <p:cNvPr id="54" name="Shape 52"/>
-          <p:cNvSpPr/>
-          <p:nvPr/>
-        </p:nvSpPr>
-        <p:spPr>
-          <a:xfrm>
-            <a:off x="3294126" y="2633472"/>
-            <a:ext cx="1504188" cy="182880"/>
-          </a:xfrm>
-          <a:prstGeom prst="rect">
-            <a:avLst/>
-          </a:prstGeom>
-          <a:solidFill>
-            <a:srgbClr val="073FA8"/>
-          </a:solidFill>
-          <a:ln w="12700">
-            <a:solidFill>
-              <a:srgbClr val="073FA8"/>
-            </a:solidFill>
-            <a:prstDash val="solid"/>
-          </a:ln>
-        </p:spPr>
-      </p:sp>
-      <p:sp>
-        <p:nvSpPr>
-          <p:cNvPr id="55" name="Text 53"/>
-          <p:cNvSpPr/>
-          <p:nvPr/>
-        </p:nvSpPr>
-        <p:spPr>
-          <a:xfrm>
-            <a:off x="3358134" y="2633472"/>
-            <a:ext cx="1394460" cy="182880"/>
-          </a:xfrm>
-          <a:prstGeom prst="rect">
-            <a:avLst/>
-          </a:prstGeom>
-          <a:noFill/>
-          <a:ln/>
-        </p:spPr>
-        <p:txBody>
-          <a:bodyPr wrap="square" lIns="0" tIns="0" rIns="0" bIns="0" rtlCol="0" anchor="ctr"/>
-          <a:lstStyle/>
-          <a:p>
-            <a:pPr indent="0" marL="0">
-              <a:buNone/>
-            </a:pPr>
-            <a:r>
-              <a:rPr lang="en-US" sz="750" dirty="0">
-                <a:solidFill>
-                  <a:srgbClr val="FFFFFF"/>
-                </a:solidFill>
-                <a:latin typeface="Calibri" pitchFamily="34" charset="0"/>
-                <a:ea typeface="Calibri" pitchFamily="34" charset="-122"/>
-                <a:cs typeface="Calibri" pitchFamily="34" charset="-120"/>
-              </a:rPr>
-              <a:t>Zelle Memo Intelligence · Anomaly</a:t>
-            </a:r>
-            <a:endParaRPr lang="en-US" sz="750" dirty="0"/>
-          </a:p>
-        </p:txBody>
-      </p:sp>
-      <p:sp>
-        <p:nvSpPr>
-          <p:cNvPr id="56" name="Shape 54"/>
-          <p:cNvSpPr/>
-          <p:nvPr/>
-        </p:nvSpPr>
-        <p:spPr>
-          <a:xfrm>
-            <a:off x="274320" y="2944368"/>
-            <a:ext cx="8503920" cy="356616"/>
-          </a:xfrm>
-          <a:prstGeom prst="rect">
-            <a:avLst/>
-          </a:prstGeom>
-          <a:solidFill>
-            <a:srgbClr val="FFFFFF"/>
-          </a:solidFill>
-          <a:ln w="12700">
-            <a:solidFill>
-              <a:srgbClr val="E7ECF0"/>
-            </a:solidFill>
-            <a:prstDash val="solid"/>
-          </a:ln>
-        </p:spPr>
-      </p:sp>
-      <p:sp>
-        <p:nvSpPr>
-          <p:cNvPr id="57" name="Shape 55"/>
-          <p:cNvSpPr/>
-          <p:nvPr/>
-        </p:nvSpPr>
-        <p:spPr>
-          <a:xfrm>
-            <a:off x="274320" y="2944368"/>
-            <a:ext cx="54864" cy="356616"/>
-          </a:xfrm>
-          <a:prstGeom prst="rect">
-            <a:avLst/>
-          </a:prstGeom>
-          <a:solidFill>
-            <a:srgbClr val="073FA8"/>
-          </a:solidFill>
-          <a:ln w="12700">
-            <a:solidFill>
-              <a:srgbClr val="073FA8"/>
-            </a:solidFill>
-            <a:prstDash val="solid"/>
-          </a:ln>
-        </p:spPr>
-      </p:sp>
-      <p:sp>
-        <p:nvSpPr>
-          <p:cNvPr id="58" name="Text 56"/>
-          <p:cNvSpPr/>
-          <p:nvPr/>
-        </p:nvSpPr>
-        <p:spPr>
-          <a:xfrm>
-            <a:off x="384048" y="2971800"/>
-            <a:ext cx="1892808" cy="201168"/>
-          </a:xfrm>
-          <a:prstGeom prst="rect">
-            <a:avLst/>
-          </a:prstGeom>
-          <a:noFill/>
-          <a:ln/>
-        </p:spPr>
-        <p:txBody>
-          <a:bodyPr wrap="square" lIns="0" tIns="0" rIns="0" bIns="0" rtlCol="0" anchor="ctr"/>
-          <a:lstStyle/>
-          <a:p>
-            <a:pPr indent="0" marL="0">
-              <a:buNone/>
-            </a:pPr>
-            <a:r>
-              <a:rPr lang="en-US" sz="850" b="1" dirty="0">
-                <a:solidFill>
-                  <a:srgbClr val="06185F"/>
-                </a:solidFill>
-                <a:latin typeface="Calibri" pitchFamily="34" charset="0"/>
-                <a:ea typeface="Calibri" pitchFamily="34" charset="-122"/>
-                <a:cs typeface="Calibri" pitchFamily="34" charset="-120"/>
-              </a:rPr>
-              <a:t>Jack Henry Wires</a:t>
-            </a:r>
-            <a:endParaRPr lang="en-US" sz="850" dirty="0"/>
-          </a:p>
-        </p:txBody>
-      </p:sp>
-      <p:sp>
-        <p:nvSpPr>
-          <p:cNvPr id="59" name="Text 57"/>
-          <p:cNvSpPr/>
-          <p:nvPr/>
-        </p:nvSpPr>
-        <p:spPr>
-          <a:xfrm>
-            <a:off x="384048" y="3163824"/>
-            <a:ext cx="1892808" cy="137160"/>
-          </a:xfrm>
-          <a:prstGeom prst="rect">
-            <a:avLst/>
-          </a:prstGeom>
-          <a:noFill/>
-          <a:ln/>
-        </p:spPr>
-        <p:txBody>
-          <a:bodyPr wrap="square" lIns="0" tIns="0" rIns="0" bIns="0" rtlCol="0" anchor="ctr"/>
-          <a:lstStyle/>
-          <a:p>
-            <a:pPr indent="0" marL="0">
-              <a:buNone/>
-            </a:pPr>
-            <a:r>
-              <a:rPr lang="en-US" sz="750" i="1" dirty="0">
-                <a:solidFill>
-                  <a:srgbClr val="B6BBC0"/>
-                </a:solidFill>
-                <a:latin typeface="Calibri" pitchFamily="34" charset="0"/>
-                <a:ea typeface="Calibri" pitchFamily="34" charset="-122"/>
-                <a:cs typeface="Calibri" pitchFamily="34" charset="-120"/>
-              </a:rPr>
-              <a:t>Domestic FedWire + Intl</a:t>
-            </a:r>
-            <a:endParaRPr lang="en-US" sz="750" dirty="0"/>
-          </a:p>
-        </p:txBody>
-      </p:sp>
-      <p:sp>
-        <p:nvSpPr>
-          <p:cNvPr id="60" name="Shape 58"/>
-          <p:cNvSpPr/>
-          <p:nvPr/>
-        </p:nvSpPr>
-        <p:spPr>
-          <a:xfrm>
-            <a:off x="3294126" y="3017520"/>
-            <a:ext cx="1504188" cy="182880"/>
-          </a:xfrm>
-          <a:prstGeom prst="rect">
-            <a:avLst/>
-          </a:prstGeom>
-          <a:solidFill>
-            <a:srgbClr val="073FA8"/>
-          </a:solidFill>
-          <a:ln w="12700">
-            <a:solidFill>
-              <a:srgbClr val="073FA8"/>
-            </a:solidFill>
-            <a:prstDash val="solid"/>
-          </a:ln>
-        </p:spPr>
-      </p:sp>
-      <p:sp>
-        <p:nvSpPr>
-          <p:cNvPr id="61" name="Text 59"/>
-          <p:cNvSpPr/>
-          <p:nvPr/>
-        </p:nvSpPr>
-        <p:spPr>
-          <a:xfrm>
-            <a:off x="3358134" y="3017520"/>
-            <a:ext cx="1394460" cy="182880"/>
-          </a:xfrm>
-          <a:prstGeom prst="rect">
-            <a:avLst/>
-          </a:prstGeom>
-          <a:noFill/>
-          <a:ln/>
-        </p:spPr>
-        <p:txBody>
-          <a:bodyPr wrap="square" lIns="0" tIns="0" rIns="0" bIns="0" rtlCol="0" anchor="ctr"/>
-          <a:lstStyle/>
-          <a:p>
-            <a:pPr indent="0" marL="0">
-              <a:buNone/>
-            </a:pPr>
-            <a:r>
-              <a:rPr lang="en-US" sz="750" dirty="0">
-                <a:solidFill>
-                  <a:srgbClr val="FFFFFF"/>
-                </a:solidFill>
-                <a:latin typeface="Calibri" pitchFamily="34" charset="0"/>
-                <a:ea typeface="Calibri" pitchFamily="34" charset="-122"/>
-                <a:cs typeface="Calibri" pitchFamily="34" charset="-120"/>
-              </a:rPr>
-              <a:t>Anomaly Detection (wire fraud)</a:t>
-            </a:r>
-            <a:endParaRPr lang="en-US" sz="750" dirty="0"/>
-          </a:p>
-        </p:txBody>
-      </p:sp>
-      <p:sp>
-        <p:nvSpPr>
-          <p:cNvPr id="62" name="Shape 60"/>
-          <p:cNvSpPr/>
-          <p:nvPr/>
-        </p:nvSpPr>
-        <p:spPr>
-          <a:xfrm>
-            <a:off x="274320" y="3328416"/>
-            <a:ext cx="8503920" cy="356616"/>
-          </a:xfrm>
-          <a:prstGeom prst="rect">
-            <a:avLst/>
-          </a:prstGeom>
-          <a:solidFill>
-            <a:srgbClr val="F8F9FA"/>
-          </a:solidFill>
-          <a:ln w="12700">
-            <a:solidFill>
-              <a:srgbClr val="E7ECF0"/>
-            </a:solidFill>
-            <a:prstDash val="solid"/>
-          </a:ln>
-        </p:spPr>
-      </p:sp>
-      <p:sp>
-        <p:nvSpPr>
-          <p:cNvPr id="63" name="Shape 61"/>
-          <p:cNvSpPr/>
-          <p:nvPr/>
-        </p:nvSpPr>
-        <p:spPr>
-          <a:xfrm>
-            <a:off x="274320" y="3328416"/>
-            <a:ext cx="54864" cy="356616"/>
-          </a:xfrm>
-          <a:prstGeom prst="rect">
-            <a:avLst/>
-          </a:prstGeom>
-          <a:solidFill>
-            <a:srgbClr val="0B68D4"/>
-          </a:solidFill>
-          <a:ln w="12700">
-            <a:solidFill>
-              <a:srgbClr val="0B68D4"/>
-            </a:solidFill>
-            <a:prstDash val="solid"/>
-          </a:ln>
-        </p:spPr>
-      </p:sp>
-      <p:sp>
-        <p:nvSpPr>
-          <p:cNvPr id="64" name="Text 62"/>
-          <p:cNvSpPr/>
-          <p:nvPr/>
-        </p:nvSpPr>
-        <p:spPr>
-          <a:xfrm>
-            <a:off x="384048" y="3355848"/>
-            <a:ext cx="1892808" cy="201168"/>
-          </a:xfrm>
-          <a:prstGeom prst="rect">
-            <a:avLst/>
-          </a:prstGeom>
-          <a:noFill/>
-          <a:ln/>
-        </p:spPr>
-        <p:txBody>
-          <a:bodyPr wrap="square" lIns="0" tIns="0" rIns="0" bIns="0" rtlCol="0" anchor="ctr"/>
-          <a:lstStyle/>
-          <a:p>
-            <a:pPr indent="0" marL="0">
-              <a:buNone/>
-            </a:pPr>
-            <a:r>
-              <a:rPr lang="en-US" sz="850" b="1" dirty="0">
-                <a:solidFill>
-                  <a:srgbClr val="06185F"/>
-                </a:solidFill>
-                <a:latin typeface="Calibri" pitchFamily="34" charset="0"/>
-                <a:ea typeface="Calibri" pitchFamily="34" charset="-122"/>
-                <a:cs typeface="Calibri" pitchFamily="34" charset="-120"/>
-              </a:rPr>
-              <a:t>iPay Bill Pay</a:t>
-            </a:r>
-            <a:endParaRPr lang="en-US" sz="850" dirty="0"/>
-          </a:p>
-        </p:txBody>
-      </p:sp>
-      <p:sp>
-        <p:nvSpPr>
-          <p:cNvPr id="65" name="Text 63"/>
-          <p:cNvSpPr/>
-          <p:nvPr/>
-        </p:nvSpPr>
-        <p:spPr>
-          <a:xfrm>
-            <a:off x="384048" y="3547872"/>
-            <a:ext cx="1892808" cy="137160"/>
-          </a:xfrm>
-          <a:prstGeom prst="rect">
-            <a:avLst/>
-          </a:prstGeom>
-          <a:noFill/>
-          <a:ln/>
-        </p:spPr>
-        <p:txBody>
-          <a:bodyPr wrap="square" lIns="0" tIns="0" rIns="0" bIns="0" rtlCol="0" anchor="ctr"/>
-          <a:lstStyle/>
-          <a:p>
-            <a:pPr indent="0" marL="0">
-              <a:buNone/>
-            </a:pPr>
-            <a:r>
-              <a:rPr lang="en-US" sz="750" i="1" dirty="0">
-                <a:solidFill>
-                  <a:srgbClr val="B6BBC0"/>
-                </a:solidFill>
-                <a:latin typeface="Calibri" pitchFamily="34" charset="0"/>
-                <a:ea typeface="Calibri" pitchFamily="34" charset="-122"/>
-                <a:cs typeface="Calibri" pitchFamily="34" charset="-120"/>
-              </a:rPr>
-              <a:t>Consumer + Business bill pay</a:t>
-            </a:r>
-            <a:endParaRPr lang="en-US" sz="750" dirty="0"/>
-          </a:p>
-        </p:txBody>
-      </p:sp>
-      <p:sp>
-        <p:nvSpPr>
-          <p:cNvPr id="66" name="Shape 64"/>
-          <p:cNvSpPr/>
-          <p:nvPr/>
-        </p:nvSpPr>
-        <p:spPr>
-          <a:xfrm>
-            <a:off x="4082796" y="3401568"/>
-            <a:ext cx="1504188" cy="182880"/>
-          </a:xfrm>
-          <a:prstGeom prst="rect">
-            <a:avLst/>
-          </a:prstGeom>
-          <a:solidFill>
-            <a:srgbClr val="0B68D4"/>
-          </a:solidFill>
-          <a:ln w="12700">
-            <a:solidFill>
-              <a:srgbClr val="0B68D4"/>
-            </a:solidFill>
-            <a:prstDash val="solid"/>
-          </a:ln>
-        </p:spPr>
-      </p:sp>
-      <p:sp>
-        <p:nvSpPr>
-          <p:cNvPr id="67" name="Text 65"/>
-          <p:cNvSpPr/>
-          <p:nvPr/>
-        </p:nvSpPr>
-        <p:spPr>
-          <a:xfrm>
-            <a:off x="4146804" y="3401568"/>
-            <a:ext cx="1394460" cy="182880"/>
-          </a:xfrm>
-          <a:prstGeom prst="rect">
-            <a:avLst/>
-          </a:prstGeom>
-          <a:noFill/>
-          <a:ln/>
-        </p:spPr>
-        <p:txBody>
-          <a:bodyPr wrap="square" lIns="0" tIns="0" rIns="0" bIns="0" rtlCol="0" anchor="ctr"/>
-          <a:lstStyle/>
-          <a:p>
-            <a:pPr indent="0" marL="0">
-              <a:buNone/>
-            </a:pPr>
-            <a:r>
-              <a:rPr lang="en-US" sz="750" dirty="0">
-                <a:solidFill>
-                  <a:srgbClr val="FFFFFF"/>
-                </a:solidFill>
-                <a:latin typeface="Calibri" pitchFamily="34" charset="0"/>
-                <a:ea typeface="Calibri" pitchFamily="34" charset="-122"/>
-                <a:cs typeface="Calibri" pitchFamily="34" charset="-120"/>
-              </a:rPr>
-              <a:t>Cross-Sell Propensity</a:t>
-            </a:r>
-            <a:endParaRPr lang="en-US" sz="750" dirty="0"/>
-          </a:p>
-        </p:txBody>
-      </p:sp>
-      <p:sp>
-        <p:nvSpPr>
-          <p:cNvPr id="68" name="Shape 66"/>
-          <p:cNvSpPr/>
-          <p:nvPr/>
-        </p:nvSpPr>
-        <p:spPr>
-          <a:xfrm>
-            <a:off x="274320" y="3712464"/>
-            <a:ext cx="8503920" cy="356616"/>
-          </a:xfrm>
-          <a:prstGeom prst="rect">
-            <a:avLst/>
-          </a:prstGeom>
-          <a:solidFill>
-            <a:srgbClr val="FFFFFF"/>
-          </a:solidFill>
-          <a:ln w="12700">
-            <a:solidFill>
-              <a:srgbClr val="E7ECF0"/>
-            </a:solidFill>
-            <a:prstDash val="solid"/>
-          </a:ln>
-        </p:spPr>
-      </p:sp>
-      <p:sp>
-        <p:nvSpPr>
-          <p:cNvPr id="69" name="Shape 67"/>
-          <p:cNvSpPr/>
-          <p:nvPr/>
-        </p:nvSpPr>
-        <p:spPr>
-          <a:xfrm>
-            <a:off x="274320" y="3712464"/>
-            <a:ext cx="54864" cy="356616"/>
-          </a:xfrm>
-          <a:prstGeom prst="rect">
-            <a:avLst/>
-          </a:prstGeom>
-          <a:solidFill>
-            <a:srgbClr val="0B68D4"/>
-          </a:solidFill>
-          <a:ln w="12700">
-            <a:solidFill>
-              <a:srgbClr val="0B68D4"/>
-            </a:solidFill>
-            <a:prstDash val="solid"/>
-          </a:ln>
-        </p:spPr>
-      </p:sp>
-      <p:sp>
-        <p:nvSpPr>
-          <p:cNvPr id="70" name="Text 68"/>
-          <p:cNvSpPr/>
-          <p:nvPr/>
-        </p:nvSpPr>
-        <p:spPr>
-          <a:xfrm>
-            <a:off x="384048" y="3739896"/>
-            <a:ext cx="1892808" cy="201168"/>
-          </a:xfrm>
-          <a:prstGeom prst="rect">
-            <a:avLst/>
-          </a:prstGeom>
-          <a:noFill/>
-          <a:ln/>
-        </p:spPr>
-        <p:txBody>
-          <a:bodyPr wrap="square" lIns="0" tIns="0" rIns="0" bIns="0" rtlCol="0" anchor="ctr"/>
-          <a:lstStyle/>
-          <a:p>
-            <a:pPr indent="0" marL="0">
-              <a:buNone/>
-            </a:pPr>
-            <a:r>
-              <a:rPr lang="en-US" sz="850" b="1" dirty="0">
-                <a:solidFill>
-                  <a:srgbClr val="06185F"/>
-                </a:solidFill>
-                <a:latin typeface="Calibri" pitchFamily="34" charset="0"/>
-                <a:ea typeface="Calibri" pitchFamily="34" charset="-122"/>
-                <a:cs typeface="Calibri" pitchFamily="34" charset="-120"/>
-              </a:rPr>
-              <a:t>Payrailz (P2P / A2A)</a:t>
-            </a:r>
-            <a:endParaRPr lang="en-US" sz="850" dirty="0"/>
-          </a:p>
-        </p:txBody>
-      </p:sp>
-      <p:sp>
-        <p:nvSpPr>
-          <p:cNvPr id="71" name="Text 69"/>
-          <p:cNvSpPr/>
-          <p:nvPr/>
-        </p:nvSpPr>
-        <p:spPr>
-          <a:xfrm>
-            <a:off x="384048" y="3931920"/>
-            <a:ext cx="1892808" cy="137160"/>
-          </a:xfrm>
-          <a:prstGeom prst="rect">
-            <a:avLst/>
-          </a:prstGeom>
-          <a:noFill/>
-          <a:ln/>
-        </p:spPr>
-        <p:txBody>
-          <a:bodyPr wrap="square" lIns="0" tIns="0" rIns="0" bIns="0" rtlCol="0" anchor="ctr"/>
-          <a:lstStyle/>
-          <a:p>
-            <a:pPr indent="0" marL="0">
-              <a:buNone/>
-            </a:pPr>
-            <a:r>
-              <a:rPr lang="en-US" sz="750" i="1" dirty="0">
-                <a:solidFill>
-                  <a:srgbClr val="B6BBC0"/>
-                </a:solidFill>
-                <a:latin typeface="Calibri" pitchFamily="34" charset="0"/>
-                <a:ea typeface="Calibri" pitchFamily="34" charset="-122"/>
-                <a:cs typeface="Calibri" pitchFamily="34" charset="-120"/>
-              </a:rPr>
-              <a:t>Pay a Person, Transfer Money</a:t>
-            </a:r>
-            <a:endParaRPr lang="en-US" sz="750" dirty="0"/>
-          </a:p>
-        </p:txBody>
-      </p:sp>
-      <p:sp>
-        <p:nvSpPr>
-          <p:cNvPr id="72" name="Shape 70"/>
-          <p:cNvSpPr/>
-          <p:nvPr/>
-        </p:nvSpPr>
-        <p:spPr>
-          <a:xfrm>
-            <a:off x="4082796" y="3785616"/>
-            <a:ext cx="1504188" cy="182880"/>
-          </a:xfrm>
-          <a:prstGeom prst="rect">
-            <a:avLst/>
-          </a:prstGeom>
-          <a:solidFill>
-            <a:srgbClr val="0B68D4"/>
-          </a:solidFill>
-          <a:ln w="12700">
-            <a:solidFill>
-              <a:srgbClr val="0B68D4"/>
-            </a:solidFill>
-            <a:prstDash val="solid"/>
-          </a:ln>
-        </p:spPr>
-      </p:sp>
-      <p:sp>
-        <p:nvSpPr>
-          <p:cNvPr id="73" name="Text 71"/>
-          <p:cNvSpPr/>
-          <p:nvPr/>
-        </p:nvSpPr>
-        <p:spPr>
-          <a:xfrm>
-            <a:off x="4146804" y="3785616"/>
-            <a:ext cx="1394460" cy="182880"/>
-          </a:xfrm>
-          <a:prstGeom prst="rect">
-            <a:avLst/>
-          </a:prstGeom>
-          <a:noFill/>
-          <a:ln/>
-        </p:spPr>
-        <p:txBody>
-          <a:bodyPr wrap="square" lIns="0" tIns="0" rIns="0" bIns="0" rtlCol="0" anchor="ctr"/>
-          <a:lstStyle/>
-          <a:p>
-            <a:pPr indent="0" marL="0">
-              <a:buNone/>
-            </a:pPr>
-            <a:r>
-              <a:rPr lang="en-US" sz="750" dirty="0">
-                <a:solidFill>
-                  <a:srgbClr val="FFFFFF"/>
-                </a:solidFill>
-                <a:latin typeface="Calibri" pitchFamily="34" charset="0"/>
-                <a:ea typeface="Calibri" pitchFamily="34" charset="-122"/>
-                <a:cs typeface="Calibri" pitchFamily="34" charset="-120"/>
-              </a:rPr>
-              <a:t>Fraud Ring Detection</a:t>
-            </a:r>
-            <a:endParaRPr lang="en-US" sz="750" dirty="0"/>
-          </a:p>
-        </p:txBody>
-      </p:sp>
-      <p:sp>
-        <p:nvSpPr>
-          <p:cNvPr id="74" name="Shape 72"/>
-          <p:cNvSpPr/>
-          <p:nvPr/>
-        </p:nvSpPr>
-        <p:spPr>
-          <a:xfrm>
-            <a:off x="274320" y="4096512"/>
-            <a:ext cx="8503920" cy="356616"/>
-          </a:xfrm>
-          <a:prstGeom prst="rect">
-            <a:avLst/>
-          </a:prstGeom>
-          <a:solidFill>
-            <a:srgbClr val="F8F9FA"/>
-          </a:solidFill>
-          <a:ln w="12700">
-            <a:solidFill>
-              <a:srgbClr val="E7ECF0"/>
-            </a:solidFill>
-            <a:prstDash val="solid"/>
-          </a:ln>
-        </p:spPr>
-      </p:sp>
-      <p:sp>
-        <p:nvSpPr>
-          <p:cNvPr id="75" name="Shape 73"/>
-          <p:cNvSpPr/>
-          <p:nvPr/>
-        </p:nvSpPr>
-        <p:spPr>
-          <a:xfrm>
-            <a:off x="274320" y="4096512"/>
-            <a:ext cx="54864" cy="356616"/>
+          <p:cNvPr id="84" name="Shape 82"/>
+          <p:cNvSpPr/>
+          <p:nvPr/>
+        </p:nvSpPr>
+        <p:spPr>
+          <a:xfrm>
+            <a:off x="5660136" y="4809744"/>
+            <a:ext cx="2292858" cy="182880"/>
           </a:xfrm>
           <a:prstGeom prst="rect">
             <a:avLst/>
@@ -19432,14 +19727,14 @@
       </p:sp>
       <p:sp>
         <p:nvSpPr>
-          <p:cNvPr id="76" name="Text 74"/>
-          <p:cNvSpPr/>
-          <p:nvPr/>
-        </p:nvSpPr>
-        <p:spPr>
-          <a:xfrm>
-            <a:off x="384048" y="4123944"/>
-            <a:ext cx="1892808" cy="201168"/>
+          <p:cNvPr id="85" name="Text 83"/>
+          <p:cNvSpPr/>
+          <p:nvPr/>
+        </p:nvSpPr>
+        <p:spPr>
+          <a:xfrm>
+            <a:off x="5724144" y="4809744"/>
+            <a:ext cx="2183130" cy="182880"/>
           </a:xfrm>
           <a:prstGeom prst="rect">
             <a:avLst/>
@@ -19455,54 +19750,15 @@
               <a:buNone/>
             </a:pPr>
             <a:r>
-              <a:rPr lang="en-US" sz="850" b="1" dirty="0">
-                <a:solidFill>
-                  <a:srgbClr val="06185F"/>
-                </a:solidFill>
-                <a:latin typeface="Calibri" pitchFamily="34" charset="0"/>
-                <a:ea typeface="Calibri" pitchFamily="34" charset="-122"/>
-                <a:cs typeface="Calibri" pitchFamily="34" charset="-120"/>
-              </a:rPr>
-              <a:t>Banno Digital Platform</a:t>
-            </a:r>
-            <a:endParaRPr lang="en-US" sz="850" dirty="0"/>
-          </a:p>
-        </p:txBody>
-      </p:sp>
-      <p:sp>
-        <p:nvSpPr>
-          <p:cNvPr id="77" name="Text 75"/>
-          <p:cNvSpPr/>
-          <p:nvPr/>
-        </p:nvSpPr>
-        <p:spPr>
-          <a:xfrm>
-            <a:off x="384048" y="4315968"/>
-            <a:ext cx="1892808" cy="137160"/>
-          </a:xfrm>
-          <a:prstGeom prst="rect">
-            <a:avLst/>
-          </a:prstGeom>
-          <a:noFill/>
-          <a:ln/>
-        </p:spPr>
-        <p:txBody>
-          <a:bodyPr wrap="square" lIns="0" tIns="0" rIns="0" bIns="0" rtlCol="0" anchor="ctr"/>
-          <a:lstStyle/>
-          <a:p>
-            <a:pPr indent="0" marL="0">
-              <a:buNone/>
-            </a:pPr>
-            <a:r>
-              <a:rPr lang="en-US" sz="750" i="1" dirty="0">
-                <a:solidFill>
-                  <a:srgbClr val="B6BBC0"/>
-                </a:solidFill>
-                <a:latin typeface="Calibri" pitchFamily="34" charset="0"/>
-                <a:ea typeface="Calibri" pitchFamily="34" charset="-122"/>
-                <a:cs typeface="Calibri" pitchFamily="34" charset="-120"/>
-              </a:rPr>
-              <a:t>Session, engagement, clicks</a:t>
+              <a:rPr lang="en-US" sz="750" dirty="0">
+                <a:solidFill>
+                  <a:srgbClr val="FFFFFF"/>
+                </a:solidFill>
+                <a:latin typeface="Calibri" pitchFamily="34" charset="0"/>
+                <a:ea typeface="Calibri" pitchFamily="34" charset="-122"/>
+                <a:cs typeface="Calibri" pitchFamily="34" charset="-120"/>
+              </a:rPr>
+              <a:t>Sentiment · Next Best Action · FI Decision Studio</a:t>
             </a:r>
             <a:endParaRPr lang="en-US" sz="750" dirty="0"/>
           </a:p>
@@ -19510,461 +19766,13 @@
       </p:sp>
       <p:sp>
         <p:nvSpPr>
-          <p:cNvPr id="78" name="Shape 76"/>
-          <p:cNvSpPr/>
-          <p:nvPr/>
-        </p:nvSpPr>
-        <p:spPr>
-          <a:xfrm>
-            <a:off x="4871466" y="4169664"/>
-            <a:ext cx="1504188" cy="182880"/>
-          </a:xfrm>
-          <a:prstGeom prst="rect">
-            <a:avLst/>
-          </a:prstGeom>
-          <a:solidFill>
-            <a:srgbClr val="575A5D"/>
-          </a:solidFill>
-          <a:ln w="12700">
-            <a:solidFill>
-              <a:srgbClr val="575A5D"/>
-            </a:solidFill>
-            <a:prstDash val="solid"/>
-          </a:ln>
-        </p:spPr>
-      </p:sp>
-      <p:sp>
-        <p:nvSpPr>
-          <p:cNvPr id="79" name="Text 77"/>
-          <p:cNvSpPr/>
-          <p:nvPr/>
-        </p:nvSpPr>
-        <p:spPr>
-          <a:xfrm>
-            <a:off x="4935474" y="4169664"/>
-            <a:ext cx="1394460" cy="182880"/>
-          </a:xfrm>
-          <a:prstGeom prst="rect">
-            <a:avLst/>
-          </a:prstGeom>
-          <a:noFill/>
-          <a:ln/>
-        </p:spPr>
-        <p:txBody>
-          <a:bodyPr wrap="square" lIns="0" tIns="0" rIns="0" bIns="0" rtlCol="0" anchor="ctr"/>
-          <a:lstStyle/>
-          <a:p>
-            <a:pPr indent="0" marL="0">
-              <a:buNone/>
-            </a:pPr>
-            <a:r>
-              <a:rPr lang="en-US" sz="750" dirty="0">
-                <a:solidFill>
-                  <a:srgbClr val="FFFFFF"/>
-                </a:solidFill>
-                <a:latin typeface="Calibri" pitchFamily="34" charset="0"/>
-                <a:ea typeface="Calibri" pitchFamily="34" charset="-122"/>
-                <a:cs typeface="Calibri" pitchFamily="34" charset="-120"/>
-              </a:rPr>
-              <a:t>Sentiment Engine · Next Best Action</a:t>
-            </a:r>
-            <a:endParaRPr lang="en-US" sz="750" dirty="0"/>
-          </a:p>
-        </p:txBody>
-      </p:sp>
-      <p:sp>
-        <p:nvSpPr>
-          <p:cNvPr id="80" name="Shape 78"/>
-          <p:cNvSpPr/>
-          <p:nvPr/>
-        </p:nvSpPr>
-        <p:spPr>
-          <a:xfrm>
-            <a:off x="274320" y="4480560"/>
-            <a:ext cx="8503920" cy="356616"/>
-          </a:xfrm>
-          <a:prstGeom prst="rect">
-            <a:avLst/>
-          </a:prstGeom>
-          <a:solidFill>
-            <a:srgbClr val="FFFFFF"/>
-          </a:solidFill>
-          <a:ln w="12700">
-            <a:solidFill>
-              <a:srgbClr val="E7ECF0"/>
-            </a:solidFill>
-            <a:prstDash val="solid"/>
-          </a:ln>
-        </p:spPr>
-      </p:sp>
-      <p:sp>
-        <p:nvSpPr>
-          <p:cNvPr id="81" name="Shape 79"/>
-          <p:cNvSpPr/>
-          <p:nvPr/>
-        </p:nvSpPr>
-        <p:spPr>
-          <a:xfrm>
-            <a:off x="274320" y="4480560"/>
-            <a:ext cx="54864" cy="356616"/>
-          </a:xfrm>
-          <a:prstGeom prst="rect">
-            <a:avLst/>
-          </a:prstGeom>
-          <a:solidFill>
-            <a:srgbClr val="575A5D"/>
-          </a:solidFill>
-          <a:ln w="12700">
-            <a:solidFill>
-              <a:srgbClr val="575A5D"/>
-            </a:solidFill>
-            <a:prstDash val="solid"/>
-          </a:ln>
-        </p:spPr>
-      </p:sp>
-      <p:sp>
-        <p:nvSpPr>
-          <p:cNvPr id="82" name="Text 80"/>
-          <p:cNvSpPr/>
-          <p:nvPr/>
-        </p:nvSpPr>
-        <p:spPr>
-          <a:xfrm>
-            <a:off x="384048" y="4507992"/>
-            <a:ext cx="1892808" cy="201168"/>
-          </a:xfrm>
-          <a:prstGeom prst="rect">
-            <a:avLst/>
-          </a:prstGeom>
-          <a:noFill/>
-          <a:ln/>
-        </p:spPr>
-        <p:txBody>
-          <a:bodyPr wrap="square" lIns="0" tIns="0" rIns="0" bIns="0" rtlCol="0" anchor="ctr"/>
-          <a:lstStyle/>
-          <a:p>
-            <a:pPr indent="0" marL="0">
-              <a:buNone/>
-            </a:pPr>
-            <a:r>
-              <a:rPr lang="en-US" sz="850" b="1" dirty="0">
-                <a:solidFill>
-                  <a:srgbClr val="06185F"/>
-                </a:solidFill>
-                <a:latin typeface="Calibri" pitchFamily="34" charset="0"/>
-                <a:ea typeface="Calibri" pitchFamily="34" charset="-122"/>
-                <a:cs typeface="Calibri" pitchFamily="34" charset="-120"/>
-              </a:rPr>
-              <a:t>Business Pmts / SmartPay</a:t>
-            </a:r>
-            <a:endParaRPr lang="en-US" sz="850" dirty="0"/>
-          </a:p>
-        </p:txBody>
-      </p:sp>
-      <p:sp>
-        <p:nvSpPr>
-          <p:cNvPr id="83" name="Text 81"/>
-          <p:cNvSpPr/>
-          <p:nvPr/>
-        </p:nvSpPr>
-        <p:spPr>
-          <a:xfrm>
-            <a:off x="384048" y="4700016"/>
-            <a:ext cx="1892808" cy="137160"/>
-          </a:xfrm>
-          <a:prstGeom prst="rect">
-            <a:avLst/>
-          </a:prstGeom>
-          <a:noFill/>
-          <a:ln/>
-        </p:spPr>
-        <p:txBody>
-          <a:bodyPr wrap="square" lIns="0" tIns="0" rIns="0" bIns="0" rtlCol="0" anchor="ctr"/>
-          <a:lstStyle/>
-          <a:p>
-            <a:pPr indent="0" marL="0">
-              <a:buNone/>
-            </a:pPr>
-            <a:r>
-              <a:rPr lang="en-US" sz="750" i="1" dirty="0">
-                <a:solidFill>
-                  <a:srgbClr val="B6BBC0"/>
-                </a:solidFill>
-                <a:latin typeface="Calibri" pitchFamily="34" charset="0"/>
-                <a:ea typeface="Calibri" pitchFamily="34" charset="-122"/>
-                <a:cs typeface="Calibri" pitchFamily="34" charset="-120"/>
-              </a:rPr>
-              <a:t>B2B, ACH vendor, remittance</a:t>
-            </a:r>
-            <a:endParaRPr lang="en-US" sz="750" dirty="0"/>
-          </a:p>
-        </p:txBody>
-      </p:sp>
-      <p:sp>
-        <p:nvSpPr>
-          <p:cNvPr id="84" name="Shape 82"/>
-          <p:cNvSpPr/>
-          <p:nvPr/>
-        </p:nvSpPr>
-        <p:spPr>
-          <a:xfrm>
-            <a:off x="5660136" y="4553712"/>
-            <a:ext cx="1504188" cy="182880"/>
-          </a:xfrm>
-          <a:prstGeom prst="rect">
-            <a:avLst/>
-          </a:prstGeom>
-          <a:solidFill>
-            <a:srgbClr val="575A5D"/>
-          </a:solidFill>
-          <a:ln w="12700">
-            <a:solidFill>
-              <a:srgbClr val="575A5D"/>
-            </a:solidFill>
-            <a:prstDash val="solid"/>
-          </a:ln>
-        </p:spPr>
-      </p:sp>
-      <p:sp>
-        <p:nvSpPr>
-          <p:cNvPr id="85" name="Text 83"/>
-          <p:cNvSpPr/>
-          <p:nvPr/>
-        </p:nvSpPr>
-        <p:spPr>
-          <a:xfrm>
-            <a:off x="5724144" y="4553712"/>
-            <a:ext cx="1394460" cy="182880"/>
-          </a:xfrm>
-          <a:prstGeom prst="rect">
-            <a:avLst/>
-          </a:prstGeom>
-          <a:noFill/>
-          <a:ln/>
-        </p:spPr>
-        <p:txBody>
-          <a:bodyPr wrap="square" lIns="0" tIns="0" rIns="0" bIns="0" rtlCol="0" anchor="ctr"/>
-          <a:lstStyle/>
-          <a:p>
-            <a:pPr indent="0" marL="0">
-              <a:buNone/>
-            </a:pPr>
-            <a:r>
-              <a:rPr lang="en-US" sz="750" dirty="0">
-                <a:solidFill>
-                  <a:srgbClr val="FFFFFF"/>
-                </a:solidFill>
-                <a:latin typeface="Calibri" pitchFamily="34" charset="0"/>
-                <a:ea typeface="Calibri" pitchFamily="34" charset="-122"/>
-                <a:cs typeface="Calibri" pitchFamily="34" charset="-120"/>
-              </a:rPr>
-              <a:t>Overdraft Prediction</a:t>
-            </a:r>
-            <a:endParaRPr lang="en-US" sz="750" dirty="0"/>
-          </a:p>
-        </p:txBody>
-      </p:sp>
-      <p:sp>
-        <p:nvSpPr>
           <p:cNvPr id="86" name="Shape 84"/>
           <p:cNvSpPr/>
           <p:nvPr/>
         </p:nvSpPr>
         <p:spPr>
           <a:xfrm>
-            <a:off x="274320" y="4864608"/>
-            <a:ext cx="8503920" cy="356616"/>
-          </a:xfrm>
-          <a:prstGeom prst="rect">
-            <a:avLst/>
-          </a:prstGeom>
-          <a:solidFill>
-            <a:srgbClr val="F8F9FA"/>
-          </a:solidFill>
-          <a:ln w="12700">
-            <a:solidFill>
-              <a:srgbClr val="E7ECF0"/>
-            </a:solidFill>
-            <a:prstDash val="solid"/>
-          </a:ln>
-        </p:spPr>
-      </p:sp>
-      <p:sp>
-        <p:nvSpPr>
-          <p:cNvPr id="87" name="Shape 85"/>
-          <p:cNvSpPr/>
-          <p:nvPr/>
-        </p:nvSpPr>
-        <p:spPr>
-          <a:xfrm>
-            <a:off x="274320" y="4864608"/>
-            <a:ext cx="54864" cy="356616"/>
-          </a:xfrm>
-          <a:prstGeom prst="rect">
-            <a:avLst/>
-          </a:prstGeom>
-          <a:solidFill>
-            <a:srgbClr val="0D2E7A"/>
-          </a:solidFill>
-          <a:ln w="12700">
-            <a:solidFill>
-              <a:srgbClr val="0D2E7A"/>
-            </a:solidFill>
-            <a:prstDash val="solid"/>
-          </a:ln>
-        </p:spPr>
-      </p:sp>
-      <p:sp>
-        <p:nvSpPr>
-          <p:cNvPr id="88" name="Text 86"/>
-          <p:cNvSpPr/>
-          <p:nvPr/>
-        </p:nvSpPr>
-        <p:spPr>
-          <a:xfrm>
-            <a:off x="384048" y="4892040"/>
-            <a:ext cx="1892808" cy="201168"/>
-          </a:xfrm>
-          <a:prstGeom prst="rect">
-            <a:avLst/>
-          </a:prstGeom>
-          <a:noFill/>
-          <a:ln/>
-        </p:spPr>
-        <p:txBody>
-          <a:bodyPr wrap="square" lIns="0" tIns="0" rIns="0" bIns="0" rtlCol="0" anchor="ctr"/>
-          <a:lstStyle/>
-          <a:p>
-            <a:pPr indent="0" marL="0">
-              <a:buNone/>
-            </a:pPr>
-            <a:r>
-              <a:rPr lang="en-US" sz="850" b="1" dirty="0">
-                <a:solidFill>
-                  <a:srgbClr val="06185F"/>
-                </a:solidFill>
-                <a:latin typeface="Calibri" pitchFamily="34" charset="0"/>
-                <a:ea typeface="Calibri" pitchFamily="34" charset="-122"/>
-                <a:cs typeface="Calibri" pitchFamily="34" charset="-120"/>
-              </a:rPr>
-              <a:t>FI Decision Studio</a:t>
-            </a:r>
-            <a:endParaRPr lang="en-US" sz="850" dirty="0"/>
-          </a:p>
-        </p:txBody>
-      </p:sp>
-      <p:sp>
-        <p:nvSpPr>
-          <p:cNvPr id="89" name="Text 87"/>
-          <p:cNvSpPr/>
-          <p:nvPr/>
-        </p:nvSpPr>
-        <p:spPr>
-          <a:xfrm>
-            <a:off x="384048" y="5084064"/>
-            <a:ext cx="1892808" cy="137160"/>
-          </a:xfrm>
-          <a:prstGeom prst="rect">
-            <a:avLst/>
-          </a:prstGeom>
-          <a:noFill/>
-          <a:ln/>
-        </p:spPr>
-        <p:txBody>
-          <a:bodyPr wrap="square" lIns="0" tIns="0" rIns="0" bIns="0" rtlCol="0" anchor="ctr"/>
-          <a:lstStyle/>
-          <a:p>
-            <a:pPr indent="0" marL="0">
-              <a:buNone/>
-            </a:pPr>
-            <a:r>
-              <a:rPr lang="en-US" sz="750" i="1" dirty="0">
-                <a:solidFill>
-                  <a:srgbClr val="B6BBC0"/>
-                </a:solidFill>
-                <a:latin typeface="Calibri" pitchFamily="34" charset="0"/>
-                <a:ea typeface="Calibri" pitchFamily="34" charset="-122"/>
-                <a:cs typeface="Calibri" pitchFamily="34" charset="-120"/>
-              </a:rPr>
-              <a:t>AutoML · SHAP · Rules · API</a:t>
-            </a:r>
-            <a:endParaRPr lang="en-US" sz="750" dirty="0"/>
-          </a:p>
-        </p:txBody>
-      </p:sp>
-      <p:sp>
-        <p:nvSpPr>
-          <p:cNvPr id="90" name="Shape 88"/>
-          <p:cNvSpPr/>
-          <p:nvPr/>
-        </p:nvSpPr>
-        <p:spPr>
-          <a:xfrm>
-            <a:off x="5660136" y="4937760"/>
-            <a:ext cx="3081528" cy="182880"/>
-          </a:xfrm>
-          <a:prstGeom prst="rect">
-            <a:avLst/>
-          </a:prstGeom>
-          <a:solidFill>
-            <a:srgbClr val="0D2E7A"/>
-          </a:solidFill>
-          <a:ln w="12700">
-            <a:solidFill>
-              <a:srgbClr val="0D2E7A"/>
-            </a:solidFill>
-            <a:prstDash val="solid"/>
-          </a:ln>
-        </p:spPr>
-      </p:sp>
-      <p:sp>
-        <p:nvSpPr>
-          <p:cNvPr id="91" name="Text 89"/>
-          <p:cNvSpPr/>
-          <p:nvPr/>
-        </p:nvSpPr>
-        <p:spPr>
-          <a:xfrm>
-            <a:off x="5724144" y="4937760"/>
-            <a:ext cx="2971800" cy="182880"/>
-          </a:xfrm>
-          <a:prstGeom prst="rect">
-            <a:avLst/>
-          </a:prstGeom>
-          <a:noFill/>
-          <a:ln/>
-        </p:spPr>
-        <p:txBody>
-          <a:bodyPr wrap="square" lIns="0" tIns="0" rIns="0" bIns="0" rtlCol="0" anchor="ctr"/>
-          <a:lstStyle/>
-          <a:p>
-            <a:pPr indent="0" marL="0">
-              <a:buNone/>
-            </a:pPr>
-            <a:r>
-              <a:rPr lang="en-US" sz="750" dirty="0">
-                <a:solidFill>
-                  <a:srgbClr val="FFFFFF"/>
-                </a:solidFill>
-                <a:latin typeface="Calibri" pitchFamily="34" charset="0"/>
-                <a:ea typeface="Calibri" pitchFamily="34" charset="-122"/>
-                <a:cs typeface="Calibri" pitchFamily="34" charset="-120"/>
-              </a:rPr>
-              <a:t>Custom FI Models (all data sources)</a:t>
-            </a:r>
-            <a:endParaRPr lang="en-US" sz="750" dirty="0"/>
-          </a:p>
-        </p:txBody>
-      </p:sp>
-      <p:sp>
-        <p:nvSpPr>
-          <p:cNvPr id="92" name="Shape 90"/>
-          <p:cNvSpPr/>
-          <p:nvPr/>
-        </p:nvSpPr>
-        <p:spPr>
-          <a:xfrm>
-            <a:off x="2482596" y="859536"/>
+            <a:off x="2482596" y="1115568"/>
             <a:ext cx="36576" cy="4005072"/>
           </a:xfrm>
           <a:prstGeom prst="rect">
@@ -19983,13 +19791,13 @@
       </p:sp>
       <p:sp>
         <p:nvSpPr>
-          <p:cNvPr id="93" name="Text 91"/>
-          <p:cNvSpPr/>
-          <p:nvPr/>
-        </p:nvSpPr>
-        <p:spPr>
-          <a:xfrm>
-            <a:off x="2359152" y="841248"/>
+          <p:cNvPr id="87" name="Text 85"/>
+          <p:cNvSpPr/>
+          <p:nvPr/>
+        </p:nvSpPr>
+        <p:spPr>
+          <a:xfrm>
+            <a:off x="2359152" y="1097280"/>
             <a:ext cx="502920" cy="219456"/>
           </a:xfrm>
           <a:prstGeom prst="rect">

</xml_diff>

<commit_message>
Fix App 7 & 8 detail slide overflow; add research source footnotes
- Shortened problem paragraphs on Personal-as-Commercial and Generational
  Wealth Deflection slides to fit within card bounds (no more header overlap)
- Added source footnote strip to both slides with Bank Director / Datos Insights
  citations (App 7) and Cerulli / McKinsey / LIMRA citations (App 8)

Co-Authored-By: Claude Sonnet 4.6 <noreply@anthropic.com>
</commit_message>
<xml_diff>
--- a/JH_DS_Strategy_JHBI.pptx
+++ b/JH_DS_Strategy_JHBI.pptx
@@ -3952,7 +3952,7 @@
         <p:spPr>
           <a:xfrm>
             <a:off x="438912" y="3785616"/>
-            <a:ext cx="2414016" cy="585216"/>
+            <a:ext cx="2414016" cy="548640"/>
           </a:xfrm>
           <a:prstGeom prst="rect">
             <a:avLst/>
@@ -3990,8 +3990,8 @@
         </p:nvSpPr>
         <p:spPr>
           <a:xfrm>
-            <a:off x="438912" y="4389120"/>
-            <a:ext cx="2414016" cy="475488"/>
+            <a:off x="438912" y="4343400"/>
+            <a:ext cx="2414016" cy="438912"/>
           </a:xfrm>
           <a:prstGeom prst="rect">
             <a:avLst/>
@@ -4079,7 +4079,7 @@
         <p:spPr>
           <a:xfrm>
             <a:off x="3364992" y="3785616"/>
-            <a:ext cx="2414016" cy="585216"/>
+            <a:ext cx="2414016" cy="548640"/>
           </a:xfrm>
           <a:prstGeom prst="rect">
             <a:avLst/>
@@ -4117,8 +4117,8 @@
         </p:nvSpPr>
         <p:spPr>
           <a:xfrm>
-            <a:off x="3364992" y="4389120"/>
-            <a:ext cx="2414016" cy="475488"/>
+            <a:off x="3364992" y="4343400"/>
+            <a:ext cx="2414016" cy="438912"/>
           </a:xfrm>
           <a:prstGeom prst="rect">
             <a:avLst/>
@@ -4206,7 +4206,7 @@
         <p:spPr>
           <a:xfrm>
             <a:off x="6291072" y="3785616"/>
-            <a:ext cx="2414016" cy="585216"/>
+            <a:ext cx="2414016" cy="548640"/>
           </a:xfrm>
           <a:prstGeom prst="rect">
             <a:avLst/>
@@ -4244,8 +4244,8 @@
         </p:nvSpPr>
         <p:spPr>
           <a:xfrm>
-            <a:off x="6291072" y="4389120"/>
-            <a:ext cx="2414016" cy="475488"/>
+            <a:off x="6291072" y="4343400"/>
+            <a:ext cx="2414016" cy="438912"/>
           </a:xfrm>
           <a:prstGeom prst="rect">
             <a:avLst/>
@@ -4580,7 +4580,7 @@
                 <a:ea typeface="Calibri" pitchFamily="34" charset="-122"/>
                 <a:cs typeface="Calibri" pitchFamily="34" charset="-120"/>
               </a:rPr>
-              <a:t>Business owners and sole proprietors routinely run commercial operations through personal checking and savings accounts — creating invisible BSA/AML exposure for FIs, Regulation E compliance gaps, and hundreds of thousands of unrecognized SMB relationships that should be in business banking. JH's core FIs collectively hold enormous pools of miscategorized commercial activity they can neither see nor monetize.</a:t>
+              <a:t>Business owners run commercial operations through personal accounts daily — creating BSA/AML blind spots, Reg E gaps, and hiding SMB relationships that belong in business banking generating fee income, treasury products, and SBA loan revenue.</a:t>
             </a:r>
             <a:endParaRPr lang="en-US" sz="1100" dirty="0"/>
           </a:p>
@@ -4725,7 +4725,7 @@
                 <a:ea typeface="Calibri" pitchFamily="34" charset="-122"/>
                 <a:cs typeface="Calibri" pitchFamily="34" charset="-120"/>
               </a:rPr>
-              <a:t>Sole proprietors remain in consumer tiers — no differentiated service or relationship depth</a:t>
+              <a:t>Sole proprietors remain in consumer tiers with no differentiated service or depth</a:t>
             </a:r>
             <a:endParaRPr lang="en-US" sz="1050" dirty="0"/>
           </a:p>
@@ -4860,7 +4860,7 @@
                 <a:ea typeface="Calibri" pitchFamily="34" charset="-122"/>
                 <a:cs typeface="Calibri" pitchFamily="34" charset="-120"/>
               </a:rPr>
-              <a:t>An ML classification model analyzing transaction velocity, ACH vendor/payroll signatures, payee diversity, and cash flow patterns to score personal accounts for commercial usage probability — surfacing them automatically for business banking outreach and revenue conversion.</a:t>
+              <a:t>An ML classification model analyzing transaction velocity, ACH vendor/payroll signatures, payee diversity, and cash flow patterns to score personal accounts for commercial usage probability — surfacing them for business banking outreach and revenue conversion.</a:t>
             </a:r>
             <a:endParaRPr lang="en-US" sz="1100" dirty="0"/>
           </a:p>
@@ -5019,8 +5019,8 @@
         </p:nvSpPr>
         <p:spPr>
           <a:xfrm>
-            <a:off x="365760" y="3739896"/>
-            <a:ext cx="2560320" cy="1207008"/>
+            <a:off x="365760" y="3657600"/>
+            <a:ext cx="2560320" cy="1097280"/>
           </a:xfrm>
           <a:prstGeom prst="rect">
             <a:avLst/>
@@ -5051,8 +5051,8 @@
         </p:nvSpPr>
         <p:spPr>
           <a:xfrm>
-            <a:off x="438912" y="3785616"/>
-            <a:ext cx="2414016" cy="585216"/>
+            <a:off x="438912" y="3703320"/>
+            <a:ext cx="2414016" cy="548640"/>
           </a:xfrm>
           <a:prstGeom prst="rect">
             <a:avLst/>
@@ -5090,8 +5090,8 @@
         </p:nvSpPr>
         <p:spPr>
           <a:xfrm>
-            <a:off x="438912" y="4389120"/>
-            <a:ext cx="2414016" cy="475488"/>
+            <a:off x="438912" y="4261104"/>
+            <a:ext cx="2414016" cy="438912"/>
           </a:xfrm>
           <a:prstGeom prst="rect">
             <a:avLst/>
@@ -5146,8 +5146,8 @@
         </p:nvSpPr>
         <p:spPr>
           <a:xfrm>
-            <a:off x="3291840" y="3739896"/>
-            <a:ext cx="2560320" cy="1207008"/>
+            <a:off x="3291840" y="3657600"/>
+            <a:ext cx="2560320" cy="1097280"/>
           </a:xfrm>
           <a:prstGeom prst="rect">
             <a:avLst/>
@@ -5178,8 +5178,8 @@
         </p:nvSpPr>
         <p:spPr>
           <a:xfrm>
-            <a:off x="3364992" y="3785616"/>
-            <a:ext cx="2414016" cy="585216"/>
+            <a:off x="3364992" y="3703320"/>
+            <a:ext cx="2414016" cy="548640"/>
           </a:xfrm>
           <a:prstGeom prst="rect">
             <a:avLst/>
@@ -5217,8 +5217,8 @@
         </p:nvSpPr>
         <p:spPr>
           <a:xfrm>
-            <a:off x="3364992" y="4389120"/>
-            <a:ext cx="2414016" cy="475488"/>
+            <a:off x="3364992" y="4261104"/>
+            <a:ext cx="2414016" cy="438912"/>
           </a:xfrm>
           <a:prstGeom prst="rect">
             <a:avLst/>
@@ -5273,8 +5273,8 @@
         </p:nvSpPr>
         <p:spPr>
           <a:xfrm>
-            <a:off x="6217920" y="3739896"/>
-            <a:ext cx="2560320" cy="1207008"/>
+            <a:off x="6217920" y="3657600"/>
+            <a:ext cx="2560320" cy="1097280"/>
           </a:xfrm>
           <a:prstGeom prst="rect">
             <a:avLst/>
@@ -5305,8 +5305,8 @@
         </p:nvSpPr>
         <p:spPr>
           <a:xfrm>
-            <a:off x="6291072" y="3785616"/>
-            <a:ext cx="2414016" cy="585216"/>
+            <a:off x="6291072" y="3703320"/>
+            <a:ext cx="2414016" cy="548640"/>
           </a:xfrm>
           <a:prstGeom prst="rect">
             <a:avLst/>
@@ -5344,8 +5344,8 @@
         </p:nvSpPr>
         <p:spPr>
           <a:xfrm>
-            <a:off x="6291072" y="4389120"/>
-            <a:ext cx="2414016" cy="475488"/>
+            <a:off x="6291072" y="4261104"/>
+            <a:ext cx="2414016" cy="438912"/>
           </a:xfrm>
           <a:prstGeom prst="rect">
             <a:avLst/>
@@ -5389,6 +5389,95 @@
               <a:t>delivery</a:t>
             </a:r>
             <a:endParaRPr lang="en-US" sz="1050" dirty="0"/>
+          </a:p>
+        </p:txBody>
+      </p:sp>
+      <p:sp>
+        <p:nvSpPr>
+          <p:cNvPr id="27" name="Shape 24"/>
+          <p:cNvSpPr/>
+          <p:nvPr/>
+        </p:nvSpPr>
+        <p:spPr>
+          <a:xfrm>
+            <a:off x="256032" y="4791456"/>
+            <a:ext cx="8631936" cy="146304"/>
+          </a:xfrm>
+          <a:prstGeom prst="rect">
+            <a:avLst/>
+          </a:prstGeom>
+          <a:solidFill>
+            <a:srgbClr val="E7ECF0"/>
+          </a:solidFill>
+          <a:ln w="12700">
+            <a:solidFill>
+              <a:srgbClr val="E7ECF0"/>
+            </a:solidFill>
+            <a:prstDash val="solid"/>
+          </a:ln>
+        </p:spPr>
+      </p:sp>
+      <p:sp>
+        <p:nvSpPr>
+          <p:cNvPr id="28" name="Shape 25"/>
+          <p:cNvSpPr/>
+          <p:nvPr/>
+        </p:nvSpPr>
+        <p:spPr>
+          <a:xfrm>
+            <a:off x="256032" y="4791456"/>
+            <a:ext cx="54864" cy="146304"/>
+          </a:xfrm>
+          <a:prstGeom prst="rect">
+            <a:avLst/>
+          </a:prstGeom>
+          <a:solidFill>
+            <a:srgbClr val="0A52C4"/>
+          </a:solidFill>
+          <a:ln w="12700">
+            <a:solidFill>
+              <a:srgbClr val="0A52C4"/>
+            </a:solidFill>
+            <a:prstDash val="solid"/>
+          </a:ln>
+        </p:spPr>
+      </p:sp>
+      <p:sp>
+        <p:nvSpPr>
+          <p:cNvPr id="29" name="Text 26"/>
+          <p:cNvSpPr/>
+          <p:nvPr/>
+        </p:nvSpPr>
+        <p:spPr>
+          <a:xfrm>
+            <a:off x="384048" y="4791456"/>
+            <a:ext cx="8467344" cy="146304"/>
+          </a:xfrm>
+          <a:prstGeom prst="rect">
+            <a:avLst/>
+          </a:prstGeom>
+          <a:noFill/>
+          <a:ln/>
+        </p:spPr>
+        <p:txBody>
+          <a:bodyPr wrap="square" lIns="0" tIns="0" rIns="0" bIns="0" rtlCol="0" anchor="ctr"/>
+          <a:lstStyle/>
+          <a:p>
+            <a:pPr indent="0" marL="0">
+              <a:buNone/>
+            </a:pPr>
+            <a:r>
+              <a:rPr lang="en-US" sz="700" i="1" dirty="0">
+                <a:solidFill>
+                  <a:srgbClr val="575A5D"/>
+                </a:solidFill>
+                <a:latin typeface="Calibri" pitchFamily="34" charset="0"/>
+                <a:ea typeface="Calibri" pitchFamily="34" charset="-122"/>
+                <a:cs typeface="Calibri" pitchFamily="34" charset="-120"/>
+              </a:rPr>
+              <a:t>Bank Director — 'The Untapped Market Hiding in Consumer Bank Accounts' (bankdirector.com/article/the-untapped-market-hiding-in-consumer-bank-accounts)  ·  Datos Insights — 'Bank Wealth Managers: Business Owner Client Opportunity' (datos-insights.com)</a:t>
+            </a:r>
+            <a:endParaRPr lang="en-US" sz="700" dirty="0"/>
           </a:p>
         </p:txBody>
       </p:sp>
@@ -5680,7 +5769,7 @@
                 <a:ea typeface="Calibri" pitchFamily="34" charset="-122"/>
                 <a:cs typeface="Calibri" pitchFamily="34" charset="-120"/>
               </a:rPr>
-              <a:t>Most FIs hold deep relationships with individual account holders but have no household coverage model. Wealth is concentrated in single-holder accounts with no joint account holders, no next-generation relationships, and no digital engagement with family members. When wealth transitions — through estate events, life changes, or generational transfer — FIs with no family footprint lose assets to competitors who already have relationships with the heirs.</a:t>
+              <a:t>FIs manage individual accounts but have no household model — so when wealth concentrates in a single-holder account with no family ties at the FI, a life event sends those assets to a competitor who already has the relationship with the heirs.</a:t>
             </a:r>
             <a:endParaRPr lang="en-US" sz="1100" dirty="0"/>
           </a:p>
@@ -5825,7 +5914,7 @@
                 <a:ea typeface="Calibri" pitchFamily="34" charset="-122"/>
                 <a:cs typeface="Calibri" pitchFamily="34" charset="-120"/>
               </a:rPr>
-              <a:t>Next-generation account holders are captured by digital-first competitors before the FI engages</a:t>
+              <a:t>Next-gen account holders are captured by digital-first competitors before FI engages</a:t>
             </a:r>
             <a:endParaRPr lang="en-US" sz="1050" dirty="0"/>
           </a:p>
@@ -6119,8 +6208,8 @@
         </p:nvSpPr>
         <p:spPr>
           <a:xfrm>
-            <a:off x="365760" y="3739896"/>
-            <a:ext cx="2560320" cy="1207008"/>
+            <a:off x="365760" y="3657600"/>
+            <a:ext cx="2560320" cy="1097280"/>
           </a:xfrm>
           <a:prstGeom prst="rect">
             <a:avLst/>
@@ -6151,8 +6240,8 @@
         </p:nvSpPr>
         <p:spPr>
           <a:xfrm>
-            <a:off x="438912" y="3785616"/>
-            <a:ext cx="2414016" cy="585216"/>
+            <a:off x="438912" y="3703320"/>
+            <a:ext cx="2414016" cy="548640"/>
           </a:xfrm>
           <a:prstGeom prst="rect">
             <a:avLst/>
@@ -6190,8 +6279,8 @@
         </p:nvSpPr>
         <p:spPr>
           <a:xfrm>
-            <a:off x="438912" y="4389120"/>
-            <a:ext cx="2414016" cy="475488"/>
+            <a:off x="438912" y="4261104"/>
+            <a:ext cx="2414016" cy="438912"/>
           </a:xfrm>
           <a:prstGeom prst="rect">
             <a:avLst/>
@@ -6246,8 +6335,8 @@
         </p:nvSpPr>
         <p:spPr>
           <a:xfrm>
-            <a:off x="3291840" y="3739896"/>
-            <a:ext cx="2560320" cy="1207008"/>
+            <a:off x="3291840" y="3657600"/>
+            <a:ext cx="2560320" cy="1097280"/>
           </a:xfrm>
           <a:prstGeom prst="rect">
             <a:avLst/>
@@ -6278,8 +6367,8 @@
         </p:nvSpPr>
         <p:spPr>
           <a:xfrm>
-            <a:off x="3364992" y="3785616"/>
-            <a:ext cx="2414016" cy="585216"/>
+            <a:off x="3364992" y="3703320"/>
+            <a:ext cx="2414016" cy="548640"/>
           </a:xfrm>
           <a:prstGeom prst="rect">
             <a:avLst/>
@@ -6317,8 +6406,8 @@
         </p:nvSpPr>
         <p:spPr>
           <a:xfrm>
-            <a:off x="3364992" y="4389120"/>
-            <a:ext cx="2414016" cy="475488"/>
+            <a:off x="3364992" y="4261104"/>
+            <a:ext cx="2414016" cy="438912"/>
           </a:xfrm>
           <a:prstGeom prst="rect">
             <a:avLst/>
@@ -6373,8 +6462,8 @@
         </p:nvSpPr>
         <p:spPr>
           <a:xfrm>
-            <a:off x="6217920" y="3739896"/>
-            <a:ext cx="2560320" cy="1207008"/>
+            <a:off x="6217920" y="3657600"/>
+            <a:ext cx="2560320" cy="1097280"/>
           </a:xfrm>
           <a:prstGeom prst="rect">
             <a:avLst/>
@@ -6405,8 +6494,8 @@
         </p:nvSpPr>
         <p:spPr>
           <a:xfrm>
-            <a:off x="6291072" y="3785616"/>
-            <a:ext cx="2414016" cy="585216"/>
+            <a:off x="6291072" y="3703320"/>
+            <a:ext cx="2414016" cy="548640"/>
           </a:xfrm>
           <a:prstGeom prst="rect">
             <a:avLst/>
@@ -6444,8 +6533,8 @@
         </p:nvSpPr>
         <p:spPr>
           <a:xfrm>
-            <a:off x="6291072" y="4389120"/>
-            <a:ext cx="2414016" cy="475488"/>
+            <a:off x="6291072" y="4261104"/>
+            <a:ext cx="2414016" cy="438912"/>
           </a:xfrm>
           <a:prstGeom prst="rect">
             <a:avLst/>
@@ -6489,6 +6578,95 @@
               <a:t>delivery</a:t>
             </a:r>
             <a:endParaRPr lang="en-US" sz="1050" dirty="0"/>
+          </a:p>
+        </p:txBody>
+      </p:sp>
+      <p:sp>
+        <p:nvSpPr>
+          <p:cNvPr id="27" name="Shape 24"/>
+          <p:cNvSpPr/>
+          <p:nvPr/>
+        </p:nvSpPr>
+        <p:spPr>
+          <a:xfrm>
+            <a:off x="256032" y="4791456"/>
+            <a:ext cx="8631936" cy="146304"/>
+          </a:xfrm>
+          <a:prstGeom prst="rect">
+            <a:avLst/>
+          </a:prstGeom>
+          <a:solidFill>
+            <a:srgbClr val="E7ECF0"/>
+          </a:solidFill>
+          <a:ln w="12700">
+            <a:solidFill>
+              <a:srgbClr val="E7ECF0"/>
+            </a:solidFill>
+            <a:prstDash val="solid"/>
+          </a:ln>
+        </p:spPr>
+      </p:sp>
+      <p:sp>
+        <p:nvSpPr>
+          <p:cNvPr id="28" name="Shape 25"/>
+          <p:cNvSpPr/>
+          <p:nvPr/>
+        </p:nvSpPr>
+        <p:spPr>
+          <a:xfrm>
+            <a:off x="256032" y="4791456"/>
+            <a:ext cx="54864" cy="146304"/>
+          </a:xfrm>
+          <a:prstGeom prst="rect">
+            <a:avLst/>
+          </a:prstGeom>
+          <a:solidFill>
+            <a:srgbClr val="0F3D8A"/>
+          </a:solidFill>
+          <a:ln w="12700">
+            <a:solidFill>
+              <a:srgbClr val="0F3D8A"/>
+            </a:solidFill>
+            <a:prstDash val="solid"/>
+          </a:ln>
+        </p:spPr>
+      </p:sp>
+      <p:sp>
+        <p:nvSpPr>
+          <p:cNvPr id="29" name="Text 26"/>
+          <p:cNvSpPr/>
+          <p:nvPr/>
+        </p:nvSpPr>
+        <p:spPr>
+          <a:xfrm>
+            <a:off x="384048" y="4791456"/>
+            <a:ext cx="8467344" cy="146304"/>
+          </a:xfrm>
+          <a:prstGeom prst="rect">
+            <a:avLst/>
+          </a:prstGeom>
+          <a:noFill/>
+          <a:ln/>
+        </p:spPr>
+        <p:txBody>
+          <a:bodyPr wrap="square" lIns="0" tIns="0" rIns="0" bIns="0" rtlCol="0" anchor="ctr"/>
+          <a:lstStyle/>
+          <a:p>
+            <a:pPr indent="0" marL="0">
+              <a:buNone/>
+            </a:pPr>
+            <a:r>
+              <a:rPr lang="en-US" sz="700" i="1" dirty="0">
+                <a:solidFill>
+                  <a:srgbClr val="575A5D"/>
+                </a:solidFill>
+                <a:latin typeface="Calibri" pitchFamily="34" charset="0"/>
+                <a:ea typeface="Calibri" pitchFamily="34" charset="-122"/>
+                <a:cs typeface="Calibri" pitchFamily="34" charset="-120"/>
+              </a:rPr>
+              <a:t>Cerulli Associates — 'U.S. High-Net-Worth and Ultra-High-Net-Worth Markets 2023'  ·  McKinsey — 'The Great Wealth Transfer' (2023)  ·  LIMRA — Intergenerational Wealth Transfer Research</a:t>
+            </a:r>
+            <a:endParaRPr lang="en-US" sz="700" dirty="0"/>
           </a:p>
         </p:txBody>
       </p:sp>
@@ -31024,7 +31202,7 @@
         <p:spPr>
           <a:xfrm>
             <a:off x="438912" y="3785616"/>
-            <a:ext cx="2414016" cy="585216"/>
+            <a:ext cx="2414016" cy="548640"/>
           </a:xfrm>
           <a:prstGeom prst="rect">
             <a:avLst/>
@@ -31062,8 +31240,8 @@
         </p:nvSpPr>
         <p:spPr>
           <a:xfrm>
-            <a:off x="438912" y="4389120"/>
-            <a:ext cx="2414016" cy="475488"/>
+            <a:off x="438912" y="4343400"/>
+            <a:ext cx="2414016" cy="438912"/>
           </a:xfrm>
           <a:prstGeom prst="rect">
             <a:avLst/>
@@ -31151,7 +31329,7 @@
         <p:spPr>
           <a:xfrm>
             <a:off x="3364992" y="3785616"/>
-            <a:ext cx="2414016" cy="585216"/>
+            <a:ext cx="2414016" cy="548640"/>
           </a:xfrm>
           <a:prstGeom prst="rect">
             <a:avLst/>
@@ -31189,8 +31367,8 @@
         </p:nvSpPr>
         <p:spPr>
           <a:xfrm>
-            <a:off x="3364992" y="4389120"/>
-            <a:ext cx="2414016" cy="475488"/>
+            <a:off x="3364992" y="4343400"/>
+            <a:ext cx="2414016" cy="438912"/>
           </a:xfrm>
           <a:prstGeom prst="rect">
             <a:avLst/>
@@ -31278,7 +31456,7 @@
         <p:spPr>
           <a:xfrm>
             <a:off x="6291072" y="3785616"/>
-            <a:ext cx="2414016" cy="585216"/>
+            <a:ext cx="2414016" cy="548640"/>
           </a:xfrm>
           <a:prstGeom prst="rect">
             <a:avLst/>
@@ -31316,8 +31494,8 @@
         </p:nvSpPr>
         <p:spPr>
           <a:xfrm>
-            <a:off x="6291072" y="4389120"/>
-            <a:ext cx="2414016" cy="475488"/>
+            <a:off x="6291072" y="4343400"/>
+            <a:ext cx="2414016" cy="438912"/>
           </a:xfrm>
           <a:prstGeom prst="rect">
             <a:avLst/>
@@ -32124,7 +32302,7 @@
         <p:spPr>
           <a:xfrm>
             <a:off x="438912" y="3785616"/>
-            <a:ext cx="2414016" cy="585216"/>
+            <a:ext cx="2414016" cy="548640"/>
           </a:xfrm>
           <a:prstGeom prst="rect">
             <a:avLst/>
@@ -32162,8 +32340,8 @@
         </p:nvSpPr>
         <p:spPr>
           <a:xfrm>
-            <a:off x="438912" y="4389120"/>
-            <a:ext cx="2414016" cy="475488"/>
+            <a:off x="438912" y="4343400"/>
+            <a:ext cx="2414016" cy="438912"/>
           </a:xfrm>
           <a:prstGeom prst="rect">
             <a:avLst/>
@@ -32251,7 +32429,7 @@
         <p:spPr>
           <a:xfrm>
             <a:off x="3364992" y="3785616"/>
-            <a:ext cx="2414016" cy="585216"/>
+            <a:ext cx="2414016" cy="548640"/>
           </a:xfrm>
           <a:prstGeom prst="rect">
             <a:avLst/>
@@ -32289,8 +32467,8 @@
         </p:nvSpPr>
         <p:spPr>
           <a:xfrm>
-            <a:off x="3364992" y="4389120"/>
-            <a:ext cx="2414016" cy="475488"/>
+            <a:off x="3364992" y="4343400"/>
+            <a:ext cx="2414016" cy="438912"/>
           </a:xfrm>
           <a:prstGeom prst="rect">
             <a:avLst/>
@@ -32378,7 +32556,7 @@
         <p:spPr>
           <a:xfrm>
             <a:off x="6291072" y="3785616"/>
-            <a:ext cx="2414016" cy="585216"/>
+            <a:ext cx="2414016" cy="548640"/>
           </a:xfrm>
           <a:prstGeom prst="rect">
             <a:avLst/>
@@ -32416,8 +32594,8 @@
         </p:nvSpPr>
         <p:spPr>
           <a:xfrm>
-            <a:off x="6291072" y="4389120"/>
-            <a:ext cx="2414016" cy="475488"/>
+            <a:off x="6291072" y="4343400"/>
+            <a:ext cx="2414016" cy="438912"/>
           </a:xfrm>
           <a:prstGeom prst="rect">
             <a:avLst/>
@@ -33224,7 +33402,7 @@
         <p:spPr>
           <a:xfrm>
             <a:off x="438912" y="3785616"/>
-            <a:ext cx="2414016" cy="585216"/>
+            <a:ext cx="2414016" cy="548640"/>
           </a:xfrm>
           <a:prstGeom prst="rect">
             <a:avLst/>
@@ -33262,8 +33440,8 @@
         </p:nvSpPr>
         <p:spPr>
           <a:xfrm>
-            <a:off x="438912" y="4389120"/>
-            <a:ext cx="2414016" cy="475488"/>
+            <a:off x="438912" y="4343400"/>
+            <a:ext cx="2414016" cy="438912"/>
           </a:xfrm>
           <a:prstGeom prst="rect">
             <a:avLst/>
@@ -33351,7 +33529,7 @@
         <p:spPr>
           <a:xfrm>
             <a:off x="3364992" y="3785616"/>
-            <a:ext cx="2414016" cy="585216"/>
+            <a:ext cx="2414016" cy="548640"/>
           </a:xfrm>
           <a:prstGeom prst="rect">
             <a:avLst/>
@@ -33389,8 +33567,8 @@
         </p:nvSpPr>
         <p:spPr>
           <a:xfrm>
-            <a:off x="3364992" y="4389120"/>
-            <a:ext cx="2414016" cy="475488"/>
+            <a:off x="3364992" y="4343400"/>
+            <a:ext cx="2414016" cy="438912"/>
           </a:xfrm>
           <a:prstGeom prst="rect">
             <a:avLst/>
@@ -33478,7 +33656,7 @@
         <p:spPr>
           <a:xfrm>
             <a:off x="6291072" y="3785616"/>
-            <a:ext cx="2414016" cy="585216"/>
+            <a:ext cx="2414016" cy="548640"/>
           </a:xfrm>
           <a:prstGeom prst="rect">
             <a:avLst/>
@@ -33516,8 +33694,8 @@
         </p:nvSpPr>
         <p:spPr>
           <a:xfrm>
-            <a:off x="6291072" y="4389120"/>
-            <a:ext cx="2414016" cy="475488"/>
+            <a:off x="6291072" y="4343400"/>
+            <a:ext cx="2414016" cy="438912"/>
           </a:xfrm>
           <a:prstGeom prst="rect">
             <a:avLst/>
@@ -34324,7 +34502,7 @@
         <p:spPr>
           <a:xfrm>
             <a:off x="438912" y="3785616"/>
-            <a:ext cx="2414016" cy="585216"/>
+            <a:ext cx="2414016" cy="548640"/>
           </a:xfrm>
           <a:prstGeom prst="rect">
             <a:avLst/>
@@ -34362,8 +34540,8 @@
         </p:nvSpPr>
         <p:spPr>
           <a:xfrm>
-            <a:off x="438912" y="4389120"/>
-            <a:ext cx="2414016" cy="475488"/>
+            <a:off x="438912" y="4343400"/>
+            <a:ext cx="2414016" cy="438912"/>
           </a:xfrm>
           <a:prstGeom prst="rect">
             <a:avLst/>
@@ -34451,7 +34629,7 @@
         <p:spPr>
           <a:xfrm>
             <a:off x="3364992" y="3785616"/>
-            <a:ext cx="2414016" cy="585216"/>
+            <a:ext cx="2414016" cy="548640"/>
           </a:xfrm>
           <a:prstGeom prst="rect">
             <a:avLst/>
@@ -34489,8 +34667,8 @@
         </p:nvSpPr>
         <p:spPr>
           <a:xfrm>
-            <a:off x="3364992" y="4389120"/>
-            <a:ext cx="2414016" cy="475488"/>
+            <a:off x="3364992" y="4343400"/>
+            <a:ext cx="2414016" cy="438912"/>
           </a:xfrm>
           <a:prstGeom prst="rect">
             <a:avLst/>
@@ -34578,7 +34756,7 @@
         <p:spPr>
           <a:xfrm>
             <a:off x="6291072" y="3785616"/>
-            <a:ext cx="2414016" cy="585216"/>
+            <a:ext cx="2414016" cy="548640"/>
           </a:xfrm>
           <a:prstGeom prst="rect">
             <a:avLst/>
@@ -34616,8 +34794,8 @@
         </p:nvSpPr>
         <p:spPr>
           <a:xfrm>
-            <a:off x="6291072" y="4389120"/>
-            <a:ext cx="2414016" cy="475488"/>
+            <a:off x="6291072" y="4343400"/>
+            <a:ext cx="2414016" cy="438912"/>
           </a:xfrm>
           <a:prstGeom prst="rect">
             <a:avLst/>

</xml_diff>

<commit_message>
Add Application Delivery Roadmap Gantt slide (build & launch timeline)
- New slide showing all 8 apps on same Q3 FY26–Q2 FY28 timeline spine
  as the Data Source Ingestion Gantt
- Two-tone bars: lighter region = build/validate, solid cap = launch window
- Phase bands, quarter headers, TODAY marker, and build/launch legend
- Staggering shows Phase 1 (Churn Mediation, Call Report AI), Phase 2
  (Anomaly, Zelle Memo, Personal-as-Commercial, Gen. Wealth Deflection),
  and Phase 3 (Account Opening LTV, FI Decision Studio) clearly

Co-Authored-By: Claude Sonnet 4.6 <noreply@anthropic.com>
</commit_message>
<xml_diff>
--- a/JH_DS_Strategy_JHBI.pptx
+++ b/JH_DS_Strategy_JHBI.pptx
@@ -28,9 +28,10 @@
     <p:sldId id="276" r:id="rId22"/>
     <p:sldId id="277" r:id="rId23"/>
     <p:sldId id="278" r:id="rId24"/>
+    <p:sldId id="279" r:id="rId25"/>
   </p:sldIdLst>
   <p:notesMasterIdLst>
-    <p:notesMasterId r:id="rId25"/>
+    <p:notesMasterId r:id="rId26"/>
   </p:notesMasterIdLst>
   <p:sldSz cx="9144000" cy="5143500"/>
   <p:notesSz cx="5143500" cy="9144000"/>
@@ -1868,6 +1869,94 @@
             <a:fld id="{F7021451-1387-4CA6-816F-3879F97B5CBC}" type="slidenum">
               <a:rPr lang="en-US"/>
               <a:t>23</a:t>
+            </a:fld>
+            <a:endParaRPr lang="en-US"/>
+          </a:p>
+        </p:txBody>
+      </p:sp>
+    </p:spTree>
+    <p:extLst>
+      <p:ext uri="{BB962C8B-B14F-4D97-AF65-F5344CB8AC3E}">
+        <p14:creationId xmlns:p14="http://schemas.microsoft.com/office/powerpoint/2010/main" val="1024086991"/>
+      </p:ext>
+    </p:extLst>
+  </p:cSld>
+  <p:clrMapOvr>
+    <a:masterClrMapping/>
+  </p:clrMapOvr>
+</p:notes>
+</file>
+
+<file path=ppt/notesSlides/notesSlide24.xml><?xml version="1.0" encoding="utf-8"?>
+<p:notes xmlns:a="http://schemas.openxmlformats.org/drawingml/2006/main" xmlns:r="http://schemas.openxmlformats.org/officeDocument/2006/relationships" xmlns:p="http://schemas.openxmlformats.org/presentationml/2006/main">
+  <p:cSld>
+    <p:spTree>
+      <p:nvGrpSpPr>
+        <p:cNvPr id="1" name=""/>
+        <p:cNvGrpSpPr/>
+        <p:nvPr/>
+      </p:nvGrpSpPr>
+      <p:grpSpPr>
+        <a:xfrm>
+          <a:off x="0" y="0"/>
+          <a:ext cx="0" cy="0"/>
+          <a:chOff x="0" y="0"/>
+          <a:chExt cx="0" cy="0"/>
+        </a:xfrm>
+      </p:grpSpPr>
+      <p:sp>
+        <p:nvSpPr>
+          <p:cNvPr id="2" name="Slide Image Placeholder 1"/>
+          <p:cNvSpPr>
+            <a:spLocks noGrp="1" noRot="1" noChangeAspect="1"/>
+          </p:cNvSpPr>
+          <p:nvPr>
+            <p:ph type="sldImg"/>
+          </p:nvPr>
+        </p:nvSpPr>
+        <p:spPr/>
+      </p:sp>
+      <p:sp>
+        <p:nvSpPr>
+          <p:cNvPr id="3" name="Notes Placeholder 2"/>
+          <p:cNvSpPr>
+            <a:spLocks noGrp="1"/>
+          </p:cNvSpPr>
+          <p:nvPr>
+            <p:ph type="body" idx="1"/>
+          </p:nvPr>
+        </p:nvSpPr>
+        <p:spPr/>
+        <p:txBody>
+          <a:bodyPr/>
+          <a:lstStyle/>
+          <a:p>
+            <a:r>
+              <a:rPr lang="en-US" dirty="0"/>
+              <a:t/>
+            </a:r>
+            <a:endParaRPr lang="en-US" dirty="0"/>
+          </a:p>
+        </p:txBody>
+      </p:sp>
+      <p:sp>
+        <p:nvSpPr>
+          <p:cNvPr id="4" name="Slide Number Placeholder 3"/>
+          <p:cNvSpPr>
+            <a:spLocks noGrp="1"/>
+          </p:cNvSpPr>
+          <p:nvPr>
+            <p:ph type="sldNum" sz="quarter" idx="10"/>
+          </p:nvPr>
+        </p:nvSpPr>
+        <p:spPr/>
+        <p:txBody>
+          <a:bodyPr/>
+          <a:lstStyle/>
+          <a:p>
+            <a:fld id="{F7021451-1387-4CA6-816F-3879F97B5CBC}" type="slidenum">
+              <a:rPr lang="en-US"/>
+              <a:t>24</a:t>
             </a:fld>
             <a:endParaRPr lang="en-US"/>
           </a:p>
@@ -24120,6 +24209,2932 @@
     <p:bg>
       <p:bgPr>
         <a:solidFill>
+          <a:srgbClr val="FEFDF8"/>
+        </a:solidFill>
+      </p:bgPr>
+    </p:bg>
+    <p:spTree>
+      <p:nvGrpSpPr>
+        <p:cNvPr id="1" name=""/>
+        <p:cNvGrpSpPr/>
+        <p:nvPr/>
+      </p:nvGrpSpPr>
+      <p:grpSpPr>
+        <a:xfrm>
+          <a:off x="0" y="0"/>
+          <a:ext cx="0" cy="0"/>
+          <a:chOff x="0" y="0"/>
+          <a:chExt cx="0" cy="0"/>
+        </a:xfrm>
+      </p:grpSpPr>
+      <p:sp>
+        <p:nvSpPr>
+          <p:cNvPr id="2" name="Shape 0"/>
+          <p:cNvSpPr/>
+          <p:nvPr/>
+        </p:nvSpPr>
+        <p:spPr>
+          <a:xfrm>
+            <a:off x="0" y="0"/>
+            <a:ext cx="9144000" cy="658368"/>
+          </a:xfrm>
+          <a:prstGeom prst="rect">
+            <a:avLst/>
+          </a:prstGeom>
+          <a:solidFill>
+            <a:srgbClr val="06185F"/>
+          </a:solidFill>
+          <a:ln w="12700">
+            <a:solidFill>
+              <a:srgbClr val="06185F"/>
+            </a:solidFill>
+            <a:prstDash val="solid"/>
+          </a:ln>
+        </p:spPr>
+      </p:sp>
+      <p:sp>
+        <p:nvSpPr>
+          <p:cNvPr id="3" name="Text 1"/>
+          <p:cNvSpPr/>
+          <p:nvPr/>
+        </p:nvSpPr>
+        <p:spPr>
+          <a:xfrm>
+            <a:off x="365760" y="73152"/>
+            <a:ext cx="8412480" cy="512064"/>
+          </a:xfrm>
+          <a:prstGeom prst="rect">
+            <a:avLst/>
+          </a:prstGeom>
+          <a:noFill/>
+          <a:ln/>
+        </p:spPr>
+        <p:txBody>
+          <a:bodyPr wrap="square" lIns="0" tIns="0" rIns="0" bIns="0" rtlCol="0" anchor="ctr"/>
+          <a:lstStyle/>
+          <a:p>
+            <a:pPr indent="0" marL="0">
+              <a:buNone/>
+            </a:pPr>
+            <a:r>
+              <a:rPr lang="en-US" sz="2000" b="1" dirty="0">
+                <a:solidFill>
+                  <a:srgbClr val="FFFFFF"/>
+                </a:solidFill>
+                <a:latin typeface="Calibri" pitchFamily="34" charset="0"/>
+                <a:ea typeface="Calibri" pitchFamily="34" charset="-122"/>
+                <a:cs typeface="Calibri" pitchFamily="34" charset="-120"/>
+              </a:rPr>
+              <a:t>Application Delivery Roadmap — Build &amp; Launch Timeline</a:t>
+            </a:r>
+            <a:endParaRPr lang="en-US" sz="2000" dirty="0"/>
+          </a:p>
+        </p:txBody>
+      </p:sp>
+      <p:sp>
+        <p:nvSpPr>
+          <p:cNvPr id="4" name="Text 2"/>
+          <p:cNvSpPr/>
+          <p:nvPr/>
+        </p:nvSpPr>
+        <p:spPr>
+          <a:xfrm>
+            <a:off x="365760" y="713232"/>
+            <a:ext cx="8412480" cy="256032"/>
+          </a:xfrm>
+          <a:prstGeom prst="rect">
+            <a:avLst/>
+          </a:prstGeom>
+          <a:noFill/>
+          <a:ln/>
+        </p:spPr>
+        <p:txBody>
+          <a:bodyPr wrap="square" lIns="0" tIns="0" rIns="0" bIns="0" rtlCol="0" anchor="ctr"/>
+          <a:lstStyle/>
+          <a:p>
+            <a:pPr indent="0" marL="0">
+              <a:buNone/>
+            </a:pPr>
+            <a:r>
+              <a:rPr lang="en-US" sz="1000" dirty="0">
+                <a:solidFill>
+                  <a:srgbClr val="575A5D"/>
+                </a:solidFill>
+                <a:latin typeface="Calibri" pitchFamily="34" charset="0"/>
+                <a:ea typeface="Calibri" pitchFamily="34" charset="-122"/>
+                <a:cs typeface="Calibri" pitchFamily="34" charset="-120"/>
+              </a:rPr>
+              <a:t>Eight applications sequenced across three phases. Each bar spans the active build and validation window; wider bars reflect higher integration complexity.</a:t>
+            </a:r>
+            <a:endParaRPr lang="en-US" sz="1000" dirty="0"/>
+          </a:p>
+        </p:txBody>
+      </p:sp>
+      <p:sp>
+        <p:nvSpPr>
+          <p:cNvPr id="5" name="Shape 3"/>
+          <p:cNvSpPr/>
+          <p:nvPr/>
+        </p:nvSpPr>
+        <p:spPr>
+          <a:xfrm>
+            <a:off x="2505456" y="1133856"/>
+            <a:ext cx="1568196" cy="237744"/>
+          </a:xfrm>
+          <a:prstGeom prst="rect">
+            <a:avLst/>
+          </a:prstGeom>
+          <a:solidFill>
+            <a:srgbClr val="085CE5"/>
+          </a:solidFill>
+          <a:ln w="12700">
+            <a:solidFill>
+              <a:srgbClr val="085CE5"/>
+            </a:solidFill>
+            <a:prstDash val="solid"/>
+          </a:ln>
+        </p:spPr>
+      </p:sp>
+      <p:sp>
+        <p:nvSpPr>
+          <p:cNvPr id="6" name="Text 4"/>
+          <p:cNvSpPr/>
+          <p:nvPr/>
+        </p:nvSpPr>
+        <p:spPr>
+          <a:xfrm>
+            <a:off x="2551176" y="1133856"/>
+            <a:ext cx="1476756" cy="237744"/>
+          </a:xfrm>
+          <a:prstGeom prst="rect">
+            <a:avLst/>
+          </a:prstGeom>
+          <a:noFill/>
+          <a:ln/>
+        </p:spPr>
+        <p:txBody>
+          <a:bodyPr wrap="square" lIns="0" tIns="0" rIns="0" bIns="0" rtlCol="0" anchor="ctr"/>
+          <a:lstStyle/>
+          <a:p>
+            <a:pPr indent="0" marL="0">
+              <a:buNone/>
+            </a:pPr>
+            <a:r>
+              <a:rPr lang="en-US" sz="750" b="1" dirty="0">
+                <a:solidFill>
+                  <a:srgbClr val="FFFFFF"/>
+                </a:solidFill>
+                <a:latin typeface="Calibri" pitchFamily="34" charset="0"/>
+                <a:ea typeface="Calibri" pitchFamily="34" charset="-122"/>
+                <a:cs typeface="Calibri" pitchFamily="34" charset="-120"/>
+              </a:rPr>
+              <a:t>PHASE 1 — Foundation  (Q3–Q4 FY26)</a:t>
+            </a:r>
+            <a:endParaRPr lang="en-US" sz="750" dirty="0"/>
+          </a:p>
+        </p:txBody>
+      </p:sp>
+      <p:sp>
+        <p:nvSpPr>
+          <p:cNvPr id="7" name="Shape 5"/>
+          <p:cNvSpPr/>
+          <p:nvPr/>
+        </p:nvSpPr>
+        <p:spPr>
+          <a:xfrm>
+            <a:off x="4073652" y="1133856"/>
+            <a:ext cx="1568196" cy="237744"/>
+          </a:xfrm>
+          <a:prstGeom prst="rect">
+            <a:avLst/>
+          </a:prstGeom>
+          <a:solidFill>
+            <a:srgbClr val="073FA8"/>
+          </a:solidFill>
+          <a:ln w="12700">
+            <a:solidFill>
+              <a:srgbClr val="073FA8"/>
+            </a:solidFill>
+            <a:prstDash val="solid"/>
+          </a:ln>
+        </p:spPr>
+      </p:sp>
+      <p:sp>
+        <p:nvSpPr>
+          <p:cNvPr id="8" name="Text 6"/>
+          <p:cNvSpPr/>
+          <p:nvPr/>
+        </p:nvSpPr>
+        <p:spPr>
+          <a:xfrm>
+            <a:off x="4119372" y="1133856"/>
+            <a:ext cx="1476756" cy="237744"/>
+          </a:xfrm>
+          <a:prstGeom prst="rect">
+            <a:avLst/>
+          </a:prstGeom>
+          <a:noFill/>
+          <a:ln/>
+        </p:spPr>
+        <p:txBody>
+          <a:bodyPr wrap="square" lIns="0" tIns="0" rIns="0" bIns="0" rtlCol="0" anchor="ctr"/>
+          <a:lstStyle/>
+          <a:p>
+            <a:pPr indent="0" marL="0">
+              <a:buNone/>
+            </a:pPr>
+            <a:r>
+              <a:rPr lang="en-US" sz="750" b="1" dirty="0">
+                <a:solidFill>
+                  <a:srgbClr val="FFFFFF"/>
+                </a:solidFill>
+                <a:latin typeface="Calibri" pitchFamily="34" charset="0"/>
+                <a:ea typeface="Calibri" pitchFamily="34" charset="-122"/>
+                <a:cs typeface="Calibri" pitchFamily="34" charset="-120"/>
+              </a:rPr>
+              <a:t>PHASE 2 — Core Applications  (Q1–Q2 FY27)</a:t>
+            </a:r>
+            <a:endParaRPr lang="en-US" sz="750" dirty="0"/>
+          </a:p>
+        </p:txBody>
+      </p:sp>
+      <p:sp>
+        <p:nvSpPr>
+          <p:cNvPr id="9" name="Shape 7"/>
+          <p:cNvSpPr/>
+          <p:nvPr/>
+        </p:nvSpPr>
+        <p:spPr>
+          <a:xfrm>
+            <a:off x="5641848" y="1133856"/>
+            <a:ext cx="3136392" cy="237744"/>
+          </a:xfrm>
+          <a:prstGeom prst="rect">
+            <a:avLst/>
+          </a:prstGeom>
+          <a:solidFill>
+            <a:srgbClr val="575A5D"/>
+          </a:solidFill>
+          <a:ln w="12700">
+            <a:solidFill>
+              <a:srgbClr val="575A5D"/>
+            </a:solidFill>
+            <a:prstDash val="solid"/>
+          </a:ln>
+        </p:spPr>
+      </p:sp>
+      <p:sp>
+        <p:nvSpPr>
+          <p:cNvPr id="10" name="Text 8"/>
+          <p:cNvSpPr/>
+          <p:nvPr/>
+        </p:nvSpPr>
+        <p:spPr>
+          <a:xfrm>
+            <a:off x="5687568" y="1133856"/>
+            <a:ext cx="3044952" cy="237744"/>
+          </a:xfrm>
+          <a:prstGeom prst="rect">
+            <a:avLst/>
+          </a:prstGeom>
+          <a:noFill/>
+          <a:ln/>
+        </p:spPr>
+        <p:txBody>
+          <a:bodyPr wrap="square" lIns="0" tIns="0" rIns="0" bIns="0" rtlCol="0" anchor="ctr"/>
+          <a:lstStyle/>
+          <a:p>
+            <a:pPr indent="0" marL="0">
+              <a:buNone/>
+            </a:pPr>
+            <a:r>
+              <a:rPr lang="en-US" sz="750" b="1" dirty="0">
+                <a:solidFill>
+                  <a:srgbClr val="FFFFFF"/>
+                </a:solidFill>
+                <a:latin typeface="Calibri" pitchFamily="34" charset="0"/>
+                <a:ea typeface="Calibri" pitchFamily="34" charset="-122"/>
+                <a:cs typeface="Calibri" pitchFamily="34" charset="-120"/>
+              </a:rPr>
+              <a:t>PHASE 3 — Scale &amp; Expand  (Q3 FY27+)</a:t>
+            </a:r>
+            <a:endParaRPr lang="en-US" sz="750" dirty="0"/>
+          </a:p>
+        </p:txBody>
+      </p:sp>
+      <p:sp>
+        <p:nvSpPr>
+          <p:cNvPr id="11" name="Shape 9"/>
+          <p:cNvSpPr/>
+          <p:nvPr/>
+        </p:nvSpPr>
+        <p:spPr>
+          <a:xfrm>
+            <a:off x="2505456" y="1389888"/>
+            <a:ext cx="6272784" cy="256032"/>
+          </a:xfrm>
+          <a:prstGeom prst="rect">
+            <a:avLst/>
+          </a:prstGeom>
+          <a:solidFill>
+            <a:srgbClr val="E7ECF0"/>
+          </a:solidFill>
+          <a:ln w="12700">
+            <a:solidFill>
+              <a:srgbClr val="E7ECF0"/>
+            </a:solidFill>
+            <a:prstDash val="solid"/>
+          </a:ln>
+        </p:spPr>
+      </p:sp>
+      <p:sp>
+        <p:nvSpPr>
+          <p:cNvPr id="12" name="Shape 10"/>
+          <p:cNvSpPr/>
+          <p:nvPr/>
+        </p:nvSpPr>
+        <p:spPr>
+          <a:xfrm>
+            <a:off x="2505456" y="1664208"/>
+            <a:ext cx="784098" cy="3218688"/>
+          </a:xfrm>
+          <a:prstGeom prst="rect">
+            <a:avLst/>
+          </a:prstGeom>
+          <a:solidFill>
+            <a:srgbClr val="F4F6F8"/>
+          </a:solidFill>
+          <a:ln w="12700">
+            <a:solidFill>
+              <a:srgbClr val="F4F6F8"/>
+            </a:solidFill>
+            <a:prstDash val="solid"/>
+          </a:ln>
+        </p:spPr>
+      </p:sp>
+      <p:sp>
+        <p:nvSpPr>
+          <p:cNvPr id="13" name="Text 11"/>
+          <p:cNvSpPr/>
+          <p:nvPr/>
+        </p:nvSpPr>
+        <p:spPr>
+          <a:xfrm>
+            <a:off x="2505456" y="1389888"/>
+            <a:ext cx="784098" cy="237744"/>
+          </a:xfrm>
+          <a:prstGeom prst="rect">
+            <a:avLst/>
+          </a:prstGeom>
+          <a:noFill/>
+          <a:ln/>
+        </p:spPr>
+        <p:txBody>
+          <a:bodyPr wrap="square" lIns="0" tIns="0" rIns="0" bIns="0" rtlCol="0" anchor="ctr"/>
+          <a:lstStyle/>
+          <a:p>
+            <a:pPr algn="ctr" indent="0" marL="0">
+              <a:buNone/>
+            </a:pPr>
+            <a:r>
+              <a:rPr lang="en-US" sz="750" b="1" dirty="0">
+                <a:solidFill>
+                  <a:srgbClr val="575A5D"/>
+                </a:solidFill>
+                <a:latin typeface="Calibri" pitchFamily="34" charset="0"/>
+                <a:ea typeface="Calibri" pitchFamily="34" charset="-122"/>
+                <a:cs typeface="Calibri" pitchFamily="34" charset="-120"/>
+              </a:rPr>
+              <a:t>Q3 FY26</a:t>
+            </a:r>
+            <a:endParaRPr lang="en-US" sz="750" dirty="0"/>
+          </a:p>
+        </p:txBody>
+      </p:sp>
+      <p:sp>
+        <p:nvSpPr>
+          <p:cNvPr id="14" name="Shape 12"/>
+          <p:cNvSpPr/>
+          <p:nvPr/>
+        </p:nvSpPr>
+        <p:spPr>
+          <a:xfrm>
+            <a:off x="2505456" y="1133856"/>
+            <a:ext cx="13716" cy="3749040"/>
+          </a:xfrm>
+          <a:prstGeom prst="rect">
+            <a:avLst/>
+          </a:prstGeom>
+          <a:solidFill>
+            <a:srgbClr val="B6BBC0"/>
+          </a:solidFill>
+          <a:ln w="12700">
+            <a:solidFill>
+              <a:srgbClr val="B6BBC0"/>
+            </a:solidFill>
+            <a:prstDash val="solid"/>
+          </a:ln>
+        </p:spPr>
+      </p:sp>
+      <p:sp>
+        <p:nvSpPr>
+          <p:cNvPr id="15" name="Text 13"/>
+          <p:cNvSpPr/>
+          <p:nvPr/>
+        </p:nvSpPr>
+        <p:spPr>
+          <a:xfrm>
+            <a:off x="3289554" y="1389888"/>
+            <a:ext cx="784098" cy="237744"/>
+          </a:xfrm>
+          <a:prstGeom prst="rect">
+            <a:avLst/>
+          </a:prstGeom>
+          <a:noFill/>
+          <a:ln/>
+        </p:spPr>
+        <p:txBody>
+          <a:bodyPr wrap="square" lIns="0" tIns="0" rIns="0" bIns="0" rtlCol="0" anchor="ctr"/>
+          <a:lstStyle/>
+          <a:p>
+            <a:pPr algn="ctr" indent="0" marL="0">
+              <a:buNone/>
+            </a:pPr>
+            <a:r>
+              <a:rPr lang="en-US" sz="750" b="1" dirty="0">
+                <a:solidFill>
+                  <a:srgbClr val="575A5D"/>
+                </a:solidFill>
+                <a:latin typeface="Calibri" pitchFamily="34" charset="0"/>
+                <a:ea typeface="Calibri" pitchFamily="34" charset="-122"/>
+                <a:cs typeface="Calibri" pitchFamily="34" charset="-120"/>
+              </a:rPr>
+              <a:t>Q4 FY26</a:t>
+            </a:r>
+            <a:endParaRPr lang="en-US" sz="750" dirty="0"/>
+          </a:p>
+        </p:txBody>
+      </p:sp>
+      <p:sp>
+        <p:nvSpPr>
+          <p:cNvPr id="16" name="Shape 14"/>
+          <p:cNvSpPr/>
+          <p:nvPr/>
+        </p:nvSpPr>
+        <p:spPr>
+          <a:xfrm>
+            <a:off x="3289554" y="1133856"/>
+            <a:ext cx="13716" cy="3749040"/>
+          </a:xfrm>
+          <a:prstGeom prst="rect">
+            <a:avLst/>
+          </a:prstGeom>
+          <a:solidFill>
+            <a:srgbClr val="B6BBC0"/>
+          </a:solidFill>
+          <a:ln w="12700">
+            <a:solidFill>
+              <a:srgbClr val="B6BBC0"/>
+            </a:solidFill>
+            <a:prstDash val="solid"/>
+          </a:ln>
+        </p:spPr>
+      </p:sp>
+      <p:sp>
+        <p:nvSpPr>
+          <p:cNvPr id="17" name="Shape 15"/>
+          <p:cNvSpPr/>
+          <p:nvPr/>
+        </p:nvSpPr>
+        <p:spPr>
+          <a:xfrm>
+            <a:off x="4073652" y="1664208"/>
+            <a:ext cx="784098" cy="3218688"/>
+          </a:xfrm>
+          <a:prstGeom prst="rect">
+            <a:avLst/>
+          </a:prstGeom>
+          <a:solidFill>
+            <a:srgbClr val="F4F6F8"/>
+          </a:solidFill>
+          <a:ln w="12700">
+            <a:solidFill>
+              <a:srgbClr val="F4F6F8"/>
+            </a:solidFill>
+            <a:prstDash val="solid"/>
+          </a:ln>
+        </p:spPr>
+      </p:sp>
+      <p:sp>
+        <p:nvSpPr>
+          <p:cNvPr id="18" name="Text 16"/>
+          <p:cNvSpPr/>
+          <p:nvPr/>
+        </p:nvSpPr>
+        <p:spPr>
+          <a:xfrm>
+            <a:off x="4073652" y="1389888"/>
+            <a:ext cx="784098" cy="237744"/>
+          </a:xfrm>
+          <a:prstGeom prst="rect">
+            <a:avLst/>
+          </a:prstGeom>
+          <a:noFill/>
+          <a:ln/>
+        </p:spPr>
+        <p:txBody>
+          <a:bodyPr wrap="square" lIns="0" tIns="0" rIns="0" bIns="0" rtlCol="0" anchor="ctr"/>
+          <a:lstStyle/>
+          <a:p>
+            <a:pPr algn="ctr" indent="0" marL="0">
+              <a:buNone/>
+            </a:pPr>
+            <a:r>
+              <a:rPr lang="en-US" sz="750" b="1" dirty="0">
+                <a:solidFill>
+                  <a:srgbClr val="575A5D"/>
+                </a:solidFill>
+                <a:latin typeface="Calibri" pitchFamily="34" charset="0"/>
+                <a:ea typeface="Calibri" pitchFamily="34" charset="-122"/>
+                <a:cs typeface="Calibri" pitchFamily="34" charset="-120"/>
+              </a:rPr>
+              <a:t>Q1 FY27</a:t>
+            </a:r>
+            <a:endParaRPr lang="en-US" sz="750" dirty="0"/>
+          </a:p>
+        </p:txBody>
+      </p:sp>
+      <p:sp>
+        <p:nvSpPr>
+          <p:cNvPr id="19" name="Shape 17"/>
+          <p:cNvSpPr/>
+          <p:nvPr/>
+        </p:nvSpPr>
+        <p:spPr>
+          <a:xfrm>
+            <a:off x="4073652" y="1133856"/>
+            <a:ext cx="13716" cy="3749040"/>
+          </a:xfrm>
+          <a:prstGeom prst="rect">
+            <a:avLst/>
+          </a:prstGeom>
+          <a:solidFill>
+            <a:srgbClr val="B6BBC0"/>
+          </a:solidFill>
+          <a:ln w="12700">
+            <a:solidFill>
+              <a:srgbClr val="B6BBC0"/>
+            </a:solidFill>
+            <a:prstDash val="solid"/>
+          </a:ln>
+        </p:spPr>
+      </p:sp>
+      <p:sp>
+        <p:nvSpPr>
+          <p:cNvPr id="20" name="Text 18"/>
+          <p:cNvSpPr/>
+          <p:nvPr/>
+        </p:nvSpPr>
+        <p:spPr>
+          <a:xfrm>
+            <a:off x="4857750" y="1389888"/>
+            <a:ext cx="784098" cy="237744"/>
+          </a:xfrm>
+          <a:prstGeom prst="rect">
+            <a:avLst/>
+          </a:prstGeom>
+          <a:noFill/>
+          <a:ln/>
+        </p:spPr>
+        <p:txBody>
+          <a:bodyPr wrap="square" lIns="0" tIns="0" rIns="0" bIns="0" rtlCol="0" anchor="ctr"/>
+          <a:lstStyle/>
+          <a:p>
+            <a:pPr algn="ctr" indent="0" marL="0">
+              <a:buNone/>
+            </a:pPr>
+            <a:r>
+              <a:rPr lang="en-US" sz="750" b="1" dirty="0">
+                <a:solidFill>
+                  <a:srgbClr val="575A5D"/>
+                </a:solidFill>
+                <a:latin typeface="Calibri" pitchFamily="34" charset="0"/>
+                <a:ea typeface="Calibri" pitchFamily="34" charset="-122"/>
+                <a:cs typeface="Calibri" pitchFamily="34" charset="-120"/>
+              </a:rPr>
+              <a:t>Q2 FY27</a:t>
+            </a:r>
+            <a:endParaRPr lang="en-US" sz="750" dirty="0"/>
+          </a:p>
+        </p:txBody>
+      </p:sp>
+      <p:sp>
+        <p:nvSpPr>
+          <p:cNvPr id="21" name="Shape 19"/>
+          <p:cNvSpPr/>
+          <p:nvPr/>
+        </p:nvSpPr>
+        <p:spPr>
+          <a:xfrm>
+            <a:off x="4857750" y="1133856"/>
+            <a:ext cx="13716" cy="3749040"/>
+          </a:xfrm>
+          <a:prstGeom prst="rect">
+            <a:avLst/>
+          </a:prstGeom>
+          <a:solidFill>
+            <a:srgbClr val="B6BBC0"/>
+          </a:solidFill>
+          <a:ln w="12700">
+            <a:solidFill>
+              <a:srgbClr val="B6BBC0"/>
+            </a:solidFill>
+            <a:prstDash val="solid"/>
+          </a:ln>
+        </p:spPr>
+      </p:sp>
+      <p:sp>
+        <p:nvSpPr>
+          <p:cNvPr id="22" name="Shape 20"/>
+          <p:cNvSpPr/>
+          <p:nvPr/>
+        </p:nvSpPr>
+        <p:spPr>
+          <a:xfrm>
+            <a:off x="5641848" y="1664208"/>
+            <a:ext cx="784098" cy="3218688"/>
+          </a:xfrm>
+          <a:prstGeom prst="rect">
+            <a:avLst/>
+          </a:prstGeom>
+          <a:solidFill>
+            <a:srgbClr val="F4F6F8"/>
+          </a:solidFill>
+          <a:ln w="12700">
+            <a:solidFill>
+              <a:srgbClr val="F4F6F8"/>
+            </a:solidFill>
+            <a:prstDash val="solid"/>
+          </a:ln>
+        </p:spPr>
+      </p:sp>
+      <p:sp>
+        <p:nvSpPr>
+          <p:cNvPr id="23" name="Text 21"/>
+          <p:cNvSpPr/>
+          <p:nvPr/>
+        </p:nvSpPr>
+        <p:spPr>
+          <a:xfrm>
+            <a:off x="5641848" y="1389888"/>
+            <a:ext cx="784098" cy="237744"/>
+          </a:xfrm>
+          <a:prstGeom prst="rect">
+            <a:avLst/>
+          </a:prstGeom>
+          <a:noFill/>
+          <a:ln/>
+        </p:spPr>
+        <p:txBody>
+          <a:bodyPr wrap="square" lIns="0" tIns="0" rIns="0" bIns="0" rtlCol="0" anchor="ctr"/>
+          <a:lstStyle/>
+          <a:p>
+            <a:pPr algn="ctr" indent="0" marL="0">
+              <a:buNone/>
+            </a:pPr>
+            <a:r>
+              <a:rPr lang="en-US" sz="750" b="1" dirty="0">
+                <a:solidFill>
+                  <a:srgbClr val="575A5D"/>
+                </a:solidFill>
+                <a:latin typeface="Calibri" pitchFamily="34" charset="0"/>
+                <a:ea typeface="Calibri" pitchFamily="34" charset="-122"/>
+                <a:cs typeface="Calibri" pitchFamily="34" charset="-120"/>
+              </a:rPr>
+              <a:t>Q3 FY27</a:t>
+            </a:r>
+            <a:endParaRPr lang="en-US" sz="750" dirty="0"/>
+          </a:p>
+        </p:txBody>
+      </p:sp>
+      <p:sp>
+        <p:nvSpPr>
+          <p:cNvPr id="24" name="Shape 22"/>
+          <p:cNvSpPr/>
+          <p:nvPr/>
+        </p:nvSpPr>
+        <p:spPr>
+          <a:xfrm>
+            <a:off x="5641848" y="1133856"/>
+            <a:ext cx="13716" cy="3749040"/>
+          </a:xfrm>
+          <a:prstGeom prst="rect">
+            <a:avLst/>
+          </a:prstGeom>
+          <a:solidFill>
+            <a:srgbClr val="B6BBC0"/>
+          </a:solidFill>
+          <a:ln w="12700">
+            <a:solidFill>
+              <a:srgbClr val="B6BBC0"/>
+            </a:solidFill>
+            <a:prstDash val="solid"/>
+          </a:ln>
+        </p:spPr>
+      </p:sp>
+      <p:sp>
+        <p:nvSpPr>
+          <p:cNvPr id="25" name="Text 23"/>
+          <p:cNvSpPr/>
+          <p:nvPr/>
+        </p:nvSpPr>
+        <p:spPr>
+          <a:xfrm>
+            <a:off x="6425946" y="1389888"/>
+            <a:ext cx="784098" cy="237744"/>
+          </a:xfrm>
+          <a:prstGeom prst="rect">
+            <a:avLst/>
+          </a:prstGeom>
+          <a:noFill/>
+          <a:ln/>
+        </p:spPr>
+        <p:txBody>
+          <a:bodyPr wrap="square" lIns="0" tIns="0" rIns="0" bIns="0" rtlCol="0" anchor="ctr"/>
+          <a:lstStyle/>
+          <a:p>
+            <a:pPr algn="ctr" indent="0" marL="0">
+              <a:buNone/>
+            </a:pPr>
+            <a:r>
+              <a:rPr lang="en-US" sz="750" b="1" dirty="0">
+                <a:solidFill>
+                  <a:srgbClr val="575A5D"/>
+                </a:solidFill>
+                <a:latin typeface="Calibri" pitchFamily="34" charset="0"/>
+                <a:ea typeface="Calibri" pitchFamily="34" charset="-122"/>
+                <a:cs typeface="Calibri" pitchFamily="34" charset="-120"/>
+              </a:rPr>
+              <a:t>Q4 FY27</a:t>
+            </a:r>
+            <a:endParaRPr lang="en-US" sz="750" dirty="0"/>
+          </a:p>
+        </p:txBody>
+      </p:sp>
+      <p:sp>
+        <p:nvSpPr>
+          <p:cNvPr id="26" name="Shape 24"/>
+          <p:cNvSpPr/>
+          <p:nvPr/>
+        </p:nvSpPr>
+        <p:spPr>
+          <a:xfrm>
+            <a:off x="6425946" y="1133856"/>
+            <a:ext cx="13716" cy="3749040"/>
+          </a:xfrm>
+          <a:prstGeom prst="rect">
+            <a:avLst/>
+          </a:prstGeom>
+          <a:solidFill>
+            <a:srgbClr val="B6BBC0"/>
+          </a:solidFill>
+          <a:ln w="12700">
+            <a:solidFill>
+              <a:srgbClr val="B6BBC0"/>
+            </a:solidFill>
+            <a:prstDash val="solid"/>
+          </a:ln>
+        </p:spPr>
+      </p:sp>
+      <p:sp>
+        <p:nvSpPr>
+          <p:cNvPr id="27" name="Shape 25"/>
+          <p:cNvSpPr/>
+          <p:nvPr/>
+        </p:nvSpPr>
+        <p:spPr>
+          <a:xfrm>
+            <a:off x="7210044" y="1664208"/>
+            <a:ext cx="784098" cy="3218688"/>
+          </a:xfrm>
+          <a:prstGeom prst="rect">
+            <a:avLst/>
+          </a:prstGeom>
+          <a:solidFill>
+            <a:srgbClr val="F4F6F8"/>
+          </a:solidFill>
+          <a:ln w="12700">
+            <a:solidFill>
+              <a:srgbClr val="F4F6F8"/>
+            </a:solidFill>
+            <a:prstDash val="solid"/>
+          </a:ln>
+        </p:spPr>
+      </p:sp>
+      <p:sp>
+        <p:nvSpPr>
+          <p:cNvPr id="28" name="Text 26"/>
+          <p:cNvSpPr/>
+          <p:nvPr/>
+        </p:nvSpPr>
+        <p:spPr>
+          <a:xfrm>
+            <a:off x="7210044" y="1389888"/>
+            <a:ext cx="784098" cy="237744"/>
+          </a:xfrm>
+          <a:prstGeom prst="rect">
+            <a:avLst/>
+          </a:prstGeom>
+          <a:noFill/>
+          <a:ln/>
+        </p:spPr>
+        <p:txBody>
+          <a:bodyPr wrap="square" lIns="0" tIns="0" rIns="0" bIns="0" rtlCol="0" anchor="ctr"/>
+          <a:lstStyle/>
+          <a:p>
+            <a:pPr algn="ctr" indent="0" marL="0">
+              <a:buNone/>
+            </a:pPr>
+            <a:r>
+              <a:rPr lang="en-US" sz="750" b="1" dirty="0">
+                <a:solidFill>
+                  <a:srgbClr val="575A5D"/>
+                </a:solidFill>
+                <a:latin typeface="Calibri" pitchFamily="34" charset="0"/>
+                <a:ea typeface="Calibri" pitchFamily="34" charset="-122"/>
+                <a:cs typeface="Calibri" pitchFamily="34" charset="-120"/>
+              </a:rPr>
+              <a:t>Q1 FY28</a:t>
+            </a:r>
+            <a:endParaRPr lang="en-US" sz="750" dirty="0"/>
+          </a:p>
+        </p:txBody>
+      </p:sp>
+      <p:sp>
+        <p:nvSpPr>
+          <p:cNvPr id="29" name="Shape 27"/>
+          <p:cNvSpPr/>
+          <p:nvPr/>
+        </p:nvSpPr>
+        <p:spPr>
+          <a:xfrm>
+            <a:off x="7210044" y="1133856"/>
+            <a:ext cx="13716" cy="3749040"/>
+          </a:xfrm>
+          <a:prstGeom prst="rect">
+            <a:avLst/>
+          </a:prstGeom>
+          <a:solidFill>
+            <a:srgbClr val="B6BBC0"/>
+          </a:solidFill>
+          <a:ln w="12700">
+            <a:solidFill>
+              <a:srgbClr val="B6BBC0"/>
+            </a:solidFill>
+            <a:prstDash val="solid"/>
+          </a:ln>
+        </p:spPr>
+      </p:sp>
+      <p:sp>
+        <p:nvSpPr>
+          <p:cNvPr id="30" name="Text 28"/>
+          <p:cNvSpPr/>
+          <p:nvPr/>
+        </p:nvSpPr>
+        <p:spPr>
+          <a:xfrm>
+            <a:off x="7994142" y="1389888"/>
+            <a:ext cx="784098" cy="237744"/>
+          </a:xfrm>
+          <a:prstGeom prst="rect">
+            <a:avLst/>
+          </a:prstGeom>
+          <a:noFill/>
+          <a:ln/>
+        </p:spPr>
+        <p:txBody>
+          <a:bodyPr wrap="square" lIns="0" tIns="0" rIns="0" bIns="0" rtlCol="0" anchor="ctr"/>
+          <a:lstStyle/>
+          <a:p>
+            <a:pPr algn="ctr" indent="0" marL="0">
+              <a:buNone/>
+            </a:pPr>
+            <a:r>
+              <a:rPr lang="en-US" sz="750" b="1" dirty="0">
+                <a:solidFill>
+                  <a:srgbClr val="575A5D"/>
+                </a:solidFill>
+                <a:latin typeface="Calibri" pitchFamily="34" charset="0"/>
+                <a:ea typeface="Calibri" pitchFamily="34" charset="-122"/>
+                <a:cs typeface="Calibri" pitchFamily="34" charset="-120"/>
+              </a:rPr>
+              <a:t>Q2 FY28</a:t>
+            </a:r>
+            <a:endParaRPr lang="en-US" sz="750" dirty="0"/>
+          </a:p>
+        </p:txBody>
+      </p:sp>
+      <p:sp>
+        <p:nvSpPr>
+          <p:cNvPr id="31" name="Shape 29"/>
+          <p:cNvSpPr/>
+          <p:nvPr/>
+        </p:nvSpPr>
+        <p:spPr>
+          <a:xfrm>
+            <a:off x="7994142" y="1133856"/>
+            <a:ext cx="13716" cy="3749040"/>
+          </a:xfrm>
+          <a:prstGeom prst="rect">
+            <a:avLst/>
+          </a:prstGeom>
+          <a:solidFill>
+            <a:srgbClr val="B6BBC0"/>
+          </a:solidFill>
+          <a:ln w="12700">
+            <a:solidFill>
+              <a:srgbClr val="B6BBC0"/>
+            </a:solidFill>
+            <a:prstDash val="solid"/>
+          </a:ln>
+        </p:spPr>
+      </p:sp>
+      <p:sp>
+        <p:nvSpPr>
+          <p:cNvPr id="32" name="Shape 30"/>
+          <p:cNvSpPr/>
+          <p:nvPr/>
+        </p:nvSpPr>
+        <p:spPr>
+          <a:xfrm>
+            <a:off x="274320" y="1664208"/>
+            <a:ext cx="8503920" cy="374904"/>
+          </a:xfrm>
+          <a:prstGeom prst="rect">
+            <a:avLst/>
+          </a:prstGeom>
+          <a:solidFill>
+            <a:srgbClr val="FFFFFF"/>
+          </a:solidFill>
+          <a:ln w="12700">
+            <a:solidFill>
+              <a:srgbClr val="E7ECF0"/>
+            </a:solidFill>
+            <a:prstDash val="solid"/>
+          </a:ln>
+        </p:spPr>
+      </p:sp>
+      <p:sp>
+        <p:nvSpPr>
+          <p:cNvPr id="33" name="Shape 31"/>
+          <p:cNvSpPr/>
+          <p:nvPr/>
+        </p:nvSpPr>
+        <p:spPr>
+          <a:xfrm>
+            <a:off x="274320" y="1664208"/>
+            <a:ext cx="54864" cy="374904"/>
+          </a:xfrm>
+          <a:prstGeom prst="rect">
+            <a:avLst/>
+          </a:prstGeom>
+          <a:solidFill>
+            <a:srgbClr val="085CE5"/>
+          </a:solidFill>
+          <a:ln w="12700">
+            <a:solidFill>
+              <a:srgbClr val="085CE5"/>
+            </a:solidFill>
+            <a:prstDash val="solid"/>
+          </a:ln>
+        </p:spPr>
+      </p:sp>
+      <p:sp>
+        <p:nvSpPr>
+          <p:cNvPr id="34" name="Text 32"/>
+          <p:cNvSpPr/>
+          <p:nvPr/>
+        </p:nvSpPr>
+        <p:spPr>
+          <a:xfrm>
+            <a:off x="384048" y="1691640"/>
+            <a:ext cx="1938528" cy="201168"/>
+          </a:xfrm>
+          <a:prstGeom prst="rect">
+            <a:avLst/>
+          </a:prstGeom>
+          <a:noFill/>
+          <a:ln/>
+        </p:spPr>
+        <p:txBody>
+          <a:bodyPr wrap="square" lIns="0" tIns="0" rIns="0" bIns="0" rtlCol="0" anchor="ctr"/>
+          <a:lstStyle/>
+          <a:p>
+            <a:pPr indent="0" marL="0">
+              <a:buNone/>
+            </a:pPr>
+            <a:r>
+              <a:rPr lang="en-US" sz="850" b="1" dirty="0">
+                <a:solidFill>
+                  <a:srgbClr val="06185F"/>
+                </a:solidFill>
+                <a:latin typeface="Calibri" pitchFamily="34" charset="0"/>
+                <a:ea typeface="Calibri" pitchFamily="34" charset="-122"/>
+                <a:cs typeface="Calibri" pitchFamily="34" charset="-120"/>
+              </a:rPr>
+              <a:t>Churn Mediation</a:t>
+            </a:r>
+            <a:endParaRPr lang="en-US" sz="850" dirty="0"/>
+          </a:p>
+        </p:txBody>
+      </p:sp>
+      <p:sp>
+        <p:nvSpPr>
+          <p:cNvPr id="35" name="Text 33"/>
+          <p:cNvSpPr/>
+          <p:nvPr/>
+        </p:nvSpPr>
+        <p:spPr>
+          <a:xfrm>
+            <a:off x="384048" y="1892808"/>
+            <a:ext cx="1938528" cy="137160"/>
+          </a:xfrm>
+          <a:prstGeom prst="rect">
+            <a:avLst/>
+          </a:prstGeom>
+          <a:noFill/>
+          <a:ln/>
+        </p:spPr>
+        <p:txBody>
+          <a:bodyPr wrap="square" lIns="0" tIns="0" rIns="0" bIns="0" rtlCol="0" anchor="ctr"/>
+          <a:lstStyle/>
+          <a:p>
+            <a:pPr indent="0" marL="0">
+              <a:buNone/>
+            </a:pPr>
+            <a:r>
+              <a:rPr lang="en-US" sz="750" i="1" dirty="0">
+                <a:solidFill>
+                  <a:srgbClr val="B6BBC0"/>
+                </a:solidFill>
+                <a:latin typeface="Calibri" pitchFamily="34" charset="0"/>
+                <a:ea typeface="Calibri" pitchFamily="34" charset="-122"/>
+                <a:cs typeface="Calibri" pitchFamily="34" charset="-120"/>
+              </a:rPr>
+              <a:t>Phase 1 MVP</a:t>
+            </a:r>
+            <a:endParaRPr lang="en-US" sz="750" dirty="0"/>
+          </a:p>
+        </p:txBody>
+      </p:sp>
+      <p:sp>
+        <p:nvSpPr>
+          <p:cNvPr id="36" name="Shape 34"/>
+          <p:cNvSpPr/>
+          <p:nvPr/>
+        </p:nvSpPr>
+        <p:spPr>
+          <a:xfrm>
+            <a:off x="2542032" y="1755648"/>
+            <a:ext cx="1495044" cy="182880"/>
+          </a:xfrm>
+          <a:prstGeom prst="rect">
+            <a:avLst/>
+          </a:prstGeom>
+          <a:solidFill>
+            <a:srgbClr val="085CE5">
+              <a:alpha val="70000"/>
+            </a:srgbClr>
+          </a:solidFill>
+          <a:ln w="12700">
+            <a:solidFill>
+              <a:srgbClr val="085CE5">
+                <a:alpha val="90000"/>
+              </a:srgbClr>
+            </a:solidFill>
+            <a:prstDash val="solid"/>
+          </a:ln>
+        </p:spPr>
+      </p:sp>
+      <p:sp>
+        <p:nvSpPr>
+          <p:cNvPr id="37" name="Shape 35"/>
+          <p:cNvSpPr/>
+          <p:nvPr/>
+        </p:nvSpPr>
+        <p:spPr>
+          <a:xfrm>
+            <a:off x="3618464" y="1755648"/>
+            <a:ext cx="418612" cy="182880"/>
+          </a:xfrm>
+          <a:prstGeom prst="rect">
+            <a:avLst/>
+          </a:prstGeom>
+          <a:solidFill>
+            <a:srgbClr val="085CE5"/>
+          </a:solidFill>
+          <a:ln w="12700">
+            <a:solidFill>
+              <a:srgbClr val="085CE5"/>
+            </a:solidFill>
+            <a:prstDash val="solid"/>
+          </a:ln>
+        </p:spPr>
+      </p:sp>
+      <p:sp>
+        <p:nvSpPr>
+          <p:cNvPr id="38" name="Text 36"/>
+          <p:cNvSpPr/>
+          <p:nvPr/>
+        </p:nvSpPr>
+        <p:spPr>
+          <a:xfrm>
+            <a:off x="2606040" y="1755648"/>
+            <a:ext cx="1367028" cy="182880"/>
+          </a:xfrm>
+          <a:prstGeom prst="rect">
+            <a:avLst/>
+          </a:prstGeom>
+          <a:noFill/>
+          <a:ln/>
+        </p:spPr>
+        <p:txBody>
+          <a:bodyPr wrap="square" lIns="0" tIns="0" rIns="0" bIns="0" rtlCol="0" anchor="ctr"/>
+          <a:lstStyle/>
+          <a:p>
+            <a:pPr indent="0" marL="0">
+              <a:buNone/>
+            </a:pPr>
+            <a:r>
+              <a:rPr lang="en-US" sz="750" dirty="0">
+                <a:solidFill>
+                  <a:srgbClr val="FFFFFF"/>
+                </a:solidFill>
+                <a:latin typeface="Calibri" pitchFamily="34" charset="0"/>
+                <a:ea typeface="Calibri" pitchFamily="34" charset="-122"/>
+                <a:cs typeface="Calibri" pitchFamily="34" charset="-120"/>
+              </a:rPr>
+              <a:t>MVP  ·  Phase 1</a:t>
+            </a:r>
+            <a:endParaRPr lang="en-US" sz="750" dirty="0"/>
+          </a:p>
+        </p:txBody>
+      </p:sp>
+      <p:sp>
+        <p:nvSpPr>
+          <p:cNvPr id="39" name="Shape 37"/>
+          <p:cNvSpPr/>
+          <p:nvPr/>
+        </p:nvSpPr>
+        <p:spPr>
+          <a:xfrm>
+            <a:off x="274320" y="2066544"/>
+            <a:ext cx="8503920" cy="374904"/>
+          </a:xfrm>
+          <a:prstGeom prst="rect">
+            <a:avLst/>
+          </a:prstGeom>
+          <a:solidFill>
+            <a:srgbClr val="F8F9FA"/>
+          </a:solidFill>
+          <a:ln w="12700">
+            <a:solidFill>
+              <a:srgbClr val="E7ECF0"/>
+            </a:solidFill>
+            <a:prstDash val="solid"/>
+          </a:ln>
+        </p:spPr>
+      </p:sp>
+      <p:sp>
+        <p:nvSpPr>
+          <p:cNvPr id="40" name="Shape 38"/>
+          <p:cNvSpPr/>
+          <p:nvPr/>
+        </p:nvSpPr>
+        <p:spPr>
+          <a:xfrm>
+            <a:off x="274320" y="2066544"/>
+            <a:ext cx="54864" cy="374904"/>
+          </a:xfrm>
+          <a:prstGeom prst="rect">
+            <a:avLst/>
+          </a:prstGeom>
+          <a:solidFill>
+            <a:srgbClr val="575A5D"/>
+          </a:solidFill>
+          <a:ln w="12700">
+            <a:solidFill>
+              <a:srgbClr val="575A5D"/>
+            </a:solidFill>
+            <a:prstDash val="solid"/>
+          </a:ln>
+        </p:spPr>
+      </p:sp>
+      <p:sp>
+        <p:nvSpPr>
+          <p:cNvPr id="41" name="Text 39"/>
+          <p:cNvSpPr/>
+          <p:nvPr/>
+        </p:nvSpPr>
+        <p:spPr>
+          <a:xfrm>
+            <a:off x="384048" y="2093976"/>
+            <a:ext cx="1938528" cy="201168"/>
+          </a:xfrm>
+          <a:prstGeom prst="rect">
+            <a:avLst/>
+          </a:prstGeom>
+          <a:noFill/>
+          <a:ln/>
+        </p:spPr>
+        <p:txBody>
+          <a:bodyPr wrap="square" lIns="0" tIns="0" rIns="0" bIns="0" rtlCol="0" anchor="ctr"/>
+          <a:lstStyle/>
+          <a:p>
+            <a:pPr indent="0" marL="0">
+              <a:buNone/>
+            </a:pPr>
+            <a:r>
+              <a:rPr lang="en-US" sz="850" b="1" dirty="0">
+                <a:solidFill>
+                  <a:srgbClr val="06185F"/>
+                </a:solidFill>
+                <a:latin typeface="Calibri" pitchFamily="34" charset="0"/>
+                <a:ea typeface="Calibri" pitchFamily="34" charset="-122"/>
+                <a:cs typeface="Calibri" pitchFamily="34" charset="-120"/>
+              </a:rPr>
+              <a:t>Call Report AI</a:t>
+            </a:r>
+            <a:endParaRPr lang="en-US" sz="850" dirty="0"/>
+          </a:p>
+        </p:txBody>
+      </p:sp>
+      <p:sp>
+        <p:nvSpPr>
+          <p:cNvPr id="42" name="Text 40"/>
+          <p:cNvSpPr/>
+          <p:nvPr/>
+        </p:nvSpPr>
+        <p:spPr>
+          <a:xfrm>
+            <a:off x="384048" y="2295144"/>
+            <a:ext cx="1938528" cy="137160"/>
+          </a:xfrm>
+          <a:prstGeom prst="rect">
+            <a:avLst/>
+          </a:prstGeom>
+          <a:noFill/>
+          <a:ln/>
+        </p:spPr>
+        <p:txBody>
+          <a:bodyPr wrap="square" lIns="0" tIns="0" rIns="0" bIns="0" rtlCol="0" anchor="ctr"/>
+          <a:lstStyle/>
+          <a:p>
+            <a:pPr indent="0" marL="0">
+              <a:buNone/>
+            </a:pPr>
+            <a:r>
+              <a:rPr lang="en-US" sz="750" i="1" dirty="0">
+                <a:solidFill>
+                  <a:srgbClr val="B6BBC0"/>
+                </a:solidFill>
+                <a:latin typeface="Calibri" pitchFamily="34" charset="0"/>
+                <a:ea typeface="Calibri" pitchFamily="34" charset="-122"/>
+                <a:cs typeface="Calibri" pitchFamily="34" charset="-120"/>
+              </a:rPr>
+              <a:t>Aug/Sept 2026 launch</a:t>
+            </a:r>
+            <a:endParaRPr lang="en-US" sz="750" dirty="0"/>
+          </a:p>
+        </p:txBody>
+      </p:sp>
+      <p:sp>
+        <p:nvSpPr>
+          <p:cNvPr id="43" name="Shape 41"/>
+          <p:cNvSpPr/>
+          <p:nvPr/>
+        </p:nvSpPr>
+        <p:spPr>
+          <a:xfrm>
+            <a:off x="2542032" y="2157984"/>
+            <a:ext cx="2279142" cy="182880"/>
+          </a:xfrm>
+          <a:prstGeom prst="rect">
+            <a:avLst/>
+          </a:prstGeom>
+          <a:solidFill>
+            <a:srgbClr val="575A5D">
+              <a:alpha val="70000"/>
+            </a:srgbClr>
+          </a:solidFill>
+          <a:ln w="12700">
+            <a:solidFill>
+              <a:srgbClr val="575A5D">
+                <a:alpha val="90000"/>
+              </a:srgbClr>
+            </a:solidFill>
+            <a:prstDash val="solid"/>
+          </a:ln>
+        </p:spPr>
+      </p:sp>
+      <p:sp>
+        <p:nvSpPr>
+          <p:cNvPr id="44" name="Shape 42"/>
+          <p:cNvSpPr/>
+          <p:nvPr/>
+        </p:nvSpPr>
+        <p:spPr>
+          <a:xfrm>
+            <a:off x="4183014" y="2157984"/>
+            <a:ext cx="638160" cy="182880"/>
+          </a:xfrm>
+          <a:prstGeom prst="rect">
+            <a:avLst/>
+          </a:prstGeom>
+          <a:solidFill>
+            <a:srgbClr val="575A5D"/>
+          </a:solidFill>
+          <a:ln w="12700">
+            <a:solidFill>
+              <a:srgbClr val="575A5D"/>
+            </a:solidFill>
+            <a:prstDash val="solid"/>
+          </a:ln>
+        </p:spPr>
+      </p:sp>
+      <p:sp>
+        <p:nvSpPr>
+          <p:cNvPr id="45" name="Text 43"/>
+          <p:cNvSpPr/>
+          <p:nvPr/>
+        </p:nvSpPr>
+        <p:spPr>
+          <a:xfrm>
+            <a:off x="2606040" y="2157984"/>
+            <a:ext cx="2151126" cy="182880"/>
+          </a:xfrm>
+          <a:prstGeom prst="rect">
+            <a:avLst/>
+          </a:prstGeom>
+          <a:noFill/>
+          <a:ln/>
+        </p:spPr>
+        <p:txBody>
+          <a:bodyPr wrap="square" lIns="0" tIns="0" rIns="0" bIns="0" rtlCol="0" anchor="ctr"/>
+          <a:lstStyle/>
+          <a:p>
+            <a:pPr indent="0" marL="0">
+              <a:buNone/>
+            </a:pPr>
+            <a:r>
+              <a:rPr lang="en-US" sz="750" dirty="0">
+                <a:solidFill>
+                  <a:srgbClr val="FFFFFF"/>
+                </a:solidFill>
+                <a:latin typeface="Calibri" pitchFamily="34" charset="0"/>
+                <a:ea typeface="Calibri" pitchFamily="34" charset="-122"/>
+                <a:cs typeface="Calibri" pitchFamily="34" charset="-120"/>
+              </a:rPr>
+              <a:t>Active dev  →  Aug/Sept '26</a:t>
+            </a:r>
+            <a:endParaRPr lang="en-US" sz="750" dirty="0"/>
+          </a:p>
+        </p:txBody>
+      </p:sp>
+      <p:sp>
+        <p:nvSpPr>
+          <p:cNvPr id="46" name="Shape 44"/>
+          <p:cNvSpPr/>
+          <p:nvPr/>
+        </p:nvSpPr>
+        <p:spPr>
+          <a:xfrm>
+            <a:off x="274320" y="2468880"/>
+            <a:ext cx="8503920" cy="374904"/>
+          </a:xfrm>
+          <a:prstGeom prst="rect">
+            <a:avLst/>
+          </a:prstGeom>
+          <a:solidFill>
+            <a:srgbClr val="FFFFFF"/>
+          </a:solidFill>
+          <a:ln w="12700">
+            <a:solidFill>
+              <a:srgbClr val="E7ECF0"/>
+            </a:solidFill>
+            <a:prstDash val="solid"/>
+          </a:ln>
+        </p:spPr>
+      </p:sp>
+      <p:sp>
+        <p:nvSpPr>
+          <p:cNvPr id="47" name="Shape 45"/>
+          <p:cNvSpPr/>
+          <p:nvPr/>
+        </p:nvSpPr>
+        <p:spPr>
+          <a:xfrm>
+            <a:off x="274320" y="2468880"/>
+            <a:ext cx="54864" cy="374904"/>
+          </a:xfrm>
+          <a:prstGeom prst="rect">
+            <a:avLst/>
+          </a:prstGeom>
+          <a:solidFill>
+            <a:srgbClr val="073FA8"/>
+          </a:solidFill>
+          <a:ln w="12700">
+            <a:solidFill>
+              <a:srgbClr val="073FA8"/>
+            </a:solidFill>
+            <a:prstDash val="solid"/>
+          </a:ln>
+        </p:spPr>
+      </p:sp>
+      <p:sp>
+        <p:nvSpPr>
+          <p:cNvPr id="48" name="Text 46"/>
+          <p:cNvSpPr/>
+          <p:nvPr/>
+        </p:nvSpPr>
+        <p:spPr>
+          <a:xfrm>
+            <a:off x="384048" y="2496312"/>
+            <a:ext cx="1938528" cy="201168"/>
+          </a:xfrm>
+          <a:prstGeom prst="rect">
+            <a:avLst/>
+          </a:prstGeom>
+          <a:noFill/>
+          <a:ln/>
+        </p:spPr>
+        <p:txBody>
+          <a:bodyPr wrap="square" lIns="0" tIns="0" rIns="0" bIns="0" rtlCol="0" anchor="ctr"/>
+          <a:lstStyle/>
+          <a:p>
+            <a:pPr indent="0" marL="0">
+              <a:buNone/>
+            </a:pPr>
+            <a:r>
+              <a:rPr lang="en-US" sz="850" b="1" dirty="0">
+                <a:solidFill>
+                  <a:srgbClr val="06185F"/>
+                </a:solidFill>
+                <a:latin typeface="Calibri" pitchFamily="34" charset="0"/>
+                <a:ea typeface="Calibri" pitchFamily="34" charset="-122"/>
+                <a:cs typeface="Calibri" pitchFamily="34" charset="-120"/>
+              </a:rPr>
+              <a:t>Anomaly Detection</a:t>
+            </a:r>
+            <a:endParaRPr lang="en-US" sz="850" dirty="0"/>
+          </a:p>
+        </p:txBody>
+      </p:sp>
+      <p:sp>
+        <p:nvSpPr>
+          <p:cNvPr id="49" name="Text 47"/>
+          <p:cNvSpPr/>
+          <p:nvPr/>
+        </p:nvSpPr>
+        <p:spPr>
+          <a:xfrm>
+            <a:off x="384048" y="2697480"/>
+            <a:ext cx="1938528" cy="137160"/>
+          </a:xfrm>
+          <a:prstGeom prst="rect">
+            <a:avLst/>
+          </a:prstGeom>
+          <a:noFill/>
+          <a:ln/>
+        </p:spPr>
+        <p:txBody>
+          <a:bodyPr wrap="square" lIns="0" tIns="0" rIns="0" bIns="0" rtlCol="0" anchor="ctr"/>
+          <a:lstStyle/>
+          <a:p>
+            <a:pPr indent="0" marL="0">
+              <a:buNone/>
+            </a:pPr>
+            <a:r>
+              <a:rPr lang="en-US" sz="750" i="1" dirty="0">
+                <a:solidFill>
+                  <a:srgbClr val="B6BBC0"/>
+                </a:solidFill>
+                <a:latin typeface="Calibri" pitchFamily="34" charset="0"/>
+                <a:ea typeface="Calibri" pitchFamily="34" charset="-122"/>
+                <a:cs typeface="Calibri" pitchFamily="34" charset="-120"/>
+              </a:rPr>
+              <a:t>Real-time fraud engine</a:t>
+            </a:r>
+            <a:endParaRPr lang="en-US" sz="750" dirty="0"/>
+          </a:p>
+        </p:txBody>
+      </p:sp>
+      <p:sp>
+        <p:nvSpPr>
+          <p:cNvPr id="50" name="Shape 48"/>
+          <p:cNvSpPr/>
+          <p:nvPr/>
+        </p:nvSpPr>
+        <p:spPr>
+          <a:xfrm>
+            <a:off x="3326130" y="2560320"/>
+            <a:ext cx="2279142" cy="182880"/>
+          </a:xfrm>
+          <a:prstGeom prst="rect">
+            <a:avLst/>
+          </a:prstGeom>
+          <a:solidFill>
+            <a:srgbClr val="073FA8">
+              <a:alpha val="70000"/>
+            </a:srgbClr>
+          </a:solidFill>
+          <a:ln w="12700">
+            <a:solidFill>
+              <a:srgbClr val="073FA8">
+                <a:alpha val="90000"/>
+              </a:srgbClr>
+            </a:solidFill>
+            <a:prstDash val="solid"/>
+          </a:ln>
+        </p:spPr>
+      </p:sp>
+      <p:sp>
+        <p:nvSpPr>
+          <p:cNvPr id="51" name="Shape 49"/>
+          <p:cNvSpPr/>
+          <p:nvPr/>
+        </p:nvSpPr>
+        <p:spPr>
+          <a:xfrm>
+            <a:off x="4967112" y="2560320"/>
+            <a:ext cx="638160" cy="182880"/>
+          </a:xfrm>
+          <a:prstGeom prst="rect">
+            <a:avLst/>
+          </a:prstGeom>
+          <a:solidFill>
+            <a:srgbClr val="073FA8"/>
+          </a:solidFill>
+          <a:ln w="12700">
+            <a:solidFill>
+              <a:srgbClr val="073FA8"/>
+            </a:solidFill>
+            <a:prstDash val="solid"/>
+          </a:ln>
+        </p:spPr>
+      </p:sp>
+      <p:sp>
+        <p:nvSpPr>
+          <p:cNvPr id="52" name="Text 50"/>
+          <p:cNvSpPr/>
+          <p:nvPr/>
+        </p:nvSpPr>
+        <p:spPr>
+          <a:xfrm>
+            <a:off x="3390138" y="2560320"/>
+            <a:ext cx="2151126" cy="182880"/>
+          </a:xfrm>
+          <a:prstGeom prst="rect">
+            <a:avLst/>
+          </a:prstGeom>
+          <a:noFill/>
+          <a:ln/>
+        </p:spPr>
+        <p:txBody>
+          <a:bodyPr wrap="square" lIns="0" tIns="0" rIns="0" bIns="0" rtlCol="0" anchor="ctr"/>
+          <a:lstStyle/>
+          <a:p>
+            <a:pPr indent="0" marL="0">
+              <a:buNone/>
+            </a:pPr>
+            <a:r>
+              <a:rPr lang="en-US" sz="750" dirty="0">
+                <a:solidFill>
+                  <a:srgbClr val="FFFFFF"/>
+                </a:solidFill>
+                <a:latin typeface="Calibri" pitchFamily="34" charset="0"/>
+                <a:ea typeface="Calibri" pitchFamily="34" charset="-122"/>
+                <a:cs typeface="Calibri" pitchFamily="34" charset="-120"/>
+              </a:rPr>
+              <a:t>Build  →  Phase 2 launch</a:t>
+            </a:r>
+            <a:endParaRPr lang="en-US" sz="750" dirty="0"/>
+          </a:p>
+        </p:txBody>
+      </p:sp>
+      <p:sp>
+        <p:nvSpPr>
+          <p:cNvPr id="53" name="Shape 51"/>
+          <p:cNvSpPr/>
+          <p:nvPr/>
+        </p:nvSpPr>
+        <p:spPr>
+          <a:xfrm>
+            <a:off x="274320" y="2871216"/>
+            <a:ext cx="8503920" cy="374904"/>
+          </a:xfrm>
+          <a:prstGeom prst="rect">
+            <a:avLst/>
+          </a:prstGeom>
+          <a:solidFill>
+            <a:srgbClr val="F8F9FA"/>
+          </a:solidFill>
+          <a:ln w="12700">
+            <a:solidFill>
+              <a:srgbClr val="E7ECF0"/>
+            </a:solidFill>
+            <a:prstDash val="solid"/>
+          </a:ln>
+        </p:spPr>
+      </p:sp>
+      <p:sp>
+        <p:nvSpPr>
+          <p:cNvPr id="54" name="Shape 52"/>
+          <p:cNvSpPr/>
+          <p:nvPr/>
+        </p:nvSpPr>
+        <p:spPr>
+          <a:xfrm>
+            <a:off x="274320" y="2871216"/>
+            <a:ext cx="54864" cy="374904"/>
+          </a:xfrm>
+          <a:prstGeom prst="rect">
+            <a:avLst/>
+          </a:prstGeom>
+          <a:solidFill>
+            <a:srgbClr val="06185F"/>
+          </a:solidFill>
+          <a:ln w="12700">
+            <a:solidFill>
+              <a:srgbClr val="06185F"/>
+            </a:solidFill>
+            <a:prstDash val="solid"/>
+          </a:ln>
+        </p:spPr>
+      </p:sp>
+      <p:sp>
+        <p:nvSpPr>
+          <p:cNvPr id="55" name="Text 53"/>
+          <p:cNvSpPr/>
+          <p:nvPr/>
+        </p:nvSpPr>
+        <p:spPr>
+          <a:xfrm>
+            <a:off x="384048" y="2898648"/>
+            <a:ext cx="1938528" cy="201168"/>
+          </a:xfrm>
+          <a:prstGeom prst="rect">
+            <a:avLst/>
+          </a:prstGeom>
+          <a:noFill/>
+          <a:ln/>
+        </p:spPr>
+        <p:txBody>
+          <a:bodyPr wrap="square" lIns="0" tIns="0" rIns="0" bIns="0" rtlCol="0" anchor="ctr"/>
+          <a:lstStyle/>
+          <a:p>
+            <a:pPr indent="0" marL="0">
+              <a:buNone/>
+            </a:pPr>
+            <a:r>
+              <a:rPr lang="en-US" sz="850" b="1" dirty="0">
+                <a:solidFill>
+                  <a:srgbClr val="06185F"/>
+                </a:solidFill>
+                <a:latin typeface="Calibri" pitchFamily="34" charset="0"/>
+                <a:ea typeface="Calibri" pitchFamily="34" charset="-122"/>
+                <a:cs typeface="Calibri" pitchFamily="34" charset="-120"/>
+              </a:rPr>
+              <a:t>Zelle Memo Intelligence</a:t>
+            </a:r>
+            <a:endParaRPr lang="en-US" sz="850" dirty="0"/>
+          </a:p>
+        </p:txBody>
+      </p:sp>
+      <p:sp>
+        <p:nvSpPr>
+          <p:cNvPr id="56" name="Text 54"/>
+          <p:cNvSpPr/>
+          <p:nvPr/>
+        </p:nvSpPr>
+        <p:spPr>
+          <a:xfrm>
+            <a:off x="384048" y="3099816"/>
+            <a:ext cx="1938528" cy="137160"/>
+          </a:xfrm>
+          <a:prstGeom prst="rect">
+            <a:avLst/>
+          </a:prstGeom>
+          <a:noFill/>
+          <a:ln/>
+        </p:spPr>
+        <p:txBody>
+          <a:bodyPr wrap="square" lIns="0" tIns="0" rIns="0" bIns="0" rtlCol="0" anchor="ctr"/>
+          <a:lstStyle/>
+          <a:p>
+            <a:pPr indent="0" marL="0">
+              <a:buNone/>
+            </a:pPr>
+            <a:r>
+              <a:rPr lang="en-US" sz="750" i="1" dirty="0">
+                <a:solidFill>
+                  <a:srgbClr val="B6BBC0"/>
+                </a:solidFill>
+                <a:latin typeface="Calibri" pitchFamily="34" charset="0"/>
+                <a:ea typeface="Calibri" pitchFamily="34" charset="-122"/>
+                <a:cs typeface="Calibri" pitchFamily="34" charset="-120"/>
+              </a:rPr>
+              <a:t>NLP compliance pipeline</a:t>
+            </a:r>
+            <a:endParaRPr lang="en-US" sz="750" dirty="0"/>
+          </a:p>
+        </p:txBody>
+      </p:sp>
+      <p:sp>
+        <p:nvSpPr>
+          <p:cNvPr id="57" name="Shape 55"/>
+          <p:cNvSpPr/>
+          <p:nvPr/>
+        </p:nvSpPr>
+        <p:spPr>
+          <a:xfrm>
+            <a:off x="4110228" y="2962656"/>
+            <a:ext cx="1495044" cy="182880"/>
+          </a:xfrm>
+          <a:prstGeom prst="rect">
+            <a:avLst/>
+          </a:prstGeom>
+          <a:solidFill>
+            <a:srgbClr val="06185F">
+              <a:alpha val="70000"/>
+            </a:srgbClr>
+          </a:solidFill>
+          <a:ln w="12700">
+            <a:solidFill>
+              <a:srgbClr val="06185F">
+                <a:alpha val="90000"/>
+              </a:srgbClr>
+            </a:solidFill>
+            <a:prstDash val="solid"/>
+          </a:ln>
+        </p:spPr>
+      </p:sp>
+      <p:sp>
+        <p:nvSpPr>
+          <p:cNvPr id="58" name="Shape 56"/>
+          <p:cNvSpPr/>
+          <p:nvPr/>
+        </p:nvSpPr>
+        <p:spPr>
+          <a:xfrm>
+            <a:off x="5186660" y="2962656"/>
+            <a:ext cx="418612" cy="182880"/>
+          </a:xfrm>
+          <a:prstGeom prst="rect">
+            <a:avLst/>
+          </a:prstGeom>
+          <a:solidFill>
+            <a:srgbClr val="06185F"/>
+          </a:solidFill>
+          <a:ln w="12700">
+            <a:solidFill>
+              <a:srgbClr val="06185F"/>
+            </a:solidFill>
+            <a:prstDash val="solid"/>
+          </a:ln>
+        </p:spPr>
+      </p:sp>
+      <p:sp>
+        <p:nvSpPr>
+          <p:cNvPr id="59" name="Text 57"/>
+          <p:cNvSpPr/>
+          <p:nvPr/>
+        </p:nvSpPr>
+        <p:spPr>
+          <a:xfrm>
+            <a:off x="4174236" y="2962656"/>
+            <a:ext cx="1367028" cy="182880"/>
+          </a:xfrm>
+          <a:prstGeom prst="rect">
+            <a:avLst/>
+          </a:prstGeom>
+          <a:noFill/>
+          <a:ln/>
+        </p:spPr>
+        <p:txBody>
+          <a:bodyPr wrap="square" lIns="0" tIns="0" rIns="0" bIns="0" rtlCol="0" anchor="ctr"/>
+          <a:lstStyle/>
+          <a:p>
+            <a:pPr indent="0" marL="0">
+              <a:buNone/>
+            </a:pPr>
+            <a:r>
+              <a:rPr lang="en-US" sz="750" dirty="0">
+                <a:solidFill>
+                  <a:srgbClr val="FFFFFF"/>
+                </a:solidFill>
+                <a:latin typeface="Calibri" pitchFamily="34" charset="0"/>
+                <a:ea typeface="Calibri" pitchFamily="34" charset="-122"/>
+                <a:cs typeface="Calibri" pitchFamily="34" charset="-120"/>
+              </a:rPr>
+              <a:t>Build  →  Phase 2 launch</a:t>
+            </a:r>
+            <a:endParaRPr lang="en-US" sz="750" dirty="0"/>
+          </a:p>
+        </p:txBody>
+      </p:sp>
+      <p:sp>
+        <p:nvSpPr>
+          <p:cNvPr id="60" name="Shape 58"/>
+          <p:cNvSpPr/>
+          <p:nvPr/>
+        </p:nvSpPr>
+        <p:spPr>
+          <a:xfrm>
+            <a:off x="274320" y="3273552"/>
+            <a:ext cx="8503920" cy="374904"/>
+          </a:xfrm>
+          <a:prstGeom prst="rect">
+            <a:avLst/>
+          </a:prstGeom>
+          <a:solidFill>
+            <a:srgbClr val="FFFFFF"/>
+          </a:solidFill>
+          <a:ln w="12700">
+            <a:solidFill>
+              <a:srgbClr val="E7ECF0"/>
+            </a:solidFill>
+            <a:prstDash val="solid"/>
+          </a:ln>
+        </p:spPr>
+      </p:sp>
+      <p:sp>
+        <p:nvSpPr>
+          <p:cNvPr id="61" name="Shape 59"/>
+          <p:cNvSpPr/>
+          <p:nvPr/>
+        </p:nvSpPr>
+        <p:spPr>
+          <a:xfrm>
+            <a:off x="274320" y="3273552"/>
+            <a:ext cx="54864" cy="374904"/>
+          </a:xfrm>
+          <a:prstGeom prst="rect">
+            <a:avLst/>
+          </a:prstGeom>
+          <a:solidFill>
+            <a:srgbClr val="0A52C4"/>
+          </a:solidFill>
+          <a:ln w="12700">
+            <a:solidFill>
+              <a:srgbClr val="0A52C4"/>
+            </a:solidFill>
+            <a:prstDash val="solid"/>
+          </a:ln>
+        </p:spPr>
+      </p:sp>
+      <p:sp>
+        <p:nvSpPr>
+          <p:cNvPr id="62" name="Text 60"/>
+          <p:cNvSpPr/>
+          <p:nvPr/>
+        </p:nvSpPr>
+        <p:spPr>
+          <a:xfrm>
+            <a:off x="384048" y="3300984"/>
+            <a:ext cx="1938528" cy="201168"/>
+          </a:xfrm>
+          <a:prstGeom prst="rect">
+            <a:avLst/>
+          </a:prstGeom>
+          <a:noFill/>
+          <a:ln/>
+        </p:spPr>
+        <p:txBody>
+          <a:bodyPr wrap="square" lIns="0" tIns="0" rIns="0" bIns="0" rtlCol="0" anchor="ctr"/>
+          <a:lstStyle/>
+          <a:p>
+            <a:pPr indent="0" marL="0">
+              <a:buNone/>
+            </a:pPr>
+            <a:r>
+              <a:rPr lang="en-US" sz="850" b="1" dirty="0">
+                <a:solidFill>
+                  <a:srgbClr val="06185F"/>
+                </a:solidFill>
+                <a:latin typeface="Calibri" pitchFamily="34" charset="0"/>
+                <a:ea typeface="Calibri" pitchFamily="34" charset="-122"/>
+                <a:cs typeface="Calibri" pitchFamily="34" charset="-120"/>
+              </a:rPr>
+              <a:t>Personal-as-Commercial</a:t>
+            </a:r>
+            <a:endParaRPr lang="en-US" sz="850" dirty="0"/>
+          </a:p>
+        </p:txBody>
+      </p:sp>
+      <p:sp>
+        <p:nvSpPr>
+          <p:cNvPr id="63" name="Text 61"/>
+          <p:cNvSpPr/>
+          <p:nvPr/>
+        </p:nvSpPr>
+        <p:spPr>
+          <a:xfrm>
+            <a:off x="384048" y="3502152"/>
+            <a:ext cx="1938528" cy="137160"/>
+          </a:xfrm>
+          <a:prstGeom prst="rect">
+            <a:avLst/>
+          </a:prstGeom>
+          <a:noFill/>
+          <a:ln/>
+        </p:spPr>
+        <p:txBody>
+          <a:bodyPr wrap="square" lIns="0" tIns="0" rIns="0" bIns="0" rtlCol="0" anchor="ctr"/>
+          <a:lstStyle/>
+          <a:p>
+            <a:pPr indent="0" marL="0">
+              <a:buNone/>
+            </a:pPr>
+            <a:r>
+              <a:rPr lang="en-US" sz="750" i="1" dirty="0">
+                <a:solidFill>
+                  <a:srgbClr val="B6BBC0"/>
+                </a:solidFill>
+                <a:latin typeface="Calibri" pitchFamily="34" charset="0"/>
+                <a:ea typeface="Calibri" pitchFamily="34" charset="-122"/>
+                <a:cs typeface="Calibri" pitchFamily="34" charset="-120"/>
+              </a:rPr>
+              <a:t>SMB conversion model</a:t>
+            </a:r>
+            <a:endParaRPr lang="en-US" sz="750" dirty="0"/>
+          </a:p>
+        </p:txBody>
+      </p:sp>
+      <p:sp>
+        <p:nvSpPr>
+          <p:cNvPr id="64" name="Shape 62"/>
+          <p:cNvSpPr/>
+          <p:nvPr/>
+        </p:nvSpPr>
+        <p:spPr>
+          <a:xfrm>
+            <a:off x="4110228" y="3364992"/>
+            <a:ext cx="1495044" cy="182880"/>
+          </a:xfrm>
+          <a:prstGeom prst="rect">
+            <a:avLst/>
+          </a:prstGeom>
+          <a:solidFill>
+            <a:srgbClr val="0A52C4">
+              <a:alpha val="70000"/>
+            </a:srgbClr>
+          </a:solidFill>
+          <a:ln w="12700">
+            <a:solidFill>
+              <a:srgbClr val="0A52C4">
+                <a:alpha val="90000"/>
+              </a:srgbClr>
+            </a:solidFill>
+            <a:prstDash val="solid"/>
+          </a:ln>
+        </p:spPr>
+      </p:sp>
+      <p:sp>
+        <p:nvSpPr>
+          <p:cNvPr id="65" name="Shape 63"/>
+          <p:cNvSpPr/>
+          <p:nvPr/>
+        </p:nvSpPr>
+        <p:spPr>
+          <a:xfrm>
+            <a:off x="5186660" y="3364992"/>
+            <a:ext cx="418612" cy="182880"/>
+          </a:xfrm>
+          <a:prstGeom prst="rect">
+            <a:avLst/>
+          </a:prstGeom>
+          <a:solidFill>
+            <a:srgbClr val="0A52C4"/>
+          </a:solidFill>
+          <a:ln w="12700">
+            <a:solidFill>
+              <a:srgbClr val="0A52C4"/>
+            </a:solidFill>
+            <a:prstDash val="solid"/>
+          </a:ln>
+        </p:spPr>
+      </p:sp>
+      <p:sp>
+        <p:nvSpPr>
+          <p:cNvPr id="66" name="Text 64"/>
+          <p:cNvSpPr/>
+          <p:nvPr/>
+        </p:nvSpPr>
+        <p:spPr>
+          <a:xfrm>
+            <a:off x="4174236" y="3364992"/>
+            <a:ext cx="1367028" cy="182880"/>
+          </a:xfrm>
+          <a:prstGeom prst="rect">
+            <a:avLst/>
+          </a:prstGeom>
+          <a:noFill/>
+          <a:ln/>
+        </p:spPr>
+        <p:txBody>
+          <a:bodyPr wrap="square" lIns="0" tIns="0" rIns="0" bIns="0" rtlCol="0" anchor="ctr"/>
+          <a:lstStyle/>
+          <a:p>
+            <a:pPr indent="0" marL="0">
+              <a:buNone/>
+            </a:pPr>
+            <a:r>
+              <a:rPr lang="en-US" sz="750" dirty="0">
+                <a:solidFill>
+                  <a:srgbClr val="FFFFFF"/>
+                </a:solidFill>
+                <a:latin typeface="Calibri" pitchFamily="34" charset="0"/>
+                <a:ea typeface="Calibri" pitchFamily="34" charset="-122"/>
+                <a:cs typeface="Calibri" pitchFamily="34" charset="-120"/>
+              </a:rPr>
+              <a:t>Build  →  Phase 2 launch</a:t>
+            </a:r>
+            <a:endParaRPr lang="en-US" sz="750" dirty="0"/>
+          </a:p>
+        </p:txBody>
+      </p:sp>
+      <p:sp>
+        <p:nvSpPr>
+          <p:cNvPr id="67" name="Shape 65"/>
+          <p:cNvSpPr/>
+          <p:nvPr/>
+        </p:nvSpPr>
+        <p:spPr>
+          <a:xfrm>
+            <a:off x="274320" y="3675888"/>
+            <a:ext cx="8503920" cy="374904"/>
+          </a:xfrm>
+          <a:prstGeom prst="rect">
+            <a:avLst/>
+          </a:prstGeom>
+          <a:solidFill>
+            <a:srgbClr val="F8F9FA"/>
+          </a:solidFill>
+          <a:ln w="12700">
+            <a:solidFill>
+              <a:srgbClr val="E7ECF0"/>
+            </a:solidFill>
+            <a:prstDash val="solid"/>
+          </a:ln>
+        </p:spPr>
+      </p:sp>
+      <p:sp>
+        <p:nvSpPr>
+          <p:cNvPr id="68" name="Shape 66"/>
+          <p:cNvSpPr/>
+          <p:nvPr/>
+        </p:nvSpPr>
+        <p:spPr>
+          <a:xfrm>
+            <a:off x="274320" y="3675888"/>
+            <a:ext cx="54864" cy="374904"/>
+          </a:xfrm>
+          <a:prstGeom prst="rect">
+            <a:avLst/>
+          </a:prstGeom>
+          <a:solidFill>
+            <a:srgbClr val="0F3D8A"/>
+          </a:solidFill>
+          <a:ln w="12700">
+            <a:solidFill>
+              <a:srgbClr val="0F3D8A"/>
+            </a:solidFill>
+            <a:prstDash val="solid"/>
+          </a:ln>
+        </p:spPr>
+      </p:sp>
+      <p:sp>
+        <p:nvSpPr>
+          <p:cNvPr id="69" name="Text 67"/>
+          <p:cNvSpPr/>
+          <p:nvPr/>
+        </p:nvSpPr>
+        <p:spPr>
+          <a:xfrm>
+            <a:off x="384048" y="3703320"/>
+            <a:ext cx="1938528" cy="201168"/>
+          </a:xfrm>
+          <a:prstGeom prst="rect">
+            <a:avLst/>
+          </a:prstGeom>
+          <a:noFill/>
+          <a:ln/>
+        </p:spPr>
+        <p:txBody>
+          <a:bodyPr wrap="square" lIns="0" tIns="0" rIns="0" bIns="0" rtlCol="0" anchor="ctr"/>
+          <a:lstStyle/>
+          <a:p>
+            <a:pPr indent="0" marL="0">
+              <a:buNone/>
+            </a:pPr>
+            <a:r>
+              <a:rPr lang="en-US" sz="850" b="1" dirty="0">
+                <a:solidFill>
+                  <a:srgbClr val="06185F"/>
+                </a:solidFill>
+                <a:latin typeface="Calibri" pitchFamily="34" charset="0"/>
+                <a:ea typeface="Calibri" pitchFamily="34" charset="-122"/>
+                <a:cs typeface="Calibri" pitchFamily="34" charset="-120"/>
+              </a:rPr>
+              <a:t>Gen. Wealth Deflection</a:t>
+            </a:r>
+            <a:endParaRPr lang="en-US" sz="850" dirty="0"/>
+          </a:p>
+        </p:txBody>
+      </p:sp>
+      <p:sp>
+        <p:nvSpPr>
+          <p:cNvPr id="70" name="Text 68"/>
+          <p:cNvSpPr/>
+          <p:nvPr/>
+        </p:nvSpPr>
+        <p:spPr>
+          <a:xfrm>
+            <a:off x="384048" y="3904488"/>
+            <a:ext cx="1938528" cy="137160"/>
+          </a:xfrm>
+          <a:prstGeom prst="rect">
+            <a:avLst/>
+          </a:prstGeom>
+          <a:noFill/>
+          <a:ln/>
+        </p:spPr>
+        <p:txBody>
+          <a:bodyPr wrap="square" lIns="0" tIns="0" rIns="0" bIns="0" rtlCol="0" anchor="ctr"/>
+          <a:lstStyle/>
+          <a:p>
+            <a:pPr indent="0" marL="0">
+              <a:buNone/>
+            </a:pPr>
+            <a:r>
+              <a:rPr lang="en-US" sz="750" i="1" dirty="0">
+                <a:solidFill>
+                  <a:srgbClr val="B6BBC0"/>
+                </a:solidFill>
+                <a:latin typeface="Calibri" pitchFamily="34" charset="0"/>
+                <a:ea typeface="Calibri" pitchFamily="34" charset="-122"/>
+                <a:cs typeface="Calibri" pitchFamily="34" charset="-120"/>
+              </a:rPr>
+              <a:t>Household coverage model</a:t>
+            </a:r>
+            <a:endParaRPr lang="en-US" sz="750" dirty="0"/>
+          </a:p>
+        </p:txBody>
+      </p:sp>
+      <p:sp>
+        <p:nvSpPr>
+          <p:cNvPr id="71" name="Shape 69"/>
+          <p:cNvSpPr/>
+          <p:nvPr/>
+        </p:nvSpPr>
+        <p:spPr>
+          <a:xfrm>
+            <a:off x="4110228" y="3767328"/>
+            <a:ext cx="2279142" cy="182880"/>
+          </a:xfrm>
+          <a:prstGeom prst="rect">
+            <a:avLst/>
+          </a:prstGeom>
+          <a:solidFill>
+            <a:srgbClr val="0F3D8A">
+              <a:alpha val="70000"/>
+            </a:srgbClr>
+          </a:solidFill>
+          <a:ln w="12700">
+            <a:solidFill>
+              <a:srgbClr val="0F3D8A">
+                <a:alpha val="90000"/>
+              </a:srgbClr>
+            </a:solidFill>
+            <a:prstDash val="solid"/>
+          </a:ln>
+        </p:spPr>
+      </p:sp>
+      <p:sp>
+        <p:nvSpPr>
+          <p:cNvPr id="72" name="Shape 70"/>
+          <p:cNvSpPr/>
+          <p:nvPr/>
+        </p:nvSpPr>
+        <p:spPr>
+          <a:xfrm>
+            <a:off x="5751210" y="3767328"/>
+            <a:ext cx="638160" cy="182880"/>
+          </a:xfrm>
+          <a:prstGeom prst="rect">
+            <a:avLst/>
+          </a:prstGeom>
+          <a:solidFill>
+            <a:srgbClr val="0F3D8A"/>
+          </a:solidFill>
+          <a:ln w="12700">
+            <a:solidFill>
+              <a:srgbClr val="0F3D8A"/>
+            </a:solidFill>
+            <a:prstDash val="solid"/>
+          </a:ln>
+        </p:spPr>
+      </p:sp>
+      <p:sp>
+        <p:nvSpPr>
+          <p:cNvPr id="73" name="Text 71"/>
+          <p:cNvSpPr/>
+          <p:nvPr/>
+        </p:nvSpPr>
+        <p:spPr>
+          <a:xfrm>
+            <a:off x="4174236" y="3767328"/>
+            <a:ext cx="2151126" cy="182880"/>
+          </a:xfrm>
+          <a:prstGeom prst="rect">
+            <a:avLst/>
+          </a:prstGeom>
+          <a:noFill/>
+          <a:ln/>
+        </p:spPr>
+        <p:txBody>
+          <a:bodyPr wrap="square" lIns="0" tIns="0" rIns="0" bIns="0" rtlCol="0" anchor="ctr"/>
+          <a:lstStyle/>
+          <a:p>
+            <a:pPr indent="0" marL="0">
+              <a:buNone/>
+            </a:pPr>
+            <a:r>
+              <a:rPr lang="en-US" sz="750" dirty="0">
+                <a:solidFill>
+                  <a:srgbClr val="FFFFFF"/>
+                </a:solidFill>
+                <a:latin typeface="Calibri" pitchFamily="34" charset="0"/>
+                <a:ea typeface="Calibri" pitchFamily="34" charset="-122"/>
+                <a:cs typeface="Calibri" pitchFamily="34" charset="-120"/>
+              </a:rPr>
+              <a:t>Phase 2 build  →  Phase 3</a:t>
+            </a:r>
+            <a:endParaRPr lang="en-US" sz="750" dirty="0"/>
+          </a:p>
+        </p:txBody>
+      </p:sp>
+      <p:sp>
+        <p:nvSpPr>
+          <p:cNvPr id="74" name="Shape 72"/>
+          <p:cNvSpPr/>
+          <p:nvPr/>
+        </p:nvSpPr>
+        <p:spPr>
+          <a:xfrm>
+            <a:off x="274320" y="4078224"/>
+            <a:ext cx="8503920" cy="374904"/>
+          </a:xfrm>
+          <a:prstGeom prst="rect">
+            <a:avLst/>
+          </a:prstGeom>
+          <a:solidFill>
+            <a:srgbClr val="FFFFFF"/>
+          </a:solidFill>
+          <a:ln w="12700">
+            <a:solidFill>
+              <a:srgbClr val="E7ECF0"/>
+            </a:solidFill>
+            <a:prstDash val="solid"/>
+          </a:ln>
+        </p:spPr>
+      </p:sp>
+      <p:sp>
+        <p:nvSpPr>
+          <p:cNvPr id="75" name="Shape 73"/>
+          <p:cNvSpPr/>
+          <p:nvPr/>
+        </p:nvSpPr>
+        <p:spPr>
+          <a:xfrm>
+            <a:off x="274320" y="4078224"/>
+            <a:ext cx="54864" cy="374904"/>
+          </a:xfrm>
+          <a:prstGeom prst="rect">
+            <a:avLst/>
+          </a:prstGeom>
+          <a:solidFill>
+            <a:srgbClr val="0B68D4"/>
+          </a:solidFill>
+          <a:ln w="12700">
+            <a:solidFill>
+              <a:srgbClr val="0B68D4"/>
+            </a:solidFill>
+            <a:prstDash val="solid"/>
+          </a:ln>
+        </p:spPr>
+      </p:sp>
+      <p:sp>
+        <p:nvSpPr>
+          <p:cNvPr id="76" name="Text 74"/>
+          <p:cNvSpPr/>
+          <p:nvPr/>
+        </p:nvSpPr>
+        <p:spPr>
+          <a:xfrm>
+            <a:off x="384048" y="4105656"/>
+            <a:ext cx="1938528" cy="201168"/>
+          </a:xfrm>
+          <a:prstGeom prst="rect">
+            <a:avLst/>
+          </a:prstGeom>
+          <a:noFill/>
+          <a:ln/>
+        </p:spPr>
+        <p:txBody>
+          <a:bodyPr wrap="square" lIns="0" tIns="0" rIns="0" bIns="0" rtlCol="0" anchor="ctr"/>
+          <a:lstStyle/>
+          <a:p>
+            <a:pPr indent="0" marL="0">
+              <a:buNone/>
+            </a:pPr>
+            <a:r>
+              <a:rPr lang="en-US" sz="850" b="1" dirty="0">
+                <a:solidFill>
+                  <a:srgbClr val="06185F"/>
+                </a:solidFill>
+                <a:latin typeface="Calibri" pitchFamily="34" charset="0"/>
+                <a:ea typeface="Calibri" pitchFamily="34" charset="-122"/>
+                <a:cs typeface="Calibri" pitchFamily="34" charset="-120"/>
+              </a:rPr>
+              <a:t>Account Opening LTV</a:t>
+            </a:r>
+            <a:endParaRPr lang="en-US" sz="850" dirty="0"/>
+          </a:p>
+        </p:txBody>
+      </p:sp>
+      <p:sp>
+        <p:nvSpPr>
+          <p:cNvPr id="77" name="Text 75"/>
+          <p:cNvSpPr/>
+          <p:nvPr/>
+        </p:nvSpPr>
+        <p:spPr>
+          <a:xfrm>
+            <a:off x="384048" y="4306824"/>
+            <a:ext cx="1938528" cy="137160"/>
+          </a:xfrm>
+          <a:prstGeom prst="rect">
+            <a:avLst/>
+          </a:prstGeom>
+          <a:noFill/>
+          <a:ln/>
+        </p:spPr>
+        <p:txBody>
+          <a:bodyPr wrap="square" lIns="0" tIns="0" rIns="0" bIns="0" rtlCol="0" anchor="ctr"/>
+          <a:lstStyle/>
+          <a:p>
+            <a:pPr indent="0" marL="0">
+              <a:buNone/>
+            </a:pPr>
+            <a:r>
+              <a:rPr lang="en-US" sz="750" i="1" dirty="0">
+                <a:solidFill>
+                  <a:srgbClr val="B6BBC0"/>
+                </a:solidFill>
+                <a:latin typeface="Calibri" pitchFamily="34" charset="0"/>
+                <a:ea typeface="Calibri" pitchFamily="34" charset="-122"/>
+                <a:cs typeface="Calibri" pitchFamily="34" charset="-120"/>
+              </a:rPr>
+              <a:t>New account LTV scoring</a:t>
+            </a:r>
+            <a:endParaRPr lang="en-US" sz="750" dirty="0"/>
+          </a:p>
+        </p:txBody>
+      </p:sp>
+      <p:sp>
+        <p:nvSpPr>
+          <p:cNvPr id="78" name="Shape 76"/>
+          <p:cNvSpPr/>
+          <p:nvPr/>
+        </p:nvSpPr>
+        <p:spPr>
+          <a:xfrm>
+            <a:off x="5678424" y="4169664"/>
+            <a:ext cx="1495044" cy="182880"/>
+          </a:xfrm>
+          <a:prstGeom prst="rect">
+            <a:avLst/>
+          </a:prstGeom>
+          <a:solidFill>
+            <a:srgbClr val="0B68D4">
+              <a:alpha val="70000"/>
+            </a:srgbClr>
+          </a:solidFill>
+          <a:ln w="12700">
+            <a:solidFill>
+              <a:srgbClr val="0B68D4">
+                <a:alpha val="90000"/>
+              </a:srgbClr>
+            </a:solidFill>
+            <a:prstDash val="solid"/>
+          </a:ln>
+        </p:spPr>
+      </p:sp>
+      <p:sp>
+        <p:nvSpPr>
+          <p:cNvPr id="79" name="Shape 77"/>
+          <p:cNvSpPr/>
+          <p:nvPr/>
+        </p:nvSpPr>
+        <p:spPr>
+          <a:xfrm>
+            <a:off x="6754856" y="4169664"/>
+            <a:ext cx="418612" cy="182880"/>
+          </a:xfrm>
+          <a:prstGeom prst="rect">
+            <a:avLst/>
+          </a:prstGeom>
+          <a:solidFill>
+            <a:srgbClr val="0B68D4"/>
+          </a:solidFill>
+          <a:ln w="12700">
+            <a:solidFill>
+              <a:srgbClr val="0B68D4"/>
+            </a:solidFill>
+            <a:prstDash val="solid"/>
+          </a:ln>
+        </p:spPr>
+      </p:sp>
+      <p:sp>
+        <p:nvSpPr>
+          <p:cNvPr id="80" name="Text 78"/>
+          <p:cNvSpPr/>
+          <p:nvPr/>
+        </p:nvSpPr>
+        <p:spPr>
+          <a:xfrm>
+            <a:off x="5742432" y="4169664"/>
+            <a:ext cx="1367028" cy="182880"/>
+          </a:xfrm>
+          <a:prstGeom prst="rect">
+            <a:avLst/>
+          </a:prstGeom>
+          <a:noFill/>
+          <a:ln/>
+        </p:spPr>
+        <p:txBody>
+          <a:bodyPr wrap="square" lIns="0" tIns="0" rIns="0" bIns="0" rtlCol="0" anchor="ctr"/>
+          <a:lstStyle/>
+          <a:p>
+            <a:pPr indent="0" marL="0">
+              <a:buNone/>
+            </a:pPr>
+            <a:r>
+              <a:rPr lang="en-US" sz="750" dirty="0">
+                <a:solidFill>
+                  <a:srgbClr val="FFFFFF"/>
+                </a:solidFill>
+                <a:latin typeface="Calibri" pitchFamily="34" charset="0"/>
+                <a:ea typeface="Calibri" pitchFamily="34" charset="-122"/>
+                <a:cs typeface="Calibri" pitchFamily="34" charset="-120"/>
+              </a:rPr>
+              <a:t>Build  →  Phase 3 launch</a:t>
+            </a:r>
+            <a:endParaRPr lang="en-US" sz="750" dirty="0"/>
+          </a:p>
+        </p:txBody>
+      </p:sp>
+      <p:sp>
+        <p:nvSpPr>
+          <p:cNvPr id="81" name="Shape 79"/>
+          <p:cNvSpPr/>
+          <p:nvPr/>
+        </p:nvSpPr>
+        <p:spPr>
+          <a:xfrm>
+            <a:off x="274320" y="4480560"/>
+            <a:ext cx="8503920" cy="374904"/>
+          </a:xfrm>
+          <a:prstGeom prst="rect">
+            <a:avLst/>
+          </a:prstGeom>
+          <a:solidFill>
+            <a:srgbClr val="F8F9FA"/>
+          </a:solidFill>
+          <a:ln w="12700">
+            <a:solidFill>
+              <a:srgbClr val="E7ECF0"/>
+            </a:solidFill>
+            <a:prstDash val="solid"/>
+          </a:ln>
+        </p:spPr>
+      </p:sp>
+      <p:sp>
+        <p:nvSpPr>
+          <p:cNvPr id="82" name="Shape 80"/>
+          <p:cNvSpPr/>
+          <p:nvPr/>
+        </p:nvSpPr>
+        <p:spPr>
+          <a:xfrm>
+            <a:off x="274320" y="4480560"/>
+            <a:ext cx="54864" cy="374904"/>
+          </a:xfrm>
+          <a:prstGeom prst="rect">
+            <a:avLst/>
+          </a:prstGeom>
+          <a:solidFill>
+            <a:srgbClr val="0D2E7A"/>
+          </a:solidFill>
+          <a:ln w="12700">
+            <a:solidFill>
+              <a:srgbClr val="0D2E7A"/>
+            </a:solidFill>
+            <a:prstDash val="solid"/>
+          </a:ln>
+        </p:spPr>
+      </p:sp>
+      <p:sp>
+        <p:nvSpPr>
+          <p:cNvPr id="83" name="Text 81"/>
+          <p:cNvSpPr/>
+          <p:nvPr/>
+        </p:nvSpPr>
+        <p:spPr>
+          <a:xfrm>
+            <a:off x="384048" y="4507992"/>
+            <a:ext cx="1938528" cy="201168"/>
+          </a:xfrm>
+          <a:prstGeom prst="rect">
+            <a:avLst/>
+          </a:prstGeom>
+          <a:noFill/>
+          <a:ln/>
+        </p:spPr>
+        <p:txBody>
+          <a:bodyPr wrap="square" lIns="0" tIns="0" rIns="0" bIns="0" rtlCol="0" anchor="ctr"/>
+          <a:lstStyle/>
+          <a:p>
+            <a:pPr indent="0" marL="0">
+              <a:buNone/>
+            </a:pPr>
+            <a:r>
+              <a:rPr lang="en-US" sz="850" b="1" dirty="0">
+                <a:solidFill>
+                  <a:srgbClr val="06185F"/>
+                </a:solidFill>
+                <a:latin typeface="Calibri" pitchFamily="34" charset="0"/>
+                <a:ea typeface="Calibri" pitchFamily="34" charset="-122"/>
+                <a:cs typeface="Calibri" pitchFamily="34" charset="-120"/>
+              </a:rPr>
+              <a:t>FI Decision Studio</a:t>
+            </a:r>
+            <a:endParaRPr lang="en-US" sz="850" dirty="0"/>
+          </a:p>
+        </p:txBody>
+      </p:sp>
+      <p:sp>
+        <p:nvSpPr>
+          <p:cNvPr id="84" name="Text 82"/>
+          <p:cNvSpPr/>
+          <p:nvPr/>
+        </p:nvSpPr>
+        <p:spPr>
+          <a:xfrm>
+            <a:off x="384048" y="4709160"/>
+            <a:ext cx="1938528" cy="137160"/>
+          </a:xfrm>
+          <a:prstGeom prst="rect">
+            <a:avLst/>
+          </a:prstGeom>
+          <a:noFill/>
+          <a:ln/>
+        </p:spPr>
+        <p:txBody>
+          <a:bodyPr wrap="square" lIns="0" tIns="0" rIns="0" bIns="0" rtlCol="0" anchor="ctr"/>
+          <a:lstStyle/>
+          <a:p>
+            <a:pPr indent="0" marL="0">
+              <a:buNone/>
+            </a:pPr>
+            <a:r>
+              <a:rPr lang="en-US" sz="750" i="1" dirty="0">
+                <a:solidFill>
+                  <a:srgbClr val="B6BBC0"/>
+                </a:solidFill>
+                <a:latin typeface="Calibri" pitchFamily="34" charset="0"/>
+                <a:ea typeface="Calibri" pitchFamily="34" charset="-122"/>
+                <a:cs typeface="Calibri" pitchFamily="34" charset="-120"/>
+              </a:rPr>
+              <a:t>AutoML platform  ·  GA</a:t>
+            </a:r>
+            <a:endParaRPr lang="en-US" sz="750" dirty="0"/>
+          </a:p>
+        </p:txBody>
+      </p:sp>
+      <p:sp>
+        <p:nvSpPr>
+          <p:cNvPr id="85" name="Shape 83"/>
+          <p:cNvSpPr/>
+          <p:nvPr/>
+        </p:nvSpPr>
+        <p:spPr>
+          <a:xfrm>
+            <a:off x="5678424" y="4572000"/>
+            <a:ext cx="3063240" cy="182880"/>
+          </a:xfrm>
+          <a:prstGeom prst="rect">
+            <a:avLst/>
+          </a:prstGeom>
+          <a:solidFill>
+            <a:srgbClr val="0D2E7A">
+              <a:alpha val="70000"/>
+            </a:srgbClr>
+          </a:solidFill>
+          <a:ln w="12700">
+            <a:solidFill>
+              <a:srgbClr val="0D2E7A">
+                <a:alpha val="90000"/>
+              </a:srgbClr>
+            </a:solidFill>
+            <a:prstDash val="solid"/>
+          </a:ln>
+        </p:spPr>
+      </p:sp>
+      <p:sp>
+        <p:nvSpPr>
+          <p:cNvPr id="86" name="Shape 84"/>
+          <p:cNvSpPr/>
+          <p:nvPr/>
+        </p:nvSpPr>
+        <p:spPr>
+          <a:xfrm>
+            <a:off x="8030718" y="4572000"/>
+            <a:ext cx="710946" cy="182880"/>
+          </a:xfrm>
+          <a:prstGeom prst="rect">
+            <a:avLst/>
+          </a:prstGeom>
+          <a:solidFill>
+            <a:srgbClr val="0D2E7A"/>
+          </a:solidFill>
+          <a:ln w="12700">
+            <a:solidFill>
+              <a:srgbClr val="0D2E7A"/>
+            </a:solidFill>
+            <a:prstDash val="solid"/>
+          </a:ln>
+        </p:spPr>
+      </p:sp>
+      <p:sp>
+        <p:nvSpPr>
+          <p:cNvPr id="87" name="Text 85"/>
+          <p:cNvSpPr/>
+          <p:nvPr/>
+        </p:nvSpPr>
+        <p:spPr>
+          <a:xfrm>
+            <a:off x="5742432" y="4572000"/>
+            <a:ext cx="2935224" cy="182880"/>
+          </a:xfrm>
+          <a:prstGeom prst="rect">
+            <a:avLst/>
+          </a:prstGeom>
+          <a:noFill/>
+          <a:ln/>
+        </p:spPr>
+        <p:txBody>
+          <a:bodyPr wrap="square" lIns="0" tIns="0" rIns="0" bIns="0" rtlCol="0" anchor="ctr"/>
+          <a:lstStyle/>
+          <a:p>
+            <a:pPr indent="0" marL="0">
+              <a:buNone/>
+            </a:pPr>
+            <a:r>
+              <a:rPr lang="en-US" sz="750" dirty="0">
+                <a:solidFill>
+                  <a:srgbClr val="FFFFFF"/>
+                </a:solidFill>
+                <a:latin typeface="Calibri" pitchFamily="34" charset="0"/>
+                <a:ea typeface="Calibri" pitchFamily="34" charset="-122"/>
+                <a:cs typeface="Calibri" pitchFamily="34" charset="-120"/>
+              </a:rPr>
+              <a:t>Platform build  →  Phase 3 GA</a:t>
+            </a:r>
+            <a:endParaRPr lang="en-US" sz="750" dirty="0"/>
+          </a:p>
+        </p:txBody>
+      </p:sp>
+      <p:sp>
+        <p:nvSpPr>
+          <p:cNvPr id="88" name="Shape 86"/>
+          <p:cNvSpPr/>
+          <p:nvPr/>
+        </p:nvSpPr>
+        <p:spPr>
+          <a:xfrm>
+            <a:off x="384048" y="4919472"/>
+            <a:ext cx="457200" cy="128016"/>
+          </a:xfrm>
+          <a:prstGeom prst="rect">
+            <a:avLst/>
+          </a:prstGeom>
+          <a:solidFill>
+            <a:srgbClr val="085CE5">
+              <a:alpha val="70000"/>
+            </a:srgbClr>
+          </a:solidFill>
+          <a:ln w="12700">
+            <a:solidFill>
+              <a:srgbClr val="085CE5"/>
+            </a:solidFill>
+            <a:prstDash val="solid"/>
+          </a:ln>
+        </p:spPr>
+      </p:sp>
+      <p:sp>
+        <p:nvSpPr>
+          <p:cNvPr id="89" name="Text 87"/>
+          <p:cNvSpPr/>
+          <p:nvPr/>
+        </p:nvSpPr>
+        <p:spPr>
+          <a:xfrm>
+            <a:off x="896112" y="4919472"/>
+            <a:ext cx="1280160" cy="128016"/>
+          </a:xfrm>
+          <a:prstGeom prst="rect">
+            <a:avLst/>
+          </a:prstGeom>
+          <a:noFill/>
+          <a:ln/>
+        </p:spPr>
+        <p:txBody>
+          <a:bodyPr wrap="square" lIns="0" tIns="0" rIns="0" bIns="0" rtlCol="0" anchor="ctr"/>
+          <a:lstStyle/>
+          <a:p>
+            <a:pPr indent="0" marL="0">
+              <a:buNone/>
+            </a:pPr>
+            <a:r>
+              <a:rPr lang="en-US" sz="750" dirty="0">
+                <a:solidFill>
+                  <a:srgbClr val="575A5D"/>
+                </a:solidFill>
+                <a:latin typeface="Calibri" pitchFamily="34" charset="0"/>
+                <a:ea typeface="Calibri" pitchFamily="34" charset="-122"/>
+                <a:cs typeface="Calibri" pitchFamily="34" charset="-120"/>
+              </a:rPr>
+              <a:t>Build / validate</a:t>
+            </a:r>
+            <a:endParaRPr lang="en-US" sz="750" dirty="0"/>
+          </a:p>
+        </p:txBody>
+      </p:sp>
+      <p:sp>
+        <p:nvSpPr>
+          <p:cNvPr id="90" name="Shape 88"/>
+          <p:cNvSpPr/>
+          <p:nvPr/>
+        </p:nvSpPr>
+        <p:spPr>
+          <a:xfrm>
+            <a:off x="2304288" y="4919472"/>
+            <a:ext cx="457200" cy="128016"/>
+          </a:xfrm>
+          <a:prstGeom prst="rect">
+            <a:avLst/>
+          </a:prstGeom>
+          <a:solidFill>
+            <a:srgbClr val="085CE5"/>
+          </a:solidFill>
+          <a:ln w="12700">
+            <a:solidFill>
+              <a:srgbClr val="085CE5"/>
+            </a:solidFill>
+            <a:prstDash val="solid"/>
+          </a:ln>
+        </p:spPr>
+      </p:sp>
+      <p:sp>
+        <p:nvSpPr>
+          <p:cNvPr id="91" name="Text 89"/>
+          <p:cNvSpPr/>
+          <p:nvPr/>
+        </p:nvSpPr>
+        <p:spPr>
+          <a:xfrm>
+            <a:off x="2816352" y="4919472"/>
+            <a:ext cx="1280160" cy="128016"/>
+          </a:xfrm>
+          <a:prstGeom prst="rect">
+            <a:avLst/>
+          </a:prstGeom>
+          <a:noFill/>
+          <a:ln/>
+        </p:spPr>
+        <p:txBody>
+          <a:bodyPr wrap="square" lIns="0" tIns="0" rIns="0" bIns="0" rtlCol="0" anchor="ctr"/>
+          <a:lstStyle/>
+          <a:p>
+            <a:pPr indent="0" marL="0">
+              <a:buNone/>
+            </a:pPr>
+            <a:r>
+              <a:rPr lang="en-US" sz="750" dirty="0">
+                <a:solidFill>
+                  <a:srgbClr val="575A5D"/>
+                </a:solidFill>
+                <a:latin typeface="Calibri" pitchFamily="34" charset="0"/>
+                <a:ea typeface="Calibri" pitchFamily="34" charset="-122"/>
+                <a:cs typeface="Calibri" pitchFamily="34" charset="-120"/>
+              </a:rPr>
+              <a:t>Launch window</a:t>
+            </a:r>
+            <a:endParaRPr lang="en-US" sz="750" dirty="0"/>
+          </a:p>
+        </p:txBody>
+      </p:sp>
+      <p:sp>
+        <p:nvSpPr>
+          <p:cNvPr id="92" name="Shape 90"/>
+          <p:cNvSpPr/>
+          <p:nvPr/>
+        </p:nvSpPr>
+        <p:spPr>
+          <a:xfrm>
+            <a:off x="2519172" y="1115568"/>
+            <a:ext cx="36576" cy="3767328"/>
+          </a:xfrm>
+          <a:prstGeom prst="rect">
+            <a:avLst/>
+          </a:prstGeom>
+          <a:solidFill>
+            <a:srgbClr val="76DCFD"/>
+          </a:solidFill>
+          <a:ln w="12700">
+            <a:solidFill>
+              <a:srgbClr val="76DCFD"/>
+            </a:solidFill>
+            <a:prstDash val="solid"/>
+          </a:ln>
+        </p:spPr>
+      </p:sp>
+      <p:sp>
+        <p:nvSpPr>
+          <p:cNvPr id="93" name="Text 91"/>
+          <p:cNvSpPr/>
+          <p:nvPr/>
+        </p:nvSpPr>
+        <p:spPr>
+          <a:xfrm>
+            <a:off x="2395728" y="1097280"/>
+            <a:ext cx="502920" cy="219456"/>
+          </a:xfrm>
+          <a:prstGeom prst="rect">
+            <a:avLst/>
+          </a:prstGeom>
+          <a:noFill/>
+          <a:ln/>
+        </p:spPr>
+        <p:txBody>
+          <a:bodyPr wrap="square" lIns="0" tIns="0" rIns="0" bIns="0" rtlCol="0" anchor="ctr"/>
+          <a:lstStyle/>
+          <a:p>
+            <a:pPr algn="ctr" indent="0" marL="0">
+              <a:buNone/>
+            </a:pPr>
+            <a:r>
+              <a:rPr lang="en-US" sz="700" b="1" dirty="0">
+                <a:solidFill>
+                  <a:srgbClr val="76DCFD"/>
+                </a:solidFill>
+                <a:latin typeface="Calibri" pitchFamily="34" charset="0"/>
+                <a:ea typeface="Calibri" pitchFamily="34" charset="-122"/>
+                <a:cs typeface="Calibri" pitchFamily="34" charset="-120"/>
+              </a:rPr>
+              <a:t>NOW</a:t>
+            </a:r>
+            <a:endParaRPr lang="en-US" sz="700" dirty="0"/>
+          </a:p>
+        </p:txBody>
+      </p:sp>
+    </p:spTree>
+  </p:cSld>
+  <p:clrMapOvr>
+    <a:masterClrMapping/>
+  </p:clrMapOvr>
+</p:sld>
+</file>
+
+<file path=ppt/slides/slide23.xml><?xml version="1.0" encoding="utf-8"?>
+<p:sld xmlns:a="http://schemas.openxmlformats.org/drawingml/2006/main" xmlns:r="http://schemas.openxmlformats.org/officeDocument/2006/relationships" xmlns:p="http://schemas.openxmlformats.org/presentationml/2006/main">
+  <p:cSld name="Slide 23">
+    <p:bg>
+      <p:bgPr>
+        <a:solidFill>
           <a:srgbClr val="E8F7F7"/>
         </a:solidFill>
       </p:bgPr>
@@ -26525,9 +29540,9 @@
 </p:sld>
 </file>
 
-<file path=ppt/slides/slide23.xml><?xml version="1.0" encoding="utf-8"?>
+<file path=ppt/slides/slide24.xml><?xml version="1.0" encoding="utf-8"?>
 <p:sld xmlns:a="http://schemas.openxmlformats.org/drawingml/2006/main" xmlns:r="http://schemas.openxmlformats.org/officeDocument/2006/relationships" xmlns:p="http://schemas.openxmlformats.org/presentationml/2006/main">
-  <p:cSld name="Slide 23">
+  <p:cSld name="Slide 24">
     <p:bg>
       <p:bgPr>
         <a:solidFill>

</xml_diff>

<commit_message>
Move Call Report AI & Account Opening LTV to Horizon Pipeline slide
- Portfolio overview (slide 5) now shows 6 core apps in 3x2 grid with
  a Horizon callout strip listing what's in the pipeline
- Horizon Pipeline slide expanded to 4x2 grid (8 items total):
  Call Report AI and Account Opening LTV listed as "Phase 2" promotions
  with Aug '26 / Phase 2 badges; original 6 Horizon apps labeled "Year 2"
- Footnote clarifies the two tiers of the pipeline

Co-Authored-By: Claude Sonnet 4.6 <noreply@anthropic.com>
</commit_message>
<xml_diff>
--- a/JH_DS_Strategy_JHBI.pptx
+++ b/JH_DS_Strategy_JHBI.pptx
@@ -15986,7 +15986,7 @@
               <a:buNone/>
             </a:pPr>
             <a:r>
-              <a:rPr lang="en-US" sz="2200" b="1" dirty="0">
+              <a:rPr lang="en-US" sz="2000" b="1" dirty="0">
                 <a:solidFill>
                   <a:srgbClr val="FFFFFF"/>
                 </a:solidFill>
@@ -15994,9 +15994,9 @@
                 <a:ea typeface="Calibri" pitchFamily="34" charset="-122"/>
                 <a:cs typeface="Calibri" pitchFamily="34" charset="-120"/>
               </a:rPr>
-              <a:t>Horizon Pipeline: Year 2 Platform Opportunities</a:t>
-            </a:r>
-            <a:endParaRPr lang="en-US" sz="2200" dirty="0"/>
+              <a:t>Horizon Pipeline — Phase 2 &amp; Year 2 Platform Opportunities</a:t>
+            </a:r>
+            <a:endParaRPr lang="en-US" sz="2000" dirty="0"/>
           </a:p>
         </p:txBody>
       </p:sp>
@@ -16008,8 +16008,8 @@
         </p:nvSpPr>
         <p:spPr>
           <a:xfrm>
-            <a:off x="274320" y="786384"/>
-            <a:ext cx="2743200" cy="1901952"/>
+            <a:off x="128016" y="786384"/>
+            <a:ext cx="2084832" cy="1938528"/>
           </a:xfrm>
           <a:prstGeom prst="rect">
             <a:avLst/>
@@ -16040,26 +16040,90 @@
         </p:nvSpPr>
         <p:spPr>
           <a:xfrm>
-            <a:off x="274320" y="786384"/>
-            <a:ext cx="2743200" cy="73152"/>
-          </a:xfrm>
-          <a:prstGeom prst="rect">
-            <a:avLst/>
-          </a:prstGeom>
-          <a:solidFill>
-            <a:srgbClr val="085CE5"/>
+            <a:off x="128016" y="786384"/>
+            <a:ext cx="2084832" cy="73152"/>
+          </a:xfrm>
+          <a:prstGeom prst="rect">
+            <a:avLst/>
+          </a:prstGeom>
+          <a:solidFill>
+            <a:srgbClr val="575A5D"/>
           </a:solidFill>
           <a:ln w="12700">
             <a:solidFill>
-              <a:srgbClr val="085CE5"/>
+              <a:srgbClr val="575A5D"/>
             </a:solidFill>
             <a:prstDash val="solid"/>
           </a:ln>
         </p:spPr>
       </p:sp>
+      <p:sp>
+        <p:nvSpPr>
+          <p:cNvPr id="6" name="Shape 4"/>
+          <p:cNvSpPr/>
+          <p:nvPr/>
+        </p:nvSpPr>
+        <p:spPr>
+          <a:xfrm>
+            <a:off x="1609344" y="914400"/>
+            <a:ext cx="548640" cy="182880"/>
+          </a:xfrm>
+          <a:prstGeom prst="rect">
+            <a:avLst/>
+          </a:prstGeom>
+          <a:solidFill>
+            <a:srgbClr val="575A5D"/>
+          </a:solidFill>
+          <a:ln w="12700">
+            <a:solidFill>
+              <a:srgbClr val="575A5D"/>
+            </a:solidFill>
+            <a:prstDash val="solid"/>
+          </a:ln>
+        </p:spPr>
+      </p:sp>
+      <p:sp>
+        <p:nvSpPr>
+          <p:cNvPr id="7" name="Text 5"/>
+          <p:cNvSpPr/>
+          <p:nvPr/>
+        </p:nvSpPr>
+        <p:spPr>
+          <a:xfrm>
+            <a:off x="1609344" y="914400"/>
+            <a:ext cx="548640" cy="182880"/>
+          </a:xfrm>
+          <a:prstGeom prst="rect">
+            <a:avLst/>
+          </a:prstGeom>
+          <a:noFill/>
+          <a:ln/>
+        </p:spPr>
+        <p:txBody>
+          <a:bodyPr wrap="square" lIns="0" tIns="0" rIns="0" bIns="0" rtlCol="0" anchor="ctr"/>
+          <a:lstStyle/>
+          <a:p>
+            <a:pPr algn="ctr" indent="0" marL="0">
+              <a:buNone/>
+            </a:pPr>
+            <a:r>
+              <a:rPr lang="en-US" sz="650" b="1" dirty="0">
+                <a:solidFill>
+                  <a:srgbClr val="FFFFFF"/>
+                </a:solidFill>
+                <a:latin typeface="Calibri" pitchFamily="34" charset="0"/>
+                <a:ea typeface="Calibri" pitchFamily="34" charset="-122"/>
+                <a:cs typeface="Calibri" pitchFamily="34" charset="-120"/>
+              </a:rPr>
+              <a:t>Aug '26</a:t>
+            </a:r>
+            <a:endParaRPr lang="en-US" sz="650" dirty="0"/>
+          </a:p>
+        </p:txBody>
+      </p:sp>
       <p:pic>
         <p:nvPicPr>
-          <p:cNvPr id="6" name="Image 0" descr="preencoded.png">    </p:cNvPr>
+          <p:cNvPr id="8" name="Image 0" descr="preencoded.png">    </p:cNvPr>
           <p:cNvPicPr>
             <a:picLocks noChangeAspect="1"/>
           </p:cNvPicPr>
@@ -16073,8 +16137,8 @@
         </p:blipFill>
         <p:spPr>
           <a:xfrm>
-            <a:off x="429768" y="969264"/>
-            <a:ext cx="347472" cy="347472"/>
+            <a:off x="256032" y="969264"/>
+            <a:ext cx="310896" cy="310896"/>
           </a:xfrm>
           <a:prstGeom prst="rect">
             <a:avLst/>
@@ -16083,14 +16147,14 @@
       </p:pic>
       <p:sp>
         <p:nvSpPr>
-          <p:cNvPr id="7" name="Text 4"/>
-          <p:cNvSpPr/>
-          <p:nvPr/>
-        </p:nvSpPr>
-        <p:spPr>
-          <a:xfrm>
-            <a:off x="868680" y="914400"/>
-            <a:ext cx="2057400" cy="457200"/>
+          <p:cNvPr id="9" name="Text 6"/>
+          <p:cNvSpPr/>
+          <p:nvPr/>
+        </p:nvSpPr>
+        <p:spPr>
+          <a:xfrm>
+            <a:off x="621792" y="914400"/>
+            <a:ext cx="950976" cy="402336"/>
           </a:xfrm>
           <a:prstGeom prst="rect">
             <a:avLst/>
@@ -16106,7 +16170,7 @@
               <a:buNone/>
             </a:pPr>
             <a:r>
-              <a:rPr lang="en-US" sz="1050" b="1" dirty="0">
+              <a:rPr lang="en-US" sz="950" b="1" dirty="0">
                 <a:solidFill>
                   <a:srgbClr val="06185F"/>
                 </a:solidFill>
@@ -16114,22 +16178,22 @@
                 <a:ea typeface="Calibri" pitchFamily="34" charset="-122"/>
                 <a:cs typeface="Calibri" pitchFamily="34" charset="-120"/>
               </a:rPr>
-              <a:t>Cross-Sell Propensity Engine</a:t>
-            </a:r>
-            <a:endParaRPr lang="en-US" sz="1050" dirty="0"/>
-          </a:p>
-        </p:txBody>
-      </p:sp>
-      <p:sp>
-        <p:nvSpPr>
-          <p:cNvPr id="8" name="Text 5"/>
-          <p:cNvSpPr/>
-          <p:nvPr/>
-        </p:nvSpPr>
-        <p:spPr>
-          <a:xfrm>
-            <a:off x="411480" y="1444752"/>
-            <a:ext cx="2487168" cy="1115568"/>
+              <a:t>Call Report AI</a:t>
+            </a:r>
+            <a:endParaRPr lang="en-US" sz="950" dirty="0"/>
+          </a:p>
+        </p:txBody>
+      </p:sp>
+      <p:sp>
+        <p:nvSpPr>
+          <p:cNvPr id="10" name="Text 7"/>
+          <p:cNvSpPr/>
+          <p:nvPr/>
+        </p:nvSpPr>
+        <p:spPr>
+          <a:xfrm>
+            <a:off x="237744" y="1389888"/>
+            <a:ext cx="1865376" cy="1225296"/>
           </a:xfrm>
           <a:prstGeom prst="rect">
             <a:avLst/>
@@ -16145,7 +16209,7 @@
               <a:buNone/>
             </a:pPr>
             <a:r>
-              <a:rPr lang="en-US" sz="1000" dirty="0">
+              <a:rPr lang="en-US" sz="900" dirty="0">
                 <a:solidFill>
                   <a:srgbClr val="575A5D"/>
                 </a:solidFill>
@@ -16153,22 +16217,22 @@
                 <a:ea typeface="Calibri" pitchFamily="34" charset="-122"/>
                 <a:cs typeface="Calibri" pitchFamily="34" charset="-120"/>
               </a:rPr>
-              <a:t>ML model scoring each FI customer's likelihood to open savings, CDs, credit cards, or mortgage — enabling timed, personalized offers embedded in Banno.</a:t>
-            </a:r>
-            <a:endParaRPr lang="en-US" sz="1000" dirty="0"/>
-          </a:p>
-        </p:txBody>
-      </p:sp>
-      <p:sp>
-        <p:nvSpPr>
-          <p:cNvPr id="9" name="Shape 6"/>
-          <p:cNvSpPr/>
-          <p:nvPr/>
-        </p:nvSpPr>
-        <p:spPr>
-          <a:xfrm>
-            <a:off x="3154680" y="786384"/>
-            <a:ext cx="2743200" cy="1901952"/>
+              <a:t>Claude-powered NCUA 5300 intelligence — market pulse, NL Q&amp;A, and peer benchmarking for CU executives. In active development, targeting Aug/Sept 2026.</a:t>
+            </a:r>
+            <a:endParaRPr lang="en-US" sz="900" dirty="0"/>
+          </a:p>
+        </p:txBody>
+      </p:sp>
+      <p:sp>
+        <p:nvSpPr>
+          <p:cNvPr id="11" name="Shape 8"/>
+          <p:cNvSpPr/>
+          <p:nvPr/>
+        </p:nvSpPr>
+        <p:spPr>
+          <a:xfrm>
+            <a:off x="2350008" y="786384"/>
+            <a:ext cx="2084832" cy="1938528"/>
           </a:xfrm>
           <a:prstGeom prst="rect">
             <a:avLst/>
@@ -16193,32 +16257,96 @@
       </p:sp>
       <p:sp>
         <p:nvSpPr>
-          <p:cNvPr id="10" name="Shape 7"/>
-          <p:cNvSpPr/>
-          <p:nvPr/>
-        </p:nvSpPr>
-        <p:spPr>
-          <a:xfrm>
-            <a:off x="3154680" y="786384"/>
-            <a:ext cx="2743200" cy="73152"/>
-          </a:xfrm>
-          <a:prstGeom prst="rect">
-            <a:avLst/>
-          </a:prstGeom>
-          <a:solidFill>
-            <a:srgbClr val="06185F"/>
+          <p:cNvPr id="12" name="Shape 9"/>
+          <p:cNvSpPr/>
+          <p:nvPr/>
+        </p:nvSpPr>
+        <p:spPr>
+          <a:xfrm>
+            <a:off x="2350008" y="786384"/>
+            <a:ext cx="2084832" cy="73152"/>
+          </a:xfrm>
+          <a:prstGeom prst="rect">
+            <a:avLst/>
+          </a:prstGeom>
+          <a:solidFill>
+            <a:srgbClr val="0B68D4"/>
           </a:solidFill>
           <a:ln w="12700">
             <a:solidFill>
-              <a:srgbClr val="06185F"/>
+              <a:srgbClr val="0B68D4"/>
             </a:solidFill>
             <a:prstDash val="solid"/>
           </a:ln>
         </p:spPr>
       </p:sp>
+      <p:sp>
+        <p:nvSpPr>
+          <p:cNvPr id="13" name="Shape 10"/>
+          <p:cNvSpPr/>
+          <p:nvPr/>
+        </p:nvSpPr>
+        <p:spPr>
+          <a:xfrm>
+            <a:off x="3831336" y="914400"/>
+            <a:ext cx="548640" cy="182880"/>
+          </a:xfrm>
+          <a:prstGeom prst="rect">
+            <a:avLst/>
+          </a:prstGeom>
+          <a:solidFill>
+            <a:srgbClr val="0B68D4"/>
+          </a:solidFill>
+          <a:ln w="12700">
+            <a:solidFill>
+              <a:srgbClr val="0B68D4"/>
+            </a:solidFill>
+            <a:prstDash val="solid"/>
+          </a:ln>
+        </p:spPr>
+      </p:sp>
+      <p:sp>
+        <p:nvSpPr>
+          <p:cNvPr id="14" name="Text 11"/>
+          <p:cNvSpPr/>
+          <p:nvPr/>
+        </p:nvSpPr>
+        <p:spPr>
+          <a:xfrm>
+            <a:off x="3831336" y="914400"/>
+            <a:ext cx="548640" cy="182880"/>
+          </a:xfrm>
+          <a:prstGeom prst="rect">
+            <a:avLst/>
+          </a:prstGeom>
+          <a:noFill/>
+          <a:ln/>
+        </p:spPr>
+        <p:txBody>
+          <a:bodyPr wrap="square" lIns="0" tIns="0" rIns="0" bIns="0" rtlCol="0" anchor="ctr"/>
+          <a:lstStyle/>
+          <a:p>
+            <a:pPr algn="ctr" indent="0" marL="0">
+              <a:buNone/>
+            </a:pPr>
+            <a:r>
+              <a:rPr lang="en-US" sz="650" b="1" dirty="0">
+                <a:solidFill>
+                  <a:srgbClr val="FFFFFF"/>
+                </a:solidFill>
+                <a:latin typeface="Calibri" pitchFamily="34" charset="0"/>
+                <a:ea typeface="Calibri" pitchFamily="34" charset="-122"/>
+                <a:cs typeface="Calibri" pitchFamily="34" charset="-120"/>
+              </a:rPr>
+              <a:t>Phase 2</a:t>
+            </a:r>
+            <a:endParaRPr lang="en-US" sz="650" dirty="0"/>
+          </a:p>
+        </p:txBody>
+      </p:sp>
       <p:pic>
         <p:nvPicPr>
-          <p:cNvPr id="11" name="Image 1" descr="preencoded.png">    </p:cNvPr>
+          <p:cNvPr id="15" name="Image 1" descr="preencoded.png">    </p:cNvPr>
           <p:cNvPicPr>
             <a:picLocks noChangeAspect="1"/>
           </p:cNvPicPr>
@@ -16232,8 +16360,8 @@
         </p:blipFill>
         <p:spPr>
           <a:xfrm>
-            <a:off x="3310128" y="969264"/>
-            <a:ext cx="347472" cy="347472"/>
+            <a:off x="2478024" y="969264"/>
+            <a:ext cx="310896" cy="310896"/>
           </a:xfrm>
           <a:prstGeom prst="rect">
             <a:avLst/>
@@ -16242,14 +16370,14 @@
       </p:pic>
       <p:sp>
         <p:nvSpPr>
-          <p:cNvPr id="12" name="Text 8"/>
-          <p:cNvSpPr/>
-          <p:nvPr/>
-        </p:nvSpPr>
-        <p:spPr>
-          <a:xfrm>
-            <a:off x="3749040" y="914400"/>
-            <a:ext cx="2057400" cy="457200"/>
+          <p:cNvPr id="16" name="Text 12"/>
+          <p:cNvSpPr/>
+          <p:nvPr/>
+        </p:nvSpPr>
+        <p:spPr>
+          <a:xfrm>
+            <a:off x="2843784" y="914400"/>
+            <a:ext cx="950976" cy="402336"/>
           </a:xfrm>
           <a:prstGeom prst="rect">
             <a:avLst/>
@@ -16265,7 +16393,7 @@
               <a:buNone/>
             </a:pPr>
             <a:r>
-              <a:rPr lang="en-US" sz="1050" b="1" dirty="0">
+              <a:rPr lang="en-US" sz="950" b="1" dirty="0">
                 <a:solidFill>
                   <a:srgbClr val="06185F"/>
                 </a:solidFill>
@@ -16273,22 +16401,22 @@
                 <a:ea typeface="Calibri" pitchFamily="34" charset="-122"/>
                 <a:cs typeface="Calibri" pitchFamily="34" charset="-120"/>
               </a:rPr>
-              <a:t>Fraud Ring Detection</a:t>
-            </a:r>
-            <a:endParaRPr lang="en-US" sz="1050" dirty="0"/>
-          </a:p>
-        </p:txBody>
-      </p:sp>
-      <p:sp>
-        <p:nvSpPr>
-          <p:cNvPr id="13" name="Text 9"/>
-          <p:cNvSpPr/>
-          <p:nvPr/>
-        </p:nvSpPr>
-        <p:spPr>
-          <a:xfrm>
-            <a:off x="3291840" y="1444752"/>
-            <a:ext cx="2487168" cy="1115568"/>
+              <a:t>Account Opening LTV</a:t>
+            </a:r>
+            <a:endParaRPr lang="en-US" sz="950" dirty="0"/>
+          </a:p>
+        </p:txBody>
+      </p:sp>
+      <p:sp>
+        <p:nvSpPr>
+          <p:cNvPr id="17" name="Text 13"/>
+          <p:cNvSpPr/>
+          <p:nvPr/>
+        </p:nvSpPr>
+        <p:spPr>
+          <a:xfrm>
+            <a:off x="2459736" y="1389888"/>
+            <a:ext cx="1865376" cy="1225296"/>
           </a:xfrm>
           <a:prstGeom prst="rect">
             <a:avLst/>
@@ -16304,7 +16432,7 @@
               <a:buNone/>
             </a:pPr>
             <a:r>
-              <a:rPr lang="en-US" sz="1000" dirty="0">
+              <a:rPr lang="en-US" sz="900" dirty="0">
                 <a:solidFill>
                   <a:srgbClr val="575A5D"/>
                 </a:solidFill>
@@ -16312,22 +16440,22 @@
                 <a:ea typeface="Calibri" pitchFamily="34" charset="-122"/>
                 <a:cs typeface="Calibri" pitchFamily="34" charset="-120"/>
               </a:rPr>
-              <a:t>Graph-based ML to identify coordinated fraud across linked accounts, shared devices, and IP clusters — across the entire JH network for cross-institution signals.</a:t>
-            </a:r>
-            <a:endParaRPr lang="en-US" sz="1000" dirty="0"/>
-          </a:p>
-        </p:txBody>
-      </p:sp>
-      <p:sp>
-        <p:nvSpPr>
-          <p:cNvPr id="14" name="Shape 10"/>
-          <p:cNvSpPr/>
-          <p:nvPr/>
-        </p:nvSpPr>
-        <p:spPr>
-          <a:xfrm>
-            <a:off x="6035040" y="786384"/>
-            <a:ext cx="2743200" cy="1901952"/>
+              <a:t>Score new accounts by predicted LTV at opening — routing applicants to differentiated service tiers and triggering ML-guided cross-sell sequencing.</a:t>
+            </a:r>
+            <a:endParaRPr lang="en-US" sz="900" dirty="0"/>
+          </a:p>
+        </p:txBody>
+      </p:sp>
+      <p:sp>
+        <p:nvSpPr>
+          <p:cNvPr id="18" name="Shape 14"/>
+          <p:cNvSpPr/>
+          <p:nvPr/>
+        </p:nvSpPr>
+        <p:spPr>
+          <a:xfrm>
+            <a:off x="4572000" y="786384"/>
+            <a:ext cx="2084832" cy="1938528"/>
           </a:xfrm>
           <a:prstGeom prst="rect">
             <a:avLst/>
@@ -16352,32 +16480,96 @@
       </p:sp>
       <p:sp>
         <p:nvSpPr>
-          <p:cNvPr id="15" name="Shape 11"/>
-          <p:cNvSpPr/>
-          <p:nvPr/>
-        </p:nvSpPr>
-        <p:spPr>
-          <a:xfrm>
-            <a:off x="6035040" y="786384"/>
-            <a:ext cx="2743200" cy="73152"/>
-          </a:xfrm>
-          <a:prstGeom prst="rect">
-            <a:avLst/>
-          </a:prstGeom>
-          <a:solidFill>
-            <a:srgbClr val="073FA8"/>
+          <p:cNvPr id="19" name="Shape 15"/>
+          <p:cNvSpPr/>
+          <p:nvPr/>
+        </p:nvSpPr>
+        <p:spPr>
+          <a:xfrm>
+            <a:off x="4572000" y="786384"/>
+            <a:ext cx="2084832" cy="73152"/>
+          </a:xfrm>
+          <a:prstGeom prst="rect">
+            <a:avLst/>
+          </a:prstGeom>
+          <a:solidFill>
+            <a:srgbClr val="085CE5"/>
           </a:solidFill>
           <a:ln w="12700">
             <a:solidFill>
-              <a:srgbClr val="073FA8"/>
+              <a:srgbClr val="085CE5"/>
             </a:solidFill>
             <a:prstDash val="solid"/>
           </a:ln>
         </p:spPr>
       </p:sp>
+      <p:sp>
+        <p:nvSpPr>
+          <p:cNvPr id="20" name="Shape 16"/>
+          <p:cNvSpPr/>
+          <p:nvPr/>
+        </p:nvSpPr>
+        <p:spPr>
+          <a:xfrm>
+            <a:off x="6053328" y="914400"/>
+            <a:ext cx="548640" cy="182880"/>
+          </a:xfrm>
+          <a:prstGeom prst="rect">
+            <a:avLst/>
+          </a:prstGeom>
+          <a:solidFill>
+            <a:srgbClr val="085CE5"/>
+          </a:solidFill>
+          <a:ln w="12700">
+            <a:solidFill>
+              <a:srgbClr val="085CE5"/>
+            </a:solidFill>
+            <a:prstDash val="solid"/>
+          </a:ln>
+        </p:spPr>
+      </p:sp>
+      <p:sp>
+        <p:nvSpPr>
+          <p:cNvPr id="21" name="Text 17"/>
+          <p:cNvSpPr/>
+          <p:nvPr/>
+        </p:nvSpPr>
+        <p:spPr>
+          <a:xfrm>
+            <a:off x="6053328" y="914400"/>
+            <a:ext cx="548640" cy="182880"/>
+          </a:xfrm>
+          <a:prstGeom prst="rect">
+            <a:avLst/>
+          </a:prstGeom>
+          <a:noFill/>
+          <a:ln/>
+        </p:spPr>
+        <p:txBody>
+          <a:bodyPr wrap="square" lIns="0" tIns="0" rIns="0" bIns="0" rtlCol="0" anchor="ctr"/>
+          <a:lstStyle/>
+          <a:p>
+            <a:pPr algn="ctr" indent="0" marL="0">
+              <a:buNone/>
+            </a:pPr>
+            <a:r>
+              <a:rPr lang="en-US" sz="650" b="1" dirty="0">
+                <a:solidFill>
+                  <a:srgbClr val="FFFFFF"/>
+                </a:solidFill>
+                <a:latin typeface="Calibri" pitchFamily="34" charset="0"/>
+                <a:ea typeface="Calibri" pitchFamily="34" charset="-122"/>
+                <a:cs typeface="Calibri" pitchFamily="34" charset="-120"/>
+              </a:rPr>
+              <a:t>Year 2</a:t>
+            </a:r>
+            <a:endParaRPr lang="en-US" sz="650" dirty="0"/>
+          </a:p>
+        </p:txBody>
+      </p:sp>
       <p:pic>
         <p:nvPicPr>
-          <p:cNvPr id="16" name="Image 2" descr="preencoded.png">    </p:cNvPr>
+          <p:cNvPr id="22" name="Image 2" descr="preencoded.png">    </p:cNvPr>
           <p:cNvPicPr>
             <a:picLocks noChangeAspect="1"/>
           </p:cNvPicPr>
@@ -16391,8 +16583,8 @@
         </p:blipFill>
         <p:spPr>
           <a:xfrm>
-            <a:off x="6190488" y="969264"/>
-            <a:ext cx="347472" cy="347472"/>
+            <a:off x="4700016" y="969264"/>
+            <a:ext cx="310896" cy="310896"/>
           </a:xfrm>
           <a:prstGeom prst="rect">
             <a:avLst/>
@@ -16401,14 +16593,14 @@
       </p:pic>
       <p:sp>
         <p:nvSpPr>
-          <p:cNvPr id="17" name="Text 12"/>
-          <p:cNvSpPr/>
-          <p:nvPr/>
-        </p:nvSpPr>
-        <p:spPr>
-          <a:xfrm>
-            <a:off x="6629400" y="914400"/>
-            <a:ext cx="2057400" cy="457200"/>
+          <p:cNvPr id="23" name="Text 18"/>
+          <p:cNvSpPr/>
+          <p:nvPr/>
+        </p:nvSpPr>
+        <p:spPr>
+          <a:xfrm>
+            <a:off x="5065776" y="914400"/>
+            <a:ext cx="950976" cy="402336"/>
           </a:xfrm>
           <a:prstGeom prst="rect">
             <a:avLst/>
@@ -16424,7 +16616,7 @@
               <a:buNone/>
             </a:pPr>
             <a:r>
-              <a:rPr lang="en-US" sz="1050" b="1" dirty="0">
+              <a:rPr lang="en-US" sz="950" b="1" dirty="0">
                 <a:solidFill>
                   <a:srgbClr val="06185F"/>
                 </a:solidFill>
@@ -16432,22 +16624,22 @@
                 <a:ea typeface="Calibri" pitchFamily="34" charset="-122"/>
                 <a:cs typeface="Calibri" pitchFamily="34" charset="-120"/>
               </a:rPr>
-              <a:t>Deposit Runoff Forecasting</a:t>
-            </a:r>
-            <a:endParaRPr lang="en-US" sz="1050" dirty="0"/>
-          </a:p>
-        </p:txBody>
-      </p:sp>
-      <p:sp>
-        <p:nvSpPr>
-          <p:cNvPr id="18" name="Text 13"/>
-          <p:cNvSpPr/>
-          <p:nvPr/>
-        </p:nvSpPr>
-        <p:spPr>
-          <a:xfrm>
-            <a:off x="6172200" y="1444752"/>
-            <a:ext cx="2487168" cy="1115568"/>
+              <a:t>Cross-Sell Propensity</a:t>
+            </a:r>
+            <a:endParaRPr lang="en-US" sz="950" dirty="0"/>
+          </a:p>
+        </p:txBody>
+      </p:sp>
+      <p:sp>
+        <p:nvSpPr>
+          <p:cNvPr id="24" name="Text 19"/>
+          <p:cNvSpPr/>
+          <p:nvPr/>
+        </p:nvSpPr>
+        <p:spPr>
+          <a:xfrm>
+            <a:off x="4681728" y="1389888"/>
+            <a:ext cx="1865376" cy="1225296"/>
           </a:xfrm>
           <a:prstGeom prst="rect">
             <a:avLst/>
@@ -16463,7 +16655,7 @@
               <a:buNone/>
             </a:pPr>
             <a:r>
-              <a:rPr lang="en-US" sz="1000" dirty="0">
+              <a:rPr lang="en-US" sz="900" dirty="0">
                 <a:solidFill>
                   <a:srgbClr val="575A5D"/>
                 </a:solidFill>
@@ -16471,22 +16663,22 @@
                 <a:ea typeface="Calibri" pitchFamily="34" charset="-122"/>
                 <a:cs typeface="Calibri" pitchFamily="34" charset="-120"/>
               </a:rPr>
-              <a:t>Portfolio-level deposit attrition prediction to support FI clients' ALM, liquidity stress testing, and treasury planning with 90-day forward visibility.</a:t>
-            </a:r>
-            <a:endParaRPr lang="en-US" sz="1000" dirty="0"/>
-          </a:p>
-        </p:txBody>
-      </p:sp>
-      <p:sp>
-        <p:nvSpPr>
-          <p:cNvPr id="19" name="Shape 14"/>
-          <p:cNvSpPr/>
-          <p:nvPr/>
-        </p:nvSpPr>
-        <p:spPr>
-          <a:xfrm>
-            <a:off x="274320" y="2871216"/>
-            <a:ext cx="2743200" cy="1901952"/>
+              <a:t>ML model scoring each FI customer's likelihood to open savings, CDs, credit cards, or mortgage — enabling timed, personalized offers embedded in Banno.</a:t>
+            </a:r>
+            <a:endParaRPr lang="en-US" sz="900" dirty="0"/>
+          </a:p>
+        </p:txBody>
+      </p:sp>
+      <p:sp>
+        <p:nvSpPr>
+          <p:cNvPr id="25" name="Shape 20"/>
+          <p:cNvSpPr/>
+          <p:nvPr/>
+        </p:nvSpPr>
+        <p:spPr>
+          <a:xfrm>
+            <a:off x="6793992" y="786384"/>
+            <a:ext cx="2084832" cy="1938528"/>
           </a:xfrm>
           <a:prstGeom prst="rect">
             <a:avLst/>
@@ -16511,32 +16703,96 @@
       </p:sp>
       <p:sp>
         <p:nvSpPr>
-          <p:cNvPr id="20" name="Shape 15"/>
-          <p:cNvSpPr/>
-          <p:nvPr/>
-        </p:nvSpPr>
-        <p:spPr>
-          <a:xfrm>
-            <a:off x="274320" y="2871216"/>
-            <a:ext cx="2743200" cy="73152"/>
-          </a:xfrm>
-          <a:prstGeom prst="rect">
-            <a:avLst/>
-          </a:prstGeom>
-          <a:solidFill>
-            <a:srgbClr val="575A5D"/>
+          <p:cNvPr id="26" name="Shape 21"/>
+          <p:cNvSpPr/>
+          <p:nvPr/>
+        </p:nvSpPr>
+        <p:spPr>
+          <a:xfrm>
+            <a:off x="6793992" y="786384"/>
+            <a:ext cx="2084832" cy="73152"/>
+          </a:xfrm>
+          <a:prstGeom prst="rect">
+            <a:avLst/>
+          </a:prstGeom>
+          <a:solidFill>
+            <a:srgbClr val="06185F"/>
           </a:solidFill>
           <a:ln w="12700">
             <a:solidFill>
-              <a:srgbClr val="575A5D"/>
+              <a:srgbClr val="06185F"/>
             </a:solidFill>
             <a:prstDash val="solid"/>
           </a:ln>
         </p:spPr>
       </p:sp>
+      <p:sp>
+        <p:nvSpPr>
+          <p:cNvPr id="27" name="Shape 22"/>
+          <p:cNvSpPr/>
+          <p:nvPr/>
+        </p:nvSpPr>
+        <p:spPr>
+          <a:xfrm>
+            <a:off x="8275320" y="914400"/>
+            <a:ext cx="548640" cy="182880"/>
+          </a:xfrm>
+          <a:prstGeom prst="rect">
+            <a:avLst/>
+          </a:prstGeom>
+          <a:solidFill>
+            <a:srgbClr val="06185F"/>
+          </a:solidFill>
+          <a:ln w="12700">
+            <a:solidFill>
+              <a:srgbClr val="06185F"/>
+            </a:solidFill>
+            <a:prstDash val="solid"/>
+          </a:ln>
+        </p:spPr>
+      </p:sp>
+      <p:sp>
+        <p:nvSpPr>
+          <p:cNvPr id="28" name="Text 23"/>
+          <p:cNvSpPr/>
+          <p:nvPr/>
+        </p:nvSpPr>
+        <p:spPr>
+          <a:xfrm>
+            <a:off x="8275320" y="914400"/>
+            <a:ext cx="548640" cy="182880"/>
+          </a:xfrm>
+          <a:prstGeom prst="rect">
+            <a:avLst/>
+          </a:prstGeom>
+          <a:noFill/>
+          <a:ln/>
+        </p:spPr>
+        <p:txBody>
+          <a:bodyPr wrap="square" lIns="0" tIns="0" rIns="0" bIns="0" rtlCol="0" anchor="ctr"/>
+          <a:lstStyle/>
+          <a:p>
+            <a:pPr algn="ctr" indent="0" marL="0">
+              <a:buNone/>
+            </a:pPr>
+            <a:r>
+              <a:rPr lang="en-US" sz="650" b="1" dirty="0">
+                <a:solidFill>
+                  <a:srgbClr val="FFFFFF"/>
+                </a:solidFill>
+                <a:latin typeface="Calibri" pitchFamily="34" charset="0"/>
+                <a:ea typeface="Calibri" pitchFamily="34" charset="-122"/>
+                <a:cs typeface="Calibri" pitchFamily="34" charset="-120"/>
+              </a:rPr>
+              <a:t>Year 2</a:t>
+            </a:r>
+            <a:endParaRPr lang="en-US" sz="650" dirty="0"/>
+          </a:p>
+        </p:txBody>
+      </p:sp>
       <p:pic>
         <p:nvPicPr>
-          <p:cNvPr id="21" name="Image 3" descr="preencoded.png">    </p:cNvPr>
+          <p:cNvPr id="29" name="Image 3" descr="preencoded.png">    </p:cNvPr>
           <p:cNvPicPr>
             <a:picLocks noChangeAspect="1"/>
           </p:cNvPicPr>
@@ -16550,8 +16806,8 @@
         </p:blipFill>
         <p:spPr>
           <a:xfrm>
-            <a:off x="429768" y="3054096"/>
-            <a:ext cx="347472" cy="347472"/>
+            <a:off x="6922008" y="969264"/>
+            <a:ext cx="310896" cy="310896"/>
           </a:xfrm>
           <a:prstGeom prst="rect">
             <a:avLst/>
@@ -16560,14 +16816,14 @@
       </p:pic>
       <p:sp>
         <p:nvSpPr>
-          <p:cNvPr id="22" name="Text 16"/>
-          <p:cNvSpPr/>
-          <p:nvPr/>
-        </p:nvSpPr>
-        <p:spPr>
-          <a:xfrm>
-            <a:off x="868680" y="2999232"/>
-            <a:ext cx="2057400" cy="457200"/>
+          <p:cNvPr id="30" name="Text 24"/>
+          <p:cNvSpPr/>
+          <p:nvPr/>
+        </p:nvSpPr>
+        <p:spPr>
+          <a:xfrm>
+            <a:off x="7287768" y="914400"/>
+            <a:ext cx="950976" cy="402336"/>
           </a:xfrm>
           <a:prstGeom prst="rect">
             <a:avLst/>
@@ -16583,7 +16839,7 @@
               <a:buNone/>
             </a:pPr>
             <a:r>
-              <a:rPr lang="en-US" sz="1050" b="1" dirty="0">
+              <a:rPr lang="en-US" sz="950" b="1" dirty="0">
                 <a:solidFill>
                   <a:srgbClr val="06185F"/>
                 </a:solidFill>
@@ -16591,22 +16847,22 @@
                 <a:ea typeface="Calibri" pitchFamily="34" charset="-122"/>
                 <a:cs typeface="Calibri" pitchFamily="34" charset="-120"/>
               </a:rPr>
-              <a:t>Overdraft Prediction &amp; Mediation</a:t>
-            </a:r>
-            <a:endParaRPr lang="en-US" sz="1050" dirty="0"/>
-          </a:p>
-        </p:txBody>
-      </p:sp>
-      <p:sp>
-        <p:nvSpPr>
-          <p:cNvPr id="23" name="Text 17"/>
-          <p:cNvSpPr/>
-          <p:nvPr/>
-        </p:nvSpPr>
-        <p:spPr>
-          <a:xfrm>
-            <a:off x="411480" y="3529584"/>
-            <a:ext cx="2487168" cy="1115568"/>
+              <a:t>Fraud Ring Detection</a:t>
+            </a:r>
+            <a:endParaRPr lang="en-US" sz="950" dirty="0"/>
+          </a:p>
+        </p:txBody>
+      </p:sp>
+      <p:sp>
+        <p:nvSpPr>
+          <p:cNvPr id="31" name="Text 25"/>
+          <p:cNvSpPr/>
+          <p:nvPr/>
+        </p:nvSpPr>
+        <p:spPr>
+          <a:xfrm>
+            <a:off x="6903720" y="1389888"/>
+            <a:ext cx="1865376" cy="1225296"/>
           </a:xfrm>
           <a:prstGeom prst="rect">
             <a:avLst/>
@@ -16622,7 +16878,7 @@
               <a:buNone/>
             </a:pPr>
             <a:r>
-              <a:rPr lang="en-US" sz="1000" dirty="0">
+              <a:rPr lang="en-US" sz="900" dirty="0">
                 <a:solidFill>
                   <a:srgbClr val="575A5D"/>
                 </a:solidFill>
@@ -16630,22 +16886,22 @@
                 <a:ea typeface="Calibri" pitchFamily="34" charset="-122"/>
                 <a:cs typeface="Calibri" pitchFamily="34" charset="-120"/>
               </a:rPr>
-              <a:t>Anticipate overdraft events before they occur and surface proactive micro-loan offers or alerts in Banno — improving CX while reducing NSF fee risk for FIs.</a:t>
-            </a:r>
-            <a:endParaRPr lang="en-US" sz="1000" dirty="0"/>
-          </a:p>
-        </p:txBody>
-      </p:sp>
-      <p:sp>
-        <p:nvSpPr>
-          <p:cNvPr id="24" name="Shape 18"/>
-          <p:cNvSpPr/>
-          <p:nvPr/>
-        </p:nvSpPr>
-        <p:spPr>
-          <a:xfrm>
-            <a:off x="3154680" y="2871216"/>
-            <a:ext cx="2743200" cy="1901952"/>
+              <a:t>Graph-based ML to identify coordinated fraud across linked accounts, shared devices, and IP clusters — across the entire JH network for cross-institution signals.</a:t>
+            </a:r>
+            <a:endParaRPr lang="en-US" sz="900" dirty="0"/>
+          </a:p>
+        </p:txBody>
+      </p:sp>
+      <p:sp>
+        <p:nvSpPr>
+          <p:cNvPr id="32" name="Shape 26"/>
+          <p:cNvSpPr/>
+          <p:nvPr/>
+        </p:nvSpPr>
+        <p:spPr>
+          <a:xfrm>
+            <a:off x="128016" y="2889504"/>
+            <a:ext cx="2084832" cy="1938528"/>
           </a:xfrm>
           <a:prstGeom prst="rect">
             <a:avLst/>
@@ -16670,32 +16926,96 @@
       </p:sp>
       <p:sp>
         <p:nvSpPr>
-          <p:cNvPr id="25" name="Shape 19"/>
-          <p:cNvSpPr/>
-          <p:nvPr/>
-        </p:nvSpPr>
-        <p:spPr>
-          <a:xfrm>
-            <a:off x="3154680" y="2871216"/>
-            <a:ext cx="2743200" cy="73152"/>
-          </a:xfrm>
-          <a:prstGeom prst="rect">
-            <a:avLst/>
-          </a:prstGeom>
-          <a:solidFill>
-            <a:srgbClr val="0B68D4"/>
+          <p:cNvPr id="33" name="Shape 27"/>
+          <p:cNvSpPr/>
+          <p:nvPr/>
+        </p:nvSpPr>
+        <p:spPr>
+          <a:xfrm>
+            <a:off x="128016" y="2889504"/>
+            <a:ext cx="2084832" cy="73152"/>
+          </a:xfrm>
+          <a:prstGeom prst="rect">
+            <a:avLst/>
+          </a:prstGeom>
+          <a:solidFill>
+            <a:srgbClr val="073FA8"/>
           </a:solidFill>
           <a:ln w="12700">
             <a:solidFill>
-              <a:srgbClr val="0B68D4"/>
+              <a:srgbClr val="073FA8"/>
             </a:solidFill>
             <a:prstDash val="solid"/>
           </a:ln>
         </p:spPr>
       </p:sp>
+      <p:sp>
+        <p:nvSpPr>
+          <p:cNvPr id="34" name="Shape 28"/>
+          <p:cNvSpPr/>
+          <p:nvPr/>
+        </p:nvSpPr>
+        <p:spPr>
+          <a:xfrm>
+            <a:off x="1609344" y="3017520"/>
+            <a:ext cx="548640" cy="182880"/>
+          </a:xfrm>
+          <a:prstGeom prst="rect">
+            <a:avLst/>
+          </a:prstGeom>
+          <a:solidFill>
+            <a:srgbClr val="073FA8"/>
+          </a:solidFill>
+          <a:ln w="12700">
+            <a:solidFill>
+              <a:srgbClr val="073FA8"/>
+            </a:solidFill>
+            <a:prstDash val="solid"/>
+          </a:ln>
+        </p:spPr>
+      </p:sp>
+      <p:sp>
+        <p:nvSpPr>
+          <p:cNvPr id="35" name="Text 29"/>
+          <p:cNvSpPr/>
+          <p:nvPr/>
+        </p:nvSpPr>
+        <p:spPr>
+          <a:xfrm>
+            <a:off x="1609344" y="3017520"/>
+            <a:ext cx="548640" cy="182880"/>
+          </a:xfrm>
+          <a:prstGeom prst="rect">
+            <a:avLst/>
+          </a:prstGeom>
+          <a:noFill/>
+          <a:ln/>
+        </p:spPr>
+        <p:txBody>
+          <a:bodyPr wrap="square" lIns="0" tIns="0" rIns="0" bIns="0" rtlCol="0" anchor="ctr"/>
+          <a:lstStyle/>
+          <a:p>
+            <a:pPr algn="ctr" indent="0" marL="0">
+              <a:buNone/>
+            </a:pPr>
+            <a:r>
+              <a:rPr lang="en-US" sz="650" b="1" dirty="0">
+                <a:solidFill>
+                  <a:srgbClr val="FFFFFF"/>
+                </a:solidFill>
+                <a:latin typeface="Calibri" pitchFamily="34" charset="0"/>
+                <a:ea typeface="Calibri" pitchFamily="34" charset="-122"/>
+                <a:cs typeface="Calibri" pitchFamily="34" charset="-120"/>
+              </a:rPr>
+              <a:t>Year 2</a:t>
+            </a:r>
+            <a:endParaRPr lang="en-US" sz="650" dirty="0"/>
+          </a:p>
+        </p:txBody>
+      </p:sp>
       <p:pic>
         <p:nvPicPr>
-          <p:cNvPr id="26" name="Image 4" descr="preencoded.png">    </p:cNvPr>
+          <p:cNvPr id="36" name="Image 4" descr="preencoded.png">    </p:cNvPr>
           <p:cNvPicPr>
             <a:picLocks noChangeAspect="1"/>
           </p:cNvPicPr>
@@ -16709,8 +17029,8 @@
         </p:blipFill>
         <p:spPr>
           <a:xfrm>
-            <a:off x="3310128" y="3054096"/>
-            <a:ext cx="347472" cy="347472"/>
+            <a:off x="256032" y="3072384"/>
+            <a:ext cx="310896" cy="310896"/>
           </a:xfrm>
           <a:prstGeom prst="rect">
             <a:avLst/>
@@ -16719,14 +17039,14 @@
       </p:pic>
       <p:sp>
         <p:nvSpPr>
-          <p:cNvPr id="27" name="Text 20"/>
-          <p:cNvSpPr/>
-          <p:nvPr/>
-        </p:nvSpPr>
-        <p:spPr>
-          <a:xfrm>
-            <a:off x="3749040" y="2999232"/>
-            <a:ext cx="2057400" cy="457200"/>
+          <p:cNvPr id="37" name="Text 30"/>
+          <p:cNvSpPr/>
+          <p:nvPr/>
+        </p:nvSpPr>
+        <p:spPr>
+          <a:xfrm>
+            <a:off x="621792" y="3017520"/>
+            <a:ext cx="950976" cy="402336"/>
           </a:xfrm>
           <a:prstGeom prst="rect">
             <a:avLst/>
@@ -16742,7 +17062,7 @@
               <a:buNone/>
             </a:pPr>
             <a:r>
-              <a:rPr lang="en-US" sz="1050" b="1" dirty="0">
+              <a:rPr lang="en-US" sz="950" b="1" dirty="0">
                 <a:solidFill>
                   <a:srgbClr val="06185F"/>
                 </a:solidFill>
@@ -16750,22 +17070,22 @@
                 <a:ea typeface="Calibri" pitchFamily="34" charset="-122"/>
                 <a:cs typeface="Calibri" pitchFamily="34" charset="-120"/>
               </a:rPr>
-              <a:t>Customer Sentiment Engine</a:t>
-            </a:r>
-            <a:endParaRPr lang="en-US" sz="1050" dirty="0"/>
-          </a:p>
-        </p:txBody>
-      </p:sp>
-      <p:sp>
-        <p:nvSpPr>
-          <p:cNvPr id="28" name="Text 21"/>
-          <p:cNvSpPr/>
-          <p:nvPr/>
-        </p:nvSpPr>
-        <p:spPr>
-          <a:xfrm>
-            <a:off x="3291840" y="3529584"/>
-            <a:ext cx="2487168" cy="1115568"/>
+              <a:t>Deposit Runoff Forecasting</a:t>
+            </a:r>
+            <a:endParaRPr lang="en-US" sz="950" dirty="0"/>
+          </a:p>
+        </p:txBody>
+      </p:sp>
+      <p:sp>
+        <p:nvSpPr>
+          <p:cNvPr id="38" name="Text 31"/>
+          <p:cNvSpPr/>
+          <p:nvPr/>
+        </p:nvSpPr>
+        <p:spPr>
+          <a:xfrm>
+            <a:off x="237744" y="3493008"/>
+            <a:ext cx="1865376" cy="1225296"/>
           </a:xfrm>
           <a:prstGeom prst="rect">
             <a:avLst/>
@@ -16781,7 +17101,7 @@
               <a:buNone/>
             </a:pPr>
             <a:r>
-              <a:rPr lang="en-US" sz="1000" dirty="0">
+              <a:rPr lang="en-US" sz="900" dirty="0">
                 <a:solidFill>
                   <a:srgbClr val="575A5D"/>
                 </a:solidFill>
@@ -16789,22 +17109,22 @@
                 <a:ea typeface="Calibri" pitchFamily="34" charset="-122"/>
                 <a:cs typeface="Calibri" pitchFamily="34" charset="-120"/>
               </a:rPr>
-              <a:t>NLP analysis of call transcripts and CFPB complaints to generate real-time CX health scores — helping FIs identify and route at-risk relationships before escalation.</a:t>
-            </a:r>
-            <a:endParaRPr lang="en-US" sz="1000" dirty="0"/>
-          </a:p>
-        </p:txBody>
-      </p:sp>
-      <p:sp>
-        <p:nvSpPr>
-          <p:cNvPr id="29" name="Shape 22"/>
-          <p:cNvSpPr/>
-          <p:nvPr/>
-        </p:nvSpPr>
-        <p:spPr>
-          <a:xfrm>
-            <a:off x="6035040" y="2871216"/>
-            <a:ext cx="2743200" cy="1901952"/>
+              <a:t>Portfolio-level deposit attrition prediction to support FI clients' ALM, liquidity stress testing, and treasury planning with 90-day forward visibility.</a:t>
+            </a:r>
+            <a:endParaRPr lang="en-US" sz="900" dirty="0"/>
+          </a:p>
+        </p:txBody>
+      </p:sp>
+      <p:sp>
+        <p:nvSpPr>
+          <p:cNvPr id="39" name="Shape 32"/>
+          <p:cNvSpPr/>
+          <p:nvPr/>
+        </p:nvSpPr>
+        <p:spPr>
+          <a:xfrm>
+            <a:off x="2350008" y="2889504"/>
+            <a:ext cx="2084832" cy="1938528"/>
           </a:xfrm>
           <a:prstGeom prst="rect">
             <a:avLst/>
@@ -16829,32 +17149,96 @@
       </p:sp>
       <p:sp>
         <p:nvSpPr>
-          <p:cNvPr id="30" name="Shape 23"/>
-          <p:cNvSpPr/>
-          <p:nvPr/>
-        </p:nvSpPr>
-        <p:spPr>
-          <a:xfrm>
-            <a:off x="6035040" y="2871216"/>
-            <a:ext cx="2743200" cy="73152"/>
-          </a:xfrm>
-          <a:prstGeom prst="rect">
-            <a:avLst/>
-          </a:prstGeom>
-          <a:solidFill>
-            <a:srgbClr val="0D2E7A"/>
+          <p:cNvPr id="40" name="Shape 33"/>
+          <p:cNvSpPr/>
+          <p:nvPr/>
+        </p:nvSpPr>
+        <p:spPr>
+          <a:xfrm>
+            <a:off x="2350008" y="2889504"/>
+            <a:ext cx="2084832" cy="73152"/>
+          </a:xfrm>
+          <a:prstGeom prst="rect">
+            <a:avLst/>
+          </a:prstGeom>
+          <a:solidFill>
+            <a:srgbClr val="575A5D"/>
           </a:solidFill>
           <a:ln w="12700">
             <a:solidFill>
-              <a:srgbClr val="0D2E7A"/>
+              <a:srgbClr val="575A5D"/>
             </a:solidFill>
             <a:prstDash val="solid"/>
           </a:ln>
         </p:spPr>
       </p:sp>
+      <p:sp>
+        <p:nvSpPr>
+          <p:cNvPr id="41" name="Shape 34"/>
+          <p:cNvSpPr/>
+          <p:nvPr/>
+        </p:nvSpPr>
+        <p:spPr>
+          <a:xfrm>
+            <a:off x="3831336" y="3017520"/>
+            <a:ext cx="548640" cy="182880"/>
+          </a:xfrm>
+          <a:prstGeom prst="rect">
+            <a:avLst/>
+          </a:prstGeom>
+          <a:solidFill>
+            <a:srgbClr val="575A5D"/>
+          </a:solidFill>
+          <a:ln w="12700">
+            <a:solidFill>
+              <a:srgbClr val="575A5D"/>
+            </a:solidFill>
+            <a:prstDash val="solid"/>
+          </a:ln>
+        </p:spPr>
+      </p:sp>
+      <p:sp>
+        <p:nvSpPr>
+          <p:cNvPr id="42" name="Text 35"/>
+          <p:cNvSpPr/>
+          <p:nvPr/>
+        </p:nvSpPr>
+        <p:spPr>
+          <a:xfrm>
+            <a:off x="3831336" y="3017520"/>
+            <a:ext cx="548640" cy="182880"/>
+          </a:xfrm>
+          <a:prstGeom prst="rect">
+            <a:avLst/>
+          </a:prstGeom>
+          <a:noFill/>
+          <a:ln/>
+        </p:spPr>
+        <p:txBody>
+          <a:bodyPr wrap="square" lIns="0" tIns="0" rIns="0" bIns="0" rtlCol="0" anchor="ctr"/>
+          <a:lstStyle/>
+          <a:p>
+            <a:pPr algn="ctr" indent="0" marL="0">
+              <a:buNone/>
+            </a:pPr>
+            <a:r>
+              <a:rPr lang="en-US" sz="650" b="1" dirty="0">
+                <a:solidFill>
+                  <a:srgbClr val="FFFFFF"/>
+                </a:solidFill>
+                <a:latin typeface="Calibri" pitchFamily="34" charset="0"/>
+                <a:ea typeface="Calibri" pitchFamily="34" charset="-122"/>
+                <a:cs typeface="Calibri" pitchFamily="34" charset="-120"/>
+              </a:rPr>
+              <a:t>Year 2</a:t>
+            </a:r>
+            <a:endParaRPr lang="en-US" sz="650" dirty="0"/>
+          </a:p>
+        </p:txBody>
+      </p:sp>
       <p:pic>
         <p:nvPicPr>
-          <p:cNvPr id="31" name="Image 5" descr="preencoded.png">    </p:cNvPr>
+          <p:cNvPr id="43" name="Image 5" descr="preencoded.png">    </p:cNvPr>
           <p:cNvPicPr>
             <a:picLocks noChangeAspect="1"/>
           </p:cNvPicPr>
@@ -16868,8 +17252,8 @@
         </p:blipFill>
         <p:spPr>
           <a:xfrm>
-            <a:off x="6190488" y="3054096"/>
-            <a:ext cx="347472" cy="347472"/>
+            <a:off x="2478024" y="3072384"/>
+            <a:ext cx="310896" cy="310896"/>
           </a:xfrm>
           <a:prstGeom prst="rect">
             <a:avLst/>
@@ -16878,14 +17262,14 @@
       </p:pic>
       <p:sp>
         <p:nvSpPr>
-          <p:cNvPr id="32" name="Text 24"/>
-          <p:cNvSpPr/>
-          <p:nvPr/>
-        </p:nvSpPr>
-        <p:spPr>
-          <a:xfrm>
-            <a:off x="6629400" y="2999232"/>
-            <a:ext cx="2057400" cy="457200"/>
+          <p:cNvPr id="44" name="Text 36"/>
+          <p:cNvSpPr/>
+          <p:nvPr/>
+        </p:nvSpPr>
+        <p:spPr>
+          <a:xfrm>
+            <a:off x="2843784" y="3017520"/>
+            <a:ext cx="950976" cy="402336"/>
           </a:xfrm>
           <a:prstGeom prst="rect">
             <a:avLst/>
@@ -16901,7 +17285,7 @@
               <a:buNone/>
             </a:pPr>
             <a:r>
-              <a:rPr lang="en-US" sz="1050" b="1" dirty="0">
+              <a:rPr lang="en-US" sz="950" b="1" dirty="0">
                 <a:solidFill>
                   <a:srgbClr val="06185F"/>
                 </a:solidFill>
@@ -16909,22 +17293,468 @@
                 <a:ea typeface="Calibri" pitchFamily="34" charset="-122"/>
                 <a:cs typeface="Calibri" pitchFamily="34" charset="-120"/>
               </a:rPr>
+              <a:t>Overdraft Prediction</a:t>
+            </a:r>
+            <a:endParaRPr lang="en-US" sz="950" dirty="0"/>
+          </a:p>
+        </p:txBody>
+      </p:sp>
+      <p:sp>
+        <p:nvSpPr>
+          <p:cNvPr id="45" name="Text 37"/>
+          <p:cNvSpPr/>
+          <p:nvPr/>
+        </p:nvSpPr>
+        <p:spPr>
+          <a:xfrm>
+            <a:off x="2459736" y="3493008"/>
+            <a:ext cx="1865376" cy="1225296"/>
+          </a:xfrm>
+          <a:prstGeom prst="rect">
+            <a:avLst/>
+          </a:prstGeom>
+          <a:noFill/>
+          <a:ln/>
+        </p:spPr>
+        <p:txBody>
+          <a:bodyPr wrap="square" lIns="0" tIns="0" rIns="0" bIns="0" rtlCol="0" anchor="ctr"/>
+          <a:lstStyle/>
+          <a:p>
+            <a:pPr indent="0" marL="0">
+              <a:buNone/>
+            </a:pPr>
+            <a:r>
+              <a:rPr lang="en-US" sz="900" dirty="0">
+                <a:solidFill>
+                  <a:srgbClr val="575A5D"/>
+                </a:solidFill>
+                <a:latin typeface="Calibri" pitchFamily="34" charset="0"/>
+                <a:ea typeface="Calibri" pitchFamily="34" charset="-122"/>
+                <a:cs typeface="Calibri" pitchFamily="34" charset="-120"/>
+              </a:rPr>
+              <a:t>Anticipate overdraft events before they occur and surface proactive micro-loan offers or alerts in Banno — improving CX while reducing NSF fee risk for FIs.</a:t>
+            </a:r>
+            <a:endParaRPr lang="en-US" sz="900" dirty="0"/>
+          </a:p>
+        </p:txBody>
+      </p:sp>
+      <p:sp>
+        <p:nvSpPr>
+          <p:cNvPr id="46" name="Shape 38"/>
+          <p:cNvSpPr/>
+          <p:nvPr/>
+        </p:nvSpPr>
+        <p:spPr>
+          <a:xfrm>
+            <a:off x="4572000" y="2889504"/>
+            <a:ext cx="2084832" cy="1938528"/>
+          </a:xfrm>
+          <a:prstGeom prst="rect">
+            <a:avLst/>
+          </a:prstGeom>
+          <a:solidFill>
+            <a:srgbClr val="FFFFFF"/>
+          </a:solidFill>
+          <a:ln w="12700">
+            <a:solidFill>
+              <a:srgbClr val="E7ECF0"/>
+            </a:solidFill>
+            <a:prstDash val="solid"/>
+          </a:ln>
+          <a:effectLst>
+            <a:outerShdw sx="100000" sy="100000" kx="0" ky="0" algn="bl" rotWithShape="0" blurRad="101600" dist="38100" dir="8100000">
+              <a:srgbClr val="000000">
+                <a:alpha val="10000"/>
+              </a:srgbClr>
+            </a:outerShdw>
+          </a:effectLst>
+        </p:spPr>
+      </p:sp>
+      <p:sp>
+        <p:nvSpPr>
+          <p:cNvPr id="47" name="Shape 39"/>
+          <p:cNvSpPr/>
+          <p:nvPr/>
+        </p:nvSpPr>
+        <p:spPr>
+          <a:xfrm>
+            <a:off x="4572000" y="2889504"/>
+            <a:ext cx="2084832" cy="73152"/>
+          </a:xfrm>
+          <a:prstGeom prst="rect">
+            <a:avLst/>
+          </a:prstGeom>
+          <a:solidFill>
+            <a:srgbClr val="0B68D4"/>
+          </a:solidFill>
+          <a:ln w="12700">
+            <a:solidFill>
+              <a:srgbClr val="0B68D4"/>
+            </a:solidFill>
+            <a:prstDash val="solid"/>
+          </a:ln>
+        </p:spPr>
+      </p:sp>
+      <p:sp>
+        <p:nvSpPr>
+          <p:cNvPr id="48" name="Shape 40"/>
+          <p:cNvSpPr/>
+          <p:nvPr/>
+        </p:nvSpPr>
+        <p:spPr>
+          <a:xfrm>
+            <a:off x="6053328" y="3017520"/>
+            <a:ext cx="548640" cy="182880"/>
+          </a:xfrm>
+          <a:prstGeom prst="rect">
+            <a:avLst/>
+          </a:prstGeom>
+          <a:solidFill>
+            <a:srgbClr val="0B68D4"/>
+          </a:solidFill>
+          <a:ln w="12700">
+            <a:solidFill>
+              <a:srgbClr val="0B68D4"/>
+            </a:solidFill>
+            <a:prstDash val="solid"/>
+          </a:ln>
+        </p:spPr>
+      </p:sp>
+      <p:sp>
+        <p:nvSpPr>
+          <p:cNvPr id="49" name="Text 41"/>
+          <p:cNvSpPr/>
+          <p:nvPr/>
+        </p:nvSpPr>
+        <p:spPr>
+          <a:xfrm>
+            <a:off x="6053328" y="3017520"/>
+            <a:ext cx="548640" cy="182880"/>
+          </a:xfrm>
+          <a:prstGeom prst="rect">
+            <a:avLst/>
+          </a:prstGeom>
+          <a:noFill/>
+          <a:ln/>
+        </p:spPr>
+        <p:txBody>
+          <a:bodyPr wrap="square" lIns="0" tIns="0" rIns="0" bIns="0" rtlCol="0" anchor="ctr"/>
+          <a:lstStyle/>
+          <a:p>
+            <a:pPr algn="ctr" indent="0" marL="0">
+              <a:buNone/>
+            </a:pPr>
+            <a:r>
+              <a:rPr lang="en-US" sz="650" b="1" dirty="0">
+                <a:solidFill>
+                  <a:srgbClr val="FFFFFF"/>
+                </a:solidFill>
+                <a:latin typeface="Calibri" pitchFamily="34" charset="0"/>
+                <a:ea typeface="Calibri" pitchFamily="34" charset="-122"/>
+                <a:cs typeface="Calibri" pitchFamily="34" charset="-120"/>
+              </a:rPr>
+              <a:t>Year 2</a:t>
+            </a:r>
+            <a:endParaRPr lang="en-US" sz="650" dirty="0"/>
+          </a:p>
+        </p:txBody>
+      </p:sp>
+      <p:pic>
+        <p:nvPicPr>
+          <p:cNvPr id="50" name="Image 6" descr="preencoded.png">    </p:cNvPr>
+          <p:cNvPicPr>
+            <a:picLocks noChangeAspect="1"/>
+          </p:cNvPicPr>
+          <p:nvPr/>
+        </p:nvPicPr>
+        <p:blipFill>
+          <a:blip r:embed="rId7"/>
+          <a:stretch>
+            <a:fillRect/>
+          </a:stretch>
+        </p:blipFill>
+        <p:spPr>
+          <a:xfrm>
+            <a:off x="4700016" y="3072384"/>
+            <a:ext cx="310896" cy="310896"/>
+          </a:xfrm>
+          <a:prstGeom prst="rect">
+            <a:avLst/>
+          </a:prstGeom>
+        </p:spPr>
+      </p:pic>
+      <p:sp>
+        <p:nvSpPr>
+          <p:cNvPr id="51" name="Text 42"/>
+          <p:cNvSpPr/>
+          <p:nvPr/>
+        </p:nvSpPr>
+        <p:spPr>
+          <a:xfrm>
+            <a:off x="5065776" y="3017520"/>
+            <a:ext cx="950976" cy="402336"/>
+          </a:xfrm>
+          <a:prstGeom prst="rect">
+            <a:avLst/>
+          </a:prstGeom>
+          <a:noFill/>
+          <a:ln/>
+        </p:spPr>
+        <p:txBody>
+          <a:bodyPr wrap="square" lIns="0" tIns="0" rIns="0" bIns="0" rtlCol="0" anchor="ctr"/>
+          <a:lstStyle/>
+          <a:p>
+            <a:pPr indent="0" marL="0">
+              <a:buNone/>
+            </a:pPr>
+            <a:r>
+              <a:rPr lang="en-US" sz="950" b="1" dirty="0">
+                <a:solidFill>
+                  <a:srgbClr val="06185F"/>
+                </a:solidFill>
+                <a:latin typeface="Calibri" pitchFamily="34" charset="0"/>
+                <a:ea typeface="Calibri" pitchFamily="34" charset="-122"/>
+                <a:cs typeface="Calibri" pitchFamily="34" charset="-120"/>
+              </a:rPr>
+              <a:t>Customer Sentiment Engine</a:t>
+            </a:r>
+            <a:endParaRPr lang="en-US" sz="950" dirty="0"/>
+          </a:p>
+        </p:txBody>
+      </p:sp>
+      <p:sp>
+        <p:nvSpPr>
+          <p:cNvPr id="52" name="Text 43"/>
+          <p:cNvSpPr/>
+          <p:nvPr/>
+        </p:nvSpPr>
+        <p:spPr>
+          <a:xfrm>
+            <a:off x="4681728" y="3493008"/>
+            <a:ext cx="1865376" cy="1225296"/>
+          </a:xfrm>
+          <a:prstGeom prst="rect">
+            <a:avLst/>
+          </a:prstGeom>
+          <a:noFill/>
+          <a:ln/>
+        </p:spPr>
+        <p:txBody>
+          <a:bodyPr wrap="square" lIns="0" tIns="0" rIns="0" bIns="0" rtlCol="0" anchor="ctr"/>
+          <a:lstStyle/>
+          <a:p>
+            <a:pPr indent="0" marL="0">
+              <a:buNone/>
+            </a:pPr>
+            <a:r>
+              <a:rPr lang="en-US" sz="900" dirty="0">
+                <a:solidFill>
+                  <a:srgbClr val="575A5D"/>
+                </a:solidFill>
+                <a:latin typeface="Calibri" pitchFamily="34" charset="0"/>
+                <a:ea typeface="Calibri" pitchFamily="34" charset="-122"/>
+                <a:cs typeface="Calibri" pitchFamily="34" charset="-120"/>
+              </a:rPr>
+              <a:t>NLP analysis of call transcripts and CFPB complaints to generate real-time CX health scores — helping FIs identify and route at-risk relationships before escalation.</a:t>
+            </a:r>
+            <a:endParaRPr lang="en-US" sz="900" dirty="0"/>
+          </a:p>
+        </p:txBody>
+      </p:sp>
+      <p:sp>
+        <p:nvSpPr>
+          <p:cNvPr id="53" name="Shape 44"/>
+          <p:cNvSpPr/>
+          <p:nvPr/>
+        </p:nvSpPr>
+        <p:spPr>
+          <a:xfrm>
+            <a:off x="6793992" y="2889504"/>
+            <a:ext cx="2084832" cy="1938528"/>
+          </a:xfrm>
+          <a:prstGeom prst="rect">
+            <a:avLst/>
+          </a:prstGeom>
+          <a:solidFill>
+            <a:srgbClr val="FFFFFF"/>
+          </a:solidFill>
+          <a:ln w="12700">
+            <a:solidFill>
+              <a:srgbClr val="E7ECF0"/>
+            </a:solidFill>
+            <a:prstDash val="solid"/>
+          </a:ln>
+          <a:effectLst>
+            <a:outerShdw sx="100000" sy="100000" kx="0" ky="0" algn="bl" rotWithShape="0" blurRad="101600" dist="38100" dir="8100000">
+              <a:srgbClr val="000000">
+                <a:alpha val="10000"/>
+              </a:srgbClr>
+            </a:outerShdw>
+          </a:effectLst>
+        </p:spPr>
+      </p:sp>
+      <p:sp>
+        <p:nvSpPr>
+          <p:cNvPr id="54" name="Shape 45"/>
+          <p:cNvSpPr/>
+          <p:nvPr/>
+        </p:nvSpPr>
+        <p:spPr>
+          <a:xfrm>
+            <a:off x="6793992" y="2889504"/>
+            <a:ext cx="2084832" cy="73152"/>
+          </a:xfrm>
+          <a:prstGeom prst="rect">
+            <a:avLst/>
+          </a:prstGeom>
+          <a:solidFill>
+            <a:srgbClr val="0D2E7A"/>
+          </a:solidFill>
+          <a:ln w="12700">
+            <a:solidFill>
+              <a:srgbClr val="0D2E7A"/>
+            </a:solidFill>
+            <a:prstDash val="solid"/>
+          </a:ln>
+        </p:spPr>
+      </p:sp>
+      <p:sp>
+        <p:nvSpPr>
+          <p:cNvPr id="55" name="Shape 46"/>
+          <p:cNvSpPr/>
+          <p:nvPr/>
+        </p:nvSpPr>
+        <p:spPr>
+          <a:xfrm>
+            <a:off x="8275320" y="3017520"/>
+            <a:ext cx="548640" cy="182880"/>
+          </a:xfrm>
+          <a:prstGeom prst="rect">
+            <a:avLst/>
+          </a:prstGeom>
+          <a:solidFill>
+            <a:srgbClr val="0D2E7A"/>
+          </a:solidFill>
+          <a:ln w="12700">
+            <a:solidFill>
+              <a:srgbClr val="0D2E7A"/>
+            </a:solidFill>
+            <a:prstDash val="solid"/>
+          </a:ln>
+        </p:spPr>
+      </p:sp>
+      <p:sp>
+        <p:nvSpPr>
+          <p:cNvPr id="56" name="Text 47"/>
+          <p:cNvSpPr/>
+          <p:nvPr/>
+        </p:nvSpPr>
+        <p:spPr>
+          <a:xfrm>
+            <a:off x="8275320" y="3017520"/>
+            <a:ext cx="548640" cy="182880"/>
+          </a:xfrm>
+          <a:prstGeom prst="rect">
+            <a:avLst/>
+          </a:prstGeom>
+          <a:noFill/>
+          <a:ln/>
+        </p:spPr>
+        <p:txBody>
+          <a:bodyPr wrap="square" lIns="0" tIns="0" rIns="0" bIns="0" rtlCol="0" anchor="ctr"/>
+          <a:lstStyle/>
+          <a:p>
+            <a:pPr algn="ctr" indent="0" marL="0">
+              <a:buNone/>
+            </a:pPr>
+            <a:r>
+              <a:rPr lang="en-US" sz="650" b="1" dirty="0">
+                <a:solidFill>
+                  <a:srgbClr val="FFFFFF"/>
+                </a:solidFill>
+                <a:latin typeface="Calibri" pitchFamily="34" charset="0"/>
+                <a:ea typeface="Calibri" pitchFamily="34" charset="-122"/>
+                <a:cs typeface="Calibri" pitchFamily="34" charset="-120"/>
+              </a:rPr>
+              <a:t>Year 2</a:t>
+            </a:r>
+            <a:endParaRPr lang="en-US" sz="650" dirty="0"/>
+          </a:p>
+        </p:txBody>
+      </p:sp>
+      <p:pic>
+        <p:nvPicPr>
+          <p:cNvPr id="57" name="Image 7" descr="preencoded.png">    </p:cNvPr>
+          <p:cNvPicPr>
+            <a:picLocks noChangeAspect="1"/>
+          </p:cNvPicPr>
+          <p:nvPr/>
+        </p:nvPicPr>
+        <p:blipFill>
+          <a:blip r:embed="rId8"/>
+          <a:stretch>
+            <a:fillRect/>
+          </a:stretch>
+        </p:blipFill>
+        <p:spPr>
+          <a:xfrm>
+            <a:off x="6922008" y="3072384"/>
+            <a:ext cx="310896" cy="310896"/>
+          </a:xfrm>
+          <a:prstGeom prst="rect">
+            <a:avLst/>
+          </a:prstGeom>
+        </p:spPr>
+      </p:pic>
+      <p:sp>
+        <p:nvSpPr>
+          <p:cNvPr id="58" name="Text 48"/>
+          <p:cNvSpPr/>
+          <p:nvPr/>
+        </p:nvSpPr>
+        <p:spPr>
+          <a:xfrm>
+            <a:off x="7287768" y="3017520"/>
+            <a:ext cx="950976" cy="402336"/>
+          </a:xfrm>
+          <a:prstGeom prst="rect">
+            <a:avLst/>
+          </a:prstGeom>
+          <a:noFill/>
+          <a:ln/>
+        </p:spPr>
+        <p:txBody>
+          <a:bodyPr wrap="square" lIns="0" tIns="0" rIns="0" bIns="0" rtlCol="0" anchor="ctr"/>
+          <a:lstStyle/>
+          <a:p>
+            <a:pPr indent="0" marL="0">
+              <a:buNone/>
+            </a:pPr>
+            <a:r>
+              <a:rPr lang="en-US" sz="950" b="1" dirty="0">
+                <a:solidFill>
+                  <a:srgbClr val="06185F"/>
+                </a:solidFill>
+                <a:latin typeface="Calibri" pitchFamily="34" charset="0"/>
+                <a:ea typeface="Calibri" pitchFamily="34" charset="-122"/>
+                <a:cs typeface="Calibri" pitchFamily="34" charset="-120"/>
+              </a:rPr>
               <a:t>Next Best Action Platform</a:t>
             </a:r>
-            <a:endParaRPr lang="en-US" sz="1050" dirty="0"/>
-          </a:p>
-        </p:txBody>
-      </p:sp>
-      <p:sp>
-        <p:nvSpPr>
-          <p:cNvPr id="33" name="Text 25"/>
-          <p:cNvSpPr/>
-          <p:nvPr/>
-        </p:nvSpPr>
-        <p:spPr>
-          <a:xfrm>
-            <a:off x="6172200" y="3529584"/>
-            <a:ext cx="2487168" cy="1115568"/>
+            <a:endParaRPr lang="en-US" sz="950" dirty="0"/>
+          </a:p>
+        </p:txBody>
+      </p:sp>
+      <p:sp>
+        <p:nvSpPr>
+          <p:cNvPr id="59" name="Text 49"/>
+          <p:cNvSpPr/>
+          <p:nvPr/>
+        </p:nvSpPr>
+        <p:spPr>
+          <a:xfrm>
+            <a:off x="6903720" y="3493008"/>
+            <a:ext cx="1865376" cy="1225296"/>
           </a:xfrm>
           <a:prstGeom prst="rect">
             <a:avLst/>
@@ -16940,7 +17770,7 @@
               <a:buNone/>
             </a:pPr>
             <a:r>
-              <a:rPr lang="en-US" sz="1000" dirty="0">
+              <a:rPr lang="en-US" sz="900" dirty="0">
                 <a:solidFill>
                   <a:srgbClr val="575A5D"/>
                 </a:solidFill>
@@ -16950,19 +17780,19 @@
               </a:rPr>
               <a:t>Unified orchestration engine synthesizing all model outputs — churn score, LTV, propensity, sentiment — into a single ranked recommendation per customer per channel.</a:t>
             </a:r>
-            <a:endParaRPr lang="en-US" sz="1000" dirty="0"/>
-          </a:p>
-        </p:txBody>
-      </p:sp>
-      <p:sp>
-        <p:nvSpPr>
-          <p:cNvPr id="34" name="Text 26"/>
-          <p:cNvSpPr/>
-          <p:nvPr/>
-        </p:nvSpPr>
-        <p:spPr>
-          <a:xfrm>
-            <a:off x="365760" y="4846320"/>
+            <a:endParaRPr lang="en-US" sz="900" dirty="0"/>
+          </a:p>
+        </p:txBody>
+      </p:sp>
+      <p:sp>
+        <p:nvSpPr>
+          <p:cNvPr id="60" name="Text 50"/>
+          <p:cNvSpPr/>
+          <p:nvPr/>
+        </p:nvSpPr>
+        <p:spPr>
+          <a:xfrm>
+            <a:off x="365760" y="4773168"/>
             <a:ext cx="8412480" cy="256032"/>
           </a:xfrm>
           <a:prstGeom prst="rect">
@@ -16979,7 +17809,7 @@
               <a:buNone/>
             </a:pPr>
             <a:r>
-              <a:rPr lang="en-US" sz="950" i="1" dirty="0">
+              <a:rPr lang="en-US" sz="900" i="1" dirty="0">
                 <a:solidFill>
                   <a:srgbClr val="B6BBC0"/>
                 </a:solidFill>
@@ -16987,9 +17817,9 @@
                 <a:ea typeface="Calibri" pitchFamily="34" charset="-122"/>
                 <a:cs typeface="Calibri" pitchFamily="34" charset="-120"/>
               </a:rPr>
-              <a:t>These opportunities are sequenced for Year 2, contingent on successful Phase 1 delivery and continued investment approval.</a:t>
-            </a:r>
-            <a:endParaRPr lang="en-US" sz="950" dirty="0"/>
+              <a:t>Call Report AI and Account Opening LTV are Phase 2 promotions. Remaining six are Year 2 opportunities contingent on Phase 1 delivery and continued investment approval.</a:t>
+            </a:r>
+            <a:endParaRPr lang="en-US" sz="900" dirty="0"/>
           </a:p>
         </p:txBody>
       </p:sp>
@@ -32060,7 +32890,7 @@
                 <a:ea typeface="Calibri" pitchFamily="34" charset="-122"/>
                 <a:cs typeface="Calibri" pitchFamily="34" charset="-120"/>
               </a:rPr>
-              <a:t>JH Platform AI Application Suite — Eight Strategic Products</a:t>
+              <a:t>JH Platform AI — Six Core Applications</a:t>
             </a:r>
             <a:endParaRPr lang="en-US" sz="2200" dirty="0"/>
           </a:p>
@@ -32074,8 +32904,8 @@
         </p:nvSpPr>
         <p:spPr>
           <a:xfrm>
-            <a:off x="128016" y="777240"/>
-            <a:ext cx="2084832" cy="1938528"/>
+            <a:off x="320040" y="777240"/>
+            <a:ext cx="2706624" cy="2011680"/>
           </a:xfrm>
           <a:prstGeom prst="rect">
             <a:avLst/>
@@ -32106,8 +32936,8 @@
         </p:nvSpPr>
         <p:spPr>
           <a:xfrm>
-            <a:off x="128016" y="777240"/>
-            <a:ext cx="2084832" cy="585216"/>
+            <a:off x="320040" y="777240"/>
+            <a:ext cx="2706624" cy="658368"/>
           </a:xfrm>
           <a:prstGeom prst="rect">
             <a:avLst/>
@@ -32139,8 +32969,8 @@
         </p:blipFill>
         <p:spPr>
           <a:xfrm>
-            <a:off x="237744" y="886968"/>
-            <a:ext cx="347472" cy="347472"/>
+            <a:off x="457200" y="905256"/>
+            <a:ext cx="384048" cy="384048"/>
           </a:xfrm>
           <a:prstGeom prst="rect">
             <a:avLst/>
@@ -32155,8 +32985,8 @@
         </p:nvSpPr>
         <p:spPr>
           <a:xfrm>
-            <a:off x="640080" y="832104"/>
-            <a:ext cx="1499616" cy="512064"/>
+            <a:off x="914400" y="850392"/>
+            <a:ext cx="2020824" cy="566928"/>
           </a:xfrm>
           <a:prstGeom prst="rect">
             <a:avLst/>
@@ -32172,7 +33002,7 @@
               <a:buNone/>
             </a:pPr>
             <a:r>
-              <a:rPr lang="en-US" sz="1000" b="1" dirty="0">
+              <a:rPr lang="en-US" sz="1150" b="1" dirty="0">
                 <a:solidFill>
                   <a:srgbClr val="FFFFFF"/>
                 </a:solidFill>
@@ -32182,14 +33012,14 @@
               </a:rPr>
               <a:t>Attrition /</a:t>
             </a:r>
-            <a:endParaRPr lang="en-US" sz="1000" dirty="0"/>
+            <a:endParaRPr lang="en-US" sz="1150" dirty="0"/>
           </a:p>
           <a:p>
             <a:pPr indent="0" marL="0">
               <a:buNone/>
             </a:pPr>
             <a:r>
-              <a:rPr lang="en-US" sz="1000" b="1" dirty="0">
+              <a:rPr lang="en-US" sz="1150" b="1" dirty="0">
                 <a:solidFill>
                   <a:srgbClr val="FFFFFF"/>
                 </a:solidFill>
@@ -32199,7 +33029,7 @@
               </a:rPr>
               <a:t>Churn Mediation</a:t>
             </a:r>
-            <a:endParaRPr lang="en-US" sz="1000" dirty="0"/>
+            <a:endParaRPr lang="en-US" sz="1150" dirty="0"/>
           </a:p>
         </p:txBody>
       </p:sp>
@@ -32211,8 +33041,8 @@
         </p:nvSpPr>
         <p:spPr>
           <a:xfrm>
-            <a:off x="219456" y="1435608"/>
-            <a:ext cx="1901952" cy="1170432"/>
+            <a:off x="429768" y="1508760"/>
+            <a:ext cx="2487168" cy="1170432"/>
           </a:xfrm>
           <a:prstGeom prst="rect">
             <a:avLst/>
@@ -32228,7 +33058,7 @@
               <a:buNone/>
             </a:pPr>
             <a:r>
-              <a:rPr lang="en-US" sz="950" dirty="0">
+              <a:rPr lang="en-US" sz="1050" dirty="0">
                 <a:solidFill>
                   <a:srgbClr val="575A5D"/>
                 </a:solidFill>
@@ -32238,7 +33068,7 @@
               </a:rPr>
               <a:t>ML scoring to identify at-risk FI customers weekly and power proactive retention workflows before churn occurs.</a:t>
             </a:r>
-            <a:endParaRPr lang="en-US" sz="950" dirty="0"/>
+            <a:endParaRPr lang="en-US" sz="1050" dirty="0"/>
           </a:p>
         </p:txBody>
       </p:sp>
@@ -32250,8 +33080,8 @@
         </p:nvSpPr>
         <p:spPr>
           <a:xfrm>
-            <a:off x="2350008" y="777240"/>
-            <a:ext cx="2084832" cy="1938528"/>
+            <a:off x="3172968" y="777240"/>
+            <a:ext cx="2706624" cy="2011680"/>
           </a:xfrm>
           <a:prstGeom prst="rect">
             <a:avLst/>
@@ -32282,8 +33112,8 @@
         </p:nvSpPr>
         <p:spPr>
           <a:xfrm>
-            <a:off x="2350008" y="777240"/>
-            <a:ext cx="2084832" cy="585216"/>
+            <a:off x="3172968" y="777240"/>
+            <a:ext cx="2706624" cy="658368"/>
           </a:xfrm>
           <a:prstGeom prst="rect">
             <a:avLst/>
@@ -32315,8 +33145,8 @@
         </p:blipFill>
         <p:spPr>
           <a:xfrm>
-            <a:off x="2459736" y="886968"/>
-            <a:ext cx="347472" cy="347472"/>
+            <a:off x="3310128" y="905256"/>
+            <a:ext cx="384048" cy="384048"/>
           </a:xfrm>
           <a:prstGeom prst="rect">
             <a:avLst/>
@@ -32331,8 +33161,8 @@
         </p:nvSpPr>
         <p:spPr>
           <a:xfrm>
-            <a:off x="2862072" y="832104"/>
-            <a:ext cx="1499616" cy="512064"/>
+            <a:off x="3767328" y="850392"/>
+            <a:ext cx="2020824" cy="566928"/>
           </a:xfrm>
           <a:prstGeom prst="rect">
             <a:avLst/>
@@ -32348,7 +33178,7 @@
               <a:buNone/>
             </a:pPr>
             <a:r>
-              <a:rPr lang="en-US" sz="1000" b="1" dirty="0">
+              <a:rPr lang="en-US" sz="1150" b="1" dirty="0">
                 <a:solidFill>
                   <a:srgbClr val="FFFFFF"/>
                 </a:solidFill>
@@ -32358,14 +33188,14 @@
               </a:rPr>
               <a:t>Zelle Memo</a:t>
             </a:r>
-            <a:endParaRPr lang="en-US" sz="1000" dirty="0"/>
+            <a:endParaRPr lang="en-US" sz="1150" dirty="0"/>
           </a:p>
           <a:p>
             <a:pPr indent="0" marL="0">
               <a:buNone/>
             </a:pPr>
             <a:r>
-              <a:rPr lang="en-US" sz="1000" b="1" dirty="0">
+              <a:rPr lang="en-US" sz="1150" b="1" dirty="0">
                 <a:solidFill>
                   <a:srgbClr val="FFFFFF"/>
                 </a:solidFill>
@@ -32375,7 +33205,7 @@
               </a:rPr>
               <a:t>Intelligence</a:t>
             </a:r>
-            <a:endParaRPr lang="en-US" sz="1000" dirty="0"/>
+            <a:endParaRPr lang="en-US" sz="1150" dirty="0"/>
           </a:p>
         </p:txBody>
       </p:sp>
@@ -32387,8 +33217,8 @@
         </p:nvSpPr>
         <p:spPr>
           <a:xfrm>
-            <a:off x="2441448" y="1435608"/>
-            <a:ext cx="1901952" cy="1170432"/>
+            <a:off x="3282696" y="1508760"/>
+            <a:ext cx="2487168" cy="1170432"/>
           </a:xfrm>
           <a:prstGeom prst="rect">
             <a:avLst/>
@@ -32404,7 +33234,7 @@
               <a:buNone/>
             </a:pPr>
             <a:r>
-              <a:rPr lang="en-US" sz="950" dirty="0">
+              <a:rPr lang="en-US" sz="1050" dirty="0">
                 <a:solidFill>
                   <a:srgbClr val="575A5D"/>
                 </a:solidFill>
@@ -32414,7 +33244,7 @@
               </a:rPr>
               <a:t>NLP pipeline to classify Zelle memos for fraud patterns, elder abuse, and compliance flags — automatically.</a:t>
             </a:r>
-            <a:endParaRPr lang="en-US" sz="950" dirty="0"/>
+            <a:endParaRPr lang="en-US" sz="1050" dirty="0"/>
           </a:p>
         </p:txBody>
       </p:sp>
@@ -32426,8 +33256,8 @@
         </p:nvSpPr>
         <p:spPr>
           <a:xfrm>
-            <a:off x="4572000" y="777240"/>
-            <a:ext cx="2084832" cy="1938528"/>
+            <a:off x="6025896" y="777240"/>
+            <a:ext cx="2706624" cy="2011680"/>
           </a:xfrm>
           <a:prstGeom prst="rect">
             <a:avLst/>
@@ -32458,8 +33288,8 @@
         </p:nvSpPr>
         <p:spPr>
           <a:xfrm>
-            <a:off x="4572000" y="777240"/>
-            <a:ext cx="2084832" cy="585216"/>
+            <a:off x="6025896" y="777240"/>
+            <a:ext cx="2706624" cy="658368"/>
           </a:xfrm>
           <a:prstGeom prst="rect">
             <a:avLst/>
@@ -32491,8 +33321,8 @@
         </p:blipFill>
         <p:spPr>
           <a:xfrm>
-            <a:off x="4681728" y="886968"/>
-            <a:ext cx="347472" cy="347472"/>
+            <a:off x="6163056" y="905256"/>
+            <a:ext cx="384048" cy="384048"/>
           </a:xfrm>
           <a:prstGeom prst="rect">
             <a:avLst/>
@@ -32507,8 +33337,8 @@
         </p:nvSpPr>
         <p:spPr>
           <a:xfrm>
-            <a:off x="5084064" y="832104"/>
-            <a:ext cx="1499616" cy="512064"/>
+            <a:off x="6620256" y="850392"/>
+            <a:ext cx="2020824" cy="566928"/>
           </a:xfrm>
           <a:prstGeom prst="rect">
             <a:avLst/>
@@ -32524,7 +33354,7 @@
               <a:buNone/>
             </a:pPr>
             <a:r>
-              <a:rPr lang="en-US" sz="1000" b="1" dirty="0">
+              <a:rPr lang="en-US" sz="1150" b="1" dirty="0">
                 <a:solidFill>
                   <a:srgbClr val="FFFFFF"/>
                 </a:solidFill>
@@ -32534,14 +33364,14 @@
               </a:rPr>
               <a:t>Anomaly</a:t>
             </a:r>
-            <a:endParaRPr lang="en-US" sz="1000" dirty="0"/>
+            <a:endParaRPr lang="en-US" sz="1150" dirty="0"/>
           </a:p>
           <a:p>
             <a:pPr indent="0" marL="0">
               <a:buNone/>
             </a:pPr>
             <a:r>
-              <a:rPr lang="en-US" sz="1000" b="1" dirty="0">
+              <a:rPr lang="en-US" sz="1150" b="1" dirty="0">
                 <a:solidFill>
                   <a:srgbClr val="FFFFFF"/>
                 </a:solidFill>
@@ -32551,7 +33381,7 @@
               </a:rPr>
               <a:t>Detection</a:t>
             </a:r>
-            <a:endParaRPr lang="en-US" sz="1000" dirty="0"/>
+            <a:endParaRPr lang="en-US" sz="1150" dirty="0"/>
           </a:p>
         </p:txBody>
       </p:sp>
@@ -32563,8 +33393,8 @@
         </p:nvSpPr>
         <p:spPr>
           <a:xfrm>
-            <a:off x="4663440" y="1435608"/>
-            <a:ext cx="1901952" cy="1170432"/>
+            <a:off x="6135624" y="1508760"/>
+            <a:ext cx="2487168" cy="1170432"/>
           </a:xfrm>
           <a:prstGeom prst="rect">
             <a:avLst/>
@@ -32580,7 +33410,7 @@
               <a:buNone/>
             </a:pPr>
             <a:r>
-              <a:rPr lang="en-US" sz="950" dirty="0">
+              <a:rPr lang="en-US" sz="1050" dirty="0">
                 <a:solidFill>
                   <a:srgbClr val="575A5D"/>
                 </a:solidFill>
@@ -32590,7 +33420,7 @@
               </a:rPr>
               <a:t>Real-time ML detection of unusual account behavior and transaction patterns across JH-powered institutions.</a:t>
             </a:r>
-            <a:endParaRPr lang="en-US" sz="950" dirty="0"/>
+            <a:endParaRPr lang="en-US" sz="1050" dirty="0"/>
           </a:p>
         </p:txBody>
       </p:sp>
@@ -32602,8 +33432,8 @@
         </p:nvSpPr>
         <p:spPr>
           <a:xfrm>
-            <a:off x="6793992" y="777240"/>
-            <a:ext cx="2084832" cy="1938528"/>
+            <a:off x="320040" y="2953512"/>
+            <a:ext cx="2706624" cy="2011680"/>
           </a:xfrm>
           <a:prstGeom prst="rect">
             <a:avLst/>
@@ -32634,18 +33464,18 @@
         </p:nvSpPr>
         <p:spPr>
           <a:xfrm>
-            <a:off x="6793992" y="777240"/>
-            <a:ext cx="2084832" cy="585216"/>
-          </a:xfrm>
-          <a:prstGeom prst="rect">
-            <a:avLst/>
-          </a:prstGeom>
-          <a:solidFill>
-            <a:srgbClr val="575A5D"/>
+            <a:off x="320040" y="2953512"/>
+            <a:ext cx="2706624" cy="658368"/>
+          </a:xfrm>
+          <a:prstGeom prst="rect">
+            <a:avLst/>
+          </a:prstGeom>
+          <a:solidFill>
+            <a:srgbClr val="0D2E7A"/>
           </a:solidFill>
           <a:ln w="12700">
             <a:solidFill>
-              <a:srgbClr val="575A5D"/>
+              <a:srgbClr val="0D2E7A"/>
             </a:solidFill>
             <a:prstDash val="solid"/>
           </a:ln>
@@ -32667,8 +33497,8 @@
         </p:blipFill>
         <p:spPr>
           <a:xfrm>
-            <a:off x="6903720" y="886968"/>
-            <a:ext cx="347472" cy="347472"/>
+            <a:off x="457200" y="3081528"/>
+            <a:ext cx="384048" cy="384048"/>
           </a:xfrm>
           <a:prstGeom prst="rect">
             <a:avLst/>
@@ -32683,8 +33513,8 @@
         </p:nvSpPr>
         <p:spPr>
           <a:xfrm>
-            <a:off x="7306056" y="832104"/>
-            <a:ext cx="1499616" cy="512064"/>
+            <a:off x="914400" y="3026664"/>
+            <a:ext cx="2020824" cy="566928"/>
           </a:xfrm>
           <a:prstGeom prst="rect">
             <a:avLst/>
@@ -32700,7 +33530,7 @@
               <a:buNone/>
             </a:pPr>
             <a:r>
-              <a:rPr lang="en-US" sz="1000" b="1" dirty="0">
+              <a:rPr lang="en-US" sz="1150" b="1" dirty="0">
                 <a:solidFill>
                   <a:srgbClr val="FFFFFF"/>
                 </a:solidFill>
@@ -32708,9 +33538,26 @@
                 <a:ea typeface="Calibri" pitchFamily="34" charset="-122"/>
                 <a:cs typeface="Calibri" pitchFamily="34" charset="-120"/>
               </a:rPr>
-              <a:t>Call Report AI</a:t>
-            </a:r>
-            <a:endParaRPr lang="en-US" sz="1000" dirty="0"/>
+              <a:t>FI Decision</a:t>
+            </a:r>
+            <a:endParaRPr lang="en-US" sz="1150" dirty="0"/>
+          </a:p>
+          <a:p>
+            <a:pPr indent="0" marL="0">
+              <a:buNone/>
+            </a:pPr>
+            <a:r>
+              <a:rPr lang="en-US" sz="1150" b="1" dirty="0">
+                <a:solidFill>
+                  <a:srgbClr val="FFFFFF"/>
+                </a:solidFill>
+                <a:latin typeface="Calibri" pitchFamily="34" charset="0"/>
+                <a:ea typeface="Calibri" pitchFamily="34" charset="-122"/>
+                <a:cs typeface="Calibri" pitchFamily="34" charset="-120"/>
+              </a:rPr>
+              <a:t>Studio</a:t>
+            </a:r>
+            <a:endParaRPr lang="en-US" sz="1150" dirty="0"/>
           </a:p>
         </p:txBody>
       </p:sp>
@@ -32722,8 +33569,8 @@
         </p:nvSpPr>
         <p:spPr>
           <a:xfrm>
-            <a:off x="6885432" y="1435608"/>
-            <a:ext cx="1901952" cy="1170432"/>
+            <a:off x="429768" y="3685032"/>
+            <a:ext cx="2487168" cy="1170432"/>
           </a:xfrm>
           <a:prstGeom prst="rect">
             <a:avLst/>
@@ -32739,7 +33586,7 @@
               <a:buNone/>
             </a:pPr>
             <a:r>
-              <a:rPr lang="en-US" sz="950" dirty="0">
+              <a:rPr lang="en-US" sz="1050" dirty="0">
                 <a:solidFill>
                   <a:srgbClr val="575A5D"/>
                 </a:solidFill>
@@ -32747,9 +33594,9 @@
                 <a:ea typeface="Calibri" pitchFamily="34" charset="-122"/>
                 <a:cs typeface="Calibri" pitchFamily="34" charset="-120"/>
               </a:rPr>
-              <a:t>Claude-powered NCUA 5300 intelligence: market pulse, NL Q&amp;A, and peer benchmarking for CU executives. Aug/Sept 2026 launch.</a:t>
-            </a:r>
-            <a:endParaRPr lang="en-US" sz="950" dirty="0"/>
+              <a:t>No-code AutoML for FIs: upload data, train custom models, explain with SHAP, author rules, deploy as API, monitor drift.</a:t>
+            </a:r>
+            <a:endParaRPr lang="en-US" sz="1050" dirty="0"/>
           </a:p>
         </p:txBody>
       </p:sp>
@@ -32761,8 +33608,8 @@
         </p:nvSpPr>
         <p:spPr>
           <a:xfrm>
-            <a:off x="128016" y="2880360"/>
-            <a:ext cx="2084832" cy="1938528"/>
+            <a:off x="3172968" y="2953512"/>
+            <a:ext cx="2706624" cy="2011680"/>
           </a:xfrm>
           <a:prstGeom prst="rect">
             <a:avLst/>
@@ -32793,18 +33640,18 @@
         </p:nvSpPr>
         <p:spPr>
           <a:xfrm>
-            <a:off x="128016" y="2880360"/>
-            <a:ext cx="2084832" cy="585216"/>
-          </a:xfrm>
-          <a:prstGeom prst="rect">
-            <a:avLst/>
-          </a:prstGeom>
-          <a:solidFill>
-            <a:srgbClr val="0B68D4"/>
+            <a:off x="3172968" y="2953512"/>
+            <a:ext cx="2706624" cy="658368"/>
+          </a:xfrm>
+          <a:prstGeom prst="rect">
+            <a:avLst/>
+          </a:prstGeom>
+          <a:solidFill>
+            <a:srgbClr val="0A52C4"/>
           </a:solidFill>
           <a:ln w="12700">
             <a:solidFill>
-              <a:srgbClr val="0B68D4"/>
+              <a:srgbClr val="0A52C4"/>
             </a:solidFill>
             <a:prstDash val="solid"/>
           </a:ln>
@@ -32826,8 +33673,8 @@
         </p:blipFill>
         <p:spPr>
           <a:xfrm>
-            <a:off x="237744" y="2990088"/>
-            <a:ext cx="347472" cy="347472"/>
+            <a:off x="3310128" y="3081528"/>
+            <a:ext cx="384048" cy="384048"/>
           </a:xfrm>
           <a:prstGeom prst="rect">
             <a:avLst/>
@@ -32842,8 +33689,8 @@
         </p:nvSpPr>
         <p:spPr>
           <a:xfrm>
-            <a:off x="640080" y="2935224"/>
-            <a:ext cx="1499616" cy="512064"/>
+            <a:off x="3767328" y="3026664"/>
+            <a:ext cx="2020824" cy="566928"/>
           </a:xfrm>
           <a:prstGeom prst="rect">
             <a:avLst/>
@@ -32859,7 +33706,7 @@
               <a:buNone/>
             </a:pPr>
             <a:r>
-              <a:rPr lang="en-US" sz="1000" b="1" dirty="0">
+              <a:rPr lang="en-US" sz="1150" b="1" dirty="0">
                 <a:solidFill>
                   <a:srgbClr val="FFFFFF"/>
                 </a:solidFill>
@@ -32867,16 +33714,16 @@
                 <a:ea typeface="Calibri" pitchFamily="34" charset="-122"/>
                 <a:cs typeface="Calibri" pitchFamily="34" charset="-120"/>
               </a:rPr>
-              <a:t>Account Opening</a:t>
-            </a:r>
-            <a:endParaRPr lang="en-US" sz="1000" dirty="0"/>
+              <a:t>Personal-as-</a:t>
+            </a:r>
+            <a:endParaRPr lang="en-US" sz="1150" dirty="0"/>
           </a:p>
           <a:p>
             <a:pPr indent="0" marL="0">
               <a:buNone/>
             </a:pPr>
             <a:r>
-              <a:rPr lang="en-US" sz="1000" b="1" dirty="0">
+              <a:rPr lang="en-US" sz="1150" b="1" dirty="0">
                 <a:solidFill>
                   <a:srgbClr val="FFFFFF"/>
                 </a:solidFill>
@@ -32884,9 +33731,9 @@
                 <a:ea typeface="Calibri" pitchFamily="34" charset="-122"/>
                 <a:cs typeface="Calibri" pitchFamily="34" charset="-120"/>
               </a:rPr>
-              <a:t>Lifetime Value</a:t>
-            </a:r>
-            <a:endParaRPr lang="en-US" sz="1000" dirty="0"/>
+              <a:t>Commercial Detection</a:t>
+            </a:r>
+            <a:endParaRPr lang="en-US" sz="1150" dirty="0"/>
           </a:p>
         </p:txBody>
       </p:sp>
@@ -32898,8 +33745,8 @@
         </p:nvSpPr>
         <p:spPr>
           <a:xfrm>
-            <a:off x="219456" y="3538728"/>
-            <a:ext cx="1901952" cy="1170432"/>
+            <a:off x="3282696" y="3685032"/>
+            <a:ext cx="2487168" cy="1170432"/>
           </a:xfrm>
           <a:prstGeom prst="rect">
             <a:avLst/>
@@ -32915,7 +33762,7 @@
               <a:buNone/>
             </a:pPr>
             <a:r>
-              <a:rPr lang="en-US" sz="950" dirty="0">
+              <a:rPr lang="en-US" sz="1050" dirty="0">
                 <a:solidFill>
                   <a:srgbClr val="575A5D"/>
                 </a:solidFill>
@@ -32923,9 +33770,9 @@
                 <a:ea typeface="Calibri" pitchFamily="34" charset="-122"/>
                 <a:cs typeface="Calibri" pitchFamily="34" charset="-120"/>
               </a:rPr>
-              <a:t>Score new accounts by predicted LTV at opening to optimize onboarding resources and cross-sell sequencing.</a:t>
-            </a:r>
-            <a:endParaRPr lang="en-US" sz="950" dirty="0"/>
+              <a:t>ML classifier surfacing personal accounts with commercial transaction signatures — converting hidden SMB relationships to business banking.</a:t>
+            </a:r>
+            <a:endParaRPr lang="en-US" sz="1050" dirty="0"/>
           </a:p>
         </p:txBody>
       </p:sp>
@@ -32937,8 +33784,8 @@
         </p:nvSpPr>
         <p:spPr>
           <a:xfrm>
-            <a:off x="2350008" y="2880360"/>
-            <a:ext cx="2084832" cy="1938528"/>
+            <a:off x="6025896" y="2953512"/>
+            <a:ext cx="2706624" cy="2011680"/>
           </a:xfrm>
           <a:prstGeom prst="rect">
             <a:avLst/>
@@ -32969,18 +33816,18 @@
         </p:nvSpPr>
         <p:spPr>
           <a:xfrm>
-            <a:off x="2350008" y="2880360"/>
-            <a:ext cx="2084832" cy="585216"/>
-          </a:xfrm>
-          <a:prstGeom prst="rect">
-            <a:avLst/>
-          </a:prstGeom>
-          <a:solidFill>
-            <a:srgbClr val="0D2E7A"/>
+            <a:off x="6025896" y="2953512"/>
+            <a:ext cx="2706624" cy="658368"/>
+          </a:xfrm>
+          <a:prstGeom prst="rect">
+            <a:avLst/>
+          </a:prstGeom>
+          <a:solidFill>
+            <a:srgbClr val="0F3D8A"/>
           </a:solidFill>
           <a:ln w="12700">
             <a:solidFill>
-              <a:srgbClr val="0D2E7A"/>
+              <a:srgbClr val="0F3D8A"/>
             </a:solidFill>
             <a:prstDash val="solid"/>
           </a:ln>
@@ -33002,8 +33849,8 @@
         </p:blipFill>
         <p:spPr>
           <a:xfrm>
-            <a:off x="2459736" y="2990088"/>
-            <a:ext cx="347472" cy="347472"/>
+            <a:off x="6163056" y="3081528"/>
+            <a:ext cx="384048" cy="384048"/>
           </a:xfrm>
           <a:prstGeom prst="rect">
             <a:avLst/>
@@ -33018,8 +33865,8 @@
         </p:nvSpPr>
         <p:spPr>
           <a:xfrm>
-            <a:off x="2862072" y="2935224"/>
-            <a:ext cx="1499616" cy="512064"/>
+            <a:off x="6620256" y="3026664"/>
+            <a:ext cx="2020824" cy="566928"/>
           </a:xfrm>
           <a:prstGeom prst="rect">
             <a:avLst/>
@@ -33035,7 +33882,7 @@
               <a:buNone/>
             </a:pPr>
             <a:r>
-              <a:rPr lang="en-US" sz="1000" b="1" dirty="0">
+              <a:rPr lang="en-US" sz="1150" b="1" dirty="0">
                 <a:solidFill>
                   <a:srgbClr val="FFFFFF"/>
                 </a:solidFill>
@@ -33043,16 +33890,16 @@
                 <a:ea typeface="Calibri" pitchFamily="34" charset="-122"/>
                 <a:cs typeface="Calibri" pitchFamily="34" charset="-120"/>
               </a:rPr>
-              <a:t>FI Decision</a:t>
-            </a:r>
-            <a:endParaRPr lang="en-US" sz="1000" dirty="0"/>
+              <a:t>Generational</a:t>
+            </a:r>
+            <a:endParaRPr lang="en-US" sz="1150" dirty="0"/>
           </a:p>
           <a:p>
             <a:pPr indent="0" marL="0">
               <a:buNone/>
             </a:pPr>
             <a:r>
-              <a:rPr lang="en-US" sz="1000" b="1" dirty="0">
+              <a:rPr lang="en-US" sz="1150" b="1" dirty="0">
                 <a:solidFill>
                   <a:srgbClr val="FFFFFF"/>
                 </a:solidFill>
@@ -33060,9 +33907,9 @@
                 <a:ea typeface="Calibri" pitchFamily="34" charset="-122"/>
                 <a:cs typeface="Calibri" pitchFamily="34" charset="-120"/>
               </a:rPr>
-              <a:t>Studio</a:t>
-            </a:r>
-            <a:endParaRPr lang="en-US" sz="1000" dirty="0"/>
+              <a:t>Wealth Deflection</a:t>
+            </a:r>
+            <a:endParaRPr lang="en-US" sz="1150" dirty="0"/>
           </a:p>
         </p:txBody>
       </p:sp>
@@ -33074,8 +33921,8 @@
         </p:nvSpPr>
         <p:spPr>
           <a:xfrm>
-            <a:off x="2441448" y="3538728"/>
-            <a:ext cx="1901952" cy="1170432"/>
+            <a:off x="6135624" y="3685032"/>
+            <a:ext cx="2487168" cy="1170432"/>
           </a:xfrm>
           <a:prstGeom prst="rect">
             <a:avLst/>
@@ -33091,7 +33938,7 @@
               <a:buNone/>
             </a:pPr>
             <a:r>
-              <a:rPr lang="en-US" sz="950" dirty="0">
+              <a:rPr lang="en-US" sz="1050" dirty="0">
                 <a:solidFill>
                   <a:srgbClr val="575A5D"/>
                 </a:solidFill>
@@ -33099,9 +33946,9 @@
                 <a:ea typeface="Calibri" pitchFamily="34" charset="-122"/>
                 <a:cs typeface="Calibri" pitchFamily="34" charset="-120"/>
               </a:rPr>
-              <a:t>No-code AutoML for FIs: upload data, train custom models, explain with SHAP, author rules, deploy as API, monitor drift.</a:t>
-            </a:r>
-            <a:endParaRPr lang="en-US" sz="950" dirty="0"/>
+              <a:t>Household coverage scoring to identify single-holder wealth concentration and expand FI relationships to next-generation family members.</a:t>
+            </a:r>
+            <a:endParaRPr lang="en-US" sz="1050" dirty="0"/>
           </a:p>
         </p:txBody>
       </p:sp>
@@ -33113,89 +33960,33 @@
         </p:nvSpPr>
         <p:spPr>
           <a:xfrm>
-            <a:off x="4572000" y="2880360"/>
-            <a:ext cx="2084832" cy="1938528"/>
-          </a:xfrm>
-          <a:prstGeom prst="rect">
-            <a:avLst/>
-          </a:prstGeom>
-          <a:solidFill>
-            <a:srgbClr val="FFFFFF"/>
+            <a:off x="320040" y="4718304"/>
+            <a:ext cx="8503920" cy="329184"/>
+          </a:xfrm>
+          <a:prstGeom prst="rect">
+            <a:avLst/>
+          </a:prstGeom>
+          <a:solidFill>
+            <a:srgbClr val="E8F7F7"/>
           </a:solidFill>
           <a:ln w="12700">
             <a:solidFill>
-              <a:srgbClr val="E7ECF0"/>
+              <a:srgbClr val="085CE5"/>
             </a:solidFill>
             <a:prstDash val="solid"/>
           </a:ln>
-          <a:effectLst>
-            <a:outerShdw sx="100000" sy="100000" kx="0" ky="0" algn="bl" rotWithShape="0" blurRad="101600" dist="38100" dir="8100000">
-              <a:srgbClr val="000000">
-                <a:alpha val="10000"/>
-              </a:srgbClr>
-            </a:outerShdw>
-          </a:effectLst>
-        </p:spPr>
-      </p:sp>
-      <p:sp>
-        <p:nvSpPr>
-          <p:cNvPr id="35" name="Shape 27"/>
-          <p:cNvSpPr/>
-          <p:nvPr/>
-        </p:nvSpPr>
-        <p:spPr>
-          <a:xfrm>
-            <a:off x="4572000" y="2880360"/>
-            <a:ext cx="2084832" cy="585216"/>
-          </a:xfrm>
-          <a:prstGeom prst="rect">
-            <a:avLst/>
-          </a:prstGeom>
-          <a:solidFill>
-            <a:srgbClr val="0A52C4"/>
-          </a:solidFill>
-          <a:ln w="12700">
-            <a:solidFill>
-              <a:srgbClr val="0A52C4"/>
-            </a:solidFill>
-            <a:prstDash val="solid"/>
-          </a:ln>
-        </p:spPr>
-      </p:sp>
-      <p:pic>
-        <p:nvPicPr>
-          <p:cNvPr id="36" name="Image 6" descr="preencoded.png">    </p:cNvPr>
-          <p:cNvPicPr>
-            <a:picLocks noChangeAspect="1"/>
-          </p:cNvPicPr>
-          <p:nvPr/>
-        </p:nvPicPr>
-        <p:blipFill>
-          <a:blip r:embed="rId7"/>
-          <a:stretch>
-            <a:fillRect/>
-          </a:stretch>
-        </p:blipFill>
-        <p:spPr>
-          <a:xfrm>
-            <a:off x="4681728" y="2990088"/>
-            <a:ext cx="347472" cy="347472"/>
-          </a:xfrm>
-          <a:prstGeom prst="rect">
-            <a:avLst/>
-          </a:prstGeom>
-        </p:spPr>
-      </p:pic>
-      <p:sp>
-        <p:nvSpPr>
-          <p:cNvPr id="37" name="Text 28"/>
-          <p:cNvSpPr/>
-          <p:nvPr/>
-        </p:nvSpPr>
-        <p:spPr>
-          <a:xfrm>
-            <a:off x="5084064" y="2935224"/>
-            <a:ext cx="1499616" cy="512064"/>
+        </p:spPr>
+      </p:sp>
+      <p:sp>
+        <p:nvSpPr>
+          <p:cNvPr id="35" name="Text 27"/>
+          <p:cNvSpPr/>
+          <p:nvPr/>
+        </p:nvSpPr>
+        <p:spPr>
+          <a:xfrm>
+            <a:off x="475488" y="4736592"/>
+            <a:ext cx="8229600" cy="274320"/>
           </a:xfrm>
           <a:prstGeom prst="rect">
             <a:avLst/>
@@ -33211,247 +34002,15 @@
               <a:buNone/>
             </a:pPr>
             <a:r>
-              <a:rPr lang="en-US" sz="1000" b="1" dirty="0">
-                <a:solidFill>
-                  <a:srgbClr val="FFFFFF"/>
-                </a:solidFill>
-                <a:latin typeface="Calibri" pitchFamily="34" charset="0"/>
-                <a:ea typeface="Calibri" pitchFamily="34" charset="-122"/>
-                <a:cs typeface="Calibri" pitchFamily="34" charset="-120"/>
-              </a:rPr>
-              <a:t>Personal-as-</a:t>
-            </a:r>
-            <a:endParaRPr lang="en-US" sz="1000" dirty="0"/>
-          </a:p>
-          <a:p>
-            <a:pPr indent="0" marL="0">
-              <a:buNone/>
-            </a:pPr>
-            <a:r>
-              <a:rPr lang="en-US" sz="1000" b="1" dirty="0">
-                <a:solidFill>
-                  <a:srgbClr val="FFFFFF"/>
-                </a:solidFill>
-                <a:latin typeface="Calibri" pitchFamily="34" charset="0"/>
-                <a:ea typeface="Calibri" pitchFamily="34" charset="-122"/>
-                <a:cs typeface="Calibri" pitchFamily="34" charset="-120"/>
-              </a:rPr>
-              <a:t>Commercial Detection</a:t>
-            </a:r>
-            <a:endParaRPr lang="en-US" sz="1000" dirty="0"/>
-          </a:p>
-        </p:txBody>
-      </p:sp>
-      <p:sp>
-        <p:nvSpPr>
-          <p:cNvPr id="38" name="Text 29"/>
-          <p:cNvSpPr/>
-          <p:nvPr/>
-        </p:nvSpPr>
-        <p:spPr>
-          <a:xfrm>
-            <a:off x="4663440" y="3538728"/>
-            <a:ext cx="1901952" cy="1170432"/>
-          </a:xfrm>
-          <a:prstGeom prst="rect">
-            <a:avLst/>
-          </a:prstGeom>
-          <a:noFill/>
-          <a:ln/>
-        </p:spPr>
-        <p:txBody>
-          <a:bodyPr wrap="square" lIns="0" tIns="0" rIns="0" bIns="0" rtlCol="0" anchor="ctr"/>
-          <a:lstStyle/>
-          <a:p>
-            <a:pPr indent="0" marL="0">
-              <a:buNone/>
-            </a:pPr>
-            <a:r>
-              <a:rPr lang="en-US" sz="950" dirty="0">
-                <a:solidFill>
-                  <a:srgbClr val="575A5D"/>
-                </a:solidFill>
-                <a:latin typeface="Calibri" pitchFamily="34" charset="0"/>
-                <a:ea typeface="Calibri" pitchFamily="34" charset="-122"/>
-                <a:cs typeface="Calibri" pitchFamily="34" charset="-120"/>
-              </a:rPr>
-              <a:t>ML classifier surfacing personal accounts with commercial transaction signatures — converting hidden SMB relationships to business banking.</a:t>
-            </a:r>
-            <a:endParaRPr lang="en-US" sz="950" dirty="0"/>
-          </a:p>
-        </p:txBody>
-      </p:sp>
-      <p:sp>
-        <p:nvSpPr>
-          <p:cNvPr id="39" name="Shape 30"/>
-          <p:cNvSpPr/>
-          <p:nvPr/>
-        </p:nvSpPr>
-        <p:spPr>
-          <a:xfrm>
-            <a:off x="6793992" y="2880360"/>
-            <a:ext cx="2084832" cy="1938528"/>
-          </a:xfrm>
-          <a:prstGeom prst="rect">
-            <a:avLst/>
-          </a:prstGeom>
-          <a:solidFill>
-            <a:srgbClr val="FFFFFF"/>
-          </a:solidFill>
-          <a:ln w="12700">
-            <a:solidFill>
-              <a:srgbClr val="E7ECF0"/>
-            </a:solidFill>
-            <a:prstDash val="solid"/>
-          </a:ln>
-          <a:effectLst>
-            <a:outerShdw sx="100000" sy="100000" kx="0" ky="0" algn="bl" rotWithShape="0" blurRad="101600" dist="38100" dir="8100000">
-              <a:srgbClr val="000000">
-                <a:alpha val="10000"/>
-              </a:srgbClr>
-            </a:outerShdw>
-          </a:effectLst>
-        </p:spPr>
-      </p:sp>
-      <p:sp>
-        <p:nvSpPr>
-          <p:cNvPr id="40" name="Shape 31"/>
-          <p:cNvSpPr/>
-          <p:nvPr/>
-        </p:nvSpPr>
-        <p:spPr>
-          <a:xfrm>
-            <a:off x="6793992" y="2880360"/>
-            <a:ext cx="2084832" cy="585216"/>
-          </a:xfrm>
-          <a:prstGeom prst="rect">
-            <a:avLst/>
-          </a:prstGeom>
-          <a:solidFill>
-            <a:srgbClr val="0F3D8A"/>
-          </a:solidFill>
-          <a:ln w="12700">
-            <a:solidFill>
-              <a:srgbClr val="0F3D8A"/>
-            </a:solidFill>
-            <a:prstDash val="solid"/>
-          </a:ln>
-        </p:spPr>
-      </p:sp>
-      <p:pic>
-        <p:nvPicPr>
-          <p:cNvPr id="41" name="Image 7" descr="preencoded.png">    </p:cNvPr>
-          <p:cNvPicPr>
-            <a:picLocks noChangeAspect="1"/>
-          </p:cNvPicPr>
-          <p:nvPr/>
-        </p:nvPicPr>
-        <p:blipFill>
-          <a:blip r:embed="rId8"/>
-          <a:stretch>
-            <a:fillRect/>
-          </a:stretch>
-        </p:blipFill>
-        <p:spPr>
-          <a:xfrm>
-            <a:off x="6903720" y="2990088"/>
-            <a:ext cx="347472" cy="347472"/>
-          </a:xfrm>
-          <a:prstGeom prst="rect">
-            <a:avLst/>
-          </a:prstGeom>
-        </p:spPr>
-      </p:pic>
-      <p:sp>
-        <p:nvSpPr>
-          <p:cNvPr id="42" name="Text 32"/>
-          <p:cNvSpPr/>
-          <p:nvPr/>
-        </p:nvSpPr>
-        <p:spPr>
-          <a:xfrm>
-            <a:off x="7306056" y="2935224"/>
-            <a:ext cx="1499616" cy="512064"/>
-          </a:xfrm>
-          <a:prstGeom prst="rect">
-            <a:avLst/>
-          </a:prstGeom>
-          <a:noFill/>
-          <a:ln/>
-        </p:spPr>
-        <p:txBody>
-          <a:bodyPr wrap="square" lIns="0" tIns="0" rIns="0" bIns="0" rtlCol="0" anchor="ctr"/>
-          <a:lstStyle/>
-          <a:p>
-            <a:pPr indent="0" marL="0">
-              <a:buNone/>
-            </a:pPr>
-            <a:r>
-              <a:rPr lang="en-US" sz="1000" b="1" dirty="0">
-                <a:solidFill>
-                  <a:srgbClr val="FFFFFF"/>
-                </a:solidFill>
-                <a:latin typeface="Calibri" pitchFamily="34" charset="0"/>
-                <a:ea typeface="Calibri" pitchFamily="34" charset="-122"/>
-                <a:cs typeface="Calibri" pitchFamily="34" charset="-120"/>
-              </a:rPr>
-              <a:t>Generational</a:t>
-            </a:r>
-            <a:endParaRPr lang="en-US" sz="1000" dirty="0"/>
-          </a:p>
-          <a:p>
-            <a:pPr indent="0" marL="0">
-              <a:buNone/>
-            </a:pPr>
-            <a:r>
-              <a:rPr lang="en-US" sz="1000" b="1" dirty="0">
-                <a:solidFill>
-                  <a:srgbClr val="FFFFFF"/>
-                </a:solidFill>
-                <a:latin typeface="Calibri" pitchFamily="34" charset="0"/>
-                <a:ea typeface="Calibri" pitchFamily="34" charset="-122"/>
-                <a:cs typeface="Calibri" pitchFamily="34" charset="-120"/>
-              </a:rPr>
-              <a:t>Wealth Deflection</a:t>
-            </a:r>
-            <a:endParaRPr lang="en-US" sz="1000" dirty="0"/>
-          </a:p>
-        </p:txBody>
-      </p:sp>
-      <p:sp>
-        <p:nvSpPr>
-          <p:cNvPr id="43" name="Text 33"/>
-          <p:cNvSpPr/>
-          <p:nvPr/>
-        </p:nvSpPr>
-        <p:spPr>
-          <a:xfrm>
-            <a:off x="6885432" y="3538728"/>
-            <a:ext cx="1901952" cy="1170432"/>
-          </a:xfrm>
-          <a:prstGeom prst="rect">
-            <a:avLst/>
-          </a:prstGeom>
-          <a:noFill/>
-          <a:ln/>
-        </p:spPr>
-        <p:txBody>
-          <a:bodyPr wrap="square" lIns="0" tIns="0" rIns="0" bIns="0" rtlCol="0" anchor="ctr"/>
-          <a:lstStyle/>
-          <a:p>
-            <a:pPr indent="0" marL="0">
-              <a:buNone/>
-            </a:pPr>
-            <a:r>
-              <a:rPr lang="en-US" sz="950" dirty="0">
-                <a:solidFill>
-                  <a:srgbClr val="575A5D"/>
-                </a:solidFill>
-                <a:latin typeface="Calibri" pitchFamily="34" charset="0"/>
-                <a:ea typeface="Calibri" pitchFamily="34" charset="-122"/>
-                <a:cs typeface="Calibri" pitchFamily="34" charset="-120"/>
-              </a:rPr>
-              <a:t>Household coverage scoring to identify single-holder wealth concentration and expand FI relationships to next-generation family members.</a:t>
+              <a:rPr lang="en-US" sz="950" i="1" dirty="0">
+                <a:solidFill>
+                  <a:srgbClr val="085CE5"/>
+                </a:solidFill>
+                <a:latin typeface="Calibri" pitchFamily="34" charset="0"/>
+                <a:ea typeface="Calibri" pitchFamily="34" charset="-122"/>
+                <a:cs typeface="Calibri" pitchFamily="34" charset="-120"/>
+              </a:rPr>
+              <a:t>Horizon Pipeline also includes: Call Report AI  ·  Account Opening LTV  ·  Cross-Sell Propensity  ·  Fraud Ring Detection  ·  and more →  see Horizon slide</a:t>
             </a:r>
             <a:endParaRPr lang="en-US" sz="950" dirty="0"/>
           </a:p>

</xml_diff>

<commit_message>
Remove Call Report AI & Account Opening LTV; move Anomaly Detection to Phase 3
- Horizon Pipeline: removed Call Report AI and Account Opening LTV; resized to 3x2 grid (6 Year 2 apps)
- App Delivery Gantt: removed Call Report AI and Account Opening LTV rows; moved Anomaly Detection bar to Phase 3 (Q3 FY27+)
- Phased Roadmap: Phase 2 now has Zelle Memo, Personal-as-Commercial, Gen. Wealth Deflection; Phase 3 adds Anomaly Detection, removes Account Opening LTV
- Data Source Gantt: removed NCUA 5300 Call Reports row; cleaned up Core Banking apps reference
- Updated Horizon callout strip and footer text throughout
</commit_message>
<xml_diff>
--- a/JH_DS_Strategy_JHBI.pptx
+++ b/JH_DS_Strategy_JHBI.pptx
@@ -14865,7 +14865,7 @@
                 <a:ea typeface="Calibri" pitchFamily="34" charset="-122"/>
                 <a:cs typeface="Calibri" pitchFamily="34" charset="-120"/>
               </a:rPr>
-              <a:t>Churn Mediation  ·  Account Opening LTV  ·  Cross-Sell Propensity</a:t>
+              <a:t>Churn Mediation  ·  Cross-Sell Propensity</a:t>
             </a:r>
             <a:endParaRPr lang="en-US" sz="850" dirty="0"/>
           </a:p>
@@ -16009,7 +16009,7 @@
         <p:spPr>
           <a:xfrm>
             <a:off x="128016" y="786384"/>
-            <a:ext cx="2084832" cy="1938528"/>
+            <a:ext cx="2798064" cy="1938528"/>
           </a:xfrm>
           <a:prstGeom prst="rect">
             <a:avLst/>
@@ -16041,17 +16041,17 @@
         <p:spPr>
           <a:xfrm>
             <a:off x="128016" y="786384"/>
-            <a:ext cx="2084832" cy="73152"/>
+            <a:ext cx="2798064" cy="73152"/>
           </a:xfrm>
           <a:prstGeom prst="rect">
             <a:avLst/>
           </a:prstGeom>
           <a:solidFill>
-            <a:srgbClr val="575A5D"/>
+            <a:srgbClr val="085CE5"/>
           </a:solidFill>
           <a:ln w="12700">
             <a:solidFill>
-              <a:srgbClr val="575A5D"/>
+              <a:srgbClr val="085CE5"/>
             </a:solidFill>
             <a:prstDash val="solid"/>
           </a:ln>
@@ -16065,18 +16065,18 @@
         </p:nvSpPr>
         <p:spPr>
           <a:xfrm>
-            <a:off x="1609344" y="914400"/>
+            <a:off x="2322576" y="914400"/>
             <a:ext cx="548640" cy="182880"/>
           </a:xfrm>
           <a:prstGeom prst="rect">
             <a:avLst/>
           </a:prstGeom>
           <a:solidFill>
-            <a:srgbClr val="575A5D"/>
+            <a:srgbClr val="085CE5"/>
           </a:solidFill>
           <a:ln w="12700">
             <a:solidFill>
-              <a:srgbClr val="575A5D"/>
+              <a:srgbClr val="085CE5"/>
             </a:solidFill>
             <a:prstDash val="solid"/>
           </a:ln>
@@ -16090,7 +16090,7 @@
         </p:nvSpPr>
         <p:spPr>
           <a:xfrm>
-            <a:off x="1609344" y="914400"/>
+            <a:off x="2322576" y="914400"/>
             <a:ext cx="548640" cy="182880"/>
           </a:xfrm>
           <a:prstGeom prst="rect">
@@ -16115,7 +16115,7 @@
                 <a:ea typeface="Calibri" pitchFamily="34" charset="-122"/>
                 <a:cs typeface="Calibri" pitchFamily="34" charset="-120"/>
               </a:rPr>
-              <a:t>Aug '26</a:t>
+              <a:t>Year 2</a:t>
             </a:r>
             <a:endParaRPr lang="en-US" sz="650" dirty="0"/>
           </a:p>
@@ -16154,7 +16154,7 @@
         <p:spPr>
           <a:xfrm>
             <a:off x="621792" y="914400"/>
-            <a:ext cx="950976" cy="402336"/>
+            <a:ext cx="1645920" cy="402336"/>
           </a:xfrm>
           <a:prstGeom prst="rect">
             <a:avLst/>
@@ -16178,7 +16178,7 @@
                 <a:ea typeface="Calibri" pitchFamily="34" charset="-122"/>
                 <a:cs typeface="Calibri" pitchFamily="34" charset="-120"/>
               </a:rPr>
-              <a:t>Call Report AI</a:t>
+              <a:t>Cross-Sell Propensity</a:t>
             </a:r>
             <a:endParaRPr lang="en-US" sz="950" dirty="0"/>
           </a:p>
@@ -16193,7 +16193,7 @@
         <p:spPr>
           <a:xfrm>
             <a:off x="237744" y="1389888"/>
-            <a:ext cx="1865376" cy="1225296"/>
+            <a:ext cx="2578608" cy="1225296"/>
           </a:xfrm>
           <a:prstGeom prst="rect">
             <a:avLst/>
@@ -16217,7 +16217,7 @@
                 <a:ea typeface="Calibri" pitchFamily="34" charset="-122"/>
                 <a:cs typeface="Calibri" pitchFamily="34" charset="-120"/>
               </a:rPr>
-              <a:t>Claude-powered NCUA 5300 intelligence — market pulse, NL Q&amp;A, and peer benchmarking for CU executives. In active development, targeting Aug/Sept 2026.</a:t>
+              <a:t>ML model scoring each FI customer's likelihood to open savings, CDs, credit cards, or mortgage — enabling timed, personalized offers embedded in Banno.</a:t>
             </a:r>
             <a:endParaRPr lang="en-US" sz="900" dirty="0"/>
           </a:p>
@@ -16231,8 +16231,8 @@
         </p:nvSpPr>
         <p:spPr>
           <a:xfrm>
-            <a:off x="2350008" y="786384"/>
-            <a:ext cx="2084832" cy="1938528"/>
+            <a:off x="3072384" y="786384"/>
+            <a:ext cx="2798064" cy="1938528"/>
           </a:xfrm>
           <a:prstGeom prst="rect">
             <a:avLst/>
@@ -16263,18 +16263,18 @@
         </p:nvSpPr>
         <p:spPr>
           <a:xfrm>
-            <a:off x="2350008" y="786384"/>
-            <a:ext cx="2084832" cy="73152"/>
+            <a:off x="3072384" y="786384"/>
+            <a:ext cx="2798064" cy="73152"/>
           </a:xfrm>
           <a:prstGeom prst="rect">
             <a:avLst/>
           </a:prstGeom>
           <a:solidFill>
-            <a:srgbClr val="0B68D4"/>
+            <a:srgbClr val="06185F"/>
           </a:solidFill>
           <a:ln w="12700">
             <a:solidFill>
-              <a:srgbClr val="0B68D4"/>
+              <a:srgbClr val="06185F"/>
             </a:solidFill>
             <a:prstDash val="solid"/>
           </a:ln>
@@ -16288,18 +16288,18 @@
         </p:nvSpPr>
         <p:spPr>
           <a:xfrm>
-            <a:off x="3831336" y="914400"/>
+            <a:off x="5266944" y="914400"/>
             <a:ext cx="548640" cy="182880"/>
           </a:xfrm>
           <a:prstGeom prst="rect">
             <a:avLst/>
           </a:prstGeom>
           <a:solidFill>
-            <a:srgbClr val="0B68D4"/>
+            <a:srgbClr val="06185F"/>
           </a:solidFill>
           <a:ln w="12700">
             <a:solidFill>
-              <a:srgbClr val="0B68D4"/>
+              <a:srgbClr val="06185F"/>
             </a:solidFill>
             <a:prstDash val="solid"/>
           </a:ln>
@@ -16313,7 +16313,7 @@
         </p:nvSpPr>
         <p:spPr>
           <a:xfrm>
-            <a:off x="3831336" y="914400"/>
+            <a:off x="5266944" y="914400"/>
             <a:ext cx="548640" cy="182880"/>
           </a:xfrm>
           <a:prstGeom prst="rect">
@@ -16338,7 +16338,7 @@
                 <a:ea typeface="Calibri" pitchFamily="34" charset="-122"/>
                 <a:cs typeface="Calibri" pitchFamily="34" charset="-120"/>
               </a:rPr>
-              <a:t>Phase 2</a:t>
+              <a:t>Year 2</a:t>
             </a:r>
             <a:endParaRPr lang="en-US" sz="650" dirty="0"/>
           </a:p>
@@ -16360,7 +16360,7 @@
         </p:blipFill>
         <p:spPr>
           <a:xfrm>
-            <a:off x="2478024" y="969264"/>
+            <a:off x="3200400" y="969264"/>
             <a:ext cx="310896" cy="310896"/>
           </a:xfrm>
           <a:prstGeom prst="rect">
@@ -16376,8 +16376,8 @@
         </p:nvSpPr>
         <p:spPr>
           <a:xfrm>
-            <a:off x="2843784" y="914400"/>
-            <a:ext cx="950976" cy="402336"/>
+            <a:off x="3566160" y="914400"/>
+            <a:ext cx="1645920" cy="402336"/>
           </a:xfrm>
           <a:prstGeom prst="rect">
             <a:avLst/>
@@ -16401,7 +16401,7 @@
                 <a:ea typeface="Calibri" pitchFamily="34" charset="-122"/>
                 <a:cs typeface="Calibri" pitchFamily="34" charset="-120"/>
               </a:rPr>
-              <a:t>Account Opening LTV</a:t>
+              <a:t>Fraud Ring Detection</a:t>
             </a:r>
             <a:endParaRPr lang="en-US" sz="950" dirty="0"/>
           </a:p>
@@ -16415,8 +16415,8 @@
         </p:nvSpPr>
         <p:spPr>
           <a:xfrm>
-            <a:off x="2459736" y="1389888"/>
-            <a:ext cx="1865376" cy="1225296"/>
+            <a:off x="3182112" y="1389888"/>
+            <a:ext cx="2578608" cy="1225296"/>
           </a:xfrm>
           <a:prstGeom prst="rect">
             <a:avLst/>
@@ -16440,7 +16440,7 @@
                 <a:ea typeface="Calibri" pitchFamily="34" charset="-122"/>
                 <a:cs typeface="Calibri" pitchFamily="34" charset="-120"/>
               </a:rPr>
-              <a:t>Score new accounts by predicted LTV at opening — routing applicants to differentiated service tiers and triggering ML-guided cross-sell sequencing.</a:t>
+              <a:t>Graph-based ML to identify coordinated fraud across linked accounts, shared devices, and IP clusters — across the entire JH network for cross-institution signals.</a:t>
             </a:r>
             <a:endParaRPr lang="en-US" sz="900" dirty="0"/>
           </a:p>
@@ -16454,8 +16454,8 @@
         </p:nvSpPr>
         <p:spPr>
           <a:xfrm>
-            <a:off x="4572000" y="786384"/>
-            <a:ext cx="2084832" cy="1938528"/>
+            <a:off x="6016752" y="786384"/>
+            <a:ext cx="2798064" cy="1938528"/>
           </a:xfrm>
           <a:prstGeom prst="rect">
             <a:avLst/>
@@ -16486,18 +16486,18 @@
         </p:nvSpPr>
         <p:spPr>
           <a:xfrm>
-            <a:off x="4572000" y="786384"/>
-            <a:ext cx="2084832" cy="73152"/>
+            <a:off x="6016752" y="786384"/>
+            <a:ext cx="2798064" cy="73152"/>
           </a:xfrm>
           <a:prstGeom prst="rect">
             <a:avLst/>
           </a:prstGeom>
           <a:solidFill>
-            <a:srgbClr val="085CE5"/>
+            <a:srgbClr val="073FA8"/>
           </a:solidFill>
           <a:ln w="12700">
             <a:solidFill>
-              <a:srgbClr val="085CE5"/>
+              <a:srgbClr val="073FA8"/>
             </a:solidFill>
             <a:prstDash val="solid"/>
           </a:ln>
@@ -16511,18 +16511,18 @@
         </p:nvSpPr>
         <p:spPr>
           <a:xfrm>
-            <a:off x="6053328" y="914400"/>
+            <a:off x="8211312" y="914400"/>
             <a:ext cx="548640" cy="182880"/>
           </a:xfrm>
           <a:prstGeom prst="rect">
             <a:avLst/>
           </a:prstGeom>
           <a:solidFill>
-            <a:srgbClr val="085CE5"/>
+            <a:srgbClr val="073FA8"/>
           </a:solidFill>
           <a:ln w="12700">
             <a:solidFill>
-              <a:srgbClr val="085CE5"/>
+              <a:srgbClr val="073FA8"/>
             </a:solidFill>
             <a:prstDash val="solid"/>
           </a:ln>
@@ -16536,7 +16536,7 @@
         </p:nvSpPr>
         <p:spPr>
           <a:xfrm>
-            <a:off x="6053328" y="914400"/>
+            <a:off x="8211312" y="914400"/>
             <a:ext cx="548640" cy="182880"/>
           </a:xfrm>
           <a:prstGeom prst="rect">
@@ -16583,7 +16583,7 @@
         </p:blipFill>
         <p:spPr>
           <a:xfrm>
-            <a:off x="4700016" y="969264"/>
+            <a:off x="6144768" y="969264"/>
             <a:ext cx="310896" cy="310896"/>
           </a:xfrm>
           <a:prstGeom prst="rect">
@@ -16599,8 +16599,8 @@
         </p:nvSpPr>
         <p:spPr>
           <a:xfrm>
-            <a:off x="5065776" y="914400"/>
-            <a:ext cx="950976" cy="402336"/>
+            <a:off x="6510528" y="914400"/>
+            <a:ext cx="1645920" cy="402336"/>
           </a:xfrm>
           <a:prstGeom prst="rect">
             <a:avLst/>
@@ -16624,7 +16624,7 @@
                 <a:ea typeface="Calibri" pitchFamily="34" charset="-122"/>
                 <a:cs typeface="Calibri" pitchFamily="34" charset="-120"/>
               </a:rPr>
-              <a:t>Cross-Sell Propensity</a:t>
+              <a:t>Deposit Runoff Forecasting</a:t>
             </a:r>
             <a:endParaRPr lang="en-US" sz="950" dirty="0"/>
           </a:p>
@@ -16638,8 +16638,8 @@
         </p:nvSpPr>
         <p:spPr>
           <a:xfrm>
-            <a:off x="4681728" y="1389888"/>
-            <a:ext cx="1865376" cy="1225296"/>
+            <a:off x="6126480" y="1389888"/>
+            <a:ext cx="2578608" cy="1225296"/>
           </a:xfrm>
           <a:prstGeom prst="rect">
             <a:avLst/>
@@ -16663,7 +16663,7 @@
                 <a:ea typeface="Calibri" pitchFamily="34" charset="-122"/>
                 <a:cs typeface="Calibri" pitchFamily="34" charset="-120"/>
               </a:rPr>
-              <a:t>ML model scoring each FI customer's likelihood to open savings, CDs, credit cards, or mortgage — enabling timed, personalized offers embedded in Banno.</a:t>
+              <a:t>Portfolio-level deposit attrition prediction to support FI clients' ALM, liquidity stress testing, and treasury planning with 90-day forward visibility.</a:t>
             </a:r>
             <a:endParaRPr lang="en-US" sz="900" dirty="0"/>
           </a:p>
@@ -16677,8 +16677,8 @@
         </p:nvSpPr>
         <p:spPr>
           <a:xfrm>
-            <a:off x="6793992" y="786384"/>
-            <a:ext cx="2084832" cy="1938528"/>
+            <a:off x="128016" y="2889504"/>
+            <a:ext cx="2798064" cy="1938528"/>
           </a:xfrm>
           <a:prstGeom prst="rect">
             <a:avLst/>
@@ -16709,18 +16709,18 @@
         </p:nvSpPr>
         <p:spPr>
           <a:xfrm>
-            <a:off x="6793992" y="786384"/>
-            <a:ext cx="2084832" cy="73152"/>
+            <a:off x="128016" y="2889504"/>
+            <a:ext cx="2798064" cy="73152"/>
           </a:xfrm>
           <a:prstGeom prst="rect">
             <a:avLst/>
           </a:prstGeom>
           <a:solidFill>
-            <a:srgbClr val="06185F"/>
+            <a:srgbClr val="575A5D"/>
           </a:solidFill>
           <a:ln w="12700">
             <a:solidFill>
-              <a:srgbClr val="06185F"/>
+              <a:srgbClr val="575A5D"/>
             </a:solidFill>
             <a:prstDash val="solid"/>
           </a:ln>
@@ -16734,18 +16734,18 @@
         </p:nvSpPr>
         <p:spPr>
           <a:xfrm>
-            <a:off x="8275320" y="914400"/>
+            <a:off x="2322576" y="3017520"/>
             <a:ext cx="548640" cy="182880"/>
           </a:xfrm>
           <a:prstGeom prst="rect">
             <a:avLst/>
           </a:prstGeom>
           <a:solidFill>
-            <a:srgbClr val="06185F"/>
+            <a:srgbClr val="575A5D"/>
           </a:solidFill>
           <a:ln w="12700">
             <a:solidFill>
-              <a:srgbClr val="06185F"/>
+              <a:srgbClr val="575A5D"/>
             </a:solidFill>
             <a:prstDash val="solid"/>
           </a:ln>
@@ -16759,7 +16759,7 @@
         </p:nvSpPr>
         <p:spPr>
           <a:xfrm>
-            <a:off x="8275320" y="914400"/>
+            <a:off x="2322576" y="3017520"/>
             <a:ext cx="548640" cy="182880"/>
           </a:xfrm>
           <a:prstGeom prst="rect">
@@ -16806,7 +16806,7 @@
         </p:blipFill>
         <p:spPr>
           <a:xfrm>
-            <a:off x="6922008" y="969264"/>
+            <a:off x="256032" y="3072384"/>
             <a:ext cx="310896" cy="310896"/>
           </a:xfrm>
           <a:prstGeom prst="rect">
@@ -16822,8 +16822,8 @@
         </p:nvSpPr>
         <p:spPr>
           <a:xfrm>
-            <a:off x="7287768" y="914400"/>
-            <a:ext cx="950976" cy="402336"/>
+            <a:off x="621792" y="3017520"/>
+            <a:ext cx="1645920" cy="402336"/>
           </a:xfrm>
           <a:prstGeom prst="rect">
             <a:avLst/>
@@ -16847,7 +16847,7 @@
                 <a:ea typeface="Calibri" pitchFamily="34" charset="-122"/>
                 <a:cs typeface="Calibri" pitchFamily="34" charset="-120"/>
               </a:rPr>
-              <a:t>Fraud Ring Detection</a:t>
+              <a:t>Overdraft Prediction</a:t>
             </a:r>
             <a:endParaRPr lang="en-US" sz="950" dirty="0"/>
           </a:p>
@@ -16861,8 +16861,8 @@
         </p:nvSpPr>
         <p:spPr>
           <a:xfrm>
-            <a:off x="6903720" y="1389888"/>
-            <a:ext cx="1865376" cy="1225296"/>
+            <a:off x="237744" y="3493008"/>
+            <a:ext cx="2578608" cy="1225296"/>
           </a:xfrm>
           <a:prstGeom prst="rect">
             <a:avLst/>
@@ -16886,7 +16886,7 @@
                 <a:ea typeface="Calibri" pitchFamily="34" charset="-122"/>
                 <a:cs typeface="Calibri" pitchFamily="34" charset="-120"/>
               </a:rPr>
-              <a:t>Graph-based ML to identify coordinated fraud across linked accounts, shared devices, and IP clusters — across the entire JH network for cross-institution signals.</a:t>
+              <a:t>Anticipate overdraft events before they occur and surface proactive micro-loan offers or alerts in Banno — improving CX while reducing NSF fee risk for FIs.</a:t>
             </a:r>
             <a:endParaRPr lang="en-US" sz="900" dirty="0"/>
           </a:p>
@@ -16900,8 +16900,8 @@
         </p:nvSpPr>
         <p:spPr>
           <a:xfrm>
-            <a:off x="128016" y="2889504"/>
-            <a:ext cx="2084832" cy="1938528"/>
+            <a:off x="3072384" y="2889504"/>
+            <a:ext cx="2798064" cy="1938528"/>
           </a:xfrm>
           <a:prstGeom prst="rect">
             <a:avLst/>
@@ -16932,18 +16932,18 @@
         </p:nvSpPr>
         <p:spPr>
           <a:xfrm>
-            <a:off x="128016" y="2889504"/>
-            <a:ext cx="2084832" cy="73152"/>
+            <a:off x="3072384" y="2889504"/>
+            <a:ext cx="2798064" cy="73152"/>
           </a:xfrm>
           <a:prstGeom prst="rect">
             <a:avLst/>
           </a:prstGeom>
           <a:solidFill>
-            <a:srgbClr val="073FA8"/>
+            <a:srgbClr val="0B68D4"/>
           </a:solidFill>
           <a:ln w="12700">
             <a:solidFill>
-              <a:srgbClr val="073FA8"/>
+              <a:srgbClr val="0B68D4"/>
             </a:solidFill>
             <a:prstDash val="solid"/>
           </a:ln>
@@ -16957,18 +16957,18 @@
         </p:nvSpPr>
         <p:spPr>
           <a:xfrm>
-            <a:off x="1609344" y="3017520"/>
+            <a:off x="5266944" y="3017520"/>
             <a:ext cx="548640" cy="182880"/>
           </a:xfrm>
           <a:prstGeom prst="rect">
             <a:avLst/>
           </a:prstGeom>
           <a:solidFill>
-            <a:srgbClr val="073FA8"/>
+            <a:srgbClr val="0B68D4"/>
           </a:solidFill>
           <a:ln w="12700">
             <a:solidFill>
-              <a:srgbClr val="073FA8"/>
+              <a:srgbClr val="0B68D4"/>
             </a:solidFill>
             <a:prstDash val="solid"/>
           </a:ln>
@@ -16982,7 +16982,7 @@
         </p:nvSpPr>
         <p:spPr>
           <a:xfrm>
-            <a:off x="1609344" y="3017520"/>
+            <a:off x="5266944" y="3017520"/>
             <a:ext cx="548640" cy="182880"/>
           </a:xfrm>
           <a:prstGeom prst="rect">
@@ -17029,7 +17029,7 @@
         </p:blipFill>
         <p:spPr>
           <a:xfrm>
-            <a:off x="256032" y="3072384"/>
+            <a:off x="3200400" y="3072384"/>
             <a:ext cx="310896" cy="310896"/>
           </a:xfrm>
           <a:prstGeom prst="rect">
@@ -17045,8 +17045,8 @@
         </p:nvSpPr>
         <p:spPr>
           <a:xfrm>
-            <a:off x="621792" y="3017520"/>
-            <a:ext cx="950976" cy="402336"/>
+            <a:off x="3566160" y="3017520"/>
+            <a:ext cx="1645920" cy="402336"/>
           </a:xfrm>
           <a:prstGeom prst="rect">
             <a:avLst/>
@@ -17070,7 +17070,7 @@
                 <a:ea typeface="Calibri" pitchFamily="34" charset="-122"/>
                 <a:cs typeface="Calibri" pitchFamily="34" charset="-120"/>
               </a:rPr>
-              <a:t>Deposit Runoff Forecasting</a:t>
+              <a:t>Customer Sentiment Engine</a:t>
             </a:r>
             <a:endParaRPr lang="en-US" sz="950" dirty="0"/>
           </a:p>
@@ -17084,8 +17084,8 @@
         </p:nvSpPr>
         <p:spPr>
           <a:xfrm>
-            <a:off x="237744" y="3493008"/>
-            <a:ext cx="1865376" cy="1225296"/>
+            <a:off x="3182112" y="3493008"/>
+            <a:ext cx="2578608" cy="1225296"/>
           </a:xfrm>
           <a:prstGeom prst="rect">
             <a:avLst/>
@@ -17109,7 +17109,7 @@
                 <a:ea typeface="Calibri" pitchFamily="34" charset="-122"/>
                 <a:cs typeface="Calibri" pitchFamily="34" charset="-120"/>
               </a:rPr>
-              <a:t>Portfolio-level deposit attrition prediction to support FI clients' ALM, liquidity stress testing, and treasury planning with 90-day forward visibility.</a:t>
+              <a:t>NLP analysis of call transcripts and CFPB complaints to generate real-time CX health scores — helping FIs identify and route at-risk relationships before escalation.</a:t>
             </a:r>
             <a:endParaRPr lang="en-US" sz="900" dirty="0"/>
           </a:p>
@@ -17123,8 +17123,8 @@
         </p:nvSpPr>
         <p:spPr>
           <a:xfrm>
-            <a:off x="2350008" y="2889504"/>
-            <a:ext cx="2084832" cy="1938528"/>
+            <a:off x="6016752" y="2889504"/>
+            <a:ext cx="2798064" cy="1938528"/>
           </a:xfrm>
           <a:prstGeom prst="rect">
             <a:avLst/>
@@ -17155,454 +17155,8 @@
         </p:nvSpPr>
         <p:spPr>
           <a:xfrm>
-            <a:off x="2350008" y="2889504"/>
-            <a:ext cx="2084832" cy="73152"/>
-          </a:xfrm>
-          <a:prstGeom prst="rect">
-            <a:avLst/>
-          </a:prstGeom>
-          <a:solidFill>
-            <a:srgbClr val="575A5D"/>
-          </a:solidFill>
-          <a:ln w="12700">
-            <a:solidFill>
-              <a:srgbClr val="575A5D"/>
-            </a:solidFill>
-            <a:prstDash val="solid"/>
-          </a:ln>
-        </p:spPr>
-      </p:sp>
-      <p:sp>
-        <p:nvSpPr>
-          <p:cNvPr id="41" name="Shape 34"/>
-          <p:cNvSpPr/>
-          <p:nvPr/>
-        </p:nvSpPr>
-        <p:spPr>
-          <a:xfrm>
-            <a:off x="3831336" y="3017520"/>
-            <a:ext cx="548640" cy="182880"/>
-          </a:xfrm>
-          <a:prstGeom prst="rect">
-            <a:avLst/>
-          </a:prstGeom>
-          <a:solidFill>
-            <a:srgbClr val="575A5D"/>
-          </a:solidFill>
-          <a:ln w="12700">
-            <a:solidFill>
-              <a:srgbClr val="575A5D"/>
-            </a:solidFill>
-            <a:prstDash val="solid"/>
-          </a:ln>
-        </p:spPr>
-      </p:sp>
-      <p:sp>
-        <p:nvSpPr>
-          <p:cNvPr id="42" name="Text 35"/>
-          <p:cNvSpPr/>
-          <p:nvPr/>
-        </p:nvSpPr>
-        <p:spPr>
-          <a:xfrm>
-            <a:off x="3831336" y="3017520"/>
-            <a:ext cx="548640" cy="182880"/>
-          </a:xfrm>
-          <a:prstGeom prst="rect">
-            <a:avLst/>
-          </a:prstGeom>
-          <a:noFill/>
-          <a:ln/>
-        </p:spPr>
-        <p:txBody>
-          <a:bodyPr wrap="square" lIns="0" tIns="0" rIns="0" bIns="0" rtlCol="0" anchor="ctr"/>
-          <a:lstStyle/>
-          <a:p>
-            <a:pPr algn="ctr" indent="0" marL="0">
-              <a:buNone/>
-            </a:pPr>
-            <a:r>
-              <a:rPr lang="en-US" sz="650" b="1" dirty="0">
-                <a:solidFill>
-                  <a:srgbClr val="FFFFFF"/>
-                </a:solidFill>
-                <a:latin typeface="Calibri" pitchFamily="34" charset="0"/>
-                <a:ea typeface="Calibri" pitchFamily="34" charset="-122"/>
-                <a:cs typeface="Calibri" pitchFamily="34" charset="-120"/>
-              </a:rPr>
-              <a:t>Year 2</a:t>
-            </a:r>
-            <a:endParaRPr lang="en-US" sz="650" dirty="0"/>
-          </a:p>
-        </p:txBody>
-      </p:sp>
-      <p:pic>
-        <p:nvPicPr>
-          <p:cNvPr id="43" name="Image 5" descr="preencoded.png">    </p:cNvPr>
-          <p:cNvPicPr>
-            <a:picLocks noChangeAspect="1"/>
-          </p:cNvPicPr>
-          <p:nvPr/>
-        </p:nvPicPr>
-        <p:blipFill>
-          <a:blip r:embed="rId6"/>
-          <a:stretch>
-            <a:fillRect/>
-          </a:stretch>
-        </p:blipFill>
-        <p:spPr>
-          <a:xfrm>
-            <a:off x="2478024" y="3072384"/>
-            <a:ext cx="310896" cy="310896"/>
-          </a:xfrm>
-          <a:prstGeom prst="rect">
-            <a:avLst/>
-          </a:prstGeom>
-        </p:spPr>
-      </p:pic>
-      <p:sp>
-        <p:nvSpPr>
-          <p:cNvPr id="44" name="Text 36"/>
-          <p:cNvSpPr/>
-          <p:nvPr/>
-        </p:nvSpPr>
-        <p:spPr>
-          <a:xfrm>
-            <a:off x="2843784" y="3017520"/>
-            <a:ext cx="950976" cy="402336"/>
-          </a:xfrm>
-          <a:prstGeom prst="rect">
-            <a:avLst/>
-          </a:prstGeom>
-          <a:noFill/>
-          <a:ln/>
-        </p:spPr>
-        <p:txBody>
-          <a:bodyPr wrap="square" lIns="0" tIns="0" rIns="0" bIns="0" rtlCol="0" anchor="ctr"/>
-          <a:lstStyle/>
-          <a:p>
-            <a:pPr indent="0" marL="0">
-              <a:buNone/>
-            </a:pPr>
-            <a:r>
-              <a:rPr lang="en-US" sz="950" b="1" dirty="0">
-                <a:solidFill>
-                  <a:srgbClr val="06185F"/>
-                </a:solidFill>
-                <a:latin typeface="Calibri" pitchFamily="34" charset="0"/>
-                <a:ea typeface="Calibri" pitchFamily="34" charset="-122"/>
-                <a:cs typeface="Calibri" pitchFamily="34" charset="-120"/>
-              </a:rPr>
-              <a:t>Overdraft Prediction</a:t>
-            </a:r>
-            <a:endParaRPr lang="en-US" sz="950" dirty="0"/>
-          </a:p>
-        </p:txBody>
-      </p:sp>
-      <p:sp>
-        <p:nvSpPr>
-          <p:cNvPr id="45" name="Text 37"/>
-          <p:cNvSpPr/>
-          <p:nvPr/>
-        </p:nvSpPr>
-        <p:spPr>
-          <a:xfrm>
-            <a:off x="2459736" y="3493008"/>
-            <a:ext cx="1865376" cy="1225296"/>
-          </a:xfrm>
-          <a:prstGeom prst="rect">
-            <a:avLst/>
-          </a:prstGeom>
-          <a:noFill/>
-          <a:ln/>
-        </p:spPr>
-        <p:txBody>
-          <a:bodyPr wrap="square" lIns="0" tIns="0" rIns="0" bIns="0" rtlCol="0" anchor="ctr"/>
-          <a:lstStyle/>
-          <a:p>
-            <a:pPr indent="0" marL="0">
-              <a:buNone/>
-            </a:pPr>
-            <a:r>
-              <a:rPr lang="en-US" sz="900" dirty="0">
-                <a:solidFill>
-                  <a:srgbClr val="575A5D"/>
-                </a:solidFill>
-                <a:latin typeface="Calibri" pitchFamily="34" charset="0"/>
-                <a:ea typeface="Calibri" pitchFamily="34" charset="-122"/>
-                <a:cs typeface="Calibri" pitchFamily="34" charset="-120"/>
-              </a:rPr>
-              <a:t>Anticipate overdraft events before they occur and surface proactive micro-loan offers or alerts in Banno — improving CX while reducing NSF fee risk for FIs.</a:t>
-            </a:r>
-            <a:endParaRPr lang="en-US" sz="900" dirty="0"/>
-          </a:p>
-        </p:txBody>
-      </p:sp>
-      <p:sp>
-        <p:nvSpPr>
-          <p:cNvPr id="46" name="Shape 38"/>
-          <p:cNvSpPr/>
-          <p:nvPr/>
-        </p:nvSpPr>
-        <p:spPr>
-          <a:xfrm>
-            <a:off x="4572000" y="2889504"/>
-            <a:ext cx="2084832" cy="1938528"/>
-          </a:xfrm>
-          <a:prstGeom prst="rect">
-            <a:avLst/>
-          </a:prstGeom>
-          <a:solidFill>
-            <a:srgbClr val="FFFFFF"/>
-          </a:solidFill>
-          <a:ln w="12700">
-            <a:solidFill>
-              <a:srgbClr val="E7ECF0"/>
-            </a:solidFill>
-            <a:prstDash val="solid"/>
-          </a:ln>
-          <a:effectLst>
-            <a:outerShdw sx="100000" sy="100000" kx="0" ky="0" algn="bl" rotWithShape="0" blurRad="101600" dist="38100" dir="8100000">
-              <a:srgbClr val="000000">
-                <a:alpha val="10000"/>
-              </a:srgbClr>
-            </a:outerShdw>
-          </a:effectLst>
-        </p:spPr>
-      </p:sp>
-      <p:sp>
-        <p:nvSpPr>
-          <p:cNvPr id="47" name="Shape 39"/>
-          <p:cNvSpPr/>
-          <p:nvPr/>
-        </p:nvSpPr>
-        <p:spPr>
-          <a:xfrm>
-            <a:off x="4572000" y="2889504"/>
-            <a:ext cx="2084832" cy="73152"/>
-          </a:xfrm>
-          <a:prstGeom prst="rect">
-            <a:avLst/>
-          </a:prstGeom>
-          <a:solidFill>
-            <a:srgbClr val="0B68D4"/>
-          </a:solidFill>
-          <a:ln w="12700">
-            <a:solidFill>
-              <a:srgbClr val="0B68D4"/>
-            </a:solidFill>
-            <a:prstDash val="solid"/>
-          </a:ln>
-        </p:spPr>
-      </p:sp>
-      <p:sp>
-        <p:nvSpPr>
-          <p:cNvPr id="48" name="Shape 40"/>
-          <p:cNvSpPr/>
-          <p:nvPr/>
-        </p:nvSpPr>
-        <p:spPr>
-          <a:xfrm>
-            <a:off x="6053328" y="3017520"/>
-            <a:ext cx="548640" cy="182880"/>
-          </a:xfrm>
-          <a:prstGeom prst="rect">
-            <a:avLst/>
-          </a:prstGeom>
-          <a:solidFill>
-            <a:srgbClr val="0B68D4"/>
-          </a:solidFill>
-          <a:ln w="12700">
-            <a:solidFill>
-              <a:srgbClr val="0B68D4"/>
-            </a:solidFill>
-            <a:prstDash val="solid"/>
-          </a:ln>
-        </p:spPr>
-      </p:sp>
-      <p:sp>
-        <p:nvSpPr>
-          <p:cNvPr id="49" name="Text 41"/>
-          <p:cNvSpPr/>
-          <p:nvPr/>
-        </p:nvSpPr>
-        <p:spPr>
-          <a:xfrm>
-            <a:off x="6053328" y="3017520"/>
-            <a:ext cx="548640" cy="182880"/>
-          </a:xfrm>
-          <a:prstGeom prst="rect">
-            <a:avLst/>
-          </a:prstGeom>
-          <a:noFill/>
-          <a:ln/>
-        </p:spPr>
-        <p:txBody>
-          <a:bodyPr wrap="square" lIns="0" tIns="0" rIns="0" bIns="0" rtlCol="0" anchor="ctr"/>
-          <a:lstStyle/>
-          <a:p>
-            <a:pPr algn="ctr" indent="0" marL="0">
-              <a:buNone/>
-            </a:pPr>
-            <a:r>
-              <a:rPr lang="en-US" sz="650" b="1" dirty="0">
-                <a:solidFill>
-                  <a:srgbClr val="FFFFFF"/>
-                </a:solidFill>
-                <a:latin typeface="Calibri" pitchFamily="34" charset="0"/>
-                <a:ea typeface="Calibri" pitchFamily="34" charset="-122"/>
-                <a:cs typeface="Calibri" pitchFamily="34" charset="-120"/>
-              </a:rPr>
-              <a:t>Year 2</a:t>
-            </a:r>
-            <a:endParaRPr lang="en-US" sz="650" dirty="0"/>
-          </a:p>
-        </p:txBody>
-      </p:sp>
-      <p:pic>
-        <p:nvPicPr>
-          <p:cNvPr id="50" name="Image 6" descr="preencoded.png">    </p:cNvPr>
-          <p:cNvPicPr>
-            <a:picLocks noChangeAspect="1"/>
-          </p:cNvPicPr>
-          <p:nvPr/>
-        </p:nvPicPr>
-        <p:blipFill>
-          <a:blip r:embed="rId7"/>
-          <a:stretch>
-            <a:fillRect/>
-          </a:stretch>
-        </p:blipFill>
-        <p:spPr>
-          <a:xfrm>
-            <a:off x="4700016" y="3072384"/>
-            <a:ext cx="310896" cy="310896"/>
-          </a:xfrm>
-          <a:prstGeom prst="rect">
-            <a:avLst/>
-          </a:prstGeom>
-        </p:spPr>
-      </p:pic>
-      <p:sp>
-        <p:nvSpPr>
-          <p:cNvPr id="51" name="Text 42"/>
-          <p:cNvSpPr/>
-          <p:nvPr/>
-        </p:nvSpPr>
-        <p:spPr>
-          <a:xfrm>
-            <a:off x="5065776" y="3017520"/>
-            <a:ext cx="950976" cy="402336"/>
-          </a:xfrm>
-          <a:prstGeom prst="rect">
-            <a:avLst/>
-          </a:prstGeom>
-          <a:noFill/>
-          <a:ln/>
-        </p:spPr>
-        <p:txBody>
-          <a:bodyPr wrap="square" lIns="0" tIns="0" rIns="0" bIns="0" rtlCol="0" anchor="ctr"/>
-          <a:lstStyle/>
-          <a:p>
-            <a:pPr indent="0" marL="0">
-              <a:buNone/>
-            </a:pPr>
-            <a:r>
-              <a:rPr lang="en-US" sz="950" b="1" dirty="0">
-                <a:solidFill>
-                  <a:srgbClr val="06185F"/>
-                </a:solidFill>
-                <a:latin typeface="Calibri" pitchFamily="34" charset="0"/>
-                <a:ea typeface="Calibri" pitchFamily="34" charset="-122"/>
-                <a:cs typeface="Calibri" pitchFamily="34" charset="-120"/>
-              </a:rPr>
-              <a:t>Customer Sentiment Engine</a:t>
-            </a:r>
-            <a:endParaRPr lang="en-US" sz="950" dirty="0"/>
-          </a:p>
-        </p:txBody>
-      </p:sp>
-      <p:sp>
-        <p:nvSpPr>
-          <p:cNvPr id="52" name="Text 43"/>
-          <p:cNvSpPr/>
-          <p:nvPr/>
-        </p:nvSpPr>
-        <p:spPr>
-          <a:xfrm>
-            <a:off x="4681728" y="3493008"/>
-            <a:ext cx="1865376" cy="1225296"/>
-          </a:xfrm>
-          <a:prstGeom prst="rect">
-            <a:avLst/>
-          </a:prstGeom>
-          <a:noFill/>
-          <a:ln/>
-        </p:spPr>
-        <p:txBody>
-          <a:bodyPr wrap="square" lIns="0" tIns="0" rIns="0" bIns="0" rtlCol="0" anchor="ctr"/>
-          <a:lstStyle/>
-          <a:p>
-            <a:pPr indent="0" marL="0">
-              <a:buNone/>
-            </a:pPr>
-            <a:r>
-              <a:rPr lang="en-US" sz="900" dirty="0">
-                <a:solidFill>
-                  <a:srgbClr val="575A5D"/>
-                </a:solidFill>
-                <a:latin typeface="Calibri" pitchFamily="34" charset="0"/>
-                <a:ea typeface="Calibri" pitchFamily="34" charset="-122"/>
-                <a:cs typeface="Calibri" pitchFamily="34" charset="-120"/>
-              </a:rPr>
-              <a:t>NLP analysis of call transcripts and CFPB complaints to generate real-time CX health scores — helping FIs identify and route at-risk relationships before escalation.</a:t>
-            </a:r>
-            <a:endParaRPr lang="en-US" sz="900" dirty="0"/>
-          </a:p>
-        </p:txBody>
-      </p:sp>
-      <p:sp>
-        <p:nvSpPr>
-          <p:cNvPr id="53" name="Shape 44"/>
-          <p:cNvSpPr/>
-          <p:nvPr/>
-        </p:nvSpPr>
-        <p:spPr>
-          <a:xfrm>
-            <a:off x="6793992" y="2889504"/>
-            <a:ext cx="2084832" cy="1938528"/>
-          </a:xfrm>
-          <a:prstGeom prst="rect">
-            <a:avLst/>
-          </a:prstGeom>
-          <a:solidFill>
-            <a:srgbClr val="FFFFFF"/>
-          </a:solidFill>
-          <a:ln w="12700">
-            <a:solidFill>
-              <a:srgbClr val="E7ECF0"/>
-            </a:solidFill>
-            <a:prstDash val="solid"/>
-          </a:ln>
-          <a:effectLst>
-            <a:outerShdw sx="100000" sy="100000" kx="0" ky="0" algn="bl" rotWithShape="0" blurRad="101600" dist="38100" dir="8100000">
-              <a:srgbClr val="000000">
-                <a:alpha val="10000"/>
-              </a:srgbClr>
-            </a:outerShdw>
-          </a:effectLst>
-        </p:spPr>
-      </p:sp>
-      <p:sp>
-        <p:nvSpPr>
-          <p:cNvPr id="54" name="Shape 45"/>
-          <p:cNvSpPr/>
-          <p:nvPr/>
-        </p:nvSpPr>
-        <p:spPr>
-          <a:xfrm>
-            <a:off x="6793992" y="2889504"/>
-            <a:ext cx="2084832" cy="73152"/>
+            <a:off x="6016752" y="2889504"/>
+            <a:ext cx="2798064" cy="73152"/>
           </a:xfrm>
           <a:prstGeom prst="rect">
             <a:avLst/>
@@ -17620,13 +17174,13 @@
       </p:sp>
       <p:sp>
         <p:nvSpPr>
-          <p:cNvPr id="55" name="Shape 46"/>
-          <p:cNvSpPr/>
-          <p:nvPr/>
-        </p:nvSpPr>
-        <p:spPr>
-          <a:xfrm>
-            <a:off x="8275320" y="3017520"/>
+          <p:cNvPr id="41" name="Shape 34"/>
+          <p:cNvSpPr/>
+          <p:nvPr/>
+        </p:nvSpPr>
+        <p:spPr>
+          <a:xfrm>
+            <a:off x="8211312" y="3017520"/>
             <a:ext cx="548640" cy="182880"/>
           </a:xfrm>
           <a:prstGeom prst="rect">
@@ -17645,13 +17199,13 @@
       </p:sp>
       <p:sp>
         <p:nvSpPr>
-          <p:cNvPr id="56" name="Text 47"/>
-          <p:cNvSpPr/>
-          <p:nvPr/>
-        </p:nvSpPr>
-        <p:spPr>
-          <a:xfrm>
-            <a:off x="8275320" y="3017520"/>
+          <p:cNvPr id="42" name="Text 35"/>
+          <p:cNvSpPr/>
+          <p:nvPr/>
+        </p:nvSpPr>
+        <p:spPr>
+          <a:xfrm>
+            <a:off x="8211312" y="3017520"/>
             <a:ext cx="548640" cy="182880"/>
           </a:xfrm>
           <a:prstGeom prst="rect">
@@ -17684,21 +17238,21 @@
       </p:sp>
       <p:pic>
         <p:nvPicPr>
-          <p:cNvPr id="57" name="Image 7" descr="preencoded.png">    </p:cNvPr>
+          <p:cNvPr id="43" name="Image 5" descr="preencoded.png">    </p:cNvPr>
           <p:cNvPicPr>
             <a:picLocks noChangeAspect="1"/>
           </p:cNvPicPr>
           <p:nvPr/>
         </p:nvPicPr>
         <p:blipFill>
-          <a:blip r:embed="rId8"/>
+          <a:blip r:embed="rId6"/>
           <a:stretch>
             <a:fillRect/>
           </a:stretch>
         </p:blipFill>
         <p:spPr>
           <a:xfrm>
-            <a:off x="6922008" y="3072384"/>
+            <a:off x="6144768" y="3072384"/>
             <a:ext cx="310896" cy="310896"/>
           </a:xfrm>
           <a:prstGeom prst="rect">
@@ -17708,14 +17262,14 @@
       </p:pic>
       <p:sp>
         <p:nvSpPr>
-          <p:cNvPr id="58" name="Text 48"/>
-          <p:cNvSpPr/>
-          <p:nvPr/>
-        </p:nvSpPr>
-        <p:spPr>
-          <a:xfrm>
-            <a:off x="7287768" y="3017520"/>
-            <a:ext cx="950976" cy="402336"/>
+          <p:cNvPr id="44" name="Text 36"/>
+          <p:cNvSpPr/>
+          <p:nvPr/>
+        </p:nvSpPr>
+        <p:spPr>
+          <a:xfrm>
+            <a:off x="6510528" y="3017520"/>
+            <a:ext cx="1645920" cy="402336"/>
           </a:xfrm>
           <a:prstGeom prst="rect">
             <a:avLst/>
@@ -17747,14 +17301,14 @@
       </p:sp>
       <p:sp>
         <p:nvSpPr>
-          <p:cNvPr id="59" name="Text 49"/>
-          <p:cNvSpPr/>
-          <p:nvPr/>
-        </p:nvSpPr>
-        <p:spPr>
-          <a:xfrm>
-            <a:off x="6903720" y="3493008"/>
-            <a:ext cx="1865376" cy="1225296"/>
+          <p:cNvPr id="45" name="Text 37"/>
+          <p:cNvSpPr/>
+          <p:nvPr/>
+        </p:nvSpPr>
+        <p:spPr>
+          <a:xfrm>
+            <a:off x="6126480" y="3493008"/>
+            <a:ext cx="2578608" cy="1225296"/>
           </a:xfrm>
           <a:prstGeom prst="rect">
             <a:avLst/>
@@ -17786,7 +17340,7 @@
       </p:sp>
       <p:sp>
         <p:nvSpPr>
-          <p:cNvPr id="60" name="Text 50"/>
+          <p:cNvPr id="46" name="Text 38"/>
           <p:cNvSpPr/>
           <p:nvPr/>
         </p:nvSpPr>
@@ -17817,7 +17371,7 @@
                 <a:ea typeface="Calibri" pitchFamily="34" charset="-122"/>
                 <a:cs typeface="Calibri" pitchFamily="34" charset="-120"/>
               </a:rPr>
-              <a:t>Call Report AI and Account Opening LTV are Phase 2 promotions. Remaining six are Year 2 opportunities contingent on Phase 1 delivery and continued investment approval.</a:t>
+              <a:t>Year 2 opportunities contingent on Phase 1 &amp; Phase 2 delivery and continued investment approval.</a:t>
             </a:r>
             <a:endParaRPr lang="en-US" sz="900" dirty="0"/>
           </a:p>
@@ -23316,7 +22870,7 @@
                 <a:ea typeface="Calibri" pitchFamily="34" charset="-122"/>
                 <a:cs typeface="Calibri" pitchFamily="34" charset="-120"/>
               </a:rPr>
-              <a:t>NCUA 5300 Call Reports</a:t>
+              <a:t>ACH / EPS</a:t>
             </a:r>
             <a:endParaRPr lang="en-US" sz="850" dirty="0"/>
           </a:p>
@@ -23355,7 +22909,7 @@
                 <a:ea typeface="Calibri" pitchFamily="34" charset="-122"/>
                 <a:cs typeface="Calibri" pitchFamily="34" charset="-120"/>
               </a:rPr>
-              <a:t>Public regulatory</a:t>
+              <a:t>ACH credits, debits, RDC</a:t>
             </a:r>
             <a:endParaRPr lang="en-US" sz="750" dirty="0"/>
           </a:p>
@@ -23370,7 +22924,7 @@
         <p:spPr>
           <a:xfrm>
             <a:off x="2505456" y="1737360"/>
-            <a:ext cx="715518" cy="182880"/>
+            <a:ext cx="1504188" cy="182880"/>
           </a:xfrm>
           <a:prstGeom prst="rect">
             <a:avLst/>
@@ -23394,8 +22948,8 @@
         </p:nvSpPr>
         <p:spPr>
           <a:xfrm>
-            <a:off x="3275838" y="1737360"/>
-            <a:ext cx="2194560" cy="182880"/>
+            <a:off x="2569464" y="1737360"/>
+            <a:ext cx="1394460" cy="182880"/>
           </a:xfrm>
           <a:prstGeom prst="rect">
             <a:avLst/>
@@ -23411,15 +22965,15 @@
               <a:buNone/>
             </a:pPr>
             <a:r>
-              <a:rPr lang="en-US" sz="750" i="1" dirty="0">
-                <a:solidFill>
-                  <a:srgbClr val="085CE5"/>
-                </a:solidFill>
-                <a:latin typeface="Calibri" pitchFamily="34" charset="0"/>
-                <a:ea typeface="Calibri" pitchFamily="34" charset="-122"/>
-                <a:cs typeface="Calibri" pitchFamily="34" charset="-120"/>
-              </a:rPr>
-              <a:t>Call Report AI</a:t>
+              <a:rPr lang="en-US" sz="750" dirty="0">
+                <a:solidFill>
+                  <a:srgbClr val="FFFFFF"/>
+                </a:solidFill>
+                <a:latin typeface="Calibri" pitchFamily="34" charset="0"/>
+                <a:ea typeface="Calibri" pitchFamily="34" charset="-122"/>
+                <a:cs typeface="Calibri" pitchFamily="34" charset="-120"/>
+              </a:rPr>
+              <a:t>Anomaly Detection</a:t>
             </a:r>
             <a:endParaRPr lang="en-US" sz="750" dirty="0"/>
           </a:p>
@@ -23508,7 +23062,7 @@
                 <a:ea typeface="Calibri" pitchFamily="34" charset="-122"/>
                 <a:cs typeface="Calibri" pitchFamily="34" charset="-120"/>
               </a:rPr>
-              <a:t>ACH / EPS</a:t>
+              <a:t>Zelle / JHA PayCenter</a:t>
             </a:r>
             <a:endParaRPr lang="en-US" sz="850" dirty="0"/>
           </a:p>
@@ -23547,7 +23101,7 @@
                 <a:ea typeface="Calibri" pitchFamily="34" charset="-122"/>
                 <a:cs typeface="Calibri" pitchFamily="34" charset="-120"/>
               </a:rPr>
-              <a:t>ACH credits, debits, RDC</a:t>
+              <a:t>P2P, Zelle, RTP, FedNow</a:t>
             </a:r>
             <a:endParaRPr lang="en-US" sz="750" dirty="0"/>
           </a:p>
@@ -23611,7 +23165,7 @@
                 <a:ea typeface="Calibri" pitchFamily="34" charset="-122"/>
                 <a:cs typeface="Calibri" pitchFamily="34" charset="-120"/>
               </a:rPr>
-              <a:t>Anomaly Detection</a:t>
+              <a:t>Zelle Memo Intelligence · Anomaly</a:t>
             </a:r>
             <a:endParaRPr lang="en-US" sz="750" dirty="0"/>
           </a:p>
@@ -23700,7 +23254,7 @@
                 <a:ea typeface="Calibri" pitchFamily="34" charset="-122"/>
                 <a:cs typeface="Calibri" pitchFamily="34" charset="-120"/>
               </a:rPr>
-              <a:t>Zelle / JHA PayCenter</a:t>
+              <a:t>Jack Henry Wires</a:t>
             </a:r>
             <a:endParaRPr lang="en-US" sz="850" dirty="0"/>
           </a:p>
@@ -23739,7 +23293,7 @@
                 <a:ea typeface="Calibri" pitchFamily="34" charset="-122"/>
                 <a:cs typeface="Calibri" pitchFamily="34" charset="-120"/>
               </a:rPr>
-              <a:t>P2P, Zelle, RTP, FedNow</a:t>
+              <a:t>Domestic FedWire + Intl</a:t>
             </a:r>
             <a:endParaRPr lang="en-US" sz="750" dirty="0"/>
           </a:p>
@@ -23803,7 +23357,7 @@
                 <a:ea typeface="Calibri" pitchFamily="34" charset="-122"/>
                 <a:cs typeface="Calibri" pitchFamily="34" charset="-120"/>
               </a:rPr>
-              <a:t>Zelle Memo Intelligence · Anomaly</a:t>
+              <a:t>Anomaly Detection (wire fraud)</a:t>
             </a:r>
             <a:endParaRPr lang="en-US" sz="750" dirty="0"/>
           </a:p>
@@ -23892,7 +23446,7 @@
                 <a:ea typeface="Calibri" pitchFamily="34" charset="-122"/>
                 <a:cs typeface="Calibri" pitchFamily="34" charset="-120"/>
               </a:rPr>
-              <a:t>Jack Henry Wires</a:t>
+              <a:t>iPay Bill Pay</a:t>
             </a:r>
             <a:endParaRPr lang="en-US" sz="850" dirty="0"/>
           </a:p>
@@ -23931,7 +23485,7 @@
                 <a:ea typeface="Calibri" pitchFamily="34" charset="-122"/>
                 <a:cs typeface="Calibri" pitchFamily="34" charset="-120"/>
               </a:rPr>
-              <a:t>Domestic FedWire + Intl</a:t>
+              <a:t>Consumer + Business bill pay</a:t>
             </a:r>
             <a:endParaRPr lang="en-US" sz="750" dirty="0"/>
           </a:p>
@@ -23995,7 +23549,7 @@
                 <a:ea typeface="Calibri" pitchFamily="34" charset="-122"/>
                 <a:cs typeface="Calibri" pitchFamily="34" charset="-120"/>
               </a:rPr>
-              <a:t>Anomaly Detection (wire fraud)</a:t>
+              <a:t>Cross-Sell Propensity</a:t>
             </a:r>
             <a:endParaRPr lang="en-US" sz="750" dirty="0"/>
           </a:p>
@@ -24084,7 +23638,7 @@
                 <a:ea typeface="Calibri" pitchFamily="34" charset="-122"/>
                 <a:cs typeface="Calibri" pitchFamily="34" charset="-120"/>
               </a:rPr>
-              <a:t>iPay Bill Pay</a:t>
+              <a:t>JHA SmartPay / Biz Payments</a:t>
             </a:r>
             <a:endParaRPr lang="en-US" sz="850" dirty="0"/>
           </a:p>
@@ -24123,7 +23677,7 @@
                 <a:ea typeface="Calibri" pitchFamily="34" charset="-122"/>
                 <a:cs typeface="Calibri" pitchFamily="34" charset="-120"/>
               </a:rPr>
-              <a:t>Consumer + Business bill pay</a:t>
+              <a:t>B2B ACH, vendor, remittance</a:t>
             </a:r>
             <a:endParaRPr lang="en-US" sz="750" dirty="0"/>
           </a:p>
@@ -24187,7 +23741,7 @@
                 <a:ea typeface="Calibri" pitchFamily="34" charset="-122"/>
                 <a:cs typeface="Calibri" pitchFamily="34" charset="-120"/>
               </a:rPr>
-              <a:t>Cross-Sell Propensity</a:t>
+              <a:t>Overdraft Prediction</a:t>
             </a:r>
             <a:endParaRPr lang="en-US" sz="750" dirty="0"/>
           </a:p>
@@ -24276,7 +23830,7 @@
                 <a:ea typeface="Calibri" pitchFamily="34" charset="-122"/>
                 <a:cs typeface="Calibri" pitchFamily="34" charset="-120"/>
               </a:rPr>
-              <a:t>JHA SmartPay / Biz Payments</a:t>
+              <a:t>Payrailz (P2P / A2A)</a:t>
             </a:r>
             <a:endParaRPr lang="en-US" sz="850" dirty="0"/>
           </a:p>
@@ -24315,7 +23869,7 @@
                 <a:ea typeface="Calibri" pitchFamily="34" charset="-122"/>
                 <a:cs typeface="Calibri" pitchFamily="34" charset="-120"/>
               </a:rPr>
-              <a:t>B2B ACH, vendor, remittance</a:t>
+              <a:t>Pay a Person, Transfer Money</a:t>
             </a:r>
             <a:endParaRPr lang="en-US" sz="750" dirty="0"/>
           </a:p>
@@ -24379,7 +23933,7 @@
                 <a:ea typeface="Calibri" pitchFamily="34" charset="-122"/>
                 <a:cs typeface="Calibri" pitchFamily="34" charset="-120"/>
               </a:rPr>
-              <a:t>Overdraft Prediction</a:t>
+              <a:t>Fraud Ring Detection</a:t>
             </a:r>
             <a:endParaRPr lang="en-US" sz="750" dirty="0"/>
           </a:p>
@@ -24425,11 +23979,11 @@
             <a:avLst/>
           </a:prstGeom>
           <a:solidFill>
-            <a:srgbClr val="085CE5"/>
+            <a:srgbClr val="073FA8"/>
           </a:solidFill>
           <a:ln w="12700">
             <a:solidFill>
-              <a:srgbClr val="085CE5"/>
+              <a:srgbClr val="073FA8"/>
             </a:solidFill>
             <a:prstDash val="solid"/>
           </a:ln>
@@ -24468,7 +24022,7 @@
                 <a:ea typeface="Calibri" pitchFamily="34" charset="-122"/>
                 <a:cs typeface="Calibri" pitchFamily="34" charset="-120"/>
               </a:rPr>
-              <a:t>Payrailz (P2P / A2A)</a:t>
+              <a:t>Core Banking (jhaEnterprise / Symitar)</a:t>
             </a:r>
             <a:endParaRPr lang="en-US" sz="850" dirty="0"/>
           </a:p>
@@ -24507,7 +24061,7 @@
                 <a:ea typeface="Calibri" pitchFamily="34" charset="-122"/>
                 <a:cs typeface="Calibri" pitchFamily="34" charset="-120"/>
               </a:rPr>
-              <a:t>Pay a Person, Transfer Money</a:t>
+              <a:t>Core txns, deposits, loans</a:t>
             </a:r>
             <a:endParaRPr lang="en-US" sz="750" dirty="0"/>
           </a:p>
@@ -24521,18 +24075,18 @@
         </p:nvSpPr>
         <p:spPr>
           <a:xfrm>
-            <a:off x="2505456" y="4041648"/>
+            <a:off x="4082796" y="4041648"/>
             <a:ext cx="1504188" cy="182880"/>
           </a:xfrm>
           <a:prstGeom prst="rect">
             <a:avLst/>
           </a:prstGeom>
           <a:solidFill>
-            <a:srgbClr val="085CE5"/>
+            <a:srgbClr val="073FA8"/>
           </a:solidFill>
           <a:ln w="12700">
             <a:solidFill>
-              <a:srgbClr val="085CE5"/>
+              <a:srgbClr val="073FA8"/>
             </a:solidFill>
             <a:prstDash val="solid"/>
           </a:ln>
@@ -24546,7 +24100,7 @@
         </p:nvSpPr>
         <p:spPr>
           <a:xfrm>
-            <a:off x="2569464" y="4041648"/>
+            <a:off x="4146804" y="4041648"/>
             <a:ext cx="1394460" cy="182880"/>
           </a:xfrm>
           <a:prstGeom prst="rect">
@@ -24571,7 +24125,7 @@
                 <a:ea typeface="Calibri" pitchFamily="34" charset="-122"/>
                 <a:cs typeface="Calibri" pitchFamily="34" charset="-120"/>
               </a:rPr>
-              <a:t>Fraud Ring Detection</a:t>
+              <a:t>Churn Mediation · Acct Opening LTV · Personal-as-Commercial · Wealth Deflection</a:t>
             </a:r>
             <a:endParaRPr lang="en-US" sz="750" dirty="0"/>
           </a:p>
@@ -24617,11 +24171,11 @@
             <a:avLst/>
           </a:prstGeom>
           <a:solidFill>
-            <a:srgbClr val="073FA8"/>
+            <a:srgbClr val="575A5D"/>
           </a:solidFill>
           <a:ln w="12700">
             <a:solidFill>
-              <a:srgbClr val="073FA8"/>
+              <a:srgbClr val="575A5D"/>
             </a:solidFill>
             <a:prstDash val="solid"/>
           </a:ln>
@@ -24660,7 +24214,7 @@
                 <a:ea typeface="Calibri" pitchFamily="34" charset="-122"/>
                 <a:cs typeface="Calibri" pitchFamily="34" charset="-120"/>
               </a:rPr>
-              <a:t>Core Banking (jhaEnterprise / Symitar)</a:t>
+              <a:t>Banno Digital + Lending</a:t>
             </a:r>
             <a:endParaRPr lang="en-US" sz="850" dirty="0"/>
           </a:p>
@@ -24699,7 +24253,7 @@
                 <a:ea typeface="Calibri" pitchFamily="34" charset="-122"/>
                 <a:cs typeface="Calibri" pitchFamily="34" charset="-120"/>
               </a:rPr>
-              <a:t>Core txns, deposits, loans</a:t>
+              <a:t>Session behavior, loan data</a:t>
             </a:r>
             <a:endParaRPr lang="en-US" sz="750" dirty="0"/>
           </a:p>
@@ -24713,97 +24267,8 @@
         </p:nvSpPr>
         <p:spPr>
           <a:xfrm>
-            <a:off x="4082796" y="4425696"/>
-            <a:ext cx="1504188" cy="182880"/>
-          </a:xfrm>
-          <a:prstGeom prst="rect">
-            <a:avLst/>
-          </a:prstGeom>
-          <a:solidFill>
-            <a:srgbClr val="073FA8"/>
-          </a:solidFill>
-          <a:ln w="12700">
-            <a:solidFill>
-              <a:srgbClr val="073FA8"/>
-            </a:solidFill>
-            <a:prstDash val="solid"/>
-          </a:ln>
-        </p:spPr>
-      </p:sp>
-      <p:sp>
-        <p:nvSpPr>
-          <p:cNvPr id="79" name="Text 77"/>
-          <p:cNvSpPr/>
-          <p:nvPr/>
-        </p:nvSpPr>
-        <p:spPr>
-          <a:xfrm>
-            <a:off x="4146804" y="4425696"/>
-            <a:ext cx="1394460" cy="182880"/>
-          </a:xfrm>
-          <a:prstGeom prst="rect">
-            <a:avLst/>
-          </a:prstGeom>
-          <a:noFill/>
-          <a:ln/>
-        </p:spPr>
-        <p:txBody>
-          <a:bodyPr wrap="square" lIns="0" tIns="0" rIns="0" bIns="0" rtlCol="0" anchor="ctr"/>
-          <a:lstStyle/>
-          <a:p>
-            <a:pPr indent="0" marL="0">
-              <a:buNone/>
-            </a:pPr>
-            <a:r>
-              <a:rPr lang="en-US" sz="750" dirty="0">
-                <a:solidFill>
-                  <a:srgbClr val="FFFFFF"/>
-                </a:solidFill>
-                <a:latin typeface="Calibri" pitchFamily="34" charset="0"/>
-                <a:ea typeface="Calibri" pitchFamily="34" charset="-122"/>
-                <a:cs typeface="Calibri" pitchFamily="34" charset="-120"/>
-              </a:rPr>
-              <a:t>Churn Mediation · Acct Opening LTV · Personal-as-Commercial · Wealth Deflection</a:t>
-            </a:r>
-            <a:endParaRPr lang="en-US" sz="750" dirty="0"/>
-          </a:p>
-        </p:txBody>
-      </p:sp>
-      <p:sp>
-        <p:nvSpPr>
-          <p:cNvPr id="80" name="Shape 78"/>
-          <p:cNvSpPr/>
-          <p:nvPr/>
-        </p:nvSpPr>
-        <p:spPr>
-          <a:xfrm>
-            <a:off x="274320" y="4736592"/>
-            <a:ext cx="8503920" cy="356616"/>
-          </a:xfrm>
-          <a:prstGeom prst="rect">
-            <a:avLst/>
-          </a:prstGeom>
-          <a:solidFill>
-            <a:srgbClr val="FFFFFF"/>
-          </a:solidFill>
-          <a:ln w="12700">
-            <a:solidFill>
-              <a:srgbClr val="E7ECF0"/>
-            </a:solidFill>
-            <a:prstDash val="solid"/>
-          </a:ln>
-        </p:spPr>
-      </p:sp>
-      <p:sp>
-        <p:nvSpPr>
-          <p:cNvPr id="81" name="Shape 79"/>
-          <p:cNvSpPr/>
-          <p:nvPr/>
-        </p:nvSpPr>
-        <p:spPr>
-          <a:xfrm>
-            <a:off x="274320" y="4736592"/>
-            <a:ext cx="54864" cy="356616"/>
+            <a:off x="5660136" y="4425696"/>
+            <a:ext cx="2292858" cy="182880"/>
           </a:xfrm>
           <a:prstGeom prst="rect">
             <a:avLst/>
@@ -24821,14 +24286,14 @@
       </p:sp>
       <p:sp>
         <p:nvSpPr>
-          <p:cNvPr id="82" name="Text 80"/>
-          <p:cNvSpPr/>
-          <p:nvPr/>
-        </p:nvSpPr>
-        <p:spPr>
-          <a:xfrm>
-            <a:off x="384048" y="4764024"/>
-            <a:ext cx="1892808" cy="201168"/>
+          <p:cNvPr id="79" name="Text 77"/>
+          <p:cNvSpPr/>
+          <p:nvPr/>
+        </p:nvSpPr>
+        <p:spPr>
+          <a:xfrm>
+            <a:off x="5724144" y="4425696"/>
+            <a:ext cx="2183130" cy="182880"/>
           </a:xfrm>
           <a:prstGeom prst="rect">
             <a:avLst/>
@@ -24844,54 +24309,15 @@
               <a:buNone/>
             </a:pPr>
             <a:r>
-              <a:rPr lang="en-US" sz="850" b="1" dirty="0">
-                <a:solidFill>
-                  <a:srgbClr val="06185F"/>
-                </a:solidFill>
-                <a:latin typeface="Calibri" pitchFamily="34" charset="0"/>
-                <a:ea typeface="Calibri" pitchFamily="34" charset="-122"/>
-                <a:cs typeface="Calibri" pitchFamily="34" charset="-120"/>
-              </a:rPr>
-              <a:t>Banno Digital + Lending</a:t>
-            </a:r>
-            <a:endParaRPr lang="en-US" sz="850" dirty="0"/>
-          </a:p>
-        </p:txBody>
-      </p:sp>
-      <p:sp>
-        <p:nvSpPr>
-          <p:cNvPr id="83" name="Text 81"/>
-          <p:cNvSpPr/>
-          <p:nvPr/>
-        </p:nvSpPr>
-        <p:spPr>
-          <a:xfrm>
-            <a:off x="384048" y="4956048"/>
-            <a:ext cx="1892808" cy="137160"/>
-          </a:xfrm>
-          <a:prstGeom prst="rect">
-            <a:avLst/>
-          </a:prstGeom>
-          <a:noFill/>
-          <a:ln/>
-        </p:spPr>
-        <p:txBody>
-          <a:bodyPr wrap="square" lIns="0" tIns="0" rIns="0" bIns="0" rtlCol="0" anchor="ctr"/>
-          <a:lstStyle/>
-          <a:p>
-            <a:pPr indent="0" marL="0">
-              <a:buNone/>
-            </a:pPr>
-            <a:r>
-              <a:rPr lang="en-US" sz="750" i="1" dirty="0">
-                <a:solidFill>
-                  <a:srgbClr val="B6BBC0"/>
-                </a:solidFill>
-                <a:latin typeface="Calibri" pitchFamily="34" charset="0"/>
-                <a:ea typeface="Calibri" pitchFamily="34" charset="-122"/>
-                <a:cs typeface="Calibri" pitchFamily="34" charset="-120"/>
-              </a:rPr>
-              <a:t>Session behavior, loan data</a:t>
+              <a:rPr lang="en-US" sz="750" dirty="0">
+                <a:solidFill>
+                  <a:srgbClr val="FFFFFF"/>
+                </a:solidFill>
+                <a:latin typeface="Calibri" pitchFamily="34" charset="0"/>
+                <a:ea typeface="Calibri" pitchFamily="34" charset="-122"/>
+                <a:cs typeface="Calibri" pitchFamily="34" charset="-120"/>
+              </a:rPr>
+              <a:t>Sentiment · Next Best Action · FI Decision Studio</a:t>
             </a:r>
             <a:endParaRPr lang="en-US" sz="750" dirty="0"/>
           </a:p>
@@ -24899,71 +24325,7 @@
       </p:sp>
       <p:sp>
         <p:nvSpPr>
-          <p:cNvPr id="84" name="Shape 82"/>
-          <p:cNvSpPr/>
-          <p:nvPr/>
-        </p:nvSpPr>
-        <p:spPr>
-          <a:xfrm>
-            <a:off x="5660136" y="4809744"/>
-            <a:ext cx="2292858" cy="182880"/>
-          </a:xfrm>
-          <a:prstGeom prst="rect">
-            <a:avLst/>
-          </a:prstGeom>
-          <a:solidFill>
-            <a:srgbClr val="575A5D"/>
-          </a:solidFill>
-          <a:ln w="12700">
-            <a:solidFill>
-              <a:srgbClr val="575A5D"/>
-            </a:solidFill>
-            <a:prstDash val="solid"/>
-          </a:ln>
-        </p:spPr>
-      </p:sp>
-      <p:sp>
-        <p:nvSpPr>
-          <p:cNvPr id="85" name="Text 83"/>
-          <p:cNvSpPr/>
-          <p:nvPr/>
-        </p:nvSpPr>
-        <p:spPr>
-          <a:xfrm>
-            <a:off x="5724144" y="4809744"/>
-            <a:ext cx="2183130" cy="182880"/>
-          </a:xfrm>
-          <a:prstGeom prst="rect">
-            <a:avLst/>
-          </a:prstGeom>
-          <a:noFill/>
-          <a:ln/>
-        </p:spPr>
-        <p:txBody>
-          <a:bodyPr wrap="square" lIns="0" tIns="0" rIns="0" bIns="0" rtlCol="0" anchor="ctr"/>
-          <a:lstStyle/>
-          <a:p>
-            <a:pPr indent="0" marL="0">
-              <a:buNone/>
-            </a:pPr>
-            <a:r>
-              <a:rPr lang="en-US" sz="750" dirty="0">
-                <a:solidFill>
-                  <a:srgbClr val="FFFFFF"/>
-                </a:solidFill>
-                <a:latin typeface="Calibri" pitchFamily="34" charset="0"/>
-                <a:ea typeface="Calibri" pitchFamily="34" charset="-122"/>
-                <a:cs typeface="Calibri" pitchFamily="34" charset="-120"/>
-              </a:rPr>
-              <a:t>Sentiment · Next Best Action · FI Decision Studio</a:t>
-            </a:r>
-            <a:endParaRPr lang="en-US" sz="750" dirty="0"/>
-          </a:p>
-        </p:txBody>
-      </p:sp>
-      <p:sp>
-        <p:nvSpPr>
-          <p:cNvPr id="86" name="Shape 84"/>
+          <p:cNvPr id="80" name="Shape 78"/>
           <p:cNvSpPr/>
           <p:nvPr/>
         </p:nvSpPr>
@@ -24988,7 +24350,7 @@
       </p:sp>
       <p:sp>
         <p:nvSpPr>
-          <p:cNvPr id="87" name="Text 85"/>
+          <p:cNvPr id="81" name="Text 79"/>
           <p:cNvSpPr/>
           <p:nvPr/>
         </p:nvSpPr>
@@ -26250,11 +25612,11 @@
             <a:avLst/>
           </a:prstGeom>
           <a:solidFill>
-            <a:srgbClr val="575A5D"/>
+            <a:srgbClr val="06185F"/>
           </a:solidFill>
           <a:ln w="12700">
             <a:solidFill>
-              <a:srgbClr val="575A5D"/>
+              <a:srgbClr val="06185F"/>
             </a:solidFill>
             <a:prstDash val="solid"/>
           </a:ln>
@@ -26293,7 +25655,7 @@
                 <a:ea typeface="Calibri" pitchFamily="34" charset="-122"/>
                 <a:cs typeface="Calibri" pitchFamily="34" charset="-120"/>
               </a:rPr>
-              <a:t>Call Report AI</a:t>
+              <a:t>Zelle Memo Intelligence</a:t>
             </a:r>
             <a:endParaRPr lang="en-US" sz="850" dirty="0"/>
           </a:p>
@@ -26332,7 +25694,7 @@
                 <a:ea typeface="Calibri" pitchFamily="34" charset="-122"/>
                 <a:cs typeface="Calibri" pitchFamily="34" charset="-120"/>
               </a:rPr>
-              <a:t>Aug/Sept 2026 launch</a:t>
+              <a:t>NLP compliance pipeline</a:t>
             </a:r>
             <a:endParaRPr lang="en-US" sz="750" dirty="0"/>
           </a:p>
@@ -26346,20 +25708,20 @@
         </p:nvSpPr>
         <p:spPr>
           <a:xfrm>
-            <a:off x="2542032" y="2157984"/>
-            <a:ext cx="2279142" cy="182880"/>
+            <a:off x="4110228" y="2157984"/>
+            <a:ext cx="1495044" cy="182880"/>
           </a:xfrm>
           <a:prstGeom prst="rect">
             <a:avLst/>
           </a:prstGeom>
           <a:solidFill>
-            <a:srgbClr val="575A5D">
+            <a:srgbClr val="06185F">
               <a:alpha val="70000"/>
             </a:srgbClr>
           </a:solidFill>
           <a:ln w="12700">
             <a:solidFill>
-              <a:srgbClr val="575A5D">
+              <a:srgbClr val="06185F">
                 <a:alpha val="90000"/>
               </a:srgbClr>
             </a:solidFill>
@@ -26375,18 +25737,18 @@
         </p:nvSpPr>
         <p:spPr>
           <a:xfrm>
-            <a:off x="4183014" y="2157984"/>
-            <a:ext cx="638160" cy="182880"/>
+            <a:off x="5186660" y="2157984"/>
+            <a:ext cx="418612" cy="182880"/>
           </a:xfrm>
           <a:prstGeom prst="rect">
             <a:avLst/>
           </a:prstGeom>
           <a:solidFill>
-            <a:srgbClr val="575A5D"/>
+            <a:srgbClr val="06185F"/>
           </a:solidFill>
           <a:ln w="12700">
             <a:solidFill>
-              <a:srgbClr val="575A5D"/>
+              <a:srgbClr val="06185F"/>
             </a:solidFill>
             <a:prstDash val="solid"/>
           </a:ln>
@@ -26400,8 +25762,8 @@
         </p:nvSpPr>
         <p:spPr>
           <a:xfrm>
-            <a:off x="2606040" y="2157984"/>
-            <a:ext cx="2151126" cy="182880"/>
+            <a:off x="4174236" y="2157984"/>
+            <a:ext cx="1367028" cy="182880"/>
           </a:xfrm>
           <a:prstGeom prst="rect">
             <a:avLst/>
@@ -26425,7 +25787,7 @@
                 <a:ea typeface="Calibri" pitchFamily="34" charset="-122"/>
                 <a:cs typeface="Calibri" pitchFamily="34" charset="-120"/>
               </a:rPr>
-              <a:t>Active dev  →  Aug/Sept '26</a:t>
+              <a:t>Build  →  Phase 2 launch</a:t>
             </a:r>
             <a:endParaRPr lang="en-US" sz="750" dirty="0"/>
           </a:p>
@@ -26471,6 +25833,448 @@
             <a:avLst/>
           </a:prstGeom>
           <a:solidFill>
+            <a:srgbClr val="0A52C4"/>
+          </a:solidFill>
+          <a:ln w="12700">
+            <a:solidFill>
+              <a:srgbClr val="0A52C4"/>
+            </a:solidFill>
+            <a:prstDash val="solid"/>
+          </a:ln>
+        </p:spPr>
+      </p:sp>
+      <p:sp>
+        <p:nvSpPr>
+          <p:cNvPr id="48" name="Text 46"/>
+          <p:cNvSpPr/>
+          <p:nvPr/>
+        </p:nvSpPr>
+        <p:spPr>
+          <a:xfrm>
+            <a:off x="384048" y="2496312"/>
+            <a:ext cx="1938528" cy="201168"/>
+          </a:xfrm>
+          <a:prstGeom prst="rect">
+            <a:avLst/>
+          </a:prstGeom>
+          <a:noFill/>
+          <a:ln/>
+        </p:spPr>
+        <p:txBody>
+          <a:bodyPr wrap="square" lIns="0" tIns="0" rIns="0" bIns="0" rtlCol="0" anchor="ctr"/>
+          <a:lstStyle/>
+          <a:p>
+            <a:pPr indent="0" marL="0">
+              <a:buNone/>
+            </a:pPr>
+            <a:r>
+              <a:rPr lang="en-US" sz="850" b="1" dirty="0">
+                <a:solidFill>
+                  <a:srgbClr val="06185F"/>
+                </a:solidFill>
+                <a:latin typeface="Calibri" pitchFamily="34" charset="0"/>
+                <a:ea typeface="Calibri" pitchFamily="34" charset="-122"/>
+                <a:cs typeface="Calibri" pitchFamily="34" charset="-120"/>
+              </a:rPr>
+              <a:t>Personal-as-Commercial</a:t>
+            </a:r>
+            <a:endParaRPr lang="en-US" sz="850" dirty="0"/>
+          </a:p>
+        </p:txBody>
+      </p:sp>
+      <p:sp>
+        <p:nvSpPr>
+          <p:cNvPr id="49" name="Text 47"/>
+          <p:cNvSpPr/>
+          <p:nvPr/>
+        </p:nvSpPr>
+        <p:spPr>
+          <a:xfrm>
+            <a:off x="384048" y="2697480"/>
+            <a:ext cx="1938528" cy="137160"/>
+          </a:xfrm>
+          <a:prstGeom prst="rect">
+            <a:avLst/>
+          </a:prstGeom>
+          <a:noFill/>
+          <a:ln/>
+        </p:spPr>
+        <p:txBody>
+          <a:bodyPr wrap="square" lIns="0" tIns="0" rIns="0" bIns="0" rtlCol="0" anchor="ctr"/>
+          <a:lstStyle/>
+          <a:p>
+            <a:pPr indent="0" marL="0">
+              <a:buNone/>
+            </a:pPr>
+            <a:r>
+              <a:rPr lang="en-US" sz="750" i="1" dirty="0">
+                <a:solidFill>
+                  <a:srgbClr val="B6BBC0"/>
+                </a:solidFill>
+                <a:latin typeface="Calibri" pitchFamily="34" charset="0"/>
+                <a:ea typeface="Calibri" pitchFamily="34" charset="-122"/>
+                <a:cs typeface="Calibri" pitchFamily="34" charset="-120"/>
+              </a:rPr>
+              <a:t>SMB conversion model</a:t>
+            </a:r>
+            <a:endParaRPr lang="en-US" sz="750" dirty="0"/>
+          </a:p>
+        </p:txBody>
+      </p:sp>
+      <p:sp>
+        <p:nvSpPr>
+          <p:cNvPr id="50" name="Shape 48"/>
+          <p:cNvSpPr/>
+          <p:nvPr/>
+        </p:nvSpPr>
+        <p:spPr>
+          <a:xfrm>
+            <a:off x="4110228" y="2560320"/>
+            <a:ext cx="1495044" cy="182880"/>
+          </a:xfrm>
+          <a:prstGeom prst="rect">
+            <a:avLst/>
+          </a:prstGeom>
+          <a:solidFill>
+            <a:srgbClr val="0A52C4">
+              <a:alpha val="70000"/>
+            </a:srgbClr>
+          </a:solidFill>
+          <a:ln w="12700">
+            <a:solidFill>
+              <a:srgbClr val="0A52C4">
+                <a:alpha val="90000"/>
+              </a:srgbClr>
+            </a:solidFill>
+            <a:prstDash val="solid"/>
+          </a:ln>
+        </p:spPr>
+      </p:sp>
+      <p:sp>
+        <p:nvSpPr>
+          <p:cNvPr id="51" name="Shape 49"/>
+          <p:cNvSpPr/>
+          <p:nvPr/>
+        </p:nvSpPr>
+        <p:spPr>
+          <a:xfrm>
+            <a:off x="5186660" y="2560320"/>
+            <a:ext cx="418612" cy="182880"/>
+          </a:xfrm>
+          <a:prstGeom prst="rect">
+            <a:avLst/>
+          </a:prstGeom>
+          <a:solidFill>
+            <a:srgbClr val="0A52C4"/>
+          </a:solidFill>
+          <a:ln w="12700">
+            <a:solidFill>
+              <a:srgbClr val="0A52C4"/>
+            </a:solidFill>
+            <a:prstDash val="solid"/>
+          </a:ln>
+        </p:spPr>
+      </p:sp>
+      <p:sp>
+        <p:nvSpPr>
+          <p:cNvPr id="52" name="Text 50"/>
+          <p:cNvSpPr/>
+          <p:nvPr/>
+        </p:nvSpPr>
+        <p:spPr>
+          <a:xfrm>
+            <a:off x="4174236" y="2560320"/>
+            <a:ext cx="1367028" cy="182880"/>
+          </a:xfrm>
+          <a:prstGeom prst="rect">
+            <a:avLst/>
+          </a:prstGeom>
+          <a:noFill/>
+          <a:ln/>
+        </p:spPr>
+        <p:txBody>
+          <a:bodyPr wrap="square" lIns="0" tIns="0" rIns="0" bIns="0" rtlCol="0" anchor="ctr"/>
+          <a:lstStyle/>
+          <a:p>
+            <a:pPr indent="0" marL="0">
+              <a:buNone/>
+            </a:pPr>
+            <a:r>
+              <a:rPr lang="en-US" sz="750" dirty="0">
+                <a:solidFill>
+                  <a:srgbClr val="FFFFFF"/>
+                </a:solidFill>
+                <a:latin typeface="Calibri" pitchFamily="34" charset="0"/>
+                <a:ea typeface="Calibri" pitchFamily="34" charset="-122"/>
+                <a:cs typeface="Calibri" pitchFamily="34" charset="-120"/>
+              </a:rPr>
+              <a:t>Build  →  Phase 2 launch</a:t>
+            </a:r>
+            <a:endParaRPr lang="en-US" sz="750" dirty="0"/>
+          </a:p>
+        </p:txBody>
+      </p:sp>
+      <p:sp>
+        <p:nvSpPr>
+          <p:cNvPr id="53" name="Shape 51"/>
+          <p:cNvSpPr/>
+          <p:nvPr/>
+        </p:nvSpPr>
+        <p:spPr>
+          <a:xfrm>
+            <a:off x="274320" y="2871216"/>
+            <a:ext cx="8503920" cy="374904"/>
+          </a:xfrm>
+          <a:prstGeom prst="rect">
+            <a:avLst/>
+          </a:prstGeom>
+          <a:solidFill>
+            <a:srgbClr val="F8F9FA"/>
+          </a:solidFill>
+          <a:ln w="12700">
+            <a:solidFill>
+              <a:srgbClr val="E7ECF0"/>
+            </a:solidFill>
+            <a:prstDash val="solid"/>
+          </a:ln>
+        </p:spPr>
+      </p:sp>
+      <p:sp>
+        <p:nvSpPr>
+          <p:cNvPr id="54" name="Shape 52"/>
+          <p:cNvSpPr/>
+          <p:nvPr/>
+        </p:nvSpPr>
+        <p:spPr>
+          <a:xfrm>
+            <a:off x="274320" y="2871216"/>
+            <a:ext cx="54864" cy="374904"/>
+          </a:xfrm>
+          <a:prstGeom prst="rect">
+            <a:avLst/>
+          </a:prstGeom>
+          <a:solidFill>
+            <a:srgbClr val="0F3D8A"/>
+          </a:solidFill>
+          <a:ln w="12700">
+            <a:solidFill>
+              <a:srgbClr val="0F3D8A"/>
+            </a:solidFill>
+            <a:prstDash val="solid"/>
+          </a:ln>
+        </p:spPr>
+      </p:sp>
+      <p:sp>
+        <p:nvSpPr>
+          <p:cNvPr id="55" name="Text 53"/>
+          <p:cNvSpPr/>
+          <p:nvPr/>
+        </p:nvSpPr>
+        <p:spPr>
+          <a:xfrm>
+            <a:off x="384048" y="2898648"/>
+            <a:ext cx="1938528" cy="201168"/>
+          </a:xfrm>
+          <a:prstGeom prst="rect">
+            <a:avLst/>
+          </a:prstGeom>
+          <a:noFill/>
+          <a:ln/>
+        </p:spPr>
+        <p:txBody>
+          <a:bodyPr wrap="square" lIns="0" tIns="0" rIns="0" bIns="0" rtlCol="0" anchor="ctr"/>
+          <a:lstStyle/>
+          <a:p>
+            <a:pPr indent="0" marL="0">
+              <a:buNone/>
+            </a:pPr>
+            <a:r>
+              <a:rPr lang="en-US" sz="850" b="1" dirty="0">
+                <a:solidFill>
+                  <a:srgbClr val="06185F"/>
+                </a:solidFill>
+                <a:latin typeface="Calibri" pitchFamily="34" charset="0"/>
+                <a:ea typeface="Calibri" pitchFamily="34" charset="-122"/>
+                <a:cs typeface="Calibri" pitchFamily="34" charset="-120"/>
+              </a:rPr>
+              <a:t>Gen. Wealth Deflection</a:t>
+            </a:r>
+            <a:endParaRPr lang="en-US" sz="850" dirty="0"/>
+          </a:p>
+        </p:txBody>
+      </p:sp>
+      <p:sp>
+        <p:nvSpPr>
+          <p:cNvPr id="56" name="Text 54"/>
+          <p:cNvSpPr/>
+          <p:nvPr/>
+        </p:nvSpPr>
+        <p:spPr>
+          <a:xfrm>
+            <a:off x="384048" y="3099816"/>
+            <a:ext cx="1938528" cy="137160"/>
+          </a:xfrm>
+          <a:prstGeom prst="rect">
+            <a:avLst/>
+          </a:prstGeom>
+          <a:noFill/>
+          <a:ln/>
+        </p:spPr>
+        <p:txBody>
+          <a:bodyPr wrap="square" lIns="0" tIns="0" rIns="0" bIns="0" rtlCol="0" anchor="ctr"/>
+          <a:lstStyle/>
+          <a:p>
+            <a:pPr indent="0" marL="0">
+              <a:buNone/>
+            </a:pPr>
+            <a:r>
+              <a:rPr lang="en-US" sz="750" i="1" dirty="0">
+                <a:solidFill>
+                  <a:srgbClr val="B6BBC0"/>
+                </a:solidFill>
+                <a:latin typeface="Calibri" pitchFamily="34" charset="0"/>
+                <a:ea typeface="Calibri" pitchFamily="34" charset="-122"/>
+                <a:cs typeface="Calibri" pitchFamily="34" charset="-120"/>
+              </a:rPr>
+              <a:t>Household coverage model</a:t>
+            </a:r>
+            <a:endParaRPr lang="en-US" sz="750" dirty="0"/>
+          </a:p>
+        </p:txBody>
+      </p:sp>
+      <p:sp>
+        <p:nvSpPr>
+          <p:cNvPr id="57" name="Shape 55"/>
+          <p:cNvSpPr/>
+          <p:nvPr/>
+        </p:nvSpPr>
+        <p:spPr>
+          <a:xfrm>
+            <a:off x="4110228" y="2962656"/>
+            <a:ext cx="2279142" cy="182880"/>
+          </a:xfrm>
+          <a:prstGeom prst="rect">
+            <a:avLst/>
+          </a:prstGeom>
+          <a:solidFill>
+            <a:srgbClr val="0F3D8A">
+              <a:alpha val="70000"/>
+            </a:srgbClr>
+          </a:solidFill>
+          <a:ln w="12700">
+            <a:solidFill>
+              <a:srgbClr val="0F3D8A">
+                <a:alpha val="90000"/>
+              </a:srgbClr>
+            </a:solidFill>
+            <a:prstDash val="solid"/>
+          </a:ln>
+        </p:spPr>
+      </p:sp>
+      <p:sp>
+        <p:nvSpPr>
+          <p:cNvPr id="58" name="Shape 56"/>
+          <p:cNvSpPr/>
+          <p:nvPr/>
+        </p:nvSpPr>
+        <p:spPr>
+          <a:xfrm>
+            <a:off x="5751210" y="2962656"/>
+            <a:ext cx="638160" cy="182880"/>
+          </a:xfrm>
+          <a:prstGeom prst="rect">
+            <a:avLst/>
+          </a:prstGeom>
+          <a:solidFill>
+            <a:srgbClr val="0F3D8A"/>
+          </a:solidFill>
+          <a:ln w="12700">
+            <a:solidFill>
+              <a:srgbClr val="0F3D8A"/>
+            </a:solidFill>
+            <a:prstDash val="solid"/>
+          </a:ln>
+        </p:spPr>
+      </p:sp>
+      <p:sp>
+        <p:nvSpPr>
+          <p:cNvPr id="59" name="Text 57"/>
+          <p:cNvSpPr/>
+          <p:nvPr/>
+        </p:nvSpPr>
+        <p:spPr>
+          <a:xfrm>
+            <a:off x="4174236" y="2962656"/>
+            <a:ext cx="2151126" cy="182880"/>
+          </a:xfrm>
+          <a:prstGeom prst="rect">
+            <a:avLst/>
+          </a:prstGeom>
+          <a:noFill/>
+          <a:ln/>
+        </p:spPr>
+        <p:txBody>
+          <a:bodyPr wrap="square" lIns="0" tIns="0" rIns="0" bIns="0" rtlCol="0" anchor="ctr"/>
+          <a:lstStyle/>
+          <a:p>
+            <a:pPr indent="0" marL="0">
+              <a:buNone/>
+            </a:pPr>
+            <a:r>
+              <a:rPr lang="en-US" sz="750" dirty="0">
+                <a:solidFill>
+                  <a:srgbClr val="FFFFFF"/>
+                </a:solidFill>
+                <a:latin typeface="Calibri" pitchFamily="34" charset="0"/>
+                <a:ea typeface="Calibri" pitchFamily="34" charset="-122"/>
+                <a:cs typeface="Calibri" pitchFamily="34" charset="-120"/>
+              </a:rPr>
+              <a:t>Phase 2 build  →  Phase 3</a:t>
+            </a:r>
+            <a:endParaRPr lang="en-US" sz="750" dirty="0"/>
+          </a:p>
+        </p:txBody>
+      </p:sp>
+      <p:sp>
+        <p:nvSpPr>
+          <p:cNvPr id="60" name="Shape 58"/>
+          <p:cNvSpPr/>
+          <p:nvPr/>
+        </p:nvSpPr>
+        <p:spPr>
+          <a:xfrm>
+            <a:off x="274320" y="3273552"/>
+            <a:ext cx="8503920" cy="374904"/>
+          </a:xfrm>
+          <a:prstGeom prst="rect">
+            <a:avLst/>
+          </a:prstGeom>
+          <a:solidFill>
+            <a:srgbClr val="FFFFFF"/>
+          </a:solidFill>
+          <a:ln w="12700">
+            <a:solidFill>
+              <a:srgbClr val="E7ECF0"/>
+            </a:solidFill>
+            <a:prstDash val="solid"/>
+          </a:ln>
+        </p:spPr>
+      </p:sp>
+      <p:sp>
+        <p:nvSpPr>
+          <p:cNvPr id="61" name="Shape 59"/>
+          <p:cNvSpPr/>
+          <p:nvPr/>
+        </p:nvSpPr>
+        <p:spPr>
+          <a:xfrm>
+            <a:off x="274320" y="3273552"/>
+            <a:ext cx="54864" cy="374904"/>
+          </a:xfrm>
+          <a:prstGeom prst="rect">
+            <a:avLst/>
+          </a:prstGeom>
+          <a:solidFill>
             <a:srgbClr val="073FA8"/>
           </a:solidFill>
           <a:ln w="12700">
@@ -26483,13 +26287,13 @@
       </p:sp>
       <p:sp>
         <p:nvSpPr>
-          <p:cNvPr id="48" name="Text 46"/>
-          <p:cNvSpPr/>
-          <p:nvPr/>
-        </p:nvSpPr>
-        <p:spPr>
-          <a:xfrm>
-            <a:off x="384048" y="2496312"/>
+          <p:cNvPr id="62" name="Text 60"/>
+          <p:cNvSpPr/>
+          <p:nvPr/>
+        </p:nvSpPr>
+        <p:spPr>
+          <a:xfrm>
+            <a:off x="384048" y="3300984"/>
             <a:ext cx="1938528" cy="201168"/>
           </a:xfrm>
           <a:prstGeom prst="rect">
@@ -26522,13 +26326,13 @@
       </p:sp>
       <p:sp>
         <p:nvSpPr>
-          <p:cNvPr id="49" name="Text 47"/>
-          <p:cNvSpPr/>
-          <p:nvPr/>
-        </p:nvSpPr>
-        <p:spPr>
-          <a:xfrm>
-            <a:off x="384048" y="2697480"/>
+          <p:cNvPr id="63" name="Text 61"/>
+          <p:cNvSpPr/>
+          <p:nvPr/>
+        </p:nvSpPr>
+        <p:spPr>
+          <a:xfrm>
+            <a:off x="384048" y="3502152"/>
             <a:ext cx="1938528" cy="137160"/>
           </a:xfrm>
           <a:prstGeom prst="rect">
@@ -26561,13 +26365,13 @@
       </p:sp>
       <p:sp>
         <p:nvSpPr>
-          <p:cNvPr id="50" name="Shape 48"/>
-          <p:cNvSpPr/>
-          <p:nvPr/>
-        </p:nvSpPr>
-        <p:spPr>
-          <a:xfrm>
-            <a:off x="3326130" y="2560320"/>
+          <p:cNvPr id="64" name="Shape 62"/>
+          <p:cNvSpPr/>
+          <p:nvPr/>
+        </p:nvSpPr>
+        <p:spPr>
+          <a:xfrm>
+            <a:off x="5678424" y="3364992"/>
             <a:ext cx="2279142" cy="182880"/>
           </a:xfrm>
           <a:prstGeom prst="rect">
@@ -26590,13 +26394,13 @@
       </p:sp>
       <p:sp>
         <p:nvSpPr>
-          <p:cNvPr id="51" name="Shape 49"/>
-          <p:cNvSpPr/>
-          <p:nvPr/>
-        </p:nvSpPr>
-        <p:spPr>
-          <a:xfrm>
-            <a:off x="4967112" y="2560320"/>
+          <p:cNvPr id="65" name="Shape 63"/>
+          <p:cNvSpPr/>
+          <p:nvPr/>
+        </p:nvSpPr>
+        <p:spPr>
+          <a:xfrm>
+            <a:off x="7319406" y="3364992"/>
             <a:ext cx="638160" cy="182880"/>
           </a:xfrm>
           <a:prstGeom prst="rect">
@@ -26615,13 +26419,13 @@
       </p:sp>
       <p:sp>
         <p:nvSpPr>
-          <p:cNvPr id="52" name="Text 50"/>
-          <p:cNvSpPr/>
-          <p:nvPr/>
-        </p:nvSpPr>
-        <p:spPr>
-          <a:xfrm>
-            <a:off x="3390138" y="2560320"/>
+          <p:cNvPr id="66" name="Text 64"/>
+          <p:cNvSpPr/>
+          <p:nvPr/>
+        </p:nvSpPr>
+        <p:spPr>
+          <a:xfrm>
+            <a:off x="5742432" y="3364992"/>
             <a:ext cx="2151126" cy="182880"/>
           </a:xfrm>
           <a:prstGeom prst="rect">
@@ -26646,7 +26450,7 @@
                 <a:ea typeface="Calibri" pitchFamily="34" charset="-122"/>
                 <a:cs typeface="Calibri" pitchFamily="34" charset="-120"/>
               </a:rPr>
-              <a:t>Build  →  Phase 2 launch</a:t>
+              <a:t>Build  →  Phase 3 launch</a:t>
             </a:r>
             <a:endParaRPr lang="en-US" sz="750" dirty="0"/>
           </a:p>
@@ -26654,13 +26458,13 @@
       </p:sp>
       <p:sp>
         <p:nvSpPr>
-          <p:cNvPr id="53" name="Shape 51"/>
-          <p:cNvSpPr/>
-          <p:nvPr/>
-        </p:nvSpPr>
-        <p:spPr>
-          <a:xfrm>
-            <a:off x="274320" y="2871216"/>
+          <p:cNvPr id="67" name="Shape 65"/>
+          <p:cNvSpPr/>
+          <p:nvPr/>
+        </p:nvSpPr>
+        <p:spPr>
+          <a:xfrm>
+            <a:off x="274320" y="3675888"/>
             <a:ext cx="8503920" cy="374904"/>
           </a:xfrm>
           <a:prstGeom prst="rect">
@@ -26679,897 +26483,13 @@
       </p:sp>
       <p:sp>
         <p:nvSpPr>
-          <p:cNvPr id="54" name="Shape 52"/>
-          <p:cNvSpPr/>
-          <p:nvPr/>
-        </p:nvSpPr>
-        <p:spPr>
-          <a:xfrm>
-            <a:off x="274320" y="2871216"/>
-            <a:ext cx="54864" cy="374904"/>
-          </a:xfrm>
-          <a:prstGeom prst="rect">
-            <a:avLst/>
-          </a:prstGeom>
-          <a:solidFill>
-            <a:srgbClr val="06185F"/>
-          </a:solidFill>
-          <a:ln w="12700">
-            <a:solidFill>
-              <a:srgbClr val="06185F"/>
-            </a:solidFill>
-            <a:prstDash val="solid"/>
-          </a:ln>
-        </p:spPr>
-      </p:sp>
-      <p:sp>
-        <p:nvSpPr>
-          <p:cNvPr id="55" name="Text 53"/>
-          <p:cNvSpPr/>
-          <p:nvPr/>
-        </p:nvSpPr>
-        <p:spPr>
-          <a:xfrm>
-            <a:off x="384048" y="2898648"/>
-            <a:ext cx="1938528" cy="201168"/>
-          </a:xfrm>
-          <a:prstGeom prst="rect">
-            <a:avLst/>
-          </a:prstGeom>
-          <a:noFill/>
-          <a:ln/>
-        </p:spPr>
-        <p:txBody>
-          <a:bodyPr wrap="square" lIns="0" tIns="0" rIns="0" bIns="0" rtlCol="0" anchor="ctr"/>
-          <a:lstStyle/>
-          <a:p>
-            <a:pPr indent="0" marL="0">
-              <a:buNone/>
-            </a:pPr>
-            <a:r>
-              <a:rPr lang="en-US" sz="850" b="1" dirty="0">
-                <a:solidFill>
-                  <a:srgbClr val="06185F"/>
-                </a:solidFill>
-                <a:latin typeface="Calibri" pitchFamily="34" charset="0"/>
-                <a:ea typeface="Calibri" pitchFamily="34" charset="-122"/>
-                <a:cs typeface="Calibri" pitchFamily="34" charset="-120"/>
-              </a:rPr>
-              <a:t>Zelle Memo Intelligence</a:t>
-            </a:r>
-            <a:endParaRPr lang="en-US" sz="850" dirty="0"/>
-          </a:p>
-        </p:txBody>
-      </p:sp>
-      <p:sp>
-        <p:nvSpPr>
-          <p:cNvPr id="56" name="Text 54"/>
-          <p:cNvSpPr/>
-          <p:nvPr/>
-        </p:nvSpPr>
-        <p:spPr>
-          <a:xfrm>
-            <a:off x="384048" y="3099816"/>
-            <a:ext cx="1938528" cy="137160"/>
-          </a:xfrm>
-          <a:prstGeom prst="rect">
-            <a:avLst/>
-          </a:prstGeom>
-          <a:noFill/>
-          <a:ln/>
-        </p:spPr>
-        <p:txBody>
-          <a:bodyPr wrap="square" lIns="0" tIns="0" rIns="0" bIns="0" rtlCol="0" anchor="ctr"/>
-          <a:lstStyle/>
-          <a:p>
-            <a:pPr indent="0" marL="0">
-              <a:buNone/>
-            </a:pPr>
-            <a:r>
-              <a:rPr lang="en-US" sz="750" i="1" dirty="0">
-                <a:solidFill>
-                  <a:srgbClr val="B6BBC0"/>
-                </a:solidFill>
-                <a:latin typeface="Calibri" pitchFamily="34" charset="0"/>
-                <a:ea typeface="Calibri" pitchFamily="34" charset="-122"/>
-                <a:cs typeface="Calibri" pitchFamily="34" charset="-120"/>
-              </a:rPr>
-              <a:t>NLP compliance pipeline</a:t>
-            </a:r>
-            <a:endParaRPr lang="en-US" sz="750" dirty="0"/>
-          </a:p>
-        </p:txBody>
-      </p:sp>
-      <p:sp>
-        <p:nvSpPr>
-          <p:cNvPr id="57" name="Shape 55"/>
-          <p:cNvSpPr/>
-          <p:nvPr/>
-        </p:nvSpPr>
-        <p:spPr>
-          <a:xfrm>
-            <a:off x="4110228" y="2962656"/>
-            <a:ext cx="1495044" cy="182880"/>
-          </a:xfrm>
-          <a:prstGeom prst="rect">
-            <a:avLst/>
-          </a:prstGeom>
-          <a:solidFill>
-            <a:srgbClr val="06185F">
-              <a:alpha val="70000"/>
-            </a:srgbClr>
-          </a:solidFill>
-          <a:ln w="12700">
-            <a:solidFill>
-              <a:srgbClr val="06185F">
-                <a:alpha val="90000"/>
-              </a:srgbClr>
-            </a:solidFill>
-            <a:prstDash val="solid"/>
-          </a:ln>
-        </p:spPr>
-      </p:sp>
-      <p:sp>
-        <p:nvSpPr>
-          <p:cNvPr id="58" name="Shape 56"/>
-          <p:cNvSpPr/>
-          <p:nvPr/>
-        </p:nvSpPr>
-        <p:spPr>
-          <a:xfrm>
-            <a:off x="5186660" y="2962656"/>
-            <a:ext cx="418612" cy="182880"/>
-          </a:xfrm>
-          <a:prstGeom prst="rect">
-            <a:avLst/>
-          </a:prstGeom>
-          <a:solidFill>
-            <a:srgbClr val="06185F"/>
-          </a:solidFill>
-          <a:ln w="12700">
-            <a:solidFill>
-              <a:srgbClr val="06185F"/>
-            </a:solidFill>
-            <a:prstDash val="solid"/>
-          </a:ln>
-        </p:spPr>
-      </p:sp>
-      <p:sp>
-        <p:nvSpPr>
-          <p:cNvPr id="59" name="Text 57"/>
-          <p:cNvSpPr/>
-          <p:nvPr/>
-        </p:nvSpPr>
-        <p:spPr>
-          <a:xfrm>
-            <a:off x="4174236" y="2962656"/>
-            <a:ext cx="1367028" cy="182880"/>
-          </a:xfrm>
-          <a:prstGeom prst="rect">
-            <a:avLst/>
-          </a:prstGeom>
-          <a:noFill/>
-          <a:ln/>
-        </p:spPr>
-        <p:txBody>
-          <a:bodyPr wrap="square" lIns="0" tIns="0" rIns="0" bIns="0" rtlCol="0" anchor="ctr"/>
-          <a:lstStyle/>
-          <a:p>
-            <a:pPr indent="0" marL="0">
-              <a:buNone/>
-            </a:pPr>
-            <a:r>
-              <a:rPr lang="en-US" sz="750" dirty="0">
-                <a:solidFill>
-                  <a:srgbClr val="FFFFFF"/>
-                </a:solidFill>
-                <a:latin typeface="Calibri" pitchFamily="34" charset="0"/>
-                <a:ea typeface="Calibri" pitchFamily="34" charset="-122"/>
-                <a:cs typeface="Calibri" pitchFamily="34" charset="-120"/>
-              </a:rPr>
-              <a:t>Build  →  Phase 2 launch</a:t>
-            </a:r>
-            <a:endParaRPr lang="en-US" sz="750" dirty="0"/>
-          </a:p>
-        </p:txBody>
-      </p:sp>
-      <p:sp>
-        <p:nvSpPr>
-          <p:cNvPr id="60" name="Shape 58"/>
-          <p:cNvSpPr/>
-          <p:nvPr/>
-        </p:nvSpPr>
-        <p:spPr>
-          <a:xfrm>
-            <a:off x="274320" y="3273552"/>
-            <a:ext cx="8503920" cy="374904"/>
-          </a:xfrm>
-          <a:prstGeom prst="rect">
-            <a:avLst/>
-          </a:prstGeom>
-          <a:solidFill>
-            <a:srgbClr val="FFFFFF"/>
-          </a:solidFill>
-          <a:ln w="12700">
-            <a:solidFill>
-              <a:srgbClr val="E7ECF0"/>
-            </a:solidFill>
-            <a:prstDash val="solid"/>
-          </a:ln>
-        </p:spPr>
-      </p:sp>
-      <p:sp>
-        <p:nvSpPr>
-          <p:cNvPr id="61" name="Shape 59"/>
-          <p:cNvSpPr/>
-          <p:nvPr/>
-        </p:nvSpPr>
-        <p:spPr>
-          <a:xfrm>
-            <a:off x="274320" y="3273552"/>
-            <a:ext cx="54864" cy="374904"/>
-          </a:xfrm>
-          <a:prstGeom prst="rect">
-            <a:avLst/>
-          </a:prstGeom>
-          <a:solidFill>
-            <a:srgbClr val="0A52C4"/>
-          </a:solidFill>
-          <a:ln w="12700">
-            <a:solidFill>
-              <a:srgbClr val="0A52C4"/>
-            </a:solidFill>
-            <a:prstDash val="solid"/>
-          </a:ln>
-        </p:spPr>
-      </p:sp>
-      <p:sp>
-        <p:nvSpPr>
-          <p:cNvPr id="62" name="Text 60"/>
-          <p:cNvSpPr/>
-          <p:nvPr/>
-        </p:nvSpPr>
-        <p:spPr>
-          <a:xfrm>
-            <a:off x="384048" y="3300984"/>
-            <a:ext cx="1938528" cy="201168"/>
-          </a:xfrm>
-          <a:prstGeom prst="rect">
-            <a:avLst/>
-          </a:prstGeom>
-          <a:noFill/>
-          <a:ln/>
-        </p:spPr>
-        <p:txBody>
-          <a:bodyPr wrap="square" lIns="0" tIns="0" rIns="0" bIns="0" rtlCol="0" anchor="ctr"/>
-          <a:lstStyle/>
-          <a:p>
-            <a:pPr indent="0" marL="0">
-              <a:buNone/>
-            </a:pPr>
-            <a:r>
-              <a:rPr lang="en-US" sz="850" b="1" dirty="0">
-                <a:solidFill>
-                  <a:srgbClr val="06185F"/>
-                </a:solidFill>
-                <a:latin typeface="Calibri" pitchFamily="34" charset="0"/>
-                <a:ea typeface="Calibri" pitchFamily="34" charset="-122"/>
-                <a:cs typeface="Calibri" pitchFamily="34" charset="-120"/>
-              </a:rPr>
-              <a:t>Personal-as-Commercial</a:t>
-            </a:r>
-            <a:endParaRPr lang="en-US" sz="850" dirty="0"/>
-          </a:p>
-        </p:txBody>
-      </p:sp>
-      <p:sp>
-        <p:nvSpPr>
-          <p:cNvPr id="63" name="Text 61"/>
-          <p:cNvSpPr/>
-          <p:nvPr/>
-        </p:nvSpPr>
-        <p:spPr>
-          <a:xfrm>
-            <a:off x="384048" y="3502152"/>
-            <a:ext cx="1938528" cy="137160"/>
-          </a:xfrm>
-          <a:prstGeom prst="rect">
-            <a:avLst/>
-          </a:prstGeom>
-          <a:noFill/>
-          <a:ln/>
-        </p:spPr>
-        <p:txBody>
-          <a:bodyPr wrap="square" lIns="0" tIns="0" rIns="0" bIns="0" rtlCol="0" anchor="ctr"/>
-          <a:lstStyle/>
-          <a:p>
-            <a:pPr indent="0" marL="0">
-              <a:buNone/>
-            </a:pPr>
-            <a:r>
-              <a:rPr lang="en-US" sz="750" i="1" dirty="0">
-                <a:solidFill>
-                  <a:srgbClr val="B6BBC0"/>
-                </a:solidFill>
-                <a:latin typeface="Calibri" pitchFamily="34" charset="0"/>
-                <a:ea typeface="Calibri" pitchFamily="34" charset="-122"/>
-                <a:cs typeface="Calibri" pitchFamily="34" charset="-120"/>
-              </a:rPr>
-              <a:t>SMB conversion model</a:t>
-            </a:r>
-            <a:endParaRPr lang="en-US" sz="750" dirty="0"/>
-          </a:p>
-        </p:txBody>
-      </p:sp>
-      <p:sp>
-        <p:nvSpPr>
-          <p:cNvPr id="64" name="Shape 62"/>
-          <p:cNvSpPr/>
-          <p:nvPr/>
-        </p:nvSpPr>
-        <p:spPr>
-          <a:xfrm>
-            <a:off x="4110228" y="3364992"/>
-            <a:ext cx="1495044" cy="182880"/>
-          </a:xfrm>
-          <a:prstGeom prst="rect">
-            <a:avLst/>
-          </a:prstGeom>
-          <a:solidFill>
-            <a:srgbClr val="0A52C4">
-              <a:alpha val="70000"/>
-            </a:srgbClr>
-          </a:solidFill>
-          <a:ln w="12700">
-            <a:solidFill>
-              <a:srgbClr val="0A52C4">
-                <a:alpha val="90000"/>
-              </a:srgbClr>
-            </a:solidFill>
-            <a:prstDash val="solid"/>
-          </a:ln>
-        </p:spPr>
-      </p:sp>
-      <p:sp>
-        <p:nvSpPr>
-          <p:cNvPr id="65" name="Shape 63"/>
-          <p:cNvSpPr/>
-          <p:nvPr/>
-        </p:nvSpPr>
-        <p:spPr>
-          <a:xfrm>
-            <a:off x="5186660" y="3364992"/>
-            <a:ext cx="418612" cy="182880"/>
-          </a:xfrm>
-          <a:prstGeom prst="rect">
-            <a:avLst/>
-          </a:prstGeom>
-          <a:solidFill>
-            <a:srgbClr val="0A52C4"/>
-          </a:solidFill>
-          <a:ln w="12700">
-            <a:solidFill>
-              <a:srgbClr val="0A52C4"/>
-            </a:solidFill>
-            <a:prstDash val="solid"/>
-          </a:ln>
-        </p:spPr>
-      </p:sp>
-      <p:sp>
-        <p:nvSpPr>
-          <p:cNvPr id="66" name="Text 64"/>
-          <p:cNvSpPr/>
-          <p:nvPr/>
-        </p:nvSpPr>
-        <p:spPr>
-          <a:xfrm>
-            <a:off x="4174236" y="3364992"/>
-            <a:ext cx="1367028" cy="182880"/>
-          </a:xfrm>
-          <a:prstGeom prst="rect">
-            <a:avLst/>
-          </a:prstGeom>
-          <a:noFill/>
-          <a:ln/>
-        </p:spPr>
-        <p:txBody>
-          <a:bodyPr wrap="square" lIns="0" tIns="0" rIns="0" bIns="0" rtlCol="0" anchor="ctr"/>
-          <a:lstStyle/>
-          <a:p>
-            <a:pPr indent="0" marL="0">
-              <a:buNone/>
-            </a:pPr>
-            <a:r>
-              <a:rPr lang="en-US" sz="750" dirty="0">
-                <a:solidFill>
-                  <a:srgbClr val="FFFFFF"/>
-                </a:solidFill>
-                <a:latin typeface="Calibri" pitchFamily="34" charset="0"/>
-                <a:ea typeface="Calibri" pitchFamily="34" charset="-122"/>
-                <a:cs typeface="Calibri" pitchFamily="34" charset="-120"/>
-              </a:rPr>
-              <a:t>Build  →  Phase 2 launch</a:t>
-            </a:r>
-            <a:endParaRPr lang="en-US" sz="750" dirty="0"/>
-          </a:p>
-        </p:txBody>
-      </p:sp>
-      <p:sp>
-        <p:nvSpPr>
-          <p:cNvPr id="67" name="Shape 65"/>
+          <p:cNvPr id="68" name="Shape 66"/>
           <p:cNvSpPr/>
           <p:nvPr/>
         </p:nvSpPr>
         <p:spPr>
           <a:xfrm>
             <a:off x="274320" y="3675888"/>
-            <a:ext cx="8503920" cy="374904"/>
-          </a:xfrm>
-          <a:prstGeom prst="rect">
-            <a:avLst/>
-          </a:prstGeom>
-          <a:solidFill>
-            <a:srgbClr val="F8F9FA"/>
-          </a:solidFill>
-          <a:ln w="12700">
-            <a:solidFill>
-              <a:srgbClr val="E7ECF0"/>
-            </a:solidFill>
-            <a:prstDash val="solid"/>
-          </a:ln>
-        </p:spPr>
-      </p:sp>
-      <p:sp>
-        <p:nvSpPr>
-          <p:cNvPr id="68" name="Shape 66"/>
-          <p:cNvSpPr/>
-          <p:nvPr/>
-        </p:nvSpPr>
-        <p:spPr>
-          <a:xfrm>
-            <a:off x="274320" y="3675888"/>
-            <a:ext cx="54864" cy="374904"/>
-          </a:xfrm>
-          <a:prstGeom prst="rect">
-            <a:avLst/>
-          </a:prstGeom>
-          <a:solidFill>
-            <a:srgbClr val="0F3D8A"/>
-          </a:solidFill>
-          <a:ln w="12700">
-            <a:solidFill>
-              <a:srgbClr val="0F3D8A"/>
-            </a:solidFill>
-            <a:prstDash val="solid"/>
-          </a:ln>
-        </p:spPr>
-      </p:sp>
-      <p:sp>
-        <p:nvSpPr>
-          <p:cNvPr id="69" name="Text 67"/>
-          <p:cNvSpPr/>
-          <p:nvPr/>
-        </p:nvSpPr>
-        <p:spPr>
-          <a:xfrm>
-            <a:off x="384048" y="3703320"/>
-            <a:ext cx="1938528" cy="201168"/>
-          </a:xfrm>
-          <a:prstGeom prst="rect">
-            <a:avLst/>
-          </a:prstGeom>
-          <a:noFill/>
-          <a:ln/>
-        </p:spPr>
-        <p:txBody>
-          <a:bodyPr wrap="square" lIns="0" tIns="0" rIns="0" bIns="0" rtlCol="0" anchor="ctr"/>
-          <a:lstStyle/>
-          <a:p>
-            <a:pPr indent="0" marL="0">
-              <a:buNone/>
-            </a:pPr>
-            <a:r>
-              <a:rPr lang="en-US" sz="850" b="1" dirty="0">
-                <a:solidFill>
-                  <a:srgbClr val="06185F"/>
-                </a:solidFill>
-                <a:latin typeface="Calibri" pitchFamily="34" charset="0"/>
-                <a:ea typeface="Calibri" pitchFamily="34" charset="-122"/>
-                <a:cs typeface="Calibri" pitchFamily="34" charset="-120"/>
-              </a:rPr>
-              <a:t>Gen. Wealth Deflection</a:t>
-            </a:r>
-            <a:endParaRPr lang="en-US" sz="850" dirty="0"/>
-          </a:p>
-        </p:txBody>
-      </p:sp>
-      <p:sp>
-        <p:nvSpPr>
-          <p:cNvPr id="70" name="Text 68"/>
-          <p:cNvSpPr/>
-          <p:nvPr/>
-        </p:nvSpPr>
-        <p:spPr>
-          <a:xfrm>
-            <a:off x="384048" y="3904488"/>
-            <a:ext cx="1938528" cy="137160"/>
-          </a:xfrm>
-          <a:prstGeom prst="rect">
-            <a:avLst/>
-          </a:prstGeom>
-          <a:noFill/>
-          <a:ln/>
-        </p:spPr>
-        <p:txBody>
-          <a:bodyPr wrap="square" lIns="0" tIns="0" rIns="0" bIns="0" rtlCol="0" anchor="ctr"/>
-          <a:lstStyle/>
-          <a:p>
-            <a:pPr indent="0" marL="0">
-              <a:buNone/>
-            </a:pPr>
-            <a:r>
-              <a:rPr lang="en-US" sz="750" i="1" dirty="0">
-                <a:solidFill>
-                  <a:srgbClr val="B6BBC0"/>
-                </a:solidFill>
-                <a:latin typeface="Calibri" pitchFamily="34" charset="0"/>
-                <a:ea typeface="Calibri" pitchFamily="34" charset="-122"/>
-                <a:cs typeface="Calibri" pitchFamily="34" charset="-120"/>
-              </a:rPr>
-              <a:t>Household coverage model</a:t>
-            </a:r>
-            <a:endParaRPr lang="en-US" sz="750" dirty="0"/>
-          </a:p>
-        </p:txBody>
-      </p:sp>
-      <p:sp>
-        <p:nvSpPr>
-          <p:cNvPr id="71" name="Shape 69"/>
-          <p:cNvSpPr/>
-          <p:nvPr/>
-        </p:nvSpPr>
-        <p:spPr>
-          <a:xfrm>
-            <a:off x="4110228" y="3767328"/>
-            <a:ext cx="2279142" cy="182880"/>
-          </a:xfrm>
-          <a:prstGeom prst="rect">
-            <a:avLst/>
-          </a:prstGeom>
-          <a:solidFill>
-            <a:srgbClr val="0F3D8A">
-              <a:alpha val="70000"/>
-            </a:srgbClr>
-          </a:solidFill>
-          <a:ln w="12700">
-            <a:solidFill>
-              <a:srgbClr val="0F3D8A">
-                <a:alpha val="90000"/>
-              </a:srgbClr>
-            </a:solidFill>
-            <a:prstDash val="solid"/>
-          </a:ln>
-        </p:spPr>
-      </p:sp>
-      <p:sp>
-        <p:nvSpPr>
-          <p:cNvPr id="72" name="Shape 70"/>
-          <p:cNvSpPr/>
-          <p:nvPr/>
-        </p:nvSpPr>
-        <p:spPr>
-          <a:xfrm>
-            <a:off x="5751210" y="3767328"/>
-            <a:ext cx="638160" cy="182880"/>
-          </a:xfrm>
-          <a:prstGeom prst="rect">
-            <a:avLst/>
-          </a:prstGeom>
-          <a:solidFill>
-            <a:srgbClr val="0F3D8A"/>
-          </a:solidFill>
-          <a:ln w="12700">
-            <a:solidFill>
-              <a:srgbClr val="0F3D8A"/>
-            </a:solidFill>
-            <a:prstDash val="solid"/>
-          </a:ln>
-        </p:spPr>
-      </p:sp>
-      <p:sp>
-        <p:nvSpPr>
-          <p:cNvPr id="73" name="Text 71"/>
-          <p:cNvSpPr/>
-          <p:nvPr/>
-        </p:nvSpPr>
-        <p:spPr>
-          <a:xfrm>
-            <a:off x="4174236" y="3767328"/>
-            <a:ext cx="2151126" cy="182880"/>
-          </a:xfrm>
-          <a:prstGeom prst="rect">
-            <a:avLst/>
-          </a:prstGeom>
-          <a:noFill/>
-          <a:ln/>
-        </p:spPr>
-        <p:txBody>
-          <a:bodyPr wrap="square" lIns="0" tIns="0" rIns="0" bIns="0" rtlCol="0" anchor="ctr"/>
-          <a:lstStyle/>
-          <a:p>
-            <a:pPr indent="0" marL="0">
-              <a:buNone/>
-            </a:pPr>
-            <a:r>
-              <a:rPr lang="en-US" sz="750" dirty="0">
-                <a:solidFill>
-                  <a:srgbClr val="FFFFFF"/>
-                </a:solidFill>
-                <a:latin typeface="Calibri" pitchFamily="34" charset="0"/>
-                <a:ea typeface="Calibri" pitchFamily="34" charset="-122"/>
-                <a:cs typeface="Calibri" pitchFamily="34" charset="-120"/>
-              </a:rPr>
-              <a:t>Phase 2 build  →  Phase 3</a:t>
-            </a:r>
-            <a:endParaRPr lang="en-US" sz="750" dirty="0"/>
-          </a:p>
-        </p:txBody>
-      </p:sp>
-      <p:sp>
-        <p:nvSpPr>
-          <p:cNvPr id="74" name="Shape 72"/>
-          <p:cNvSpPr/>
-          <p:nvPr/>
-        </p:nvSpPr>
-        <p:spPr>
-          <a:xfrm>
-            <a:off x="274320" y="4078224"/>
-            <a:ext cx="8503920" cy="374904"/>
-          </a:xfrm>
-          <a:prstGeom prst="rect">
-            <a:avLst/>
-          </a:prstGeom>
-          <a:solidFill>
-            <a:srgbClr val="FFFFFF"/>
-          </a:solidFill>
-          <a:ln w="12700">
-            <a:solidFill>
-              <a:srgbClr val="E7ECF0"/>
-            </a:solidFill>
-            <a:prstDash val="solid"/>
-          </a:ln>
-        </p:spPr>
-      </p:sp>
-      <p:sp>
-        <p:nvSpPr>
-          <p:cNvPr id="75" name="Shape 73"/>
-          <p:cNvSpPr/>
-          <p:nvPr/>
-        </p:nvSpPr>
-        <p:spPr>
-          <a:xfrm>
-            <a:off x="274320" y="4078224"/>
-            <a:ext cx="54864" cy="374904"/>
-          </a:xfrm>
-          <a:prstGeom prst="rect">
-            <a:avLst/>
-          </a:prstGeom>
-          <a:solidFill>
-            <a:srgbClr val="0B68D4"/>
-          </a:solidFill>
-          <a:ln w="12700">
-            <a:solidFill>
-              <a:srgbClr val="0B68D4"/>
-            </a:solidFill>
-            <a:prstDash val="solid"/>
-          </a:ln>
-        </p:spPr>
-      </p:sp>
-      <p:sp>
-        <p:nvSpPr>
-          <p:cNvPr id="76" name="Text 74"/>
-          <p:cNvSpPr/>
-          <p:nvPr/>
-        </p:nvSpPr>
-        <p:spPr>
-          <a:xfrm>
-            <a:off x="384048" y="4105656"/>
-            <a:ext cx="1938528" cy="201168"/>
-          </a:xfrm>
-          <a:prstGeom prst="rect">
-            <a:avLst/>
-          </a:prstGeom>
-          <a:noFill/>
-          <a:ln/>
-        </p:spPr>
-        <p:txBody>
-          <a:bodyPr wrap="square" lIns="0" tIns="0" rIns="0" bIns="0" rtlCol="0" anchor="ctr"/>
-          <a:lstStyle/>
-          <a:p>
-            <a:pPr indent="0" marL="0">
-              <a:buNone/>
-            </a:pPr>
-            <a:r>
-              <a:rPr lang="en-US" sz="850" b="1" dirty="0">
-                <a:solidFill>
-                  <a:srgbClr val="06185F"/>
-                </a:solidFill>
-                <a:latin typeface="Calibri" pitchFamily="34" charset="0"/>
-                <a:ea typeface="Calibri" pitchFamily="34" charset="-122"/>
-                <a:cs typeface="Calibri" pitchFamily="34" charset="-120"/>
-              </a:rPr>
-              <a:t>Account Opening LTV</a:t>
-            </a:r>
-            <a:endParaRPr lang="en-US" sz="850" dirty="0"/>
-          </a:p>
-        </p:txBody>
-      </p:sp>
-      <p:sp>
-        <p:nvSpPr>
-          <p:cNvPr id="77" name="Text 75"/>
-          <p:cNvSpPr/>
-          <p:nvPr/>
-        </p:nvSpPr>
-        <p:spPr>
-          <a:xfrm>
-            <a:off x="384048" y="4306824"/>
-            <a:ext cx="1938528" cy="137160"/>
-          </a:xfrm>
-          <a:prstGeom prst="rect">
-            <a:avLst/>
-          </a:prstGeom>
-          <a:noFill/>
-          <a:ln/>
-        </p:spPr>
-        <p:txBody>
-          <a:bodyPr wrap="square" lIns="0" tIns="0" rIns="0" bIns="0" rtlCol="0" anchor="ctr"/>
-          <a:lstStyle/>
-          <a:p>
-            <a:pPr indent="0" marL="0">
-              <a:buNone/>
-            </a:pPr>
-            <a:r>
-              <a:rPr lang="en-US" sz="750" i="1" dirty="0">
-                <a:solidFill>
-                  <a:srgbClr val="B6BBC0"/>
-                </a:solidFill>
-                <a:latin typeface="Calibri" pitchFamily="34" charset="0"/>
-                <a:ea typeface="Calibri" pitchFamily="34" charset="-122"/>
-                <a:cs typeface="Calibri" pitchFamily="34" charset="-120"/>
-              </a:rPr>
-              <a:t>New account LTV scoring</a:t>
-            </a:r>
-            <a:endParaRPr lang="en-US" sz="750" dirty="0"/>
-          </a:p>
-        </p:txBody>
-      </p:sp>
-      <p:sp>
-        <p:nvSpPr>
-          <p:cNvPr id="78" name="Shape 76"/>
-          <p:cNvSpPr/>
-          <p:nvPr/>
-        </p:nvSpPr>
-        <p:spPr>
-          <a:xfrm>
-            <a:off x="5678424" y="4169664"/>
-            <a:ext cx="1495044" cy="182880"/>
-          </a:xfrm>
-          <a:prstGeom prst="rect">
-            <a:avLst/>
-          </a:prstGeom>
-          <a:solidFill>
-            <a:srgbClr val="0B68D4">
-              <a:alpha val="70000"/>
-            </a:srgbClr>
-          </a:solidFill>
-          <a:ln w="12700">
-            <a:solidFill>
-              <a:srgbClr val="0B68D4">
-                <a:alpha val="90000"/>
-              </a:srgbClr>
-            </a:solidFill>
-            <a:prstDash val="solid"/>
-          </a:ln>
-        </p:spPr>
-      </p:sp>
-      <p:sp>
-        <p:nvSpPr>
-          <p:cNvPr id="79" name="Shape 77"/>
-          <p:cNvSpPr/>
-          <p:nvPr/>
-        </p:nvSpPr>
-        <p:spPr>
-          <a:xfrm>
-            <a:off x="6754856" y="4169664"/>
-            <a:ext cx="418612" cy="182880"/>
-          </a:xfrm>
-          <a:prstGeom prst="rect">
-            <a:avLst/>
-          </a:prstGeom>
-          <a:solidFill>
-            <a:srgbClr val="0B68D4"/>
-          </a:solidFill>
-          <a:ln w="12700">
-            <a:solidFill>
-              <a:srgbClr val="0B68D4"/>
-            </a:solidFill>
-            <a:prstDash val="solid"/>
-          </a:ln>
-        </p:spPr>
-      </p:sp>
-      <p:sp>
-        <p:nvSpPr>
-          <p:cNvPr id="80" name="Text 78"/>
-          <p:cNvSpPr/>
-          <p:nvPr/>
-        </p:nvSpPr>
-        <p:spPr>
-          <a:xfrm>
-            <a:off x="5742432" y="4169664"/>
-            <a:ext cx="1367028" cy="182880"/>
-          </a:xfrm>
-          <a:prstGeom prst="rect">
-            <a:avLst/>
-          </a:prstGeom>
-          <a:noFill/>
-          <a:ln/>
-        </p:spPr>
-        <p:txBody>
-          <a:bodyPr wrap="square" lIns="0" tIns="0" rIns="0" bIns="0" rtlCol="0" anchor="ctr"/>
-          <a:lstStyle/>
-          <a:p>
-            <a:pPr indent="0" marL="0">
-              <a:buNone/>
-            </a:pPr>
-            <a:r>
-              <a:rPr lang="en-US" sz="750" dirty="0">
-                <a:solidFill>
-                  <a:srgbClr val="FFFFFF"/>
-                </a:solidFill>
-                <a:latin typeface="Calibri" pitchFamily="34" charset="0"/>
-                <a:ea typeface="Calibri" pitchFamily="34" charset="-122"/>
-                <a:cs typeface="Calibri" pitchFamily="34" charset="-120"/>
-              </a:rPr>
-              <a:t>Build  →  Phase 3 launch</a:t>
-            </a:r>
-            <a:endParaRPr lang="en-US" sz="750" dirty="0"/>
-          </a:p>
-        </p:txBody>
-      </p:sp>
-      <p:sp>
-        <p:nvSpPr>
-          <p:cNvPr id="81" name="Shape 79"/>
-          <p:cNvSpPr/>
-          <p:nvPr/>
-        </p:nvSpPr>
-        <p:spPr>
-          <a:xfrm>
-            <a:off x="274320" y="4480560"/>
-            <a:ext cx="8503920" cy="374904"/>
-          </a:xfrm>
-          <a:prstGeom prst="rect">
-            <a:avLst/>
-          </a:prstGeom>
-          <a:solidFill>
-            <a:srgbClr val="F8F9FA"/>
-          </a:solidFill>
-          <a:ln w="12700">
-            <a:solidFill>
-              <a:srgbClr val="E7ECF0"/>
-            </a:solidFill>
-            <a:prstDash val="solid"/>
-          </a:ln>
-        </p:spPr>
-      </p:sp>
-      <p:sp>
-        <p:nvSpPr>
-          <p:cNvPr id="82" name="Shape 80"/>
-          <p:cNvSpPr/>
-          <p:nvPr/>
-        </p:nvSpPr>
-        <p:spPr>
-          <a:xfrm>
-            <a:off x="274320" y="4480560"/>
             <a:ext cx="54864" cy="374904"/>
           </a:xfrm>
           <a:prstGeom prst="rect">
@@ -27588,13 +26508,13 @@
       </p:sp>
       <p:sp>
         <p:nvSpPr>
-          <p:cNvPr id="83" name="Text 81"/>
-          <p:cNvSpPr/>
-          <p:nvPr/>
-        </p:nvSpPr>
-        <p:spPr>
-          <a:xfrm>
-            <a:off x="384048" y="4507992"/>
+          <p:cNvPr id="69" name="Text 67"/>
+          <p:cNvSpPr/>
+          <p:nvPr/>
+        </p:nvSpPr>
+        <p:spPr>
+          <a:xfrm>
+            <a:off x="384048" y="3703320"/>
             <a:ext cx="1938528" cy="201168"/>
           </a:xfrm>
           <a:prstGeom prst="rect">
@@ -27627,13 +26547,13 @@
       </p:sp>
       <p:sp>
         <p:nvSpPr>
-          <p:cNvPr id="84" name="Text 82"/>
-          <p:cNvSpPr/>
-          <p:nvPr/>
-        </p:nvSpPr>
-        <p:spPr>
-          <a:xfrm>
-            <a:off x="384048" y="4709160"/>
+          <p:cNvPr id="70" name="Text 68"/>
+          <p:cNvSpPr/>
+          <p:nvPr/>
+        </p:nvSpPr>
+        <p:spPr>
+          <a:xfrm>
+            <a:off x="384048" y="3904488"/>
             <a:ext cx="1938528" cy="137160"/>
           </a:xfrm>
           <a:prstGeom prst="rect">
@@ -27666,13 +26586,13 @@
       </p:sp>
       <p:sp>
         <p:nvSpPr>
-          <p:cNvPr id="85" name="Shape 83"/>
-          <p:cNvSpPr/>
-          <p:nvPr/>
-        </p:nvSpPr>
-        <p:spPr>
-          <a:xfrm>
-            <a:off x="5678424" y="4572000"/>
+          <p:cNvPr id="71" name="Shape 69"/>
+          <p:cNvSpPr/>
+          <p:nvPr/>
+        </p:nvSpPr>
+        <p:spPr>
+          <a:xfrm>
+            <a:off x="5678424" y="3767328"/>
             <a:ext cx="3063240" cy="182880"/>
           </a:xfrm>
           <a:prstGeom prst="rect">
@@ -27695,13 +26615,13 @@
       </p:sp>
       <p:sp>
         <p:nvSpPr>
-          <p:cNvPr id="86" name="Shape 84"/>
-          <p:cNvSpPr/>
-          <p:nvPr/>
-        </p:nvSpPr>
-        <p:spPr>
-          <a:xfrm>
-            <a:off x="8030718" y="4572000"/>
+          <p:cNvPr id="72" name="Shape 70"/>
+          <p:cNvSpPr/>
+          <p:nvPr/>
+        </p:nvSpPr>
+        <p:spPr>
+          <a:xfrm>
+            <a:off x="8030718" y="3767328"/>
             <a:ext cx="710946" cy="182880"/>
           </a:xfrm>
           <a:prstGeom prst="rect">
@@ -27720,13 +26640,13 @@
       </p:sp>
       <p:sp>
         <p:nvSpPr>
-          <p:cNvPr id="87" name="Text 85"/>
-          <p:cNvSpPr/>
-          <p:nvPr/>
-        </p:nvSpPr>
-        <p:spPr>
-          <a:xfrm>
-            <a:off x="5742432" y="4572000"/>
+          <p:cNvPr id="73" name="Text 71"/>
+          <p:cNvSpPr/>
+          <p:nvPr/>
+        </p:nvSpPr>
+        <p:spPr>
+          <a:xfrm>
+            <a:off x="5742432" y="3767328"/>
             <a:ext cx="2935224" cy="182880"/>
           </a:xfrm>
           <a:prstGeom prst="rect">
@@ -27759,7 +26679,7 @@
       </p:sp>
       <p:sp>
         <p:nvSpPr>
-          <p:cNvPr id="88" name="Shape 86"/>
+          <p:cNvPr id="74" name="Shape 72"/>
           <p:cNvSpPr/>
           <p:nvPr/>
         </p:nvSpPr>
@@ -27786,7 +26706,7 @@
       </p:sp>
       <p:sp>
         <p:nvSpPr>
-          <p:cNvPr id="89" name="Text 87"/>
+          <p:cNvPr id="75" name="Text 73"/>
           <p:cNvSpPr/>
           <p:nvPr/>
         </p:nvSpPr>
@@ -27825,7 +26745,7 @@
       </p:sp>
       <p:sp>
         <p:nvSpPr>
-          <p:cNvPr id="90" name="Shape 88"/>
+          <p:cNvPr id="76" name="Shape 74"/>
           <p:cNvSpPr/>
           <p:nvPr/>
         </p:nvSpPr>
@@ -27850,7 +26770,7 @@
       </p:sp>
       <p:sp>
         <p:nvSpPr>
-          <p:cNvPr id="91" name="Text 89"/>
+          <p:cNvPr id="77" name="Text 75"/>
           <p:cNvSpPr/>
           <p:nvPr/>
         </p:nvSpPr>
@@ -27889,7 +26809,7 @@
       </p:sp>
       <p:sp>
         <p:nvSpPr>
-          <p:cNvPr id="92" name="Shape 90"/>
+          <p:cNvPr id="78" name="Shape 76"/>
           <p:cNvSpPr/>
           <p:nvPr/>
         </p:nvSpPr>
@@ -27914,7 +26834,7 @@
       </p:sp>
       <p:sp>
         <p:nvSpPr>
-          <p:cNvPr id="93" name="Text 91"/>
+          <p:cNvPr id="79" name="Text 77"/>
           <p:cNvSpPr/>
           <p:nvPr/>
         </p:nvSpPr>
@@ -28850,7 +27770,7 @@
                 <a:ea typeface="Calibri" pitchFamily="34" charset="-122"/>
                 <a:cs typeface="Calibri" pitchFamily="34" charset="-120"/>
               </a:rPr>
-              <a:t>MLOps pipeline + streaming anomaly engine live</a:t>
+              <a:t>Core banking + payments data integration complete</a:t>
             </a:r>
             <a:endParaRPr lang="en-US" sz="1000" dirty="0"/>
           </a:p>
@@ -28871,7 +27791,7 @@
                 <a:ea typeface="Calibri" pitchFamily="34" charset="-122"/>
                 <a:cs typeface="Calibri" pitchFamily="34" charset="-120"/>
               </a:rPr>
-              <a:t>Core banking + payments data integration complete</a:t>
+              <a:t>Exec dashboards + FI banker score explorer live</a:t>
             </a:r>
             <a:endParaRPr lang="en-US" sz="1000" dirty="0"/>
           </a:p>
@@ -28892,7 +27812,7 @@
                 <a:ea typeface="Calibri" pitchFamily="34" charset="-122"/>
                 <a:cs typeface="Calibri" pitchFamily="34" charset="-120"/>
               </a:rPr>
-              <a:t>Exec dashboards + FI banker score explorer</a:t>
+              <a:t>Personal-as-Commercial SMB conversion model</a:t>
             </a:r>
             <a:endParaRPr lang="en-US" sz="1000" dirty="0"/>
           </a:p>
@@ -28913,7 +27833,7 @@
                 <a:ea typeface="Calibri" pitchFamily="34" charset="-122"/>
                 <a:cs typeface="Calibri" pitchFamily="34" charset="-120"/>
               </a:rPr>
-              <a:t>Call Report AI full CU client base rollout</a:t>
+              <a:t>Generational Wealth household relationship engine</a:t>
             </a:r>
             <a:endParaRPr lang="en-US" sz="1000" dirty="0"/>
           </a:p>
@@ -28927,7 +27847,7 @@
         </p:nvSpPr>
         <p:spPr>
           <a:xfrm>
-            <a:off x="3200400" y="3438144"/>
+            <a:off x="3200400" y="3675888"/>
             <a:ext cx="2816352" cy="237744"/>
           </a:xfrm>
           <a:prstGeom prst="rect">
@@ -28956,7 +27876,7 @@
         </p:nvSpPr>
         <p:spPr>
           <a:xfrm>
-            <a:off x="3200400" y="3438144"/>
+            <a:off x="3200400" y="3675888"/>
             <a:ext cx="54864" cy="237744"/>
           </a:xfrm>
           <a:prstGeom prst="rect">
@@ -28981,7 +27901,7 @@
         </p:nvSpPr>
         <p:spPr>
           <a:xfrm>
-            <a:off x="3328416" y="3438144"/>
+            <a:off x="3328416" y="3675888"/>
             <a:ext cx="2651760" cy="237744"/>
           </a:xfrm>
           <a:prstGeom prst="rect">
@@ -29020,18 +27940,18 @@
         </p:nvSpPr>
         <p:spPr>
           <a:xfrm>
-            <a:off x="3328416" y="3712464"/>
-            <a:ext cx="2523744" cy="219456"/>
+            <a:off x="3328416" y="3950208"/>
+            <a:ext cx="2523744" cy="256032"/>
           </a:xfrm>
           <a:prstGeom prst="rect">
             <a:avLst/>
           </a:prstGeom>
           <a:solidFill>
-            <a:srgbClr val="073FA8"/>
+            <a:srgbClr val="06185F"/>
           </a:solidFill>
           <a:ln w="12700">
             <a:solidFill>
-              <a:srgbClr val="073FA8"/>
+              <a:srgbClr val="06185F"/>
             </a:solidFill>
             <a:prstDash val="solid"/>
           </a:ln>
@@ -29045,7 +27965,7 @@
         </p:nvSpPr>
         <p:spPr>
           <a:xfrm>
-            <a:off x="3383280" y="3758184"/>
+            <a:off x="3383280" y="4014216"/>
             <a:ext cx="128016" cy="128016"/>
           </a:xfrm>
           <a:prstGeom prst="ellipse">
@@ -29074,8 +27994,8 @@
         </p:nvSpPr>
         <p:spPr>
           <a:xfrm>
-            <a:off x="3566160" y="3712464"/>
-            <a:ext cx="2231136" cy="219456"/>
+            <a:off x="3566160" y="3950208"/>
+            <a:ext cx="2231136" cy="256032"/>
           </a:xfrm>
           <a:prstGeom prst="rect">
             <a:avLst/>
@@ -29091,7 +28011,7 @@
               <a:buNone/>
             </a:pPr>
             <a:r>
-              <a:rPr lang="en-US" sz="800" b="1" dirty="0">
+              <a:rPr lang="en-US" sz="900" b="1" dirty="0">
                 <a:solidFill>
                   <a:srgbClr val="FFFFFF"/>
                 </a:solidFill>
@@ -29099,9 +28019,9 @@
                 <a:ea typeface="Calibri" pitchFamily="34" charset="-122"/>
                 <a:cs typeface="Calibri" pitchFamily="34" charset="-120"/>
               </a:rPr>
-              <a:t>Anomaly Detection</a:t>
-            </a:r>
-            <a:endParaRPr lang="en-US" sz="800" dirty="0"/>
+              <a:t>Zelle Memo Intelligence</a:t>
+            </a:r>
+            <a:endParaRPr lang="en-US" sz="900" dirty="0"/>
           </a:p>
         </p:txBody>
       </p:sp>
@@ -29113,18 +28033,18 @@
         </p:nvSpPr>
         <p:spPr>
           <a:xfrm>
-            <a:off x="3328416" y="3968496"/>
-            <a:ext cx="2523744" cy="219456"/>
+            <a:off x="3328416" y="4279392"/>
+            <a:ext cx="2523744" cy="256032"/>
           </a:xfrm>
           <a:prstGeom prst="rect">
             <a:avLst/>
           </a:prstGeom>
           <a:solidFill>
-            <a:srgbClr val="06185F"/>
+            <a:srgbClr val="0A52C4"/>
           </a:solidFill>
           <a:ln w="12700">
             <a:solidFill>
-              <a:srgbClr val="06185F"/>
+              <a:srgbClr val="0A52C4"/>
             </a:solidFill>
             <a:prstDash val="solid"/>
           </a:ln>
@@ -29138,7 +28058,7 @@
         </p:nvSpPr>
         <p:spPr>
           <a:xfrm>
-            <a:off x="3383280" y="4014216"/>
+            <a:off x="3383280" y="4343400"/>
             <a:ext cx="128016" cy="128016"/>
           </a:xfrm>
           <a:prstGeom prst="ellipse">
@@ -29167,8 +28087,8 @@
         </p:nvSpPr>
         <p:spPr>
           <a:xfrm>
-            <a:off x="3566160" y="3968496"/>
-            <a:ext cx="2231136" cy="219456"/>
+            <a:off x="3566160" y="4279392"/>
+            <a:ext cx="2231136" cy="256032"/>
           </a:xfrm>
           <a:prstGeom prst="rect">
             <a:avLst/>
@@ -29184,7 +28104,7 @@
               <a:buNone/>
             </a:pPr>
             <a:r>
-              <a:rPr lang="en-US" sz="800" b="1" dirty="0">
+              <a:rPr lang="en-US" sz="900" b="1" dirty="0">
                 <a:solidFill>
                   <a:srgbClr val="FFFFFF"/>
                 </a:solidFill>
@@ -29192,9 +28112,9 @@
                 <a:ea typeface="Calibri" pitchFamily="34" charset="-122"/>
                 <a:cs typeface="Calibri" pitchFamily="34" charset="-120"/>
               </a:rPr>
-              <a:t>Zelle Memo Intelligence</a:t>
-            </a:r>
-            <a:endParaRPr lang="en-US" sz="800" dirty="0"/>
+              <a:t>Personal-as-Commercial</a:t>
+            </a:r>
+            <a:endParaRPr lang="en-US" sz="900" dirty="0"/>
           </a:p>
         </p:txBody>
       </p:sp>
@@ -29206,18 +28126,18 @@
         </p:nvSpPr>
         <p:spPr>
           <a:xfrm>
-            <a:off x="3328416" y="4224528"/>
-            <a:ext cx="2523744" cy="219456"/>
+            <a:off x="3328416" y="4608576"/>
+            <a:ext cx="2523744" cy="256032"/>
           </a:xfrm>
           <a:prstGeom prst="rect">
             <a:avLst/>
           </a:prstGeom>
           <a:solidFill>
-            <a:srgbClr val="575A5D"/>
+            <a:srgbClr val="0F3D8A"/>
           </a:solidFill>
           <a:ln w="12700">
             <a:solidFill>
-              <a:srgbClr val="575A5D"/>
+              <a:srgbClr val="0F3D8A"/>
             </a:solidFill>
             <a:prstDash val="solid"/>
           </a:ln>
@@ -29231,7 +28151,7 @@
         </p:nvSpPr>
         <p:spPr>
           <a:xfrm>
-            <a:off x="3383280" y="4270248"/>
+            <a:off x="3383280" y="4672584"/>
             <a:ext cx="128016" cy="128016"/>
           </a:xfrm>
           <a:prstGeom prst="ellipse">
@@ -29260,8 +28180,8 @@
         </p:nvSpPr>
         <p:spPr>
           <a:xfrm>
-            <a:off x="3566160" y="4224528"/>
-            <a:ext cx="1554480" cy="219456"/>
+            <a:off x="3566160" y="4608576"/>
+            <a:ext cx="2231136" cy="256032"/>
           </a:xfrm>
           <a:prstGeom prst="rect">
             <a:avLst/>
@@ -29277,7 +28197,7 @@
               <a:buNone/>
             </a:pPr>
             <a:r>
-              <a:rPr lang="en-US" sz="800" b="1" dirty="0">
+              <a:rPr lang="en-US" sz="900" b="1" dirty="0">
                 <a:solidFill>
                   <a:srgbClr val="FFFFFF"/>
                 </a:solidFill>
@@ -29285,269 +28205,15 @@
                 <a:ea typeface="Calibri" pitchFamily="34" charset="-122"/>
                 <a:cs typeface="Calibri" pitchFamily="34" charset="-120"/>
               </a:rPr>
-              <a:t>Call Report AI</a:t>
-            </a:r>
-            <a:endParaRPr lang="en-US" sz="800" dirty="0"/>
+              <a:t>Generational Wealth Deflection</a:t>
+            </a:r>
+            <a:endParaRPr lang="en-US" sz="900" dirty="0"/>
           </a:p>
         </p:txBody>
       </p:sp>
       <p:sp>
         <p:nvSpPr>
           <p:cNvPr id="38" name="Shape 36"/>
-          <p:cNvSpPr/>
-          <p:nvPr/>
-        </p:nvSpPr>
-        <p:spPr>
-          <a:xfrm>
-            <a:off x="4974336" y="4251960"/>
-            <a:ext cx="749808" cy="164592"/>
-          </a:xfrm>
-          <a:prstGeom prst="rect">
-            <a:avLst/>
-          </a:prstGeom>
-          <a:solidFill>
-            <a:srgbClr val="FFFFFF">
-              <a:alpha val="80000"/>
-            </a:srgbClr>
-          </a:solidFill>
-          <a:ln w="12700">
-            <a:solidFill>
-              <a:srgbClr val="FFFFFF">
-                <a:alpha val="60000"/>
-              </a:srgbClr>
-            </a:solidFill>
-            <a:prstDash val="solid"/>
-          </a:ln>
-        </p:spPr>
-      </p:sp>
-      <p:sp>
-        <p:nvSpPr>
-          <p:cNvPr id="39" name="Text 37"/>
-          <p:cNvSpPr/>
-          <p:nvPr/>
-        </p:nvSpPr>
-        <p:spPr>
-          <a:xfrm>
-            <a:off x="4974336" y="4251960"/>
-            <a:ext cx="749808" cy="164592"/>
-          </a:xfrm>
-          <a:prstGeom prst="rect">
-            <a:avLst/>
-          </a:prstGeom>
-          <a:noFill/>
-          <a:ln/>
-        </p:spPr>
-        <p:txBody>
-          <a:bodyPr wrap="square" lIns="0" tIns="0" rIns="0" bIns="0" rtlCol="0" anchor="ctr"/>
-          <a:lstStyle/>
-          <a:p>
-            <a:pPr algn="ctr" indent="0" marL="0">
-              <a:buNone/>
-            </a:pPr>
-            <a:r>
-              <a:rPr lang="en-US" sz="700" b="1" dirty="0">
-                <a:solidFill>
-                  <a:srgbClr val="FFFFFF"/>
-                </a:solidFill>
-                <a:latin typeface="Calibri" pitchFamily="34" charset="0"/>
-                <a:ea typeface="Calibri" pitchFamily="34" charset="-122"/>
-                <a:cs typeface="Calibri" pitchFamily="34" charset="-120"/>
-              </a:rPr>
-              <a:t>Aug/Sept '26</a:t>
-            </a:r>
-            <a:endParaRPr lang="en-US" sz="700" dirty="0"/>
-          </a:p>
-        </p:txBody>
-      </p:sp>
-      <p:sp>
-        <p:nvSpPr>
-          <p:cNvPr id="40" name="Shape 38"/>
-          <p:cNvSpPr/>
-          <p:nvPr/>
-        </p:nvSpPr>
-        <p:spPr>
-          <a:xfrm>
-            <a:off x="3328416" y="4480560"/>
-            <a:ext cx="2523744" cy="219456"/>
-          </a:xfrm>
-          <a:prstGeom prst="rect">
-            <a:avLst/>
-          </a:prstGeom>
-          <a:solidFill>
-            <a:srgbClr val="0A52C4"/>
-          </a:solidFill>
-          <a:ln w="12700">
-            <a:solidFill>
-              <a:srgbClr val="0A52C4"/>
-            </a:solidFill>
-            <a:prstDash val="solid"/>
-          </a:ln>
-        </p:spPr>
-      </p:sp>
-      <p:sp>
-        <p:nvSpPr>
-          <p:cNvPr id="41" name="Shape 39"/>
-          <p:cNvSpPr/>
-          <p:nvPr/>
-        </p:nvSpPr>
-        <p:spPr>
-          <a:xfrm>
-            <a:off x="3383280" y="4526280"/>
-            <a:ext cx="128016" cy="128016"/>
-          </a:xfrm>
-          <a:prstGeom prst="ellipse">
-            <a:avLst/>
-          </a:prstGeom>
-          <a:solidFill>
-            <a:srgbClr val="FFFFFF">
-              <a:alpha val="70000"/>
-            </a:srgbClr>
-          </a:solidFill>
-          <a:ln w="12700">
-            <a:solidFill>
-              <a:srgbClr val="FFFFFF">
-                <a:alpha val="70000"/>
-              </a:srgbClr>
-            </a:solidFill>
-            <a:prstDash val="solid"/>
-          </a:ln>
-        </p:spPr>
-      </p:sp>
-      <p:sp>
-        <p:nvSpPr>
-          <p:cNvPr id="42" name="Text 40"/>
-          <p:cNvSpPr/>
-          <p:nvPr/>
-        </p:nvSpPr>
-        <p:spPr>
-          <a:xfrm>
-            <a:off x="3566160" y="4480560"/>
-            <a:ext cx="2231136" cy="219456"/>
-          </a:xfrm>
-          <a:prstGeom prst="rect">
-            <a:avLst/>
-          </a:prstGeom>
-          <a:noFill/>
-          <a:ln/>
-        </p:spPr>
-        <p:txBody>
-          <a:bodyPr wrap="square" lIns="0" tIns="0" rIns="0" bIns="0" rtlCol="0" anchor="ctr"/>
-          <a:lstStyle/>
-          <a:p>
-            <a:pPr indent="0" marL="0">
-              <a:buNone/>
-            </a:pPr>
-            <a:r>
-              <a:rPr lang="en-US" sz="800" b="1" dirty="0">
-                <a:solidFill>
-                  <a:srgbClr val="FFFFFF"/>
-                </a:solidFill>
-                <a:latin typeface="Calibri" pitchFamily="34" charset="0"/>
-                <a:ea typeface="Calibri" pitchFamily="34" charset="-122"/>
-                <a:cs typeface="Calibri" pitchFamily="34" charset="-120"/>
-              </a:rPr>
-              <a:t>Personal-as-Commercial</a:t>
-            </a:r>
-            <a:endParaRPr lang="en-US" sz="800" dirty="0"/>
-          </a:p>
-        </p:txBody>
-      </p:sp>
-      <p:sp>
-        <p:nvSpPr>
-          <p:cNvPr id="43" name="Shape 41"/>
-          <p:cNvSpPr/>
-          <p:nvPr/>
-        </p:nvSpPr>
-        <p:spPr>
-          <a:xfrm>
-            <a:off x="3328416" y="4736592"/>
-            <a:ext cx="2523744" cy="219456"/>
-          </a:xfrm>
-          <a:prstGeom prst="rect">
-            <a:avLst/>
-          </a:prstGeom>
-          <a:solidFill>
-            <a:srgbClr val="0F3D8A"/>
-          </a:solidFill>
-          <a:ln w="12700">
-            <a:solidFill>
-              <a:srgbClr val="0F3D8A"/>
-            </a:solidFill>
-            <a:prstDash val="solid"/>
-          </a:ln>
-        </p:spPr>
-      </p:sp>
-      <p:sp>
-        <p:nvSpPr>
-          <p:cNvPr id="44" name="Shape 42"/>
-          <p:cNvSpPr/>
-          <p:nvPr/>
-        </p:nvSpPr>
-        <p:spPr>
-          <a:xfrm>
-            <a:off x="3383280" y="4782312"/>
-            <a:ext cx="128016" cy="128016"/>
-          </a:xfrm>
-          <a:prstGeom prst="ellipse">
-            <a:avLst/>
-          </a:prstGeom>
-          <a:solidFill>
-            <a:srgbClr val="FFFFFF">
-              <a:alpha val="70000"/>
-            </a:srgbClr>
-          </a:solidFill>
-          <a:ln w="12700">
-            <a:solidFill>
-              <a:srgbClr val="FFFFFF">
-                <a:alpha val="70000"/>
-              </a:srgbClr>
-            </a:solidFill>
-            <a:prstDash val="solid"/>
-          </a:ln>
-        </p:spPr>
-      </p:sp>
-      <p:sp>
-        <p:nvSpPr>
-          <p:cNvPr id="45" name="Text 43"/>
-          <p:cNvSpPr/>
-          <p:nvPr/>
-        </p:nvSpPr>
-        <p:spPr>
-          <a:xfrm>
-            <a:off x="3566160" y="4736592"/>
-            <a:ext cx="2231136" cy="219456"/>
-          </a:xfrm>
-          <a:prstGeom prst="rect">
-            <a:avLst/>
-          </a:prstGeom>
-          <a:noFill/>
-          <a:ln/>
-        </p:spPr>
-        <p:txBody>
-          <a:bodyPr wrap="square" lIns="0" tIns="0" rIns="0" bIns="0" rtlCol="0" anchor="ctr"/>
-          <a:lstStyle/>
-          <a:p>
-            <a:pPr indent="0" marL="0">
-              <a:buNone/>
-            </a:pPr>
-            <a:r>
-              <a:rPr lang="en-US" sz="800" b="1" dirty="0">
-                <a:solidFill>
-                  <a:srgbClr val="FFFFFF"/>
-                </a:solidFill>
-                <a:latin typeface="Calibri" pitchFamily="34" charset="0"/>
-                <a:ea typeface="Calibri" pitchFamily="34" charset="-122"/>
-                <a:cs typeface="Calibri" pitchFamily="34" charset="-120"/>
-              </a:rPr>
-              <a:t>Generational Wealth Deflection</a:t>
-            </a:r>
-            <a:endParaRPr lang="en-US" sz="800" dirty="0"/>
-          </a:p>
-        </p:txBody>
-      </p:sp>
-      <p:sp>
-        <p:nvSpPr>
-          <p:cNvPr id="46" name="Shape 44"/>
           <p:cNvSpPr/>
           <p:nvPr/>
         </p:nvSpPr>
@@ -29579,7 +28245,7 @@
       </p:sp>
       <p:sp>
         <p:nvSpPr>
-          <p:cNvPr id="47" name="Shape 45"/>
+          <p:cNvPr id="39" name="Shape 37"/>
           <p:cNvSpPr/>
           <p:nvPr/>
         </p:nvSpPr>
@@ -29604,7 +28270,7 @@
       </p:sp>
       <p:sp>
         <p:nvSpPr>
-          <p:cNvPr id="48" name="Text 46"/>
+          <p:cNvPr id="40" name="Text 38"/>
           <p:cNvSpPr/>
           <p:nvPr/>
         </p:nvSpPr>
@@ -29643,7 +28309,7 @@
       </p:sp>
       <p:sp>
         <p:nvSpPr>
-          <p:cNvPr id="49" name="Shape 47"/>
+          <p:cNvPr id="41" name="Shape 39"/>
           <p:cNvSpPr/>
           <p:nvPr/>
         </p:nvSpPr>
@@ -29672,7 +28338,7 @@
       </p:sp>
       <p:sp>
         <p:nvSpPr>
-          <p:cNvPr id="50" name="Text 48"/>
+          <p:cNvPr id="42" name="Text 40"/>
           <p:cNvSpPr/>
           <p:nvPr/>
         </p:nvSpPr>
@@ -29711,7 +28377,7 @@
       </p:sp>
       <p:sp>
         <p:nvSpPr>
-          <p:cNvPr id="51" name="Text 49"/>
+          <p:cNvPr id="43" name="Text 41"/>
           <p:cNvSpPr/>
           <p:nvPr/>
         </p:nvSpPr>
@@ -29750,7 +28416,7 @@
       </p:sp>
       <p:sp>
         <p:nvSpPr>
-          <p:cNvPr id="52" name="Text 50"/>
+          <p:cNvPr id="44" name="Text 42"/>
           <p:cNvSpPr/>
           <p:nvPr/>
         </p:nvSpPr>
@@ -29785,7 +28451,7 @@
                 <a:ea typeface="Calibri" pitchFamily="34" charset="-122"/>
                 <a:cs typeface="Calibri" pitchFamily="34" charset="-120"/>
               </a:rPr>
-              <a:t>Account Opening LTV into JH onboarding flow</a:t>
+              <a:t>Anomaly Detection: real-time streaming fraud engine</a:t>
             </a:r>
             <a:endParaRPr lang="en-US" sz="1000" dirty="0"/>
           </a:p>
@@ -29827,7 +28493,7 @@
                 <a:ea typeface="Calibri" pitchFamily="34" charset="-122"/>
                 <a:cs typeface="Calibri" pitchFamily="34" charset="-120"/>
               </a:rPr>
-              <a:t>Core + Payments data modules activated</a:t>
+              <a:t>Core + Payments data modules fully activated</a:t>
             </a:r>
             <a:endParaRPr lang="en-US" sz="1000" dirty="0"/>
           </a:p>
@@ -29856,7 +28522,7 @@
       </p:sp>
       <p:sp>
         <p:nvSpPr>
-          <p:cNvPr id="53" name="Shape 51"/>
+          <p:cNvPr id="45" name="Shape 43"/>
           <p:cNvSpPr/>
           <p:nvPr/>
         </p:nvSpPr>
@@ -29885,7 +28551,7 @@
       </p:sp>
       <p:sp>
         <p:nvSpPr>
-          <p:cNvPr id="54" name="Shape 52"/>
+          <p:cNvPr id="46" name="Shape 44"/>
           <p:cNvSpPr/>
           <p:nvPr/>
         </p:nvSpPr>
@@ -29910,7 +28576,7 @@
       </p:sp>
       <p:sp>
         <p:nvSpPr>
-          <p:cNvPr id="55" name="Text 53"/>
+          <p:cNvPr id="47" name="Text 45"/>
           <p:cNvSpPr/>
           <p:nvPr/>
         </p:nvSpPr>
@@ -29949,7 +28615,7 @@
       </p:sp>
       <p:sp>
         <p:nvSpPr>
-          <p:cNvPr id="56" name="Shape 54"/>
+          <p:cNvPr id="48" name="Shape 46"/>
           <p:cNvSpPr/>
           <p:nvPr/>
         </p:nvSpPr>
@@ -29962,11 +28628,11 @@
             <a:avLst/>
           </a:prstGeom>
           <a:solidFill>
-            <a:srgbClr val="0B68D4"/>
+            <a:srgbClr val="073FA8"/>
           </a:solidFill>
           <a:ln w="12700">
             <a:solidFill>
-              <a:srgbClr val="0B68D4"/>
+              <a:srgbClr val="073FA8"/>
             </a:solidFill>
             <a:prstDash val="solid"/>
           </a:ln>
@@ -29974,7 +28640,7 @@
       </p:sp>
       <p:sp>
         <p:nvSpPr>
-          <p:cNvPr id="57" name="Shape 55"/>
+          <p:cNvPr id="49" name="Shape 47"/>
           <p:cNvSpPr/>
           <p:nvPr/>
         </p:nvSpPr>
@@ -30003,7 +28669,7 @@
       </p:sp>
       <p:sp>
         <p:nvSpPr>
-          <p:cNvPr id="58" name="Text 56"/>
+          <p:cNvPr id="50" name="Text 48"/>
           <p:cNvSpPr/>
           <p:nvPr/>
         </p:nvSpPr>
@@ -30034,7 +28700,7 @@
                 <a:ea typeface="Calibri" pitchFamily="34" charset="-122"/>
                 <a:cs typeface="Calibri" pitchFamily="34" charset="-120"/>
               </a:rPr>
-              <a:t>Account Opening LTV</a:t>
+              <a:t>Anomaly Detection</a:t>
             </a:r>
             <a:endParaRPr lang="en-US" sz="900" dirty="0"/>
           </a:p>
@@ -30042,7 +28708,7 @@
       </p:sp>
       <p:sp>
         <p:nvSpPr>
-          <p:cNvPr id="59" name="Shape 57"/>
+          <p:cNvPr id="51" name="Shape 49"/>
           <p:cNvSpPr/>
           <p:nvPr/>
         </p:nvSpPr>
@@ -30067,7 +28733,7 @@
       </p:sp>
       <p:sp>
         <p:nvSpPr>
-          <p:cNvPr id="60" name="Shape 58"/>
+          <p:cNvPr id="52" name="Shape 50"/>
           <p:cNvSpPr/>
           <p:nvPr/>
         </p:nvSpPr>
@@ -30096,7 +28762,7 @@
       </p:sp>
       <p:sp>
         <p:nvSpPr>
-          <p:cNvPr id="61" name="Text 59"/>
+          <p:cNvPr id="53" name="Text 51"/>
           <p:cNvSpPr/>
           <p:nvPr/>
         </p:nvSpPr>
@@ -30135,7 +28801,7 @@
       </p:sp>
       <p:sp>
         <p:nvSpPr>
-          <p:cNvPr id="62" name="Shape 60"/>
+          <p:cNvPr id="54" name="Shape 52"/>
           <p:cNvSpPr/>
           <p:nvPr/>
         </p:nvSpPr>
@@ -30164,7 +28830,7 @@
       </p:sp>
       <p:sp>
         <p:nvSpPr>
-          <p:cNvPr id="63" name="Text 61"/>
+          <p:cNvPr id="55" name="Text 53"/>
           <p:cNvSpPr/>
           <p:nvPr/>
         </p:nvSpPr>
@@ -30203,7 +28869,7 @@
       </p:sp>
       <p:sp>
         <p:nvSpPr>
-          <p:cNvPr id="64" name="Shape 62"/>
+          <p:cNvPr id="56" name="Shape 54"/>
           <p:cNvSpPr/>
           <p:nvPr/>
         </p:nvSpPr>
@@ -30228,7 +28894,7 @@
       </p:sp>
       <p:sp>
         <p:nvSpPr>
-          <p:cNvPr id="65" name="Shape 63"/>
+          <p:cNvPr id="57" name="Shape 55"/>
           <p:cNvSpPr/>
           <p:nvPr/>
         </p:nvSpPr>
@@ -30257,7 +28923,7 @@
       </p:sp>
       <p:sp>
         <p:nvSpPr>
-          <p:cNvPr id="66" name="Text 64"/>
+          <p:cNvPr id="58" name="Text 56"/>
           <p:cNvSpPr/>
           <p:nvPr/>
         </p:nvSpPr>
@@ -30296,7 +28962,7 @@
       </p:sp>
       <p:sp>
         <p:nvSpPr>
-          <p:cNvPr id="67" name="Shape 65"/>
+          <p:cNvPr id="59" name="Shape 57"/>
           <p:cNvSpPr/>
           <p:nvPr/>
         </p:nvSpPr>
@@ -30325,7 +28991,7 @@
       </p:sp>
       <p:sp>
         <p:nvSpPr>
-          <p:cNvPr id="68" name="Text 66"/>
+          <p:cNvPr id="60" name="Text 58"/>
           <p:cNvSpPr/>
           <p:nvPr/>
         </p:nvSpPr>
@@ -34010,7 +32676,7 @@
                 <a:ea typeface="Calibri" pitchFamily="34" charset="-122"/>
                 <a:cs typeface="Calibri" pitchFamily="34" charset="-120"/>
               </a:rPr>
-              <a:t>Horizon Pipeline also includes: Call Report AI  ·  Account Opening LTV  ·  Cross-Sell Propensity  ·  Fraud Ring Detection  ·  and more →  see Horizon slide</a:t>
+              <a:t>Horizon Pipeline includes Year 2 opportunities: Cross-Sell Propensity  ·  Fraud Ring Detection  ·  Deposit Runoff  ·  Overdraft Prediction  ·  and more →  see Horizon slide</a:t>
             </a:r>
             <a:endParaRPr lang="en-US" sz="950" dirty="0"/>
           </a:p>

</xml_diff>

<commit_message>
Rename Personal-as-Commercial Detection to CommercialSignal
Brand rename across all slides: portfolio overview, app detail slide header,
four pillars, pricing, roadmap chips and bullets, app delivery Gantt, data
source Gantt apps label, and color constant comment.
</commit_message>
<xml_diff>
--- a/JH_DS_Strategy_JHBI.pptx
+++ b/JH_DS_Strategy_JHBI.pptx
@@ -4495,7 +4495,7 @@
                 <a:ea typeface="Calibri" pitchFamily="34" charset="-122"/>
                 <a:cs typeface="Calibri" pitchFamily="34" charset="-120"/>
               </a:rPr>
-              <a:t>Personal-as-Commercial Detection</a:t>
+              <a:t>CommercialSignal</a:t>
             </a:r>
             <a:endParaRPr lang="en-US" sz="2000" dirty="0"/>
           </a:p>
@@ -9224,7 +9224,7 @@
                 <a:ea typeface="Calibri" pitchFamily="34" charset="-122"/>
                 <a:cs typeface="Calibri" pitchFamily="34" charset="-120"/>
               </a:rPr>
-              <a:t>Personal-as-Commercial Detection</a:t>
+              <a:t>CommercialSignal</a:t>
             </a:r>
             <a:endParaRPr lang="en-US" sz="950" dirty="0"/>
           </a:p>
@@ -13320,7 +13320,7 @@
                 <a:ea typeface="Calibri" pitchFamily="34" charset="-122"/>
                 <a:cs typeface="Calibri" pitchFamily="34" charset="-120"/>
               </a:rPr>
-              <a:t>Personal-as-Commercial Detection</a:t>
+              <a:t>CommercialSignal</a:t>
             </a:r>
             <a:endParaRPr lang="en-US" sz="950" dirty="0"/>
           </a:p>
@@ -24125,7 +24125,7 @@
                 <a:ea typeface="Calibri" pitchFamily="34" charset="-122"/>
                 <a:cs typeface="Calibri" pitchFamily="34" charset="-120"/>
               </a:rPr>
-              <a:t>Churn Mediation · Acct Opening LTV · Personal-as-Commercial · Wealth Deflection</a:t>
+              <a:t>Churn Mediation · Acct Opening LTV · CommercialSignal · Wealth Deflection</a:t>
             </a:r>
             <a:endParaRPr lang="en-US" sz="750" dirty="0"/>
           </a:p>
@@ -25876,7 +25876,7 @@
                 <a:ea typeface="Calibri" pitchFamily="34" charset="-122"/>
                 <a:cs typeface="Calibri" pitchFamily="34" charset="-120"/>
               </a:rPr>
-              <a:t>Personal-as-Commercial</a:t>
+              <a:t>CommercialSignal</a:t>
             </a:r>
             <a:endParaRPr lang="en-US" sz="850" dirty="0"/>
           </a:p>
@@ -27812,7 +27812,7 @@
                 <a:ea typeface="Calibri" pitchFamily="34" charset="-122"/>
                 <a:cs typeface="Calibri" pitchFamily="34" charset="-120"/>
               </a:rPr>
-              <a:t>Personal-as-Commercial SMB conversion model</a:t>
+              <a:t>CommercialSignal: personal-to-business conversion model</a:t>
             </a:r>
             <a:endParaRPr lang="en-US" sz="1000" dirty="0"/>
           </a:p>
@@ -28112,7 +28112,7 @@
                 <a:ea typeface="Calibri" pitchFamily="34" charset="-122"/>
                 <a:cs typeface="Calibri" pitchFamily="34" charset="-120"/>
               </a:rPr>
-              <a:t>Personal-as-Commercial</a:t>
+              <a:t>CommercialSignal</a:t>
             </a:r>
             <a:endParaRPr lang="en-US" sz="900" dirty="0"/>
           </a:p>
@@ -32380,24 +32380,7 @@
                 <a:ea typeface="Calibri" pitchFamily="34" charset="-122"/>
                 <a:cs typeface="Calibri" pitchFamily="34" charset="-120"/>
               </a:rPr>
-              <a:t>Personal-as-</a:t>
-            </a:r>
-            <a:endParaRPr lang="en-US" sz="1150" dirty="0"/>
-          </a:p>
-          <a:p>
-            <a:pPr indent="0" marL="0">
-              <a:buNone/>
-            </a:pPr>
-            <a:r>
-              <a:rPr lang="en-US" sz="1150" b="1" dirty="0">
-                <a:solidFill>
-                  <a:srgbClr val="FFFFFF"/>
-                </a:solidFill>
-                <a:latin typeface="Calibri" pitchFamily="34" charset="0"/>
-                <a:ea typeface="Calibri" pitchFamily="34" charset="-122"/>
-                <a:cs typeface="Calibri" pitchFamily="34" charset="-120"/>
-              </a:rPr>
-              <a:t>Commercial Detection</a:t>
+              <a:t>CommercialSignal</a:t>
             </a:r>
             <a:endParaRPr lang="en-US" sz="1150" dirty="0"/>
           </a:p>

</xml_diff>

<commit_message>
Rename to Churn Sentinel; add two-phase ACH-first signal story
- Renamed Attrition/Churn Mediation → Churn Sentinel throughout
- Detail slide rewritten: Phase 1 = ACH direct deposit monitoring,
  Phase 2 = core banking + Banno digital signal enrichment
- App Delivery Gantt: split into Churn Sentinel (Phase 1 ACH) and
  Churn Sentinel+ (Phase 2 Core+Digital) rows
- Phased Roadmap Phase 1 bullets: ACH pipeline ingestion + Sentinel launch
- Phased Roadmap Phase 2: Churn Sentinel+ chip added, bullets updated
- Next Steps: updated scoping item to ACH pipeline + DD monitoring spec
- Metric 3 updated to Q3 FY26 Phase 1 target
</commit_message>
<xml_diff>
--- a/JH_DS_Strategy_JHBI.pptx
+++ b/JH_DS_Strategy_JHBI.pptx
@@ -8389,7 +8389,7 @@
                 <a:ea typeface="Calibri" pitchFamily="34" charset="-122"/>
                 <a:cs typeface="Calibri" pitchFamily="34" charset="-120"/>
               </a:rPr>
-              <a:t>Attrition / Churn Mediation</a:t>
+              <a:t>Churn Sentinel</a:t>
             </a:r>
             <a:endParaRPr lang="en-US" sz="950" dirty="0"/>
           </a:p>
@@ -11454,7 +11454,7 @@
                 <a:ea typeface="Calibri" pitchFamily="34" charset="-122"/>
                 <a:cs typeface="Calibri" pitchFamily="34" charset="-120"/>
               </a:rPr>
-              <a:t>Attrition / Churn Mediation</a:t>
+              <a:t>Churn Sentinel</a:t>
             </a:r>
             <a:endParaRPr lang="en-US" sz="950" dirty="0"/>
           </a:p>
@@ -14865,7 +14865,7 @@
                 <a:ea typeface="Calibri" pitchFamily="34" charset="-122"/>
                 <a:cs typeface="Calibri" pitchFamily="34" charset="-120"/>
               </a:rPr>
-              <a:t>Churn Mediation  ·  Cross-Sell Propensity</a:t>
+              <a:t>Churn Sentinel  ·  Cross-Sell Propensity</a:t>
             </a:r>
             <a:endParaRPr lang="en-US" sz="850" dirty="0"/>
           </a:p>
@@ -24125,7 +24125,7 @@
                 <a:ea typeface="Calibri" pitchFamily="34" charset="-122"/>
                 <a:cs typeface="Calibri" pitchFamily="34" charset="-120"/>
               </a:rPr>
-              <a:t>Churn Mediation · Acct Opening LTV · CommercialSignal · Wealth Deflection</a:t>
+              <a:t>Churn Sentinel · Acct Opening LTV · CommercialSignal · Wealth Deflection</a:t>
             </a:r>
             <a:endParaRPr lang="en-US" sz="750" dirty="0"/>
           </a:p>
@@ -25434,7 +25434,7 @@
                 <a:ea typeface="Calibri" pitchFamily="34" charset="-122"/>
                 <a:cs typeface="Calibri" pitchFamily="34" charset="-120"/>
               </a:rPr>
-              <a:t>Churn Mediation</a:t>
+              <a:t>Churn Sentinel</a:t>
             </a:r>
             <a:endParaRPr lang="en-US" sz="850" dirty="0"/>
           </a:p>
@@ -25473,7 +25473,7 @@
                 <a:ea typeface="Calibri" pitchFamily="34" charset="-122"/>
                 <a:cs typeface="Calibri" pitchFamily="34" charset="-120"/>
               </a:rPr>
-              <a:t>Phase 1 MVP</a:t>
+              <a:t>ACH signals  ·  Phase 1</a:t>
             </a:r>
             <a:endParaRPr lang="en-US" sz="750" dirty="0"/>
           </a:p>
@@ -25566,7 +25566,7 @@
                 <a:ea typeface="Calibri" pitchFamily="34" charset="-122"/>
                 <a:cs typeface="Calibri" pitchFamily="34" charset="-120"/>
               </a:rPr>
-              <a:t>MVP  ·  Phase 1</a:t>
+              <a:t>ACH Sentinel  ·  Phase 1 launch</a:t>
             </a:r>
             <a:endParaRPr lang="en-US" sz="750" dirty="0"/>
           </a:p>
@@ -25612,6 +25612,227 @@
             <a:avLst/>
           </a:prstGeom>
           <a:solidFill>
+            <a:srgbClr val="085CE5"/>
+          </a:solidFill>
+          <a:ln w="12700">
+            <a:solidFill>
+              <a:srgbClr val="085CE5"/>
+            </a:solidFill>
+            <a:prstDash val="solid"/>
+          </a:ln>
+        </p:spPr>
+      </p:sp>
+      <p:sp>
+        <p:nvSpPr>
+          <p:cNvPr id="41" name="Text 39"/>
+          <p:cNvSpPr/>
+          <p:nvPr/>
+        </p:nvSpPr>
+        <p:spPr>
+          <a:xfrm>
+            <a:off x="384048" y="2093976"/>
+            <a:ext cx="1938528" cy="201168"/>
+          </a:xfrm>
+          <a:prstGeom prst="rect">
+            <a:avLst/>
+          </a:prstGeom>
+          <a:noFill/>
+          <a:ln/>
+        </p:spPr>
+        <p:txBody>
+          <a:bodyPr wrap="square" lIns="0" tIns="0" rIns="0" bIns="0" rtlCol="0" anchor="ctr"/>
+          <a:lstStyle/>
+          <a:p>
+            <a:pPr indent="0" marL="0">
+              <a:buNone/>
+            </a:pPr>
+            <a:r>
+              <a:rPr lang="en-US" sz="850" b="1" dirty="0">
+                <a:solidFill>
+                  <a:srgbClr val="06185F"/>
+                </a:solidFill>
+                <a:latin typeface="Calibri" pitchFamily="34" charset="0"/>
+                <a:ea typeface="Calibri" pitchFamily="34" charset="-122"/>
+                <a:cs typeface="Calibri" pitchFamily="34" charset="-120"/>
+              </a:rPr>
+              <a:t>Churn Sentinel +</a:t>
+            </a:r>
+            <a:endParaRPr lang="en-US" sz="850" dirty="0"/>
+          </a:p>
+        </p:txBody>
+      </p:sp>
+      <p:sp>
+        <p:nvSpPr>
+          <p:cNvPr id="42" name="Text 40"/>
+          <p:cNvSpPr/>
+          <p:nvPr/>
+        </p:nvSpPr>
+        <p:spPr>
+          <a:xfrm>
+            <a:off x="384048" y="2295144"/>
+            <a:ext cx="1938528" cy="137160"/>
+          </a:xfrm>
+          <a:prstGeom prst="rect">
+            <a:avLst/>
+          </a:prstGeom>
+          <a:noFill/>
+          <a:ln/>
+        </p:spPr>
+        <p:txBody>
+          <a:bodyPr wrap="square" lIns="0" tIns="0" rIns="0" bIns="0" rtlCol="0" anchor="ctr"/>
+          <a:lstStyle/>
+          <a:p>
+            <a:pPr indent="0" marL="0">
+              <a:buNone/>
+            </a:pPr>
+            <a:r>
+              <a:rPr lang="en-US" sz="750" i="1" dirty="0">
+                <a:solidFill>
+                  <a:srgbClr val="B6BBC0"/>
+                </a:solidFill>
+                <a:latin typeface="Calibri" pitchFamily="34" charset="0"/>
+                <a:ea typeface="Calibri" pitchFamily="34" charset="-122"/>
+                <a:cs typeface="Calibri" pitchFamily="34" charset="-120"/>
+              </a:rPr>
+              <a:t>Core + digital enrichment</a:t>
+            </a:r>
+            <a:endParaRPr lang="en-US" sz="750" dirty="0"/>
+          </a:p>
+        </p:txBody>
+      </p:sp>
+      <p:sp>
+        <p:nvSpPr>
+          <p:cNvPr id="43" name="Shape 41"/>
+          <p:cNvSpPr/>
+          <p:nvPr/>
+        </p:nvSpPr>
+        <p:spPr>
+          <a:xfrm>
+            <a:off x="4110228" y="2157984"/>
+            <a:ext cx="1495044" cy="182880"/>
+          </a:xfrm>
+          <a:prstGeom prst="rect">
+            <a:avLst/>
+          </a:prstGeom>
+          <a:solidFill>
+            <a:srgbClr val="085CE5">
+              <a:alpha val="70000"/>
+            </a:srgbClr>
+          </a:solidFill>
+          <a:ln w="12700">
+            <a:solidFill>
+              <a:srgbClr val="085CE5">
+                <a:alpha val="90000"/>
+              </a:srgbClr>
+            </a:solidFill>
+            <a:prstDash val="solid"/>
+          </a:ln>
+        </p:spPr>
+      </p:sp>
+      <p:sp>
+        <p:nvSpPr>
+          <p:cNvPr id="44" name="Shape 42"/>
+          <p:cNvSpPr/>
+          <p:nvPr/>
+        </p:nvSpPr>
+        <p:spPr>
+          <a:xfrm>
+            <a:off x="5186660" y="2157984"/>
+            <a:ext cx="418612" cy="182880"/>
+          </a:xfrm>
+          <a:prstGeom prst="rect">
+            <a:avLst/>
+          </a:prstGeom>
+          <a:solidFill>
+            <a:srgbClr val="085CE5"/>
+          </a:solidFill>
+          <a:ln w="12700">
+            <a:solidFill>
+              <a:srgbClr val="085CE5"/>
+            </a:solidFill>
+            <a:prstDash val="solid"/>
+          </a:ln>
+        </p:spPr>
+      </p:sp>
+      <p:sp>
+        <p:nvSpPr>
+          <p:cNvPr id="45" name="Text 43"/>
+          <p:cNvSpPr/>
+          <p:nvPr/>
+        </p:nvSpPr>
+        <p:spPr>
+          <a:xfrm>
+            <a:off x="4174236" y="2157984"/>
+            <a:ext cx="1367028" cy="182880"/>
+          </a:xfrm>
+          <a:prstGeom prst="rect">
+            <a:avLst/>
+          </a:prstGeom>
+          <a:noFill/>
+          <a:ln/>
+        </p:spPr>
+        <p:txBody>
+          <a:bodyPr wrap="square" lIns="0" tIns="0" rIns="0" bIns="0" rtlCol="0" anchor="ctr"/>
+          <a:lstStyle/>
+          <a:p>
+            <a:pPr indent="0" marL="0">
+              <a:buNone/>
+            </a:pPr>
+            <a:r>
+              <a:rPr lang="en-US" sz="750" dirty="0">
+                <a:solidFill>
+                  <a:srgbClr val="FFFFFF"/>
+                </a:solidFill>
+                <a:latin typeface="Calibri" pitchFamily="34" charset="0"/>
+                <a:ea typeface="Calibri" pitchFamily="34" charset="-122"/>
+                <a:cs typeface="Calibri" pitchFamily="34" charset="-120"/>
+              </a:rPr>
+              <a:t>Core &amp; Banno signals  →  Phase 2</a:t>
+            </a:r>
+            <a:endParaRPr lang="en-US" sz="750" dirty="0"/>
+          </a:p>
+        </p:txBody>
+      </p:sp>
+      <p:sp>
+        <p:nvSpPr>
+          <p:cNvPr id="46" name="Shape 44"/>
+          <p:cNvSpPr/>
+          <p:nvPr/>
+        </p:nvSpPr>
+        <p:spPr>
+          <a:xfrm>
+            <a:off x="274320" y="2468880"/>
+            <a:ext cx="8503920" cy="374904"/>
+          </a:xfrm>
+          <a:prstGeom prst="rect">
+            <a:avLst/>
+          </a:prstGeom>
+          <a:solidFill>
+            <a:srgbClr val="FFFFFF"/>
+          </a:solidFill>
+          <a:ln w="12700">
+            <a:solidFill>
+              <a:srgbClr val="E7ECF0"/>
+            </a:solidFill>
+            <a:prstDash val="solid"/>
+          </a:ln>
+        </p:spPr>
+      </p:sp>
+      <p:sp>
+        <p:nvSpPr>
+          <p:cNvPr id="47" name="Shape 45"/>
+          <p:cNvSpPr/>
+          <p:nvPr/>
+        </p:nvSpPr>
+        <p:spPr>
+          <a:xfrm>
+            <a:off x="274320" y="2468880"/>
+            <a:ext cx="54864" cy="374904"/>
+          </a:xfrm>
+          <a:prstGeom prst="rect">
+            <a:avLst/>
+          </a:prstGeom>
+          <a:solidFill>
             <a:srgbClr val="06185F"/>
           </a:solidFill>
           <a:ln w="12700">
@@ -25624,13 +25845,13 @@
       </p:sp>
       <p:sp>
         <p:nvSpPr>
-          <p:cNvPr id="41" name="Text 39"/>
-          <p:cNvSpPr/>
-          <p:nvPr/>
-        </p:nvSpPr>
-        <p:spPr>
-          <a:xfrm>
-            <a:off x="384048" y="2093976"/>
+          <p:cNvPr id="48" name="Text 46"/>
+          <p:cNvSpPr/>
+          <p:nvPr/>
+        </p:nvSpPr>
+        <p:spPr>
+          <a:xfrm>
+            <a:off x="384048" y="2496312"/>
             <a:ext cx="1938528" cy="201168"/>
           </a:xfrm>
           <a:prstGeom prst="rect">
@@ -25663,13 +25884,13 @@
       </p:sp>
       <p:sp>
         <p:nvSpPr>
-          <p:cNvPr id="42" name="Text 40"/>
-          <p:cNvSpPr/>
-          <p:nvPr/>
-        </p:nvSpPr>
-        <p:spPr>
-          <a:xfrm>
-            <a:off x="384048" y="2295144"/>
+          <p:cNvPr id="49" name="Text 47"/>
+          <p:cNvSpPr/>
+          <p:nvPr/>
+        </p:nvSpPr>
+        <p:spPr>
+          <a:xfrm>
+            <a:off x="384048" y="2697480"/>
             <a:ext cx="1938528" cy="137160"/>
           </a:xfrm>
           <a:prstGeom prst="rect">
@@ -25702,13 +25923,13 @@
       </p:sp>
       <p:sp>
         <p:nvSpPr>
-          <p:cNvPr id="43" name="Shape 41"/>
-          <p:cNvSpPr/>
-          <p:nvPr/>
-        </p:nvSpPr>
-        <p:spPr>
-          <a:xfrm>
-            <a:off x="4110228" y="2157984"/>
+          <p:cNvPr id="50" name="Shape 48"/>
+          <p:cNvSpPr/>
+          <p:nvPr/>
+        </p:nvSpPr>
+        <p:spPr>
+          <a:xfrm>
+            <a:off x="4110228" y="2560320"/>
             <a:ext cx="1495044" cy="182880"/>
           </a:xfrm>
           <a:prstGeom prst="rect">
@@ -25731,13 +25952,13 @@
       </p:sp>
       <p:sp>
         <p:nvSpPr>
-          <p:cNvPr id="44" name="Shape 42"/>
-          <p:cNvSpPr/>
-          <p:nvPr/>
-        </p:nvSpPr>
-        <p:spPr>
-          <a:xfrm>
-            <a:off x="5186660" y="2157984"/>
+          <p:cNvPr id="51" name="Shape 49"/>
+          <p:cNvSpPr/>
+          <p:nvPr/>
+        </p:nvSpPr>
+        <p:spPr>
+          <a:xfrm>
+            <a:off x="5186660" y="2560320"/>
             <a:ext cx="418612" cy="182880"/>
           </a:xfrm>
           <a:prstGeom prst="rect">
@@ -25756,13 +25977,13 @@
       </p:sp>
       <p:sp>
         <p:nvSpPr>
-          <p:cNvPr id="45" name="Text 43"/>
-          <p:cNvSpPr/>
-          <p:nvPr/>
-        </p:nvSpPr>
-        <p:spPr>
-          <a:xfrm>
-            <a:off x="4174236" y="2157984"/>
+          <p:cNvPr id="52" name="Text 50"/>
+          <p:cNvSpPr/>
+          <p:nvPr/>
+        </p:nvSpPr>
+        <p:spPr>
+          <a:xfrm>
+            <a:off x="4174236" y="2560320"/>
             <a:ext cx="1367028" cy="182880"/>
           </a:xfrm>
           <a:prstGeom prst="rect">
@@ -25795,20 +26016,20 @@
       </p:sp>
       <p:sp>
         <p:nvSpPr>
-          <p:cNvPr id="46" name="Shape 44"/>
-          <p:cNvSpPr/>
-          <p:nvPr/>
-        </p:nvSpPr>
-        <p:spPr>
-          <a:xfrm>
-            <a:off x="274320" y="2468880"/>
+          <p:cNvPr id="53" name="Shape 51"/>
+          <p:cNvSpPr/>
+          <p:nvPr/>
+        </p:nvSpPr>
+        <p:spPr>
+          <a:xfrm>
+            <a:off x="274320" y="2871216"/>
             <a:ext cx="8503920" cy="374904"/>
           </a:xfrm>
           <a:prstGeom prst="rect">
             <a:avLst/>
           </a:prstGeom>
           <a:solidFill>
-            <a:srgbClr val="FFFFFF"/>
+            <a:srgbClr val="F8F9FA"/>
           </a:solidFill>
           <a:ln w="12700">
             <a:solidFill>
@@ -25820,13 +26041,13 @@
       </p:sp>
       <p:sp>
         <p:nvSpPr>
-          <p:cNvPr id="47" name="Shape 45"/>
-          <p:cNvSpPr/>
-          <p:nvPr/>
-        </p:nvSpPr>
-        <p:spPr>
-          <a:xfrm>
-            <a:off x="274320" y="2468880"/>
+          <p:cNvPr id="54" name="Shape 52"/>
+          <p:cNvSpPr/>
+          <p:nvPr/>
+        </p:nvSpPr>
+        <p:spPr>
+          <a:xfrm>
+            <a:off x="274320" y="2871216"/>
             <a:ext cx="54864" cy="374904"/>
           </a:xfrm>
           <a:prstGeom prst="rect">
@@ -25845,13 +26066,13 @@
       </p:sp>
       <p:sp>
         <p:nvSpPr>
-          <p:cNvPr id="48" name="Text 46"/>
-          <p:cNvSpPr/>
-          <p:nvPr/>
-        </p:nvSpPr>
-        <p:spPr>
-          <a:xfrm>
-            <a:off x="384048" y="2496312"/>
+          <p:cNvPr id="55" name="Text 53"/>
+          <p:cNvSpPr/>
+          <p:nvPr/>
+        </p:nvSpPr>
+        <p:spPr>
+          <a:xfrm>
+            <a:off x="384048" y="2898648"/>
             <a:ext cx="1938528" cy="201168"/>
           </a:xfrm>
           <a:prstGeom prst="rect">
@@ -25884,13 +26105,13 @@
       </p:sp>
       <p:sp>
         <p:nvSpPr>
-          <p:cNvPr id="49" name="Text 47"/>
-          <p:cNvSpPr/>
-          <p:nvPr/>
-        </p:nvSpPr>
-        <p:spPr>
-          <a:xfrm>
-            <a:off x="384048" y="2697480"/>
+          <p:cNvPr id="56" name="Text 54"/>
+          <p:cNvSpPr/>
+          <p:nvPr/>
+        </p:nvSpPr>
+        <p:spPr>
+          <a:xfrm>
+            <a:off x="384048" y="3099816"/>
             <a:ext cx="1938528" cy="137160"/>
           </a:xfrm>
           <a:prstGeom prst="rect">
@@ -25923,13 +26144,13 @@
       </p:sp>
       <p:sp>
         <p:nvSpPr>
-          <p:cNvPr id="50" name="Shape 48"/>
-          <p:cNvSpPr/>
-          <p:nvPr/>
-        </p:nvSpPr>
-        <p:spPr>
-          <a:xfrm>
-            <a:off x="4110228" y="2560320"/>
+          <p:cNvPr id="57" name="Shape 55"/>
+          <p:cNvSpPr/>
+          <p:nvPr/>
+        </p:nvSpPr>
+        <p:spPr>
+          <a:xfrm>
+            <a:off x="4110228" y="2962656"/>
             <a:ext cx="1495044" cy="182880"/>
           </a:xfrm>
           <a:prstGeom prst="rect">
@@ -25952,13 +26173,13 @@
       </p:sp>
       <p:sp>
         <p:nvSpPr>
-          <p:cNvPr id="51" name="Shape 49"/>
-          <p:cNvSpPr/>
-          <p:nvPr/>
-        </p:nvSpPr>
-        <p:spPr>
-          <a:xfrm>
-            <a:off x="5186660" y="2560320"/>
+          <p:cNvPr id="58" name="Shape 56"/>
+          <p:cNvSpPr/>
+          <p:nvPr/>
+        </p:nvSpPr>
+        <p:spPr>
+          <a:xfrm>
+            <a:off x="5186660" y="2962656"/>
             <a:ext cx="418612" cy="182880"/>
           </a:xfrm>
           <a:prstGeom prst="rect">
@@ -25977,13 +26198,13 @@
       </p:sp>
       <p:sp>
         <p:nvSpPr>
-          <p:cNvPr id="52" name="Text 50"/>
-          <p:cNvSpPr/>
-          <p:nvPr/>
-        </p:nvSpPr>
-        <p:spPr>
-          <a:xfrm>
-            <a:off x="4174236" y="2560320"/>
+          <p:cNvPr id="59" name="Text 57"/>
+          <p:cNvSpPr/>
+          <p:nvPr/>
+        </p:nvSpPr>
+        <p:spPr>
+          <a:xfrm>
+            <a:off x="4174236" y="2962656"/>
             <a:ext cx="1367028" cy="182880"/>
           </a:xfrm>
           <a:prstGeom prst="rect">
@@ -26016,20 +26237,20 @@
       </p:sp>
       <p:sp>
         <p:nvSpPr>
-          <p:cNvPr id="53" name="Shape 51"/>
-          <p:cNvSpPr/>
-          <p:nvPr/>
-        </p:nvSpPr>
-        <p:spPr>
-          <a:xfrm>
-            <a:off x="274320" y="2871216"/>
+          <p:cNvPr id="60" name="Shape 58"/>
+          <p:cNvSpPr/>
+          <p:nvPr/>
+        </p:nvSpPr>
+        <p:spPr>
+          <a:xfrm>
+            <a:off x="274320" y="3273552"/>
             <a:ext cx="8503920" cy="374904"/>
           </a:xfrm>
           <a:prstGeom prst="rect">
             <a:avLst/>
           </a:prstGeom>
           <a:solidFill>
-            <a:srgbClr val="F8F9FA"/>
+            <a:srgbClr val="FFFFFF"/>
           </a:solidFill>
           <a:ln w="12700">
             <a:solidFill>
@@ -26041,13 +26262,13 @@
       </p:sp>
       <p:sp>
         <p:nvSpPr>
-          <p:cNvPr id="54" name="Shape 52"/>
-          <p:cNvSpPr/>
-          <p:nvPr/>
-        </p:nvSpPr>
-        <p:spPr>
-          <a:xfrm>
-            <a:off x="274320" y="2871216"/>
+          <p:cNvPr id="61" name="Shape 59"/>
+          <p:cNvSpPr/>
+          <p:nvPr/>
+        </p:nvSpPr>
+        <p:spPr>
+          <a:xfrm>
+            <a:off x="274320" y="3273552"/>
             <a:ext cx="54864" cy="374904"/>
           </a:xfrm>
           <a:prstGeom prst="rect">
@@ -26066,13 +26287,13 @@
       </p:sp>
       <p:sp>
         <p:nvSpPr>
-          <p:cNvPr id="55" name="Text 53"/>
-          <p:cNvSpPr/>
-          <p:nvPr/>
-        </p:nvSpPr>
-        <p:spPr>
-          <a:xfrm>
-            <a:off x="384048" y="2898648"/>
+          <p:cNvPr id="62" name="Text 60"/>
+          <p:cNvSpPr/>
+          <p:nvPr/>
+        </p:nvSpPr>
+        <p:spPr>
+          <a:xfrm>
+            <a:off x="384048" y="3300984"/>
             <a:ext cx="1938528" cy="201168"/>
           </a:xfrm>
           <a:prstGeom prst="rect">
@@ -26105,13 +26326,13 @@
       </p:sp>
       <p:sp>
         <p:nvSpPr>
-          <p:cNvPr id="56" name="Text 54"/>
-          <p:cNvSpPr/>
-          <p:nvPr/>
-        </p:nvSpPr>
-        <p:spPr>
-          <a:xfrm>
-            <a:off x="384048" y="3099816"/>
+          <p:cNvPr id="63" name="Text 61"/>
+          <p:cNvSpPr/>
+          <p:nvPr/>
+        </p:nvSpPr>
+        <p:spPr>
+          <a:xfrm>
+            <a:off x="384048" y="3502152"/>
             <a:ext cx="1938528" cy="137160"/>
           </a:xfrm>
           <a:prstGeom prst="rect">
@@ -26144,13 +26365,13 @@
       </p:sp>
       <p:sp>
         <p:nvSpPr>
-          <p:cNvPr id="57" name="Shape 55"/>
-          <p:cNvSpPr/>
-          <p:nvPr/>
-        </p:nvSpPr>
-        <p:spPr>
-          <a:xfrm>
-            <a:off x="4110228" y="2962656"/>
+          <p:cNvPr id="64" name="Shape 62"/>
+          <p:cNvSpPr/>
+          <p:nvPr/>
+        </p:nvSpPr>
+        <p:spPr>
+          <a:xfrm>
+            <a:off x="4110228" y="3364992"/>
             <a:ext cx="2279142" cy="182880"/>
           </a:xfrm>
           <a:prstGeom prst="rect">
@@ -26173,13 +26394,13 @@
       </p:sp>
       <p:sp>
         <p:nvSpPr>
-          <p:cNvPr id="58" name="Shape 56"/>
-          <p:cNvSpPr/>
-          <p:nvPr/>
-        </p:nvSpPr>
-        <p:spPr>
-          <a:xfrm>
-            <a:off x="5751210" y="2962656"/>
+          <p:cNvPr id="65" name="Shape 63"/>
+          <p:cNvSpPr/>
+          <p:nvPr/>
+        </p:nvSpPr>
+        <p:spPr>
+          <a:xfrm>
+            <a:off x="5751210" y="3364992"/>
             <a:ext cx="638160" cy="182880"/>
           </a:xfrm>
           <a:prstGeom prst="rect">
@@ -26198,13 +26419,13 @@
       </p:sp>
       <p:sp>
         <p:nvSpPr>
-          <p:cNvPr id="59" name="Text 57"/>
-          <p:cNvSpPr/>
-          <p:nvPr/>
-        </p:nvSpPr>
-        <p:spPr>
-          <a:xfrm>
-            <a:off x="4174236" y="2962656"/>
+          <p:cNvPr id="66" name="Text 64"/>
+          <p:cNvSpPr/>
+          <p:nvPr/>
+        </p:nvSpPr>
+        <p:spPr>
+          <a:xfrm>
+            <a:off x="4174236" y="3364992"/>
             <a:ext cx="2151126" cy="182880"/>
           </a:xfrm>
           <a:prstGeom prst="rect">
@@ -26237,20 +26458,20 @@
       </p:sp>
       <p:sp>
         <p:nvSpPr>
-          <p:cNvPr id="60" name="Shape 58"/>
-          <p:cNvSpPr/>
-          <p:nvPr/>
-        </p:nvSpPr>
-        <p:spPr>
-          <a:xfrm>
-            <a:off x="274320" y="3273552"/>
+          <p:cNvPr id="67" name="Shape 65"/>
+          <p:cNvSpPr/>
+          <p:nvPr/>
+        </p:nvSpPr>
+        <p:spPr>
+          <a:xfrm>
+            <a:off x="274320" y="3675888"/>
             <a:ext cx="8503920" cy="374904"/>
           </a:xfrm>
           <a:prstGeom prst="rect">
             <a:avLst/>
           </a:prstGeom>
           <a:solidFill>
-            <a:srgbClr val="FFFFFF"/>
+            <a:srgbClr val="F8F9FA"/>
           </a:solidFill>
           <a:ln w="12700">
             <a:solidFill>
@@ -26262,13 +26483,13 @@
       </p:sp>
       <p:sp>
         <p:nvSpPr>
-          <p:cNvPr id="61" name="Shape 59"/>
-          <p:cNvSpPr/>
-          <p:nvPr/>
-        </p:nvSpPr>
-        <p:spPr>
-          <a:xfrm>
-            <a:off x="274320" y="3273552"/>
+          <p:cNvPr id="68" name="Shape 66"/>
+          <p:cNvSpPr/>
+          <p:nvPr/>
+        </p:nvSpPr>
+        <p:spPr>
+          <a:xfrm>
+            <a:off x="274320" y="3675888"/>
             <a:ext cx="54864" cy="374904"/>
           </a:xfrm>
           <a:prstGeom prst="rect">
@@ -26287,13 +26508,13 @@
       </p:sp>
       <p:sp>
         <p:nvSpPr>
-          <p:cNvPr id="62" name="Text 60"/>
-          <p:cNvSpPr/>
-          <p:nvPr/>
-        </p:nvSpPr>
-        <p:spPr>
-          <a:xfrm>
-            <a:off x="384048" y="3300984"/>
+          <p:cNvPr id="69" name="Text 67"/>
+          <p:cNvSpPr/>
+          <p:nvPr/>
+        </p:nvSpPr>
+        <p:spPr>
+          <a:xfrm>
+            <a:off x="384048" y="3703320"/>
             <a:ext cx="1938528" cy="201168"/>
           </a:xfrm>
           <a:prstGeom prst="rect">
@@ -26326,13 +26547,13 @@
       </p:sp>
       <p:sp>
         <p:nvSpPr>
-          <p:cNvPr id="63" name="Text 61"/>
-          <p:cNvSpPr/>
-          <p:nvPr/>
-        </p:nvSpPr>
-        <p:spPr>
-          <a:xfrm>
-            <a:off x="384048" y="3502152"/>
+          <p:cNvPr id="70" name="Text 68"/>
+          <p:cNvSpPr/>
+          <p:nvPr/>
+        </p:nvSpPr>
+        <p:spPr>
+          <a:xfrm>
+            <a:off x="384048" y="3904488"/>
             <a:ext cx="1938528" cy="137160"/>
           </a:xfrm>
           <a:prstGeom prst="rect">
@@ -26365,13 +26586,13 @@
       </p:sp>
       <p:sp>
         <p:nvSpPr>
-          <p:cNvPr id="64" name="Shape 62"/>
-          <p:cNvSpPr/>
-          <p:nvPr/>
-        </p:nvSpPr>
-        <p:spPr>
-          <a:xfrm>
-            <a:off x="5678424" y="3364992"/>
+          <p:cNvPr id="71" name="Shape 69"/>
+          <p:cNvSpPr/>
+          <p:nvPr/>
+        </p:nvSpPr>
+        <p:spPr>
+          <a:xfrm>
+            <a:off x="5678424" y="3767328"/>
             <a:ext cx="2279142" cy="182880"/>
           </a:xfrm>
           <a:prstGeom prst="rect">
@@ -26394,13 +26615,13 @@
       </p:sp>
       <p:sp>
         <p:nvSpPr>
-          <p:cNvPr id="65" name="Shape 63"/>
-          <p:cNvSpPr/>
-          <p:nvPr/>
-        </p:nvSpPr>
-        <p:spPr>
-          <a:xfrm>
-            <a:off x="7319406" y="3364992"/>
+          <p:cNvPr id="72" name="Shape 70"/>
+          <p:cNvSpPr/>
+          <p:nvPr/>
+        </p:nvSpPr>
+        <p:spPr>
+          <a:xfrm>
+            <a:off x="7319406" y="3767328"/>
             <a:ext cx="638160" cy="182880"/>
           </a:xfrm>
           <a:prstGeom prst="rect">
@@ -26419,13 +26640,13 @@
       </p:sp>
       <p:sp>
         <p:nvSpPr>
-          <p:cNvPr id="66" name="Text 64"/>
-          <p:cNvSpPr/>
-          <p:nvPr/>
-        </p:nvSpPr>
-        <p:spPr>
-          <a:xfrm>
-            <a:off x="5742432" y="3364992"/>
+          <p:cNvPr id="73" name="Text 71"/>
+          <p:cNvSpPr/>
+          <p:nvPr/>
+        </p:nvSpPr>
+        <p:spPr>
+          <a:xfrm>
+            <a:off x="5742432" y="3767328"/>
             <a:ext cx="2151126" cy="182880"/>
           </a:xfrm>
           <a:prstGeom prst="rect">
@@ -26458,20 +26679,20 @@
       </p:sp>
       <p:sp>
         <p:nvSpPr>
-          <p:cNvPr id="67" name="Shape 65"/>
-          <p:cNvSpPr/>
-          <p:nvPr/>
-        </p:nvSpPr>
-        <p:spPr>
-          <a:xfrm>
-            <a:off x="274320" y="3675888"/>
+          <p:cNvPr id="74" name="Shape 72"/>
+          <p:cNvSpPr/>
+          <p:nvPr/>
+        </p:nvSpPr>
+        <p:spPr>
+          <a:xfrm>
+            <a:off x="274320" y="4078224"/>
             <a:ext cx="8503920" cy="374904"/>
           </a:xfrm>
           <a:prstGeom prst="rect">
             <a:avLst/>
           </a:prstGeom>
           <a:solidFill>
-            <a:srgbClr val="F8F9FA"/>
+            <a:srgbClr val="FFFFFF"/>
           </a:solidFill>
           <a:ln w="12700">
             <a:solidFill>
@@ -26483,13 +26704,13 @@
       </p:sp>
       <p:sp>
         <p:nvSpPr>
-          <p:cNvPr id="68" name="Shape 66"/>
-          <p:cNvSpPr/>
-          <p:nvPr/>
-        </p:nvSpPr>
-        <p:spPr>
-          <a:xfrm>
-            <a:off x="274320" y="3675888"/>
+          <p:cNvPr id="75" name="Shape 73"/>
+          <p:cNvSpPr/>
+          <p:nvPr/>
+        </p:nvSpPr>
+        <p:spPr>
+          <a:xfrm>
+            <a:off x="274320" y="4078224"/>
             <a:ext cx="54864" cy="374904"/>
           </a:xfrm>
           <a:prstGeom prst="rect">
@@ -26508,13 +26729,13 @@
       </p:sp>
       <p:sp>
         <p:nvSpPr>
-          <p:cNvPr id="69" name="Text 67"/>
-          <p:cNvSpPr/>
-          <p:nvPr/>
-        </p:nvSpPr>
-        <p:spPr>
-          <a:xfrm>
-            <a:off x="384048" y="3703320"/>
+          <p:cNvPr id="76" name="Text 74"/>
+          <p:cNvSpPr/>
+          <p:nvPr/>
+        </p:nvSpPr>
+        <p:spPr>
+          <a:xfrm>
+            <a:off x="384048" y="4105656"/>
             <a:ext cx="1938528" cy="201168"/>
           </a:xfrm>
           <a:prstGeom prst="rect">
@@ -26547,13 +26768,13 @@
       </p:sp>
       <p:sp>
         <p:nvSpPr>
-          <p:cNvPr id="70" name="Text 68"/>
-          <p:cNvSpPr/>
-          <p:nvPr/>
-        </p:nvSpPr>
-        <p:spPr>
-          <a:xfrm>
-            <a:off x="384048" y="3904488"/>
+          <p:cNvPr id="77" name="Text 75"/>
+          <p:cNvSpPr/>
+          <p:nvPr/>
+        </p:nvSpPr>
+        <p:spPr>
+          <a:xfrm>
+            <a:off x="384048" y="4306824"/>
             <a:ext cx="1938528" cy="137160"/>
           </a:xfrm>
           <a:prstGeom prst="rect">
@@ -26586,13 +26807,13 @@
       </p:sp>
       <p:sp>
         <p:nvSpPr>
-          <p:cNvPr id="71" name="Shape 69"/>
-          <p:cNvSpPr/>
-          <p:nvPr/>
-        </p:nvSpPr>
-        <p:spPr>
-          <a:xfrm>
-            <a:off x="5678424" y="3767328"/>
+          <p:cNvPr id="78" name="Shape 76"/>
+          <p:cNvSpPr/>
+          <p:nvPr/>
+        </p:nvSpPr>
+        <p:spPr>
+          <a:xfrm>
+            <a:off x="5678424" y="4169664"/>
             <a:ext cx="3063240" cy="182880"/>
           </a:xfrm>
           <a:prstGeom prst="rect">
@@ -26615,13 +26836,13 @@
       </p:sp>
       <p:sp>
         <p:nvSpPr>
-          <p:cNvPr id="72" name="Shape 70"/>
-          <p:cNvSpPr/>
-          <p:nvPr/>
-        </p:nvSpPr>
-        <p:spPr>
-          <a:xfrm>
-            <a:off x="8030718" y="3767328"/>
+          <p:cNvPr id="79" name="Shape 77"/>
+          <p:cNvSpPr/>
+          <p:nvPr/>
+        </p:nvSpPr>
+        <p:spPr>
+          <a:xfrm>
+            <a:off x="8030718" y="4169664"/>
             <a:ext cx="710946" cy="182880"/>
           </a:xfrm>
           <a:prstGeom prst="rect">
@@ -26640,13 +26861,13 @@
       </p:sp>
       <p:sp>
         <p:nvSpPr>
-          <p:cNvPr id="73" name="Text 71"/>
-          <p:cNvSpPr/>
-          <p:nvPr/>
-        </p:nvSpPr>
-        <p:spPr>
-          <a:xfrm>
-            <a:off x="5742432" y="3767328"/>
+          <p:cNvPr id="80" name="Text 78"/>
+          <p:cNvSpPr/>
+          <p:nvPr/>
+        </p:nvSpPr>
+        <p:spPr>
+          <a:xfrm>
+            <a:off x="5742432" y="4169664"/>
             <a:ext cx="2935224" cy="182880"/>
           </a:xfrm>
           <a:prstGeom prst="rect">
@@ -26679,7 +26900,7 @@
       </p:sp>
       <p:sp>
         <p:nvSpPr>
-          <p:cNvPr id="74" name="Shape 72"/>
+          <p:cNvPr id="81" name="Shape 79"/>
           <p:cNvSpPr/>
           <p:nvPr/>
         </p:nvSpPr>
@@ -26706,7 +26927,7 @@
       </p:sp>
       <p:sp>
         <p:nvSpPr>
-          <p:cNvPr id="75" name="Text 73"/>
+          <p:cNvPr id="82" name="Text 80"/>
           <p:cNvSpPr/>
           <p:nvPr/>
         </p:nvSpPr>
@@ -26745,7 +26966,7 @@
       </p:sp>
       <p:sp>
         <p:nvSpPr>
-          <p:cNvPr id="76" name="Shape 74"/>
+          <p:cNvPr id="83" name="Shape 81"/>
           <p:cNvSpPr/>
           <p:nvPr/>
         </p:nvSpPr>
@@ -26770,7 +26991,7 @@
       </p:sp>
       <p:sp>
         <p:nvSpPr>
-          <p:cNvPr id="77" name="Text 75"/>
+          <p:cNvPr id="84" name="Text 82"/>
           <p:cNvSpPr/>
           <p:nvPr/>
         </p:nvSpPr>
@@ -26809,7 +27030,7 @@
       </p:sp>
       <p:sp>
         <p:nvSpPr>
-          <p:cNvPr id="78" name="Shape 76"/>
+          <p:cNvPr id="85" name="Shape 83"/>
           <p:cNvSpPr/>
           <p:nvPr/>
         </p:nvSpPr>
@@ -26834,7 +27055,7 @@
       </p:sp>
       <p:sp>
         <p:nvSpPr>
-          <p:cNvPr id="79" name="Text 77"/>
+          <p:cNvPr id="86" name="Text 84"/>
           <p:cNvSpPr/>
           <p:nvPr/>
         </p:nvSpPr>
@@ -27249,7 +27470,7 @@
                 <a:ea typeface="Calibri" pitchFamily="34" charset="-122"/>
                 <a:cs typeface="Calibri" pitchFamily="34" charset="-120"/>
               </a:rPr>
-              <a:t>Build FI data pipelines from JH core banking systems</a:t>
+              <a:t>Ingest ACH payment rails — direct deposit monitoring live</a:t>
             </a:r>
             <a:endParaRPr lang="en-US" sz="1000" dirty="0"/>
           </a:p>
@@ -27270,7 +27491,7 @@
                 <a:ea typeface="Calibri" pitchFamily="34" charset="-122"/>
                 <a:cs typeface="Calibri" pitchFamily="34" charset="-120"/>
               </a:rPr>
-              <a:t>Establish data governance and model review process</a:t>
+              <a:t>Churn Sentinel Phase 1: ACH cadence + originator change alerts</a:t>
             </a:r>
             <a:endParaRPr lang="en-US" sz="1000" dirty="0"/>
           </a:p>
@@ -27456,7 +27677,7 @@
                 <a:ea typeface="Calibri" pitchFamily="34" charset="-122"/>
                 <a:cs typeface="Calibri" pitchFamily="34" charset="-120"/>
               </a:rPr>
-              <a:t>Attrition / Churn Mediation</a:t>
+              <a:t>Churn Sentinel</a:t>
             </a:r>
             <a:endParaRPr lang="en-US" sz="900" dirty="0"/>
           </a:p>
@@ -27524,7 +27745,7 @@
                 <a:ea typeface="Calibri" pitchFamily="34" charset="-122"/>
                 <a:cs typeface="Calibri" pitchFamily="34" charset="-120"/>
               </a:rPr>
-              <a:t>MVP</a:t>
+              <a:t>ACH</a:t>
             </a:r>
             <a:endParaRPr lang="en-US" sz="700" dirty="0"/>
           </a:p>
@@ -27770,7 +27991,7 @@
                 <a:ea typeface="Calibri" pitchFamily="34" charset="-122"/>
                 <a:cs typeface="Calibri" pitchFamily="34" charset="-120"/>
               </a:rPr>
-              <a:t>Core banking + payments data integration complete</a:t>
+              <a:t>Churn Sentinel Phase 2: core banking + Banno digital signals</a:t>
             </a:r>
             <a:endParaRPr lang="en-US" sz="1000" dirty="0"/>
           </a:p>
@@ -27791,7 +28012,7 @@
                 <a:ea typeface="Calibri" pitchFamily="34" charset="-122"/>
                 <a:cs typeface="Calibri" pitchFamily="34" charset="-120"/>
               </a:rPr>
-              <a:t>Exec dashboards + FI banker score explorer live</a:t>
+              <a:t>CommercialSignal: personal-to-business conversion model</a:t>
             </a:r>
             <a:endParaRPr lang="en-US" sz="1000" dirty="0"/>
           </a:p>
@@ -27812,7 +28033,7 @@
                 <a:ea typeface="Calibri" pitchFamily="34" charset="-122"/>
                 <a:cs typeface="Calibri" pitchFamily="34" charset="-120"/>
               </a:rPr>
-              <a:t>CommercialSignal: personal-to-business conversion model</a:t>
+              <a:t>Generational Wealth household relationship engine</a:t>
             </a:r>
             <a:endParaRPr lang="en-US" sz="1000" dirty="0"/>
           </a:p>
@@ -27833,7 +28054,7 @@
                 <a:ea typeface="Calibri" pitchFamily="34" charset="-122"/>
                 <a:cs typeface="Calibri" pitchFamily="34" charset="-120"/>
               </a:rPr>
-              <a:t>Generational Wealth household relationship engine</a:t>
+              <a:t>Exec dashboards + FI banker score explorer live</a:t>
             </a:r>
             <a:endParaRPr lang="en-US" sz="1000" dirty="0"/>
           </a:p>
@@ -27847,7 +28068,7 @@
         </p:nvSpPr>
         <p:spPr>
           <a:xfrm>
-            <a:off x="3200400" y="3675888"/>
+            <a:off x="3200400" y="3438144"/>
             <a:ext cx="2816352" cy="237744"/>
           </a:xfrm>
           <a:prstGeom prst="rect">
@@ -27876,7 +28097,7 @@
         </p:nvSpPr>
         <p:spPr>
           <a:xfrm>
-            <a:off x="3200400" y="3675888"/>
+            <a:off x="3200400" y="3438144"/>
             <a:ext cx="54864" cy="237744"/>
           </a:xfrm>
           <a:prstGeom prst="rect">
@@ -27901,7 +28122,7 @@
         </p:nvSpPr>
         <p:spPr>
           <a:xfrm>
-            <a:off x="3328416" y="3675888"/>
+            <a:off x="3328416" y="3438144"/>
             <a:ext cx="2651760" cy="237744"/>
           </a:xfrm>
           <a:prstGeom prst="rect">
@@ -27940,18 +28161,18 @@
         </p:nvSpPr>
         <p:spPr>
           <a:xfrm>
-            <a:off x="3328416" y="3950208"/>
-            <a:ext cx="2523744" cy="256032"/>
+            <a:off x="3328416" y="3712464"/>
+            <a:ext cx="2523744" cy="219456"/>
           </a:xfrm>
           <a:prstGeom prst="rect">
             <a:avLst/>
           </a:prstGeom>
           <a:solidFill>
-            <a:srgbClr val="06185F"/>
+            <a:srgbClr val="085CE5"/>
           </a:solidFill>
           <a:ln w="12700">
             <a:solidFill>
-              <a:srgbClr val="06185F"/>
+              <a:srgbClr val="085CE5"/>
             </a:solidFill>
             <a:prstDash val="solid"/>
           </a:ln>
@@ -27965,7 +28186,7 @@
         </p:nvSpPr>
         <p:spPr>
           <a:xfrm>
-            <a:off x="3383280" y="4014216"/>
+            <a:off x="3383280" y="3758184"/>
             <a:ext cx="128016" cy="128016"/>
           </a:xfrm>
           <a:prstGeom prst="ellipse">
@@ -27994,8 +28215,8 @@
         </p:nvSpPr>
         <p:spPr>
           <a:xfrm>
-            <a:off x="3566160" y="3950208"/>
-            <a:ext cx="2231136" cy="256032"/>
+            <a:off x="3566160" y="3712464"/>
+            <a:ext cx="1554480" cy="219456"/>
           </a:xfrm>
           <a:prstGeom prst="rect">
             <a:avLst/>
@@ -28011,7 +28232,7 @@
               <a:buNone/>
             </a:pPr>
             <a:r>
-              <a:rPr lang="en-US" sz="900" b="1" dirty="0">
+              <a:rPr lang="en-US" sz="800" b="1" dirty="0">
                 <a:solidFill>
                   <a:srgbClr val="FFFFFF"/>
                 </a:solidFill>
@@ -28019,9 +28240,9 @@
                 <a:ea typeface="Calibri" pitchFamily="34" charset="-122"/>
                 <a:cs typeface="Calibri" pitchFamily="34" charset="-120"/>
               </a:rPr>
-              <a:t>Zelle Memo Intelligence</a:t>
-            </a:r>
-            <a:endParaRPr lang="en-US" sz="900" dirty="0"/>
+              <a:t>Churn Sentinel +</a:t>
+            </a:r>
+            <a:endParaRPr lang="en-US" sz="800" dirty="0"/>
           </a:p>
         </p:txBody>
       </p:sp>
@@ -28033,18 +28254,22 @@
         </p:nvSpPr>
         <p:spPr>
           <a:xfrm>
-            <a:off x="3328416" y="4279392"/>
-            <a:ext cx="2523744" cy="256032"/>
+            <a:off x="4974336" y="3739896"/>
+            <a:ext cx="749808" cy="164592"/>
           </a:xfrm>
           <a:prstGeom prst="rect">
             <a:avLst/>
           </a:prstGeom>
           <a:solidFill>
-            <a:srgbClr val="0A52C4"/>
+            <a:srgbClr val="FFFFFF">
+              <a:alpha val="80000"/>
+            </a:srgbClr>
           </a:solidFill>
           <a:ln w="12700">
             <a:solidFill>
-              <a:srgbClr val="0A52C4"/>
+              <a:srgbClr val="FFFFFF">
+                <a:alpha val="60000"/>
+              </a:srgbClr>
             </a:solidFill>
             <a:prstDash val="solid"/>
           </a:ln>
@@ -28052,13 +28277,77 @@
       </p:sp>
       <p:sp>
         <p:nvSpPr>
-          <p:cNvPr id="33" name="Shape 31"/>
-          <p:cNvSpPr/>
-          <p:nvPr/>
-        </p:nvSpPr>
-        <p:spPr>
-          <a:xfrm>
-            <a:off x="3383280" y="4343400"/>
+          <p:cNvPr id="33" name="Text 31"/>
+          <p:cNvSpPr/>
+          <p:nvPr/>
+        </p:nvSpPr>
+        <p:spPr>
+          <a:xfrm>
+            <a:off x="4974336" y="3739896"/>
+            <a:ext cx="749808" cy="164592"/>
+          </a:xfrm>
+          <a:prstGeom prst="rect">
+            <a:avLst/>
+          </a:prstGeom>
+          <a:noFill/>
+          <a:ln/>
+        </p:spPr>
+        <p:txBody>
+          <a:bodyPr wrap="square" lIns="0" tIns="0" rIns="0" bIns="0" rtlCol="0" anchor="ctr"/>
+          <a:lstStyle/>
+          <a:p>
+            <a:pPr algn="ctr" indent="0" marL="0">
+              <a:buNone/>
+            </a:pPr>
+            <a:r>
+              <a:rPr lang="en-US" sz="700" b="1" dirty="0">
+                <a:solidFill>
+                  <a:srgbClr val="FFFFFF"/>
+                </a:solidFill>
+                <a:latin typeface="Calibri" pitchFamily="34" charset="0"/>
+                <a:ea typeface="Calibri" pitchFamily="34" charset="-122"/>
+                <a:cs typeface="Calibri" pitchFamily="34" charset="-120"/>
+              </a:rPr>
+              <a:t>Core+Digital</a:t>
+            </a:r>
+            <a:endParaRPr lang="en-US" sz="700" dirty="0"/>
+          </a:p>
+        </p:txBody>
+      </p:sp>
+      <p:sp>
+        <p:nvSpPr>
+          <p:cNvPr id="34" name="Shape 32"/>
+          <p:cNvSpPr/>
+          <p:nvPr/>
+        </p:nvSpPr>
+        <p:spPr>
+          <a:xfrm>
+            <a:off x="3328416" y="3968496"/>
+            <a:ext cx="2523744" cy="219456"/>
+          </a:xfrm>
+          <a:prstGeom prst="rect">
+            <a:avLst/>
+          </a:prstGeom>
+          <a:solidFill>
+            <a:srgbClr val="06185F"/>
+          </a:solidFill>
+          <a:ln w="12700">
+            <a:solidFill>
+              <a:srgbClr val="06185F"/>
+            </a:solidFill>
+            <a:prstDash val="solid"/>
+          </a:ln>
+        </p:spPr>
+      </p:sp>
+      <p:sp>
+        <p:nvSpPr>
+          <p:cNvPr id="35" name="Shape 33"/>
+          <p:cNvSpPr/>
+          <p:nvPr/>
+        </p:nvSpPr>
+        <p:spPr>
+          <a:xfrm>
+            <a:off x="3383280" y="4014216"/>
             <a:ext cx="128016" cy="128016"/>
           </a:xfrm>
           <a:prstGeom prst="ellipse">
@@ -28081,14 +28370,14 @@
       </p:sp>
       <p:sp>
         <p:nvSpPr>
-          <p:cNvPr id="34" name="Text 32"/>
-          <p:cNvSpPr/>
-          <p:nvPr/>
-        </p:nvSpPr>
-        <p:spPr>
-          <a:xfrm>
-            <a:off x="3566160" y="4279392"/>
-            <a:ext cx="2231136" cy="256032"/>
+          <p:cNvPr id="36" name="Text 34"/>
+          <p:cNvSpPr/>
+          <p:nvPr/>
+        </p:nvSpPr>
+        <p:spPr>
+          <a:xfrm>
+            <a:off x="3566160" y="3968496"/>
+            <a:ext cx="2231136" cy="219456"/>
           </a:xfrm>
           <a:prstGeom prst="rect">
             <a:avLst/>
@@ -28104,7 +28393,7 @@
               <a:buNone/>
             </a:pPr>
             <a:r>
-              <a:rPr lang="en-US" sz="900" b="1" dirty="0">
+              <a:rPr lang="en-US" sz="800" b="1" dirty="0">
                 <a:solidFill>
                   <a:srgbClr val="FFFFFF"/>
                 </a:solidFill>
@@ -28112,32 +28401,32 @@
                 <a:ea typeface="Calibri" pitchFamily="34" charset="-122"/>
                 <a:cs typeface="Calibri" pitchFamily="34" charset="-120"/>
               </a:rPr>
-              <a:t>CommercialSignal</a:t>
-            </a:r>
-            <a:endParaRPr lang="en-US" sz="900" dirty="0"/>
-          </a:p>
-        </p:txBody>
-      </p:sp>
-      <p:sp>
-        <p:nvSpPr>
-          <p:cNvPr id="35" name="Shape 33"/>
-          <p:cNvSpPr/>
-          <p:nvPr/>
-        </p:nvSpPr>
-        <p:spPr>
-          <a:xfrm>
-            <a:off x="3328416" y="4608576"/>
-            <a:ext cx="2523744" cy="256032"/>
+              <a:t>Zelle Memo Intelligence</a:t>
+            </a:r>
+            <a:endParaRPr lang="en-US" sz="800" dirty="0"/>
+          </a:p>
+        </p:txBody>
+      </p:sp>
+      <p:sp>
+        <p:nvSpPr>
+          <p:cNvPr id="37" name="Shape 35"/>
+          <p:cNvSpPr/>
+          <p:nvPr/>
+        </p:nvSpPr>
+        <p:spPr>
+          <a:xfrm>
+            <a:off x="3328416" y="4224528"/>
+            <a:ext cx="2523744" cy="219456"/>
           </a:xfrm>
           <a:prstGeom prst="rect">
             <a:avLst/>
           </a:prstGeom>
           <a:solidFill>
-            <a:srgbClr val="0F3D8A"/>
+            <a:srgbClr val="0A52C4"/>
           </a:solidFill>
           <a:ln w="12700">
             <a:solidFill>
-              <a:srgbClr val="0F3D8A"/>
+              <a:srgbClr val="0A52C4"/>
             </a:solidFill>
             <a:prstDash val="solid"/>
           </a:ln>
@@ -28145,13 +28434,13 @@
       </p:sp>
       <p:sp>
         <p:nvSpPr>
-          <p:cNvPr id="36" name="Shape 34"/>
-          <p:cNvSpPr/>
-          <p:nvPr/>
-        </p:nvSpPr>
-        <p:spPr>
-          <a:xfrm>
-            <a:off x="3383280" y="4672584"/>
+          <p:cNvPr id="38" name="Shape 36"/>
+          <p:cNvSpPr/>
+          <p:nvPr/>
+        </p:nvSpPr>
+        <p:spPr>
+          <a:xfrm>
+            <a:off x="3383280" y="4270248"/>
             <a:ext cx="128016" cy="128016"/>
           </a:xfrm>
           <a:prstGeom prst="ellipse">
@@ -28174,14 +28463,14 @@
       </p:sp>
       <p:sp>
         <p:nvSpPr>
-          <p:cNvPr id="37" name="Text 35"/>
-          <p:cNvSpPr/>
-          <p:nvPr/>
-        </p:nvSpPr>
-        <p:spPr>
-          <a:xfrm>
-            <a:off x="3566160" y="4608576"/>
-            <a:ext cx="2231136" cy="256032"/>
+          <p:cNvPr id="39" name="Text 37"/>
+          <p:cNvSpPr/>
+          <p:nvPr/>
+        </p:nvSpPr>
+        <p:spPr>
+          <a:xfrm>
+            <a:off x="3566160" y="4224528"/>
+            <a:ext cx="2231136" cy="219456"/>
           </a:xfrm>
           <a:prstGeom prst="rect">
             <a:avLst/>
@@ -28197,7 +28486,7 @@
               <a:buNone/>
             </a:pPr>
             <a:r>
-              <a:rPr lang="en-US" sz="900" b="1" dirty="0">
+              <a:rPr lang="en-US" sz="800" b="1" dirty="0">
                 <a:solidFill>
                   <a:srgbClr val="FFFFFF"/>
                 </a:solidFill>
@@ -28205,15 +28494,108 @@
                 <a:ea typeface="Calibri" pitchFamily="34" charset="-122"/>
                 <a:cs typeface="Calibri" pitchFamily="34" charset="-120"/>
               </a:rPr>
+              <a:t>CommercialSignal</a:t>
+            </a:r>
+            <a:endParaRPr lang="en-US" sz="800" dirty="0"/>
+          </a:p>
+        </p:txBody>
+      </p:sp>
+      <p:sp>
+        <p:nvSpPr>
+          <p:cNvPr id="40" name="Shape 38"/>
+          <p:cNvSpPr/>
+          <p:nvPr/>
+        </p:nvSpPr>
+        <p:spPr>
+          <a:xfrm>
+            <a:off x="3328416" y="4480560"/>
+            <a:ext cx="2523744" cy="219456"/>
+          </a:xfrm>
+          <a:prstGeom prst="rect">
+            <a:avLst/>
+          </a:prstGeom>
+          <a:solidFill>
+            <a:srgbClr val="0F3D8A"/>
+          </a:solidFill>
+          <a:ln w="12700">
+            <a:solidFill>
+              <a:srgbClr val="0F3D8A"/>
+            </a:solidFill>
+            <a:prstDash val="solid"/>
+          </a:ln>
+        </p:spPr>
+      </p:sp>
+      <p:sp>
+        <p:nvSpPr>
+          <p:cNvPr id="41" name="Shape 39"/>
+          <p:cNvSpPr/>
+          <p:nvPr/>
+        </p:nvSpPr>
+        <p:spPr>
+          <a:xfrm>
+            <a:off x="3383280" y="4526280"/>
+            <a:ext cx="128016" cy="128016"/>
+          </a:xfrm>
+          <a:prstGeom prst="ellipse">
+            <a:avLst/>
+          </a:prstGeom>
+          <a:solidFill>
+            <a:srgbClr val="FFFFFF">
+              <a:alpha val="70000"/>
+            </a:srgbClr>
+          </a:solidFill>
+          <a:ln w="12700">
+            <a:solidFill>
+              <a:srgbClr val="FFFFFF">
+                <a:alpha val="70000"/>
+              </a:srgbClr>
+            </a:solidFill>
+            <a:prstDash val="solid"/>
+          </a:ln>
+        </p:spPr>
+      </p:sp>
+      <p:sp>
+        <p:nvSpPr>
+          <p:cNvPr id="42" name="Text 40"/>
+          <p:cNvSpPr/>
+          <p:nvPr/>
+        </p:nvSpPr>
+        <p:spPr>
+          <a:xfrm>
+            <a:off x="3566160" y="4480560"/>
+            <a:ext cx="2231136" cy="219456"/>
+          </a:xfrm>
+          <a:prstGeom prst="rect">
+            <a:avLst/>
+          </a:prstGeom>
+          <a:noFill/>
+          <a:ln/>
+        </p:spPr>
+        <p:txBody>
+          <a:bodyPr wrap="square" lIns="0" tIns="0" rIns="0" bIns="0" rtlCol="0" anchor="ctr"/>
+          <a:lstStyle/>
+          <a:p>
+            <a:pPr indent="0" marL="0">
+              <a:buNone/>
+            </a:pPr>
+            <a:r>
+              <a:rPr lang="en-US" sz="800" b="1" dirty="0">
+                <a:solidFill>
+                  <a:srgbClr val="FFFFFF"/>
+                </a:solidFill>
+                <a:latin typeface="Calibri" pitchFamily="34" charset="0"/>
+                <a:ea typeface="Calibri" pitchFamily="34" charset="-122"/>
+                <a:cs typeface="Calibri" pitchFamily="34" charset="-120"/>
+              </a:rPr>
               <a:t>Generational Wealth Deflection</a:t>
             </a:r>
-            <a:endParaRPr lang="en-US" sz="900" dirty="0"/>
-          </a:p>
-        </p:txBody>
-      </p:sp>
-      <p:sp>
-        <p:nvSpPr>
-          <p:cNvPr id="38" name="Shape 36"/>
+            <a:endParaRPr lang="en-US" sz="800" dirty="0"/>
+          </a:p>
+        </p:txBody>
+      </p:sp>
+      <p:sp>
+        <p:nvSpPr>
+          <p:cNvPr id="43" name="Shape 41"/>
           <p:cNvSpPr/>
           <p:nvPr/>
         </p:nvSpPr>
@@ -28245,7 +28627,7 @@
       </p:sp>
       <p:sp>
         <p:nvSpPr>
-          <p:cNvPr id="39" name="Shape 37"/>
+          <p:cNvPr id="44" name="Shape 42"/>
           <p:cNvSpPr/>
           <p:nvPr/>
         </p:nvSpPr>
@@ -28270,7 +28652,7 @@
       </p:sp>
       <p:sp>
         <p:nvSpPr>
-          <p:cNvPr id="40" name="Text 38"/>
+          <p:cNvPr id="45" name="Text 43"/>
           <p:cNvSpPr/>
           <p:nvPr/>
         </p:nvSpPr>
@@ -28309,7 +28691,7 @@
       </p:sp>
       <p:sp>
         <p:nvSpPr>
-          <p:cNvPr id="41" name="Shape 39"/>
+          <p:cNvPr id="46" name="Shape 44"/>
           <p:cNvSpPr/>
           <p:nvPr/>
         </p:nvSpPr>
@@ -28338,7 +28720,7 @@
       </p:sp>
       <p:sp>
         <p:nvSpPr>
-          <p:cNvPr id="42" name="Text 40"/>
+          <p:cNvPr id="47" name="Text 45"/>
           <p:cNvSpPr/>
           <p:nvPr/>
         </p:nvSpPr>
@@ -28377,7 +28759,7 @@
       </p:sp>
       <p:sp>
         <p:nvSpPr>
-          <p:cNvPr id="43" name="Text 41"/>
+          <p:cNvPr id="48" name="Text 46"/>
           <p:cNvSpPr/>
           <p:nvPr/>
         </p:nvSpPr>
@@ -28416,7 +28798,7 @@
       </p:sp>
       <p:sp>
         <p:nvSpPr>
-          <p:cNvPr id="44" name="Text 42"/>
+          <p:cNvPr id="49" name="Text 47"/>
           <p:cNvSpPr/>
           <p:nvPr/>
         </p:nvSpPr>
@@ -28522,7 +28904,7 @@
       </p:sp>
       <p:sp>
         <p:nvSpPr>
-          <p:cNvPr id="45" name="Shape 43"/>
+          <p:cNvPr id="50" name="Shape 48"/>
           <p:cNvSpPr/>
           <p:nvPr/>
         </p:nvSpPr>
@@ -28551,7 +28933,7 @@
       </p:sp>
       <p:sp>
         <p:nvSpPr>
-          <p:cNvPr id="46" name="Shape 44"/>
+          <p:cNvPr id="51" name="Shape 49"/>
           <p:cNvSpPr/>
           <p:nvPr/>
         </p:nvSpPr>
@@ -28576,7 +28958,7 @@
       </p:sp>
       <p:sp>
         <p:nvSpPr>
-          <p:cNvPr id="47" name="Text 45"/>
+          <p:cNvPr id="52" name="Text 50"/>
           <p:cNvSpPr/>
           <p:nvPr/>
         </p:nvSpPr>
@@ -28615,7 +28997,7 @@
       </p:sp>
       <p:sp>
         <p:nvSpPr>
-          <p:cNvPr id="48" name="Shape 46"/>
+          <p:cNvPr id="53" name="Shape 51"/>
           <p:cNvSpPr/>
           <p:nvPr/>
         </p:nvSpPr>
@@ -28640,7 +29022,7 @@
       </p:sp>
       <p:sp>
         <p:nvSpPr>
-          <p:cNvPr id="49" name="Shape 47"/>
+          <p:cNvPr id="54" name="Shape 52"/>
           <p:cNvSpPr/>
           <p:nvPr/>
         </p:nvSpPr>
@@ -28669,7 +29051,7 @@
       </p:sp>
       <p:sp>
         <p:nvSpPr>
-          <p:cNvPr id="50" name="Text 48"/>
+          <p:cNvPr id="55" name="Text 53"/>
           <p:cNvSpPr/>
           <p:nvPr/>
         </p:nvSpPr>
@@ -28708,7 +29090,7 @@
       </p:sp>
       <p:sp>
         <p:nvSpPr>
-          <p:cNvPr id="51" name="Shape 49"/>
+          <p:cNvPr id="56" name="Shape 54"/>
           <p:cNvSpPr/>
           <p:nvPr/>
         </p:nvSpPr>
@@ -28733,7 +29115,7 @@
       </p:sp>
       <p:sp>
         <p:nvSpPr>
-          <p:cNvPr id="52" name="Shape 50"/>
+          <p:cNvPr id="57" name="Shape 55"/>
           <p:cNvSpPr/>
           <p:nvPr/>
         </p:nvSpPr>
@@ -28762,7 +29144,7 @@
       </p:sp>
       <p:sp>
         <p:nvSpPr>
-          <p:cNvPr id="53" name="Text 51"/>
+          <p:cNvPr id="58" name="Text 56"/>
           <p:cNvSpPr/>
           <p:nvPr/>
         </p:nvSpPr>
@@ -28801,7 +29183,7 @@
       </p:sp>
       <p:sp>
         <p:nvSpPr>
-          <p:cNvPr id="54" name="Shape 52"/>
+          <p:cNvPr id="59" name="Shape 57"/>
           <p:cNvSpPr/>
           <p:nvPr/>
         </p:nvSpPr>
@@ -28830,7 +29212,7 @@
       </p:sp>
       <p:sp>
         <p:nvSpPr>
-          <p:cNvPr id="55" name="Text 53"/>
+          <p:cNvPr id="60" name="Text 58"/>
           <p:cNvSpPr/>
           <p:nvPr/>
         </p:nvSpPr>
@@ -28869,7 +29251,7 @@
       </p:sp>
       <p:sp>
         <p:nvSpPr>
-          <p:cNvPr id="56" name="Shape 54"/>
+          <p:cNvPr id="61" name="Shape 59"/>
           <p:cNvSpPr/>
           <p:nvPr/>
         </p:nvSpPr>
@@ -28894,7 +29276,7 @@
       </p:sp>
       <p:sp>
         <p:nvSpPr>
-          <p:cNvPr id="57" name="Shape 55"/>
+          <p:cNvPr id="62" name="Shape 60"/>
           <p:cNvSpPr/>
           <p:nvPr/>
         </p:nvSpPr>
@@ -28923,7 +29305,7 @@
       </p:sp>
       <p:sp>
         <p:nvSpPr>
-          <p:cNvPr id="58" name="Text 56"/>
+          <p:cNvPr id="63" name="Text 61"/>
           <p:cNvSpPr/>
           <p:nvPr/>
         </p:nvSpPr>
@@ -28962,7 +29344,7 @@
       </p:sp>
       <p:sp>
         <p:nvSpPr>
-          <p:cNvPr id="59" name="Shape 57"/>
+          <p:cNvPr id="64" name="Shape 62"/>
           <p:cNvSpPr/>
           <p:nvPr/>
         </p:nvSpPr>
@@ -28991,7 +29373,7 @@
       </p:sp>
       <p:sp>
         <p:nvSpPr>
-          <p:cNvPr id="60" name="Text 58"/>
+          <p:cNvPr id="65" name="Text 63"/>
           <p:cNvSpPr/>
           <p:nvPr/>
         </p:nvSpPr>
@@ -29644,7 +30026,7 @@
                 <a:ea typeface="Calibri" pitchFamily="34" charset="-122"/>
                 <a:cs typeface="Calibri" pitchFamily="34" charset="-120"/>
               </a:rPr>
-              <a:t>Churn Mediation MVP scoping session + FI data access agreements (Month 2)</a:t>
+              <a:t>Churn Sentinel Phase 1 scoping: ACH pipeline access + direct deposit monitoring spec (Month 2)</a:t>
             </a:r>
             <a:endParaRPr lang="en-US" sz="1200" dirty="0"/>
           </a:p>
@@ -31676,7 +32058,7 @@
                 <a:ea typeface="Calibri" pitchFamily="34" charset="-122"/>
                 <a:cs typeface="Calibri" pitchFamily="34" charset="-120"/>
               </a:rPr>
-              <a:t>Attrition /</a:t>
+              <a:t>Churn</a:t>
             </a:r>
             <a:endParaRPr lang="en-US" sz="1150" dirty="0"/>
           </a:p>
@@ -31693,7 +32075,7 @@
                 <a:ea typeface="Calibri" pitchFamily="34" charset="-122"/>
                 <a:cs typeface="Calibri" pitchFamily="34" charset="-120"/>
               </a:rPr>
-              <a:t>Churn Mediation</a:t>
+              <a:t>Sentinel</a:t>
             </a:r>
             <a:endParaRPr lang="en-US" sz="1150" dirty="0"/>
           </a:p>
@@ -32779,7 +33161,7 @@
                 <a:ea typeface="Calibri" pitchFamily="34" charset="-122"/>
                 <a:cs typeface="Calibri" pitchFamily="34" charset="-120"/>
               </a:rPr>
-              <a:t>Attrition / Churn Mediation</a:t>
+              <a:t>Churn Sentinel</a:t>
             </a:r>
             <a:endParaRPr lang="en-US" sz="2000" dirty="0"/>
           </a:p>
@@ -32953,7 +33335,7 @@
                 <a:ea typeface="Calibri" pitchFamily="34" charset="-122"/>
                 <a:cs typeface="Calibri" pitchFamily="34" charset="-120"/>
               </a:rPr>
-              <a:t>Community banks and credit unions lose 8–12% of their customer/member base annually to attrition. Without predictive capability embedded in their platform, FI staff can only react after the account is already closing — when outreach success rates drop below 20%.</a:t>
+              <a:t>Community banks and credit unions lose 8–12% of their customer base annually — but the signal is hiding in plain sight. Direct deposit cadence changes, ACH originator shifts, and balance migration patterns in payments data telegraph defection weeks before an account closes. By the time staff react, the relationship is already gone.</a:t>
             </a:r>
             <a:endParaRPr lang="en-US" sz="1100" dirty="0"/>
           </a:p>
@@ -33035,7 +33417,7 @@
                 <a:ea typeface="Calibri" pitchFamily="34" charset="-122"/>
                 <a:cs typeface="Calibri" pitchFamily="34" charset="-120"/>
               </a:rPr>
-              <a:t>No early warning system for at-risk customers/members</a:t>
+              <a:t>Direct deposit moves are the #1 churn signal — caught only after the fact</a:t>
             </a:r>
             <a:endParaRPr lang="en-US" sz="1050" dirty="0"/>
           </a:p>
@@ -33056,7 +33438,7 @@
                 <a:ea typeface="Calibri" pitchFamily="34" charset="-122"/>
                 <a:cs typeface="Calibri" pitchFamily="34" charset="-120"/>
               </a:rPr>
-              <a:t>Relationship managers lack behavioral risk scoring</a:t>
+              <a:t>ACH cadence breaks (frequency, amount, originator) go unmonitored</a:t>
             </a:r>
             <a:endParaRPr lang="en-US" sz="1050" dirty="0"/>
           </a:p>
@@ -33077,7 +33459,7 @@
                 <a:ea typeface="Calibri" pitchFamily="34" charset="-122"/>
                 <a:cs typeface="Calibri" pitchFamily="34" charset="-120"/>
               </a:rPr>
-              <a:t>Reactive outreach is expensive with low conversion</a:t>
+              <a:t>Relationship managers have no behavioral risk score to prioritize outreach</a:t>
             </a:r>
             <a:endParaRPr lang="en-US" sz="1050" dirty="0"/>
           </a:p>
@@ -33098,7 +33480,7 @@
                 <a:ea typeface="Calibri" pitchFamily="34" charset="-122"/>
                 <a:cs typeface="Calibri" pitchFamily="34" charset="-120"/>
               </a:rPr>
-              <a:t>High cost-to-retain vs. cost-to-acquire imbalance</a:t>
+              <a:t>Reactive retention is expensive — proactive saves cost a fraction</a:t>
             </a:r>
             <a:endParaRPr lang="en-US" sz="1050" dirty="0"/>
           </a:p>
@@ -33233,7 +33615,7 @@
                 <a:ea typeface="Calibri" pitchFamily="34" charset="-122"/>
                 <a:cs typeface="Calibri" pitchFamily="34" charset="-120"/>
               </a:rPr>
-              <a:t>A survival analysis + gradient boosted model (AutoGluon / CatBoost) embedded in the JH platform — scoring every customer and member weekly on churn probability using behavioral signals from transaction, login, product, and call data.</a:t>
+              <a:t>Churn Sentinel is a two-phase signal model built on JH's network data — Phase 1 launches on ACH payments signals (direct deposit monitoring, cadence anomalies, originator changes) and Phase 2 enriches with core banking and Banno digital signals as those pipelines come online. The model trains on JH's full FI network regardless of per-FI adoption.</a:t>
             </a:r>
             <a:endParaRPr lang="en-US" sz="1100" dirty="0"/>
           </a:p>
@@ -33315,7 +33697,7 @@
                 <a:ea typeface="Calibri" pitchFamily="34" charset="-122"/>
                 <a:cs typeface="Calibri" pitchFamily="34" charset="-120"/>
               </a:rPr>
-              <a:t>AutoGluon ensemble + CatBoost scoring pipeline</a:t>
+              <a:t>Phase 1 — ACH Sentinel: direct deposit cadence + originator change detection</a:t>
             </a:r>
             <a:endParaRPr lang="en-US" sz="1050" dirty="0"/>
           </a:p>
@@ -33336,7 +33718,7 @@
                 <a:ea typeface="Calibri" pitchFamily="34" charset="-122"/>
                 <a:cs typeface="Calibri" pitchFamily="34" charset="-120"/>
               </a:rPr>
-              <a:t>SHAP values for banker-facing explainability</a:t>
+              <a:t>Phase 2 — Core + Digital: balance trends, product thinning, Banno session signals</a:t>
             </a:r>
             <a:endParaRPr lang="en-US" sz="1050" dirty="0"/>
           </a:p>
@@ -33357,7 +33739,7 @@
                 <a:ea typeface="Calibri" pitchFamily="34" charset="-122"/>
                 <a:cs typeface="Calibri" pitchFamily="34" charset="-120"/>
               </a:rPr>
-              <a:t>Automated trigger → JH CRM / outreach workflows</a:t>
+              <a:t>CatBoost survival model · SHAP explainability for banker-facing scores</a:t>
             </a:r>
             <a:endParaRPr lang="en-US" sz="1050" dirty="0"/>
           </a:p>
@@ -33378,7 +33760,7 @@
                 <a:ea typeface="Calibri" pitchFamily="34" charset="-122"/>
                 <a:cs typeface="Calibri" pitchFamily="34" charset="-120"/>
               </a:rPr>
-              <a:t>Weekly model refresh with drift monitoring alerts</a:t>
+              <a:t>Weekly scores pushed to JH CRM → automated outreach workflow triggers</a:t>
             </a:r>
             <a:endParaRPr lang="en-US" sz="1050" dirty="0"/>
           </a:p>
@@ -33703,7 +34085,7 @@
                 <a:ea typeface="Calibri" pitchFamily="34" charset="-122"/>
                 <a:cs typeface="Calibri" pitchFamily="34" charset="-120"/>
               </a:rPr>
-              <a:t>Q1 FY27</a:t>
+              <a:t>Q3 FY26</a:t>
             </a:r>
             <a:endParaRPr lang="en-US" sz="3000" dirty="0"/>
           </a:p>
@@ -33742,7 +34124,7 @@
                 <a:ea typeface="Calibri" pitchFamily="34" charset="-122"/>
                 <a:cs typeface="Calibri" pitchFamily="34" charset="-120"/>
               </a:rPr>
-              <a:t>Target JH platform</a:t>
+              <a:t>Phase 1 ACH Sentinel</a:t>
             </a:r>
             <a:endParaRPr lang="en-US" sz="1050" dirty="0"/>
           </a:p>
@@ -33759,7 +34141,7 @@
                 <a:ea typeface="Calibri" pitchFamily="34" charset="-122"/>
                 <a:cs typeface="Calibri" pitchFamily="34" charset="-120"/>
               </a:rPr>
-              <a:t>delivery</a:t>
+              <a:t>target launch</a:t>
             </a:r>
             <a:endParaRPr lang="en-US" sz="1050" dirty="0"/>
           </a:p>

</xml_diff>

<commit_message>
Add revenue model slides and Excel financial model
- Add Path to $1M ARR slide: stacked bar chart (8 quarters, 5 apps), $1M
  dashed milestone line, Q4 FY27 callout box with ~81 FIs / 4.9% penetration stats
- Add DS App Pricing slide: per-app annual pricing by 4 asset tiers, launch
  timeline, blended price assumptions footer
- Add JHBI_Revenue_Model.xlsx: 3-sheet bottoms-up model (Assumptions,
  Revenue Model, Summary); 208 formulas, zero errors; crosses $1M ARR Q4 FY27
- Add build_jhbi_revenue.py: openpyxl script for the Excel model
- Full presenter notes on both revenue slides for JHBI leadership pitch

Co-Authored-By: Claude Sonnet 4.6 <noreply@anthropic.com>
</commit_message>
<xml_diff>
--- a/JH_DS_Strategy_JHBI.pptx
+++ b/JH_DS_Strategy_JHBI.pptx
@@ -29,9 +29,11 @@
     <p:sldId id="277" r:id="rId23"/>
     <p:sldId id="278" r:id="rId24"/>
     <p:sldId id="279" r:id="rId25"/>
+    <p:sldId id="280" r:id="rId26"/>
+    <p:sldId id="281" r:id="rId27"/>
   </p:sldIdLst>
   <p:notesMasterIdLst>
-    <p:notesMasterId r:id="rId26"/>
+    <p:notesMasterId r:id="rId28"/>
   </p:notesMasterIdLst>
   <p:sldSz cx="9144000" cy="5143500"/>
   <p:notesSz cx="5143500" cy="9144000"/>
@@ -128,6 +130,746 @@
     </a:lvl9pPr>
   </p:defaultTextStyle>
 </p:presentation>
+</file>
+
+<file path=ppt/charts/chart1.xml><?xml version="1.0" encoding="utf-8"?>
+<c:chartSpace xmlns:c="http://schemas.openxmlformats.org/drawingml/2006/chart" xmlns:a="http://schemas.openxmlformats.org/drawingml/2006/main" xmlns:r="http://schemas.openxmlformats.org/officeDocument/2006/relationships">
+  <c:date1904 val="0"/>
+  <c:roundedCorners val="1"/>
+  <c:chart>
+    <c:autoTitleDeleted val="1"/>
+    <c:plotArea>
+      <c:layout/>
+      <c:barChart>
+        <c:barDir val="col"/>
+        <c:grouping val="stacked"/>
+        <c:varyColors val="0"/>
+        <c:ser>
+          <c:idx val="0"/>
+          <c:order val="0"/>
+          <c:tx>
+            <c:strRef>
+              <c:f>Sheet1!$B$1</c:f>
+              <c:strCache>
+                <c:ptCount val="1"/>
+                <c:pt idx="0">
+                  <c:v>Zelle Memo Intelligence</c:v>
+                </c:pt>
+              </c:strCache>
+            </c:strRef>
+          </c:tx>
+          <c:spPr>
+            <a:solidFill>
+              <a:srgbClr val="085CE5"/>
+            </a:solidFill>
+            <a:effectLst/>
+          </c:spPr>
+          <c:invertIfNegative val="0"/>
+          <c:dLbls>
+            <c:numFmt formatCode="#,##0" sourceLinked="0"/>
+            <c:txPr>
+              <a:bodyPr/>
+              <a:lstStyle/>
+              <a:p>
+                <a:pPr>
+                  <a:defRPr b="0" i="0" strike="noStrike" sz="1200" u="none">
+                    <a:solidFill>
+                      <a:srgbClr val="000000"/>
+                    </a:solidFill>
+                    <a:latin typeface="Arial"/>
+                  </a:defRPr>
+                </a:pPr>
+              </a:p>
+            </c:txPr>
+            <c:showLegendKey val="0"/>
+            <c:showVal val="0"/>
+            <c:showCatName val="0"/>
+            <c:showSerName val="0"/>
+            <c:showPercent val="0"/>
+            <c:showBubbleSize val="0"/>
+            <c:showLeaderLines val="0"/>
+          </c:dLbls>
+          <c:cat>
+            <c:multiLvlStrRef>
+              <c:f>Sheet1!$A$2:$A$9</c:f>
+              <c:multiLvlStrCache>
+                <c:ptCount val="8"/>
+                <c:lvl>
+                  <c:pt idx="0">
+                    <c:v>Q3 FY26</c:v>
+                  </c:pt>
+                  <c:pt idx="1">
+                    <c:v>Q4 FY26</c:v>
+                  </c:pt>
+                  <c:pt idx="2">
+                    <c:v>Q1 FY27</c:v>
+                  </c:pt>
+                  <c:pt idx="3">
+                    <c:v>Q2 FY27</c:v>
+                  </c:pt>
+                  <c:pt idx="4">
+                    <c:v>Q3 FY27</c:v>
+                  </c:pt>
+                  <c:pt idx="5">
+                    <c:v>Q4 FY27 ★</c:v>
+                  </c:pt>
+                  <c:pt idx="6">
+                    <c:v>Q1 FY28</c:v>
+                  </c:pt>
+                  <c:pt idx="7">
+                    <c:v>Q2 FY28</c:v>
+                  </c:pt>
+                </c:lvl>
+              </c:multiLvlStrCache>
+            </c:multiLvlStrRef>
+          </c:cat>
+          <c:val>
+            <c:numRef>
+              <c:f>Sheet1!$B$2:$B$9</c:f>
+              <c:numCache>
+                <c:formatCode>General</c:formatCode>
+                <c:ptCount val="8"/>
+                <c:pt idx="0">
+                  <c:v>0</c:v>
+                </c:pt>
+                <c:pt idx="1">
+                  <c:v>0</c:v>
+                </c:pt>
+                <c:pt idx="2">
+                  <c:v>116.4</c:v>
+                </c:pt>
+                <c:pt idx="3">
+                  <c:v>203.7</c:v>
+                </c:pt>
+                <c:pt idx="4">
+                  <c:v>281.3</c:v>
+                </c:pt>
+                <c:pt idx="5">
+                  <c:v>329.8</c:v>
+                </c:pt>
+                <c:pt idx="6">
+                  <c:v>368.6</c:v>
+                </c:pt>
+                <c:pt idx="7">
+                  <c:v>397.7</c:v>
+                </c:pt>
+              </c:numCache>
+            </c:numRef>
+          </c:val>
+        </c:ser>
+        <c:ser>
+          <c:idx val="1"/>
+          <c:order val="1"/>
+          <c:tx>
+            <c:strRef>
+              <c:f>Sheet1!$C$1</c:f>
+              <c:strCache>
+                <c:ptCount val="1"/>
+                <c:pt idx="0">
+                  <c:v>Churn Sentinel</c:v>
+                </c:pt>
+              </c:strCache>
+            </c:strRef>
+          </c:tx>
+          <c:spPr>
+            <a:solidFill>
+              <a:srgbClr val="06185F"/>
+            </a:solidFill>
+            <a:effectLst/>
+          </c:spPr>
+          <c:invertIfNegative val="0"/>
+          <c:dLbls>
+            <c:numFmt formatCode="#,##0" sourceLinked="0"/>
+            <c:txPr>
+              <a:bodyPr/>
+              <a:lstStyle/>
+              <a:p>
+                <a:pPr>
+                  <a:defRPr b="0" i="0" strike="noStrike" sz="1200" u="none">
+                    <a:solidFill>
+                      <a:srgbClr val="000000"/>
+                    </a:solidFill>
+                    <a:latin typeface="Arial"/>
+                  </a:defRPr>
+                </a:pPr>
+              </a:p>
+            </c:txPr>
+            <c:showLegendKey val="0"/>
+            <c:showVal val="0"/>
+            <c:showCatName val="0"/>
+            <c:showSerName val="0"/>
+            <c:showPercent val="0"/>
+            <c:showBubbleSize val="0"/>
+            <c:showLeaderLines val="0"/>
+          </c:dLbls>
+          <c:cat>
+            <c:multiLvlStrRef>
+              <c:f>Sheet1!$A$2:$A$9</c:f>
+              <c:multiLvlStrCache>
+                <c:ptCount val="8"/>
+                <c:lvl>
+                  <c:pt idx="0">
+                    <c:v>Q3 FY26</c:v>
+                  </c:pt>
+                  <c:pt idx="1">
+                    <c:v>Q4 FY26</c:v>
+                  </c:pt>
+                  <c:pt idx="2">
+                    <c:v>Q1 FY27</c:v>
+                  </c:pt>
+                  <c:pt idx="3">
+                    <c:v>Q2 FY27</c:v>
+                  </c:pt>
+                  <c:pt idx="4">
+                    <c:v>Q3 FY27</c:v>
+                  </c:pt>
+                  <c:pt idx="5">
+                    <c:v>Q4 FY27 ★</c:v>
+                  </c:pt>
+                  <c:pt idx="6">
+                    <c:v>Q1 FY28</c:v>
+                  </c:pt>
+                  <c:pt idx="7">
+                    <c:v>Q2 FY28</c:v>
+                  </c:pt>
+                </c:lvl>
+              </c:multiLvlStrCache>
+            </c:multiLvlStrRef>
+          </c:cat>
+          <c:val>
+            <c:numRef>
+              <c:f>Sheet1!$C$2:$C$9</c:f>
+              <c:numCache>
+                <c:formatCode>General</c:formatCode>
+                <c:ptCount val="8"/>
+                <c:pt idx="0">
+                  <c:v>0</c:v>
+                </c:pt>
+                <c:pt idx="1">
+                  <c:v>0</c:v>
+                </c:pt>
+                <c:pt idx="2">
+                  <c:v>0</c:v>
+                </c:pt>
+                <c:pt idx="3">
+                  <c:v>205.5</c:v>
+                </c:pt>
+                <c:pt idx="4">
+                  <c:v>369.9</c:v>
+                </c:pt>
+                <c:pt idx="5">
+                  <c:v>506.9</c:v>
+                </c:pt>
+                <c:pt idx="6">
+                  <c:v>602.8</c:v>
+                </c:pt>
+                <c:pt idx="7">
+                  <c:v>657.6</c:v>
+                </c:pt>
+              </c:numCache>
+            </c:numRef>
+          </c:val>
+        </c:ser>
+        <c:ser>
+          <c:idx val="2"/>
+          <c:order val="2"/>
+          <c:tx>
+            <c:strRef>
+              <c:f>Sheet1!$D$1</c:f>
+              <c:strCache>
+                <c:ptCount val="1"/>
+                <c:pt idx="0">
+                  <c:v>CommercialSignal</c:v>
+                </c:pt>
+              </c:strCache>
+            </c:strRef>
+          </c:tx>
+          <c:spPr>
+            <a:solidFill>
+              <a:srgbClr val="0A52C4"/>
+            </a:solidFill>
+            <a:effectLst/>
+          </c:spPr>
+          <c:invertIfNegative val="0"/>
+          <c:dLbls>
+            <c:numFmt formatCode="#,##0" sourceLinked="0"/>
+            <c:txPr>
+              <a:bodyPr/>
+              <a:lstStyle/>
+              <a:p>
+                <a:pPr>
+                  <a:defRPr b="0" i="0" strike="noStrike" sz="1200" u="none">
+                    <a:solidFill>
+                      <a:srgbClr val="000000"/>
+                    </a:solidFill>
+                    <a:latin typeface="Arial"/>
+                  </a:defRPr>
+                </a:pPr>
+              </a:p>
+            </c:txPr>
+            <c:showLegendKey val="0"/>
+            <c:showVal val="0"/>
+            <c:showCatName val="0"/>
+            <c:showSerName val="0"/>
+            <c:showPercent val="0"/>
+            <c:showBubbleSize val="0"/>
+            <c:showLeaderLines val="0"/>
+          </c:dLbls>
+          <c:cat>
+            <c:multiLvlStrRef>
+              <c:f>Sheet1!$A$2:$A$9</c:f>
+              <c:multiLvlStrCache>
+                <c:ptCount val="8"/>
+                <c:lvl>
+                  <c:pt idx="0">
+                    <c:v>Q3 FY26</c:v>
+                  </c:pt>
+                  <c:pt idx="1">
+                    <c:v>Q4 FY26</c:v>
+                  </c:pt>
+                  <c:pt idx="2">
+                    <c:v>Q1 FY27</c:v>
+                  </c:pt>
+                  <c:pt idx="3">
+                    <c:v>Q2 FY27</c:v>
+                  </c:pt>
+                  <c:pt idx="4">
+                    <c:v>Q3 FY27</c:v>
+                  </c:pt>
+                  <c:pt idx="5">
+                    <c:v>Q4 FY27 ★</c:v>
+                  </c:pt>
+                  <c:pt idx="6">
+                    <c:v>Q1 FY28</c:v>
+                  </c:pt>
+                  <c:pt idx="7">
+                    <c:v>Q2 FY28</c:v>
+                  </c:pt>
+                </c:lvl>
+              </c:multiLvlStrCache>
+            </c:multiLvlStrRef>
+          </c:cat>
+          <c:val>
+            <c:numRef>
+              <c:f>Sheet1!$D$2:$D$9</c:f>
+              <c:numCache>
+                <c:formatCode>General</c:formatCode>
+                <c:ptCount val="8"/>
+                <c:pt idx="0">
+                  <c:v>0</c:v>
+                </c:pt>
+                <c:pt idx="1">
+                  <c:v>0</c:v>
+                </c:pt>
+                <c:pt idx="2">
+                  <c:v>0</c:v>
+                </c:pt>
+                <c:pt idx="3">
+                  <c:v>0</c:v>
+                </c:pt>
+                <c:pt idx="4">
+                  <c:v>111</c:v>
+                </c:pt>
+                <c:pt idx="5">
+                  <c:v>199.8</c:v>
+                </c:pt>
+                <c:pt idx="6">
+                  <c:v>266.4</c:v>
+                </c:pt>
+                <c:pt idx="7">
+                  <c:v>321.9</c:v>
+                </c:pt>
+              </c:numCache>
+            </c:numRef>
+          </c:val>
+        </c:ser>
+        <c:ser>
+          <c:idx val="3"/>
+          <c:order val="3"/>
+          <c:tx>
+            <c:strRef>
+              <c:f>Sheet1!$E$1</c:f>
+              <c:strCache>
+                <c:ptCount val="1"/>
+                <c:pt idx="0">
+                  <c:v>Gen. Wealth Deflection</c:v>
+                </c:pt>
+              </c:strCache>
+            </c:strRef>
+          </c:tx>
+          <c:spPr>
+            <a:solidFill>
+              <a:srgbClr val="0F3D8A"/>
+            </a:solidFill>
+            <a:effectLst/>
+          </c:spPr>
+          <c:invertIfNegative val="0"/>
+          <c:dLbls>
+            <c:numFmt formatCode="#,##0" sourceLinked="0"/>
+            <c:txPr>
+              <a:bodyPr/>
+              <a:lstStyle/>
+              <a:p>
+                <a:pPr>
+                  <a:defRPr b="0" i="0" strike="noStrike" sz="1200" u="none">
+                    <a:solidFill>
+                      <a:srgbClr val="000000"/>
+                    </a:solidFill>
+                    <a:latin typeface="Arial"/>
+                  </a:defRPr>
+                </a:pPr>
+              </a:p>
+            </c:txPr>
+            <c:showLegendKey val="0"/>
+            <c:showVal val="0"/>
+            <c:showCatName val="0"/>
+            <c:showSerName val="0"/>
+            <c:showPercent val="0"/>
+            <c:showBubbleSize val="0"/>
+            <c:showLeaderLines val="0"/>
+          </c:dLbls>
+          <c:cat>
+            <c:multiLvlStrRef>
+              <c:f>Sheet1!$A$2:$A$9</c:f>
+              <c:multiLvlStrCache>
+                <c:ptCount val="8"/>
+                <c:lvl>
+                  <c:pt idx="0">
+                    <c:v>Q3 FY26</c:v>
+                  </c:pt>
+                  <c:pt idx="1">
+                    <c:v>Q4 FY26</c:v>
+                  </c:pt>
+                  <c:pt idx="2">
+                    <c:v>Q1 FY27</c:v>
+                  </c:pt>
+                  <c:pt idx="3">
+                    <c:v>Q2 FY27</c:v>
+                  </c:pt>
+                  <c:pt idx="4">
+                    <c:v>Q3 FY27</c:v>
+                  </c:pt>
+                  <c:pt idx="5">
+                    <c:v>Q4 FY27 ★</c:v>
+                  </c:pt>
+                  <c:pt idx="6">
+                    <c:v>Q1 FY28</c:v>
+                  </c:pt>
+                  <c:pt idx="7">
+                    <c:v>Q2 FY28</c:v>
+                  </c:pt>
+                </c:lvl>
+              </c:multiLvlStrCache>
+            </c:multiLvlStrRef>
+          </c:cat>
+          <c:val>
+            <c:numRef>
+              <c:f>Sheet1!$E$2:$E$9</c:f>
+              <c:numCache>
+                <c:formatCode>General</c:formatCode>
+                <c:ptCount val="8"/>
+                <c:pt idx="0">
+                  <c:v>0</c:v>
+                </c:pt>
+                <c:pt idx="1">
+                  <c:v>0</c:v>
+                </c:pt>
+                <c:pt idx="2">
+                  <c:v>0</c:v>
+                </c:pt>
+                <c:pt idx="3">
+                  <c:v>0</c:v>
+                </c:pt>
+                <c:pt idx="4">
+                  <c:v>0</c:v>
+                </c:pt>
+                <c:pt idx="5">
+                  <c:v>0</c:v>
+                </c:pt>
+                <c:pt idx="6">
+                  <c:v>95.2</c:v>
+                </c:pt>
+                <c:pt idx="7">
+                  <c:v>163.2</c:v>
+                </c:pt>
+              </c:numCache>
+            </c:numRef>
+          </c:val>
+        </c:ser>
+        <c:ser>
+          <c:idx val="4"/>
+          <c:order val="4"/>
+          <c:tx>
+            <c:strRef>
+              <c:f>Sheet1!$F$1</c:f>
+              <c:strCache>
+                <c:ptCount val="1"/>
+                <c:pt idx="0">
+                  <c:v>Anomaly Detection</c:v>
+                </c:pt>
+              </c:strCache>
+            </c:strRef>
+          </c:tx>
+          <c:spPr>
+            <a:solidFill>
+              <a:srgbClr val="575A5D"/>
+            </a:solidFill>
+            <a:effectLst/>
+          </c:spPr>
+          <c:invertIfNegative val="0"/>
+          <c:dLbls>
+            <c:numFmt formatCode="#,##0" sourceLinked="0"/>
+            <c:txPr>
+              <a:bodyPr/>
+              <a:lstStyle/>
+              <a:p>
+                <a:pPr>
+                  <a:defRPr b="0" i="0" strike="noStrike" sz="1200" u="none">
+                    <a:solidFill>
+                      <a:srgbClr val="000000"/>
+                    </a:solidFill>
+                    <a:latin typeface="Arial"/>
+                  </a:defRPr>
+                </a:pPr>
+              </a:p>
+            </c:txPr>
+            <c:showLegendKey val="0"/>
+            <c:showVal val="0"/>
+            <c:showCatName val="0"/>
+            <c:showSerName val="0"/>
+            <c:showPercent val="0"/>
+            <c:showBubbleSize val="0"/>
+            <c:showLeaderLines val="0"/>
+          </c:dLbls>
+          <c:cat>
+            <c:multiLvlStrRef>
+              <c:f>Sheet1!$A$2:$A$9</c:f>
+              <c:multiLvlStrCache>
+                <c:ptCount val="8"/>
+                <c:lvl>
+                  <c:pt idx="0">
+                    <c:v>Q3 FY26</c:v>
+                  </c:pt>
+                  <c:pt idx="1">
+                    <c:v>Q4 FY26</c:v>
+                  </c:pt>
+                  <c:pt idx="2">
+                    <c:v>Q1 FY27</c:v>
+                  </c:pt>
+                  <c:pt idx="3">
+                    <c:v>Q2 FY27</c:v>
+                  </c:pt>
+                  <c:pt idx="4">
+                    <c:v>Q3 FY27</c:v>
+                  </c:pt>
+                  <c:pt idx="5">
+                    <c:v>Q4 FY27 ★</c:v>
+                  </c:pt>
+                  <c:pt idx="6">
+                    <c:v>Q1 FY28</c:v>
+                  </c:pt>
+                  <c:pt idx="7">
+                    <c:v>Q2 FY28</c:v>
+                  </c:pt>
+                </c:lvl>
+              </c:multiLvlStrCache>
+            </c:multiLvlStrRef>
+          </c:cat>
+          <c:val>
+            <c:numRef>
+              <c:f>Sheet1!$F$2:$F$9</c:f>
+              <c:numCache>
+                <c:formatCode>General</c:formatCode>
+                <c:ptCount val="8"/>
+                <c:pt idx="0">
+                  <c:v>0</c:v>
+                </c:pt>
+                <c:pt idx="1">
+                  <c:v>0</c:v>
+                </c:pt>
+                <c:pt idx="2">
+                  <c:v>0</c:v>
+                </c:pt>
+                <c:pt idx="3">
+                  <c:v>0</c:v>
+                </c:pt>
+                <c:pt idx="4">
+                  <c:v>0</c:v>
+                </c:pt>
+                <c:pt idx="5">
+                  <c:v>0</c:v>
+                </c:pt>
+                <c:pt idx="6">
+                  <c:v>0</c:v>
+                </c:pt>
+                <c:pt idx="7">
+                  <c:v>117.6</c:v>
+                </c:pt>
+              </c:numCache>
+            </c:numRef>
+          </c:val>
+        </c:ser>
+        <c:dLbls>
+          <c:numFmt formatCode="#,##0" sourceLinked="0"/>
+          <c:txPr>
+            <a:bodyPr/>
+            <a:lstStyle/>
+            <a:p>
+              <a:pPr>
+                <a:defRPr b="0" i="0" strike="noStrike" sz="1200" u="none">
+                  <a:solidFill>
+                    <a:srgbClr val="000000"/>
+                  </a:solidFill>
+                  <a:latin typeface="Arial"/>
+                </a:defRPr>
+              </a:pPr>
+            </a:p>
+          </c:txPr>
+          <c:showLegendKey val="0"/>
+          <c:showVal val="0"/>
+          <c:showCatName val="0"/>
+          <c:showSerName val="0"/>
+          <c:showPercent val="0"/>
+          <c:showBubbleSize val="0"/>
+          <c:showLeaderLines val="0"/>
+        </c:dLbls>
+        <c:gapWidth val="50"/>
+        <c:overlap val="100"/>
+        <c:axId val="2094734554"/>
+        <c:axId val="2094734552"/>
+        <c:axId val="2094734556"/>
+      </c:barChart>
+      <c:catAx>
+        <c:axId val="2094734554"/>
+        <c:scaling>
+          <c:orientation val="minMax"/>
+        </c:scaling>
+        <c:delete val="0"/>
+        <c:axPos val="b"/>
+        <c:numFmt formatCode="General" sourceLinked="1"/>
+        <c:majorTickMark val="out"/>
+        <c:minorTickMark val="none"/>
+        <c:tickLblPos val="low"/>
+        <c:spPr>
+          <a:ln w="12700" cap="flat">
+            <a:solidFill>
+              <a:srgbClr val="888888"/>
+            </a:solidFill>
+            <a:prstDash val="solid"/>
+            <a:round/>
+          </a:ln>
+        </c:spPr>
+        <c:txPr>
+          <a:bodyPr/>
+          <a:lstStyle/>
+          <a:p>
+            <a:pPr>
+              <a:defRPr sz="900" b="0" i="0" u="none" strike="noStrike">
+                <a:solidFill>
+                  <a:srgbClr val="575A5D"/>
+                </a:solidFill>
+                <a:latin typeface="Arial"/>
+              </a:defRPr>
+            </a:pPr>
+            <a:endParaRPr lang="en-US"/>
+          </a:p>
+        </c:txPr>
+        <c:crossAx val="2094734552"/>
+        <c:crosses val="autoZero"/>
+        <c:auto val="1"/>
+        <c:lblAlgn val="ctr"/>
+        <c:noMultiLvlLbl val="1"/>
+      </c:catAx>
+      <c:valAx>
+        <c:axId val="2094734552"/>
+        <c:scaling>
+          <c:orientation val="minMax"/>
+          <c:max val="1800"/>
+        </c:scaling>
+        <c:delete val="0"/>
+        <c:axPos val="l"/>
+        <c:majorGridlines>
+          <c:spPr>
+            <a:ln w="12700" cap="flat">
+              <a:solidFill>
+                <a:srgbClr val="888888"/>
+              </a:solidFill>
+              <a:prstDash val="solid"/>
+              <a:round/>
+            </a:ln>
+          </c:spPr>
+        </c:majorGridlines>
+        <c:numFmt formatCode="General" sourceLinked="0"/>
+        <c:majorTickMark val="out"/>
+        <c:minorTickMark val="none"/>
+        <c:tickLblPos val="nextTo"/>
+        <c:spPr>
+          <a:ln w="12700" cap="flat">
+            <a:solidFill>
+              <a:srgbClr val="888888"/>
+            </a:solidFill>
+            <a:prstDash val="solid"/>
+            <a:round/>
+          </a:ln>
+        </c:spPr>
+        <c:txPr>
+          <a:bodyPr/>
+          <a:lstStyle/>
+          <a:p>
+            <a:pPr>
+              <a:defRPr sz="900" b="0" i="0" u="none" strike="noStrike">
+                <a:solidFill>
+                  <a:srgbClr val="575A5D"/>
+                </a:solidFill>
+                <a:latin typeface="Arial"/>
+              </a:defRPr>
+            </a:pPr>
+            <a:endParaRPr lang="en-US"/>
+          </a:p>
+        </c:txPr>
+        <c:crossAx val="2094734554"/>
+        <c:crosses val="autoZero"/>
+        <c:crossBetween val="between"/>
+      </c:valAx>
+      <c:spPr>
+        <a:noFill/>
+        <a:ln>
+          <a:noFill/>
+        </a:ln>
+        <a:effectLst/>
+      </c:spPr>
+    </c:plotArea>
+    <c:legend>
+      <c:legendPos val="b"/>
+      <c:overlay val="0"/>
+      <c:txPr>
+        <a:bodyPr/>
+        <a:lstStyle/>
+        <a:p>
+          <a:pPr>
+            <a:defRPr sz="800">
+              <a:latin typeface="Calibri"/>
+              <a:cs typeface="Calibri"/>
+            </a:defRPr>
+          </a:pPr>
+          <a:endParaRPr lang="en-US"/>
+        </a:p>
+      </c:txPr>
+    </c:legend>
+    <c:plotVisOnly val="1"/>
+    <c:dispBlanksAs val="span"/>
+  </c:chart>
+  <c:spPr>
+    <a:noFill/>
+    <a:ln>
+      <a:noFill/>
+    </a:ln>
+    <a:effectLst/>
+  </c:spPr>
+  <c:externalData r:id="rId1">
+    <c:autoUpdate val="0"/>
+  </c:externalData>
+</c:chartSpace>
 </file>
 
 <file path=ppt/notesMasters/notesMaster1.xml><?xml version="1.0" encoding="utf-8"?>
@@ -1933,7 +2675,30 @@
           <a:p>
             <a:r>
               <a:rPr lang="en-US" dirty="0"/>
-              <a:t/>
+              <a:t>PATH TO $1M ARR — Presenter Talking Points
+OPENING FRAME (30 seconds):
+"This slide answers the question we always get from leadership: what's the return? The answer is $1M in ARR by Q4 FY27 — that's April through June of next year — driven by just three apps and less than five percent penetration of our existing FI base."
+THE MODEL STRUCTURE:
+• This is not a top-down market-sizing exercise. It's a bottoms-up, account-by-account model built on JH's actual 1,660 contracted FIs.
+• We segmented those FIs by asset tier and CU/bank split (44% CU / 56% bank). CUs get a 12% pricing accommodation for cooperative budget structures.
+• Each app has a blended average price — weighted across tiers — that we used to project ARR as FIs onboard quarterly.
+• We applied an 8% annual subscription churn rate (2% per quarter) to model attrition realistically.
+THE RAMP (walk the chart left to right):
+• Q3–Q4 FY26: Build quarters — no revenue. The team is building Churn Sentinel ACH pipeline.
+• Q1 FY27: Zelle Memo Intelligence launches. 12 FIs in first quarter → $116K ARR. Zelle-enabled FIs only (~580 addressable).
+• Q2 FY27: Churn Sentinel launches. 15 new FIs added. Total ARR crosses $400K.
+• Q3 FY27: CommercialSignal adds to the stack. Three apps running simultaneously → $762K.
+• Q4 FY27 ★: The milestone quarter. $1.04M ARR. Three apps, ~81 active subscribers.
+• Q1–Q2 FY28: Gen. Wealth Deflection and Anomaly Detection come online. Trajectory toward $1.7M.
+WHAT MAKES THIS CREDIBLE:
+• 4.9% penetration of our own customer base is extremely achievable — we already have the relationships, the contracts, and the data pipelines. This is not cold outreach. These are existing JHBI clients we upsell.
+• Churn Sentinel has the broadest addressability (all 1,660 FIs), which is why it becomes the largest revenue line by Q2 FY28.
+• The model is conservative: no bundle pricing, no cross-sell acceleration, no partner channel.
+KEY RISK AND MITIGATION:
+• Biggest risk is sales cycle length — community FIs can have 6-12 month procurement cycles. Mitigation: build the pilot program (3–5 anchor FIs) into the Phase 1 plan to generate reference customers quickly.
+• "What if we miss the 12-FI launch target for Zelle Memo?" — model holds above $700K in Q3 FY27 even if launch numbers are 30% lower.
+CLOSE:
+"The Excel model behind this is available for review. Every assumption is documented, all formulas are live, and we built it so leadership can stress-test any variable — penetration rate, pricing, churn. The path to $1M is conservative and achievable within our existing FI base without adding a single new JH customer."</a:t>
             </a:r>
             <a:endParaRPr lang="en-US" dirty="0"/>
           </a:p>
@@ -1957,6 +2722,201 @@
             <a:fld id="{F7021451-1387-4CA6-816F-3879F97B5CBC}" type="slidenum">
               <a:rPr lang="en-US"/>
               <a:t>24</a:t>
+            </a:fld>
+            <a:endParaRPr lang="en-US"/>
+          </a:p>
+        </p:txBody>
+      </p:sp>
+    </p:spTree>
+    <p:extLst>
+      <p:ext uri="{BB962C8B-B14F-4D97-AF65-F5344CB8AC3E}">
+        <p14:creationId xmlns:p14="http://schemas.microsoft.com/office/powerpoint/2010/main" val="1024086991"/>
+      </p:ext>
+    </p:extLst>
+  </p:cSld>
+  <p:clrMapOvr>
+    <a:masterClrMapping/>
+  </p:clrMapOvr>
+</p:notes>
+</file>
+
+<file path=ppt/notesSlides/notesSlide25.xml><?xml version="1.0" encoding="utf-8"?>
+<p:notes xmlns:a="http://schemas.openxmlformats.org/drawingml/2006/main" xmlns:r="http://schemas.openxmlformats.org/officeDocument/2006/relationships" xmlns:p="http://schemas.openxmlformats.org/presentationml/2006/main">
+  <p:cSld>
+    <p:spTree>
+      <p:nvGrpSpPr>
+        <p:cNvPr id="1" name=""/>
+        <p:cNvGrpSpPr/>
+        <p:nvPr/>
+      </p:nvGrpSpPr>
+      <p:grpSpPr>
+        <a:xfrm>
+          <a:off x="0" y="0"/>
+          <a:ext cx="0" cy="0"/>
+          <a:chOff x="0" y="0"/>
+          <a:chExt cx="0" cy="0"/>
+        </a:xfrm>
+      </p:grpSpPr>
+      <p:sp>
+        <p:nvSpPr>
+          <p:cNvPr id="2" name="Slide Image Placeholder 1"/>
+          <p:cNvSpPr>
+            <a:spLocks noGrp="1" noRot="1" noChangeAspect="1"/>
+          </p:cNvSpPr>
+          <p:nvPr>
+            <p:ph type="sldImg"/>
+          </p:nvPr>
+        </p:nvSpPr>
+        <p:spPr/>
+      </p:sp>
+      <p:sp>
+        <p:nvSpPr>
+          <p:cNvPr id="3" name="Notes Placeholder 2"/>
+          <p:cNvSpPr>
+            <a:spLocks noGrp="1"/>
+          </p:cNvSpPr>
+          <p:nvPr>
+            <p:ph type="body" idx="1"/>
+          </p:nvPr>
+        </p:nvSpPr>
+        <p:spPr/>
+        <p:txBody>
+          <a:bodyPr/>
+          <a:lstStyle/>
+          <a:p>
+            <a:r>
+              <a:rPr lang="en-US" dirty="0"/>
+              <a:t>DS APP PRICING — Presenter Talking Points
+FRAMING (15 seconds):
+"These are annual add-on subscriptions priced on top of the JHBI platform fee. We're not replacing JHBI revenue — we're extending it. Every existing JHBI client is a potential buyer. No new sales motion required, just a product upsell."
+THE PRICING RATIONALE:
+• Pricing scales with institution size — smaller FIs (&lt;$250M) pay entry-level rates; larger FIs ($5B+) pay rates commensurate with the value at scale (a 5B+ bank protecting even 0.5% churn = multi-million dollar impact).
+• The blended average prices used in the revenue model account for our 44/56 CU/bank mix and the 12% cooperative discount for CUs.
+• Why a 12% CU discount? Credit unions run on NCUA-regulated capital ratios and cooperative surplus rules — budget flexibility is genuinely lower. A modest discount maintains the relationship without giving away margin; we're still above SAAS rule-of-thumb economics.
+TIER POSITIONING:
+• &lt;$250M tier: Entry point. $5–9K is a rounding error relative to the potential churn or fraud loss at this asset size. Easy approval cycle.
+• $250M–$1B tier: Core community bank/CU market — most of our base sits here. $8–14K annually is a 1–2 month subscriptions to a junior analyst. Model ROI is obvious.
+• $1B–$5B: Larger regional. $15–24K. These FIs often have internal analytics teams; our angle is "complement your team with JH network intelligence you can't build yourself."
+• $5B+: Strategic accounts. $25–40K. Require more complex sales cycle but anchor client wins drive brand credibility. Prioritize 1–2 pilot partners here early.
+LAUNCH SEQUENCING (connect back to the roadmap):
+• Zelle Memo launches first (Q1 FY27) because the payments pipeline is being built anyway — it's the lowest incremental lift.
+• Churn Sentinel follows in Q2 FY27 and has the broadest addressability — all 1,660 FIs, no Zelle dependency.
+• CommercialSignal Q3 FY27, Gen. Wealth and Anomaly Detection in FY28 as the model suite matures.
+ON BUNDLING:
+"We're not offering bundles at launch — we want clean per-app economics to understand what the market actually values. Once we have 4–5 apps live and 50+ FI subscribers, bundling becomes a natural conversation to drive expansion revenue. That option is built into the model as a future lever."
+ANTICIPATED QUESTION: "Why not price per-account or per-user?"
+Answer: Per-FI annual subscription is the dominant SaaS model in fintech B2B. It's predictable, easy for FI budget owners to approve (single line item), and doesn't require us to instrument usage metering in Year 1. We can layer consumption pricing in Year 2 once instrumentation is in place.</a:t>
+            </a:r>
+            <a:endParaRPr lang="en-US" dirty="0"/>
+          </a:p>
+        </p:txBody>
+      </p:sp>
+      <p:sp>
+        <p:nvSpPr>
+          <p:cNvPr id="4" name="Slide Number Placeholder 3"/>
+          <p:cNvSpPr>
+            <a:spLocks noGrp="1"/>
+          </p:cNvSpPr>
+          <p:nvPr>
+            <p:ph type="sldNum" sz="quarter" idx="10"/>
+          </p:nvPr>
+        </p:nvSpPr>
+        <p:spPr/>
+        <p:txBody>
+          <a:bodyPr/>
+          <a:lstStyle/>
+          <a:p>
+            <a:fld id="{F7021451-1387-4CA6-816F-3879F97B5CBC}" type="slidenum">
+              <a:rPr lang="en-US"/>
+              <a:t>25</a:t>
+            </a:fld>
+            <a:endParaRPr lang="en-US"/>
+          </a:p>
+        </p:txBody>
+      </p:sp>
+    </p:spTree>
+    <p:extLst>
+      <p:ext uri="{BB962C8B-B14F-4D97-AF65-F5344CB8AC3E}">
+        <p14:creationId xmlns:p14="http://schemas.microsoft.com/office/powerpoint/2010/main" val="1024086991"/>
+      </p:ext>
+    </p:extLst>
+  </p:cSld>
+  <p:clrMapOvr>
+    <a:masterClrMapping/>
+  </p:clrMapOvr>
+</p:notes>
+</file>
+
+<file path=ppt/notesSlides/notesSlide26.xml><?xml version="1.0" encoding="utf-8"?>
+<p:notes xmlns:a="http://schemas.openxmlformats.org/drawingml/2006/main" xmlns:r="http://schemas.openxmlformats.org/officeDocument/2006/relationships" xmlns:p="http://schemas.openxmlformats.org/presentationml/2006/main">
+  <p:cSld>
+    <p:spTree>
+      <p:nvGrpSpPr>
+        <p:cNvPr id="1" name=""/>
+        <p:cNvGrpSpPr/>
+        <p:nvPr/>
+      </p:nvGrpSpPr>
+      <p:grpSpPr>
+        <a:xfrm>
+          <a:off x="0" y="0"/>
+          <a:ext cx="0" cy="0"/>
+          <a:chOff x="0" y="0"/>
+          <a:chExt cx="0" cy="0"/>
+        </a:xfrm>
+      </p:grpSpPr>
+      <p:sp>
+        <p:nvSpPr>
+          <p:cNvPr id="2" name="Slide Image Placeholder 1"/>
+          <p:cNvSpPr>
+            <a:spLocks noGrp="1" noRot="1" noChangeAspect="1"/>
+          </p:cNvSpPr>
+          <p:nvPr>
+            <p:ph type="sldImg"/>
+          </p:nvPr>
+        </p:nvSpPr>
+        <p:spPr/>
+      </p:sp>
+      <p:sp>
+        <p:nvSpPr>
+          <p:cNvPr id="3" name="Notes Placeholder 2"/>
+          <p:cNvSpPr>
+            <a:spLocks noGrp="1"/>
+          </p:cNvSpPr>
+          <p:nvPr>
+            <p:ph type="body" idx="1"/>
+          </p:nvPr>
+        </p:nvSpPr>
+        <p:spPr/>
+        <p:txBody>
+          <a:bodyPr/>
+          <a:lstStyle/>
+          <a:p>
+            <a:r>
+              <a:rPr lang="en-US" dirty="0"/>
+              <a:t/>
+            </a:r>
+            <a:endParaRPr lang="en-US" dirty="0"/>
+          </a:p>
+        </p:txBody>
+      </p:sp>
+      <p:sp>
+        <p:nvSpPr>
+          <p:cNvPr id="4" name="Slide Number Placeholder 3"/>
+          <p:cNvSpPr>
+            <a:spLocks noGrp="1"/>
+          </p:cNvSpPr>
+          <p:nvPr>
+            <p:ph type="sldNum" sz="quarter" idx="10"/>
+          </p:nvPr>
+        </p:nvSpPr>
+        <p:spPr/>
+        <p:txBody>
+          <a:bodyPr/>
+          <a:lstStyle/>
+          <a:p>
+            <a:fld id="{F7021451-1387-4CA6-816F-3879F97B5CBC}" type="slidenum">
+              <a:rPr lang="en-US"/>
+              <a:t>26</a:t>
             </a:fld>
             <a:endParaRPr lang="en-US"/>
           </a:p>
@@ -29424,6 +30384,3743 @@
     <p:bg>
       <p:bgPr>
         <a:solidFill>
+          <a:srgbClr val="FFFFFF"/>
+        </a:solidFill>
+      </p:bgPr>
+    </p:bg>
+    <p:spTree>
+      <p:nvGrpSpPr>
+        <p:cNvPr id="1" name=""/>
+        <p:cNvGrpSpPr/>
+        <p:nvPr/>
+      </p:nvGrpSpPr>
+      <p:grpSpPr>
+        <a:xfrm>
+          <a:off x="0" y="0"/>
+          <a:ext cx="0" cy="0"/>
+          <a:chOff x="0" y="0"/>
+          <a:chExt cx="0" cy="0"/>
+        </a:xfrm>
+      </p:grpSpPr>
+      <p:sp>
+        <p:nvSpPr>
+          <p:cNvPr id="2" name="Shape 0"/>
+          <p:cNvSpPr/>
+          <p:nvPr/>
+        </p:nvSpPr>
+        <p:spPr>
+          <a:xfrm>
+            <a:off x="0" y="0"/>
+            <a:ext cx="9144000" cy="73152"/>
+          </a:xfrm>
+          <a:prstGeom prst="rect">
+            <a:avLst/>
+          </a:prstGeom>
+          <a:solidFill>
+            <a:srgbClr val="085CE5"/>
+          </a:solidFill>
+          <a:ln w="12700">
+            <a:solidFill>
+              <a:srgbClr val="085CE5"/>
+            </a:solidFill>
+            <a:prstDash val="solid"/>
+          </a:ln>
+        </p:spPr>
+      </p:sp>
+      <p:sp>
+        <p:nvSpPr>
+          <p:cNvPr id="3" name="Shape 1"/>
+          <p:cNvSpPr/>
+          <p:nvPr/>
+        </p:nvSpPr>
+        <p:spPr>
+          <a:xfrm>
+            <a:off x="0" y="0"/>
+            <a:ext cx="137160" cy="5143500"/>
+          </a:xfrm>
+          <a:prstGeom prst="rect">
+            <a:avLst/>
+          </a:prstGeom>
+          <a:solidFill>
+            <a:srgbClr val="085CE5"/>
+          </a:solidFill>
+          <a:ln w="12700">
+            <a:solidFill>
+              <a:srgbClr val="085CE5"/>
+            </a:solidFill>
+            <a:prstDash val="solid"/>
+          </a:ln>
+        </p:spPr>
+      </p:sp>
+      <p:sp>
+        <p:nvSpPr>
+          <p:cNvPr id="4" name="Text 2"/>
+          <p:cNvSpPr/>
+          <p:nvPr/>
+        </p:nvSpPr>
+        <p:spPr>
+          <a:xfrm>
+            <a:off x="365760" y="164592"/>
+            <a:ext cx="8229600" cy="256032"/>
+          </a:xfrm>
+          <a:prstGeom prst="rect">
+            <a:avLst/>
+          </a:prstGeom>
+          <a:noFill/>
+          <a:ln/>
+        </p:spPr>
+        <p:txBody>
+          <a:bodyPr wrap="square" lIns="0" tIns="0" rIns="0" bIns="0" rtlCol="0" anchor="ctr"/>
+          <a:lstStyle/>
+          <a:p>
+            <a:pPr indent="0" marL="0">
+              <a:buNone/>
+            </a:pPr>
+            <a:r>
+              <a:rPr lang="en-US" sz="900" b="1" spc="400" kern="0" dirty="0">
+                <a:solidFill>
+                  <a:srgbClr val="085CE5"/>
+                </a:solidFill>
+                <a:latin typeface="Calibri" pitchFamily="34" charset="0"/>
+                <a:ea typeface="Calibri" pitchFamily="34" charset="-122"/>
+                <a:cs typeface="Calibri" pitchFamily="34" charset="-120"/>
+              </a:rPr>
+              <a:t>REVENUE MODEL</a:t>
+            </a:r>
+            <a:endParaRPr lang="en-US" sz="900" dirty="0"/>
+          </a:p>
+        </p:txBody>
+      </p:sp>
+      <p:sp>
+        <p:nvSpPr>
+          <p:cNvPr id="5" name="Text 3"/>
+          <p:cNvSpPr/>
+          <p:nvPr/>
+        </p:nvSpPr>
+        <p:spPr>
+          <a:xfrm>
+            <a:off x="365760" y="475488"/>
+            <a:ext cx="8229600" cy="457200"/>
+          </a:xfrm>
+          <a:prstGeom prst="rect">
+            <a:avLst/>
+          </a:prstGeom>
+          <a:noFill/>
+          <a:ln/>
+        </p:spPr>
+        <p:txBody>
+          <a:bodyPr wrap="square" lIns="0" tIns="0" rIns="0" bIns="0" rtlCol="0" anchor="ctr"/>
+          <a:lstStyle/>
+          <a:p>
+            <a:pPr indent="0" marL="0">
+              <a:buNone/>
+            </a:pPr>
+            <a:r>
+              <a:rPr lang="en-US" sz="2400" b="1" dirty="0">
+                <a:solidFill>
+                  <a:srgbClr val="06185F"/>
+                </a:solidFill>
+                <a:latin typeface="Calibri" pitchFamily="34" charset="0"/>
+                <a:ea typeface="Calibri" pitchFamily="34" charset="-122"/>
+                <a:cs typeface="Calibri" pitchFamily="34" charset="-120"/>
+              </a:rPr>
+              <a:t>Path to $1M ARR — DS App Add-On Revenue</a:t>
+            </a:r>
+            <a:endParaRPr lang="en-US" sz="2400" dirty="0"/>
+          </a:p>
+        </p:txBody>
+      </p:sp>
+      <p:sp>
+        <p:nvSpPr>
+          <p:cNvPr id="6" name="Text 4"/>
+          <p:cNvSpPr/>
+          <p:nvPr/>
+        </p:nvSpPr>
+        <p:spPr>
+          <a:xfrm>
+            <a:off x="365760" y="960120"/>
+            <a:ext cx="8229600" cy="256032"/>
+          </a:xfrm>
+          <a:prstGeom prst="rect">
+            <a:avLst/>
+          </a:prstGeom>
+          <a:noFill/>
+          <a:ln/>
+        </p:spPr>
+        <p:txBody>
+          <a:bodyPr wrap="square" lIns="0" tIns="0" rIns="0" bIns="0" rtlCol="0" anchor="ctr"/>
+          <a:lstStyle/>
+          <a:p>
+            <a:pPr indent="0" marL="0">
+              <a:buNone/>
+            </a:pPr>
+            <a:r>
+              <a:rPr lang="en-US" sz="1100" dirty="0">
+                <a:solidFill>
+                  <a:srgbClr val="575A5D"/>
+                </a:solidFill>
+                <a:latin typeface="Calibri" pitchFamily="34" charset="0"/>
+                <a:ea typeface="Calibri" pitchFamily="34" charset="-122"/>
+                <a:cs typeface="Calibri" pitchFamily="34" charset="-120"/>
+              </a:rPr>
+              <a:t>5 apps · Add-on to JHBI platform · ~1,660 addressable FIs · Blended bank/CU pricing</a:t>
+            </a:r>
+            <a:endParaRPr lang="en-US" sz="1100" dirty="0"/>
+          </a:p>
+        </p:txBody>
+      </p:sp>
+      <p:graphicFrame>
+        <p:nvGraphicFramePr>
+          <p:cNvPr id="7" name="Chart 0" descr=""/>
+          <p:cNvGraphicFramePr/>
+          <p:nvPr/>
+        </p:nvGraphicFramePr>
+        <p:xfrm>
+          <a:off x="320040" y="1298448"/>
+          <a:ext cx="6035040" cy="3520440"/>
+        </p:xfrm>
+        <a:graphic xmlns:a="http://schemas.openxmlformats.org/drawingml/2006/main">
+          <a:graphicData uri="http://schemas.openxmlformats.org/drawingml/2006/chart">
+            <c:chart xmlns:c="http://schemas.openxmlformats.org/drawingml/2006/chart" r:id="rId1"/>
+          </a:graphicData>
+        </a:graphic>
+      </p:graphicFrame>
+      <p:sp>
+        <p:nvSpPr>
+          <p:cNvPr id="8" name="Shape 5"/>
+          <p:cNvSpPr/>
+          <p:nvPr/>
+        </p:nvSpPr>
+        <p:spPr>
+          <a:xfrm>
+            <a:off x="320040" y="2651760"/>
+            <a:ext cx="6035040" cy="0"/>
+          </a:xfrm>
+          <a:prstGeom prst="line">
+            <a:avLst/>
+          </a:prstGeom>
+          <a:noFill/>
+          <a:ln w="19050">
+            <a:solidFill>
+              <a:srgbClr val="E53030"/>
+            </a:solidFill>
+            <a:prstDash val="dash"/>
+          </a:ln>
+        </p:spPr>
+      </p:sp>
+      <p:sp>
+        <p:nvSpPr>
+          <p:cNvPr id="9" name="Text 6"/>
+          <p:cNvSpPr/>
+          <p:nvPr/>
+        </p:nvSpPr>
+        <p:spPr>
+          <a:xfrm>
+            <a:off x="6382512" y="2523744"/>
+            <a:ext cx="1920240" cy="256032"/>
+          </a:xfrm>
+          <a:prstGeom prst="rect">
+            <a:avLst/>
+          </a:prstGeom>
+          <a:noFill/>
+          <a:ln/>
+        </p:spPr>
+        <p:txBody>
+          <a:bodyPr wrap="square" lIns="0" tIns="0" rIns="0" bIns="0" rtlCol="0" anchor="ctr"/>
+          <a:lstStyle/>
+          <a:p>
+            <a:pPr indent="0" marL="0">
+              <a:buNone/>
+            </a:pPr>
+            <a:r>
+              <a:rPr lang="en-US" sz="900" b="1" dirty="0">
+                <a:solidFill>
+                  <a:srgbClr val="E53030"/>
+                </a:solidFill>
+                <a:latin typeface="Calibri" pitchFamily="34" charset="0"/>
+                <a:ea typeface="Calibri" pitchFamily="34" charset="-122"/>
+                <a:cs typeface="Calibri" pitchFamily="34" charset="-120"/>
+              </a:rPr>
+              <a:t>$1M ARR milestone</a:t>
+            </a:r>
+            <a:endParaRPr lang="en-US" sz="900" dirty="0"/>
+          </a:p>
+        </p:txBody>
+      </p:sp>
+      <p:sp>
+        <p:nvSpPr>
+          <p:cNvPr id="10" name="Shape 7"/>
+          <p:cNvSpPr/>
+          <p:nvPr/>
+        </p:nvSpPr>
+        <p:spPr>
+          <a:xfrm>
+            <a:off x="6400800" y="1298448"/>
+            <a:ext cx="2606040" cy="3520440"/>
+          </a:xfrm>
+          <a:prstGeom prst="roundRect">
+            <a:avLst>
+              <a:gd name="adj" fmla="val 2105"/>
+            </a:avLst>
+          </a:prstGeom>
+          <a:solidFill>
+            <a:srgbClr val="06185F"/>
+          </a:solidFill>
+          <a:ln w="12700">
+            <a:solidFill>
+              <a:srgbClr val="06185F"/>
+            </a:solidFill>
+            <a:prstDash val="solid"/>
+          </a:ln>
+        </p:spPr>
+      </p:sp>
+      <p:sp>
+        <p:nvSpPr>
+          <p:cNvPr id="11" name="Text 8"/>
+          <p:cNvSpPr/>
+          <p:nvPr/>
+        </p:nvSpPr>
+        <p:spPr>
+          <a:xfrm>
+            <a:off x="6400800" y="1417320"/>
+            <a:ext cx="2606040" cy="347472"/>
+          </a:xfrm>
+          <a:prstGeom prst="rect">
+            <a:avLst/>
+          </a:prstGeom>
+          <a:noFill/>
+          <a:ln/>
+        </p:spPr>
+        <p:txBody>
+          <a:bodyPr wrap="square" lIns="0" tIns="0" rIns="0" bIns="0" rtlCol="0" anchor="ctr"/>
+          <a:lstStyle/>
+          <a:p>
+            <a:pPr algn="ctr" indent="0" marL="0">
+              <a:buNone/>
+            </a:pPr>
+            <a:r>
+              <a:rPr lang="en-US" sz="1300" b="1" dirty="0">
+                <a:solidFill>
+                  <a:srgbClr val="76DCFD"/>
+                </a:solidFill>
+                <a:latin typeface="Calibri" pitchFamily="34" charset="0"/>
+                <a:ea typeface="Calibri" pitchFamily="34" charset="-122"/>
+                <a:cs typeface="Calibri" pitchFamily="34" charset="-120"/>
+              </a:rPr>
+              <a:t>Q4 FY27</a:t>
+            </a:r>
+            <a:endParaRPr lang="en-US" sz="1300" dirty="0"/>
+          </a:p>
+        </p:txBody>
+      </p:sp>
+      <p:sp>
+        <p:nvSpPr>
+          <p:cNvPr id="12" name="Text 9"/>
+          <p:cNvSpPr/>
+          <p:nvPr/>
+        </p:nvSpPr>
+        <p:spPr>
+          <a:xfrm>
+            <a:off x="6400800" y="1792224"/>
+            <a:ext cx="2606040" cy="566928"/>
+          </a:xfrm>
+          <a:prstGeom prst="rect">
+            <a:avLst/>
+          </a:prstGeom>
+          <a:noFill/>
+          <a:ln/>
+        </p:spPr>
+        <p:txBody>
+          <a:bodyPr wrap="square" lIns="0" tIns="0" rIns="0" bIns="0" rtlCol="0" anchor="ctr"/>
+          <a:lstStyle/>
+          <a:p>
+            <a:pPr algn="ctr" indent="0" marL="0">
+              <a:buNone/>
+            </a:pPr>
+            <a:r>
+              <a:rPr lang="en-US" sz="3200" b="1" dirty="0">
+                <a:solidFill>
+                  <a:srgbClr val="FFFFFF"/>
+                </a:solidFill>
+                <a:latin typeface="Calibri" pitchFamily="34" charset="0"/>
+                <a:ea typeface="Calibri" pitchFamily="34" charset="-122"/>
+                <a:cs typeface="Calibri" pitchFamily="34" charset="-120"/>
+              </a:rPr>
+              <a:t>$1.04M</a:t>
+            </a:r>
+            <a:endParaRPr lang="en-US" sz="3200" dirty="0"/>
+          </a:p>
+        </p:txBody>
+      </p:sp>
+      <p:sp>
+        <p:nvSpPr>
+          <p:cNvPr id="13" name="Text 10"/>
+          <p:cNvSpPr/>
+          <p:nvPr/>
+        </p:nvSpPr>
+        <p:spPr>
+          <a:xfrm>
+            <a:off x="6400800" y="2340864"/>
+            <a:ext cx="2606040" cy="256032"/>
+          </a:xfrm>
+          <a:prstGeom prst="rect">
+            <a:avLst/>
+          </a:prstGeom>
+          <a:noFill/>
+          <a:ln/>
+        </p:spPr>
+        <p:txBody>
+          <a:bodyPr wrap="square" lIns="0" tIns="0" rIns="0" bIns="0" rtlCol="0" anchor="ctr"/>
+          <a:lstStyle/>
+          <a:p>
+            <a:pPr algn="ctr" indent="0" marL="0">
+              <a:buNone/>
+            </a:pPr>
+            <a:r>
+              <a:rPr lang="en-US" sz="1300" dirty="0">
+                <a:solidFill>
+                  <a:srgbClr val="B6BBC0"/>
+                </a:solidFill>
+                <a:latin typeface="Calibri" pitchFamily="34" charset="0"/>
+                <a:ea typeface="Calibri" pitchFamily="34" charset="-122"/>
+                <a:cs typeface="Calibri" pitchFamily="34" charset="-120"/>
+              </a:rPr>
+              <a:t>ARR</a:t>
+            </a:r>
+            <a:endParaRPr lang="en-US" sz="1300" dirty="0"/>
+          </a:p>
+        </p:txBody>
+      </p:sp>
+      <p:sp>
+        <p:nvSpPr>
+          <p:cNvPr id="14" name="Shape 11"/>
+          <p:cNvSpPr/>
+          <p:nvPr/>
+        </p:nvSpPr>
+        <p:spPr>
+          <a:xfrm>
+            <a:off x="6601968" y="2670048"/>
+            <a:ext cx="2212848" cy="9144"/>
+          </a:xfrm>
+          <a:prstGeom prst="rect">
+            <a:avLst/>
+          </a:prstGeom>
+          <a:solidFill>
+            <a:srgbClr val="0A52C4"/>
+          </a:solidFill>
+          <a:ln w="12700">
+            <a:solidFill>
+              <a:srgbClr val="0A52C4"/>
+            </a:solidFill>
+            <a:prstDash val="solid"/>
+          </a:ln>
+        </p:spPr>
+      </p:sp>
+      <p:sp>
+        <p:nvSpPr>
+          <p:cNvPr id="15" name="Text 12"/>
+          <p:cNvSpPr/>
+          <p:nvPr/>
+        </p:nvSpPr>
+        <p:spPr>
+          <a:xfrm>
+            <a:off x="6400800" y="2798064"/>
+            <a:ext cx="2606040" cy="329184"/>
+          </a:xfrm>
+          <a:prstGeom prst="rect">
+            <a:avLst/>
+          </a:prstGeom>
+          <a:noFill/>
+          <a:ln/>
+        </p:spPr>
+        <p:txBody>
+          <a:bodyPr wrap="square" lIns="0" tIns="0" rIns="0" bIns="0" rtlCol="0" anchor="ctr"/>
+          <a:lstStyle/>
+          <a:p>
+            <a:pPr algn="ctr" indent="0" marL="0">
+              <a:buNone/>
+            </a:pPr>
+            <a:r>
+              <a:rPr lang="en-US" sz="1800" b="1" dirty="0">
+                <a:solidFill>
+                  <a:srgbClr val="FFFFFF"/>
+                </a:solidFill>
+                <a:latin typeface="Calibri" pitchFamily="34" charset="0"/>
+                <a:ea typeface="Calibri" pitchFamily="34" charset="-122"/>
+                <a:cs typeface="Calibri" pitchFamily="34" charset="-120"/>
+              </a:rPr>
+              <a:t>~81</a:t>
+            </a:r>
+            <a:endParaRPr lang="en-US" sz="1800" dirty="0"/>
+          </a:p>
+        </p:txBody>
+      </p:sp>
+      <p:sp>
+        <p:nvSpPr>
+          <p:cNvPr id="16" name="Text 13"/>
+          <p:cNvSpPr/>
+          <p:nvPr/>
+        </p:nvSpPr>
+        <p:spPr>
+          <a:xfrm>
+            <a:off x="6400800" y="3127248"/>
+            <a:ext cx="2606040" cy="201168"/>
+          </a:xfrm>
+          <a:prstGeom prst="rect">
+            <a:avLst/>
+          </a:prstGeom>
+          <a:noFill/>
+          <a:ln/>
+        </p:spPr>
+        <p:txBody>
+          <a:bodyPr wrap="square" lIns="0" tIns="0" rIns="0" bIns="0" rtlCol="0" anchor="ctr"/>
+          <a:lstStyle/>
+          <a:p>
+            <a:pPr algn="ctr" indent="0" marL="0">
+              <a:buNone/>
+            </a:pPr>
+            <a:r>
+              <a:rPr lang="en-US" sz="900" dirty="0">
+                <a:solidFill>
+                  <a:srgbClr val="B6BBC0"/>
+                </a:solidFill>
+                <a:latin typeface="Calibri" pitchFamily="34" charset="0"/>
+                <a:ea typeface="Calibri" pitchFamily="34" charset="-122"/>
+                <a:cs typeface="Calibri" pitchFamily="34" charset="-120"/>
+              </a:rPr>
+              <a:t>active FI subscriptions</a:t>
+            </a:r>
+            <a:endParaRPr lang="en-US" sz="900" dirty="0"/>
+          </a:p>
+        </p:txBody>
+      </p:sp>
+      <p:sp>
+        <p:nvSpPr>
+          <p:cNvPr id="17" name="Text 14"/>
+          <p:cNvSpPr/>
+          <p:nvPr/>
+        </p:nvSpPr>
+        <p:spPr>
+          <a:xfrm>
+            <a:off x="6400800" y="3456432"/>
+            <a:ext cx="2606040" cy="329184"/>
+          </a:xfrm>
+          <a:prstGeom prst="rect">
+            <a:avLst/>
+          </a:prstGeom>
+          <a:noFill/>
+          <a:ln/>
+        </p:spPr>
+        <p:txBody>
+          <a:bodyPr wrap="square" lIns="0" tIns="0" rIns="0" bIns="0" rtlCol="0" anchor="ctr"/>
+          <a:lstStyle/>
+          <a:p>
+            <a:pPr algn="ctr" indent="0" marL="0">
+              <a:buNone/>
+            </a:pPr>
+            <a:r>
+              <a:rPr lang="en-US" sz="1800" b="1" dirty="0">
+                <a:solidFill>
+                  <a:srgbClr val="FFFFFF"/>
+                </a:solidFill>
+                <a:latin typeface="Calibri" pitchFamily="34" charset="0"/>
+                <a:ea typeface="Calibri" pitchFamily="34" charset="-122"/>
+                <a:cs typeface="Calibri" pitchFamily="34" charset="-120"/>
+              </a:rPr>
+              <a:t>4.9%</a:t>
+            </a:r>
+            <a:endParaRPr lang="en-US" sz="1800" dirty="0"/>
+          </a:p>
+        </p:txBody>
+      </p:sp>
+      <p:sp>
+        <p:nvSpPr>
+          <p:cNvPr id="18" name="Text 15"/>
+          <p:cNvSpPr/>
+          <p:nvPr/>
+        </p:nvSpPr>
+        <p:spPr>
+          <a:xfrm>
+            <a:off x="6400800" y="3785616"/>
+            <a:ext cx="2606040" cy="201168"/>
+          </a:xfrm>
+          <a:prstGeom prst="rect">
+            <a:avLst/>
+          </a:prstGeom>
+          <a:noFill/>
+          <a:ln/>
+        </p:spPr>
+        <p:txBody>
+          <a:bodyPr wrap="square" lIns="0" tIns="0" rIns="0" bIns="0" rtlCol="0" anchor="ctr"/>
+          <a:lstStyle/>
+          <a:p>
+            <a:pPr algn="ctr" indent="0" marL="0">
+              <a:buNone/>
+            </a:pPr>
+            <a:r>
+              <a:rPr lang="en-US" sz="900" dirty="0">
+                <a:solidFill>
+                  <a:srgbClr val="B6BBC0"/>
+                </a:solidFill>
+                <a:latin typeface="Calibri" pitchFamily="34" charset="0"/>
+                <a:ea typeface="Calibri" pitchFamily="34" charset="-122"/>
+                <a:cs typeface="Calibri" pitchFamily="34" charset="-120"/>
+              </a:rPr>
+              <a:t>of 1,660-FI base</a:t>
+            </a:r>
+            <a:endParaRPr lang="en-US" sz="900" dirty="0"/>
+          </a:p>
+        </p:txBody>
+      </p:sp>
+      <p:sp>
+        <p:nvSpPr>
+          <p:cNvPr id="19" name="Text 16"/>
+          <p:cNvSpPr/>
+          <p:nvPr/>
+        </p:nvSpPr>
+        <p:spPr>
+          <a:xfrm>
+            <a:off x="6400800" y="4114800"/>
+            <a:ext cx="2606040" cy="329184"/>
+          </a:xfrm>
+          <a:prstGeom prst="rect">
+            <a:avLst/>
+          </a:prstGeom>
+          <a:noFill/>
+          <a:ln/>
+        </p:spPr>
+        <p:txBody>
+          <a:bodyPr wrap="square" lIns="0" tIns="0" rIns="0" bIns="0" rtlCol="0" anchor="ctr"/>
+          <a:lstStyle/>
+          <a:p>
+            <a:pPr algn="ctr" indent="0" marL="0">
+              <a:buNone/>
+            </a:pPr>
+            <a:r>
+              <a:rPr lang="en-US" sz="1800" b="1" dirty="0">
+                <a:solidFill>
+                  <a:srgbClr val="FFFFFF"/>
+                </a:solidFill>
+                <a:latin typeface="Calibri" pitchFamily="34" charset="0"/>
+                <a:ea typeface="Calibri" pitchFamily="34" charset="-122"/>
+                <a:cs typeface="Calibri" pitchFamily="34" charset="-120"/>
+              </a:rPr>
+              <a:t>3 apps</a:t>
+            </a:r>
+            <a:endParaRPr lang="en-US" sz="1800" dirty="0"/>
+          </a:p>
+        </p:txBody>
+      </p:sp>
+      <p:sp>
+        <p:nvSpPr>
+          <p:cNvPr id="20" name="Text 17"/>
+          <p:cNvSpPr/>
+          <p:nvPr/>
+        </p:nvSpPr>
+        <p:spPr>
+          <a:xfrm>
+            <a:off x="6400800" y="4443984"/>
+            <a:ext cx="2606040" cy="201168"/>
+          </a:xfrm>
+          <a:prstGeom prst="rect">
+            <a:avLst/>
+          </a:prstGeom>
+          <a:noFill/>
+          <a:ln/>
+        </p:spPr>
+        <p:txBody>
+          <a:bodyPr wrap="square" lIns="0" tIns="0" rIns="0" bIns="0" rtlCol="0" anchor="ctr"/>
+          <a:lstStyle/>
+          <a:p>
+            <a:pPr algn="ctr" indent="0" marL="0">
+              <a:buNone/>
+            </a:pPr>
+            <a:r>
+              <a:rPr lang="en-US" sz="900" dirty="0">
+                <a:solidFill>
+                  <a:srgbClr val="B6BBC0"/>
+                </a:solidFill>
+                <a:latin typeface="Calibri" pitchFamily="34" charset="0"/>
+                <a:ea typeface="Calibri" pitchFamily="34" charset="-122"/>
+                <a:cs typeface="Calibri" pitchFamily="34" charset="-120"/>
+              </a:rPr>
+              <a:t>driving first $1M</a:t>
+            </a:r>
+            <a:endParaRPr lang="en-US" sz="900" dirty="0"/>
+          </a:p>
+        </p:txBody>
+      </p:sp>
+      <p:sp>
+        <p:nvSpPr>
+          <p:cNvPr id="21" name="Text 18"/>
+          <p:cNvSpPr/>
+          <p:nvPr/>
+        </p:nvSpPr>
+        <p:spPr>
+          <a:xfrm>
+            <a:off x="320040" y="4882896"/>
+            <a:ext cx="8595360" cy="201168"/>
+          </a:xfrm>
+          <a:prstGeom prst="rect">
+            <a:avLst/>
+          </a:prstGeom>
+          <a:noFill/>
+          <a:ln/>
+        </p:spPr>
+        <p:txBody>
+          <a:bodyPr wrap="square" lIns="0" tIns="0" rIns="0" bIns="0" rtlCol="0" anchor="ctr"/>
+          <a:lstStyle/>
+          <a:p>
+            <a:pPr indent="0" marL="0">
+              <a:buNone/>
+            </a:pPr>
+            <a:r>
+              <a:rPr lang="en-US" sz="750" i="1" dirty="0">
+                <a:solidFill>
+                  <a:srgbClr val="B6BBC0"/>
+                </a:solidFill>
+                <a:latin typeface="Calibri" pitchFamily="34" charset="0"/>
+                <a:ea typeface="Calibri" pitchFamily="34" charset="-122"/>
+                <a:cs typeface="Calibri" pitchFamily="34" charset="-120"/>
+              </a:rPr>
+              <a:t>★ Q4 FY27 = Apr–Jun 2027  ·  ARR values are model projections; actual results depend on FI adoption and sales cycle timing</a:t>
+            </a:r>
+            <a:endParaRPr lang="en-US" sz="750" dirty="0"/>
+          </a:p>
+        </p:txBody>
+      </p:sp>
+    </p:spTree>
+  </p:cSld>
+  <p:clrMapOvr>
+    <a:masterClrMapping/>
+  </p:clrMapOvr>
+</p:sld>
+</file>
+
+<file path=ppt/slides/slide25.xml><?xml version="1.0" encoding="utf-8"?>
+<p:sld xmlns:a="http://schemas.openxmlformats.org/drawingml/2006/main" xmlns:r="http://schemas.openxmlformats.org/officeDocument/2006/relationships" xmlns:p="http://schemas.openxmlformats.org/presentationml/2006/main">
+  <p:cSld name="Slide 25">
+    <p:bg>
+      <p:bgPr>
+        <a:solidFill>
+          <a:srgbClr val="FFFFFF"/>
+        </a:solidFill>
+      </p:bgPr>
+    </p:bg>
+    <p:spTree>
+      <p:nvGrpSpPr>
+        <p:cNvPr id="1" name=""/>
+        <p:cNvGrpSpPr/>
+        <p:nvPr/>
+      </p:nvGrpSpPr>
+      <p:grpSpPr>
+        <a:xfrm>
+          <a:off x="0" y="0"/>
+          <a:ext cx="0" cy="0"/>
+          <a:chOff x="0" y="0"/>
+          <a:chExt cx="0" cy="0"/>
+        </a:xfrm>
+      </p:grpSpPr>
+      <p:sp>
+        <p:nvSpPr>
+          <p:cNvPr id="2" name="Shape 0"/>
+          <p:cNvSpPr/>
+          <p:nvPr/>
+        </p:nvSpPr>
+        <p:spPr>
+          <a:xfrm>
+            <a:off x="0" y="0"/>
+            <a:ext cx="9144000" cy="73152"/>
+          </a:xfrm>
+          <a:prstGeom prst="rect">
+            <a:avLst/>
+          </a:prstGeom>
+          <a:solidFill>
+            <a:srgbClr val="085CE5"/>
+          </a:solidFill>
+          <a:ln w="12700">
+            <a:solidFill>
+              <a:srgbClr val="085CE5"/>
+            </a:solidFill>
+            <a:prstDash val="solid"/>
+          </a:ln>
+        </p:spPr>
+      </p:sp>
+      <p:sp>
+        <p:nvSpPr>
+          <p:cNvPr id="3" name="Shape 1"/>
+          <p:cNvSpPr/>
+          <p:nvPr/>
+        </p:nvSpPr>
+        <p:spPr>
+          <a:xfrm>
+            <a:off x="0" y="0"/>
+            <a:ext cx="137160" cy="5143500"/>
+          </a:xfrm>
+          <a:prstGeom prst="rect">
+            <a:avLst/>
+          </a:prstGeom>
+          <a:solidFill>
+            <a:srgbClr val="085CE5"/>
+          </a:solidFill>
+          <a:ln w="12700">
+            <a:solidFill>
+              <a:srgbClr val="085CE5"/>
+            </a:solidFill>
+            <a:prstDash val="solid"/>
+          </a:ln>
+        </p:spPr>
+      </p:sp>
+      <p:sp>
+        <p:nvSpPr>
+          <p:cNvPr id="4" name="Text 2"/>
+          <p:cNvSpPr/>
+          <p:nvPr/>
+        </p:nvSpPr>
+        <p:spPr>
+          <a:xfrm>
+            <a:off x="365760" y="164592"/>
+            <a:ext cx="8229600" cy="256032"/>
+          </a:xfrm>
+          <a:prstGeom prst="rect">
+            <a:avLst/>
+          </a:prstGeom>
+          <a:noFill/>
+          <a:ln/>
+        </p:spPr>
+        <p:txBody>
+          <a:bodyPr wrap="square" lIns="0" tIns="0" rIns="0" bIns="0" rtlCol="0" anchor="ctr"/>
+          <a:lstStyle/>
+          <a:p>
+            <a:pPr indent="0" marL="0">
+              <a:buNone/>
+            </a:pPr>
+            <a:r>
+              <a:rPr lang="en-US" sz="900" b="1" spc="400" kern="0" dirty="0">
+                <a:solidFill>
+                  <a:srgbClr val="085CE5"/>
+                </a:solidFill>
+                <a:latin typeface="Calibri" pitchFamily="34" charset="0"/>
+                <a:ea typeface="Calibri" pitchFamily="34" charset="-122"/>
+                <a:cs typeface="Calibri" pitchFamily="34" charset="-120"/>
+              </a:rPr>
+              <a:t>REVENUE MODEL</a:t>
+            </a:r>
+            <a:endParaRPr lang="en-US" sz="900" dirty="0"/>
+          </a:p>
+        </p:txBody>
+      </p:sp>
+      <p:sp>
+        <p:nvSpPr>
+          <p:cNvPr id="5" name="Text 3"/>
+          <p:cNvSpPr/>
+          <p:nvPr/>
+        </p:nvSpPr>
+        <p:spPr>
+          <a:xfrm>
+            <a:off x="365760" y="475488"/>
+            <a:ext cx="7315200" cy="457200"/>
+          </a:xfrm>
+          <a:prstGeom prst="rect">
+            <a:avLst/>
+          </a:prstGeom>
+          <a:noFill/>
+          <a:ln/>
+        </p:spPr>
+        <p:txBody>
+          <a:bodyPr wrap="square" lIns="0" tIns="0" rIns="0" bIns="0" rtlCol="0" anchor="ctr"/>
+          <a:lstStyle/>
+          <a:p>
+            <a:pPr indent="0" marL="0">
+              <a:buNone/>
+            </a:pPr>
+            <a:r>
+              <a:rPr lang="en-US" sz="2400" b="1" dirty="0">
+                <a:solidFill>
+                  <a:srgbClr val="06185F"/>
+                </a:solidFill>
+                <a:latin typeface="Calibri" pitchFamily="34" charset="0"/>
+                <a:ea typeface="Calibri" pitchFamily="34" charset="-122"/>
+                <a:cs typeface="Calibri" pitchFamily="34" charset="-120"/>
+              </a:rPr>
+              <a:t>DS App Pricing — Annual Add-On per FI</a:t>
+            </a:r>
+            <a:endParaRPr lang="en-US" sz="2400" dirty="0"/>
+          </a:p>
+        </p:txBody>
+      </p:sp>
+      <p:sp>
+        <p:nvSpPr>
+          <p:cNvPr id="6" name="Text 4"/>
+          <p:cNvSpPr/>
+          <p:nvPr/>
+        </p:nvSpPr>
+        <p:spPr>
+          <a:xfrm>
+            <a:off x="365760" y="960120"/>
+            <a:ext cx="8229600" cy="256032"/>
+          </a:xfrm>
+          <a:prstGeom prst="rect">
+            <a:avLst/>
+          </a:prstGeom>
+          <a:noFill/>
+          <a:ln/>
+        </p:spPr>
+        <p:txBody>
+          <a:bodyPr wrap="square" lIns="0" tIns="0" rIns="0" bIns="0" rtlCol="0" anchor="ctr"/>
+          <a:lstStyle/>
+          <a:p>
+            <a:pPr indent="0" marL="0">
+              <a:buNone/>
+            </a:pPr>
+            <a:r>
+              <a:rPr lang="en-US" sz="1100" dirty="0">
+                <a:solidFill>
+                  <a:srgbClr val="575A5D"/>
+                </a:solidFill>
+                <a:latin typeface="Calibri" pitchFamily="34" charset="0"/>
+                <a:ea typeface="Calibri" pitchFamily="34" charset="-122"/>
+                <a:cs typeface="Calibri" pitchFamily="34" charset="-120"/>
+              </a:rPr>
+              <a:t>Priced as annual subscriptions, add-on to JHBI platform fee  ·  CUs receive 12% pricing accommodation</a:t>
+            </a:r>
+            <a:endParaRPr lang="en-US" sz="1100" dirty="0"/>
+          </a:p>
+        </p:txBody>
+      </p:sp>
+      <p:sp>
+        <p:nvSpPr>
+          <p:cNvPr id="7" name="Shape 5"/>
+          <p:cNvSpPr/>
+          <p:nvPr/>
+        </p:nvSpPr>
+        <p:spPr>
+          <a:xfrm>
+            <a:off x="320040" y="1298448"/>
+            <a:ext cx="1828800" cy="347472"/>
+          </a:xfrm>
+          <a:prstGeom prst="rect">
+            <a:avLst/>
+          </a:prstGeom>
+          <a:solidFill>
+            <a:srgbClr val="06185F"/>
+          </a:solidFill>
+          <a:ln w="12700">
+            <a:solidFill>
+              <a:srgbClr val="06185F"/>
+            </a:solidFill>
+            <a:prstDash val="solid"/>
+          </a:ln>
+        </p:spPr>
+      </p:sp>
+      <p:sp>
+        <p:nvSpPr>
+          <p:cNvPr id="8" name="Text 6"/>
+          <p:cNvSpPr/>
+          <p:nvPr/>
+        </p:nvSpPr>
+        <p:spPr>
+          <a:xfrm>
+            <a:off x="320040" y="1298448"/>
+            <a:ext cx="1828800" cy="347472"/>
+          </a:xfrm>
+          <a:prstGeom prst="rect">
+            <a:avLst/>
+          </a:prstGeom>
+          <a:noFill/>
+          <a:ln/>
+        </p:spPr>
+        <p:txBody>
+          <a:bodyPr wrap="square" lIns="0" tIns="0" rIns="0" bIns="0" rtlCol="0" anchor="ctr"/>
+          <a:lstStyle/>
+          <a:p>
+            <a:pPr algn="ctr" indent="0" marL="0">
+              <a:buNone/>
+            </a:pPr>
+            <a:r>
+              <a:rPr lang="en-US" sz="950" b="1" dirty="0">
+                <a:solidFill>
+                  <a:srgbClr val="FFFFFF"/>
+                </a:solidFill>
+                <a:latin typeface="Calibri" pitchFamily="34" charset="0"/>
+                <a:ea typeface="Calibri" pitchFamily="34" charset="-122"/>
+                <a:cs typeface="Calibri" pitchFamily="34" charset="-120"/>
+              </a:rPr>
+              <a:t>DS App</a:t>
+            </a:r>
+            <a:endParaRPr lang="en-US" sz="950" dirty="0"/>
+          </a:p>
+        </p:txBody>
+      </p:sp>
+      <p:sp>
+        <p:nvSpPr>
+          <p:cNvPr id="9" name="Shape 7"/>
+          <p:cNvSpPr/>
+          <p:nvPr/>
+        </p:nvSpPr>
+        <p:spPr>
+          <a:xfrm>
+            <a:off x="2194560" y="1298448"/>
+            <a:ext cx="1325880" cy="347472"/>
+          </a:xfrm>
+          <a:prstGeom prst="rect">
+            <a:avLst/>
+          </a:prstGeom>
+          <a:solidFill>
+            <a:srgbClr val="06185F"/>
+          </a:solidFill>
+          <a:ln w="12700">
+            <a:solidFill>
+              <a:srgbClr val="06185F"/>
+            </a:solidFill>
+            <a:prstDash val="solid"/>
+          </a:ln>
+        </p:spPr>
+      </p:sp>
+      <p:sp>
+        <p:nvSpPr>
+          <p:cNvPr id="10" name="Text 8"/>
+          <p:cNvSpPr/>
+          <p:nvPr/>
+        </p:nvSpPr>
+        <p:spPr>
+          <a:xfrm>
+            <a:off x="2194560" y="1298448"/>
+            <a:ext cx="1325880" cy="347472"/>
+          </a:xfrm>
+          <a:prstGeom prst="rect">
+            <a:avLst/>
+          </a:prstGeom>
+          <a:noFill/>
+          <a:ln/>
+        </p:spPr>
+        <p:txBody>
+          <a:bodyPr wrap="square" lIns="0" tIns="0" rIns="0" bIns="0" rtlCol="0" anchor="ctr"/>
+          <a:lstStyle/>
+          <a:p>
+            <a:pPr algn="ctr" indent="0" marL="0">
+              <a:buNone/>
+            </a:pPr>
+            <a:r>
+              <a:rPr lang="en-US" sz="950" b="1" dirty="0">
+                <a:solidFill>
+                  <a:srgbClr val="FFFFFF"/>
+                </a:solidFill>
+                <a:latin typeface="Calibri" pitchFamily="34" charset="0"/>
+                <a:ea typeface="Calibri" pitchFamily="34" charset="-122"/>
+                <a:cs typeface="Calibri" pitchFamily="34" charset="-120"/>
+              </a:rPr>
+              <a:t>&lt;$250M</a:t>
+            </a:r>
+            <a:endParaRPr lang="en-US" sz="950" dirty="0"/>
+          </a:p>
+        </p:txBody>
+      </p:sp>
+      <p:sp>
+        <p:nvSpPr>
+          <p:cNvPr id="11" name="Shape 9"/>
+          <p:cNvSpPr/>
+          <p:nvPr/>
+        </p:nvSpPr>
+        <p:spPr>
+          <a:xfrm>
+            <a:off x="3566160" y="1298448"/>
+            <a:ext cx="1316736" cy="347472"/>
+          </a:xfrm>
+          <a:prstGeom prst="rect">
+            <a:avLst/>
+          </a:prstGeom>
+          <a:solidFill>
+            <a:srgbClr val="06185F"/>
+          </a:solidFill>
+          <a:ln w="12700">
+            <a:solidFill>
+              <a:srgbClr val="06185F"/>
+            </a:solidFill>
+            <a:prstDash val="solid"/>
+          </a:ln>
+        </p:spPr>
+      </p:sp>
+      <p:sp>
+        <p:nvSpPr>
+          <p:cNvPr id="12" name="Text 10"/>
+          <p:cNvSpPr/>
+          <p:nvPr/>
+        </p:nvSpPr>
+        <p:spPr>
+          <a:xfrm>
+            <a:off x="3566160" y="1298448"/>
+            <a:ext cx="1316736" cy="347472"/>
+          </a:xfrm>
+          <a:prstGeom prst="rect">
+            <a:avLst/>
+          </a:prstGeom>
+          <a:noFill/>
+          <a:ln/>
+        </p:spPr>
+        <p:txBody>
+          <a:bodyPr wrap="square" lIns="0" tIns="0" rIns="0" bIns="0" rtlCol="0" anchor="ctr"/>
+          <a:lstStyle/>
+          <a:p>
+            <a:pPr algn="ctr" indent="0" marL="0">
+              <a:buNone/>
+            </a:pPr>
+            <a:r>
+              <a:rPr lang="en-US" sz="950" b="1" dirty="0">
+                <a:solidFill>
+                  <a:srgbClr val="FFFFFF"/>
+                </a:solidFill>
+                <a:latin typeface="Calibri" pitchFamily="34" charset="0"/>
+                <a:ea typeface="Calibri" pitchFamily="34" charset="-122"/>
+                <a:cs typeface="Calibri" pitchFamily="34" charset="-120"/>
+              </a:rPr>
+              <a:t>$250M–$1B</a:t>
+            </a:r>
+            <a:endParaRPr lang="en-US" sz="950" dirty="0"/>
+          </a:p>
+        </p:txBody>
+      </p:sp>
+      <p:sp>
+        <p:nvSpPr>
+          <p:cNvPr id="13" name="Shape 11"/>
+          <p:cNvSpPr/>
+          <p:nvPr/>
+        </p:nvSpPr>
+        <p:spPr>
+          <a:xfrm>
+            <a:off x="4919472" y="1298448"/>
+            <a:ext cx="1316736" cy="347472"/>
+          </a:xfrm>
+          <a:prstGeom prst="rect">
+            <a:avLst/>
+          </a:prstGeom>
+          <a:solidFill>
+            <a:srgbClr val="06185F"/>
+          </a:solidFill>
+          <a:ln w="12700">
+            <a:solidFill>
+              <a:srgbClr val="06185F"/>
+            </a:solidFill>
+            <a:prstDash val="solid"/>
+          </a:ln>
+        </p:spPr>
+      </p:sp>
+      <p:sp>
+        <p:nvSpPr>
+          <p:cNvPr id="14" name="Text 12"/>
+          <p:cNvSpPr/>
+          <p:nvPr/>
+        </p:nvSpPr>
+        <p:spPr>
+          <a:xfrm>
+            <a:off x="4919472" y="1298448"/>
+            <a:ext cx="1316736" cy="347472"/>
+          </a:xfrm>
+          <a:prstGeom prst="rect">
+            <a:avLst/>
+          </a:prstGeom>
+          <a:noFill/>
+          <a:ln/>
+        </p:spPr>
+        <p:txBody>
+          <a:bodyPr wrap="square" lIns="0" tIns="0" rIns="0" bIns="0" rtlCol="0" anchor="ctr"/>
+          <a:lstStyle/>
+          <a:p>
+            <a:pPr algn="ctr" indent="0" marL="0">
+              <a:buNone/>
+            </a:pPr>
+            <a:r>
+              <a:rPr lang="en-US" sz="950" b="1" dirty="0">
+                <a:solidFill>
+                  <a:srgbClr val="FFFFFF"/>
+                </a:solidFill>
+                <a:latin typeface="Calibri" pitchFamily="34" charset="0"/>
+                <a:ea typeface="Calibri" pitchFamily="34" charset="-122"/>
+                <a:cs typeface="Calibri" pitchFamily="34" charset="-120"/>
+              </a:rPr>
+              <a:t>$1B–$5B</a:t>
+            </a:r>
+            <a:endParaRPr lang="en-US" sz="950" dirty="0"/>
+          </a:p>
+        </p:txBody>
+      </p:sp>
+      <p:sp>
+        <p:nvSpPr>
+          <p:cNvPr id="15" name="Shape 13"/>
+          <p:cNvSpPr/>
+          <p:nvPr/>
+        </p:nvSpPr>
+        <p:spPr>
+          <a:xfrm>
+            <a:off x="6272784" y="1298448"/>
+            <a:ext cx="1143000" cy="347472"/>
+          </a:xfrm>
+          <a:prstGeom prst="rect">
+            <a:avLst/>
+          </a:prstGeom>
+          <a:solidFill>
+            <a:srgbClr val="06185F"/>
+          </a:solidFill>
+          <a:ln w="12700">
+            <a:solidFill>
+              <a:srgbClr val="06185F"/>
+            </a:solidFill>
+            <a:prstDash val="solid"/>
+          </a:ln>
+        </p:spPr>
+      </p:sp>
+      <p:sp>
+        <p:nvSpPr>
+          <p:cNvPr id="16" name="Text 14"/>
+          <p:cNvSpPr/>
+          <p:nvPr/>
+        </p:nvSpPr>
+        <p:spPr>
+          <a:xfrm>
+            <a:off x="6272784" y="1298448"/>
+            <a:ext cx="1143000" cy="347472"/>
+          </a:xfrm>
+          <a:prstGeom prst="rect">
+            <a:avLst/>
+          </a:prstGeom>
+          <a:noFill/>
+          <a:ln/>
+        </p:spPr>
+        <p:txBody>
+          <a:bodyPr wrap="square" lIns="0" tIns="0" rIns="0" bIns="0" rtlCol="0" anchor="ctr"/>
+          <a:lstStyle/>
+          <a:p>
+            <a:pPr algn="ctr" indent="0" marL="0">
+              <a:buNone/>
+            </a:pPr>
+            <a:r>
+              <a:rPr lang="en-US" sz="950" b="1" dirty="0">
+                <a:solidFill>
+                  <a:srgbClr val="FFFFFF"/>
+                </a:solidFill>
+                <a:latin typeface="Calibri" pitchFamily="34" charset="0"/>
+                <a:ea typeface="Calibri" pitchFamily="34" charset="-122"/>
+                <a:cs typeface="Calibri" pitchFamily="34" charset="-120"/>
+              </a:rPr>
+              <a:t>$5B+</a:t>
+            </a:r>
+            <a:endParaRPr lang="en-US" sz="950" dirty="0"/>
+          </a:p>
+        </p:txBody>
+      </p:sp>
+      <p:sp>
+        <p:nvSpPr>
+          <p:cNvPr id="17" name="Shape 15"/>
+          <p:cNvSpPr/>
+          <p:nvPr/>
+        </p:nvSpPr>
+        <p:spPr>
+          <a:xfrm>
+            <a:off x="7452360" y="1298448"/>
+            <a:ext cx="1508760" cy="347472"/>
+          </a:xfrm>
+          <a:prstGeom prst="rect">
+            <a:avLst/>
+          </a:prstGeom>
+          <a:solidFill>
+            <a:srgbClr val="06185F"/>
+          </a:solidFill>
+          <a:ln w="12700">
+            <a:solidFill>
+              <a:srgbClr val="06185F"/>
+            </a:solidFill>
+            <a:prstDash val="solid"/>
+          </a:ln>
+        </p:spPr>
+      </p:sp>
+      <p:sp>
+        <p:nvSpPr>
+          <p:cNvPr id="18" name="Text 16"/>
+          <p:cNvSpPr/>
+          <p:nvPr/>
+        </p:nvSpPr>
+        <p:spPr>
+          <a:xfrm>
+            <a:off x="7452360" y="1298448"/>
+            <a:ext cx="1508760" cy="347472"/>
+          </a:xfrm>
+          <a:prstGeom prst="rect">
+            <a:avLst/>
+          </a:prstGeom>
+          <a:noFill/>
+          <a:ln/>
+        </p:spPr>
+        <p:txBody>
+          <a:bodyPr wrap="square" lIns="0" tIns="0" rIns="0" bIns="0" rtlCol="0" anchor="ctr"/>
+          <a:lstStyle/>
+          <a:p>
+            <a:pPr algn="ctr" indent="0" marL="0">
+              <a:buNone/>
+            </a:pPr>
+            <a:r>
+              <a:rPr lang="en-US" sz="950" b="1" dirty="0">
+                <a:solidFill>
+                  <a:srgbClr val="FFFFFF"/>
+                </a:solidFill>
+                <a:latin typeface="Calibri" pitchFamily="34" charset="0"/>
+                <a:ea typeface="Calibri" pitchFamily="34" charset="-122"/>
+                <a:cs typeface="Calibri" pitchFamily="34" charset="-120"/>
+              </a:rPr>
+              <a:t>Launch</a:t>
+            </a:r>
+            <a:endParaRPr lang="en-US" sz="950" dirty="0"/>
+          </a:p>
+        </p:txBody>
+      </p:sp>
+      <p:sp>
+        <p:nvSpPr>
+          <p:cNvPr id="19" name="Shape 17"/>
+          <p:cNvSpPr/>
+          <p:nvPr/>
+        </p:nvSpPr>
+        <p:spPr>
+          <a:xfrm>
+            <a:off x="320040" y="1645920"/>
+            <a:ext cx="73152" cy="493776"/>
+          </a:xfrm>
+          <a:prstGeom prst="rect">
+            <a:avLst/>
+          </a:prstGeom>
+          <a:solidFill>
+            <a:srgbClr val="085CE5"/>
+          </a:solidFill>
+          <a:ln w="12700">
+            <a:solidFill>
+              <a:srgbClr val="085CE5"/>
+            </a:solidFill>
+            <a:prstDash val="solid"/>
+          </a:ln>
+        </p:spPr>
+      </p:sp>
+      <p:sp>
+        <p:nvSpPr>
+          <p:cNvPr id="20" name="Shape 18"/>
+          <p:cNvSpPr/>
+          <p:nvPr/>
+        </p:nvSpPr>
+        <p:spPr>
+          <a:xfrm>
+            <a:off x="393192" y="1645920"/>
+            <a:ext cx="1755648" cy="493776"/>
+          </a:xfrm>
+          <a:prstGeom prst="rect">
+            <a:avLst/>
+          </a:prstGeom>
+          <a:solidFill>
+            <a:srgbClr val="F4F6FA"/>
+          </a:solidFill>
+          <a:ln w="12700">
+            <a:solidFill>
+              <a:srgbClr val="E7ECF0"/>
+            </a:solidFill>
+            <a:prstDash val="solid"/>
+          </a:ln>
+        </p:spPr>
+      </p:sp>
+      <p:sp>
+        <p:nvSpPr>
+          <p:cNvPr id="21" name="Text 19"/>
+          <p:cNvSpPr/>
+          <p:nvPr/>
+        </p:nvSpPr>
+        <p:spPr>
+          <a:xfrm>
+            <a:off x="448056" y="1645920"/>
+            <a:ext cx="1700784" cy="493776"/>
+          </a:xfrm>
+          <a:prstGeom prst="rect">
+            <a:avLst/>
+          </a:prstGeom>
+          <a:noFill/>
+          <a:ln/>
+        </p:spPr>
+        <p:txBody>
+          <a:bodyPr wrap="square" lIns="0" tIns="50800" rIns="0" bIns="0" rtlCol="0" anchor="ctr"/>
+          <a:lstStyle/>
+          <a:p>
+            <a:pPr indent="0" marL="0">
+              <a:buNone/>
+            </a:pPr>
+            <a:r>
+              <a:rPr lang="en-US" sz="950" b="1" dirty="0">
+                <a:solidFill>
+                  <a:srgbClr val="06185F"/>
+                </a:solidFill>
+                <a:latin typeface="Calibri" pitchFamily="34" charset="0"/>
+                <a:ea typeface="Calibri" pitchFamily="34" charset="-122"/>
+                <a:cs typeface="Calibri" pitchFamily="34" charset="-120"/>
+              </a:rPr>
+              <a:t>Zelle Memo Intelligence</a:t>
+            </a:r>
+            <a:endParaRPr lang="en-US" sz="950" dirty="0"/>
+          </a:p>
+        </p:txBody>
+      </p:sp>
+      <p:sp>
+        <p:nvSpPr>
+          <p:cNvPr id="22" name="Shape 20"/>
+          <p:cNvSpPr/>
+          <p:nvPr/>
+        </p:nvSpPr>
+        <p:spPr>
+          <a:xfrm>
+            <a:off x="2194560" y="1645920"/>
+            <a:ext cx="1325880" cy="493776"/>
+          </a:xfrm>
+          <a:prstGeom prst="rect">
+            <a:avLst/>
+          </a:prstGeom>
+          <a:solidFill>
+            <a:srgbClr val="F4F6FA"/>
+          </a:solidFill>
+          <a:ln w="12700">
+            <a:solidFill>
+              <a:srgbClr val="E7ECF0"/>
+            </a:solidFill>
+            <a:prstDash val="solid"/>
+          </a:ln>
+        </p:spPr>
+      </p:sp>
+      <p:sp>
+        <p:nvSpPr>
+          <p:cNvPr id="23" name="Text 21"/>
+          <p:cNvSpPr/>
+          <p:nvPr/>
+        </p:nvSpPr>
+        <p:spPr>
+          <a:xfrm>
+            <a:off x="2194560" y="1645920"/>
+            <a:ext cx="1325880" cy="493776"/>
+          </a:xfrm>
+          <a:prstGeom prst="rect">
+            <a:avLst/>
+          </a:prstGeom>
+          <a:noFill/>
+          <a:ln/>
+        </p:spPr>
+        <p:txBody>
+          <a:bodyPr wrap="square" lIns="0" tIns="0" rIns="0" bIns="0" rtlCol="0" anchor="ctr"/>
+          <a:lstStyle/>
+          <a:p>
+            <a:pPr algn="ctr" indent="0" marL="0">
+              <a:buNone/>
+            </a:pPr>
+            <a:r>
+              <a:rPr lang="en-US" sz="1000" b="1" dirty="0">
+                <a:solidFill>
+                  <a:srgbClr val="085CE5"/>
+                </a:solidFill>
+                <a:latin typeface="Calibri" pitchFamily="34" charset="0"/>
+                <a:ea typeface="Calibri" pitchFamily="34" charset="-122"/>
+                <a:cs typeface="Calibri" pitchFamily="34" charset="-120"/>
+              </a:rPr>
+              <a:t>$5,000</a:t>
+            </a:r>
+            <a:endParaRPr lang="en-US" sz="1000" dirty="0"/>
+          </a:p>
+        </p:txBody>
+      </p:sp>
+      <p:sp>
+        <p:nvSpPr>
+          <p:cNvPr id="24" name="Shape 22"/>
+          <p:cNvSpPr/>
+          <p:nvPr/>
+        </p:nvSpPr>
+        <p:spPr>
+          <a:xfrm>
+            <a:off x="3566160" y="1645920"/>
+            <a:ext cx="1316736" cy="493776"/>
+          </a:xfrm>
+          <a:prstGeom prst="rect">
+            <a:avLst/>
+          </a:prstGeom>
+          <a:solidFill>
+            <a:srgbClr val="F4F6FA"/>
+          </a:solidFill>
+          <a:ln w="12700">
+            <a:solidFill>
+              <a:srgbClr val="E7ECF0"/>
+            </a:solidFill>
+            <a:prstDash val="solid"/>
+          </a:ln>
+        </p:spPr>
+      </p:sp>
+      <p:sp>
+        <p:nvSpPr>
+          <p:cNvPr id="25" name="Text 23"/>
+          <p:cNvSpPr/>
+          <p:nvPr/>
+        </p:nvSpPr>
+        <p:spPr>
+          <a:xfrm>
+            <a:off x="3566160" y="1645920"/>
+            <a:ext cx="1316736" cy="493776"/>
+          </a:xfrm>
+          <a:prstGeom prst="rect">
+            <a:avLst/>
+          </a:prstGeom>
+          <a:noFill/>
+          <a:ln/>
+        </p:spPr>
+        <p:txBody>
+          <a:bodyPr wrap="square" lIns="0" tIns="0" rIns="0" bIns="0" rtlCol="0" anchor="ctr"/>
+          <a:lstStyle/>
+          <a:p>
+            <a:pPr algn="ctr" indent="0" marL="0">
+              <a:buNone/>
+            </a:pPr>
+            <a:r>
+              <a:rPr lang="en-US" sz="1000" b="1" dirty="0">
+                <a:solidFill>
+                  <a:srgbClr val="085CE5"/>
+                </a:solidFill>
+                <a:latin typeface="Calibri" pitchFamily="34" charset="0"/>
+                <a:ea typeface="Calibri" pitchFamily="34" charset="-122"/>
+                <a:cs typeface="Calibri" pitchFamily="34" charset="-120"/>
+              </a:rPr>
+              <a:t>$8,000</a:t>
+            </a:r>
+            <a:endParaRPr lang="en-US" sz="1000" dirty="0"/>
+          </a:p>
+        </p:txBody>
+      </p:sp>
+      <p:sp>
+        <p:nvSpPr>
+          <p:cNvPr id="26" name="Shape 24"/>
+          <p:cNvSpPr/>
+          <p:nvPr/>
+        </p:nvSpPr>
+        <p:spPr>
+          <a:xfrm>
+            <a:off x="4919472" y="1645920"/>
+            <a:ext cx="1316736" cy="493776"/>
+          </a:xfrm>
+          <a:prstGeom prst="rect">
+            <a:avLst/>
+          </a:prstGeom>
+          <a:solidFill>
+            <a:srgbClr val="F4F6FA"/>
+          </a:solidFill>
+          <a:ln w="12700">
+            <a:solidFill>
+              <a:srgbClr val="E7ECF0"/>
+            </a:solidFill>
+            <a:prstDash val="solid"/>
+          </a:ln>
+        </p:spPr>
+      </p:sp>
+      <p:sp>
+        <p:nvSpPr>
+          <p:cNvPr id="27" name="Text 25"/>
+          <p:cNvSpPr/>
+          <p:nvPr/>
+        </p:nvSpPr>
+        <p:spPr>
+          <a:xfrm>
+            <a:off x="4919472" y="1645920"/>
+            <a:ext cx="1316736" cy="493776"/>
+          </a:xfrm>
+          <a:prstGeom prst="rect">
+            <a:avLst/>
+          </a:prstGeom>
+          <a:noFill/>
+          <a:ln/>
+        </p:spPr>
+        <p:txBody>
+          <a:bodyPr wrap="square" lIns="0" tIns="0" rIns="0" bIns="0" rtlCol="0" anchor="ctr"/>
+          <a:lstStyle/>
+          <a:p>
+            <a:pPr algn="ctr" indent="0" marL="0">
+              <a:buNone/>
+            </a:pPr>
+            <a:r>
+              <a:rPr lang="en-US" sz="1000" b="1" dirty="0">
+                <a:solidFill>
+                  <a:srgbClr val="085CE5"/>
+                </a:solidFill>
+                <a:latin typeface="Calibri" pitchFamily="34" charset="0"/>
+                <a:ea typeface="Calibri" pitchFamily="34" charset="-122"/>
+                <a:cs typeface="Calibri" pitchFamily="34" charset="-120"/>
+              </a:rPr>
+              <a:t>$15,000</a:t>
+            </a:r>
+            <a:endParaRPr lang="en-US" sz="1000" dirty="0"/>
+          </a:p>
+        </p:txBody>
+      </p:sp>
+      <p:sp>
+        <p:nvSpPr>
+          <p:cNvPr id="28" name="Shape 26"/>
+          <p:cNvSpPr/>
+          <p:nvPr/>
+        </p:nvSpPr>
+        <p:spPr>
+          <a:xfrm>
+            <a:off x="6272784" y="1645920"/>
+            <a:ext cx="1143000" cy="493776"/>
+          </a:xfrm>
+          <a:prstGeom prst="rect">
+            <a:avLst/>
+          </a:prstGeom>
+          <a:solidFill>
+            <a:srgbClr val="F4F6FA"/>
+          </a:solidFill>
+          <a:ln w="12700">
+            <a:solidFill>
+              <a:srgbClr val="E7ECF0"/>
+            </a:solidFill>
+            <a:prstDash val="solid"/>
+          </a:ln>
+        </p:spPr>
+      </p:sp>
+      <p:sp>
+        <p:nvSpPr>
+          <p:cNvPr id="29" name="Text 27"/>
+          <p:cNvSpPr/>
+          <p:nvPr/>
+        </p:nvSpPr>
+        <p:spPr>
+          <a:xfrm>
+            <a:off x="6272784" y="1645920"/>
+            <a:ext cx="1143000" cy="493776"/>
+          </a:xfrm>
+          <a:prstGeom prst="rect">
+            <a:avLst/>
+          </a:prstGeom>
+          <a:noFill/>
+          <a:ln/>
+        </p:spPr>
+        <p:txBody>
+          <a:bodyPr wrap="square" lIns="0" tIns="0" rIns="0" bIns="0" rtlCol="0" anchor="ctr"/>
+          <a:lstStyle/>
+          <a:p>
+            <a:pPr algn="ctr" indent="0" marL="0">
+              <a:buNone/>
+            </a:pPr>
+            <a:r>
+              <a:rPr lang="en-US" sz="1000" b="1" dirty="0">
+                <a:solidFill>
+                  <a:srgbClr val="085CE5"/>
+                </a:solidFill>
+                <a:latin typeface="Calibri" pitchFamily="34" charset="0"/>
+                <a:ea typeface="Calibri" pitchFamily="34" charset="-122"/>
+                <a:cs typeface="Calibri" pitchFamily="34" charset="-120"/>
+              </a:rPr>
+              <a:t>$25,000</a:t>
+            </a:r>
+            <a:endParaRPr lang="en-US" sz="1000" dirty="0"/>
+          </a:p>
+        </p:txBody>
+      </p:sp>
+      <p:sp>
+        <p:nvSpPr>
+          <p:cNvPr id="30" name="Shape 28"/>
+          <p:cNvSpPr/>
+          <p:nvPr/>
+        </p:nvSpPr>
+        <p:spPr>
+          <a:xfrm>
+            <a:off x="7452360" y="1645920"/>
+            <a:ext cx="1508760" cy="493776"/>
+          </a:xfrm>
+          <a:prstGeom prst="rect">
+            <a:avLst/>
+          </a:prstGeom>
+          <a:solidFill>
+            <a:srgbClr val="F4F6FA"/>
+          </a:solidFill>
+          <a:ln w="12700">
+            <a:solidFill>
+              <a:srgbClr val="E7ECF0"/>
+            </a:solidFill>
+            <a:prstDash val="solid"/>
+          </a:ln>
+        </p:spPr>
+      </p:sp>
+      <p:sp>
+        <p:nvSpPr>
+          <p:cNvPr id="31" name="Text 29"/>
+          <p:cNvSpPr/>
+          <p:nvPr/>
+        </p:nvSpPr>
+        <p:spPr>
+          <a:xfrm>
+            <a:off x="7452360" y="1682496"/>
+            <a:ext cx="1508760" cy="219456"/>
+          </a:xfrm>
+          <a:prstGeom prst="rect">
+            <a:avLst/>
+          </a:prstGeom>
+          <a:noFill/>
+          <a:ln/>
+        </p:spPr>
+        <p:txBody>
+          <a:bodyPr wrap="square" lIns="0" tIns="0" rIns="0" bIns="0" rtlCol="0" anchor="ctr"/>
+          <a:lstStyle/>
+          <a:p>
+            <a:pPr algn="ctr" indent="0" marL="0">
+              <a:buNone/>
+            </a:pPr>
+            <a:r>
+              <a:rPr lang="en-US" sz="950" b="1" dirty="0">
+                <a:solidFill>
+                  <a:srgbClr val="06185F"/>
+                </a:solidFill>
+                <a:latin typeface="Calibri" pitchFamily="34" charset="0"/>
+                <a:ea typeface="Calibri" pitchFamily="34" charset="-122"/>
+                <a:cs typeface="Calibri" pitchFamily="34" charset="-120"/>
+              </a:rPr>
+              <a:t>Q1 FY27</a:t>
+            </a:r>
+            <a:endParaRPr lang="en-US" sz="950" dirty="0"/>
+          </a:p>
+        </p:txBody>
+      </p:sp>
+      <p:sp>
+        <p:nvSpPr>
+          <p:cNvPr id="32" name="Text 30"/>
+          <p:cNvSpPr/>
+          <p:nvPr/>
+        </p:nvSpPr>
+        <p:spPr>
+          <a:xfrm>
+            <a:off x="7452360" y="1892808"/>
+            <a:ext cx="1508760" cy="219456"/>
+          </a:xfrm>
+          <a:prstGeom prst="rect">
+            <a:avLst/>
+          </a:prstGeom>
+          <a:noFill/>
+          <a:ln/>
+        </p:spPr>
+        <p:txBody>
+          <a:bodyPr wrap="square" lIns="0" tIns="0" rIns="0" bIns="0" rtlCol="0" anchor="ctr"/>
+          <a:lstStyle/>
+          <a:p>
+            <a:pPr algn="ctr" indent="0" marL="0">
+              <a:buNone/>
+            </a:pPr>
+            <a:r>
+              <a:rPr lang="en-US" sz="750" dirty="0">
+                <a:solidFill>
+                  <a:srgbClr val="575A5D"/>
+                </a:solidFill>
+                <a:latin typeface="Calibri" pitchFamily="34" charset="0"/>
+                <a:ea typeface="Calibri" pitchFamily="34" charset="-122"/>
+                <a:cs typeface="Calibri" pitchFamily="34" charset="-120"/>
+              </a:rPr>
+              <a:t>Zelle FIs only</a:t>
+            </a:r>
+            <a:endParaRPr lang="en-US" sz="750" dirty="0"/>
+          </a:p>
+          <a:p>
+            <a:pPr algn="ctr" indent="0" marL="0">
+              <a:buNone/>
+            </a:pPr>
+            <a:r>
+              <a:rPr lang="en-US" sz="750" dirty="0">
+                <a:solidFill>
+                  <a:srgbClr val="575A5D"/>
+                </a:solidFill>
+                <a:latin typeface="Calibri" pitchFamily="34" charset="0"/>
+                <a:ea typeface="Calibri" pitchFamily="34" charset="-122"/>
+                <a:cs typeface="Calibri" pitchFamily="34" charset="-120"/>
+              </a:rPr>
+              <a:t>(~580 addressable)</a:t>
+            </a:r>
+            <a:endParaRPr lang="en-US" sz="750" dirty="0"/>
+          </a:p>
+        </p:txBody>
+      </p:sp>
+      <p:sp>
+        <p:nvSpPr>
+          <p:cNvPr id="33" name="Shape 31"/>
+          <p:cNvSpPr/>
+          <p:nvPr/>
+        </p:nvSpPr>
+        <p:spPr>
+          <a:xfrm>
+            <a:off x="320040" y="2139696"/>
+            <a:ext cx="73152" cy="493776"/>
+          </a:xfrm>
+          <a:prstGeom prst="rect">
+            <a:avLst/>
+          </a:prstGeom>
+          <a:solidFill>
+            <a:srgbClr val="06185F"/>
+          </a:solidFill>
+          <a:ln w="12700">
+            <a:solidFill>
+              <a:srgbClr val="06185F"/>
+            </a:solidFill>
+            <a:prstDash val="solid"/>
+          </a:ln>
+        </p:spPr>
+      </p:sp>
+      <p:sp>
+        <p:nvSpPr>
+          <p:cNvPr id="34" name="Shape 32"/>
+          <p:cNvSpPr/>
+          <p:nvPr/>
+        </p:nvSpPr>
+        <p:spPr>
+          <a:xfrm>
+            <a:off x="393192" y="2139696"/>
+            <a:ext cx="1755648" cy="493776"/>
+          </a:xfrm>
+          <a:prstGeom prst="rect">
+            <a:avLst/>
+          </a:prstGeom>
+          <a:solidFill>
+            <a:srgbClr val="FFFFFF"/>
+          </a:solidFill>
+          <a:ln w="12700">
+            <a:solidFill>
+              <a:srgbClr val="E7ECF0"/>
+            </a:solidFill>
+            <a:prstDash val="solid"/>
+          </a:ln>
+        </p:spPr>
+      </p:sp>
+      <p:sp>
+        <p:nvSpPr>
+          <p:cNvPr id="35" name="Text 33"/>
+          <p:cNvSpPr/>
+          <p:nvPr/>
+        </p:nvSpPr>
+        <p:spPr>
+          <a:xfrm>
+            <a:off x="448056" y="2139696"/>
+            <a:ext cx="1700784" cy="493776"/>
+          </a:xfrm>
+          <a:prstGeom prst="rect">
+            <a:avLst/>
+          </a:prstGeom>
+          <a:noFill/>
+          <a:ln/>
+        </p:spPr>
+        <p:txBody>
+          <a:bodyPr wrap="square" lIns="0" tIns="50800" rIns="0" bIns="0" rtlCol="0" anchor="ctr"/>
+          <a:lstStyle/>
+          <a:p>
+            <a:pPr indent="0" marL="0">
+              <a:buNone/>
+            </a:pPr>
+            <a:r>
+              <a:rPr lang="en-US" sz="950" b="1" dirty="0">
+                <a:solidFill>
+                  <a:srgbClr val="06185F"/>
+                </a:solidFill>
+                <a:latin typeface="Calibri" pitchFamily="34" charset="0"/>
+                <a:ea typeface="Calibri" pitchFamily="34" charset="-122"/>
+                <a:cs typeface="Calibri" pitchFamily="34" charset="-120"/>
+              </a:rPr>
+              <a:t>Churn Sentinel</a:t>
+            </a:r>
+            <a:endParaRPr lang="en-US" sz="950" dirty="0"/>
+          </a:p>
+        </p:txBody>
+      </p:sp>
+      <p:sp>
+        <p:nvSpPr>
+          <p:cNvPr id="36" name="Shape 34"/>
+          <p:cNvSpPr/>
+          <p:nvPr/>
+        </p:nvSpPr>
+        <p:spPr>
+          <a:xfrm>
+            <a:off x="2194560" y="2139696"/>
+            <a:ext cx="1325880" cy="493776"/>
+          </a:xfrm>
+          <a:prstGeom prst="rect">
+            <a:avLst/>
+          </a:prstGeom>
+          <a:solidFill>
+            <a:srgbClr val="FFFFFF"/>
+          </a:solidFill>
+          <a:ln w="12700">
+            <a:solidFill>
+              <a:srgbClr val="E7ECF0"/>
+            </a:solidFill>
+            <a:prstDash val="solid"/>
+          </a:ln>
+        </p:spPr>
+      </p:sp>
+      <p:sp>
+        <p:nvSpPr>
+          <p:cNvPr id="37" name="Text 35"/>
+          <p:cNvSpPr/>
+          <p:nvPr/>
+        </p:nvSpPr>
+        <p:spPr>
+          <a:xfrm>
+            <a:off x="2194560" y="2139696"/>
+            <a:ext cx="1325880" cy="493776"/>
+          </a:xfrm>
+          <a:prstGeom prst="rect">
+            <a:avLst/>
+          </a:prstGeom>
+          <a:noFill/>
+          <a:ln/>
+        </p:spPr>
+        <p:txBody>
+          <a:bodyPr wrap="square" lIns="0" tIns="0" rIns="0" bIns="0" rtlCol="0" anchor="ctr"/>
+          <a:lstStyle/>
+          <a:p>
+            <a:pPr algn="ctr" indent="0" marL="0">
+              <a:buNone/>
+            </a:pPr>
+            <a:r>
+              <a:rPr lang="en-US" sz="1000" b="1" dirty="0">
+                <a:solidFill>
+                  <a:srgbClr val="085CE5"/>
+                </a:solidFill>
+                <a:latin typeface="Calibri" pitchFamily="34" charset="0"/>
+                <a:ea typeface="Calibri" pitchFamily="34" charset="-122"/>
+                <a:cs typeface="Calibri" pitchFamily="34" charset="-120"/>
+              </a:rPr>
+              <a:t>$8,000</a:t>
+            </a:r>
+            <a:endParaRPr lang="en-US" sz="1000" dirty="0"/>
+          </a:p>
+        </p:txBody>
+      </p:sp>
+      <p:sp>
+        <p:nvSpPr>
+          <p:cNvPr id="38" name="Shape 36"/>
+          <p:cNvSpPr/>
+          <p:nvPr/>
+        </p:nvSpPr>
+        <p:spPr>
+          <a:xfrm>
+            <a:off x="3566160" y="2139696"/>
+            <a:ext cx="1316736" cy="493776"/>
+          </a:xfrm>
+          <a:prstGeom prst="rect">
+            <a:avLst/>
+          </a:prstGeom>
+          <a:solidFill>
+            <a:srgbClr val="FFFFFF"/>
+          </a:solidFill>
+          <a:ln w="12700">
+            <a:solidFill>
+              <a:srgbClr val="E7ECF0"/>
+            </a:solidFill>
+            <a:prstDash val="solid"/>
+          </a:ln>
+        </p:spPr>
+      </p:sp>
+      <p:sp>
+        <p:nvSpPr>
+          <p:cNvPr id="39" name="Text 37"/>
+          <p:cNvSpPr/>
+          <p:nvPr/>
+        </p:nvSpPr>
+        <p:spPr>
+          <a:xfrm>
+            <a:off x="3566160" y="2139696"/>
+            <a:ext cx="1316736" cy="493776"/>
+          </a:xfrm>
+          <a:prstGeom prst="rect">
+            <a:avLst/>
+          </a:prstGeom>
+          <a:noFill/>
+          <a:ln/>
+        </p:spPr>
+        <p:txBody>
+          <a:bodyPr wrap="square" lIns="0" tIns="0" rIns="0" bIns="0" rtlCol="0" anchor="ctr"/>
+          <a:lstStyle/>
+          <a:p>
+            <a:pPr algn="ctr" indent="0" marL="0">
+              <a:buNone/>
+            </a:pPr>
+            <a:r>
+              <a:rPr lang="en-US" sz="1000" b="1" dirty="0">
+                <a:solidFill>
+                  <a:srgbClr val="085CE5"/>
+                </a:solidFill>
+                <a:latin typeface="Calibri" pitchFamily="34" charset="0"/>
+                <a:ea typeface="Calibri" pitchFamily="34" charset="-122"/>
+                <a:cs typeface="Calibri" pitchFamily="34" charset="-120"/>
+              </a:rPr>
+              <a:t>$12,000</a:t>
+            </a:r>
+            <a:endParaRPr lang="en-US" sz="1000" dirty="0"/>
+          </a:p>
+        </p:txBody>
+      </p:sp>
+      <p:sp>
+        <p:nvSpPr>
+          <p:cNvPr id="40" name="Shape 38"/>
+          <p:cNvSpPr/>
+          <p:nvPr/>
+        </p:nvSpPr>
+        <p:spPr>
+          <a:xfrm>
+            <a:off x="4919472" y="2139696"/>
+            <a:ext cx="1316736" cy="493776"/>
+          </a:xfrm>
+          <a:prstGeom prst="rect">
+            <a:avLst/>
+          </a:prstGeom>
+          <a:solidFill>
+            <a:srgbClr val="FFFFFF"/>
+          </a:solidFill>
+          <a:ln w="12700">
+            <a:solidFill>
+              <a:srgbClr val="E7ECF0"/>
+            </a:solidFill>
+            <a:prstDash val="solid"/>
+          </a:ln>
+        </p:spPr>
+      </p:sp>
+      <p:sp>
+        <p:nvSpPr>
+          <p:cNvPr id="41" name="Text 39"/>
+          <p:cNvSpPr/>
+          <p:nvPr/>
+        </p:nvSpPr>
+        <p:spPr>
+          <a:xfrm>
+            <a:off x="4919472" y="2139696"/>
+            <a:ext cx="1316736" cy="493776"/>
+          </a:xfrm>
+          <a:prstGeom prst="rect">
+            <a:avLst/>
+          </a:prstGeom>
+          <a:noFill/>
+          <a:ln/>
+        </p:spPr>
+        <p:txBody>
+          <a:bodyPr wrap="square" lIns="0" tIns="0" rIns="0" bIns="0" rtlCol="0" anchor="ctr"/>
+          <a:lstStyle/>
+          <a:p>
+            <a:pPr algn="ctr" indent="0" marL="0">
+              <a:buNone/>
+            </a:pPr>
+            <a:r>
+              <a:rPr lang="en-US" sz="1000" b="1" dirty="0">
+                <a:solidFill>
+                  <a:srgbClr val="085CE5"/>
+                </a:solidFill>
+                <a:latin typeface="Calibri" pitchFamily="34" charset="0"/>
+                <a:ea typeface="Calibri" pitchFamily="34" charset="-122"/>
+                <a:cs typeface="Calibri" pitchFamily="34" charset="-120"/>
+              </a:rPr>
+              <a:t>$22,000</a:t>
+            </a:r>
+            <a:endParaRPr lang="en-US" sz="1000" dirty="0"/>
+          </a:p>
+        </p:txBody>
+      </p:sp>
+      <p:sp>
+        <p:nvSpPr>
+          <p:cNvPr id="42" name="Shape 40"/>
+          <p:cNvSpPr/>
+          <p:nvPr/>
+        </p:nvSpPr>
+        <p:spPr>
+          <a:xfrm>
+            <a:off x="6272784" y="2139696"/>
+            <a:ext cx="1143000" cy="493776"/>
+          </a:xfrm>
+          <a:prstGeom prst="rect">
+            <a:avLst/>
+          </a:prstGeom>
+          <a:solidFill>
+            <a:srgbClr val="FFFFFF"/>
+          </a:solidFill>
+          <a:ln w="12700">
+            <a:solidFill>
+              <a:srgbClr val="E7ECF0"/>
+            </a:solidFill>
+            <a:prstDash val="solid"/>
+          </a:ln>
+        </p:spPr>
+      </p:sp>
+      <p:sp>
+        <p:nvSpPr>
+          <p:cNvPr id="43" name="Text 41"/>
+          <p:cNvSpPr/>
+          <p:nvPr/>
+        </p:nvSpPr>
+        <p:spPr>
+          <a:xfrm>
+            <a:off x="6272784" y="2139696"/>
+            <a:ext cx="1143000" cy="493776"/>
+          </a:xfrm>
+          <a:prstGeom prst="rect">
+            <a:avLst/>
+          </a:prstGeom>
+          <a:noFill/>
+          <a:ln/>
+        </p:spPr>
+        <p:txBody>
+          <a:bodyPr wrap="square" lIns="0" tIns="0" rIns="0" bIns="0" rtlCol="0" anchor="ctr"/>
+          <a:lstStyle/>
+          <a:p>
+            <a:pPr algn="ctr" indent="0" marL="0">
+              <a:buNone/>
+            </a:pPr>
+            <a:r>
+              <a:rPr lang="en-US" sz="1000" b="1" dirty="0">
+                <a:solidFill>
+                  <a:srgbClr val="085CE5"/>
+                </a:solidFill>
+                <a:latin typeface="Calibri" pitchFamily="34" charset="0"/>
+                <a:ea typeface="Calibri" pitchFamily="34" charset="-122"/>
+                <a:cs typeface="Calibri" pitchFamily="34" charset="-120"/>
+              </a:rPr>
+              <a:t>$35,000</a:t>
+            </a:r>
+            <a:endParaRPr lang="en-US" sz="1000" dirty="0"/>
+          </a:p>
+        </p:txBody>
+      </p:sp>
+      <p:sp>
+        <p:nvSpPr>
+          <p:cNvPr id="44" name="Shape 42"/>
+          <p:cNvSpPr/>
+          <p:nvPr/>
+        </p:nvSpPr>
+        <p:spPr>
+          <a:xfrm>
+            <a:off x="7452360" y="2139696"/>
+            <a:ext cx="1508760" cy="493776"/>
+          </a:xfrm>
+          <a:prstGeom prst="rect">
+            <a:avLst/>
+          </a:prstGeom>
+          <a:solidFill>
+            <a:srgbClr val="FFFFFF"/>
+          </a:solidFill>
+          <a:ln w="12700">
+            <a:solidFill>
+              <a:srgbClr val="E7ECF0"/>
+            </a:solidFill>
+            <a:prstDash val="solid"/>
+          </a:ln>
+        </p:spPr>
+      </p:sp>
+      <p:sp>
+        <p:nvSpPr>
+          <p:cNvPr id="45" name="Text 43"/>
+          <p:cNvSpPr/>
+          <p:nvPr/>
+        </p:nvSpPr>
+        <p:spPr>
+          <a:xfrm>
+            <a:off x="7452360" y="2176272"/>
+            <a:ext cx="1508760" cy="219456"/>
+          </a:xfrm>
+          <a:prstGeom prst="rect">
+            <a:avLst/>
+          </a:prstGeom>
+          <a:noFill/>
+          <a:ln/>
+        </p:spPr>
+        <p:txBody>
+          <a:bodyPr wrap="square" lIns="0" tIns="0" rIns="0" bIns="0" rtlCol="0" anchor="ctr"/>
+          <a:lstStyle/>
+          <a:p>
+            <a:pPr algn="ctr" indent="0" marL="0">
+              <a:buNone/>
+            </a:pPr>
+            <a:r>
+              <a:rPr lang="en-US" sz="950" b="1" dirty="0">
+                <a:solidFill>
+                  <a:srgbClr val="06185F"/>
+                </a:solidFill>
+                <a:latin typeface="Calibri" pitchFamily="34" charset="0"/>
+                <a:ea typeface="Calibri" pitchFamily="34" charset="-122"/>
+                <a:cs typeface="Calibri" pitchFamily="34" charset="-120"/>
+              </a:rPr>
+              <a:t>Q2 FY27</a:t>
+            </a:r>
+            <a:endParaRPr lang="en-US" sz="950" dirty="0"/>
+          </a:p>
+        </p:txBody>
+      </p:sp>
+      <p:sp>
+        <p:nvSpPr>
+          <p:cNvPr id="46" name="Text 44"/>
+          <p:cNvSpPr/>
+          <p:nvPr/>
+        </p:nvSpPr>
+        <p:spPr>
+          <a:xfrm>
+            <a:off x="7452360" y="2386584"/>
+            <a:ext cx="1508760" cy="219456"/>
+          </a:xfrm>
+          <a:prstGeom prst="rect">
+            <a:avLst/>
+          </a:prstGeom>
+          <a:noFill/>
+          <a:ln/>
+        </p:spPr>
+        <p:txBody>
+          <a:bodyPr wrap="square" lIns="0" tIns="0" rIns="0" bIns="0" rtlCol="0" anchor="ctr"/>
+          <a:lstStyle/>
+          <a:p>
+            <a:pPr algn="ctr" indent="0" marL="0">
+              <a:buNone/>
+            </a:pPr>
+            <a:r>
+              <a:rPr lang="en-US" sz="750" dirty="0">
+                <a:solidFill>
+                  <a:srgbClr val="575A5D"/>
+                </a:solidFill>
+                <a:latin typeface="Calibri" pitchFamily="34" charset="0"/>
+                <a:ea typeface="Calibri" pitchFamily="34" charset="-122"/>
+                <a:cs typeface="Calibri" pitchFamily="34" charset="-120"/>
+              </a:rPr>
+              <a:t>Universal · all FIs</a:t>
+            </a:r>
+            <a:endParaRPr lang="en-US" sz="750" dirty="0"/>
+          </a:p>
+        </p:txBody>
+      </p:sp>
+      <p:sp>
+        <p:nvSpPr>
+          <p:cNvPr id="47" name="Shape 45"/>
+          <p:cNvSpPr/>
+          <p:nvPr/>
+        </p:nvSpPr>
+        <p:spPr>
+          <a:xfrm>
+            <a:off x="320040" y="2633472"/>
+            <a:ext cx="73152" cy="493776"/>
+          </a:xfrm>
+          <a:prstGeom prst="rect">
+            <a:avLst/>
+          </a:prstGeom>
+          <a:solidFill>
+            <a:srgbClr val="0A52C4"/>
+          </a:solidFill>
+          <a:ln w="12700">
+            <a:solidFill>
+              <a:srgbClr val="0A52C4"/>
+            </a:solidFill>
+            <a:prstDash val="solid"/>
+          </a:ln>
+        </p:spPr>
+      </p:sp>
+      <p:sp>
+        <p:nvSpPr>
+          <p:cNvPr id="48" name="Shape 46"/>
+          <p:cNvSpPr/>
+          <p:nvPr/>
+        </p:nvSpPr>
+        <p:spPr>
+          <a:xfrm>
+            <a:off x="393192" y="2633472"/>
+            <a:ext cx="1755648" cy="493776"/>
+          </a:xfrm>
+          <a:prstGeom prst="rect">
+            <a:avLst/>
+          </a:prstGeom>
+          <a:solidFill>
+            <a:srgbClr val="F4F6FA"/>
+          </a:solidFill>
+          <a:ln w="12700">
+            <a:solidFill>
+              <a:srgbClr val="E7ECF0"/>
+            </a:solidFill>
+            <a:prstDash val="solid"/>
+          </a:ln>
+        </p:spPr>
+      </p:sp>
+      <p:sp>
+        <p:nvSpPr>
+          <p:cNvPr id="49" name="Text 47"/>
+          <p:cNvSpPr/>
+          <p:nvPr/>
+        </p:nvSpPr>
+        <p:spPr>
+          <a:xfrm>
+            <a:off x="448056" y="2633472"/>
+            <a:ext cx="1700784" cy="493776"/>
+          </a:xfrm>
+          <a:prstGeom prst="rect">
+            <a:avLst/>
+          </a:prstGeom>
+          <a:noFill/>
+          <a:ln/>
+        </p:spPr>
+        <p:txBody>
+          <a:bodyPr wrap="square" lIns="0" tIns="50800" rIns="0" bIns="0" rtlCol="0" anchor="ctr"/>
+          <a:lstStyle/>
+          <a:p>
+            <a:pPr indent="0" marL="0">
+              <a:buNone/>
+            </a:pPr>
+            <a:r>
+              <a:rPr lang="en-US" sz="950" b="1" dirty="0">
+                <a:solidFill>
+                  <a:srgbClr val="06185F"/>
+                </a:solidFill>
+                <a:latin typeface="Calibri" pitchFamily="34" charset="0"/>
+                <a:ea typeface="Calibri" pitchFamily="34" charset="-122"/>
+                <a:cs typeface="Calibri" pitchFamily="34" charset="-120"/>
+              </a:rPr>
+              <a:t>CommercialSignal</a:t>
+            </a:r>
+            <a:endParaRPr lang="en-US" sz="950" dirty="0"/>
+          </a:p>
+        </p:txBody>
+      </p:sp>
+      <p:sp>
+        <p:nvSpPr>
+          <p:cNvPr id="50" name="Shape 48"/>
+          <p:cNvSpPr/>
+          <p:nvPr/>
+        </p:nvSpPr>
+        <p:spPr>
+          <a:xfrm>
+            <a:off x="2194560" y="2633472"/>
+            <a:ext cx="1325880" cy="493776"/>
+          </a:xfrm>
+          <a:prstGeom prst="rect">
+            <a:avLst/>
+          </a:prstGeom>
+          <a:solidFill>
+            <a:srgbClr val="F4F6FA"/>
+          </a:solidFill>
+          <a:ln w="12700">
+            <a:solidFill>
+              <a:srgbClr val="E7ECF0"/>
+            </a:solidFill>
+            <a:prstDash val="solid"/>
+          </a:ln>
+        </p:spPr>
+      </p:sp>
+      <p:sp>
+        <p:nvSpPr>
+          <p:cNvPr id="51" name="Text 49"/>
+          <p:cNvSpPr/>
+          <p:nvPr/>
+        </p:nvSpPr>
+        <p:spPr>
+          <a:xfrm>
+            <a:off x="2194560" y="2633472"/>
+            <a:ext cx="1325880" cy="493776"/>
+          </a:xfrm>
+          <a:prstGeom prst="rect">
+            <a:avLst/>
+          </a:prstGeom>
+          <a:noFill/>
+          <a:ln/>
+        </p:spPr>
+        <p:txBody>
+          <a:bodyPr wrap="square" lIns="0" tIns="0" rIns="0" bIns="0" rtlCol="0" anchor="ctr"/>
+          <a:lstStyle/>
+          <a:p>
+            <a:pPr algn="ctr" indent="0" marL="0">
+              <a:buNone/>
+            </a:pPr>
+            <a:r>
+              <a:rPr lang="en-US" sz="1000" b="1" dirty="0">
+                <a:solidFill>
+                  <a:srgbClr val="085CE5"/>
+                </a:solidFill>
+                <a:latin typeface="Calibri" pitchFamily="34" charset="0"/>
+                <a:ea typeface="Calibri" pitchFamily="34" charset="-122"/>
+                <a:cs typeface="Calibri" pitchFamily="34" charset="-120"/>
+              </a:rPr>
+              <a:t>$6,000</a:t>
+            </a:r>
+            <a:endParaRPr lang="en-US" sz="1000" dirty="0"/>
+          </a:p>
+        </p:txBody>
+      </p:sp>
+      <p:sp>
+        <p:nvSpPr>
+          <p:cNvPr id="52" name="Shape 50"/>
+          <p:cNvSpPr/>
+          <p:nvPr/>
+        </p:nvSpPr>
+        <p:spPr>
+          <a:xfrm>
+            <a:off x="3566160" y="2633472"/>
+            <a:ext cx="1316736" cy="493776"/>
+          </a:xfrm>
+          <a:prstGeom prst="rect">
+            <a:avLst/>
+          </a:prstGeom>
+          <a:solidFill>
+            <a:srgbClr val="F4F6FA"/>
+          </a:solidFill>
+          <a:ln w="12700">
+            <a:solidFill>
+              <a:srgbClr val="E7ECF0"/>
+            </a:solidFill>
+            <a:prstDash val="solid"/>
+          </a:ln>
+        </p:spPr>
+      </p:sp>
+      <p:sp>
+        <p:nvSpPr>
+          <p:cNvPr id="53" name="Text 51"/>
+          <p:cNvSpPr/>
+          <p:nvPr/>
+        </p:nvSpPr>
+        <p:spPr>
+          <a:xfrm>
+            <a:off x="3566160" y="2633472"/>
+            <a:ext cx="1316736" cy="493776"/>
+          </a:xfrm>
+          <a:prstGeom prst="rect">
+            <a:avLst/>
+          </a:prstGeom>
+          <a:noFill/>
+          <a:ln/>
+        </p:spPr>
+        <p:txBody>
+          <a:bodyPr wrap="square" lIns="0" tIns="0" rIns="0" bIns="0" rtlCol="0" anchor="ctr"/>
+          <a:lstStyle/>
+          <a:p>
+            <a:pPr algn="ctr" indent="0" marL="0">
+              <a:buNone/>
+            </a:pPr>
+            <a:r>
+              <a:rPr lang="en-US" sz="1000" b="1" dirty="0">
+                <a:solidFill>
+                  <a:srgbClr val="085CE5"/>
+                </a:solidFill>
+                <a:latin typeface="Calibri" pitchFamily="34" charset="0"/>
+                <a:ea typeface="Calibri" pitchFamily="34" charset="-122"/>
+                <a:cs typeface="Calibri" pitchFamily="34" charset="-120"/>
+              </a:rPr>
+              <a:t>$10,000</a:t>
+            </a:r>
+            <a:endParaRPr lang="en-US" sz="1000" dirty="0"/>
+          </a:p>
+        </p:txBody>
+      </p:sp>
+      <p:sp>
+        <p:nvSpPr>
+          <p:cNvPr id="54" name="Shape 52"/>
+          <p:cNvSpPr/>
+          <p:nvPr/>
+        </p:nvSpPr>
+        <p:spPr>
+          <a:xfrm>
+            <a:off x="4919472" y="2633472"/>
+            <a:ext cx="1316736" cy="493776"/>
+          </a:xfrm>
+          <a:prstGeom prst="rect">
+            <a:avLst/>
+          </a:prstGeom>
+          <a:solidFill>
+            <a:srgbClr val="F4F6FA"/>
+          </a:solidFill>
+          <a:ln w="12700">
+            <a:solidFill>
+              <a:srgbClr val="E7ECF0"/>
+            </a:solidFill>
+            <a:prstDash val="solid"/>
+          </a:ln>
+        </p:spPr>
+      </p:sp>
+      <p:sp>
+        <p:nvSpPr>
+          <p:cNvPr id="55" name="Text 53"/>
+          <p:cNvSpPr/>
+          <p:nvPr/>
+        </p:nvSpPr>
+        <p:spPr>
+          <a:xfrm>
+            <a:off x="4919472" y="2633472"/>
+            <a:ext cx="1316736" cy="493776"/>
+          </a:xfrm>
+          <a:prstGeom prst="rect">
+            <a:avLst/>
+          </a:prstGeom>
+          <a:noFill/>
+          <a:ln/>
+        </p:spPr>
+        <p:txBody>
+          <a:bodyPr wrap="square" lIns="0" tIns="0" rIns="0" bIns="0" rtlCol="0" anchor="ctr"/>
+          <a:lstStyle/>
+          <a:p>
+            <a:pPr algn="ctr" indent="0" marL="0">
+              <a:buNone/>
+            </a:pPr>
+            <a:r>
+              <a:rPr lang="en-US" sz="1000" b="1" dirty="0">
+                <a:solidFill>
+                  <a:srgbClr val="085CE5"/>
+                </a:solidFill>
+                <a:latin typeface="Calibri" pitchFamily="34" charset="0"/>
+                <a:ea typeface="Calibri" pitchFamily="34" charset="-122"/>
+                <a:cs typeface="Calibri" pitchFamily="34" charset="-120"/>
+              </a:rPr>
+              <a:t>$18,000</a:t>
+            </a:r>
+            <a:endParaRPr lang="en-US" sz="1000" dirty="0"/>
+          </a:p>
+        </p:txBody>
+      </p:sp>
+      <p:sp>
+        <p:nvSpPr>
+          <p:cNvPr id="56" name="Shape 54"/>
+          <p:cNvSpPr/>
+          <p:nvPr/>
+        </p:nvSpPr>
+        <p:spPr>
+          <a:xfrm>
+            <a:off x="6272784" y="2633472"/>
+            <a:ext cx="1143000" cy="493776"/>
+          </a:xfrm>
+          <a:prstGeom prst="rect">
+            <a:avLst/>
+          </a:prstGeom>
+          <a:solidFill>
+            <a:srgbClr val="F4F6FA"/>
+          </a:solidFill>
+          <a:ln w="12700">
+            <a:solidFill>
+              <a:srgbClr val="E7ECF0"/>
+            </a:solidFill>
+            <a:prstDash val="solid"/>
+          </a:ln>
+        </p:spPr>
+      </p:sp>
+      <p:sp>
+        <p:nvSpPr>
+          <p:cNvPr id="57" name="Text 55"/>
+          <p:cNvSpPr/>
+          <p:nvPr/>
+        </p:nvSpPr>
+        <p:spPr>
+          <a:xfrm>
+            <a:off x="6272784" y="2633472"/>
+            <a:ext cx="1143000" cy="493776"/>
+          </a:xfrm>
+          <a:prstGeom prst="rect">
+            <a:avLst/>
+          </a:prstGeom>
+          <a:noFill/>
+          <a:ln/>
+        </p:spPr>
+        <p:txBody>
+          <a:bodyPr wrap="square" lIns="0" tIns="0" rIns="0" bIns="0" rtlCol="0" anchor="ctr"/>
+          <a:lstStyle/>
+          <a:p>
+            <a:pPr algn="ctr" indent="0" marL="0">
+              <a:buNone/>
+            </a:pPr>
+            <a:r>
+              <a:rPr lang="en-US" sz="1000" b="1" dirty="0">
+                <a:solidFill>
+                  <a:srgbClr val="085CE5"/>
+                </a:solidFill>
+                <a:latin typeface="Calibri" pitchFamily="34" charset="0"/>
+                <a:ea typeface="Calibri" pitchFamily="34" charset="-122"/>
+                <a:cs typeface="Calibri" pitchFamily="34" charset="-120"/>
+              </a:rPr>
+              <a:t>$28,000</a:t>
+            </a:r>
+            <a:endParaRPr lang="en-US" sz="1000" dirty="0"/>
+          </a:p>
+        </p:txBody>
+      </p:sp>
+      <p:sp>
+        <p:nvSpPr>
+          <p:cNvPr id="58" name="Shape 56"/>
+          <p:cNvSpPr/>
+          <p:nvPr/>
+        </p:nvSpPr>
+        <p:spPr>
+          <a:xfrm>
+            <a:off x="7452360" y="2633472"/>
+            <a:ext cx="1508760" cy="493776"/>
+          </a:xfrm>
+          <a:prstGeom prst="rect">
+            <a:avLst/>
+          </a:prstGeom>
+          <a:solidFill>
+            <a:srgbClr val="F4F6FA"/>
+          </a:solidFill>
+          <a:ln w="12700">
+            <a:solidFill>
+              <a:srgbClr val="E7ECF0"/>
+            </a:solidFill>
+            <a:prstDash val="solid"/>
+          </a:ln>
+        </p:spPr>
+      </p:sp>
+      <p:sp>
+        <p:nvSpPr>
+          <p:cNvPr id="59" name="Text 57"/>
+          <p:cNvSpPr/>
+          <p:nvPr/>
+        </p:nvSpPr>
+        <p:spPr>
+          <a:xfrm>
+            <a:off x="7452360" y="2670048"/>
+            <a:ext cx="1508760" cy="219456"/>
+          </a:xfrm>
+          <a:prstGeom prst="rect">
+            <a:avLst/>
+          </a:prstGeom>
+          <a:noFill/>
+          <a:ln/>
+        </p:spPr>
+        <p:txBody>
+          <a:bodyPr wrap="square" lIns="0" tIns="0" rIns="0" bIns="0" rtlCol="0" anchor="ctr"/>
+          <a:lstStyle/>
+          <a:p>
+            <a:pPr algn="ctr" indent="0" marL="0">
+              <a:buNone/>
+            </a:pPr>
+            <a:r>
+              <a:rPr lang="en-US" sz="950" b="1" dirty="0">
+                <a:solidFill>
+                  <a:srgbClr val="06185F"/>
+                </a:solidFill>
+                <a:latin typeface="Calibri" pitchFamily="34" charset="0"/>
+                <a:ea typeface="Calibri" pitchFamily="34" charset="-122"/>
+                <a:cs typeface="Calibri" pitchFamily="34" charset="-120"/>
+              </a:rPr>
+              <a:t>Q3 FY27</a:t>
+            </a:r>
+            <a:endParaRPr lang="en-US" sz="950" dirty="0"/>
+          </a:p>
+        </p:txBody>
+      </p:sp>
+      <p:sp>
+        <p:nvSpPr>
+          <p:cNvPr id="60" name="Text 58"/>
+          <p:cNvSpPr/>
+          <p:nvPr/>
+        </p:nvSpPr>
+        <p:spPr>
+          <a:xfrm>
+            <a:off x="7452360" y="2880360"/>
+            <a:ext cx="1508760" cy="219456"/>
+          </a:xfrm>
+          <a:prstGeom prst="rect">
+            <a:avLst/>
+          </a:prstGeom>
+          <a:noFill/>
+          <a:ln/>
+        </p:spPr>
+        <p:txBody>
+          <a:bodyPr wrap="square" lIns="0" tIns="0" rIns="0" bIns="0" rtlCol="0" anchor="ctr"/>
+          <a:lstStyle/>
+          <a:p>
+            <a:pPr algn="ctr" indent="0" marL="0">
+              <a:buNone/>
+            </a:pPr>
+            <a:r>
+              <a:rPr lang="en-US" sz="750" dirty="0">
+                <a:solidFill>
+                  <a:srgbClr val="575A5D"/>
+                </a:solidFill>
+                <a:latin typeface="Calibri" pitchFamily="34" charset="0"/>
+                <a:ea typeface="Calibri" pitchFamily="34" charset="-122"/>
+                <a:cs typeface="Calibri" pitchFamily="34" charset="-120"/>
+              </a:rPr>
+              <a:t>Universal · ACH data</a:t>
+            </a:r>
+            <a:endParaRPr lang="en-US" sz="750" dirty="0"/>
+          </a:p>
+        </p:txBody>
+      </p:sp>
+      <p:sp>
+        <p:nvSpPr>
+          <p:cNvPr id="61" name="Shape 59"/>
+          <p:cNvSpPr/>
+          <p:nvPr/>
+        </p:nvSpPr>
+        <p:spPr>
+          <a:xfrm>
+            <a:off x="320040" y="3127248"/>
+            <a:ext cx="73152" cy="493776"/>
+          </a:xfrm>
+          <a:prstGeom prst="rect">
+            <a:avLst/>
+          </a:prstGeom>
+          <a:solidFill>
+            <a:srgbClr val="0F3D8A"/>
+          </a:solidFill>
+          <a:ln w="12700">
+            <a:solidFill>
+              <a:srgbClr val="0F3D8A"/>
+            </a:solidFill>
+            <a:prstDash val="solid"/>
+          </a:ln>
+        </p:spPr>
+      </p:sp>
+      <p:sp>
+        <p:nvSpPr>
+          <p:cNvPr id="62" name="Shape 60"/>
+          <p:cNvSpPr/>
+          <p:nvPr/>
+        </p:nvSpPr>
+        <p:spPr>
+          <a:xfrm>
+            <a:off x="393192" y="3127248"/>
+            <a:ext cx="1755648" cy="493776"/>
+          </a:xfrm>
+          <a:prstGeom prst="rect">
+            <a:avLst/>
+          </a:prstGeom>
+          <a:solidFill>
+            <a:srgbClr val="FFFFFF"/>
+          </a:solidFill>
+          <a:ln w="12700">
+            <a:solidFill>
+              <a:srgbClr val="E7ECF0"/>
+            </a:solidFill>
+            <a:prstDash val="solid"/>
+          </a:ln>
+        </p:spPr>
+      </p:sp>
+      <p:sp>
+        <p:nvSpPr>
+          <p:cNvPr id="63" name="Text 61"/>
+          <p:cNvSpPr/>
+          <p:nvPr/>
+        </p:nvSpPr>
+        <p:spPr>
+          <a:xfrm>
+            <a:off x="448056" y="3127248"/>
+            <a:ext cx="1700784" cy="493776"/>
+          </a:xfrm>
+          <a:prstGeom prst="rect">
+            <a:avLst/>
+          </a:prstGeom>
+          <a:noFill/>
+          <a:ln/>
+        </p:spPr>
+        <p:txBody>
+          <a:bodyPr wrap="square" lIns="0" tIns="50800" rIns="0" bIns="0" rtlCol="0" anchor="ctr"/>
+          <a:lstStyle/>
+          <a:p>
+            <a:pPr indent="0" marL="0">
+              <a:buNone/>
+            </a:pPr>
+            <a:r>
+              <a:rPr lang="en-US" sz="950" b="1" dirty="0">
+                <a:solidFill>
+                  <a:srgbClr val="06185F"/>
+                </a:solidFill>
+                <a:latin typeface="Calibri" pitchFamily="34" charset="0"/>
+                <a:ea typeface="Calibri" pitchFamily="34" charset="-122"/>
+                <a:cs typeface="Calibri" pitchFamily="34" charset="-120"/>
+              </a:rPr>
+              <a:t>Gen. Wealth Deflection</a:t>
+            </a:r>
+            <a:endParaRPr lang="en-US" sz="950" dirty="0"/>
+          </a:p>
+        </p:txBody>
+      </p:sp>
+      <p:sp>
+        <p:nvSpPr>
+          <p:cNvPr id="64" name="Shape 62"/>
+          <p:cNvSpPr/>
+          <p:nvPr/>
+        </p:nvSpPr>
+        <p:spPr>
+          <a:xfrm>
+            <a:off x="2194560" y="3127248"/>
+            <a:ext cx="1325880" cy="493776"/>
+          </a:xfrm>
+          <a:prstGeom prst="rect">
+            <a:avLst/>
+          </a:prstGeom>
+          <a:solidFill>
+            <a:srgbClr val="FFFFFF"/>
+          </a:solidFill>
+          <a:ln w="12700">
+            <a:solidFill>
+              <a:srgbClr val="E7ECF0"/>
+            </a:solidFill>
+            <a:prstDash val="solid"/>
+          </a:ln>
+        </p:spPr>
+      </p:sp>
+      <p:sp>
+        <p:nvSpPr>
+          <p:cNvPr id="65" name="Text 63"/>
+          <p:cNvSpPr/>
+          <p:nvPr/>
+        </p:nvSpPr>
+        <p:spPr>
+          <a:xfrm>
+            <a:off x="2194560" y="3127248"/>
+            <a:ext cx="1325880" cy="493776"/>
+          </a:xfrm>
+          <a:prstGeom prst="rect">
+            <a:avLst/>
+          </a:prstGeom>
+          <a:noFill/>
+          <a:ln/>
+        </p:spPr>
+        <p:txBody>
+          <a:bodyPr wrap="square" lIns="0" tIns="0" rIns="0" bIns="0" rtlCol="0" anchor="ctr"/>
+          <a:lstStyle/>
+          <a:p>
+            <a:pPr algn="ctr" indent="0" marL="0">
+              <a:buNone/>
+            </a:pPr>
+            <a:r>
+              <a:rPr lang="en-US" sz="1000" b="1" dirty="0">
+                <a:solidFill>
+                  <a:srgbClr val="085CE5"/>
+                </a:solidFill>
+                <a:latin typeface="Calibri" pitchFamily="34" charset="0"/>
+                <a:ea typeface="Calibri" pitchFamily="34" charset="-122"/>
+                <a:cs typeface="Calibri" pitchFamily="34" charset="-120"/>
+              </a:rPr>
+              <a:t>$8,000</a:t>
+            </a:r>
+            <a:endParaRPr lang="en-US" sz="1000" dirty="0"/>
+          </a:p>
+        </p:txBody>
+      </p:sp>
+      <p:sp>
+        <p:nvSpPr>
+          <p:cNvPr id="66" name="Shape 64"/>
+          <p:cNvSpPr/>
+          <p:nvPr/>
+        </p:nvSpPr>
+        <p:spPr>
+          <a:xfrm>
+            <a:off x="3566160" y="3127248"/>
+            <a:ext cx="1316736" cy="493776"/>
+          </a:xfrm>
+          <a:prstGeom prst="rect">
+            <a:avLst/>
+          </a:prstGeom>
+          <a:solidFill>
+            <a:srgbClr val="FFFFFF"/>
+          </a:solidFill>
+          <a:ln w="12700">
+            <a:solidFill>
+              <a:srgbClr val="E7ECF0"/>
+            </a:solidFill>
+            <a:prstDash val="solid"/>
+          </a:ln>
+        </p:spPr>
+      </p:sp>
+      <p:sp>
+        <p:nvSpPr>
+          <p:cNvPr id="67" name="Text 65"/>
+          <p:cNvSpPr/>
+          <p:nvPr/>
+        </p:nvSpPr>
+        <p:spPr>
+          <a:xfrm>
+            <a:off x="3566160" y="3127248"/>
+            <a:ext cx="1316736" cy="493776"/>
+          </a:xfrm>
+          <a:prstGeom prst="rect">
+            <a:avLst/>
+          </a:prstGeom>
+          <a:noFill/>
+          <a:ln/>
+        </p:spPr>
+        <p:txBody>
+          <a:bodyPr wrap="square" lIns="0" tIns="0" rIns="0" bIns="0" rtlCol="0" anchor="ctr"/>
+          <a:lstStyle/>
+          <a:p>
+            <a:pPr algn="ctr" indent="0" marL="0">
+              <a:buNone/>
+            </a:pPr>
+            <a:r>
+              <a:rPr lang="en-US" sz="1000" b="1" dirty="0">
+                <a:solidFill>
+                  <a:srgbClr val="085CE5"/>
+                </a:solidFill>
+                <a:latin typeface="Calibri" pitchFamily="34" charset="0"/>
+                <a:ea typeface="Calibri" pitchFamily="34" charset="-122"/>
+                <a:cs typeface="Calibri" pitchFamily="34" charset="-120"/>
+              </a:rPr>
+              <a:t>$12,000</a:t>
+            </a:r>
+            <a:endParaRPr lang="en-US" sz="1000" dirty="0"/>
+          </a:p>
+        </p:txBody>
+      </p:sp>
+      <p:sp>
+        <p:nvSpPr>
+          <p:cNvPr id="68" name="Shape 66"/>
+          <p:cNvSpPr/>
+          <p:nvPr/>
+        </p:nvSpPr>
+        <p:spPr>
+          <a:xfrm>
+            <a:off x="4919472" y="3127248"/>
+            <a:ext cx="1316736" cy="493776"/>
+          </a:xfrm>
+          <a:prstGeom prst="rect">
+            <a:avLst/>
+          </a:prstGeom>
+          <a:solidFill>
+            <a:srgbClr val="FFFFFF"/>
+          </a:solidFill>
+          <a:ln w="12700">
+            <a:solidFill>
+              <a:srgbClr val="E7ECF0"/>
+            </a:solidFill>
+            <a:prstDash val="solid"/>
+          </a:ln>
+        </p:spPr>
+      </p:sp>
+      <p:sp>
+        <p:nvSpPr>
+          <p:cNvPr id="69" name="Text 67"/>
+          <p:cNvSpPr/>
+          <p:nvPr/>
+        </p:nvSpPr>
+        <p:spPr>
+          <a:xfrm>
+            <a:off x="4919472" y="3127248"/>
+            <a:ext cx="1316736" cy="493776"/>
+          </a:xfrm>
+          <a:prstGeom prst="rect">
+            <a:avLst/>
+          </a:prstGeom>
+          <a:noFill/>
+          <a:ln/>
+        </p:spPr>
+        <p:txBody>
+          <a:bodyPr wrap="square" lIns="0" tIns="0" rIns="0" bIns="0" rtlCol="0" anchor="ctr"/>
+          <a:lstStyle/>
+          <a:p>
+            <a:pPr algn="ctr" indent="0" marL="0">
+              <a:buNone/>
+            </a:pPr>
+            <a:r>
+              <a:rPr lang="en-US" sz="1000" b="1" dirty="0">
+                <a:solidFill>
+                  <a:srgbClr val="085CE5"/>
+                </a:solidFill>
+                <a:latin typeface="Calibri" pitchFamily="34" charset="0"/>
+                <a:ea typeface="Calibri" pitchFamily="34" charset="-122"/>
+                <a:cs typeface="Calibri" pitchFamily="34" charset="-120"/>
+              </a:rPr>
+              <a:t>$20,000</a:t>
+            </a:r>
+            <a:endParaRPr lang="en-US" sz="1000" dirty="0"/>
+          </a:p>
+        </p:txBody>
+      </p:sp>
+      <p:sp>
+        <p:nvSpPr>
+          <p:cNvPr id="70" name="Shape 68"/>
+          <p:cNvSpPr/>
+          <p:nvPr/>
+        </p:nvSpPr>
+        <p:spPr>
+          <a:xfrm>
+            <a:off x="6272784" y="3127248"/>
+            <a:ext cx="1143000" cy="493776"/>
+          </a:xfrm>
+          <a:prstGeom prst="rect">
+            <a:avLst/>
+          </a:prstGeom>
+          <a:solidFill>
+            <a:srgbClr val="FFFFFF"/>
+          </a:solidFill>
+          <a:ln w="12700">
+            <a:solidFill>
+              <a:srgbClr val="E7ECF0"/>
+            </a:solidFill>
+            <a:prstDash val="solid"/>
+          </a:ln>
+        </p:spPr>
+      </p:sp>
+      <p:sp>
+        <p:nvSpPr>
+          <p:cNvPr id="71" name="Text 69"/>
+          <p:cNvSpPr/>
+          <p:nvPr/>
+        </p:nvSpPr>
+        <p:spPr>
+          <a:xfrm>
+            <a:off x="6272784" y="3127248"/>
+            <a:ext cx="1143000" cy="493776"/>
+          </a:xfrm>
+          <a:prstGeom prst="rect">
+            <a:avLst/>
+          </a:prstGeom>
+          <a:noFill/>
+          <a:ln/>
+        </p:spPr>
+        <p:txBody>
+          <a:bodyPr wrap="square" lIns="0" tIns="0" rIns="0" bIns="0" rtlCol="0" anchor="ctr"/>
+          <a:lstStyle/>
+          <a:p>
+            <a:pPr algn="ctr" indent="0" marL="0">
+              <a:buNone/>
+            </a:pPr>
+            <a:r>
+              <a:rPr lang="en-US" sz="1000" b="1" dirty="0">
+                <a:solidFill>
+                  <a:srgbClr val="085CE5"/>
+                </a:solidFill>
+                <a:latin typeface="Calibri" pitchFamily="34" charset="0"/>
+                <a:ea typeface="Calibri" pitchFamily="34" charset="-122"/>
+                <a:cs typeface="Calibri" pitchFamily="34" charset="-120"/>
+              </a:rPr>
+              <a:t>$30,000</a:t>
+            </a:r>
+            <a:endParaRPr lang="en-US" sz="1000" dirty="0"/>
+          </a:p>
+        </p:txBody>
+      </p:sp>
+      <p:sp>
+        <p:nvSpPr>
+          <p:cNvPr id="72" name="Shape 70"/>
+          <p:cNvSpPr/>
+          <p:nvPr/>
+        </p:nvSpPr>
+        <p:spPr>
+          <a:xfrm>
+            <a:off x="7452360" y="3127248"/>
+            <a:ext cx="1508760" cy="493776"/>
+          </a:xfrm>
+          <a:prstGeom prst="rect">
+            <a:avLst/>
+          </a:prstGeom>
+          <a:solidFill>
+            <a:srgbClr val="FFFFFF"/>
+          </a:solidFill>
+          <a:ln w="12700">
+            <a:solidFill>
+              <a:srgbClr val="E7ECF0"/>
+            </a:solidFill>
+            <a:prstDash val="solid"/>
+          </a:ln>
+        </p:spPr>
+      </p:sp>
+      <p:sp>
+        <p:nvSpPr>
+          <p:cNvPr id="73" name="Text 71"/>
+          <p:cNvSpPr/>
+          <p:nvPr/>
+        </p:nvSpPr>
+        <p:spPr>
+          <a:xfrm>
+            <a:off x="7452360" y="3163824"/>
+            <a:ext cx="1508760" cy="219456"/>
+          </a:xfrm>
+          <a:prstGeom prst="rect">
+            <a:avLst/>
+          </a:prstGeom>
+          <a:noFill/>
+          <a:ln/>
+        </p:spPr>
+        <p:txBody>
+          <a:bodyPr wrap="square" lIns="0" tIns="0" rIns="0" bIns="0" rtlCol="0" anchor="ctr"/>
+          <a:lstStyle/>
+          <a:p>
+            <a:pPr algn="ctr" indent="0" marL="0">
+              <a:buNone/>
+            </a:pPr>
+            <a:r>
+              <a:rPr lang="en-US" sz="950" b="1" dirty="0">
+                <a:solidFill>
+                  <a:srgbClr val="06185F"/>
+                </a:solidFill>
+                <a:latin typeface="Calibri" pitchFamily="34" charset="0"/>
+                <a:ea typeface="Calibri" pitchFamily="34" charset="-122"/>
+                <a:cs typeface="Calibri" pitchFamily="34" charset="-120"/>
+              </a:rPr>
+              <a:t>Q1 FY28</a:t>
+            </a:r>
+            <a:endParaRPr lang="en-US" sz="950" dirty="0"/>
+          </a:p>
+        </p:txBody>
+      </p:sp>
+      <p:sp>
+        <p:nvSpPr>
+          <p:cNvPr id="74" name="Text 72"/>
+          <p:cNvSpPr/>
+          <p:nvPr/>
+        </p:nvSpPr>
+        <p:spPr>
+          <a:xfrm>
+            <a:off x="7452360" y="3374136"/>
+            <a:ext cx="1508760" cy="219456"/>
+          </a:xfrm>
+          <a:prstGeom prst="rect">
+            <a:avLst/>
+          </a:prstGeom>
+          <a:noFill/>
+          <a:ln/>
+        </p:spPr>
+        <p:txBody>
+          <a:bodyPr wrap="square" lIns="0" tIns="0" rIns="0" bIns="0" rtlCol="0" anchor="ctr"/>
+          <a:lstStyle/>
+          <a:p>
+            <a:pPr algn="ctr" indent="0" marL="0">
+              <a:buNone/>
+            </a:pPr>
+            <a:r>
+              <a:rPr lang="en-US" sz="750" dirty="0">
+                <a:solidFill>
+                  <a:srgbClr val="575A5D"/>
+                </a:solidFill>
+                <a:latin typeface="Calibri" pitchFamily="34" charset="0"/>
+                <a:ea typeface="Calibri" pitchFamily="34" charset="-122"/>
+                <a:cs typeface="Calibri" pitchFamily="34" charset="-120"/>
+              </a:rPr>
+              <a:t>Requires core+</a:t>
+            </a:r>
+            <a:endParaRPr lang="en-US" sz="750" dirty="0"/>
+          </a:p>
+          <a:p>
+            <a:pPr algn="ctr" indent="0" marL="0">
+              <a:buNone/>
+            </a:pPr>
+            <a:r>
+              <a:rPr lang="en-US" sz="750" dirty="0">
+                <a:solidFill>
+                  <a:srgbClr val="575A5D"/>
+                </a:solidFill>
+                <a:latin typeface="Calibri" pitchFamily="34" charset="0"/>
+                <a:ea typeface="Calibri" pitchFamily="34" charset="-122"/>
+                <a:cs typeface="Calibri" pitchFamily="34" charset="-120"/>
+              </a:rPr>
+              <a:t>household data</a:t>
+            </a:r>
+            <a:endParaRPr lang="en-US" sz="750" dirty="0"/>
+          </a:p>
+        </p:txBody>
+      </p:sp>
+      <p:sp>
+        <p:nvSpPr>
+          <p:cNvPr id="75" name="Shape 73"/>
+          <p:cNvSpPr/>
+          <p:nvPr/>
+        </p:nvSpPr>
+        <p:spPr>
+          <a:xfrm>
+            <a:off x="320040" y="3621024"/>
+            <a:ext cx="73152" cy="493776"/>
+          </a:xfrm>
+          <a:prstGeom prst="rect">
+            <a:avLst/>
+          </a:prstGeom>
+          <a:solidFill>
+            <a:srgbClr val="575A5D"/>
+          </a:solidFill>
+          <a:ln w="12700">
+            <a:solidFill>
+              <a:srgbClr val="575A5D"/>
+            </a:solidFill>
+            <a:prstDash val="solid"/>
+          </a:ln>
+        </p:spPr>
+      </p:sp>
+      <p:sp>
+        <p:nvSpPr>
+          <p:cNvPr id="76" name="Shape 74"/>
+          <p:cNvSpPr/>
+          <p:nvPr/>
+        </p:nvSpPr>
+        <p:spPr>
+          <a:xfrm>
+            <a:off x="393192" y="3621024"/>
+            <a:ext cx="1755648" cy="493776"/>
+          </a:xfrm>
+          <a:prstGeom prst="rect">
+            <a:avLst/>
+          </a:prstGeom>
+          <a:solidFill>
+            <a:srgbClr val="F4F6FA"/>
+          </a:solidFill>
+          <a:ln w="12700">
+            <a:solidFill>
+              <a:srgbClr val="E7ECF0"/>
+            </a:solidFill>
+            <a:prstDash val="solid"/>
+          </a:ln>
+        </p:spPr>
+      </p:sp>
+      <p:sp>
+        <p:nvSpPr>
+          <p:cNvPr id="77" name="Text 75"/>
+          <p:cNvSpPr/>
+          <p:nvPr/>
+        </p:nvSpPr>
+        <p:spPr>
+          <a:xfrm>
+            <a:off x="448056" y="3621024"/>
+            <a:ext cx="1700784" cy="493776"/>
+          </a:xfrm>
+          <a:prstGeom prst="rect">
+            <a:avLst/>
+          </a:prstGeom>
+          <a:noFill/>
+          <a:ln/>
+        </p:spPr>
+        <p:txBody>
+          <a:bodyPr wrap="square" lIns="0" tIns="50800" rIns="0" bIns="0" rtlCol="0" anchor="ctr"/>
+          <a:lstStyle/>
+          <a:p>
+            <a:pPr indent="0" marL="0">
+              <a:buNone/>
+            </a:pPr>
+            <a:r>
+              <a:rPr lang="en-US" sz="950" b="1" dirty="0">
+                <a:solidFill>
+                  <a:srgbClr val="06185F"/>
+                </a:solidFill>
+                <a:latin typeface="Calibri" pitchFamily="34" charset="0"/>
+                <a:ea typeface="Calibri" pitchFamily="34" charset="-122"/>
+                <a:cs typeface="Calibri" pitchFamily="34" charset="-120"/>
+              </a:rPr>
+              <a:t>Anomaly Detection</a:t>
+            </a:r>
+            <a:endParaRPr lang="en-US" sz="950" dirty="0"/>
+          </a:p>
+        </p:txBody>
+      </p:sp>
+      <p:sp>
+        <p:nvSpPr>
+          <p:cNvPr id="78" name="Shape 76"/>
+          <p:cNvSpPr/>
+          <p:nvPr/>
+        </p:nvSpPr>
+        <p:spPr>
+          <a:xfrm>
+            <a:off x="2194560" y="3621024"/>
+            <a:ext cx="1325880" cy="493776"/>
+          </a:xfrm>
+          <a:prstGeom prst="rect">
+            <a:avLst/>
+          </a:prstGeom>
+          <a:solidFill>
+            <a:srgbClr val="F4F6FA"/>
+          </a:solidFill>
+          <a:ln w="12700">
+            <a:solidFill>
+              <a:srgbClr val="E7ECF0"/>
+            </a:solidFill>
+            <a:prstDash val="solid"/>
+          </a:ln>
+        </p:spPr>
+      </p:sp>
+      <p:sp>
+        <p:nvSpPr>
+          <p:cNvPr id="79" name="Text 77"/>
+          <p:cNvSpPr/>
+          <p:nvPr/>
+        </p:nvSpPr>
+        <p:spPr>
+          <a:xfrm>
+            <a:off x="2194560" y="3621024"/>
+            <a:ext cx="1325880" cy="493776"/>
+          </a:xfrm>
+          <a:prstGeom prst="rect">
+            <a:avLst/>
+          </a:prstGeom>
+          <a:noFill/>
+          <a:ln/>
+        </p:spPr>
+        <p:txBody>
+          <a:bodyPr wrap="square" lIns="0" tIns="0" rIns="0" bIns="0" rtlCol="0" anchor="ctr"/>
+          <a:lstStyle/>
+          <a:p>
+            <a:pPr algn="ctr" indent="0" marL="0">
+              <a:buNone/>
+            </a:pPr>
+            <a:r>
+              <a:rPr lang="en-US" sz="1000" b="1" dirty="0">
+                <a:solidFill>
+                  <a:srgbClr val="085CE5"/>
+                </a:solidFill>
+                <a:latin typeface="Calibri" pitchFamily="34" charset="0"/>
+                <a:ea typeface="Calibri" pitchFamily="34" charset="-122"/>
+                <a:cs typeface="Calibri" pitchFamily="34" charset="-120"/>
+              </a:rPr>
+              <a:t>$9,000</a:t>
+            </a:r>
+            <a:endParaRPr lang="en-US" sz="1000" dirty="0"/>
+          </a:p>
+        </p:txBody>
+      </p:sp>
+      <p:sp>
+        <p:nvSpPr>
+          <p:cNvPr id="80" name="Shape 78"/>
+          <p:cNvSpPr/>
+          <p:nvPr/>
+        </p:nvSpPr>
+        <p:spPr>
+          <a:xfrm>
+            <a:off x="3566160" y="3621024"/>
+            <a:ext cx="1316736" cy="493776"/>
+          </a:xfrm>
+          <a:prstGeom prst="rect">
+            <a:avLst/>
+          </a:prstGeom>
+          <a:solidFill>
+            <a:srgbClr val="F4F6FA"/>
+          </a:solidFill>
+          <a:ln w="12700">
+            <a:solidFill>
+              <a:srgbClr val="E7ECF0"/>
+            </a:solidFill>
+            <a:prstDash val="solid"/>
+          </a:ln>
+        </p:spPr>
+      </p:sp>
+      <p:sp>
+        <p:nvSpPr>
+          <p:cNvPr id="81" name="Text 79"/>
+          <p:cNvSpPr/>
+          <p:nvPr/>
+        </p:nvSpPr>
+        <p:spPr>
+          <a:xfrm>
+            <a:off x="3566160" y="3621024"/>
+            <a:ext cx="1316736" cy="493776"/>
+          </a:xfrm>
+          <a:prstGeom prst="rect">
+            <a:avLst/>
+          </a:prstGeom>
+          <a:noFill/>
+          <a:ln/>
+        </p:spPr>
+        <p:txBody>
+          <a:bodyPr wrap="square" lIns="0" tIns="0" rIns="0" bIns="0" rtlCol="0" anchor="ctr"/>
+          <a:lstStyle/>
+          <a:p>
+            <a:pPr algn="ctr" indent="0" marL="0">
+              <a:buNone/>
+            </a:pPr>
+            <a:r>
+              <a:rPr lang="en-US" sz="1000" b="1" dirty="0">
+                <a:solidFill>
+                  <a:srgbClr val="085CE5"/>
+                </a:solidFill>
+                <a:latin typeface="Calibri" pitchFamily="34" charset="0"/>
+                <a:ea typeface="Calibri" pitchFamily="34" charset="-122"/>
+                <a:cs typeface="Calibri" pitchFamily="34" charset="-120"/>
+              </a:rPr>
+              <a:t>$14,000</a:t>
+            </a:r>
+            <a:endParaRPr lang="en-US" sz="1000" dirty="0"/>
+          </a:p>
+        </p:txBody>
+      </p:sp>
+      <p:sp>
+        <p:nvSpPr>
+          <p:cNvPr id="82" name="Shape 80"/>
+          <p:cNvSpPr/>
+          <p:nvPr/>
+        </p:nvSpPr>
+        <p:spPr>
+          <a:xfrm>
+            <a:off x="4919472" y="3621024"/>
+            <a:ext cx="1316736" cy="493776"/>
+          </a:xfrm>
+          <a:prstGeom prst="rect">
+            <a:avLst/>
+          </a:prstGeom>
+          <a:solidFill>
+            <a:srgbClr val="F4F6FA"/>
+          </a:solidFill>
+          <a:ln w="12700">
+            <a:solidFill>
+              <a:srgbClr val="E7ECF0"/>
+            </a:solidFill>
+            <a:prstDash val="solid"/>
+          </a:ln>
+        </p:spPr>
+      </p:sp>
+      <p:sp>
+        <p:nvSpPr>
+          <p:cNvPr id="83" name="Text 81"/>
+          <p:cNvSpPr/>
+          <p:nvPr/>
+        </p:nvSpPr>
+        <p:spPr>
+          <a:xfrm>
+            <a:off x="4919472" y="3621024"/>
+            <a:ext cx="1316736" cy="493776"/>
+          </a:xfrm>
+          <a:prstGeom prst="rect">
+            <a:avLst/>
+          </a:prstGeom>
+          <a:noFill/>
+          <a:ln/>
+        </p:spPr>
+        <p:txBody>
+          <a:bodyPr wrap="square" lIns="0" tIns="0" rIns="0" bIns="0" rtlCol="0" anchor="ctr"/>
+          <a:lstStyle/>
+          <a:p>
+            <a:pPr algn="ctr" indent="0" marL="0">
+              <a:buNone/>
+            </a:pPr>
+            <a:r>
+              <a:rPr lang="en-US" sz="1000" b="1" dirty="0">
+                <a:solidFill>
+                  <a:srgbClr val="085CE5"/>
+                </a:solidFill>
+                <a:latin typeface="Calibri" pitchFamily="34" charset="0"/>
+                <a:ea typeface="Calibri" pitchFamily="34" charset="-122"/>
+                <a:cs typeface="Calibri" pitchFamily="34" charset="-120"/>
+              </a:rPr>
+              <a:t>$24,000</a:t>
+            </a:r>
+            <a:endParaRPr lang="en-US" sz="1000" dirty="0"/>
+          </a:p>
+        </p:txBody>
+      </p:sp>
+      <p:sp>
+        <p:nvSpPr>
+          <p:cNvPr id="84" name="Shape 82"/>
+          <p:cNvSpPr/>
+          <p:nvPr/>
+        </p:nvSpPr>
+        <p:spPr>
+          <a:xfrm>
+            <a:off x="6272784" y="3621024"/>
+            <a:ext cx="1143000" cy="493776"/>
+          </a:xfrm>
+          <a:prstGeom prst="rect">
+            <a:avLst/>
+          </a:prstGeom>
+          <a:solidFill>
+            <a:srgbClr val="F4F6FA"/>
+          </a:solidFill>
+          <a:ln w="12700">
+            <a:solidFill>
+              <a:srgbClr val="E7ECF0"/>
+            </a:solidFill>
+            <a:prstDash val="solid"/>
+          </a:ln>
+        </p:spPr>
+      </p:sp>
+      <p:sp>
+        <p:nvSpPr>
+          <p:cNvPr id="85" name="Text 83"/>
+          <p:cNvSpPr/>
+          <p:nvPr/>
+        </p:nvSpPr>
+        <p:spPr>
+          <a:xfrm>
+            <a:off x="6272784" y="3621024"/>
+            <a:ext cx="1143000" cy="493776"/>
+          </a:xfrm>
+          <a:prstGeom prst="rect">
+            <a:avLst/>
+          </a:prstGeom>
+          <a:noFill/>
+          <a:ln/>
+        </p:spPr>
+        <p:txBody>
+          <a:bodyPr wrap="square" lIns="0" tIns="0" rIns="0" bIns="0" rtlCol="0" anchor="ctr"/>
+          <a:lstStyle/>
+          <a:p>
+            <a:pPr algn="ctr" indent="0" marL="0">
+              <a:buNone/>
+            </a:pPr>
+            <a:r>
+              <a:rPr lang="en-US" sz="1000" b="1" dirty="0">
+                <a:solidFill>
+                  <a:srgbClr val="085CE5"/>
+                </a:solidFill>
+                <a:latin typeface="Calibri" pitchFamily="34" charset="0"/>
+                <a:ea typeface="Calibri" pitchFamily="34" charset="-122"/>
+                <a:cs typeface="Calibri" pitchFamily="34" charset="-120"/>
+              </a:rPr>
+              <a:t>$40,000</a:t>
+            </a:r>
+            <a:endParaRPr lang="en-US" sz="1000" dirty="0"/>
+          </a:p>
+        </p:txBody>
+      </p:sp>
+      <p:sp>
+        <p:nvSpPr>
+          <p:cNvPr id="86" name="Shape 84"/>
+          <p:cNvSpPr/>
+          <p:nvPr/>
+        </p:nvSpPr>
+        <p:spPr>
+          <a:xfrm>
+            <a:off x="7452360" y="3621024"/>
+            <a:ext cx="1508760" cy="493776"/>
+          </a:xfrm>
+          <a:prstGeom prst="rect">
+            <a:avLst/>
+          </a:prstGeom>
+          <a:solidFill>
+            <a:srgbClr val="F4F6FA"/>
+          </a:solidFill>
+          <a:ln w="12700">
+            <a:solidFill>
+              <a:srgbClr val="E7ECF0"/>
+            </a:solidFill>
+            <a:prstDash val="solid"/>
+          </a:ln>
+        </p:spPr>
+      </p:sp>
+      <p:sp>
+        <p:nvSpPr>
+          <p:cNvPr id="87" name="Text 85"/>
+          <p:cNvSpPr/>
+          <p:nvPr/>
+        </p:nvSpPr>
+        <p:spPr>
+          <a:xfrm>
+            <a:off x="7452360" y="3657600"/>
+            <a:ext cx="1508760" cy="219456"/>
+          </a:xfrm>
+          <a:prstGeom prst="rect">
+            <a:avLst/>
+          </a:prstGeom>
+          <a:noFill/>
+          <a:ln/>
+        </p:spPr>
+        <p:txBody>
+          <a:bodyPr wrap="square" lIns="0" tIns="0" rIns="0" bIns="0" rtlCol="0" anchor="ctr"/>
+          <a:lstStyle/>
+          <a:p>
+            <a:pPr algn="ctr" indent="0" marL="0">
+              <a:buNone/>
+            </a:pPr>
+            <a:r>
+              <a:rPr lang="en-US" sz="950" b="1" dirty="0">
+                <a:solidFill>
+                  <a:srgbClr val="06185F"/>
+                </a:solidFill>
+                <a:latin typeface="Calibri" pitchFamily="34" charset="0"/>
+                <a:ea typeface="Calibri" pitchFamily="34" charset="-122"/>
+                <a:cs typeface="Calibri" pitchFamily="34" charset="-120"/>
+              </a:rPr>
+              <a:t>Q2 FY28</a:t>
+            </a:r>
+            <a:endParaRPr lang="en-US" sz="950" dirty="0"/>
+          </a:p>
+        </p:txBody>
+      </p:sp>
+      <p:sp>
+        <p:nvSpPr>
+          <p:cNvPr id="88" name="Text 86"/>
+          <p:cNvSpPr/>
+          <p:nvPr/>
+        </p:nvSpPr>
+        <p:spPr>
+          <a:xfrm>
+            <a:off x="7452360" y="3867912"/>
+            <a:ext cx="1508760" cy="219456"/>
+          </a:xfrm>
+          <a:prstGeom prst="rect">
+            <a:avLst/>
+          </a:prstGeom>
+          <a:noFill/>
+          <a:ln/>
+        </p:spPr>
+        <p:txBody>
+          <a:bodyPr wrap="square" lIns="0" tIns="0" rIns="0" bIns="0" rtlCol="0" anchor="ctr"/>
+          <a:lstStyle/>
+          <a:p>
+            <a:pPr algn="ctr" indent="0" marL="0">
+              <a:buNone/>
+            </a:pPr>
+            <a:r>
+              <a:rPr lang="en-US" sz="750" dirty="0">
+                <a:solidFill>
+                  <a:srgbClr val="575A5D"/>
+                </a:solidFill>
+                <a:latin typeface="Calibri" pitchFamily="34" charset="0"/>
+                <a:ea typeface="Calibri" pitchFamily="34" charset="-122"/>
+                <a:cs typeface="Calibri" pitchFamily="34" charset="-120"/>
+              </a:rPr>
+              <a:t>Phase 3 · real-time</a:t>
+            </a:r>
+            <a:endParaRPr lang="en-US" sz="750" dirty="0"/>
+          </a:p>
+          <a:p>
+            <a:pPr algn="ctr" indent="0" marL="0">
+              <a:buNone/>
+            </a:pPr>
+            <a:r>
+              <a:rPr lang="en-US" sz="750" dirty="0">
+                <a:solidFill>
+                  <a:srgbClr val="575A5D"/>
+                </a:solidFill>
+                <a:latin typeface="Calibri" pitchFamily="34" charset="0"/>
+                <a:ea typeface="Calibri" pitchFamily="34" charset="-122"/>
+                <a:cs typeface="Calibri" pitchFamily="34" charset="-120"/>
+              </a:rPr>
+              <a:t>fraud engine</a:t>
+            </a:r>
+            <a:endParaRPr lang="en-US" sz="750" dirty="0"/>
+          </a:p>
+        </p:txBody>
+      </p:sp>
+      <p:sp>
+        <p:nvSpPr>
+          <p:cNvPr id="89" name="Shape 87"/>
+          <p:cNvSpPr/>
+          <p:nvPr/>
+        </p:nvSpPr>
+        <p:spPr>
+          <a:xfrm>
+            <a:off x="320040" y="4279392"/>
+            <a:ext cx="8686800" cy="658368"/>
+          </a:xfrm>
+          <a:prstGeom prst="roundRect">
+            <a:avLst>
+              <a:gd name="adj" fmla="val 6944"/>
+            </a:avLst>
+          </a:prstGeom>
+          <a:solidFill>
+            <a:srgbClr val="E8F0FD"/>
+          </a:solidFill>
+          <a:ln w="12700">
+            <a:solidFill>
+              <a:srgbClr val="BCD0F5"/>
+            </a:solidFill>
+            <a:prstDash val="solid"/>
+          </a:ln>
+        </p:spPr>
+      </p:sp>
+      <p:sp>
+        <p:nvSpPr>
+          <p:cNvPr id="90" name="Text 88"/>
+          <p:cNvSpPr/>
+          <p:nvPr/>
+        </p:nvSpPr>
+        <p:spPr>
+          <a:xfrm>
+            <a:off x="448056" y="4334256"/>
+            <a:ext cx="1463040" cy="201168"/>
+          </a:xfrm>
+          <a:prstGeom prst="rect">
+            <a:avLst/>
+          </a:prstGeom>
+          <a:noFill/>
+          <a:ln/>
+        </p:spPr>
+        <p:txBody>
+          <a:bodyPr wrap="square" lIns="0" tIns="0" rIns="0" bIns="0" rtlCol="0" anchor="ctr"/>
+          <a:lstStyle/>
+          <a:p>
+            <a:pPr indent="0" marL="0">
+              <a:buNone/>
+            </a:pPr>
+            <a:r>
+              <a:rPr lang="en-US" sz="800" b="1" spc="100" kern="0" dirty="0">
+                <a:solidFill>
+                  <a:srgbClr val="085CE5"/>
+                </a:solidFill>
+                <a:latin typeface="Calibri" pitchFamily="34" charset="0"/>
+                <a:ea typeface="Calibri" pitchFamily="34" charset="-122"/>
+                <a:cs typeface="Calibri" pitchFamily="34" charset="-120"/>
+              </a:rPr>
+              <a:t>KEY ASSUMPTIONS</a:t>
+            </a:r>
+            <a:endParaRPr lang="en-US" sz="800" dirty="0"/>
+          </a:p>
+        </p:txBody>
+      </p:sp>
+      <p:sp>
+        <p:nvSpPr>
+          <p:cNvPr id="91" name="Text 89"/>
+          <p:cNvSpPr/>
+          <p:nvPr/>
+        </p:nvSpPr>
+        <p:spPr>
+          <a:xfrm>
+            <a:off x="448056" y="4517136"/>
+            <a:ext cx="8412480" cy="173736"/>
+          </a:xfrm>
+          <a:prstGeom prst="rect">
+            <a:avLst/>
+          </a:prstGeom>
+          <a:noFill/>
+          <a:ln/>
+        </p:spPr>
+        <p:txBody>
+          <a:bodyPr wrap="square" lIns="0" tIns="0" rIns="0" bIns="0" rtlCol="0" anchor="ctr"/>
+          <a:lstStyle/>
+          <a:p>
+            <a:pPr indent="0" marL="0">
+              <a:buNone/>
+            </a:pPr>
+            <a:r>
+              <a:rPr lang="en-US" sz="850" dirty="0">
+                <a:solidFill>
+                  <a:srgbClr val="334466"/>
+                </a:solidFill>
+                <a:latin typeface="Calibri" pitchFamily="34" charset="0"/>
+                <a:ea typeface="Calibri" pitchFamily="34" charset="-122"/>
+                <a:cs typeface="Calibri" pitchFamily="34" charset="-120"/>
+              </a:rPr>
+              <a:t>Blended avg price (bank/CU mix):  Zelle $9.7K  ·  Churn $13.7K  ·  CommercialSignal $11.1K  ·  Gen. Wealth $13.6K  ·  Anomaly $16.8K</a:t>
+            </a:r>
+            <a:endParaRPr lang="en-US" sz="850" dirty="0"/>
+          </a:p>
+        </p:txBody>
+      </p:sp>
+      <p:sp>
+        <p:nvSpPr>
+          <p:cNvPr id="92" name="Text 90"/>
+          <p:cNvSpPr/>
+          <p:nvPr/>
+        </p:nvSpPr>
+        <p:spPr>
+          <a:xfrm>
+            <a:off x="448056" y="4690872"/>
+            <a:ext cx="8412480" cy="173736"/>
+          </a:xfrm>
+          <a:prstGeom prst="rect">
+            <a:avLst/>
+          </a:prstGeom>
+          <a:noFill/>
+          <a:ln/>
+        </p:spPr>
+        <p:txBody>
+          <a:bodyPr wrap="square" lIns="0" tIns="0" rIns="0" bIns="0" rtlCol="0" anchor="ctr"/>
+          <a:lstStyle/>
+          <a:p>
+            <a:pPr indent="0" marL="0">
+              <a:buNone/>
+            </a:pPr>
+            <a:r>
+              <a:rPr lang="en-US" sz="850" dirty="0">
+                <a:solidFill>
+                  <a:srgbClr val="334466"/>
+                </a:solidFill>
+                <a:latin typeface="Calibri" pitchFamily="34" charset="0"/>
+                <a:ea typeface="Calibri" pitchFamily="34" charset="-122"/>
+                <a:cs typeface="Calibri" pitchFamily="34" charset="-120"/>
+              </a:rPr>
+              <a:t>44% CU / 56% bank mix  ·  12% CU discount applied  ·  8% annual subscription churn  ·  No bundle pricing (future option)</a:t>
+            </a:r>
+            <a:endParaRPr lang="en-US" sz="850" dirty="0"/>
+          </a:p>
+        </p:txBody>
+      </p:sp>
+    </p:spTree>
+  </p:cSld>
+  <p:clrMapOvr>
+    <a:masterClrMapping/>
+  </p:clrMapOvr>
+</p:sld>
+</file>
+
+<file path=ppt/slides/slide26.xml><?xml version="1.0" encoding="utf-8"?>
+<p:sld xmlns:a="http://schemas.openxmlformats.org/drawingml/2006/main" xmlns:r="http://schemas.openxmlformats.org/officeDocument/2006/relationships" xmlns:p="http://schemas.openxmlformats.org/presentationml/2006/main">
+  <p:cSld name="Slide 26">
+    <p:bg>
+      <p:bgPr>
+        <a:solidFill>
           <a:srgbClr val="06185F"/>
         </a:solidFill>
       </p:bgPr>

</xml_diff>